<commit_message>
DP1 evaluation over memory-generation systems (A100/H100/B200/VR): multi-system summary, QA3 v4 / QA4 v2 integrated, PPTs regenerated, skill H18-H21
Co-Authored-By: Claude Sonnet 5.5 <noreply@anthropic.com>
Claude-Session: https://claude.ai/code/session_018inK4pZJGzYwjdk7QAyZgn
</commit_message>
<xml_diff>
--- a/doc-mk/DP1/DP1-appendix-qa-result.pptx
+++ b/doc-mk/DP1/DP1-appendix-qa-result.pptx
@@ -4608,7 +4608,7 @@
                   <a:schemeClr val="bg1"/>
                 </a:solidFill>
               </a:rPr>
-              <a:t>DP1 평가 결과 - QA별 후보 비교 (SYS-4, Common + Stress + Dynamic)</a:t>
+              <a:t>DP1 평가 결과 - QA별 후보 비교 (메모리 세대별 4개 시스템, Common + Stress + Dynamic)</a:t>
             </a:r>
             <a:r>
               <a:rPr lang="en-US" altLang="ko-KR" sz="1400" b="1" dirty="0">
@@ -4729,7 +4729,7 @@
         <p:spPr>
           <a:xfrm>
             <a:off x="365760" y="1097280"/>
-            <a:ext cx="1417320" cy="310896"/>
+            <a:ext cx="1737360" cy="310896"/>
           </a:xfrm>
           <a:prstGeom prst="rect">
             <a:avLst/>
@@ -4784,8 +4784,8 @@
         </p:nvSpPr>
         <p:spPr>
           <a:xfrm>
-            <a:off x="1783080" y="1097280"/>
-            <a:ext cx="2514600" cy="310896"/>
+            <a:off x="2103120" y="1097280"/>
+            <a:ext cx="2331720" cy="310896"/>
           </a:xfrm>
           <a:prstGeom prst="rect">
             <a:avLst/>
@@ -4827,7 +4827,7 @@
                 <a:latin typeface="맑은 고딕"/>
                 <a:ea typeface="맑은 고딕"/>
               </a:rPr>
-              <a:t>지표 (DP1 별점 기준)</a:t>
+              <a:t>SYS-A100 (7개)</a:t>
             </a:r>
           </a:p>
         </p:txBody>
@@ -4840,8 +4840,8 @@
         </p:nvSpPr>
         <p:spPr>
           <a:xfrm>
-            <a:off x="4297680" y="1097280"/>
-            <a:ext cx="1554480" cy="310896"/>
+            <a:off x="4434840" y="1097280"/>
+            <a:ext cx="2331720" cy="310896"/>
           </a:xfrm>
           <a:prstGeom prst="rect">
             <a:avLst/>
@@ -4883,7 +4883,7 @@
                 <a:latin typeface="맑은 고딕"/>
                 <a:ea typeface="맑은 고딕"/>
               </a:rPr>
-              <a:t>Baseline</a:t>
+              <a:t>SYS-H100 (10개)</a:t>
             </a:r>
           </a:p>
         </p:txBody>
@@ -4896,8 +4896,8 @@
         </p:nvSpPr>
         <p:spPr>
           <a:xfrm>
-            <a:off x="5852160" y="1097280"/>
-            <a:ext cx="1828800" cy="310896"/>
+            <a:off x="6766559" y="1097280"/>
+            <a:ext cx="2331720" cy="310896"/>
           </a:xfrm>
           <a:prstGeom prst="rect">
             <a:avLst/>
@@ -4939,7 +4939,7 @@
                 <a:latin typeface="맑은 고딕"/>
                 <a:ea typeface="맑은 고딕"/>
               </a:rPr>
-              <a:t>C1 Resource-driven</a:t>
+              <a:t>SYS-B200 (13개)</a:t>
             </a:r>
           </a:p>
         </p:txBody>
@@ -4952,8 +4952,8 @@
         </p:nvSpPr>
         <p:spPr>
           <a:xfrm>
-            <a:off x="7680960" y="1097280"/>
-            <a:ext cx="1828800" cy="310896"/>
+            <a:off x="9098280" y="1097280"/>
+            <a:ext cx="2331720" cy="310896"/>
           </a:xfrm>
           <a:prstGeom prst="rect">
             <a:avLst/>
@@ -4995,7 +4995,7 @@
                 <a:latin typeface="맑은 고딕"/>
                 <a:ea typeface="맑은 고딕"/>
               </a:rPr>
-              <a:t>C2 Behavior-driven</a:t>
+              <a:t>SYS-VR (16개)</a:t>
             </a:r>
           </a:p>
         </p:txBody>
@@ -5008,64 +5008,8 @@
         </p:nvSpPr>
         <p:spPr>
           <a:xfrm>
-            <a:off x="9509760" y="1097280"/>
-            <a:ext cx="2286000" cy="310896"/>
-          </a:xfrm>
-          <a:prstGeom prst="rect">
-            <a:avLst/>
-          </a:prstGeom>
-          <a:solidFill>
-            <a:srgbClr val="1F4E79"/>
-          </a:solidFill>
-          <a:ln w="9525">
-            <a:solidFill>
-              <a:srgbClr val="1F4E79"/>
-            </a:solidFill>
-          </a:ln>
-          <a:effectLst/>
-        </p:spPr>
-        <p:style>
-          <a:lnRef idx="1">
-            <a:schemeClr val="accent1"/>
-          </a:lnRef>
-          <a:fillRef idx="3">
-            <a:schemeClr val="accent1"/>
-          </a:fillRef>
-          <a:effectRef idx="2">
-            <a:schemeClr val="accent1"/>
-          </a:effectRef>
-          <a:fontRef idx="minor">
-            <a:schemeClr val="lt1"/>
-          </a:fontRef>
-        </p:style>
-        <p:txBody>
-          <a:bodyPr rtlCol="0" anchor="ctr" wrap="square" lIns="45720" rIns="45720" tIns="27432" bIns="27432"/>
-          <a:lstStyle/>
-          <a:p>
-            <a:pPr algn="ctr"/>
-            <a:r>
-              <a:rPr sz="900" b="1">
-                <a:solidFill>
-                  <a:srgbClr val="FFFFFF"/>
-                </a:solidFill>
-                <a:latin typeface="맑은 고딕"/>
-                <a:ea typeface="맑은 고딕"/>
-              </a:rPr>
-              <a:t>우세</a:t>
-            </a:r>
-          </a:p>
-        </p:txBody>
-      </p:sp>
-      <p:sp>
-        <p:nvSpPr>
-          <p:cNvPr id="64" name="Rectangle 63"/>
-          <p:cNvSpPr/>
-          <p:nvPr/>
-        </p:nvSpPr>
-        <p:spPr>
-          <a:xfrm>
             <a:off x="365760" y="1444752"/>
-            <a:ext cx="1417320" cy="530352"/>
+            <a:ext cx="1737360" cy="512064"/>
           </a:xfrm>
           <a:prstGeom prst="rect">
             <a:avLst/>
@@ -5100,7 +5044,7 @@
           <a:p>
             <a:pPr algn="l"/>
             <a:r>
-              <a:rPr sz="1000" b="1">
+              <a:rPr sz="900" b="1">
                 <a:solidFill>
                   <a:srgbClr val="1A1A1A"/>
                 </a:solidFill>
@@ -5110,18 +5054,31 @@
               <a:t>QA1 Throughput [B]</a:t>
             </a:r>
           </a:p>
-        </p:txBody>
-      </p:sp>
-      <p:sp>
-        <p:nvSpPr>
-          <p:cNvPr id="65" name="Rectangle 64"/>
+          <a:p>
+            <a:pPr algn="l"/>
+            <a:r>
+              <a:rPr sz="900" b="1">
+                <a:solidFill>
+                  <a:srgbClr val="1A1A1A"/>
+                </a:solidFill>
+                <a:latin typeface="맑은 고딕"/>
+                <a:ea typeface="맑은 고딕"/>
+              </a:rPr>
+              <a:t>(Baseline 대비 goodput)</a:t>
+            </a:r>
+          </a:p>
+        </p:txBody>
+      </p:sp>
+      <p:sp>
+        <p:nvSpPr>
+          <p:cNvPr id="64" name="Rectangle 63"/>
           <p:cNvSpPr/>
           <p:nvPr/>
         </p:nvSpPr>
         <p:spPr>
           <a:xfrm>
-            <a:off x="1783080" y="1444752"/>
-            <a:ext cx="2514600" cy="530352"/>
+            <a:off x="2103120" y="1444752"/>
+            <a:ext cx="2331720" cy="512064"/>
           </a:xfrm>
           <a:prstGeom prst="rect">
             <a:avLst/>
@@ -5154,7 +5111,7 @@
           <a:bodyPr rtlCol="0" anchor="ctr" wrap="square" lIns="45720" rIns="45720" tIns="27432" bIns="27432"/>
           <a:lstStyle/>
           <a:p>
-            <a:pPr algn="l"/>
+            <a:pPr algn="ctr"/>
             <a:r>
               <a:rPr sz="1000" b="0">
                 <a:solidFill>
@@ -5163,21 +5120,34 @@
                 <a:latin typeface="맑은 고딕"/>
                 <a:ea typeface="맑은 고딕"/>
               </a:rPr>
-              <a:t>Baseline 대비 SLO goodput (geomean)</a:t>
-            </a:r>
-          </a:p>
-        </p:txBody>
-      </p:sp>
-      <p:sp>
-        <p:nvSpPr>
-          <p:cNvPr id="66" name="Rectangle 65"/>
+              <a:t>C1 ★★★ x1.32</a:t>
+            </a:r>
+          </a:p>
+          <a:p>
+            <a:pPr algn="ctr"/>
+            <a:r>
+              <a:rPr sz="1000" b="0">
+                <a:solidFill>
+                  <a:srgbClr val="1A1A1A"/>
+                </a:solidFill>
+                <a:latin typeface="맑은 고딕"/>
+                <a:ea typeface="맑은 고딕"/>
+              </a:rPr>
+              <a:t>C2 ★★★ x1.33</a:t>
+            </a:r>
+          </a:p>
+        </p:txBody>
+      </p:sp>
+      <p:sp>
+        <p:nvSpPr>
+          <p:cNvPr id="65" name="Rectangle 64"/>
           <p:cNvSpPr/>
           <p:nvPr/>
         </p:nvSpPr>
         <p:spPr>
           <a:xfrm>
-            <a:off x="4297680" y="1444752"/>
-            <a:ext cx="1554480" cy="530352"/>
+            <a:off x="4434840" y="1444752"/>
+            <a:ext cx="2331720" cy="512064"/>
           </a:xfrm>
           <a:prstGeom prst="rect">
             <a:avLst/>
@@ -5219,21 +5189,34 @@
                 <a:latin typeface="맑은 고딕"/>
                 <a:ea typeface="맑은 고딕"/>
               </a:rPr>
-              <a:t>★★ x1.00</a:t>
-            </a:r>
-          </a:p>
-        </p:txBody>
-      </p:sp>
-      <p:sp>
-        <p:nvSpPr>
-          <p:cNvPr id="67" name="Rectangle 66"/>
+              <a:t>C1 ★★ x1.29</a:t>
+            </a:r>
+          </a:p>
+          <a:p>
+            <a:pPr algn="ctr"/>
+            <a:r>
+              <a:rPr sz="1000" b="0">
+                <a:solidFill>
+                  <a:srgbClr val="1A1A1A"/>
+                </a:solidFill>
+                <a:latin typeface="맑은 고딕"/>
+                <a:ea typeface="맑은 고딕"/>
+              </a:rPr>
+              <a:t>C2 ★★★ x1.34</a:t>
+            </a:r>
+          </a:p>
+        </p:txBody>
+      </p:sp>
+      <p:sp>
+        <p:nvSpPr>
+          <p:cNvPr id="66" name="Rectangle 65"/>
           <p:cNvSpPr/>
           <p:nvPr/>
         </p:nvSpPr>
         <p:spPr>
           <a:xfrm>
-            <a:off x="5852160" y="1444752"/>
-            <a:ext cx="1828800" cy="530352"/>
+            <a:off x="6766559" y="1444752"/>
+            <a:ext cx="2331720" cy="512064"/>
           </a:xfrm>
           <a:prstGeom prst="rect">
             <a:avLst/>
@@ -5275,21 +5258,34 @@
                 <a:latin typeface="맑은 고딕"/>
                 <a:ea typeface="맑은 고딕"/>
               </a:rPr>
-              <a:t>★★ x1.26</a:t>
-            </a:r>
-          </a:p>
-        </p:txBody>
-      </p:sp>
-      <p:sp>
-        <p:nvSpPr>
-          <p:cNvPr id="68" name="Rectangle 67"/>
+              <a:t>C1 ★★ x1.26</a:t>
+            </a:r>
+          </a:p>
+          <a:p>
+            <a:pPr algn="ctr"/>
+            <a:r>
+              <a:rPr sz="1000" b="0">
+                <a:solidFill>
+                  <a:srgbClr val="1A1A1A"/>
+                </a:solidFill>
+                <a:latin typeface="맑은 고딕"/>
+                <a:ea typeface="맑은 고딕"/>
+              </a:rPr>
+              <a:t>C2 ★★★ x1.44</a:t>
+            </a:r>
+          </a:p>
+        </p:txBody>
+      </p:sp>
+      <p:sp>
+        <p:nvSpPr>
+          <p:cNvPr id="67" name="Rectangle 66"/>
           <p:cNvSpPr/>
           <p:nvPr/>
         </p:nvSpPr>
         <p:spPr>
           <a:xfrm>
-            <a:off x="7680960" y="1444752"/>
-            <a:ext cx="1828800" cy="530352"/>
+            <a:off x="9098280" y="1444752"/>
+            <a:ext cx="2331720" cy="512064"/>
           </a:xfrm>
           <a:prstGeom prst="rect">
             <a:avLst/>
@@ -5331,7 +5327,89 @@
                 <a:latin typeface="맑은 고딕"/>
                 <a:ea typeface="맑은 고딕"/>
               </a:rPr>
-              <a:t>★★★ x1.44</a:t>
+              <a:t>C1 ★★ x1.00</a:t>
+            </a:r>
+          </a:p>
+          <a:p>
+            <a:pPr algn="ctr"/>
+            <a:r>
+              <a:rPr sz="1000" b="0">
+                <a:solidFill>
+                  <a:srgbClr val="1A1A1A"/>
+                </a:solidFill>
+                <a:latin typeface="맑은 고딕"/>
+                <a:ea typeface="맑은 고딕"/>
+              </a:rPr>
+              <a:t>C2 ★★ x1.04</a:t>
+            </a:r>
+          </a:p>
+        </p:txBody>
+      </p:sp>
+      <p:sp>
+        <p:nvSpPr>
+          <p:cNvPr id="68" name="Rectangle 67"/>
+          <p:cNvSpPr/>
+          <p:nvPr/>
+        </p:nvSpPr>
+        <p:spPr>
+          <a:xfrm>
+            <a:off x="365760" y="1975104"/>
+            <a:ext cx="1737360" cy="512064"/>
+          </a:xfrm>
+          <a:prstGeom prst="rect">
+            <a:avLst/>
+          </a:prstGeom>
+          <a:solidFill>
+            <a:srgbClr val="DCE9F5"/>
+          </a:solidFill>
+          <a:ln w="9525">
+            <a:solidFill>
+              <a:srgbClr val="4D7EA8"/>
+            </a:solidFill>
+          </a:ln>
+          <a:effectLst/>
+        </p:spPr>
+        <p:style>
+          <a:lnRef idx="1">
+            <a:schemeClr val="accent1"/>
+          </a:lnRef>
+          <a:fillRef idx="3">
+            <a:schemeClr val="accent1"/>
+          </a:fillRef>
+          <a:effectRef idx="2">
+            <a:schemeClr val="accent1"/>
+          </a:effectRef>
+          <a:fontRef idx="minor">
+            <a:schemeClr val="lt1"/>
+          </a:fontRef>
+        </p:style>
+        <p:txBody>
+          <a:bodyPr rtlCol="0" anchor="ctr" wrap="square" lIns="45720" rIns="45720" tIns="27432" bIns="27432"/>
+          <a:lstStyle/>
+          <a:p>
+            <a:pPr algn="l"/>
+            <a:r>
+              <a:rPr sz="900" b="1">
+                <a:solidFill>
+                  <a:srgbClr val="1A1A1A"/>
+                </a:solidFill>
+                <a:latin typeface="맑은 고딕"/>
+                <a:ea typeface="맑은 고딕"/>
+              </a:rPr>
+              <a:t>QA2 Latency [B]</a:t>
+            </a:r>
+          </a:p>
+          <a:p>
+            <a:pPr algn="l"/>
+            <a:r>
+              <a:rPr sz="900" b="1">
+                <a:solidFill>
+                  <a:srgbClr val="1A1A1A"/>
+                </a:solidFill>
+                <a:latin typeface="맑은 고딕"/>
+                <a:ea typeface="맑은 고딕"/>
+              </a:rPr>
+              <a:t>(개선 배수)</a:t>
             </a:r>
           </a:p>
         </p:txBody>
@@ -5344,8 +5422,8 @@
         </p:nvSpPr>
         <p:spPr>
           <a:xfrm>
-            <a:off x="9509760" y="1444752"/>
-            <a:ext cx="2286000" cy="530352"/>
+            <a:off x="2103120" y="1975104"/>
+            <a:ext cx="2331720" cy="512064"/>
           </a:xfrm>
           <a:prstGeom prst="rect">
             <a:avLst/>
@@ -5380,14 +5458,27 @@
           <a:p>
             <a:pPr algn="ctr"/>
             <a:r>
-              <a:rPr sz="1000" b="1">
+              <a:rPr sz="1000" b="0">
                 <a:solidFill>
                   <a:srgbClr val="1A1A1A"/>
                 </a:solidFill>
                 <a:latin typeface="맑은 고딕"/>
                 <a:ea typeface="맑은 고딕"/>
               </a:rPr>
-              <a:t>C2</a:t>
+              <a:t>C1 ★★★ x1.48</a:t>
+            </a:r>
+          </a:p>
+          <a:p>
+            <a:pPr algn="ctr"/>
+            <a:r>
+              <a:rPr sz="1000" b="0">
+                <a:solidFill>
+                  <a:srgbClr val="1A1A1A"/>
+                </a:solidFill>
+                <a:latin typeface="맑은 고딕"/>
+                <a:ea typeface="맑은 고딕"/>
+              </a:rPr>
+              <a:t>C2 ★★★ x1.47</a:t>
             </a:r>
           </a:p>
         </p:txBody>
@@ -5400,8 +5491,215 @@
         </p:nvSpPr>
         <p:spPr>
           <a:xfrm>
-            <a:off x="365760" y="1993392"/>
-            <a:ext cx="1417320" cy="530352"/>
+            <a:off x="4434840" y="1975104"/>
+            <a:ext cx="2331720" cy="512064"/>
+          </a:xfrm>
+          <a:prstGeom prst="rect">
+            <a:avLst/>
+          </a:prstGeom>
+          <a:solidFill>
+            <a:srgbClr val="FFFFFF"/>
+          </a:solidFill>
+          <a:ln w="9525">
+            <a:solidFill>
+              <a:srgbClr val="BFBFBF"/>
+            </a:solidFill>
+          </a:ln>
+          <a:effectLst/>
+        </p:spPr>
+        <p:style>
+          <a:lnRef idx="1">
+            <a:schemeClr val="accent1"/>
+          </a:lnRef>
+          <a:fillRef idx="3">
+            <a:schemeClr val="accent1"/>
+          </a:fillRef>
+          <a:effectRef idx="2">
+            <a:schemeClr val="accent1"/>
+          </a:effectRef>
+          <a:fontRef idx="minor">
+            <a:schemeClr val="lt1"/>
+          </a:fontRef>
+        </p:style>
+        <p:txBody>
+          <a:bodyPr rtlCol="0" anchor="ctr" wrap="square" lIns="45720" rIns="45720" tIns="27432" bIns="27432"/>
+          <a:lstStyle/>
+          <a:p>
+            <a:pPr algn="ctr"/>
+            <a:r>
+              <a:rPr sz="1000" b="0">
+                <a:solidFill>
+                  <a:srgbClr val="1A1A1A"/>
+                </a:solidFill>
+                <a:latin typeface="맑은 고딕"/>
+                <a:ea typeface="맑은 고딕"/>
+              </a:rPr>
+              <a:t>C1 ★★★ x1.39</a:t>
+            </a:r>
+          </a:p>
+          <a:p>
+            <a:pPr algn="ctr"/>
+            <a:r>
+              <a:rPr sz="1000" b="0">
+                <a:solidFill>
+                  <a:srgbClr val="1A1A1A"/>
+                </a:solidFill>
+                <a:latin typeface="맑은 고딕"/>
+                <a:ea typeface="맑은 고딕"/>
+              </a:rPr>
+              <a:t>C2 ★★★ x1.67</a:t>
+            </a:r>
+          </a:p>
+        </p:txBody>
+      </p:sp>
+      <p:sp>
+        <p:nvSpPr>
+          <p:cNvPr id="71" name="Rectangle 70"/>
+          <p:cNvSpPr/>
+          <p:nvPr/>
+        </p:nvSpPr>
+        <p:spPr>
+          <a:xfrm>
+            <a:off x="6766559" y="1975104"/>
+            <a:ext cx="2331720" cy="512064"/>
+          </a:xfrm>
+          <a:prstGeom prst="rect">
+            <a:avLst/>
+          </a:prstGeom>
+          <a:solidFill>
+            <a:srgbClr val="FFFFFF"/>
+          </a:solidFill>
+          <a:ln w="9525">
+            <a:solidFill>
+              <a:srgbClr val="BFBFBF"/>
+            </a:solidFill>
+          </a:ln>
+          <a:effectLst/>
+        </p:spPr>
+        <p:style>
+          <a:lnRef idx="1">
+            <a:schemeClr val="accent1"/>
+          </a:lnRef>
+          <a:fillRef idx="3">
+            <a:schemeClr val="accent1"/>
+          </a:fillRef>
+          <a:effectRef idx="2">
+            <a:schemeClr val="accent1"/>
+          </a:effectRef>
+          <a:fontRef idx="minor">
+            <a:schemeClr val="lt1"/>
+          </a:fontRef>
+        </p:style>
+        <p:txBody>
+          <a:bodyPr rtlCol="0" anchor="ctr" wrap="square" lIns="45720" rIns="45720" tIns="27432" bIns="27432"/>
+          <a:lstStyle/>
+          <a:p>
+            <a:pPr algn="ctr"/>
+            <a:r>
+              <a:rPr sz="1000" b="0">
+                <a:solidFill>
+                  <a:srgbClr val="1A1A1A"/>
+                </a:solidFill>
+                <a:latin typeface="맑은 고딕"/>
+                <a:ea typeface="맑은 고딕"/>
+              </a:rPr>
+              <a:t>C1 ★★★ x1.41</a:t>
+            </a:r>
+          </a:p>
+          <a:p>
+            <a:pPr algn="ctr"/>
+            <a:r>
+              <a:rPr sz="1000" b="0">
+                <a:solidFill>
+                  <a:srgbClr val="1A1A1A"/>
+                </a:solidFill>
+                <a:latin typeface="맑은 고딕"/>
+                <a:ea typeface="맑은 고딕"/>
+              </a:rPr>
+              <a:t>C2 ★★★ x1.65</a:t>
+            </a:r>
+          </a:p>
+        </p:txBody>
+      </p:sp>
+      <p:sp>
+        <p:nvSpPr>
+          <p:cNvPr id="72" name="Rectangle 71"/>
+          <p:cNvSpPr/>
+          <p:nvPr/>
+        </p:nvSpPr>
+        <p:spPr>
+          <a:xfrm>
+            <a:off x="9098280" y="1975104"/>
+            <a:ext cx="2331720" cy="512064"/>
+          </a:xfrm>
+          <a:prstGeom prst="rect">
+            <a:avLst/>
+          </a:prstGeom>
+          <a:solidFill>
+            <a:srgbClr val="FFFFFF"/>
+          </a:solidFill>
+          <a:ln w="9525">
+            <a:solidFill>
+              <a:srgbClr val="BFBFBF"/>
+            </a:solidFill>
+          </a:ln>
+          <a:effectLst/>
+        </p:spPr>
+        <p:style>
+          <a:lnRef idx="1">
+            <a:schemeClr val="accent1"/>
+          </a:lnRef>
+          <a:fillRef idx="3">
+            <a:schemeClr val="accent1"/>
+          </a:fillRef>
+          <a:effectRef idx="2">
+            <a:schemeClr val="accent1"/>
+          </a:effectRef>
+          <a:fontRef idx="minor">
+            <a:schemeClr val="lt1"/>
+          </a:fontRef>
+        </p:style>
+        <p:txBody>
+          <a:bodyPr rtlCol="0" anchor="ctr" wrap="square" lIns="45720" rIns="45720" tIns="27432" bIns="27432"/>
+          <a:lstStyle/>
+          <a:p>
+            <a:pPr algn="ctr"/>
+            <a:r>
+              <a:rPr sz="1000" b="0">
+                <a:solidFill>
+                  <a:srgbClr val="1A1A1A"/>
+                </a:solidFill>
+                <a:latin typeface="맑은 고딕"/>
+                <a:ea typeface="맑은 고딕"/>
+              </a:rPr>
+              <a:t>C1 ★★ x1.05</a:t>
+            </a:r>
+          </a:p>
+          <a:p>
+            <a:pPr algn="ctr"/>
+            <a:r>
+              <a:rPr sz="1000" b="0">
+                <a:solidFill>
+                  <a:srgbClr val="1A1A1A"/>
+                </a:solidFill>
+                <a:latin typeface="맑은 고딕"/>
+                <a:ea typeface="맑은 고딕"/>
+              </a:rPr>
+              <a:t>C2 ★★★ x1.29</a:t>
+            </a:r>
+          </a:p>
+        </p:txBody>
+      </p:sp>
+      <p:sp>
+        <p:nvSpPr>
+          <p:cNvPr id="73" name="Rectangle 72"/>
+          <p:cNvSpPr/>
+          <p:nvPr/>
+        </p:nvSpPr>
+        <p:spPr>
+          <a:xfrm>
+            <a:off x="365760" y="2505456"/>
+            <a:ext cx="1737360" cy="512064"/>
           </a:xfrm>
           <a:prstGeom prst="rect">
             <a:avLst/>
@@ -5436,28 +5734,41 @@
           <a:p>
             <a:pPr algn="l"/>
             <a:r>
-              <a:rPr sz="1000" b="1">
+              <a:rPr sz="900" b="1">
                 <a:solidFill>
                   <a:srgbClr val="1A1A1A"/>
                 </a:solidFill>
                 <a:latin typeface="맑은 고딕"/>
                 <a:ea typeface="맑은 고딕"/>
               </a:rPr>
-              <a:t>QA2 Latency [B]</a:t>
-            </a:r>
-          </a:p>
-        </p:txBody>
-      </p:sp>
-      <p:sp>
-        <p:nvSpPr>
-          <p:cNvPr id="71" name="Rectangle 70"/>
+              <a:t>QA3 Utilization [B]</a:t>
+            </a:r>
+          </a:p>
+          <a:p>
+            <a:pPr algn="l"/>
+            <a:r>
+              <a:rPr sz="900" b="1">
+                <a:solidFill>
+                  <a:srgbClr val="1A1A1A"/>
+                </a:solidFill>
+                <a:latin typeface="맑은 고딕"/>
+                <a:ea typeface="맑은 고딕"/>
+              </a:rPr>
+              <a:t>(전 메모리 풀 U 상대)</a:t>
+            </a:r>
+          </a:p>
+        </p:txBody>
+      </p:sp>
+      <p:sp>
+        <p:nvSpPr>
+          <p:cNvPr id="74" name="Rectangle 73"/>
           <p:cNvSpPr/>
           <p:nvPr/>
         </p:nvSpPr>
         <p:spPr>
           <a:xfrm>
-            <a:off x="1783080" y="1993392"/>
-            <a:ext cx="2514600" cy="530352"/>
+            <a:off x="2103120" y="2505456"/>
+            <a:ext cx="2331720" cy="512064"/>
           </a:xfrm>
           <a:prstGeom prst="rect">
             <a:avLst/>
@@ -5490,7 +5801,7 @@
           <a:bodyPr rtlCol="0" anchor="ctr" wrap="square" lIns="45720" rIns="45720" tIns="27432" bIns="27432"/>
           <a:lstStyle/>
           <a:p>
-            <a:pPr algn="l"/>
+            <a:pPr algn="ctr"/>
             <a:r>
               <a:rPr sz="1000" b="0">
                 <a:solidFill>
@@ -5499,11 +5810,11 @@
                 <a:latin typeface="맑은 고딕"/>
                 <a:ea typeface="맑은 고딕"/>
               </a:rPr>
-              <a:t>TTFT/TPOT x P50/P95/P99 개선 배수 (g</a:t>
-            </a:r>
-          </a:p>
-          <a:p>
-            <a:pPr algn="l"/>
+              <a:t>C1 ★★ x1.10</a:t>
+            </a:r>
+          </a:p>
+          <a:p>
+            <a:pPr algn="ctr"/>
             <a:r>
               <a:rPr sz="1000" b="0">
                 <a:solidFill>
@@ -5512,21 +5823,21 @@
                 <a:latin typeface="맑은 고딕"/>
                 <a:ea typeface="맑은 고딕"/>
               </a:rPr>
-              <a:t>eomean)</a:t>
-            </a:r>
-          </a:p>
-        </p:txBody>
-      </p:sp>
-      <p:sp>
-        <p:nvSpPr>
-          <p:cNvPr id="72" name="Rectangle 71"/>
+              <a:t>C2 ★★ x1.00</a:t>
+            </a:r>
+          </a:p>
+        </p:txBody>
+      </p:sp>
+      <p:sp>
+        <p:nvSpPr>
+          <p:cNvPr id="75" name="Rectangle 74"/>
           <p:cNvSpPr/>
           <p:nvPr/>
         </p:nvSpPr>
         <p:spPr>
           <a:xfrm>
-            <a:off x="4297680" y="1993392"/>
-            <a:ext cx="1554480" cy="530352"/>
+            <a:off x="4434840" y="2505456"/>
+            <a:ext cx="2331720" cy="512064"/>
           </a:xfrm>
           <a:prstGeom prst="rect">
             <a:avLst/>
@@ -5568,21 +5879,34 @@
                 <a:latin typeface="맑은 고딕"/>
                 <a:ea typeface="맑은 고딕"/>
               </a:rPr>
-              <a:t>★★ x1.00</a:t>
-            </a:r>
-          </a:p>
-        </p:txBody>
-      </p:sp>
-      <p:sp>
-        <p:nvSpPr>
-          <p:cNvPr id="73" name="Rectangle 72"/>
+              <a:t>C1 ★★ x1.11</a:t>
+            </a:r>
+          </a:p>
+          <a:p>
+            <a:pPr algn="ctr"/>
+            <a:r>
+              <a:rPr sz="1000" b="0">
+                <a:solidFill>
+                  <a:srgbClr val="1A1A1A"/>
+                </a:solidFill>
+                <a:latin typeface="맑은 고딕"/>
+                <a:ea typeface="맑은 고딕"/>
+              </a:rPr>
+              <a:t>C2 ★★ x1.01</a:t>
+            </a:r>
+          </a:p>
+        </p:txBody>
+      </p:sp>
+      <p:sp>
+        <p:nvSpPr>
+          <p:cNvPr id="76" name="Rectangle 75"/>
           <p:cNvSpPr/>
           <p:nvPr/>
         </p:nvSpPr>
         <p:spPr>
           <a:xfrm>
-            <a:off x="5852160" y="1993392"/>
-            <a:ext cx="1828800" cy="530352"/>
+            <a:off x="6766559" y="2505456"/>
+            <a:ext cx="2331720" cy="512064"/>
           </a:xfrm>
           <a:prstGeom prst="rect">
             <a:avLst/>
@@ -5624,21 +5948,34 @@
                 <a:latin typeface="맑은 고딕"/>
                 <a:ea typeface="맑은 고딕"/>
               </a:rPr>
-              <a:t>★★★ x1.41</a:t>
-            </a:r>
-          </a:p>
-        </p:txBody>
-      </p:sp>
-      <p:sp>
-        <p:nvSpPr>
-          <p:cNvPr id="74" name="Rectangle 73"/>
+              <a:t>C1 ★★ x1.20</a:t>
+            </a:r>
+          </a:p>
+          <a:p>
+            <a:pPr algn="ctr"/>
+            <a:r>
+              <a:rPr sz="1000" b="0">
+                <a:solidFill>
+                  <a:srgbClr val="1A1A1A"/>
+                </a:solidFill>
+                <a:latin typeface="맑은 고딕"/>
+                <a:ea typeface="맑은 고딕"/>
+              </a:rPr>
+              <a:t>C2 ★★★ x1.25</a:t>
+            </a:r>
+          </a:p>
+        </p:txBody>
+      </p:sp>
+      <p:sp>
+        <p:nvSpPr>
+          <p:cNvPr id="77" name="Rectangle 76"/>
           <p:cNvSpPr/>
           <p:nvPr/>
         </p:nvSpPr>
         <p:spPr>
           <a:xfrm>
-            <a:off x="7680960" y="1993392"/>
-            <a:ext cx="1828800" cy="530352"/>
+            <a:off x="9098280" y="2505456"/>
+            <a:ext cx="2331720" cy="512064"/>
           </a:xfrm>
           <a:prstGeom prst="rect">
             <a:avLst/>
@@ -5680,21 +6017,103 @@
                 <a:latin typeface="맑은 고딕"/>
                 <a:ea typeface="맑은 고딕"/>
               </a:rPr>
-              <a:t>★★★ x1.65</a:t>
-            </a:r>
-          </a:p>
-        </p:txBody>
-      </p:sp>
-      <p:sp>
-        <p:nvSpPr>
-          <p:cNvPr id="75" name="Rectangle 74"/>
+              <a:t>C1 ★★ x0.99</a:t>
+            </a:r>
+          </a:p>
+          <a:p>
+            <a:pPr algn="ctr"/>
+            <a:r>
+              <a:rPr sz="1000" b="0">
+                <a:solidFill>
+                  <a:srgbClr val="1A1A1A"/>
+                </a:solidFill>
+                <a:latin typeface="맑은 고딕"/>
+                <a:ea typeface="맑은 고딕"/>
+              </a:rPr>
+              <a:t>C2 ★ x0.93</a:t>
+            </a:r>
+          </a:p>
+        </p:txBody>
+      </p:sp>
+      <p:sp>
+        <p:nvSpPr>
+          <p:cNvPr id="78" name="Rectangle 77"/>
           <p:cNvSpPr/>
           <p:nvPr/>
         </p:nvSpPr>
         <p:spPr>
           <a:xfrm>
-            <a:off x="9509760" y="1993392"/>
-            <a:ext cx="2286000" cy="530352"/>
+            <a:off x="365760" y="3035808"/>
+            <a:ext cx="1737360" cy="512064"/>
+          </a:xfrm>
+          <a:prstGeom prst="rect">
+            <a:avLst/>
+          </a:prstGeom>
+          <a:solidFill>
+            <a:srgbClr val="DCE9F5"/>
+          </a:solidFill>
+          <a:ln w="9525">
+            <a:solidFill>
+              <a:srgbClr val="4D7EA8"/>
+            </a:solidFill>
+          </a:ln>
+          <a:effectLst/>
+        </p:spPr>
+        <p:style>
+          <a:lnRef idx="1">
+            <a:schemeClr val="accent1"/>
+          </a:lnRef>
+          <a:fillRef idx="3">
+            <a:schemeClr val="accent1"/>
+          </a:fillRef>
+          <a:effectRef idx="2">
+            <a:schemeClr val="accent1"/>
+          </a:effectRef>
+          <a:fontRef idx="minor">
+            <a:schemeClr val="lt1"/>
+          </a:fontRef>
+        </p:style>
+        <p:txBody>
+          <a:bodyPr rtlCol="0" anchor="ctr" wrap="square" lIns="45720" rIns="45720" tIns="27432" bIns="27432"/>
+          <a:lstStyle/>
+          <a:p>
+            <a:pPr algn="l"/>
+            <a:r>
+              <a:rPr sz="900" b="1">
+                <a:solidFill>
+                  <a:srgbClr val="1A1A1A"/>
+                </a:solidFill>
+                <a:latin typeface="맑은 고딕"/>
+                <a:ea typeface="맑은 고딕"/>
+              </a:rPr>
+              <a:t>QA4 Modifiability [B+C]</a:t>
+            </a:r>
+          </a:p>
+          <a:p>
+            <a:pPr algn="l"/>
+            <a:r>
+              <a:rPr sz="900" b="1">
+                <a:solidFill>
+                  <a:srgbClr val="1A1A1A"/>
+                </a:solidFill>
+                <a:latin typeface="맑은 고딕"/>
+                <a:ea typeface="맑은 고딕"/>
+              </a:rPr>
+              <a:t>(module / 에이전트 비용)</a:t>
+            </a:r>
+          </a:p>
+        </p:txBody>
+      </p:sp>
+      <p:sp>
+        <p:nvSpPr>
+          <p:cNvPr id="79" name="Rectangle 78"/>
+          <p:cNvSpPr/>
+          <p:nvPr/>
+        </p:nvSpPr>
+        <p:spPr>
+          <a:xfrm>
+            <a:off x="2103120" y="3035808"/>
+            <a:ext cx="2331720" cy="512064"/>
           </a:xfrm>
           <a:prstGeom prst="rect">
             <a:avLst/>
@@ -5729,28 +6148,248 @@
           <a:p>
             <a:pPr algn="ctr"/>
             <a:r>
-              <a:rPr sz="1000" b="1">
+              <a:rPr sz="1000" b="0">
                 <a:solidFill>
                   <a:srgbClr val="1A1A1A"/>
                 </a:solidFill>
                 <a:latin typeface="맑은 고딕"/>
                 <a:ea typeface="맑은 고딕"/>
               </a:rPr>
-              <a:t>동률</a:t>
-            </a:r>
-          </a:p>
-        </p:txBody>
-      </p:sp>
-      <p:sp>
-        <p:nvSpPr>
-          <p:cNvPr id="76" name="Rectangle 75"/>
+              <a:t>C1 ★★ 1.8모듈 $1.16</a:t>
+            </a:r>
+          </a:p>
+          <a:p>
+            <a:pPr algn="ctr"/>
+            <a:r>
+              <a:rPr sz="1000" b="0">
+                <a:solidFill>
+                  <a:srgbClr val="1A1A1A"/>
+                </a:solidFill>
+                <a:latin typeface="맑은 고딕"/>
+                <a:ea typeface="맑은 고딕"/>
+              </a:rPr>
+              <a:t>C2 ★★ 2.5모듈 $1.49</a:t>
+            </a:r>
+          </a:p>
+        </p:txBody>
+      </p:sp>
+      <p:sp>
+        <p:nvSpPr>
+          <p:cNvPr id="80" name="Rectangle 79"/>
           <p:cNvSpPr/>
           <p:nvPr/>
         </p:nvSpPr>
         <p:spPr>
           <a:xfrm>
-            <a:off x="365760" y="2542032"/>
-            <a:ext cx="1417320" cy="530352"/>
+            <a:off x="4434840" y="3035808"/>
+            <a:ext cx="2331720" cy="512064"/>
+          </a:xfrm>
+          <a:prstGeom prst="rect">
+            <a:avLst/>
+          </a:prstGeom>
+          <a:solidFill>
+            <a:srgbClr val="FFFFFF"/>
+          </a:solidFill>
+          <a:ln w="9525">
+            <a:solidFill>
+              <a:srgbClr val="BFBFBF"/>
+            </a:solidFill>
+          </a:ln>
+          <a:effectLst/>
+        </p:spPr>
+        <p:style>
+          <a:lnRef idx="1">
+            <a:schemeClr val="accent1"/>
+          </a:lnRef>
+          <a:fillRef idx="3">
+            <a:schemeClr val="accent1"/>
+          </a:fillRef>
+          <a:effectRef idx="2">
+            <a:schemeClr val="accent1"/>
+          </a:effectRef>
+          <a:fontRef idx="minor">
+            <a:schemeClr val="lt1"/>
+          </a:fontRef>
+        </p:style>
+        <p:txBody>
+          <a:bodyPr rtlCol="0" anchor="ctr" wrap="square" lIns="45720" rIns="45720" tIns="27432" bIns="27432"/>
+          <a:lstStyle/>
+          <a:p>
+            <a:pPr algn="ctr"/>
+            <a:r>
+              <a:rPr sz="1000" b="0">
+                <a:solidFill>
+                  <a:srgbClr val="1A1A1A"/>
+                </a:solidFill>
+                <a:latin typeface="맑은 고딕"/>
+                <a:ea typeface="맑은 고딕"/>
+              </a:rPr>
+              <a:t>C1 ★★ 1.8모듈 $1.16</a:t>
+            </a:r>
+          </a:p>
+          <a:p>
+            <a:pPr algn="ctr"/>
+            <a:r>
+              <a:rPr sz="1000" b="0">
+                <a:solidFill>
+                  <a:srgbClr val="1A1A1A"/>
+                </a:solidFill>
+                <a:latin typeface="맑은 고딕"/>
+                <a:ea typeface="맑은 고딕"/>
+              </a:rPr>
+              <a:t>C2 ★★ 2.5모듈 $1.49</a:t>
+            </a:r>
+          </a:p>
+        </p:txBody>
+      </p:sp>
+      <p:sp>
+        <p:nvSpPr>
+          <p:cNvPr id="81" name="Rectangle 80"/>
+          <p:cNvSpPr/>
+          <p:nvPr/>
+        </p:nvSpPr>
+        <p:spPr>
+          <a:xfrm>
+            <a:off x="6766559" y="3035808"/>
+            <a:ext cx="2331720" cy="512064"/>
+          </a:xfrm>
+          <a:prstGeom prst="rect">
+            <a:avLst/>
+          </a:prstGeom>
+          <a:solidFill>
+            <a:srgbClr val="FFFFFF"/>
+          </a:solidFill>
+          <a:ln w="9525">
+            <a:solidFill>
+              <a:srgbClr val="BFBFBF"/>
+            </a:solidFill>
+          </a:ln>
+          <a:effectLst/>
+        </p:spPr>
+        <p:style>
+          <a:lnRef idx="1">
+            <a:schemeClr val="accent1"/>
+          </a:lnRef>
+          <a:fillRef idx="3">
+            <a:schemeClr val="accent1"/>
+          </a:fillRef>
+          <a:effectRef idx="2">
+            <a:schemeClr val="accent1"/>
+          </a:effectRef>
+          <a:fontRef idx="minor">
+            <a:schemeClr val="lt1"/>
+          </a:fontRef>
+        </p:style>
+        <p:txBody>
+          <a:bodyPr rtlCol="0" anchor="ctr" wrap="square" lIns="45720" rIns="45720" tIns="27432" bIns="27432"/>
+          <a:lstStyle/>
+          <a:p>
+            <a:pPr algn="ctr"/>
+            <a:r>
+              <a:rPr sz="1000" b="0">
+                <a:solidFill>
+                  <a:srgbClr val="1A1A1A"/>
+                </a:solidFill>
+                <a:latin typeface="맑은 고딕"/>
+                <a:ea typeface="맑은 고딕"/>
+              </a:rPr>
+              <a:t>C1 ★★ 1.8모듈 $1.16</a:t>
+            </a:r>
+          </a:p>
+          <a:p>
+            <a:pPr algn="ctr"/>
+            <a:r>
+              <a:rPr sz="1000" b="0">
+                <a:solidFill>
+                  <a:srgbClr val="1A1A1A"/>
+                </a:solidFill>
+                <a:latin typeface="맑은 고딕"/>
+                <a:ea typeface="맑은 고딕"/>
+              </a:rPr>
+              <a:t>C2 ★★ 2.5모듈 $1.49</a:t>
+            </a:r>
+          </a:p>
+        </p:txBody>
+      </p:sp>
+      <p:sp>
+        <p:nvSpPr>
+          <p:cNvPr id="82" name="Rectangle 81"/>
+          <p:cNvSpPr/>
+          <p:nvPr/>
+        </p:nvSpPr>
+        <p:spPr>
+          <a:xfrm>
+            <a:off x="9098280" y="3035808"/>
+            <a:ext cx="2331720" cy="512064"/>
+          </a:xfrm>
+          <a:prstGeom prst="rect">
+            <a:avLst/>
+          </a:prstGeom>
+          <a:solidFill>
+            <a:srgbClr val="FFFFFF"/>
+          </a:solidFill>
+          <a:ln w="9525">
+            <a:solidFill>
+              <a:srgbClr val="BFBFBF"/>
+            </a:solidFill>
+          </a:ln>
+          <a:effectLst/>
+        </p:spPr>
+        <p:style>
+          <a:lnRef idx="1">
+            <a:schemeClr val="accent1"/>
+          </a:lnRef>
+          <a:fillRef idx="3">
+            <a:schemeClr val="accent1"/>
+          </a:fillRef>
+          <a:effectRef idx="2">
+            <a:schemeClr val="accent1"/>
+          </a:effectRef>
+          <a:fontRef idx="minor">
+            <a:schemeClr val="lt1"/>
+          </a:fontRef>
+        </p:style>
+        <p:txBody>
+          <a:bodyPr rtlCol="0" anchor="ctr" wrap="square" lIns="45720" rIns="45720" tIns="27432" bIns="27432"/>
+          <a:lstStyle/>
+          <a:p>
+            <a:pPr algn="ctr"/>
+            <a:r>
+              <a:rPr sz="1000" b="0">
+                <a:solidFill>
+                  <a:srgbClr val="1A1A1A"/>
+                </a:solidFill>
+                <a:latin typeface="맑은 고딕"/>
+                <a:ea typeface="맑은 고딕"/>
+              </a:rPr>
+              <a:t>C1 ★★ 1.8모듈 $1.16</a:t>
+            </a:r>
+          </a:p>
+          <a:p>
+            <a:pPr algn="ctr"/>
+            <a:r>
+              <a:rPr sz="1000" b="0">
+                <a:solidFill>
+                  <a:srgbClr val="1A1A1A"/>
+                </a:solidFill>
+                <a:latin typeface="맑은 고딕"/>
+                <a:ea typeface="맑은 고딕"/>
+              </a:rPr>
+              <a:t>C2 ★★ 2.5모듈 $1.49</a:t>
+            </a:r>
+          </a:p>
+        </p:txBody>
+      </p:sp>
+      <p:sp>
+        <p:nvSpPr>
+          <p:cNvPr id="83" name="Rectangle 82"/>
+          <p:cNvSpPr/>
+          <p:nvPr/>
+        </p:nvSpPr>
+        <p:spPr>
+          <a:xfrm>
+            <a:off x="365760" y="3566160"/>
+            <a:ext cx="1737360" cy="365760"/>
           </a:xfrm>
           <a:prstGeom prst="rect">
             <a:avLst/>
@@ -5785,28 +6424,28 @@
           <a:p>
             <a:pPr algn="l"/>
             <a:r>
-              <a:rPr sz="1000" b="1">
+              <a:rPr sz="900" b="1">
                 <a:solidFill>
                   <a:srgbClr val="1A1A1A"/>
                 </a:solidFill>
                 <a:latin typeface="맑은 고딕"/>
                 <a:ea typeface="맑은 고딕"/>
               </a:rPr>
-              <a:t>QA3 Utilization [B]</a:t>
-            </a:r>
-          </a:p>
-        </p:txBody>
-      </p:sp>
-      <p:sp>
-        <p:nvSpPr>
-          <p:cNvPr id="77" name="Rectangle 76"/>
+              <a:t>별 합계 (C1 / C2)</a:t>
+            </a:r>
+          </a:p>
+        </p:txBody>
+      </p:sp>
+      <p:sp>
+        <p:nvSpPr>
+          <p:cNvPr id="84" name="Rectangle 83"/>
           <p:cNvSpPr/>
           <p:nvPr/>
         </p:nvSpPr>
         <p:spPr>
           <a:xfrm>
-            <a:off x="1783080" y="2542032"/>
-            <a:ext cx="2514600" cy="530352"/>
+            <a:off x="2103120" y="3566160"/>
+            <a:ext cx="2331720" cy="365760"/>
           </a:xfrm>
           <a:prstGeom prst="rect">
             <a:avLst/>
@@ -5839,43 +6478,30 @@
           <a:bodyPr rtlCol="0" anchor="ctr" wrap="square" lIns="45720" rIns="45720" tIns="27432" bIns="27432"/>
           <a:lstStyle/>
           <a:p>
-            <a:pPr algn="l"/>
-            <a:r>
-              <a:rPr sz="1000" b="0">
+            <a:pPr algn="ctr"/>
+            <a:r>
+              <a:rPr sz="1000" b="1">
                 <a:solidFill>
                   <a:srgbClr val="1A1A1A"/>
                 </a:solidFill>
                 <a:latin typeface="맑은 고딕"/>
                 <a:ea typeface="맑은 고딕"/>
               </a:rPr>
-              <a:t>useful 활용률 (SLO 만족 비율 x HBM 점</a:t>
-            </a:r>
-          </a:p>
-          <a:p>
-            <a:pPr algn="l"/>
-            <a:r>
-              <a:rPr sz="1000" b="0">
-                <a:solidFill>
-                  <a:srgbClr val="1A1A1A"/>
-                </a:solidFill>
-                <a:latin typeface="맑은 고딕"/>
-                <a:ea typeface="맑은 고딕"/>
-              </a:rPr>
-              <a:t>유 x (1-migration 링크 점유))</a:t>
-            </a:r>
-          </a:p>
-        </p:txBody>
-      </p:sp>
-      <p:sp>
-        <p:nvSpPr>
-          <p:cNvPr id="78" name="Rectangle 77"/>
+              <a:t>10 / 10</a:t>
+            </a:r>
+          </a:p>
+        </p:txBody>
+      </p:sp>
+      <p:sp>
+        <p:nvSpPr>
+          <p:cNvPr id="85" name="Rectangle 84"/>
           <p:cNvSpPr/>
           <p:nvPr/>
         </p:nvSpPr>
         <p:spPr>
           <a:xfrm>
-            <a:off x="4297680" y="2542032"/>
-            <a:ext cx="1554480" cy="530352"/>
+            <a:off x="4434840" y="3566160"/>
+            <a:ext cx="2331720" cy="365760"/>
           </a:xfrm>
           <a:prstGeom prst="rect">
             <a:avLst/>
@@ -5910,28 +6536,28 @@
           <a:p>
             <a:pPr algn="ctr"/>
             <a:r>
-              <a:rPr sz="1000" b="0">
+              <a:rPr sz="1000" b="1">
                 <a:solidFill>
                   <a:srgbClr val="1A1A1A"/>
                 </a:solidFill>
                 <a:latin typeface="맑은 고딕"/>
                 <a:ea typeface="맑은 고딕"/>
               </a:rPr>
-              <a:t>★★ 35%</a:t>
-            </a:r>
-          </a:p>
-        </p:txBody>
-      </p:sp>
-      <p:sp>
-        <p:nvSpPr>
-          <p:cNvPr id="79" name="Rectangle 78"/>
+              <a:t>9 / 10</a:t>
+            </a:r>
+          </a:p>
+        </p:txBody>
+      </p:sp>
+      <p:sp>
+        <p:nvSpPr>
+          <p:cNvPr id="86" name="Rectangle 85"/>
           <p:cNvSpPr/>
           <p:nvPr/>
         </p:nvSpPr>
         <p:spPr>
           <a:xfrm>
-            <a:off x="5852160" y="2542032"/>
-            <a:ext cx="1828800" cy="530352"/>
+            <a:off x="6766559" y="3566160"/>
+            <a:ext cx="2331720" cy="365760"/>
           </a:xfrm>
           <a:prstGeom prst="rect">
             <a:avLst/>
@@ -5966,28 +6592,28 @@
           <a:p>
             <a:pPr algn="ctr"/>
             <a:r>
-              <a:rPr sz="1000" b="0">
+              <a:rPr sz="1000" b="1">
                 <a:solidFill>
                   <a:srgbClr val="1A1A1A"/>
                 </a:solidFill>
                 <a:latin typeface="맑은 고딕"/>
                 <a:ea typeface="맑은 고딕"/>
               </a:rPr>
-              <a:t>★★ 42% (+7pp)</a:t>
-            </a:r>
-          </a:p>
-        </p:txBody>
-      </p:sp>
-      <p:sp>
-        <p:nvSpPr>
-          <p:cNvPr id="80" name="Rectangle 79"/>
+              <a:t>9 / 11</a:t>
+            </a:r>
+          </a:p>
+        </p:txBody>
+      </p:sp>
+      <p:sp>
+        <p:nvSpPr>
+          <p:cNvPr id="87" name="Rectangle 86"/>
           <p:cNvSpPr/>
           <p:nvPr/>
         </p:nvSpPr>
         <p:spPr>
           <a:xfrm>
-            <a:off x="7680960" y="2542032"/>
-            <a:ext cx="1828800" cy="530352"/>
+            <a:off x="9098280" y="3566160"/>
+            <a:ext cx="2331720" cy="365760"/>
           </a:xfrm>
           <a:prstGeom prst="rect">
             <a:avLst/>
@@ -6022,84 +6648,28 @@
           <a:p>
             <a:pPr algn="ctr"/>
             <a:r>
-              <a:rPr sz="1000" b="0">
+              <a:rPr sz="1000" b="1">
                 <a:solidFill>
                   <a:srgbClr val="1A1A1A"/>
                 </a:solidFill>
                 <a:latin typeface="맑은 고딕"/>
                 <a:ea typeface="맑은 고딕"/>
               </a:rPr>
-              <a:t>★★ 49% (+14pp)</a:t>
-            </a:r>
-          </a:p>
-        </p:txBody>
-      </p:sp>
-      <p:sp>
-        <p:nvSpPr>
-          <p:cNvPr id="81" name="Rectangle 80"/>
+              <a:t>8 / 8</a:t>
+            </a:r>
+          </a:p>
+        </p:txBody>
+      </p:sp>
+      <p:sp>
+        <p:nvSpPr>
+          <p:cNvPr id="88" name="Rectangle 87"/>
           <p:cNvSpPr/>
           <p:nvPr/>
         </p:nvSpPr>
         <p:spPr>
           <a:xfrm>
-            <a:off x="9509760" y="2542032"/>
-            <a:ext cx="2286000" cy="530352"/>
-          </a:xfrm>
-          <a:prstGeom prst="rect">
-            <a:avLst/>
-          </a:prstGeom>
-          <a:solidFill>
-            <a:srgbClr val="FFFFFF"/>
-          </a:solidFill>
-          <a:ln w="9525">
-            <a:solidFill>
-              <a:srgbClr val="BFBFBF"/>
-            </a:solidFill>
-          </a:ln>
-          <a:effectLst/>
-        </p:spPr>
-        <p:style>
-          <a:lnRef idx="1">
-            <a:schemeClr val="accent1"/>
-          </a:lnRef>
-          <a:fillRef idx="3">
-            <a:schemeClr val="accent1"/>
-          </a:fillRef>
-          <a:effectRef idx="2">
-            <a:schemeClr val="accent1"/>
-          </a:effectRef>
-          <a:fontRef idx="minor">
-            <a:schemeClr val="lt1"/>
-          </a:fontRef>
-        </p:style>
-        <p:txBody>
-          <a:bodyPr rtlCol="0" anchor="ctr" wrap="square" lIns="45720" rIns="45720" tIns="27432" bIns="27432"/>
-          <a:lstStyle/>
-          <a:p>
-            <a:pPr algn="ctr"/>
-            <a:r>
-              <a:rPr sz="1000" b="1">
-                <a:solidFill>
-                  <a:srgbClr val="1A1A1A"/>
-                </a:solidFill>
-                <a:latin typeface="맑은 고딕"/>
-                <a:ea typeface="맑은 고딕"/>
-              </a:rPr>
-              <a:t>동률</a:t>
-            </a:r>
-          </a:p>
-        </p:txBody>
-      </p:sp>
-      <p:sp>
-        <p:nvSpPr>
-          <p:cNvPr id="82" name="Rectangle 81"/>
-          <p:cNvSpPr/>
-          <p:nvPr/>
-        </p:nvSpPr>
-        <p:spPr>
-          <a:xfrm>
-            <a:off x="365760" y="3090672"/>
-            <a:ext cx="1417320" cy="530352"/>
+            <a:off x="365760" y="3950208"/>
+            <a:ext cx="1737360" cy="365760"/>
           </a:xfrm>
           <a:prstGeom prst="rect">
             <a:avLst/>
@@ -6134,38 +6704,38 @@
           <a:p>
             <a:pPr algn="l"/>
             <a:r>
-              <a:rPr sz="1000" b="1">
+              <a:rPr sz="900" b="1">
                 <a:solidFill>
                   <a:srgbClr val="1A1A1A"/>
                 </a:solidFill>
                 <a:latin typeface="맑은 고딕"/>
                 <a:ea typeface="맑은 고딕"/>
               </a:rPr>
-              <a:t>QA4 Modifiability [C]</a:t>
-            </a:r>
-          </a:p>
-        </p:txBody>
-      </p:sp>
-      <p:sp>
-        <p:nvSpPr>
-          <p:cNvPr id="83" name="Rectangle 82"/>
+              <a:t>선택 (우선순위 규칙)</a:t>
+            </a:r>
+          </a:p>
+        </p:txBody>
+      </p:sp>
+      <p:sp>
+        <p:nvSpPr>
+          <p:cNvPr id="89" name="Rectangle 88"/>
           <p:cNvSpPr/>
           <p:nvPr/>
         </p:nvSpPr>
         <p:spPr>
           <a:xfrm>
-            <a:off x="1783080" y="3090672"/>
-            <a:ext cx="2514600" cy="530352"/>
+            <a:off x="2103120" y="3950208"/>
+            <a:ext cx="2331720" cy="365760"/>
           </a:xfrm>
           <a:prstGeom prst="rect">
             <a:avLst/>
           </a:prstGeom>
           <a:solidFill>
-            <a:srgbClr val="FFFFFF"/>
+            <a:srgbClr val="E3F1E3"/>
           </a:solidFill>
           <a:ln w="9525">
             <a:solidFill>
-              <a:srgbClr val="BFBFBF"/>
+              <a:srgbClr val="5B9B5B"/>
             </a:solidFill>
           </a:ln>
           <a:effectLst/>
@@ -6188,53 +6758,40 @@
           <a:bodyPr rtlCol="0" anchor="ctr" wrap="square" lIns="45720" rIns="45720" tIns="27432" bIns="27432"/>
           <a:lstStyle/>
           <a:p>
-            <a:pPr algn="l"/>
-            <a:r>
-              <a:rPr sz="1000" b="0">
+            <a:pPr algn="ctr"/>
+            <a:r>
+              <a:rPr sz="1000" b="1">
                 <a:solidFill>
                   <a:srgbClr val="1A1A1A"/>
                 </a:solidFill>
                 <a:latin typeface="맑은 고딕"/>
                 <a:ea typeface="맑은 고딕"/>
               </a:rPr>
-              <a:t>신규 data type / memory 추가 시 변경 </a:t>
-            </a:r>
-          </a:p>
-          <a:p>
-            <a:pPr algn="l"/>
-            <a:r>
-              <a:rPr sz="1000" b="0">
-                <a:solidFill>
-                  <a:srgbClr val="1A1A1A"/>
-                </a:solidFill>
-                <a:latin typeface="맑은 고딕"/>
-                <a:ea typeface="맑은 고딕"/>
-              </a:rPr>
-              <a:t>module 수 (논증)</a:t>
-            </a:r>
-          </a:p>
-        </p:txBody>
-      </p:sp>
-      <p:sp>
-        <p:nvSpPr>
-          <p:cNvPr id="84" name="Rectangle 83"/>
+              <a:t>구분 불가</a:t>
+            </a:r>
+          </a:p>
+        </p:txBody>
+      </p:sp>
+      <p:sp>
+        <p:nvSpPr>
+          <p:cNvPr id="90" name="Rectangle 89"/>
           <p:cNvSpPr/>
           <p:nvPr/>
         </p:nvSpPr>
         <p:spPr>
           <a:xfrm>
-            <a:off x="4297680" y="3090672"/>
-            <a:ext cx="1554480" cy="530352"/>
+            <a:off x="4434840" y="3950208"/>
+            <a:ext cx="2331720" cy="365760"/>
           </a:xfrm>
           <a:prstGeom prst="rect">
             <a:avLst/>
           </a:prstGeom>
           <a:solidFill>
-            <a:srgbClr val="FFFFFF"/>
+            <a:srgbClr val="E3F1E3"/>
           </a:solidFill>
           <a:ln w="9525">
             <a:solidFill>
-              <a:srgbClr val="BFBFBF"/>
+              <a:srgbClr val="5B9B5B"/>
             </a:solidFill>
           </a:ln>
           <a:effectLst/>
@@ -6259,38 +6816,38 @@
           <a:p>
             <a:pPr algn="ctr"/>
             <a:r>
-              <a:rPr sz="1000" b="0">
+              <a:rPr sz="1000" b="1">
                 <a:solidFill>
                   <a:srgbClr val="1A1A1A"/>
                 </a:solidFill>
                 <a:latin typeface="맑은 고딕"/>
                 <a:ea typeface="맑은 고딕"/>
               </a:rPr>
-              <a:t>—</a:t>
-            </a:r>
-          </a:p>
-        </p:txBody>
-      </p:sp>
-      <p:sp>
-        <p:nvSpPr>
-          <p:cNvPr id="85" name="Rectangle 84"/>
+              <a:t>C2 (QA1)</a:t>
+            </a:r>
+          </a:p>
+        </p:txBody>
+      </p:sp>
+      <p:sp>
+        <p:nvSpPr>
+          <p:cNvPr id="91" name="Rectangle 90"/>
           <p:cNvSpPr/>
           <p:nvPr/>
         </p:nvSpPr>
         <p:spPr>
           <a:xfrm>
-            <a:off x="5852160" y="3090672"/>
-            <a:ext cx="1828800" cy="530352"/>
+            <a:off x="6766559" y="3950208"/>
+            <a:ext cx="2331720" cy="365760"/>
           </a:xfrm>
           <a:prstGeom prst="rect">
             <a:avLst/>
           </a:prstGeom>
           <a:solidFill>
-            <a:srgbClr val="FFFFFF"/>
+            <a:srgbClr val="E3F1E3"/>
           </a:solidFill>
           <a:ln w="9525">
             <a:solidFill>
-              <a:srgbClr val="BFBFBF"/>
+              <a:srgbClr val="5B9B5B"/>
             </a:solidFill>
           </a:ln>
           <a:effectLst/>
@@ -6315,38 +6872,38 @@
           <a:p>
             <a:pPr algn="ctr"/>
             <a:r>
-              <a:rPr sz="1000" b="0">
+              <a:rPr sz="1000" b="1">
                 <a:solidFill>
                   <a:srgbClr val="1A1A1A"/>
                 </a:solidFill>
                 <a:latin typeface="맑은 고딕"/>
                 <a:ea typeface="맑은 고딕"/>
               </a:rPr>
-              <a:t>★★★ (1~2개)</a:t>
-            </a:r>
-          </a:p>
-        </p:txBody>
-      </p:sp>
-      <p:sp>
-        <p:nvSpPr>
-          <p:cNvPr id="86" name="Rectangle 85"/>
+              <a:t>C2 (합계)</a:t>
+            </a:r>
+          </a:p>
+        </p:txBody>
+      </p:sp>
+      <p:sp>
+        <p:nvSpPr>
+          <p:cNvPr id="92" name="Rectangle 91"/>
           <p:cNvSpPr/>
           <p:nvPr/>
         </p:nvSpPr>
         <p:spPr>
           <a:xfrm>
-            <a:off x="7680960" y="3090672"/>
-            <a:ext cx="1828800" cy="530352"/>
+            <a:off x="9098280" y="3950208"/>
+            <a:ext cx="2331720" cy="365760"/>
           </a:xfrm>
           <a:prstGeom prst="rect">
             <a:avLst/>
           </a:prstGeom>
           <a:solidFill>
-            <a:srgbClr val="FFFFFF"/>
+            <a:srgbClr val="E3F1E3"/>
           </a:solidFill>
           <a:ln w="9525">
             <a:solidFill>
-              <a:srgbClr val="BFBFBF"/>
+              <a:srgbClr val="5B9B5B"/>
             </a:solidFill>
           </a:ln>
           <a:effectLst/>
@@ -6371,350 +6928,14 @@
           <a:p>
             <a:pPr algn="ctr"/>
             <a:r>
-              <a:rPr sz="1000" b="0">
+              <a:rPr sz="1000" b="1">
                 <a:solidFill>
                   <a:srgbClr val="1A1A1A"/>
                 </a:solidFill>
                 <a:latin typeface="맑은 고딕"/>
                 <a:ea typeface="맑은 고딕"/>
               </a:rPr>
-              <a:t>★★ (4개)</a:t>
-            </a:r>
-          </a:p>
-        </p:txBody>
-      </p:sp>
-      <p:sp>
-        <p:nvSpPr>
-          <p:cNvPr id="87" name="Rectangle 86"/>
-          <p:cNvSpPr/>
-          <p:nvPr/>
-        </p:nvSpPr>
-        <p:spPr>
-          <a:xfrm>
-            <a:off x="9509760" y="3090672"/>
-            <a:ext cx="2286000" cy="530352"/>
-          </a:xfrm>
-          <a:prstGeom prst="rect">
-            <a:avLst/>
-          </a:prstGeom>
-          <a:solidFill>
-            <a:srgbClr val="FFFFFF"/>
-          </a:solidFill>
-          <a:ln w="9525">
-            <a:solidFill>
-              <a:srgbClr val="BFBFBF"/>
-            </a:solidFill>
-          </a:ln>
-          <a:effectLst/>
-        </p:spPr>
-        <p:style>
-          <a:lnRef idx="1">
-            <a:schemeClr val="accent1"/>
-          </a:lnRef>
-          <a:fillRef idx="3">
-            <a:schemeClr val="accent1"/>
-          </a:fillRef>
-          <a:effectRef idx="2">
-            <a:schemeClr val="accent1"/>
-          </a:effectRef>
-          <a:fontRef idx="minor">
-            <a:schemeClr val="lt1"/>
-          </a:fontRef>
-        </p:style>
-        <p:txBody>
-          <a:bodyPr rtlCol="0" anchor="ctr" wrap="square" lIns="45720" rIns="45720" tIns="27432" bIns="27432"/>
-          <a:lstStyle/>
-          <a:p>
-            <a:pPr algn="ctr"/>
-            <a:r>
-              <a:rPr sz="1000" b="1">
-                <a:solidFill>
-                  <a:srgbClr val="1A1A1A"/>
-                </a:solidFill>
-                <a:latin typeface="맑은 고딕"/>
-                <a:ea typeface="맑은 고딕"/>
-              </a:rPr>
-              <a:t>C1</a:t>
-            </a:r>
-          </a:p>
-        </p:txBody>
-      </p:sp>
-      <p:sp>
-        <p:nvSpPr>
-          <p:cNvPr id="88" name="Rectangle 87"/>
-          <p:cNvSpPr/>
-          <p:nvPr/>
-        </p:nvSpPr>
-        <p:spPr>
-          <a:xfrm>
-            <a:off x="365760" y="3639312"/>
-            <a:ext cx="5440680" cy="365760"/>
-          </a:xfrm>
-          <a:prstGeom prst="rect">
-            <a:avLst/>
-          </a:prstGeom>
-          <a:solidFill>
-            <a:srgbClr val="DCE9F5"/>
-          </a:solidFill>
-          <a:ln w="9525">
-            <a:solidFill>
-              <a:srgbClr val="4D7EA8"/>
-            </a:solidFill>
-          </a:ln>
-          <a:effectLst/>
-        </p:spPr>
-        <p:style>
-          <a:lnRef idx="1">
-            <a:schemeClr val="accent1"/>
-          </a:lnRef>
-          <a:fillRef idx="3">
-            <a:schemeClr val="accent1"/>
-          </a:fillRef>
-          <a:effectRef idx="2">
-            <a:schemeClr val="accent1"/>
-          </a:effectRef>
-          <a:fontRef idx="minor">
-            <a:schemeClr val="lt1"/>
-          </a:fontRef>
-        </p:style>
-        <p:txBody>
-          <a:bodyPr rtlCol="0" anchor="ctr" wrap="square" lIns="45720" rIns="45720" tIns="27432" bIns="27432"/>
-          <a:lstStyle/>
-          <a:p>
-            <a:pPr algn="ctr"/>
-            <a:r>
-              <a:rPr sz="900" b="1">
-                <a:solidFill>
-                  <a:srgbClr val="1A1A1A"/>
-                </a:solidFill>
-                <a:latin typeface="맑은 고딕"/>
-                <a:ea typeface="맑은 고딕"/>
-              </a:rPr>
-              <a:t>별 합계</a:t>
-            </a:r>
-          </a:p>
-        </p:txBody>
-      </p:sp>
-      <p:sp>
-        <p:nvSpPr>
-          <p:cNvPr id="89" name="Rectangle 88"/>
-          <p:cNvSpPr/>
-          <p:nvPr/>
-        </p:nvSpPr>
-        <p:spPr>
-          <a:xfrm>
-            <a:off x="4297680" y="3639312"/>
-            <a:ext cx="1554480" cy="365760"/>
-          </a:xfrm>
-          <a:prstGeom prst="rect">
-            <a:avLst/>
-          </a:prstGeom>
-          <a:solidFill>
-            <a:srgbClr val="FFFFFF"/>
-          </a:solidFill>
-          <a:ln w="9525">
-            <a:solidFill>
-              <a:srgbClr val="BFBFBF"/>
-            </a:solidFill>
-          </a:ln>
-          <a:effectLst/>
-        </p:spPr>
-        <p:style>
-          <a:lnRef idx="1">
-            <a:schemeClr val="accent1"/>
-          </a:lnRef>
-          <a:fillRef idx="3">
-            <a:schemeClr val="accent1"/>
-          </a:fillRef>
-          <a:effectRef idx="2">
-            <a:schemeClr val="accent1"/>
-          </a:effectRef>
-          <a:fontRef idx="minor">
-            <a:schemeClr val="lt1"/>
-          </a:fontRef>
-        </p:style>
-        <p:txBody>
-          <a:bodyPr rtlCol="0" anchor="ctr" wrap="square" lIns="45720" rIns="45720" tIns="27432" bIns="27432"/>
-          <a:lstStyle/>
-          <a:p>
-            <a:pPr algn="ctr"/>
-            <a:r>
-              <a:rPr sz="900" b="0">
-                <a:solidFill>
-                  <a:srgbClr val="1A1A1A"/>
-                </a:solidFill>
-                <a:latin typeface="맑은 고딕"/>
-                <a:ea typeface="맑은 고딕"/>
-              </a:rPr>
-              <a:t>—</a:t>
-            </a:r>
-          </a:p>
-        </p:txBody>
-      </p:sp>
-      <p:sp>
-        <p:nvSpPr>
-          <p:cNvPr id="90" name="Rectangle 89"/>
-          <p:cNvSpPr/>
-          <p:nvPr/>
-        </p:nvSpPr>
-        <p:spPr>
-          <a:xfrm>
-            <a:off x="5852160" y="3639312"/>
-            <a:ext cx="1828800" cy="365760"/>
-          </a:xfrm>
-          <a:prstGeom prst="rect">
-            <a:avLst/>
-          </a:prstGeom>
-          <a:solidFill>
-            <a:srgbClr val="FFFFFF"/>
-          </a:solidFill>
-          <a:ln w="9525">
-            <a:solidFill>
-              <a:srgbClr val="BFBFBF"/>
-            </a:solidFill>
-          </a:ln>
-          <a:effectLst/>
-        </p:spPr>
-        <p:style>
-          <a:lnRef idx="1">
-            <a:schemeClr val="accent1"/>
-          </a:lnRef>
-          <a:fillRef idx="3">
-            <a:schemeClr val="accent1"/>
-          </a:fillRef>
-          <a:effectRef idx="2">
-            <a:schemeClr val="accent1"/>
-          </a:effectRef>
-          <a:fontRef idx="minor">
-            <a:schemeClr val="lt1"/>
-          </a:fontRef>
-        </p:style>
-        <p:txBody>
-          <a:bodyPr rtlCol="0" anchor="ctr" wrap="square" lIns="45720" rIns="45720" tIns="27432" bIns="27432"/>
-          <a:lstStyle/>
-          <a:p>
-            <a:pPr algn="ctr"/>
-            <a:r>
-              <a:rPr sz="1000" b="1">
-                <a:solidFill>
-                  <a:srgbClr val="1A1A1A"/>
-                </a:solidFill>
-                <a:latin typeface="맑은 고딕"/>
-                <a:ea typeface="맑은 고딕"/>
-              </a:rPr>
-              <a:t>10</a:t>
-            </a:r>
-          </a:p>
-        </p:txBody>
-      </p:sp>
-      <p:sp>
-        <p:nvSpPr>
-          <p:cNvPr id="91" name="Rectangle 90"/>
-          <p:cNvSpPr/>
-          <p:nvPr/>
-        </p:nvSpPr>
-        <p:spPr>
-          <a:xfrm>
-            <a:off x="7680960" y="3639312"/>
-            <a:ext cx="1828800" cy="365760"/>
-          </a:xfrm>
-          <a:prstGeom prst="rect">
-            <a:avLst/>
-          </a:prstGeom>
-          <a:solidFill>
-            <a:srgbClr val="FFFFFF"/>
-          </a:solidFill>
-          <a:ln w="9525">
-            <a:solidFill>
-              <a:srgbClr val="BFBFBF"/>
-            </a:solidFill>
-          </a:ln>
-          <a:effectLst/>
-        </p:spPr>
-        <p:style>
-          <a:lnRef idx="1">
-            <a:schemeClr val="accent1"/>
-          </a:lnRef>
-          <a:fillRef idx="3">
-            <a:schemeClr val="accent1"/>
-          </a:fillRef>
-          <a:effectRef idx="2">
-            <a:schemeClr val="accent1"/>
-          </a:effectRef>
-          <a:fontRef idx="minor">
-            <a:schemeClr val="lt1"/>
-          </a:fontRef>
-        </p:style>
-        <p:txBody>
-          <a:bodyPr rtlCol="0" anchor="ctr" wrap="square" lIns="45720" rIns="45720" tIns="27432" bIns="27432"/>
-          <a:lstStyle/>
-          <a:p>
-            <a:pPr algn="ctr"/>
-            <a:r>
-              <a:rPr sz="1000" b="1">
-                <a:solidFill>
-                  <a:srgbClr val="1A1A1A"/>
-                </a:solidFill>
-                <a:latin typeface="맑은 고딕"/>
-                <a:ea typeface="맑은 고딕"/>
-              </a:rPr>
-              <a:t>10</a:t>
-            </a:r>
-          </a:p>
-        </p:txBody>
-      </p:sp>
-      <p:sp>
-        <p:nvSpPr>
-          <p:cNvPr id="92" name="Rectangle 91"/>
-          <p:cNvSpPr/>
-          <p:nvPr/>
-        </p:nvSpPr>
-        <p:spPr>
-          <a:xfrm>
-            <a:off x="9509760" y="3639312"/>
-            <a:ext cx="2286000" cy="365760"/>
-          </a:xfrm>
-          <a:prstGeom prst="rect">
-            <a:avLst/>
-          </a:prstGeom>
-          <a:solidFill>
-            <a:srgbClr val="FFFFFF"/>
-          </a:solidFill>
-          <a:ln w="9525">
-            <a:solidFill>
-              <a:srgbClr val="BFBFBF"/>
-            </a:solidFill>
-          </a:ln>
-          <a:effectLst/>
-        </p:spPr>
-        <p:style>
-          <a:lnRef idx="1">
-            <a:schemeClr val="accent1"/>
-          </a:lnRef>
-          <a:fillRef idx="3">
-            <a:schemeClr val="accent1"/>
-          </a:fillRef>
-          <a:effectRef idx="2">
-            <a:schemeClr val="accent1"/>
-          </a:effectRef>
-          <a:fontRef idx="minor">
-            <a:schemeClr val="lt1"/>
-          </a:fontRef>
-        </p:style>
-        <p:txBody>
-          <a:bodyPr rtlCol="0" anchor="ctr" wrap="square" lIns="45720" rIns="45720" tIns="27432" bIns="27432"/>
-          <a:lstStyle/>
-          <a:p>
-            <a:pPr algn="ctr"/>
-            <a:r>
-              <a:rPr sz="900" b="1">
-                <a:solidFill>
-                  <a:srgbClr val="1A1A1A"/>
-                </a:solidFill>
-                <a:latin typeface="맑은 고딕"/>
-                <a:ea typeface="맑은 고딕"/>
-              </a:rPr>
-              <a:t>동점</a:t>
+              <a:t>C2 (QA2)</a:t>
             </a:r>
           </a:p>
         </p:txBody>
@@ -6727,8 +6948,8 @@
         </p:nvSpPr>
         <p:spPr>
           <a:xfrm>
-            <a:off x="365760" y="4142232"/>
-            <a:ext cx="5577840" cy="1600200"/>
+            <a:off x="365760" y="4425696"/>
+            <a:ext cx="5577840" cy="1463040"/>
           </a:xfrm>
           <a:prstGeom prst="rect">
             <a:avLst/>
@@ -6763,7 +6984,7 @@
           <a:p>
             <a:pPr algn="l"/>
             <a:r>
-              <a:rPr sz="1000" b="1">
+              <a:rPr sz="950" b="1">
                 <a:solidFill>
                   <a:srgbClr val="404040"/>
                 </a:solidFill>
@@ -6776,66 +6997,53 @@
           <a:p>
             <a:pPr algn="l"/>
             <a:r>
-              <a:rPr sz="1000" b="0">
+              <a:rPr sz="950" b="0">
                 <a:solidFill>
                   <a:srgbClr val="404040"/>
                 </a:solidFill>
                 <a:latin typeface="맑은 고딕"/>
                 <a:ea typeface="맑은 고딕"/>
               </a:rPr>
-              <a:t>- C2는 QA1에서 앞서고, C1은 QA4에서 앞선다. QA2·QA3는 같은 별이다.</a:t>
+              <a:t>- C2 우세 칸: QA1@SYS-H100, QA1@SYS-B200, QA2@SYS-VR, QA3@SYS-B200</a:t>
             </a:r>
           </a:p>
           <a:p>
             <a:pPr algn="l"/>
             <a:r>
-              <a:rPr sz="1000" b="0">
+              <a:rPr sz="950" b="0">
                 <a:solidFill>
                   <a:srgbClr val="404040"/>
                 </a:solidFill>
                 <a:latin typeface="맑은 고딕"/>
                 <a:ea typeface="맑은 고딕"/>
               </a:rPr>
-              <a:t>- C2의 비용: migration 1,239 GiB (C1 110), 링크 점유 9.5% (C1 1.3%), 신규 data type 추가 </a:t>
+              <a:t>- C1 우세 칸: QA3@SYS-VR</a:t>
             </a:r>
           </a:p>
           <a:p>
             <a:pPr algn="l"/>
             <a:r>
-              <a:rPr sz="1000" b="0">
+              <a:rPr sz="950" b="0">
                 <a:solidFill>
                   <a:srgbClr val="404040"/>
                 </a:solidFill>
                 <a:latin typeface="맑은 고딕"/>
                 <a:ea typeface="맑은 고딕"/>
               </a:rPr>
-              <a:t>시 module 4개.</a:t>
+              <a:t>- C2 비용(SYS-B200): migration 1,239 GiB (C1 110), 링크 점유 9.5% (C1 1.3%)</a:t>
             </a:r>
           </a:p>
           <a:p>
             <a:pPr algn="l"/>
             <a:r>
-              <a:rPr sz="1000" b="0">
+              <a:rPr sz="950" b="0">
                 <a:solidFill>
                   <a:srgbClr val="404040"/>
                 </a:solidFill>
                 <a:latin typeface="맑은 고딕"/>
                 <a:ea typeface="맑은 고딕"/>
               </a:rPr>
-              <a:t>- 이득은 static 배치가 stale해지는 Dynamic 시나리오에 집중. Common/Stress는 Baseline</a:t>
-            </a:r>
-          </a:p>
-          <a:p>
-            <a:pPr algn="l"/>
-            <a:r>
-              <a:rPr sz="1000" b="0">
-                <a:solidFill>
-                  <a:srgbClr val="404040"/>
-                </a:solidFill>
-                <a:latin typeface="맑은 고딕"/>
-                <a:ea typeface="맑은 고딕"/>
-              </a:rPr>
-              <a:t>과 동률.</a:t>
+              <a:t>- QA4는 두 후보 같은 별(추정), 값은 C1이 작음</a:t>
             </a:r>
           </a:p>
         </p:txBody>
@@ -6848,8 +7056,8 @@
         </p:nvSpPr>
         <p:spPr>
           <a:xfrm>
-            <a:off x="6126480" y="4142232"/>
-            <a:ext cx="5669280" cy="1600200"/>
+            <a:off x="6126480" y="4425696"/>
+            <a:ext cx="5669280" cy="1463040"/>
           </a:xfrm>
           <a:prstGeom prst="rect">
             <a:avLst/>
@@ -6884,7 +7092,7 @@
           <a:p>
             <a:pPr algn="l"/>
             <a:r>
-              <a:rPr sz="1000" b="1">
+              <a:rPr sz="950" b="1">
                 <a:solidFill>
                   <a:srgbClr val="1A1A1A"/>
                 </a:solidFill>
@@ -6897,40 +7105,40 @@
           <a:p>
             <a:pPr algn="l"/>
             <a:r>
-              <a:rPr sz="1000" b="0">
+              <a:rPr sz="950" b="0">
                 <a:solidFill>
                   <a:srgbClr val="1A1A1A"/>
                 </a:solidFill>
                 <a:latin typeface="맑은 고딕"/>
                 <a:ea typeface="맑은 고딕"/>
               </a:rPr>
-              <a:t>- 규칙: 별 합계 차이 2 이상이면 합계, 아니면 QA 우선순위(QA1 &gt; QA2 &gt; QA3 &gt; QA4).</a:t>
+              <a:t>- 시스템별: 별 합계 차이 2 이상이면 합계, 아니면 QA 우선순위(QA1 &gt; QA2 &gt; QA3 &gt; QA4).</a:t>
             </a:r>
           </a:p>
           <a:p>
             <a:pPr algn="l"/>
             <a:r>
-              <a:rPr sz="1000" b="0">
+              <a:rPr sz="950" b="0">
                 <a:solidFill>
                   <a:srgbClr val="1A1A1A"/>
                 </a:solidFill>
                 <a:latin typeface="맑은 고딕"/>
                 <a:ea typeface="맑은 고딕"/>
               </a:rPr>
-              <a:t>- 합계 10 대 10 (동점)이므로 QA1에서 앞선 후보 선택.</a:t>
+              <a:t>- 시스템별 승수 C1 0 대 C2 3. 우선순위를 뒤집으면 C2.</a:t>
             </a:r>
           </a:p>
           <a:p>
             <a:pPr algn="l"/>
             <a:r>
-              <a:rPr sz="1000" b="0">
+              <a:rPr sz="950" b="0">
                 <a:solidFill>
                   <a:srgbClr val="1A1A1A"/>
                 </a:solidFill>
                 <a:latin typeface="맑은 고딕"/>
                 <a:ea typeface="맑은 고딕"/>
               </a:rPr>
-              <a:t>- 우선순위를 뒤집으면 C1 (QA4). 선택은 우선순위 판단에 의존.</a:t>
+              <a:t>- 우선순위 상태: proposal</a:t>
             </a:r>
           </a:p>
         </p:txBody>
@@ -6943,8 +7151,8 @@
         </p:nvSpPr>
         <p:spPr>
           <a:xfrm>
-            <a:off x="365760" y="5833872"/>
-            <a:ext cx="11430000" cy="548640"/>
+            <a:off x="365760" y="5980176"/>
+            <a:ext cx="11430000" cy="502920"/>
           </a:xfrm>
           <a:prstGeom prst="rect">
             <a:avLst/>
@@ -6979,27 +7187,14 @@
           <a:p>
             <a:pPr algn="l"/>
             <a:r>
-              <a:rPr sz="900" b="0">
+              <a:rPr sz="850" b="0">
                 <a:solidFill>
                   <a:srgbClr val="1A1A1A"/>
                 </a:solidFill>
                 <a:latin typeface="맑은 고딕"/>
                 <a:ea typeface="맑은 고딕"/>
               </a:rPr>
-              <a:t>평가 조건 / 한계: Evidence [B] simulation(config 기반, [A] 실측 아님) + [C] 논증. DP1 별점 경계(QA1 1.30, QA3 +15pp)는 첫 결과를 본 뒤 정함. C2 QA3 +14pp는 경계 직전. 상세: DP1/results/2026-10-02_dp1-qa-evalu</a:t>
-            </a:r>
-          </a:p>
-          <a:p>
-            <a:pPr algn="l"/>
-            <a:r>
-              <a:rPr sz="900" b="0">
-                <a:solidFill>
-                  <a:srgbClr val="1A1A1A"/>
-                </a:solidFill>
-                <a:latin typeface="맑은 고딕"/>
-                <a:ea typeface="맑은 고딕"/>
-              </a:rPr>
-              <a:t>ation.md</a:t>
+              <a:t>한계: [B] simulation(config 기반, [A] 실측 아님). A100/H100 규격·link 스케일 ASSUMED. QA3는 SSD-PIM이 풀의 약 75%라 U가 1~2%대(상대값으로 판정). QA4 공수·비용은 가정 상수 추정. 별 경계는 결과를 본 뒤 정한 값 포함.</a:t>
             </a:r>
           </a:p>
         </p:txBody>

</xml_diff>

<commit_message>
DP1 evaluation: exclude SYS-VR from the evaluated set (owner decision); regenerate result doc and PPTs
Co-Authored-By: Claude Sonnet 5.5 <noreply@anthropic.com>
Claude-Session: https://claude.ai/code/session_018inK4pZJGzYwjdk7QAyZgn
</commit_message>
<xml_diff>
--- a/doc-mk/DP1/DP1-appendix-qa-result.pptx
+++ b/doc-mk/DP1/DP1-appendix-qa-result.pptx
@@ -4785,7 +4785,7 @@
         <p:spPr>
           <a:xfrm>
             <a:off x="2103120" y="1097280"/>
-            <a:ext cx="2331720" cy="310896"/>
+            <a:ext cx="3108960" cy="310896"/>
           </a:xfrm>
           <a:prstGeom prst="rect">
             <a:avLst/>
@@ -4840,8 +4840,8 @@
         </p:nvSpPr>
         <p:spPr>
           <a:xfrm>
-            <a:off x="4434840" y="1097280"/>
-            <a:ext cx="2331720" cy="310896"/>
+            <a:off x="5212079" y="1097280"/>
+            <a:ext cx="3108960" cy="310896"/>
           </a:xfrm>
           <a:prstGeom prst="rect">
             <a:avLst/>
@@ -4896,8 +4896,8 @@
         </p:nvSpPr>
         <p:spPr>
           <a:xfrm>
-            <a:off x="6766559" y="1097280"/>
-            <a:ext cx="2331720" cy="310896"/>
+            <a:off x="8321040" y="1097280"/>
+            <a:ext cx="3108960" cy="310896"/>
           </a:xfrm>
           <a:prstGeom prst="rect">
             <a:avLst/>
@@ -4952,62 +4952,6 @@
         </p:nvSpPr>
         <p:spPr>
           <a:xfrm>
-            <a:off x="9098280" y="1097280"/>
-            <a:ext cx="2331720" cy="310896"/>
-          </a:xfrm>
-          <a:prstGeom prst="rect">
-            <a:avLst/>
-          </a:prstGeom>
-          <a:solidFill>
-            <a:srgbClr val="1F4E79"/>
-          </a:solidFill>
-          <a:ln w="9525">
-            <a:solidFill>
-              <a:srgbClr val="1F4E79"/>
-            </a:solidFill>
-          </a:ln>
-          <a:effectLst/>
-        </p:spPr>
-        <p:style>
-          <a:lnRef idx="1">
-            <a:schemeClr val="accent1"/>
-          </a:lnRef>
-          <a:fillRef idx="3">
-            <a:schemeClr val="accent1"/>
-          </a:fillRef>
-          <a:effectRef idx="2">
-            <a:schemeClr val="accent1"/>
-          </a:effectRef>
-          <a:fontRef idx="minor">
-            <a:schemeClr val="lt1"/>
-          </a:fontRef>
-        </p:style>
-        <p:txBody>
-          <a:bodyPr rtlCol="0" anchor="ctr" wrap="square" lIns="45720" rIns="45720" tIns="27432" bIns="27432"/>
-          <a:lstStyle/>
-          <a:p>
-            <a:pPr algn="ctr"/>
-            <a:r>
-              <a:rPr sz="900" b="1">
-                <a:solidFill>
-                  <a:srgbClr val="FFFFFF"/>
-                </a:solidFill>
-                <a:latin typeface="맑은 고딕"/>
-                <a:ea typeface="맑은 고딕"/>
-              </a:rPr>
-              <a:t>SYS-VR (16개)</a:t>
-            </a:r>
-          </a:p>
-        </p:txBody>
-      </p:sp>
-      <p:sp>
-        <p:nvSpPr>
-          <p:cNvPr id="63" name="Rectangle 62"/>
-          <p:cNvSpPr/>
-          <p:nvPr/>
-        </p:nvSpPr>
-        <p:spPr>
-          <a:xfrm>
             <a:off x="365760" y="1444752"/>
             <a:ext cx="1737360" cy="512064"/>
           </a:xfrm>
@@ -5071,14 +5015,14 @@
       </p:sp>
       <p:sp>
         <p:nvSpPr>
-          <p:cNvPr id="64" name="Rectangle 63"/>
+          <p:cNvPr id="63" name="Rectangle 62"/>
           <p:cNvSpPr/>
           <p:nvPr/>
         </p:nvSpPr>
         <p:spPr>
           <a:xfrm>
             <a:off x="2103120" y="1444752"/>
-            <a:ext cx="2331720" cy="512064"/>
+            <a:ext cx="3108960" cy="512064"/>
           </a:xfrm>
           <a:prstGeom prst="rect">
             <a:avLst/>
@@ -5140,14 +5084,14 @@
       </p:sp>
       <p:sp>
         <p:nvSpPr>
-          <p:cNvPr id="65" name="Rectangle 64"/>
+          <p:cNvPr id="64" name="Rectangle 63"/>
           <p:cNvSpPr/>
           <p:nvPr/>
         </p:nvSpPr>
         <p:spPr>
           <a:xfrm>
-            <a:off x="4434840" y="1444752"/>
-            <a:ext cx="2331720" cy="512064"/>
+            <a:off x="5212079" y="1444752"/>
+            <a:ext cx="3108960" cy="512064"/>
           </a:xfrm>
           <a:prstGeom prst="rect">
             <a:avLst/>
@@ -5209,14 +5153,14 @@
       </p:sp>
       <p:sp>
         <p:nvSpPr>
-          <p:cNvPr id="66" name="Rectangle 65"/>
+          <p:cNvPr id="65" name="Rectangle 64"/>
           <p:cNvSpPr/>
           <p:nvPr/>
         </p:nvSpPr>
         <p:spPr>
           <a:xfrm>
-            <a:off x="6766559" y="1444752"/>
-            <a:ext cx="2331720" cy="512064"/>
+            <a:off x="8321040" y="1444752"/>
+            <a:ext cx="3108960" cy="512064"/>
           </a:xfrm>
           <a:prstGeom prst="rect">
             <a:avLst/>
@@ -5278,14 +5222,83 @@
       </p:sp>
       <p:sp>
         <p:nvSpPr>
+          <p:cNvPr id="66" name="Rectangle 65"/>
+          <p:cNvSpPr/>
+          <p:nvPr/>
+        </p:nvSpPr>
+        <p:spPr>
+          <a:xfrm>
+            <a:off x="365760" y="1975104"/>
+            <a:ext cx="1737360" cy="512064"/>
+          </a:xfrm>
+          <a:prstGeom prst="rect">
+            <a:avLst/>
+          </a:prstGeom>
+          <a:solidFill>
+            <a:srgbClr val="DCE9F5"/>
+          </a:solidFill>
+          <a:ln w="9525">
+            <a:solidFill>
+              <a:srgbClr val="4D7EA8"/>
+            </a:solidFill>
+          </a:ln>
+          <a:effectLst/>
+        </p:spPr>
+        <p:style>
+          <a:lnRef idx="1">
+            <a:schemeClr val="accent1"/>
+          </a:lnRef>
+          <a:fillRef idx="3">
+            <a:schemeClr val="accent1"/>
+          </a:fillRef>
+          <a:effectRef idx="2">
+            <a:schemeClr val="accent1"/>
+          </a:effectRef>
+          <a:fontRef idx="minor">
+            <a:schemeClr val="lt1"/>
+          </a:fontRef>
+        </p:style>
+        <p:txBody>
+          <a:bodyPr rtlCol="0" anchor="ctr" wrap="square" lIns="45720" rIns="45720" tIns="27432" bIns="27432"/>
+          <a:lstStyle/>
+          <a:p>
+            <a:pPr algn="l"/>
+            <a:r>
+              <a:rPr sz="900" b="1">
+                <a:solidFill>
+                  <a:srgbClr val="1A1A1A"/>
+                </a:solidFill>
+                <a:latin typeface="맑은 고딕"/>
+                <a:ea typeface="맑은 고딕"/>
+              </a:rPr>
+              <a:t>QA2 Latency [B]</a:t>
+            </a:r>
+          </a:p>
+          <a:p>
+            <a:pPr algn="l"/>
+            <a:r>
+              <a:rPr sz="900" b="1">
+                <a:solidFill>
+                  <a:srgbClr val="1A1A1A"/>
+                </a:solidFill>
+                <a:latin typeface="맑은 고딕"/>
+                <a:ea typeface="맑은 고딕"/>
+              </a:rPr>
+              <a:t>(개선 배수)</a:t>
+            </a:r>
+          </a:p>
+        </p:txBody>
+      </p:sp>
+      <p:sp>
+        <p:nvSpPr>
           <p:cNvPr id="67" name="Rectangle 66"/>
           <p:cNvSpPr/>
           <p:nvPr/>
         </p:nvSpPr>
         <p:spPr>
           <a:xfrm>
-            <a:off x="9098280" y="1444752"/>
-            <a:ext cx="2331720" cy="512064"/>
+            <a:off x="2103120" y="1975104"/>
+            <a:ext cx="3108960" cy="512064"/>
           </a:xfrm>
           <a:prstGeom prst="rect">
             <a:avLst/>
@@ -5327,7 +5340,7 @@
                 <a:latin typeface="맑은 고딕"/>
                 <a:ea typeface="맑은 고딕"/>
               </a:rPr>
-              <a:t>C1 ★★ x1.00</a:t>
+              <a:t>C1 ★★★ x1.48</a:t>
             </a:r>
           </a:p>
           <a:p>
@@ -5340,7 +5353,7 @@
                 <a:latin typeface="맑은 고딕"/>
                 <a:ea typeface="맑은 고딕"/>
               </a:rPr>
-              <a:t>C2 ★★ x1.04</a:t>
+              <a:t>C2 ★★★ x1.47</a:t>
             </a:r>
           </a:p>
         </p:txBody>
@@ -5353,7 +5366,145 @@
         </p:nvSpPr>
         <p:spPr>
           <a:xfrm>
-            <a:off x="365760" y="1975104"/>
+            <a:off x="5212079" y="1975104"/>
+            <a:ext cx="3108960" cy="512064"/>
+          </a:xfrm>
+          <a:prstGeom prst="rect">
+            <a:avLst/>
+          </a:prstGeom>
+          <a:solidFill>
+            <a:srgbClr val="FFFFFF"/>
+          </a:solidFill>
+          <a:ln w="9525">
+            <a:solidFill>
+              <a:srgbClr val="BFBFBF"/>
+            </a:solidFill>
+          </a:ln>
+          <a:effectLst/>
+        </p:spPr>
+        <p:style>
+          <a:lnRef idx="1">
+            <a:schemeClr val="accent1"/>
+          </a:lnRef>
+          <a:fillRef idx="3">
+            <a:schemeClr val="accent1"/>
+          </a:fillRef>
+          <a:effectRef idx="2">
+            <a:schemeClr val="accent1"/>
+          </a:effectRef>
+          <a:fontRef idx="minor">
+            <a:schemeClr val="lt1"/>
+          </a:fontRef>
+        </p:style>
+        <p:txBody>
+          <a:bodyPr rtlCol="0" anchor="ctr" wrap="square" lIns="45720" rIns="45720" tIns="27432" bIns="27432"/>
+          <a:lstStyle/>
+          <a:p>
+            <a:pPr algn="ctr"/>
+            <a:r>
+              <a:rPr sz="1000" b="0">
+                <a:solidFill>
+                  <a:srgbClr val="1A1A1A"/>
+                </a:solidFill>
+                <a:latin typeface="맑은 고딕"/>
+                <a:ea typeface="맑은 고딕"/>
+              </a:rPr>
+              <a:t>C1 ★★★ x1.39</a:t>
+            </a:r>
+          </a:p>
+          <a:p>
+            <a:pPr algn="ctr"/>
+            <a:r>
+              <a:rPr sz="1000" b="0">
+                <a:solidFill>
+                  <a:srgbClr val="1A1A1A"/>
+                </a:solidFill>
+                <a:latin typeface="맑은 고딕"/>
+                <a:ea typeface="맑은 고딕"/>
+              </a:rPr>
+              <a:t>C2 ★★★ x1.67</a:t>
+            </a:r>
+          </a:p>
+        </p:txBody>
+      </p:sp>
+      <p:sp>
+        <p:nvSpPr>
+          <p:cNvPr id="69" name="Rectangle 68"/>
+          <p:cNvSpPr/>
+          <p:nvPr/>
+        </p:nvSpPr>
+        <p:spPr>
+          <a:xfrm>
+            <a:off x="8321040" y="1975104"/>
+            <a:ext cx="3108960" cy="512064"/>
+          </a:xfrm>
+          <a:prstGeom prst="rect">
+            <a:avLst/>
+          </a:prstGeom>
+          <a:solidFill>
+            <a:srgbClr val="FFFFFF"/>
+          </a:solidFill>
+          <a:ln w="9525">
+            <a:solidFill>
+              <a:srgbClr val="BFBFBF"/>
+            </a:solidFill>
+          </a:ln>
+          <a:effectLst/>
+        </p:spPr>
+        <p:style>
+          <a:lnRef idx="1">
+            <a:schemeClr val="accent1"/>
+          </a:lnRef>
+          <a:fillRef idx="3">
+            <a:schemeClr val="accent1"/>
+          </a:fillRef>
+          <a:effectRef idx="2">
+            <a:schemeClr val="accent1"/>
+          </a:effectRef>
+          <a:fontRef idx="minor">
+            <a:schemeClr val="lt1"/>
+          </a:fontRef>
+        </p:style>
+        <p:txBody>
+          <a:bodyPr rtlCol="0" anchor="ctr" wrap="square" lIns="45720" rIns="45720" tIns="27432" bIns="27432"/>
+          <a:lstStyle/>
+          <a:p>
+            <a:pPr algn="ctr"/>
+            <a:r>
+              <a:rPr sz="1000" b="0">
+                <a:solidFill>
+                  <a:srgbClr val="1A1A1A"/>
+                </a:solidFill>
+                <a:latin typeface="맑은 고딕"/>
+                <a:ea typeface="맑은 고딕"/>
+              </a:rPr>
+              <a:t>C1 ★★★ x1.41</a:t>
+            </a:r>
+          </a:p>
+          <a:p>
+            <a:pPr algn="ctr"/>
+            <a:r>
+              <a:rPr sz="1000" b="0">
+                <a:solidFill>
+                  <a:srgbClr val="1A1A1A"/>
+                </a:solidFill>
+                <a:latin typeface="맑은 고딕"/>
+                <a:ea typeface="맑은 고딕"/>
+              </a:rPr>
+              <a:t>C2 ★★★ x1.65</a:t>
+            </a:r>
+          </a:p>
+        </p:txBody>
+      </p:sp>
+      <p:sp>
+        <p:nvSpPr>
+          <p:cNvPr id="70" name="Rectangle 69"/>
+          <p:cNvSpPr/>
+          <p:nvPr/>
+        </p:nvSpPr>
+        <p:spPr>
+          <a:xfrm>
+            <a:off x="365760" y="2505456"/>
             <a:ext cx="1737360" cy="512064"/>
           </a:xfrm>
           <a:prstGeom prst="rect">
@@ -5396,7 +5547,7 @@
                 <a:latin typeface="맑은 고딕"/>
                 <a:ea typeface="맑은 고딕"/>
               </a:rPr>
-              <a:t>QA2 Latency [B]</a:t>
+              <a:t>QA3 Utilization [B]</a:t>
             </a:r>
           </a:p>
           <a:p>
@@ -5409,21 +5560,21 @@
                 <a:latin typeface="맑은 고딕"/>
                 <a:ea typeface="맑은 고딕"/>
               </a:rPr>
-              <a:t>(개선 배수)</a:t>
-            </a:r>
-          </a:p>
-        </p:txBody>
-      </p:sp>
-      <p:sp>
-        <p:nvSpPr>
-          <p:cNvPr id="69" name="Rectangle 68"/>
+              <a:t>(전 메모리 풀 U 상대)</a:t>
+            </a:r>
+          </a:p>
+        </p:txBody>
+      </p:sp>
+      <p:sp>
+        <p:nvSpPr>
+          <p:cNvPr id="71" name="Rectangle 70"/>
           <p:cNvSpPr/>
           <p:nvPr/>
         </p:nvSpPr>
         <p:spPr>
           <a:xfrm>
-            <a:off x="2103120" y="1975104"/>
-            <a:ext cx="2331720" cy="512064"/>
+            <a:off x="2103120" y="2505456"/>
+            <a:ext cx="3108960" cy="512064"/>
           </a:xfrm>
           <a:prstGeom prst="rect">
             <a:avLst/>
@@ -5465,7 +5616,7 @@
                 <a:latin typeface="맑은 고딕"/>
                 <a:ea typeface="맑은 고딕"/>
               </a:rPr>
-              <a:t>C1 ★★★ x1.48</a:t>
+              <a:t>C1 ★★ x1.10</a:t>
             </a:r>
           </a:p>
           <a:p>
@@ -5478,21 +5629,21 @@
                 <a:latin typeface="맑은 고딕"/>
                 <a:ea typeface="맑은 고딕"/>
               </a:rPr>
-              <a:t>C2 ★★★ x1.47</a:t>
-            </a:r>
-          </a:p>
-        </p:txBody>
-      </p:sp>
-      <p:sp>
-        <p:nvSpPr>
-          <p:cNvPr id="70" name="Rectangle 69"/>
+              <a:t>C2 ★★ x1.00</a:t>
+            </a:r>
+          </a:p>
+        </p:txBody>
+      </p:sp>
+      <p:sp>
+        <p:nvSpPr>
+          <p:cNvPr id="72" name="Rectangle 71"/>
           <p:cNvSpPr/>
           <p:nvPr/>
         </p:nvSpPr>
         <p:spPr>
           <a:xfrm>
-            <a:off x="4434840" y="1975104"/>
-            <a:ext cx="2331720" cy="512064"/>
+            <a:off x="5212079" y="2505456"/>
+            <a:ext cx="3108960" cy="512064"/>
           </a:xfrm>
           <a:prstGeom prst="rect">
             <a:avLst/>
@@ -5534,7 +5685,7 @@
                 <a:latin typeface="맑은 고딕"/>
                 <a:ea typeface="맑은 고딕"/>
               </a:rPr>
-              <a:t>C1 ★★★ x1.39</a:t>
+              <a:t>C1 ★★ x1.11</a:t>
             </a:r>
           </a:p>
           <a:p>
@@ -5547,21 +5698,21 @@
                 <a:latin typeface="맑은 고딕"/>
                 <a:ea typeface="맑은 고딕"/>
               </a:rPr>
-              <a:t>C2 ★★★ x1.67</a:t>
-            </a:r>
-          </a:p>
-        </p:txBody>
-      </p:sp>
-      <p:sp>
-        <p:nvSpPr>
-          <p:cNvPr id="71" name="Rectangle 70"/>
+              <a:t>C2 ★★ x1.01</a:t>
+            </a:r>
+          </a:p>
+        </p:txBody>
+      </p:sp>
+      <p:sp>
+        <p:nvSpPr>
+          <p:cNvPr id="73" name="Rectangle 72"/>
           <p:cNvSpPr/>
           <p:nvPr/>
         </p:nvSpPr>
         <p:spPr>
           <a:xfrm>
-            <a:off x="6766559" y="1975104"/>
-            <a:ext cx="2331720" cy="512064"/>
+            <a:off x="8321040" y="2505456"/>
+            <a:ext cx="3108960" cy="512064"/>
           </a:xfrm>
           <a:prstGeom prst="rect">
             <a:avLst/>
@@ -5603,7 +5754,7 @@
                 <a:latin typeface="맑은 고딕"/>
                 <a:ea typeface="맑은 고딕"/>
               </a:rPr>
-              <a:t>C1 ★★★ x1.41</a:t>
+              <a:t>C1 ★★ x1.20</a:t>
             </a:r>
           </a:p>
           <a:p>
@@ -5616,21 +5767,90 @@
                 <a:latin typeface="맑은 고딕"/>
                 <a:ea typeface="맑은 고딕"/>
               </a:rPr>
-              <a:t>C2 ★★★ x1.65</a:t>
-            </a:r>
-          </a:p>
-        </p:txBody>
-      </p:sp>
-      <p:sp>
-        <p:nvSpPr>
-          <p:cNvPr id="72" name="Rectangle 71"/>
+              <a:t>C2 ★★★ x1.25</a:t>
+            </a:r>
+          </a:p>
+        </p:txBody>
+      </p:sp>
+      <p:sp>
+        <p:nvSpPr>
+          <p:cNvPr id="74" name="Rectangle 73"/>
           <p:cNvSpPr/>
           <p:nvPr/>
         </p:nvSpPr>
         <p:spPr>
           <a:xfrm>
-            <a:off x="9098280" y="1975104"/>
-            <a:ext cx="2331720" cy="512064"/>
+            <a:off x="365760" y="3035808"/>
+            <a:ext cx="1737360" cy="512064"/>
+          </a:xfrm>
+          <a:prstGeom prst="rect">
+            <a:avLst/>
+          </a:prstGeom>
+          <a:solidFill>
+            <a:srgbClr val="DCE9F5"/>
+          </a:solidFill>
+          <a:ln w="9525">
+            <a:solidFill>
+              <a:srgbClr val="4D7EA8"/>
+            </a:solidFill>
+          </a:ln>
+          <a:effectLst/>
+        </p:spPr>
+        <p:style>
+          <a:lnRef idx="1">
+            <a:schemeClr val="accent1"/>
+          </a:lnRef>
+          <a:fillRef idx="3">
+            <a:schemeClr val="accent1"/>
+          </a:fillRef>
+          <a:effectRef idx="2">
+            <a:schemeClr val="accent1"/>
+          </a:effectRef>
+          <a:fontRef idx="minor">
+            <a:schemeClr val="lt1"/>
+          </a:fontRef>
+        </p:style>
+        <p:txBody>
+          <a:bodyPr rtlCol="0" anchor="ctr" wrap="square" lIns="45720" rIns="45720" tIns="27432" bIns="27432"/>
+          <a:lstStyle/>
+          <a:p>
+            <a:pPr algn="l"/>
+            <a:r>
+              <a:rPr sz="900" b="1">
+                <a:solidFill>
+                  <a:srgbClr val="1A1A1A"/>
+                </a:solidFill>
+                <a:latin typeface="맑은 고딕"/>
+                <a:ea typeface="맑은 고딕"/>
+              </a:rPr>
+              <a:t>QA4 Modifiability [B+C]</a:t>
+            </a:r>
+          </a:p>
+          <a:p>
+            <a:pPr algn="l"/>
+            <a:r>
+              <a:rPr sz="900" b="1">
+                <a:solidFill>
+                  <a:srgbClr val="1A1A1A"/>
+                </a:solidFill>
+                <a:latin typeface="맑은 고딕"/>
+                <a:ea typeface="맑은 고딕"/>
+              </a:rPr>
+              <a:t>(module / 에이전트 비용)</a:t>
+            </a:r>
+          </a:p>
+        </p:txBody>
+      </p:sp>
+      <p:sp>
+        <p:nvSpPr>
+          <p:cNvPr id="75" name="Rectangle 74"/>
+          <p:cNvSpPr/>
+          <p:nvPr/>
+        </p:nvSpPr>
+        <p:spPr>
+          <a:xfrm>
+            <a:off x="2103120" y="3035808"/>
+            <a:ext cx="3108960" cy="512064"/>
           </a:xfrm>
           <a:prstGeom prst="rect">
             <a:avLst/>
@@ -5672,7 +5892,7 @@
                 <a:latin typeface="맑은 고딕"/>
                 <a:ea typeface="맑은 고딕"/>
               </a:rPr>
-              <a:t>C1 ★★ x1.05</a:t>
+              <a:t>C1 ★★ 1.8모듈 $1.16</a:t>
             </a:r>
           </a:p>
           <a:p>
@@ -5685,21 +5905,159 @@
                 <a:latin typeface="맑은 고딕"/>
                 <a:ea typeface="맑은 고딕"/>
               </a:rPr>
-              <a:t>C2 ★★★ x1.29</a:t>
-            </a:r>
-          </a:p>
-        </p:txBody>
-      </p:sp>
-      <p:sp>
-        <p:nvSpPr>
-          <p:cNvPr id="73" name="Rectangle 72"/>
+              <a:t>C2 ★★ 2.5모듈 $1.49</a:t>
+            </a:r>
+          </a:p>
+        </p:txBody>
+      </p:sp>
+      <p:sp>
+        <p:nvSpPr>
+          <p:cNvPr id="76" name="Rectangle 75"/>
           <p:cNvSpPr/>
           <p:nvPr/>
         </p:nvSpPr>
         <p:spPr>
           <a:xfrm>
-            <a:off x="365760" y="2505456"/>
-            <a:ext cx="1737360" cy="512064"/>
+            <a:off x="5212079" y="3035808"/>
+            <a:ext cx="3108960" cy="512064"/>
+          </a:xfrm>
+          <a:prstGeom prst="rect">
+            <a:avLst/>
+          </a:prstGeom>
+          <a:solidFill>
+            <a:srgbClr val="FFFFFF"/>
+          </a:solidFill>
+          <a:ln w="9525">
+            <a:solidFill>
+              <a:srgbClr val="BFBFBF"/>
+            </a:solidFill>
+          </a:ln>
+          <a:effectLst/>
+        </p:spPr>
+        <p:style>
+          <a:lnRef idx="1">
+            <a:schemeClr val="accent1"/>
+          </a:lnRef>
+          <a:fillRef idx="3">
+            <a:schemeClr val="accent1"/>
+          </a:fillRef>
+          <a:effectRef idx="2">
+            <a:schemeClr val="accent1"/>
+          </a:effectRef>
+          <a:fontRef idx="minor">
+            <a:schemeClr val="lt1"/>
+          </a:fontRef>
+        </p:style>
+        <p:txBody>
+          <a:bodyPr rtlCol="0" anchor="ctr" wrap="square" lIns="45720" rIns="45720" tIns="27432" bIns="27432"/>
+          <a:lstStyle/>
+          <a:p>
+            <a:pPr algn="ctr"/>
+            <a:r>
+              <a:rPr sz="1000" b="0">
+                <a:solidFill>
+                  <a:srgbClr val="1A1A1A"/>
+                </a:solidFill>
+                <a:latin typeface="맑은 고딕"/>
+                <a:ea typeface="맑은 고딕"/>
+              </a:rPr>
+              <a:t>C1 ★★ 1.8모듈 $1.16</a:t>
+            </a:r>
+          </a:p>
+          <a:p>
+            <a:pPr algn="ctr"/>
+            <a:r>
+              <a:rPr sz="1000" b="0">
+                <a:solidFill>
+                  <a:srgbClr val="1A1A1A"/>
+                </a:solidFill>
+                <a:latin typeface="맑은 고딕"/>
+                <a:ea typeface="맑은 고딕"/>
+              </a:rPr>
+              <a:t>C2 ★★ 2.5모듈 $1.49</a:t>
+            </a:r>
+          </a:p>
+        </p:txBody>
+      </p:sp>
+      <p:sp>
+        <p:nvSpPr>
+          <p:cNvPr id="77" name="Rectangle 76"/>
+          <p:cNvSpPr/>
+          <p:nvPr/>
+        </p:nvSpPr>
+        <p:spPr>
+          <a:xfrm>
+            <a:off x="8321040" y="3035808"/>
+            <a:ext cx="3108960" cy="512064"/>
+          </a:xfrm>
+          <a:prstGeom prst="rect">
+            <a:avLst/>
+          </a:prstGeom>
+          <a:solidFill>
+            <a:srgbClr val="FFFFFF"/>
+          </a:solidFill>
+          <a:ln w="9525">
+            <a:solidFill>
+              <a:srgbClr val="BFBFBF"/>
+            </a:solidFill>
+          </a:ln>
+          <a:effectLst/>
+        </p:spPr>
+        <p:style>
+          <a:lnRef idx="1">
+            <a:schemeClr val="accent1"/>
+          </a:lnRef>
+          <a:fillRef idx="3">
+            <a:schemeClr val="accent1"/>
+          </a:fillRef>
+          <a:effectRef idx="2">
+            <a:schemeClr val="accent1"/>
+          </a:effectRef>
+          <a:fontRef idx="minor">
+            <a:schemeClr val="lt1"/>
+          </a:fontRef>
+        </p:style>
+        <p:txBody>
+          <a:bodyPr rtlCol="0" anchor="ctr" wrap="square" lIns="45720" rIns="45720" tIns="27432" bIns="27432"/>
+          <a:lstStyle/>
+          <a:p>
+            <a:pPr algn="ctr"/>
+            <a:r>
+              <a:rPr sz="1000" b="0">
+                <a:solidFill>
+                  <a:srgbClr val="1A1A1A"/>
+                </a:solidFill>
+                <a:latin typeface="맑은 고딕"/>
+                <a:ea typeface="맑은 고딕"/>
+              </a:rPr>
+              <a:t>C1 ★★ 1.8모듈 $1.16</a:t>
+            </a:r>
+          </a:p>
+          <a:p>
+            <a:pPr algn="ctr"/>
+            <a:r>
+              <a:rPr sz="1000" b="0">
+                <a:solidFill>
+                  <a:srgbClr val="1A1A1A"/>
+                </a:solidFill>
+                <a:latin typeface="맑은 고딕"/>
+                <a:ea typeface="맑은 고딕"/>
+              </a:rPr>
+              <a:t>C2 ★★ 2.5모듈 $1.49</a:t>
+            </a:r>
+          </a:p>
+        </p:txBody>
+      </p:sp>
+      <p:sp>
+        <p:nvSpPr>
+          <p:cNvPr id="78" name="Rectangle 77"/>
+          <p:cNvSpPr/>
+          <p:nvPr/>
+        </p:nvSpPr>
+        <p:spPr>
+          <a:xfrm>
+            <a:off x="365760" y="3566160"/>
+            <a:ext cx="1737360" cy="365760"/>
           </a:xfrm>
           <a:prstGeom prst="rect">
             <a:avLst/>
@@ -5741,34 +6099,21 @@
                 <a:latin typeface="맑은 고딕"/>
                 <a:ea typeface="맑은 고딕"/>
               </a:rPr>
-              <a:t>QA3 Utilization [B]</a:t>
-            </a:r>
-          </a:p>
-          <a:p>
-            <a:pPr algn="l"/>
-            <a:r>
-              <a:rPr sz="900" b="1">
-                <a:solidFill>
-                  <a:srgbClr val="1A1A1A"/>
-                </a:solidFill>
-                <a:latin typeface="맑은 고딕"/>
-                <a:ea typeface="맑은 고딕"/>
-              </a:rPr>
-              <a:t>(전 메모리 풀 U 상대)</a:t>
-            </a:r>
-          </a:p>
-        </p:txBody>
-      </p:sp>
-      <p:sp>
-        <p:nvSpPr>
-          <p:cNvPr id="74" name="Rectangle 73"/>
+              <a:t>별 합계 (C1 / C2)</a:t>
+            </a:r>
+          </a:p>
+        </p:txBody>
+      </p:sp>
+      <p:sp>
+        <p:nvSpPr>
+          <p:cNvPr id="79" name="Rectangle 78"/>
           <p:cNvSpPr/>
           <p:nvPr/>
         </p:nvSpPr>
         <p:spPr>
           <a:xfrm>
-            <a:off x="2103120" y="2505456"/>
-            <a:ext cx="2331720" cy="512064"/>
+            <a:off x="2103120" y="3566160"/>
+            <a:ext cx="3108960" cy="365760"/>
           </a:xfrm>
           <a:prstGeom prst="rect">
             <a:avLst/>
@@ -5803,41 +6148,28 @@
           <a:p>
             <a:pPr algn="ctr"/>
             <a:r>
-              <a:rPr sz="1000" b="0">
+              <a:rPr sz="1000" b="1">
                 <a:solidFill>
                   <a:srgbClr val="1A1A1A"/>
                 </a:solidFill>
                 <a:latin typeface="맑은 고딕"/>
                 <a:ea typeface="맑은 고딕"/>
               </a:rPr>
-              <a:t>C1 ★★ x1.10</a:t>
-            </a:r>
-          </a:p>
-          <a:p>
-            <a:pPr algn="ctr"/>
-            <a:r>
-              <a:rPr sz="1000" b="0">
-                <a:solidFill>
-                  <a:srgbClr val="1A1A1A"/>
-                </a:solidFill>
-                <a:latin typeface="맑은 고딕"/>
-                <a:ea typeface="맑은 고딕"/>
-              </a:rPr>
-              <a:t>C2 ★★ x1.00</a:t>
-            </a:r>
-          </a:p>
-        </p:txBody>
-      </p:sp>
-      <p:sp>
-        <p:nvSpPr>
-          <p:cNvPr id="75" name="Rectangle 74"/>
+              <a:t>10 / 10</a:t>
+            </a:r>
+          </a:p>
+        </p:txBody>
+      </p:sp>
+      <p:sp>
+        <p:nvSpPr>
+          <p:cNvPr id="80" name="Rectangle 79"/>
           <p:cNvSpPr/>
           <p:nvPr/>
         </p:nvSpPr>
         <p:spPr>
           <a:xfrm>
-            <a:off x="4434840" y="2505456"/>
-            <a:ext cx="2331720" cy="512064"/>
+            <a:off x="5212079" y="3566160"/>
+            <a:ext cx="3108960" cy="365760"/>
           </a:xfrm>
           <a:prstGeom prst="rect">
             <a:avLst/>
@@ -5872,41 +6204,28 @@
           <a:p>
             <a:pPr algn="ctr"/>
             <a:r>
-              <a:rPr sz="1000" b="0">
+              <a:rPr sz="1000" b="1">
                 <a:solidFill>
                   <a:srgbClr val="1A1A1A"/>
                 </a:solidFill>
                 <a:latin typeface="맑은 고딕"/>
                 <a:ea typeface="맑은 고딕"/>
               </a:rPr>
-              <a:t>C1 ★★ x1.11</a:t>
-            </a:r>
-          </a:p>
-          <a:p>
-            <a:pPr algn="ctr"/>
-            <a:r>
-              <a:rPr sz="1000" b="0">
-                <a:solidFill>
-                  <a:srgbClr val="1A1A1A"/>
-                </a:solidFill>
-                <a:latin typeface="맑은 고딕"/>
-                <a:ea typeface="맑은 고딕"/>
-              </a:rPr>
-              <a:t>C2 ★★ x1.01</a:t>
-            </a:r>
-          </a:p>
-        </p:txBody>
-      </p:sp>
-      <p:sp>
-        <p:nvSpPr>
-          <p:cNvPr id="76" name="Rectangle 75"/>
+              <a:t>9 / 10</a:t>
+            </a:r>
+          </a:p>
+        </p:txBody>
+      </p:sp>
+      <p:sp>
+        <p:nvSpPr>
+          <p:cNvPr id="81" name="Rectangle 80"/>
           <p:cNvSpPr/>
           <p:nvPr/>
         </p:nvSpPr>
         <p:spPr>
           <a:xfrm>
-            <a:off x="6766559" y="2505456"/>
-            <a:ext cx="2331720" cy="512064"/>
+            <a:off x="8321040" y="3566160"/>
+            <a:ext cx="3108960" cy="365760"/>
           </a:xfrm>
           <a:prstGeom prst="rect">
             <a:avLst/>
@@ -5941,110 +6260,28 @@
           <a:p>
             <a:pPr algn="ctr"/>
             <a:r>
-              <a:rPr sz="1000" b="0">
+              <a:rPr sz="1000" b="1">
                 <a:solidFill>
                   <a:srgbClr val="1A1A1A"/>
                 </a:solidFill>
                 <a:latin typeface="맑은 고딕"/>
                 <a:ea typeface="맑은 고딕"/>
               </a:rPr>
-              <a:t>C1 ★★ x1.20</a:t>
-            </a:r>
-          </a:p>
-          <a:p>
-            <a:pPr algn="ctr"/>
-            <a:r>
-              <a:rPr sz="1000" b="0">
-                <a:solidFill>
-                  <a:srgbClr val="1A1A1A"/>
-                </a:solidFill>
-                <a:latin typeface="맑은 고딕"/>
-                <a:ea typeface="맑은 고딕"/>
-              </a:rPr>
-              <a:t>C2 ★★★ x1.25</a:t>
-            </a:r>
-          </a:p>
-        </p:txBody>
-      </p:sp>
-      <p:sp>
-        <p:nvSpPr>
-          <p:cNvPr id="77" name="Rectangle 76"/>
+              <a:t>9 / 11</a:t>
+            </a:r>
+          </a:p>
+        </p:txBody>
+      </p:sp>
+      <p:sp>
+        <p:nvSpPr>
+          <p:cNvPr id="82" name="Rectangle 81"/>
           <p:cNvSpPr/>
           <p:nvPr/>
         </p:nvSpPr>
         <p:spPr>
           <a:xfrm>
-            <a:off x="9098280" y="2505456"/>
-            <a:ext cx="2331720" cy="512064"/>
-          </a:xfrm>
-          <a:prstGeom prst="rect">
-            <a:avLst/>
-          </a:prstGeom>
-          <a:solidFill>
-            <a:srgbClr val="FFFFFF"/>
-          </a:solidFill>
-          <a:ln w="9525">
-            <a:solidFill>
-              <a:srgbClr val="BFBFBF"/>
-            </a:solidFill>
-          </a:ln>
-          <a:effectLst/>
-        </p:spPr>
-        <p:style>
-          <a:lnRef idx="1">
-            <a:schemeClr val="accent1"/>
-          </a:lnRef>
-          <a:fillRef idx="3">
-            <a:schemeClr val="accent1"/>
-          </a:fillRef>
-          <a:effectRef idx="2">
-            <a:schemeClr val="accent1"/>
-          </a:effectRef>
-          <a:fontRef idx="minor">
-            <a:schemeClr val="lt1"/>
-          </a:fontRef>
-        </p:style>
-        <p:txBody>
-          <a:bodyPr rtlCol="0" anchor="ctr" wrap="square" lIns="45720" rIns="45720" tIns="27432" bIns="27432"/>
-          <a:lstStyle/>
-          <a:p>
-            <a:pPr algn="ctr"/>
-            <a:r>
-              <a:rPr sz="1000" b="0">
-                <a:solidFill>
-                  <a:srgbClr val="1A1A1A"/>
-                </a:solidFill>
-                <a:latin typeface="맑은 고딕"/>
-                <a:ea typeface="맑은 고딕"/>
-              </a:rPr>
-              <a:t>C1 ★★ x0.99</a:t>
-            </a:r>
-          </a:p>
-          <a:p>
-            <a:pPr algn="ctr"/>
-            <a:r>
-              <a:rPr sz="1000" b="0">
-                <a:solidFill>
-                  <a:srgbClr val="1A1A1A"/>
-                </a:solidFill>
-                <a:latin typeface="맑은 고딕"/>
-                <a:ea typeface="맑은 고딕"/>
-              </a:rPr>
-              <a:t>C2 ★ x0.93</a:t>
-            </a:r>
-          </a:p>
-        </p:txBody>
-      </p:sp>
-      <p:sp>
-        <p:nvSpPr>
-          <p:cNvPr id="78" name="Rectangle 77"/>
-          <p:cNvSpPr/>
-          <p:nvPr/>
-        </p:nvSpPr>
-        <p:spPr>
-          <a:xfrm>
-            <a:off x="365760" y="3035808"/>
-            <a:ext cx="1737360" cy="512064"/>
+            <a:off x="365760" y="3950208"/>
+            <a:ext cx="1737360" cy="365760"/>
           </a:xfrm>
           <a:prstGeom prst="rect">
             <a:avLst/>
@@ -6086,296 +6323,7 @@
                 <a:latin typeface="맑은 고딕"/>
                 <a:ea typeface="맑은 고딕"/>
               </a:rPr>
-              <a:t>QA4 Modifiability [B+C]</a:t>
-            </a:r>
-          </a:p>
-          <a:p>
-            <a:pPr algn="l"/>
-            <a:r>
-              <a:rPr sz="900" b="1">
-                <a:solidFill>
-                  <a:srgbClr val="1A1A1A"/>
-                </a:solidFill>
-                <a:latin typeface="맑은 고딕"/>
-                <a:ea typeface="맑은 고딕"/>
-              </a:rPr>
-              <a:t>(module / 에이전트 비용)</a:t>
-            </a:r>
-          </a:p>
-        </p:txBody>
-      </p:sp>
-      <p:sp>
-        <p:nvSpPr>
-          <p:cNvPr id="79" name="Rectangle 78"/>
-          <p:cNvSpPr/>
-          <p:nvPr/>
-        </p:nvSpPr>
-        <p:spPr>
-          <a:xfrm>
-            <a:off x="2103120" y="3035808"/>
-            <a:ext cx="2331720" cy="512064"/>
-          </a:xfrm>
-          <a:prstGeom prst="rect">
-            <a:avLst/>
-          </a:prstGeom>
-          <a:solidFill>
-            <a:srgbClr val="FFFFFF"/>
-          </a:solidFill>
-          <a:ln w="9525">
-            <a:solidFill>
-              <a:srgbClr val="BFBFBF"/>
-            </a:solidFill>
-          </a:ln>
-          <a:effectLst/>
-        </p:spPr>
-        <p:style>
-          <a:lnRef idx="1">
-            <a:schemeClr val="accent1"/>
-          </a:lnRef>
-          <a:fillRef idx="3">
-            <a:schemeClr val="accent1"/>
-          </a:fillRef>
-          <a:effectRef idx="2">
-            <a:schemeClr val="accent1"/>
-          </a:effectRef>
-          <a:fontRef idx="minor">
-            <a:schemeClr val="lt1"/>
-          </a:fontRef>
-        </p:style>
-        <p:txBody>
-          <a:bodyPr rtlCol="0" anchor="ctr" wrap="square" lIns="45720" rIns="45720" tIns="27432" bIns="27432"/>
-          <a:lstStyle/>
-          <a:p>
-            <a:pPr algn="ctr"/>
-            <a:r>
-              <a:rPr sz="1000" b="0">
-                <a:solidFill>
-                  <a:srgbClr val="1A1A1A"/>
-                </a:solidFill>
-                <a:latin typeface="맑은 고딕"/>
-                <a:ea typeface="맑은 고딕"/>
-              </a:rPr>
-              <a:t>C1 ★★ 1.8모듈 $1.16</a:t>
-            </a:r>
-          </a:p>
-          <a:p>
-            <a:pPr algn="ctr"/>
-            <a:r>
-              <a:rPr sz="1000" b="0">
-                <a:solidFill>
-                  <a:srgbClr val="1A1A1A"/>
-                </a:solidFill>
-                <a:latin typeface="맑은 고딕"/>
-                <a:ea typeface="맑은 고딕"/>
-              </a:rPr>
-              <a:t>C2 ★★ 2.5모듈 $1.49</a:t>
-            </a:r>
-          </a:p>
-        </p:txBody>
-      </p:sp>
-      <p:sp>
-        <p:nvSpPr>
-          <p:cNvPr id="80" name="Rectangle 79"/>
-          <p:cNvSpPr/>
-          <p:nvPr/>
-        </p:nvSpPr>
-        <p:spPr>
-          <a:xfrm>
-            <a:off x="4434840" y="3035808"/>
-            <a:ext cx="2331720" cy="512064"/>
-          </a:xfrm>
-          <a:prstGeom prst="rect">
-            <a:avLst/>
-          </a:prstGeom>
-          <a:solidFill>
-            <a:srgbClr val="FFFFFF"/>
-          </a:solidFill>
-          <a:ln w="9525">
-            <a:solidFill>
-              <a:srgbClr val="BFBFBF"/>
-            </a:solidFill>
-          </a:ln>
-          <a:effectLst/>
-        </p:spPr>
-        <p:style>
-          <a:lnRef idx="1">
-            <a:schemeClr val="accent1"/>
-          </a:lnRef>
-          <a:fillRef idx="3">
-            <a:schemeClr val="accent1"/>
-          </a:fillRef>
-          <a:effectRef idx="2">
-            <a:schemeClr val="accent1"/>
-          </a:effectRef>
-          <a:fontRef idx="minor">
-            <a:schemeClr val="lt1"/>
-          </a:fontRef>
-        </p:style>
-        <p:txBody>
-          <a:bodyPr rtlCol="0" anchor="ctr" wrap="square" lIns="45720" rIns="45720" tIns="27432" bIns="27432"/>
-          <a:lstStyle/>
-          <a:p>
-            <a:pPr algn="ctr"/>
-            <a:r>
-              <a:rPr sz="1000" b="0">
-                <a:solidFill>
-                  <a:srgbClr val="1A1A1A"/>
-                </a:solidFill>
-                <a:latin typeface="맑은 고딕"/>
-                <a:ea typeface="맑은 고딕"/>
-              </a:rPr>
-              <a:t>C1 ★★ 1.8모듈 $1.16</a:t>
-            </a:r>
-          </a:p>
-          <a:p>
-            <a:pPr algn="ctr"/>
-            <a:r>
-              <a:rPr sz="1000" b="0">
-                <a:solidFill>
-                  <a:srgbClr val="1A1A1A"/>
-                </a:solidFill>
-                <a:latin typeface="맑은 고딕"/>
-                <a:ea typeface="맑은 고딕"/>
-              </a:rPr>
-              <a:t>C2 ★★ 2.5모듈 $1.49</a:t>
-            </a:r>
-          </a:p>
-        </p:txBody>
-      </p:sp>
-      <p:sp>
-        <p:nvSpPr>
-          <p:cNvPr id="81" name="Rectangle 80"/>
-          <p:cNvSpPr/>
-          <p:nvPr/>
-        </p:nvSpPr>
-        <p:spPr>
-          <a:xfrm>
-            <a:off x="6766559" y="3035808"/>
-            <a:ext cx="2331720" cy="512064"/>
-          </a:xfrm>
-          <a:prstGeom prst="rect">
-            <a:avLst/>
-          </a:prstGeom>
-          <a:solidFill>
-            <a:srgbClr val="FFFFFF"/>
-          </a:solidFill>
-          <a:ln w="9525">
-            <a:solidFill>
-              <a:srgbClr val="BFBFBF"/>
-            </a:solidFill>
-          </a:ln>
-          <a:effectLst/>
-        </p:spPr>
-        <p:style>
-          <a:lnRef idx="1">
-            <a:schemeClr val="accent1"/>
-          </a:lnRef>
-          <a:fillRef idx="3">
-            <a:schemeClr val="accent1"/>
-          </a:fillRef>
-          <a:effectRef idx="2">
-            <a:schemeClr val="accent1"/>
-          </a:effectRef>
-          <a:fontRef idx="minor">
-            <a:schemeClr val="lt1"/>
-          </a:fontRef>
-        </p:style>
-        <p:txBody>
-          <a:bodyPr rtlCol="0" anchor="ctr" wrap="square" lIns="45720" rIns="45720" tIns="27432" bIns="27432"/>
-          <a:lstStyle/>
-          <a:p>
-            <a:pPr algn="ctr"/>
-            <a:r>
-              <a:rPr sz="1000" b="0">
-                <a:solidFill>
-                  <a:srgbClr val="1A1A1A"/>
-                </a:solidFill>
-                <a:latin typeface="맑은 고딕"/>
-                <a:ea typeface="맑은 고딕"/>
-              </a:rPr>
-              <a:t>C1 ★★ 1.8모듈 $1.16</a:t>
-            </a:r>
-          </a:p>
-          <a:p>
-            <a:pPr algn="ctr"/>
-            <a:r>
-              <a:rPr sz="1000" b="0">
-                <a:solidFill>
-                  <a:srgbClr val="1A1A1A"/>
-                </a:solidFill>
-                <a:latin typeface="맑은 고딕"/>
-                <a:ea typeface="맑은 고딕"/>
-              </a:rPr>
-              <a:t>C2 ★★ 2.5모듈 $1.49</a:t>
-            </a:r>
-          </a:p>
-        </p:txBody>
-      </p:sp>
-      <p:sp>
-        <p:nvSpPr>
-          <p:cNvPr id="82" name="Rectangle 81"/>
-          <p:cNvSpPr/>
-          <p:nvPr/>
-        </p:nvSpPr>
-        <p:spPr>
-          <a:xfrm>
-            <a:off x="9098280" y="3035808"/>
-            <a:ext cx="2331720" cy="512064"/>
-          </a:xfrm>
-          <a:prstGeom prst="rect">
-            <a:avLst/>
-          </a:prstGeom>
-          <a:solidFill>
-            <a:srgbClr val="FFFFFF"/>
-          </a:solidFill>
-          <a:ln w="9525">
-            <a:solidFill>
-              <a:srgbClr val="BFBFBF"/>
-            </a:solidFill>
-          </a:ln>
-          <a:effectLst/>
-        </p:spPr>
-        <p:style>
-          <a:lnRef idx="1">
-            <a:schemeClr val="accent1"/>
-          </a:lnRef>
-          <a:fillRef idx="3">
-            <a:schemeClr val="accent1"/>
-          </a:fillRef>
-          <a:effectRef idx="2">
-            <a:schemeClr val="accent1"/>
-          </a:effectRef>
-          <a:fontRef idx="minor">
-            <a:schemeClr val="lt1"/>
-          </a:fontRef>
-        </p:style>
-        <p:txBody>
-          <a:bodyPr rtlCol="0" anchor="ctr" wrap="square" lIns="45720" rIns="45720" tIns="27432" bIns="27432"/>
-          <a:lstStyle/>
-          <a:p>
-            <a:pPr algn="ctr"/>
-            <a:r>
-              <a:rPr sz="1000" b="0">
-                <a:solidFill>
-                  <a:srgbClr val="1A1A1A"/>
-                </a:solidFill>
-                <a:latin typeface="맑은 고딕"/>
-                <a:ea typeface="맑은 고딕"/>
-              </a:rPr>
-              <a:t>C1 ★★ 1.8모듈 $1.16</a:t>
-            </a:r>
-          </a:p>
-          <a:p>
-            <a:pPr algn="ctr"/>
-            <a:r>
-              <a:rPr sz="1000" b="0">
-                <a:solidFill>
-                  <a:srgbClr val="1A1A1A"/>
-                </a:solidFill>
-                <a:latin typeface="맑은 고딕"/>
-                <a:ea typeface="맑은 고딕"/>
-              </a:rPr>
-              <a:t>C2 ★★ 2.5모듈 $1.49</a:t>
+              <a:t>선택 (우선순위 규칙)</a:t>
             </a:r>
           </a:p>
         </p:txBody>
@@ -6388,344 +6336,8 @@
         </p:nvSpPr>
         <p:spPr>
           <a:xfrm>
-            <a:off x="365760" y="3566160"/>
-            <a:ext cx="1737360" cy="365760"/>
-          </a:xfrm>
-          <a:prstGeom prst="rect">
-            <a:avLst/>
-          </a:prstGeom>
-          <a:solidFill>
-            <a:srgbClr val="DCE9F5"/>
-          </a:solidFill>
-          <a:ln w="9525">
-            <a:solidFill>
-              <a:srgbClr val="4D7EA8"/>
-            </a:solidFill>
-          </a:ln>
-          <a:effectLst/>
-        </p:spPr>
-        <p:style>
-          <a:lnRef idx="1">
-            <a:schemeClr val="accent1"/>
-          </a:lnRef>
-          <a:fillRef idx="3">
-            <a:schemeClr val="accent1"/>
-          </a:fillRef>
-          <a:effectRef idx="2">
-            <a:schemeClr val="accent1"/>
-          </a:effectRef>
-          <a:fontRef idx="minor">
-            <a:schemeClr val="lt1"/>
-          </a:fontRef>
-        </p:style>
-        <p:txBody>
-          <a:bodyPr rtlCol="0" anchor="ctr" wrap="square" lIns="45720" rIns="45720" tIns="27432" bIns="27432"/>
-          <a:lstStyle/>
-          <a:p>
-            <a:pPr algn="l"/>
-            <a:r>
-              <a:rPr sz="900" b="1">
-                <a:solidFill>
-                  <a:srgbClr val="1A1A1A"/>
-                </a:solidFill>
-                <a:latin typeface="맑은 고딕"/>
-                <a:ea typeface="맑은 고딕"/>
-              </a:rPr>
-              <a:t>별 합계 (C1 / C2)</a:t>
-            </a:r>
-          </a:p>
-        </p:txBody>
-      </p:sp>
-      <p:sp>
-        <p:nvSpPr>
-          <p:cNvPr id="84" name="Rectangle 83"/>
-          <p:cNvSpPr/>
-          <p:nvPr/>
-        </p:nvSpPr>
-        <p:spPr>
-          <a:xfrm>
-            <a:off x="2103120" y="3566160"/>
-            <a:ext cx="2331720" cy="365760"/>
-          </a:xfrm>
-          <a:prstGeom prst="rect">
-            <a:avLst/>
-          </a:prstGeom>
-          <a:solidFill>
-            <a:srgbClr val="FFFFFF"/>
-          </a:solidFill>
-          <a:ln w="9525">
-            <a:solidFill>
-              <a:srgbClr val="BFBFBF"/>
-            </a:solidFill>
-          </a:ln>
-          <a:effectLst/>
-        </p:spPr>
-        <p:style>
-          <a:lnRef idx="1">
-            <a:schemeClr val="accent1"/>
-          </a:lnRef>
-          <a:fillRef idx="3">
-            <a:schemeClr val="accent1"/>
-          </a:fillRef>
-          <a:effectRef idx="2">
-            <a:schemeClr val="accent1"/>
-          </a:effectRef>
-          <a:fontRef idx="minor">
-            <a:schemeClr val="lt1"/>
-          </a:fontRef>
-        </p:style>
-        <p:txBody>
-          <a:bodyPr rtlCol="0" anchor="ctr" wrap="square" lIns="45720" rIns="45720" tIns="27432" bIns="27432"/>
-          <a:lstStyle/>
-          <a:p>
-            <a:pPr algn="ctr"/>
-            <a:r>
-              <a:rPr sz="1000" b="1">
-                <a:solidFill>
-                  <a:srgbClr val="1A1A1A"/>
-                </a:solidFill>
-                <a:latin typeface="맑은 고딕"/>
-                <a:ea typeface="맑은 고딕"/>
-              </a:rPr>
-              <a:t>10 / 10</a:t>
-            </a:r>
-          </a:p>
-        </p:txBody>
-      </p:sp>
-      <p:sp>
-        <p:nvSpPr>
-          <p:cNvPr id="85" name="Rectangle 84"/>
-          <p:cNvSpPr/>
-          <p:nvPr/>
-        </p:nvSpPr>
-        <p:spPr>
-          <a:xfrm>
-            <a:off x="4434840" y="3566160"/>
-            <a:ext cx="2331720" cy="365760"/>
-          </a:xfrm>
-          <a:prstGeom prst="rect">
-            <a:avLst/>
-          </a:prstGeom>
-          <a:solidFill>
-            <a:srgbClr val="FFFFFF"/>
-          </a:solidFill>
-          <a:ln w="9525">
-            <a:solidFill>
-              <a:srgbClr val="BFBFBF"/>
-            </a:solidFill>
-          </a:ln>
-          <a:effectLst/>
-        </p:spPr>
-        <p:style>
-          <a:lnRef idx="1">
-            <a:schemeClr val="accent1"/>
-          </a:lnRef>
-          <a:fillRef idx="3">
-            <a:schemeClr val="accent1"/>
-          </a:fillRef>
-          <a:effectRef idx="2">
-            <a:schemeClr val="accent1"/>
-          </a:effectRef>
-          <a:fontRef idx="minor">
-            <a:schemeClr val="lt1"/>
-          </a:fontRef>
-        </p:style>
-        <p:txBody>
-          <a:bodyPr rtlCol="0" anchor="ctr" wrap="square" lIns="45720" rIns="45720" tIns="27432" bIns="27432"/>
-          <a:lstStyle/>
-          <a:p>
-            <a:pPr algn="ctr"/>
-            <a:r>
-              <a:rPr sz="1000" b="1">
-                <a:solidFill>
-                  <a:srgbClr val="1A1A1A"/>
-                </a:solidFill>
-                <a:latin typeface="맑은 고딕"/>
-                <a:ea typeface="맑은 고딕"/>
-              </a:rPr>
-              <a:t>9 / 10</a:t>
-            </a:r>
-          </a:p>
-        </p:txBody>
-      </p:sp>
-      <p:sp>
-        <p:nvSpPr>
-          <p:cNvPr id="86" name="Rectangle 85"/>
-          <p:cNvSpPr/>
-          <p:nvPr/>
-        </p:nvSpPr>
-        <p:spPr>
-          <a:xfrm>
-            <a:off x="6766559" y="3566160"/>
-            <a:ext cx="2331720" cy="365760"/>
-          </a:xfrm>
-          <a:prstGeom prst="rect">
-            <a:avLst/>
-          </a:prstGeom>
-          <a:solidFill>
-            <a:srgbClr val="FFFFFF"/>
-          </a:solidFill>
-          <a:ln w="9525">
-            <a:solidFill>
-              <a:srgbClr val="BFBFBF"/>
-            </a:solidFill>
-          </a:ln>
-          <a:effectLst/>
-        </p:spPr>
-        <p:style>
-          <a:lnRef idx="1">
-            <a:schemeClr val="accent1"/>
-          </a:lnRef>
-          <a:fillRef idx="3">
-            <a:schemeClr val="accent1"/>
-          </a:fillRef>
-          <a:effectRef idx="2">
-            <a:schemeClr val="accent1"/>
-          </a:effectRef>
-          <a:fontRef idx="minor">
-            <a:schemeClr val="lt1"/>
-          </a:fontRef>
-        </p:style>
-        <p:txBody>
-          <a:bodyPr rtlCol="0" anchor="ctr" wrap="square" lIns="45720" rIns="45720" tIns="27432" bIns="27432"/>
-          <a:lstStyle/>
-          <a:p>
-            <a:pPr algn="ctr"/>
-            <a:r>
-              <a:rPr sz="1000" b="1">
-                <a:solidFill>
-                  <a:srgbClr val="1A1A1A"/>
-                </a:solidFill>
-                <a:latin typeface="맑은 고딕"/>
-                <a:ea typeface="맑은 고딕"/>
-              </a:rPr>
-              <a:t>9 / 11</a:t>
-            </a:r>
-          </a:p>
-        </p:txBody>
-      </p:sp>
-      <p:sp>
-        <p:nvSpPr>
-          <p:cNvPr id="87" name="Rectangle 86"/>
-          <p:cNvSpPr/>
-          <p:nvPr/>
-        </p:nvSpPr>
-        <p:spPr>
-          <a:xfrm>
-            <a:off x="9098280" y="3566160"/>
-            <a:ext cx="2331720" cy="365760"/>
-          </a:xfrm>
-          <a:prstGeom prst="rect">
-            <a:avLst/>
-          </a:prstGeom>
-          <a:solidFill>
-            <a:srgbClr val="FFFFFF"/>
-          </a:solidFill>
-          <a:ln w="9525">
-            <a:solidFill>
-              <a:srgbClr val="BFBFBF"/>
-            </a:solidFill>
-          </a:ln>
-          <a:effectLst/>
-        </p:spPr>
-        <p:style>
-          <a:lnRef idx="1">
-            <a:schemeClr val="accent1"/>
-          </a:lnRef>
-          <a:fillRef idx="3">
-            <a:schemeClr val="accent1"/>
-          </a:fillRef>
-          <a:effectRef idx="2">
-            <a:schemeClr val="accent1"/>
-          </a:effectRef>
-          <a:fontRef idx="minor">
-            <a:schemeClr val="lt1"/>
-          </a:fontRef>
-        </p:style>
-        <p:txBody>
-          <a:bodyPr rtlCol="0" anchor="ctr" wrap="square" lIns="45720" rIns="45720" tIns="27432" bIns="27432"/>
-          <a:lstStyle/>
-          <a:p>
-            <a:pPr algn="ctr"/>
-            <a:r>
-              <a:rPr sz="1000" b="1">
-                <a:solidFill>
-                  <a:srgbClr val="1A1A1A"/>
-                </a:solidFill>
-                <a:latin typeface="맑은 고딕"/>
-                <a:ea typeface="맑은 고딕"/>
-              </a:rPr>
-              <a:t>8 / 8</a:t>
-            </a:r>
-          </a:p>
-        </p:txBody>
-      </p:sp>
-      <p:sp>
-        <p:nvSpPr>
-          <p:cNvPr id="88" name="Rectangle 87"/>
-          <p:cNvSpPr/>
-          <p:nvPr/>
-        </p:nvSpPr>
-        <p:spPr>
-          <a:xfrm>
-            <a:off x="365760" y="3950208"/>
-            <a:ext cx="1737360" cy="365760"/>
-          </a:xfrm>
-          <a:prstGeom prst="rect">
-            <a:avLst/>
-          </a:prstGeom>
-          <a:solidFill>
-            <a:srgbClr val="DCE9F5"/>
-          </a:solidFill>
-          <a:ln w="9525">
-            <a:solidFill>
-              <a:srgbClr val="4D7EA8"/>
-            </a:solidFill>
-          </a:ln>
-          <a:effectLst/>
-        </p:spPr>
-        <p:style>
-          <a:lnRef idx="1">
-            <a:schemeClr val="accent1"/>
-          </a:lnRef>
-          <a:fillRef idx="3">
-            <a:schemeClr val="accent1"/>
-          </a:fillRef>
-          <a:effectRef idx="2">
-            <a:schemeClr val="accent1"/>
-          </a:effectRef>
-          <a:fontRef idx="minor">
-            <a:schemeClr val="lt1"/>
-          </a:fontRef>
-        </p:style>
-        <p:txBody>
-          <a:bodyPr rtlCol="0" anchor="ctr" wrap="square" lIns="45720" rIns="45720" tIns="27432" bIns="27432"/>
-          <a:lstStyle/>
-          <a:p>
-            <a:pPr algn="l"/>
-            <a:r>
-              <a:rPr sz="900" b="1">
-                <a:solidFill>
-                  <a:srgbClr val="1A1A1A"/>
-                </a:solidFill>
-                <a:latin typeface="맑은 고딕"/>
-                <a:ea typeface="맑은 고딕"/>
-              </a:rPr>
-              <a:t>선택 (우선순위 규칙)</a:t>
-            </a:r>
-          </a:p>
-        </p:txBody>
-      </p:sp>
-      <p:sp>
-        <p:nvSpPr>
-          <p:cNvPr id="89" name="Rectangle 88"/>
-          <p:cNvSpPr/>
-          <p:nvPr/>
-        </p:nvSpPr>
-        <p:spPr>
-          <a:xfrm>
             <a:off x="2103120" y="3950208"/>
-            <a:ext cx="2331720" cy="365760"/>
+            <a:ext cx="3108960" cy="365760"/>
           </a:xfrm>
           <a:prstGeom prst="rect">
             <a:avLst/>
@@ -6774,14 +6386,14 @@
       </p:sp>
       <p:sp>
         <p:nvSpPr>
-          <p:cNvPr id="90" name="Rectangle 89"/>
+          <p:cNvPr id="84" name="Rectangle 83"/>
           <p:cNvSpPr/>
           <p:nvPr/>
         </p:nvSpPr>
         <p:spPr>
           <a:xfrm>
-            <a:off x="4434840" y="3950208"/>
-            <a:ext cx="2331720" cy="365760"/>
+            <a:off x="5212079" y="3950208"/>
+            <a:ext cx="3108960" cy="365760"/>
           </a:xfrm>
           <a:prstGeom prst="rect">
             <a:avLst/>
@@ -6830,14 +6442,14 @@
       </p:sp>
       <p:sp>
         <p:nvSpPr>
-          <p:cNvPr id="91" name="Rectangle 90"/>
+          <p:cNvPr id="85" name="Rectangle 84"/>
           <p:cNvSpPr/>
           <p:nvPr/>
         </p:nvSpPr>
         <p:spPr>
           <a:xfrm>
-            <a:off x="6766559" y="3950208"/>
-            <a:ext cx="2331720" cy="365760"/>
+            <a:off x="8321040" y="3950208"/>
+            <a:ext cx="3108960" cy="365760"/>
           </a:xfrm>
           <a:prstGeom prst="rect">
             <a:avLst/>
@@ -6886,14 +6498,122 @@
       </p:sp>
       <p:sp>
         <p:nvSpPr>
-          <p:cNvPr id="92" name="Rectangle 91"/>
+          <p:cNvPr id="86" name="Rectangle 85"/>
           <p:cNvSpPr/>
           <p:nvPr/>
         </p:nvSpPr>
         <p:spPr>
           <a:xfrm>
-            <a:off x="9098280" y="3950208"/>
-            <a:ext cx="2331720" cy="365760"/>
+            <a:off x="365760" y="4425696"/>
+            <a:ext cx="5577840" cy="1463040"/>
+          </a:xfrm>
+          <a:prstGeom prst="rect">
+            <a:avLst/>
+          </a:prstGeom>
+          <a:solidFill>
+            <a:srgbClr val="F2F2F2"/>
+          </a:solidFill>
+          <a:ln w="9525">
+            <a:solidFill>
+              <a:srgbClr val="BFBFBF"/>
+            </a:solidFill>
+          </a:ln>
+          <a:effectLst/>
+        </p:spPr>
+        <p:style>
+          <a:lnRef idx="1">
+            <a:schemeClr val="accent1"/>
+          </a:lnRef>
+          <a:fillRef idx="3">
+            <a:schemeClr val="accent1"/>
+          </a:fillRef>
+          <a:effectRef idx="2">
+            <a:schemeClr val="accent1"/>
+          </a:effectRef>
+          <a:fontRef idx="minor">
+            <a:schemeClr val="lt1"/>
+          </a:fontRef>
+        </p:style>
+        <p:txBody>
+          <a:bodyPr rtlCol="0" anchor="t" wrap="square" lIns="45720" rIns="45720" tIns="27432" bIns="27432"/>
+          <a:lstStyle/>
+          <a:p>
+            <a:pPr algn="l"/>
+            <a:r>
+              <a:rPr sz="950" b="1">
+                <a:solidFill>
+                  <a:srgbClr val="404040"/>
+                </a:solidFill>
+                <a:latin typeface="맑은 고딕"/>
+                <a:ea typeface="맑은 고딕"/>
+              </a:rPr>
+              <a:t>Trade-off</a:t>
+            </a:r>
+          </a:p>
+          <a:p>
+            <a:pPr algn="l"/>
+            <a:r>
+              <a:rPr sz="950" b="0">
+                <a:solidFill>
+                  <a:srgbClr val="404040"/>
+                </a:solidFill>
+                <a:latin typeface="맑은 고딕"/>
+                <a:ea typeface="맑은 고딕"/>
+              </a:rPr>
+              <a:t>- C2 우세 칸: QA1@SYS-H100, QA1@SYS-B200, QA3@SYS-B200</a:t>
+            </a:r>
+          </a:p>
+          <a:p>
+            <a:pPr algn="l"/>
+            <a:r>
+              <a:rPr sz="950" b="0">
+                <a:solidFill>
+                  <a:srgbClr val="404040"/>
+                </a:solidFill>
+                <a:latin typeface="맑은 고딕"/>
+                <a:ea typeface="맑은 고딕"/>
+              </a:rPr>
+              <a:t>- C1 우세 칸: 없음</a:t>
+            </a:r>
+          </a:p>
+          <a:p>
+            <a:pPr algn="l"/>
+            <a:r>
+              <a:rPr sz="950" b="0">
+                <a:solidFill>
+                  <a:srgbClr val="404040"/>
+                </a:solidFill>
+                <a:latin typeface="맑은 고딕"/>
+                <a:ea typeface="맑은 고딕"/>
+              </a:rPr>
+              <a:t>- C2 비용(SYS-B200): migration 1,239 GiB (C1 110), 링크 점유 9.5% (C1 1.3%)</a:t>
+            </a:r>
+          </a:p>
+          <a:p>
+            <a:pPr algn="l"/>
+            <a:r>
+              <a:rPr sz="950" b="0">
+                <a:solidFill>
+                  <a:srgbClr val="404040"/>
+                </a:solidFill>
+                <a:latin typeface="맑은 고딕"/>
+                <a:ea typeface="맑은 고딕"/>
+              </a:rPr>
+              <a:t>- QA4는 두 후보 같은 별(추정), 값은 C1이 작음</a:t>
+            </a:r>
+          </a:p>
+        </p:txBody>
+      </p:sp>
+      <p:sp>
+        <p:nvSpPr>
+          <p:cNvPr id="87" name="Rectangle 86"/>
+          <p:cNvSpPr/>
+          <p:nvPr/>
+        </p:nvSpPr>
+        <p:spPr>
+          <a:xfrm>
+            <a:off x="6126480" y="4425696"/>
+            <a:ext cx="5669280" cy="1463040"/>
           </a:xfrm>
           <a:prstGeom prst="rect">
             <a:avLst/>
@@ -6923,170 +6643,6 @@
           </a:fontRef>
         </p:style>
         <p:txBody>
-          <a:bodyPr rtlCol="0" anchor="ctr" wrap="square" lIns="45720" rIns="45720" tIns="27432" bIns="27432"/>
-          <a:lstStyle/>
-          <a:p>
-            <a:pPr algn="ctr"/>
-            <a:r>
-              <a:rPr sz="1000" b="1">
-                <a:solidFill>
-                  <a:srgbClr val="1A1A1A"/>
-                </a:solidFill>
-                <a:latin typeface="맑은 고딕"/>
-                <a:ea typeface="맑은 고딕"/>
-              </a:rPr>
-              <a:t>C2 (QA2)</a:t>
-            </a:r>
-          </a:p>
-        </p:txBody>
-      </p:sp>
-      <p:sp>
-        <p:nvSpPr>
-          <p:cNvPr id="93" name="Rectangle 92"/>
-          <p:cNvSpPr/>
-          <p:nvPr/>
-        </p:nvSpPr>
-        <p:spPr>
-          <a:xfrm>
-            <a:off x="365760" y="4425696"/>
-            <a:ext cx="5577840" cy="1463040"/>
-          </a:xfrm>
-          <a:prstGeom prst="rect">
-            <a:avLst/>
-          </a:prstGeom>
-          <a:solidFill>
-            <a:srgbClr val="F2F2F2"/>
-          </a:solidFill>
-          <a:ln w="9525">
-            <a:solidFill>
-              <a:srgbClr val="BFBFBF"/>
-            </a:solidFill>
-          </a:ln>
-          <a:effectLst/>
-        </p:spPr>
-        <p:style>
-          <a:lnRef idx="1">
-            <a:schemeClr val="accent1"/>
-          </a:lnRef>
-          <a:fillRef idx="3">
-            <a:schemeClr val="accent1"/>
-          </a:fillRef>
-          <a:effectRef idx="2">
-            <a:schemeClr val="accent1"/>
-          </a:effectRef>
-          <a:fontRef idx="minor">
-            <a:schemeClr val="lt1"/>
-          </a:fontRef>
-        </p:style>
-        <p:txBody>
-          <a:bodyPr rtlCol="0" anchor="t" wrap="square" lIns="45720" rIns="45720" tIns="27432" bIns="27432"/>
-          <a:lstStyle/>
-          <a:p>
-            <a:pPr algn="l"/>
-            <a:r>
-              <a:rPr sz="950" b="1">
-                <a:solidFill>
-                  <a:srgbClr val="404040"/>
-                </a:solidFill>
-                <a:latin typeface="맑은 고딕"/>
-                <a:ea typeface="맑은 고딕"/>
-              </a:rPr>
-              <a:t>Trade-off</a:t>
-            </a:r>
-          </a:p>
-          <a:p>
-            <a:pPr algn="l"/>
-            <a:r>
-              <a:rPr sz="950" b="0">
-                <a:solidFill>
-                  <a:srgbClr val="404040"/>
-                </a:solidFill>
-                <a:latin typeface="맑은 고딕"/>
-                <a:ea typeface="맑은 고딕"/>
-              </a:rPr>
-              <a:t>- C2 우세 칸: QA1@SYS-H100, QA1@SYS-B200, QA2@SYS-VR, QA3@SYS-B200</a:t>
-            </a:r>
-          </a:p>
-          <a:p>
-            <a:pPr algn="l"/>
-            <a:r>
-              <a:rPr sz="950" b="0">
-                <a:solidFill>
-                  <a:srgbClr val="404040"/>
-                </a:solidFill>
-                <a:latin typeface="맑은 고딕"/>
-                <a:ea typeface="맑은 고딕"/>
-              </a:rPr>
-              <a:t>- C1 우세 칸: QA3@SYS-VR</a:t>
-            </a:r>
-          </a:p>
-          <a:p>
-            <a:pPr algn="l"/>
-            <a:r>
-              <a:rPr sz="950" b="0">
-                <a:solidFill>
-                  <a:srgbClr val="404040"/>
-                </a:solidFill>
-                <a:latin typeface="맑은 고딕"/>
-                <a:ea typeface="맑은 고딕"/>
-              </a:rPr>
-              <a:t>- C2 비용(SYS-B200): migration 1,239 GiB (C1 110), 링크 점유 9.5% (C1 1.3%)</a:t>
-            </a:r>
-          </a:p>
-          <a:p>
-            <a:pPr algn="l"/>
-            <a:r>
-              <a:rPr sz="950" b="0">
-                <a:solidFill>
-                  <a:srgbClr val="404040"/>
-                </a:solidFill>
-                <a:latin typeface="맑은 고딕"/>
-                <a:ea typeface="맑은 고딕"/>
-              </a:rPr>
-              <a:t>- QA4는 두 후보 같은 별(추정), 값은 C1이 작음</a:t>
-            </a:r>
-          </a:p>
-        </p:txBody>
-      </p:sp>
-      <p:sp>
-        <p:nvSpPr>
-          <p:cNvPr id="94" name="Rectangle 93"/>
-          <p:cNvSpPr/>
-          <p:nvPr/>
-        </p:nvSpPr>
-        <p:spPr>
-          <a:xfrm>
-            <a:off x="6126480" y="4425696"/>
-            <a:ext cx="5669280" cy="1463040"/>
-          </a:xfrm>
-          <a:prstGeom prst="rect">
-            <a:avLst/>
-          </a:prstGeom>
-          <a:solidFill>
-            <a:srgbClr val="E3F1E3"/>
-          </a:solidFill>
-          <a:ln w="9525">
-            <a:solidFill>
-              <a:srgbClr val="5B9B5B"/>
-            </a:solidFill>
-          </a:ln>
-          <a:effectLst/>
-        </p:spPr>
-        <p:style>
-          <a:lnRef idx="1">
-            <a:schemeClr val="accent1"/>
-          </a:lnRef>
-          <a:fillRef idx="3">
-            <a:schemeClr val="accent1"/>
-          </a:fillRef>
-          <a:effectRef idx="2">
-            <a:schemeClr val="accent1"/>
-          </a:effectRef>
-          <a:fontRef idx="minor">
-            <a:schemeClr val="lt1"/>
-          </a:fontRef>
-        </p:style>
-        <p:txBody>
           <a:bodyPr rtlCol="0" anchor="t" wrap="square" lIns="45720" rIns="45720" tIns="27432" bIns="27432"/>
           <a:lstStyle/>
           <a:p>
@@ -7125,7 +6681,7 @@
                 <a:latin typeface="맑은 고딕"/>
                 <a:ea typeface="맑은 고딕"/>
               </a:rPr>
-              <a:t>- 시스템별 승수 C1 0 대 C2 3. 우선순위를 뒤집으면 C2.</a:t>
+              <a:t>- 시스템별 승수 C1 0 대 C2 2. 우선순위를 뒤집으면 C2.</a:t>
             </a:r>
           </a:p>
           <a:p>
@@ -7145,7 +6701,7 @@
       </p:sp>
       <p:sp>
         <p:nvSpPr>
-          <p:cNvPr id="95" name="Rectangle 94"/>
+          <p:cNvPr id="88" name="Rectangle 87"/>
           <p:cNvSpPr/>
           <p:nvPr/>
         </p:nvSpPr>

</xml_diff>

<commit_message>
DP1 evaluation: systems H100/B200 only, QA4 mean aggregation (v2), selection by star total with priority only on ties
Co-Authored-By: Claude Sonnet 5.5 <noreply@anthropic.com>
Claude-Session: https://claude.ai/code/session_018inK4pZJGzYwjdk7QAyZgn
</commit_message>
<xml_diff>
--- a/doc-mk/DP1/DP1-appendix-qa-result.pptx
+++ b/doc-mk/DP1/DP1-appendix-qa-result.pptx
@@ -4608,7 +4608,7 @@
                   <a:schemeClr val="bg1"/>
                 </a:solidFill>
               </a:rPr>
-              <a:t>DP1 평가 결과 - QA별 후보 비교 (메모리 세대별 4개 시스템, Common + Stress + Dynamic)</a:t>
+              <a:t>DP1 평가 결과 - QA별 후보 비교 (메모리 세대별 2개 시스템: H100, B200, Common + Stress + Dynamic)</a:t>
             </a:r>
             <a:r>
               <a:rPr lang="en-US" altLang="ko-KR" sz="1400" b="1" dirty="0">
@@ -4785,7 +4785,7 @@
         <p:spPr>
           <a:xfrm>
             <a:off x="2103120" y="1097280"/>
-            <a:ext cx="3108960" cy="310896"/>
+            <a:ext cx="4663440" cy="310896"/>
           </a:xfrm>
           <a:prstGeom prst="rect">
             <a:avLst/>
@@ -4827,7 +4827,7 @@
                 <a:latin typeface="맑은 고딕"/>
                 <a:ea typeface="맑은 고딕"/>
               </a:rPr>
-              <a:t>SYS-A100 (7개)</a:t>
+              <a:t>SYS-H100 (10개)</a:t>
             </a:r>
           </a:p>
         </p:txBody>
@@ -4840,8 +4840,8 @@
         </p:nvSpPr>
         <p:spPr>
           <a:xfrm>
-            <a:off x="5212079" y="1097280"/>
-            <a:ext cx="3108960" cy="310896"/>
+            <a:off x="6766559" y="1097280"/>
+            <a:ext cx="4663440" cy="310896"/>
           </a:xfrm>
           <a:prstGeom prst="rect">
             <a:avLst/>
@@ -4883,7 +4883,7 @@
                 <a:latin typeface="맑은 고딕"/>
                 <a:ea typeface="맑은 고딕"/>
               </a:rPr>
-              <a:t>SYS-H100 (10개)</a:t>
+              <a:t>SYS-B200 (13개)</a:t>
             </a:r>
           </a:p>
         </p:txBody>
@@ -4891,62 +4891,6 @@
       <p:sp>
         <p:nvSpPr>
           <p:cNvPr id="61" name="Rectangle 60"/>
-          <p:cNvSpPr/>
-          <p:nvPr/>
-        </p:nvSpPr>
-        <p:spPr>
-          <a:xfrm>
-            <a:off x="8321040" y="1097280"/>
-            <a:ext cx="3108960" cy="310896"/>
-          </a:xfrm>
-          <a:prstGeom prst="rect">
-            <a:avLst/>
-          </a:prstGeom>
-          <a:solidFill>
-            <a:srgbClr val="1F4E79"/>
-          </a:solidFill>
-          <a:ln w="9525">
-            <a:solidFill>
-              <a:srgbClr val="1F4E79"/>
-            </a:solidFill>
-          </a:ln>
-          <a:effectLst/>
-        </p:spPr>
-        <p:style>
-          <a:lnRef idx="1">
-            <a:schemeClr val="accent1"/>
-          </a:lnRef>
-          <a:fillRef idx="3">
-            <a:schemeClr val="accent1"/>
-          </a:fillRef>
-          <a:effectRef idx="2">
-            <a:schemeClr val="accent1"/>
-          </a:effectRef>
-          <a:fontRef idx="minor">
-            <a:schemeClr val="lt1"/>
-          </a:fontRef>
-        </p:style>
-        <p:txBody>
-          <a:bodyPr rtlCol="0" anchor="ctr" wrap="square" lIns="45720" rIns="45720" tIns="27432" bIns="27432"/>
-          <a:lstStyle/>
-          <a:p>
-            <a:pPr algn="ctr"/>
-            <a:r>
-              <a:rPr sz="900" b="1">
-                <a:solidFill>
-                  <a:srgbClr val="FFFFFF"/>
-                </a:solidFill>
-                <a:latin typeface="맑은 고딕"/>
-                <a:ea typeface="맑은 고딕"/>
-              </a:rPr>
-              <a:t>SYS-B200 (13개)</a:t>
-            </a:r>
-          </a:p>
-        </p:txBody>
-      </p:sp>
-      <p:sp>
-        <p:nvSpPr>
-          <p:cNvPr id="62" name="Rectangle 61"/>
           <p:cNvSpPr/>
           <p:nvPr/>
         </p:nvSpPr>
@@ -5015,14 +4959,14 @@
       </p:sp>
       <p:sp>
         <p:nvSpPr>
-          <p:cNvPr id="63" name="Rectangle 62"/>
+          <p:cNvPr id="62" name="Rectangle 61"/>
           <p:cNvSpPr/>
           <p:nvPr/>
         </p:nvSpPr>
         <p:spPr>
           <a:xfrm>
             <a:off x="2103120" y="1444752"/>
-            <a:ext cx="3108960" cy="512064"/>
+            <a:ext cx="4663440" cy="512064"/>
           </a:xfrm>
           <a:prstGeom prst="rect">
             <a:avLst/>
@@ -5064,7 +5008,7 @@
                 <a:latin typeface="맑은 고딕"/>
                 <a:ea typeface="맑은 고딕"/>
               </a:rPr>
-              <a:t>C1 ★★★ x1.32</a:t>
+              <a:t>C1 ★★ x1.29</a:t>
             </a:r>
           </a:p>
           <a:p>
@@ -5077,21 +5021,21 @@
                 <a:latin typeface="맑은 고딕"/>
                 <a:ea typeface="맑은 고딕"/>
               </a:rPr>
-              <a:t>C2 ★★★ x1.33</a:t>
-            </a:r>
-          </a:p>
-        </p:txBody>
-      </p:sp>
-      <p:sp>
-        <p:nvSpPr>
-          <p:cNvPr id="64" name="Rectangle 63"/>
+              <a:t>C2 ★★★ x1.34</a:t>
+            </a:r>
+          </a:p>
+        </p:txBody>
+      </p:sp>
+      <p:sp>
+        <p:nvSpPr>
+          <p:cNvPr id="63" name="Rectangle 62"/>
           <p:cNvSpPr/>
           <p:nvPr/>
         </p:nvSpPr>
         <p:spPr>
           <a:xfrm>
-            <a:off x="5212079" y="1444752"/>
-            <a:ext cx="3108960" cy="512064"/>
+            <a:off x="6766559" y="1444752"/>
+            <a:ext cx="4663440" cy="512064"/>
           </a:xfrm>
           <a:prstGeom prst="rect">
             <a:avLst/>
@@ -5133,75 +5077,6 @@
                 <a:latin typeface="맑은 고딕"/>
                 <a:ea typeface="맑은 고딕"/>
               </a:rPr>
-              <a:t>C1 ★★ x1.29</a:t>
-            </a:r>
-          </a:p>
-          <a:p>
-            <a:pPr algn="ctr"/>
-            <a:r>
-              <a:rPr sz="1000" b="0">
-                <a:solidFill>
-                  <a:srgbClr val="1A1A1A"/>
-                </a:solidFill>
-                <a:latin typeface="맑은 고딕"/>
-                <a:ea typeface="맑은 고딕"/>
-              </a:rPr>
-              <a:t>C2 ★★★ x1.34</a:t>
-            </a:r>
-          </a:p>
-        </p:txBody>
-      </p:sp>
-      <p:sp>
-        <p:nvSpPr>
-          <p:cNvPr id="65" name="Rectangle 64"/>
-          <p:cNvSpPr/>
-          <p:nvPr/>
-        </p:nvSpPr>
-        <p:spPr>
-          <a:xfrm>
-            <a:off x="8321040" y="1444752"/>
-            <a:ext cx="3108960" cy="512064"/>
-          </a:xfrm>
-          <a:prstGeom prst="rect">
-            <a:avLst/>
-          </a:prstGeom>
-          <a:solidFill>
-            <a:srgbClr val="FFFFFF"/>
-          </a:solidFill>
-          <a:ln w="9525">
-            <a:solidFill>
-              <a:srgbClr val="BFBFBF"/>
-            </a:solidFill>
-          </a:ln>
-          <a:effectLst/>
-        </p:spPr>
-        <p:style>
-          <a:lnRef idx="1">
-            <a:schemeClr val="accent1"/>
-          </a:lnRef>
-          <a:fillRef idx="3">
-            <a:schemeClr val="accent1"/>
-          </a:fillRef>
-          <a:effectRef idx="2">
-            <a:schemeClr val="accent1"/>
-          </a:effectRef>
-          <a:fontRef idx="minor">
-            <a:schemeClr val="lt1"/>
-          </a:fontRef>
-        </p:style>
-        <p:txBody>
-          <a:bodyPr rtlCol="0" anchor="ctr" wrap="square" lIns="45720" rIns="45720" tIns="27432" bIns="27432"/>
-          <a:lstStyle/>
-          <a:p>
-            <a:pPr algn="ctr"/>
-            <a:r>
-              <a:rPr sz="1000" b="0">
-                <a:solidFill>
-                  <a:srgbClr val="1A1A1A"/>
-                </a:solidFill>
-                <a:latin typeface="맑은 고딕"/>
-                <a:ea typeface="맑은 고딕"/>
-              </a:rPr>
               <a:t>C1 ★★ x1.26</a:t>
             </a:r>
           </a:p>
@@ -5222,7 +5097,7 @@
       </p:sp>
       <p:sp>
         <p:nvSpPr>
-          <p:cNvPr id="66" name="Rectangle 65"/>
+          <p:cNvPr id="64" name="Rectangle 63"/>
           <p:cNvSpPr/>
           <p:nvPr/>
         </p:nvSpPr>
@@ -5291,14 +5166,14 @@
       </p:sp>
       <p:sp>
         <p:nvSpPr>
-          <p:cNvPr id="67" name="Rectangle 66"/>
+          <p:cNvPr id="65" name="Rectangle 64"/>
           <p:cNvSpPr/>
           <p:nvPr/>
         </p:nvSpPr>
         <p:spPr>
           <a:xfrm>
             <a:off x="2103120" y="1975104"/>
-            <a:ext cx="3108960" cy="512064"/>
+            <a:ext cx="4663440" cy="512064"/>
           </a:xfrm>
           <a:prstGeom prst="rect">
             <a:avLst/>
@@ -5340,7 +5215,7 @@
                 <a:latin typeface="맑은 고딕"/>
                 <a:ea typeface="맑은 고딕"/>
               </a:rPr>
-              <a:t>C1 ★★★ x1.48</a:t>
+              <a:t>C1 ★★★ x1.39</a:t>
             </a:r>
           </a:p>
           <a:p>
@@ -5353,21 +5228,21 @@
                 <a:latin typeface="맑은 고딕"/>
                 <a:ea typeface="맑은 고딕"/>
               </a:rPr>
-              <a:t>C2 ★★★ x1.47</a:t>
-            </a:r>
-          </a:p>
-        </p:txBody>
-      </p:sp>
-      <p:sp>
-        <p:nvSpPr>
-          <p:cNvPr id="68" name="Rectangle 67"/>
+              <a:t>C2 ★★★ x1.67</a:t>
+            </a:r>
+          </a:p>
+        </p:txBody>
+      </p:sp>
+      <p:sp>
+        <p:nvSpPr>
+          <p:cNvPr id="66" name="Rectangle 65"/>
           <p:cNvSpPr/>
           <p:nvPr/>
         </p:nvSpPr>
         <p:spPr>
           <a:xfrm>
-            <a:off x="5212079" y="1975104"/>
-            <a:ext cx="3108960" cy="512064"/>
+            <a:off x="6766559" y="1975104"/>
+            <a:ext cx="4663440" cy="512064"/>
           </a:xfrm>
           <a:prstGeom prst="rect">
             <a:avLst/>
@@ -5409,75 +5284,6 @@
                 <a:latin typeface="맑은 고딕"/>
                 <a:ea typeface="맑은 고딕"/>
               </a:rPr>
-              <a:t>C1 ★★★ x1.39</a:t>
-            </a:r>
-          </a:p>
-          <a:p>
-            <a:pPr algn="ctr"/>
-            <a:r>
-              <a:rPr sz="1000" b="0">
-                <a:solidFill>
-                  <a:srgbClr val="1A1A1A"/>
-                </a:solidFill>
-                <a:latin typeface="맑은 고딕"/>
-                <a:ea typeface="맑은 고딕"/>
-              </a:rPr>
-              <a:t>C2 ★★★ x1.67</a:t>
-            </a:r>
-          </a:p>
-        </p:txBody>
-      </p:sp>
-      <p:sp>
-        <p:nvSpPr>
-          <p:cNvPr id="69" name="Rectangle 68"/>
-          <p:cNvSpPr/>
-          <p:nvPr/>
-        </p:nvSpPr>
-        <p:spPr>
-          <a:xfrm>
-            <a:off x="8321040" y="1975104"/>
-            <a:ext cx="3108960" cy="512064"/>
-          </a:xfrm>
-          <a:prstGeom prst="rect">
-            <a:avLst/>
-          </a:prstGeom>
-          <a:solidFill>
-            <a:srgbClr val="FFFFFF"/>
-          </a:solidFill>
-          <a:ln w="9525">
-            <a:solidFill>
-              <a:srgbClr val="BFBFBF"/>
-            </a:solidFill>
-          </a:ln>
-          <a:effectLst/>
-        </p:spPr>
-        <p:style>
-          <a:lnRef idx="1">
-            <a:schemeClr val="accent1"/>
-          </a:lnRef>
-          <a:fillRef idx="3">
-            <a:schemeClr val="accent1"/>
-          </a:fillRef>
-          <a:effectRef idx="2">
-            <a:schemeClr val="accent1"/>
-          </a:effectRef>
-          <a:fontRef idx="minor">
-            <a:schemeClr val="lt1"/>
-          </a:fontRef>
-        </p:style>
-        <p:txBody>
-          <a:bodyPr rtlCol="0" anchor="ctr" wrap="square" lIns="45720" rIns="45720" tIns="27432" bIns="27432"/>
-          <a:lstStyle/>
-          <a:p>
-            <a:pPr algn="ctr"/>
-            <a:r>
-              <a:rPr sz="1000" b="0">
-                <a:solidFill>
-                  <a:srgbClr val="1A1A1A"/>
-                </a:solidFill>
-                <a:latin typeface="맑은 고딕"/>
-                <a:ea typeface="맑은 고딕"/>
-              </a:rPr>
               <a:t>C1 ★★★ x1.41</a:t>
             </a:r>
           </a:p>
@@ -5498,7 +5304,7 @@
       </p:sp>
       <p:sp>
         <p:nvSpPr>
-          <p:cNvPr id="70" name="Rectangle 69"/>
+          <p:cNvPr id="67" name="Rectangle 66"/>
           <p:cNvSpPr/>
           <p:nvPr/>
         </p:nvSpPr>
@@ -5567,14 +5373,14 @@
       </p:sp>
       <p:sp>
         <p:nvSpPr>
-          <p:cNvPr id="71" name="Rectangle 70"/>
+          <p:cNvPr id="68" name="Rectangle 67"/>
           <p:cNvSpPr/>
           <p:nvPr/>
         </p:nvSpPr>
         <p:spPr>
           <a:xfrm>
             <a:off x="2103120" y="2505456"/>
-            <a:ext cx="3108960" cy="512064"/>
+            <a:ext cx="4663440" cy="512064"/>
           </a:xfrm>
           <a:prstGeom prst="rect">
             <a:avLst/>
@@ -5616,7 +5422,7 @@
                 <a:latin typeface="맑은 고딕"/>
                 <a:ea typeface="맑은 고딕"/>
               </a:rPr>
-              <a:t>C1 ★★ x1.10</a:t>
+              <a:t>C1 ★★ x1.11</a:t>
             </a:r>
           </a:p>
           <a:p>
@@ -5629,21 +5435,21 @@
                 <a:latin typeface="맑은 고딕"/>
                 <a:ea typeface="맑은 고딕"/>
               </a:rPr>
-              <a:t>C2 ★★ x1.00</a:t>
-            </a:r>
-          </a:p>
-        </p:txBody>
-      </p:sp>
-      <p:sp>
-        <p:nvSpPr>
-          <p:cNvPr id="72" name="Rectangle 71"/>
+              <a:t>C2 ★★ x1.01</a:t>
+            </a:r>
+          </a:p>
+        </p:txBody>
+      </p:sp>
+      <p:sp>
+        <p:nvSpPr>
+          <p:cNvPr id="69" name="Rectangle 68"/>
           <p:cNvSpPr/>
           <p:nvPr/>
         </p:nvSpPr>
         <p:spPr>
           <a:xfrm>
-            <a:off x="5212079" y="2505456"/>
-            <a:ext cx="3108960" cy="512064"/>
+            <a:off x="6766559" y="2505456"/>
+            <a:ext cx="4663440" cy="512064"/>
           </a:xfrm>
           <a:prstGeom prst="rect">
             <a:avLst/>
@@ -5685,75 +5491,6 @@
                 <a:latin typeface="맑은 고딕"/>
                 <a:ea typeface="맑은 고딕"/>
               </a:rPr>
-              <a:t>C1 ★★ x1.11</a:t>
-            </a:r>
-          </a:p>
-          <a:p>
-            <a:pPr algn="ctr"/>
-            <a:r>
-              <a:rPr sz="1000" b="0">
-                <a:solidFill>
-                  <a:srgbClr val="1A1A1A"/>
-                </a:solidFill>
-                <a:latin typeface="맑은 고딕"/>
-                <a:ea typeface="맑은 고딕"/>
-              </a:rPr>
-              <a:t>C2 ★★ x1.01</a:t>
-            </a:r>
-          </a:p>
-        </p:txBody>
-      </p:sp>
-      <p:sp>
-        <p:nvSpPr>
-          <p:cNvPr id="73" name="Rectangle 72"/>
-          <p:cNvSpPr/>
-          <p:nvPr/>
-        </p:nvSpPr>
-        <p:spPr>
-          <a:xfrm>
-            <a:off x="8321040" y="2505456"/>
-            <a:ext cx="3108960" cy="512064"/>
-          </a:xfrm>
-          <a:prstGeom prst="rect">
-            <a:avLst/>
-          </a:prstGeom>
-          <a:solidFill>
-            <a:srgbClr val="FFFFFF"/>
-          </a:solidFill>
-          <a:ln w="9525">
-            <a:solidFill>
-              <a:srgbClr val="BFBFBF"/>
-            </a:solidFill>
-          </a:ln>
-          <a:effectLst/>
-        </p:spPr>
-        <p:style>
-          <a:lnRef idx="1">
-            <a:schemeClr val="accent1"/>
-          </a:lnRef>
-          <a:fillRef idx="3">
-            <a:schemeClr val="accent1"/>
-          </a:fillRef>
-          <a:effectRef idx="2">
-            <a:schemeClr val="accent1"/>
-          </a:effectRef>
-          <a:fontRef idx="minor">
-            <a:schemeClr val="lt1"/>
-          </a:fontRef>
-        </p:style>
-        <p:txBody>
-          <a:bodyPr rtlCol="0" anchor="ctr" wrap="square" lIns="45720" rIns="45720" tIns="27432" bIns="27432"/>
-          <a:lstStyle/>
-          <a:p>
-            <a:pPr algn="ctr"/>
-            <a:r>
-              <a:rPr sz="1000" b="0">
-                <a:solidFill>
-                  <a:srgbClr val="1A1A1A"/>
-                </a:solidFill>
-                <a:latin typeface="맑은 고딕"/>
-                <a:ea typeface="맑은 고딕"/>
-              </a:rPr>
               <a:t>C1 ★★ x1.20</a:t>
             </a:r>
           </a:p>
@@ -5774,7 +5511,7 @@
       </p:sp>
       <p:sp>
         <p:nvSpPr>
-          <p:cNvPr id="74" name="Rectangle 73"/>
+          <p:cNvPr id="70" name="Rectangle 69"/>
           <p:cNvSpPr/>
           <p:nvPr/>
         </p:nvSpPr>
@@ -5843,14 +5580,14 @@
       </p:sp>
       <p:sp>
         <p:nvSpPr>
-          <p:cNvPr id="75" name="Rectangle 74"/>
+          <p:cNvPr id="71" name="Rectangle 70"/>
           <p:cNvSpPr/>
           <p:nvPr/>
         </p:nvSpPr>
         <p:spPr>
           <a:xfrm>
             <a:off x="2103120" y="3035808"/>
-            <a:ext cx="3108960" cy="512064"/>
+            <a:ext cx="4663440" cy="512064"/>
           </a:xfrm>
           <a:prstGeom prst="rect">
             <a:avLst/>
@@ -5892,7 +5629,7 @@
                 <a:latin typeface="맑은 고딕"/>
                 <a:ea typeface="맑은 고딕"/>
               </a:rPr>
-              <a:t>C1 ★★ 1.8모듈 $1.16</a:t>
+              <a:t>C1 ★★★ 1.8모듈 $1.16</a:t>
             </a:r>
           </a:p>
           <a:p>
@@ -5912,14 +5649,14 @@
       </p:sp>
       <p:sp>
         <p:nvSpPr>
-          <p:cNvPr id="76" name="Rectangle 75"/>
+          <p:cNvPr id="72" name="Rectangle 71"/>
           <p:cNvSpPr/>
           <p:nvPr/>
         </p:nvSpPr>
         <p:spPr>
           <a:xfrm>
-            <a:off x="5212079" y="3035808"/>
-            <a:ext cx="3108960" cy="512064"/>
+            <a:off x="6766559" y="3035808"/>
+            <a:ext cx="4663440" cy="512064"/>
           </a:xfrm>
           <a:prstGeom prst="rect">
             <a:avLst/>
@@ -5961,7 +5698,7 @@
                 <a:latin typeface="맑은 고딕"/>
                 <a:ea typeface="맑은 고딕"/>
               </a:rPr>
-              <a:t>C1 ★★ 1.8모듈 $1.16</a:t>
+              <a:t>C1 ★★★ 1.8모듈 $1.16</a:t>
             </a:r>
           </a:p>
           <a:p>
@@ -5981,76 +5718,7 @@
       </p:sp>
       <p:sp>
         <p:nvSpPr>
-          <p:cNvPr id="77" name="Rectangle 76"/>
-          <p:cNvSpPr/>
-          <p:nvPr/>
-        </p:nvSpPr>
-        <p:spPr>
-          <a:xfrm>
-            <a:off x="8321040" y="3035808"/>
-            <a:ext cx="3108960" cy="512064"/>
-          </a:xfrm>
-          <a:prstGeom prst="rect">
-            <a:avLst/>
-          </a:prstGeom>
-          <a:solidFill>
-            <a:srgbClr val="FFFFFF"/>
-          </a:solidFill>
-          <a:ln w="9525">
-            <a:solidFill>
-              <a:srgbClr val="BFBFBF"/>
-            </a:solidFill>
-          </a:ln>
-          <a:effectLst/>
-        </p:spPr>
-        <p:style>
-          <a:lnRef idx="1">
-            <a:schemeClr val="accent1"/>
-          </a:lnRef>
-          <a:fillRef idx="3">
-            <a:schemeClr val="accent1"/>
-          </a:fillRef>
-          <a:effectRef idx="2">
-            <a:schemeClr val="accent1"/>
-          </a:effectRef>
-          <a:fontRef idx="minor">
-            <a:schemeClr val="lt1"/>
-          </a:fontRef>
-        </p:style>
-        <p:txBody>
-          <a:bodyPr rtlCol="0" anchor="ctr" wrap="square" lIns="45720" rIns="45720" tIns="27432" bIns="27432"/>
-          <a:lstStyle/>
-          <a:p>
-            <a:pPr algn="ctr"/>
-            <a:r>
-              <a:rPr sz="1000" b="0">
-                <a:solidFill>
-                  <a:srgbClr val="1A1A1A"/>
-                </a:solidFill>
-                <a:latin typeface="맑은 고딕"/>
-                <a:ea typeface="맑은 고딕"/>
-              </a:rPr>
-              <a:t>C1 ★★ 1.8모듈 $1.16</a:t>
-            </a:r>
-          </a:p>
-          <a:p>
-            <a:pPr algn="ctr"/>
-            <a:r>
-              <a:rPr sz="1000" b="0">
-                <a:solidFill>
-                  <a:srgbClr val="1A1A1A"/>
-                </a:solidFill>
-                <a:latin typeface="맑은 고딕"/>
-                <a:ea typeface="맑은 고딕"/>
-              </a:rPr>
-              <a:t>C2 ★★ 2.5모듈 $1.49</a:t>
-            </a:r>
-          </a:p>
-        </p:txBody>
-      </p:sp>
-      <p:sp>
-        <p:nvSpPr>
-          <p:cNvPr id="78" name="Rectangle 77"/>
+          <p:cNvPr id="73" name="Rectangle 72"/>
           <p:cNvSpPr/>
           <p:nvPr/>
         </p:nvSpPr>
@@ -6106,14 +5774,14 @@
       </p:sp>
       <p:sp>
         <p:nvSpPr>
-          <p:cNvPr id="79" name="Rectangle 78"/>
+          <p:cNvPr id="74" name="Rectangle 73"/>
           <p:cNvSpPr/>
           <p:nvPr/>
         </p:nvSpPr>
         <p:spPr>
           <a:xfrm>
             <a:off x="2103120" y="3566160"/>
-            <a:ext cx="3108960" cy="365760"/>
+            <a:ext cx="4663440" cy="365760"/>
           </a:xfrm>
           <a:prstGeom prst="rect">
             <a:avLst/>
@@ -6162,14 +5830,14 @@
       </p:sp>
       <p:sp>
         <p:nvSpPr>
-          <p:cNvPr id="80" name="Rectangle 79"/>
+          <p:cNvPr id="75" name="Rectangle 74"/>
           <p:cNvSpPr/>
           <p:nvPr/>
         </p:nvSpPr>
         <p:spPr>
           <a:xfrm>
-            <a:off x="5212079" y="3566160"/>
-            <a:ext cx="3108960" cy="365760"/>
+            <a:off x="6766559" y="3566160"/>
+            <a:ext cx="4663440" cy="365760"/>
           </a:xfrm>
           <a:prstGeom prst="rect">
             <a:avLst/>
@@ -6211,70 +5879,14 @@
                 <a:latin typeface="맑은 고딕"/>
                 <a:ea typeface="맑은 고딕"/>
               </a:rPr>
-              <a:t>9 / 10</a:t>
-            </a:r>
-          </a:p>
-        </p:txBody>
-      </p:sp>
-      <p:sp>
-        <p:nvSpPr>
-          <p:cNvPr id="81" name="Rectangle 80"/>
-          <p:cNvSpPr/>
-          <p:nvPr/>
-        </p:nvSpPr>
-        <p:spPr>
-          <a:xfrm>
-            <a:off x="8321040" y="3566160"/>
-            <a:ext cx="3108960" cy="365760"/>
-          </a:xfrm>
-          <a:prstGeom prst="rect">
-            <a:avLst/>
-          </a:prstGeom>
-          <a:solidFill>
-            <a:srgbClr val="FFFFFF"/>
-          </a:solidFill>
-          <a:ln w="9525">
-            <a:solidFill>
-              <a:srgbClr val="BFBFBF"/>
-            </a:solidFill>
-          </a:ln>
-          <a:effectLst/>
-        </p:spPr>
-        <p:style>
-          <a:lnRef idx="1">
-            <a:schemeClr val="accent1"/>
-          </a:lnRef>
-          <a:fillRef idx="3">
-            <a:schemeClr val="accent1"/>
-          </a:fillRef>
-          <a:effectRef idx="2">
-            <a:schemeClr val="accent1"/>
-          </a:effectRef>
-          <a:fontRef idx="minor">
-            <a:schemeClr val="lt1"/>
-          </a:fontRef>
-        </p:style>
-        <p:txBody>
-          <a:bodyPr rtlCol="0" anchor="ctr" wrap="square" lIns="45720" rIns="45720" tIns="27432" bIns="27432"/>
-          <a:lstStyle/>
-          <a:p>
-            <a:pPr algn="ctr"/>
-            <a:r>
-              <a:rPr sz="1000" b="1">
-                <a:solidFill>
-                  <a:srgbClr val="1A1A1A"/>
-                </a:solidFill>
-                <a:latin typeface="맑은 고딕"/>
-                <a:ea typeface="맑은 고딕"/>
-              </a:rPr>
-              <a:t>9 / 11</a:t>
-            </a:r>
-          </a:p>
-        </p:txBody>
-      </p:sp>
-      <p:sp>
-        <p:nvSpPr>
-          <p:cNvPr id="82" name="Rectangle 81"/>
+              <a:t>10 / 11</a:t>
+            </a:r>
+          </a:p>
+        </p:txBody>
+      </p:sp>
+      <p:sp>
+        <p:nvSpPr>
+          <p:cNvPr id="76" name="Rectangle 75"/>
           <p:cNvSpPr/>
           <p:nvPr/>
         </p:nvSpPr>
@@ -6330,14 +5942,14 @@
       </p:sp>
       <p:sp>
         <p:nvSpPr>
-          <p:cNvPr id="83" name="Rectangle 82"/>
+          <p:cNvPr id="77" name="Rectangle 76"/>
           <p:cNvSpPr/>
           <p:nvPr/>
         </p:nvSpPr>
         <p:spPr>
           <a:xfrm>
             <a:off x="2103120" y="3950208"/>
-            <a:ext cx="3108960" cy="365760"/>
+            <a:ext cx="4663440" cy="365760"/>
           </a:xfrm>
           <a:prstGeom prst="rect">
             <a:avLst/>
@@ -6379,21 +5991,21 @@
                 <a:latin typeface="맑은 고딕"/>
                 <a:ea typeface="맑은 고딕"/>
               </a:rPr>
-              <a:t>구분 불가</a:t>
-            </a:r>
-          </a:p>
-        </p:txBody>
-      </p:sp>
-      <p:sp>
-        <p:nvSpPr>
-          <p:cNvPr id="84" name="Rectangle 83"/>
+              <a:t>C2 (QA1)</a:t>
+            </a:r>
+          </a:p>
+        </p:txBody>
+      </p:sp>
+      <p:sp>
+        <p:nvSpPr>
+          <p:cNvPr id="78" name="Rectangle 77"/>
           <p:cNvSpPr/>
           <p:nvPr/>
         </p:nvSpPr>
         <p:spPr>
           <a:xfrm>
-            <a:off x="5212079" y="3950208"/>
-            <a:ext cx="3108960" cy="365760"/>
+            <a:off x="6766559" y="3950208"/>
+            <a:ext cx="4663440" cy="365760"/>
           </a:xfrm>
           <a:prstGeom prst="rect">
             <a:avLst/>
@@ -6435,62 +6047,6 @@
                 <a:latin typeface="맑은 고딕"/>
                 <a:ea typeface="맑은 고딕"/>
               </a:rPr>
-              <a:t>C2 (QA1)</a:t>
-            </a:r>
-          </a:p>
-        </p:txBody>
-      </p:sp>
-      <p:sp>
-        <p:nvSpPr>
-          <p:cNvPr id="85" name="Rectangle 84"/>
-          <p:cNvSpPr/>
-          <p:nvPr/>
-        </p:nvSpPr>
-        <p:spPr>
-          <a:xfrm>
-            <a:off x="8321040" y="3950208"/>
-            <a:ext cx="3108960" cy="365760"/>
-          </a:xfrm>
-          <a:prstGeom prst="rect">
-            <a:avLst/>
-          </a:prstGeom>
-          <a:solidFill>
-            <a:srgbClr val="E3F1E3"/>
-          </a:solidFill>
-          <a:ln w="9525">
-            <a:solidFill>
-              <a:srgbClr val="5B9B5B"/>
-            </a:solidFill>
-          </a:ln>
-          <a:effectLst/>
-        </p:spPr>
-        <p:style>
-          <a:lnRef idx="1">
-            <a:schemeClr val="accent1"/>
-          </a:lnRef>
-          <a:fillRef idx="3">
-            <a:schemeClr val="accent1"/>
-          </a:fillRef>
-          <a:effectRef idx="2">
-            <a:schemeClr val="accent1"/>
-          </a:effectRef>
-          <a:fontRef idx="minor">
-            <a:schemeClr val="lt1"/>
-          </a:fontRef>
-        </p:style>
-        <p:txBody>
-          <a:bodyPr rtlCol="0" anchor="ctr" wrap="square" lIns="45720" rIns="45720" tIns="27432" bIns="27432"/>
-          <a:lstStyle/>
-          <a:p>
-            <a:pPr algn="ctr"/>
-            <a:r>
-              <a:rPr sz="1000" b="1">
-                <a:solidFill>
-                  <a:srgbClr val="1A1A1A"/>
-                </a:solidFill>
-                <a:latin typeface="맑은 고딕"/>
-                <a:ea typeface="맑은 고딕"/>
-              </a:rPr>
               <a:t>C2 (합계)</a:t>
             </a:r>
           </a:p>
@@ -6498,7 +6054,7 @@
       </p:sp>
       <p:sp>
         <p:nvSpPr>
-          <p:cNvPr id="86" name="Rectangle 85"/>
+          <p:cNvPr id="79" name="Rectangle 78"/>
           <p:cNvSpPr/>
           <p:nvPr/>
         </p:nvSpPr>
@@ -6573,7 +6129,7 @@
                 <a:latin typeface="맑은 고딕"/>
                 <a:ea typeface="맑은 고딕"/>
               </a:rPr>
-              <a:t>- C1 우세 칸: 없음</a:t>
+              <a:t>- C1 우세 칸: QA4@SYS-H100, QA4@SYS-B200</a:t>
             </a:r>
           </a:p>
           <a:p>
@@ -6599,14 +6155,14 @@
                 <a:latin typeface="맑은 고딕"/>
                 <a:ea typeface="맑은 고딕"/>
               </a:rPr>
-              <a:t>- QA4는 두 후보 같은 별(추정), 값은 C1이 작음</a:t>
-            </a:r>
-          </a:p>
-        </p:txBody>
-      </p:sp>
-      <p:sp>
-        <p:nvSpPr>
-          <p:cNvPr id="87" name="Rectangle 86"/>
+              <a:t>- QA4 [B+C]: 평균 집계로 C1 ★★★, C2 ★★ (C2의 공수가 경계 0.5 MM를 0.006 넘음)</a:t>
+            </a:r>
+          </a:p>
+        </p:txBody>
+      </p:sp>
+      <p:sp>
+        <p:nvSpPr>
+          <p:cNvPr id="80" name="Rectangle 79"/>
           <p:cNvSpPr/>
           <p:nvPr/>
         </p:nvSpPr>
@@ -6668,7 +6224,7 @@
                 <a:latin typeface="맑은 고딕"/>
                 <a:ea typeface="맑은 고딕"/>
               </a:rPr>
-              <a:t>- 시스템별: 별 합계 차이 2 이상이면 합계, 아니면 QA 우선순위(QA1 &gt; QA2 &gt; QA3 &gt; QA4).</a:t>
+              <a:t>- 규칙: 별 합계가 높은 후보. 합계가 같을 때만 QA 우선순위(QA1 &gt; QA2 &gt; QA3 &gt; QA4).</a:t>
             </a:r>
           </a:p>
           <a:p>
@@ -6681,7 +6237,7 @@
                 <a:latin typeface="맑은 고딕"/>
                 <a:ea typeface="맑은 고딕"/>
               </a:rPr>
-              <a:t>- 시스템별 승수 C1 0 대 C2 2. 우선순위를 뒤집으면 C2.</a:t>
+              <a:t>- 시스템별 별 합계 합: C1 20, C2 21 -&gt; C2.</a:t>
             </a:r>
           </a:p>
           <a:p>
@@ -6694,14 +6250,14 @@
                 <a:latin typeface="맑은 고딕"/>
                 <a:ea typeface="맑은 고딕"/>
               </a:rPr>
-              <a:t>- 우선순위 상태: proposal</a:t>
-            </a:r>
-          </a:p>
-        </p:txBody>
-      </p:sp>
-      <p:sp>
-        <p:nvSpPr>
-          <p:cNvPr id="88" name="Rectangle 87"/>
+              <a:t>- 우선순위 상태: confirmed by owner 2026-10-03</a:t>
+            </a:r>
+          </a:p>
+        </p:txBody>
+      </p:sp>
+      <p:sp>
+        <p:nvSpPr>
+          <p:cNvPr id="81" name="Rectangle 80"/>
           <p:cNvSpPr/>
           <p:nvPr/>
         </p:nvSpPr>
@@ -6750,7 +6306,7 @@
                 <a:latin typeface="맑은 고딕"/>
                 <a:ea typeface="맑은 고딕"/>
               </a:rPr>
-              <a:t>한계: [B] simulation(config 기반, [A] 실측 아님). A100/H100 규격·link 스케일 ASSUMED. QA3는 SSD-PIM이 풀의 약 75%라 U가 1~2%대(상대값으로 판정). QA4 공수·비용은 가정 상수 추정. 별 경계는 결과를 본 뒤 정한 값 포함.</a:t>
+              <a:t>한계: [B] simulation(config 기반, [A] 실측 아님). H100 규격·link 스케일 ASSUMED. QA3는 SSD-PIM이 풀의 약 75%라 U가 1~2%대(상대값으로 판정). QA4 공수·비용은 가정 상수 추정. 별 경계는 결과를 본 뒤 정한 값 포함.</a:t>
             </a:r>
           </a:p>
         </p:txBody>

</xml_diff>

<commit_message>
DP1 evaluation: integrate H100+B200 into one result; narrative summary (QA x C1/C2 with metrics, trade-off reasons, scenarios in plain language); PPT 2 slides
Co-Authored-By: Claude Sonnet 5.5 <noreply@anthropic.com>
Claude-Session: https://claude.ai/code/session_018inK4pZJGzYwjdk7QAyZgn
</commit_message>
<xml_diff>
--- a/doc-mk/DP1/DP1-appendix-qa-result.pptx
+++ b/doc-mk/DP1/DP1-appendix-qa-result.pptx
@@ -9,6 +9,7 @@
   </p:notesMasterIdLst>
   <p:sldIdLst>
     <p:sldId id="650" r:id="rId24"/>
+    <p:sldId id="651" r:id="rId25"/>
   </p:sldIdLst>
   <p:sldSz cx="12192000" cy="6858000"/>
   <p:notesSz cx="6858000" cy="9144000"/>
@@ -4608,7 +4609,7 @@
                   <a:schemeClr val="bg1"/>
                 </a:solidFill>
               </a:rPr>
-              <a:t>DP1 평가 결과 - QA별 후보 비교 (메모리 세대별 2개 시스템: H100, B200, Common + Stress + Dynamic)</a:t>
+              <a:t>DP1 평가 결과 - QA별 후보 비교 (H100 + B200 통합)</a:t>
             </a:r>
             <a:r>
               <a:rPr lang="en-US" altLang="ko-KR" sz="1400" b="1" dirty="0">
@@ -4729,7 +4730,7 @@
         <p:spPr>
           <a:xfrm>
             <a:off x="365760" y="1097280"/>
-            <a:ext cx="1737360" cy="310896"/>
+            <a:ext cx="2926080" cy="310896"/>
           </a:xfrm>
           <a:prstGeom prst="rect">
             <a:avLst/>
@@ -4764,14 +4765,14 @@
           <a:p>
             <a:pPr algn="ctr"/>
             <a:r>
-              <a:rPr sz="900" b="1">
+              <a:rPr sz="1000" b="1">
                 <a:solidFill>
                   <a:srgbClr val="FFFFFF"/>
                 </a:solidFill>
                 <a:latin typeface="맑은 고딕"/>
                 <a:ea typeface="맑은 고딕"/>
               </a:rPr>
-              <a:t>QA</a:t>
+              <a:t>QA / 지표</a:t>
             </a:r>
           </a:p>
         </p:txBody>
@@ -4784,8 +4785,8 @@
         </p:nvSpPr>
         <p:spPr>
           <a:xfrm>
-            <a:off x="2103120" y="1097280"/>
-            <a:ext cx="4663440" cy="310896"/>
+            <a:off x="3291840" y="1097280"/>
+            <a:ext cx="4251960" cy="310896"/>
           </a:xfrm>
           <a:prstGeom prst="rect">
             <a:avLst/>
@@ -4820,14 +4821,14 @@
           <a:p>
             <a:pPr algn="ctr"/>
             <a:r>
-              <a:rPr sz="900" b="1">
+              <a:rPr sz="1000" b="1">
                 <a:solidFill>
                   <a:srgbClr val="FFFFFF"/>
                 </a:solidFill>
                 <a:latin typeface="맑은 고딕"/>
                 <a:ea typeface="맑은 고딕"/>
               </a:rPr>
-              <a:t>SYS-H100 (10개)</a:t>
+              <a:t>C1 Resource-driven</a:t>
             </a:r>
           </a:p>
         </p:txBody>
@@ -4840,8 +4841,8 @@
         </p:nvSpPr>
         <p:spPr>
           <a:xfrm>
-            <a:off x="6766559" y="1097280"/>
-            <a:ext cx="4663440" cy="310896"/>
+            <a:off x="7543800" y="1097280"/>
+            <a:ext cx="4251960" cy="310896"/>
           </a:xfrm>
           <a:prstGeom prst="rect">
             <a:avLst/>
@@ -4876,14 +4877,14 @@
           <a:p>
             <a:pPr algn="ctr"/>
             <a:r>
-              <a:rPr sz="900" b="1">
+              <a:rPr sz="1000" b="1">
                 <a:solidFill>
                   <a:srgbClr val="FFFFFF"/>
                 </a:solidFill>
                 <a:latin typeface="맑은 고딕"/>
                 <a:ea typeface="맑은 고딕"/>
               </a:rPr>
-              <a:t>SYS-B200 (13개)</a:t>
+              <a:t>C2 Behavior-driven</a:t>
             </a:r>
           </a:p>
         </p:txBody>
@@ -4897,7 +4898,7 @@
         <p:spPr>
           <a:xfrm>
             <a:off x="365760" y="1444752"/>
-            <a:ext cx="1737360" cy="512064"/>
+            <a:ext cx="2926080" cy="566928"/>
           </a:xfrm>
           <a:prstGeom prst="rect">
             <a:avLst/>
@@ -4932,7 +4933,7 @@
           <a:p>
             <a:pPr algn="l"/>
             <a:r>
-              <a:rPr sz="900" b="1">
+              <a:rPr sz="950" b="1">
                 <a:solidFill>
                   <a:srgbClr val="1A1A1A"/>
                 </a:solidFill>
@@ -4945,14 +4946,14 @@
           <a:p>
             <a:pPr algn="l"/>
             <a:r>
-              <a:rPr sz="900" b="1">
+              <a:rPr sz="950" b="1">
                 <a:solidFill>
                   <a:srgbClr val="1A1A1A"/>
                 </a:solidFill>
                 <a:latin typeface="맑은 고딕"/>
                 <a:ea typeface="맑은 고딕"/>
               </a:rPr>
-              <a:t>(Baseline 대비 goodput)</a:t>
+              <a:t>Baseline 대비 SLO goodput 배수, 승/무/패</a:t>
             </a:r>
           </a:p>
         </p:txBody>
@@ -4965,8 +4966,8 @@
         </p:nvSpPr>
         <p:spPr>
           <a:xfrm>
-            <a:off x="2103120" y="1444752"/>
-            <a:ext cx="4663440" cy="512064"/>
+            <a:off x="3291840" y="1444752"/>
+            <a:ext cx="4251960" cy="566928"/>
           </a:xfrm>
           <a:prstGeom prst="rect">
             <a:avLst/>
@@ -5008,7 +5009,7 @@
                 <a:latin typeface="맑은 고딕"/>
                 <a:ea typeface="맑은 고딕"/>
               </a:rPr>
-              <a:t>C1 ★★ x1.29</a:t>
+              <a:t>★★  x1.27 (±0.06)</a:t>
             </a:r>
           </a:p>
           <a:p>
@@ -5021,7 +5022,7 @@
                 <a:latin typeface="맑은 고딕"/>
                 <a:ea typeface="맑은 고딕"/>
               </a:rPr>
-              <a:t>C2 ★★★ x1.34</a:t>
+              <a:t>6승 25무 0패</a:t>
             </a:r>
           </a:p>
         </p:txBody>
@@ -5034,8 +5035,8 @@
         </p:nvSpPr>
         <p:spPr>
           <a:xfrm>
-            <a:off x="6766559" y="1444752"/>
-            <a:ext cx="4663440" cy="512064"/>
+            <a:off x="7543800" y="1444752"/>
+            <a:ext cx="4251960" cy="566928"/>
           </a:xfrm>
           <a:prstGeom prst="rect">
             <a:avLst/>
@@ -5077,7 +5078,7 @@
                 <a:latin typeface="맑은 고딕"/>
                 <a:ea typeface="맑은 고딕"/>
               </a:rPr>
-              <a:t>C1 ★★ x1.26</a:t>
+              <a:t>★★★  x1.40 (±0.04)</a:t>
             </a:r>
           </a:p>
           <a:p>
@@ -5090,7 +5091,7 @@
                 <a:latin typeface="맑은 고딕"/>
                 <a:ea typeface="맑은 고딕"/>
               </a:rPr>
-              <a:t>C2 ★★★ x1.44</a:t>
+              <a:t>10승 21무 0패</a:t>
             </a:r>
           </a:p>
         </p:txBody>
@@ -5103,8 +5104,8 @@
         </p:nvSpPr>
         <p:spPr>
           <a:xfrm>
-            <a:off x="365760" y="1975104"/>
-            <a:ext cx="1737360" cy="512064"/>
+            <a:off x="365760" y="2029968"/>
+            <a:ext cx="2926080" cy="566928"/>
           </a:xfrm>
           <a:prstGeom prst="rect">
             <a:avLst/>
@@ -5139,7 +5140,7 @@
           <a:p>
             <a:pPr algn="l"/>
             <a:r>
-              <a:rPr sz="900" b="1">
+              <a:rPr sz="950" b="1">
                 <a:solidFill>
                   <a:srgbClr val="1A1A1A"/>
                 </a:solidFill>
@@ -5152,14 +5153,14 @@
           <a:p>
             <a:pPr algn="l"/>
             <a:r>
-              <a:rPr sz="900" b="1">
+              <a:rPr sz="950" b="1">
                 <a:solidFill>
                   <a:srgbClr val="1A1A1A"/>
                 </a:solidFill>
                 <a:latin typeface="맑은 고딕"/>
                 <a:ea typeface="맑은 고딕"/>
               </a:rPr>
-              <a:t>(개선 배수)</a:t>
+              <a:t>TTFT/TPOT 개선 배수(geomean), 중앙값 TTFT</a:t>
             </a:r>
           </a:p>
         </p:txBody>
@@ -5172,8 +5173,8 @@
         </p:nvSpPr>
         <p:spPr>
           <a:xfrm>
-            <a:off x="2103120" y="1975104"/>
-            <a:ext cx="4663440" cy="512064"/>
+            <a:off x="3291840" y="2029968"/>
+            <a:ext cx="4251960" cy="566928"/>
           </a:xfrm>
           <a:prstGeom prst="rect">
             <a:avLst/>
@@ -5215,7 +5216,7 @@
                 <a:latin typeface="맑은 고딕"/>
                 <a:ea typeface="맑은 고딕"/>
               </a:rPr>
-              <a:t>C1 ★★★ x1.39</a:t>
+              <a:t>★★★  x1.40</a:t>
             </a:r>
           </a:p>
           <a:p>
@@ -5228,7 +5229,7 @@
                 <a:latin typeface="맑은 고딕"/>
                 <a:ea typeface="맑은 고딕"/>
               </a:rPr>
-              <a:t>C2 ★★★ x1.67</a:t>
+              <a:t>TTFT P50/P95/P99 119/318/356 ms</a:t>
             </a:r>
           </a:p>
         </p:txBody>
@@ -5241,8 +5242,8 @@
         </p:nvSpPr>
         <p:spPr>
           <a:xfrm>
-            <a:off x="6766559" y="1975104"/>
-            <a:ext cx="4663440" cy="512064"/>
+            <a:off x="7543800" y="2029968"/>
+            <a:ext cx="4251960" cy="566928"/>
           </a:xfrm>
           <a:prstGeom prst="rect">
             <a:avLst/>
@@ -5284,7 +5285,7 @@
                 <a:latin typeface="맑은 고딕"/>
                 <a:ea typeface="맑은 고딕"/>
               </a:rPr>
-              <a:t>C1 ★★★ x1.41</a:t>
+              <a:t>★★★  x1.66</a:t>
             </a:r>
           </a:p>
           <a:p>
@@ -5297,7 +5298,7 @@
                 <a:latin typeface="맑은 고딕"/>
                 <a:ea typeface="맑은 고딕"/>
               </a:rPr>
-              <a:t>C2 ★★★ x1.65</a:t>
+              <a:t>TTFT P50/P95/P99 118/286/382 ms</a:t>
             </a:r>
           </a:p>
         </p:txBody>
@@ -5310,8 +5311,8 @@
         </p:nvSpPr>
         <p:spPr>
           <a:xfrm>
-            <a:off x="365760" y="2505456"/>
-            <a:ext cx="1737360" cy="512064"/>
+            <a:off x="365760" y="2615184"/>
+            <a:ext cx="2926080" cy="566928"/>
           </a:xfrm>
           <a:prstGeom prst="rect">
             <a:avLst/>
@@ -5346,7 +5347,7 @@
           <a:p>
             <a:pPr algn="l"/>
             <a:r>
-              <a:rPr sz="900" b="1">
+              <a:rPr sz="950" b="1">
                 <a:solidFill>
                   <a:srgbClr val="1A1A1A"/>
                 </a:solidFill>
@@ -5359,14 +5360,14 @@
           <a:p>
             <a:pPr algn="l"/>
             <a:r>
-              <a:rPr sz="900" b="1">
+              <a:rPr sz="950" b="1">
                 <a:solidFill>
                   <a:srgbClr val="1A1A1A"/>
                 </a:solidFill>
                 <a:latin typeface="맑은 고딕"/>
                 <a:ea typeface="맑은 고딕"/>
               </a:rPr>
-              <a:t>(전 메모리 풀 U 상대)</a:t>
+              <a:t>전 메모리 풀 U 상대값, HBM 점유, 링크 점유</a:t>
             </a:r>
           </a:p>
         </p:txBody>
@@ -5379,8 +5380,8 @@
         </p:nvSpPr>
         <p:spPr>
           <a:xfrm>
-            <a:off x="2103120" y="2505456"/>
-            <a:ext cx="4663440" cy="512064"/>
+            <a:off x="3291840" y="2615184"/>
+            <a:ext cx="4251960" cy="566928"/>
           </a:xfrm>
           <a:prstGeom prst="rect">
             <a:avLst/>
@@ -5422,7 +5423,7 @@
                 <a:latin typeface="맑은 고딕"/>
                 <a:ea typeface="맑은 고딕"/>
               </a:rPr>
-              <a:t>C1 ★★ x1.11</a:t>
+              <a:t>★★  x1.16 (U 1.62%)</a:t>
             </a:r>
           </a:p>
           <a:p>
@@ -5435,7 +5436,7 @@
                 <a:latin typeface="맑은 고딕"/>
                 <a:ea typeface="맑은 고딕"/>
               </a:rPr>
-              <a:t>C2 ★★ x1.01</a:t>
+              <a:t>HBM 54% · 링크 1.6%</a:t>
             </a:r>
           </a:p>
         </p:txBody>
@@ -5448,8 +5449,8 @@
         </p:nvSpPr>
         <p:spPr>
           <a:xfrm>
-            <a:off x="6766559" y="2505456"/>
-            <a:ext cx="4663440" cy="512064"/>
+            <a:off x="7543800" y="2615184"/>
+            <a:ext cx="4251960" cy="566928"/>
           </a:xfrm>
           <a:prstGeom prst="rect">
             <a:avLst/>
@@ -5491,7 +5492,7 @@
                 <a:latin typeface="맑은 고딕"/>
                 <a:ea typeface="맑은 고딕"/>
               </a:rPr>
-              <a:t>C1 ★★ x1.20</a:t>
+              <a:t>★★  x1.13 (U 1.59%)</a:t>
             </a:r>
           </a:p>
           <a:p>
@@ -5504,7 +5505,7 @@
                 <a:latin typeface="맑은 고딕"/>
                 <a:ea typeface="맑은 고딕"/>
               </a:rPr>
-              <a:t>C2 ★★★ x1.25</a:t>
+              <a:t>HBM 68% · 링크 10.5%</a:t>
             </a:r>
           </a:p>
         </p:txBody>
@@ -5517,8 +5518,8 @@
         </p:nvSpPr>
         <p:spPr>
           <a:xfrm>
-            <a:off x="365760" y="3035808"/>
-            <a:ext cx="1737360" cy="512064"/>
+            <a:off x="365760" y="3200400"/>
+            <a:ext cx="2926080" cy="566928"/>
           </a:xfrm>
           <a:prstGeom prst="rect">
             <a:avLst/>
@@ -5553,7 +5554,7 @@
           <a:p>
             <a:pPr algn="l"/>
             <a:r>
-              <a:rPr sz="900" b="1">
+              <a:rPr sz="950" b="1">
                 <a:solidFill>
                   <a:srgbClr val="1A1A1A"/>
                 </a:solidFill>
@@ -5566,14 +5567,14 @@
           <a:p>
             <a:pPr algn="l"/>
             <a:r>
-              <a:rPr sz="900" b="1">
+              <a:rPr sz="950" b="1">
                 <a:solidFill>
                   <a:srgbClr val="1A1A1A"/>
                 </a:solidFill>
                 <a:latin typeface="맑은 고딕"/>
                 <a:ea typeface="맑은 고딕"/>
               </a:rPr>
-              <a:t>(module / 에이전트 비용)</a:t>
+              <a:t>변경 4종 평균: module, 공수, 에이전트 비용</a:t>
             </a:r>
           </a:p>
         </p:txBody>
@@ -5586,8 +5587,8 @@
         </p:nvSpPr>
         <p:spPr>
           <a:xfrm>
-            <a:off x="2103120" y="3035808"/>
-            <a:ext cx="4663440" cy="512064"/>
+            <a:off x="3291840" y="3200400"/>
+            <a:ext cx="4251960" cy="566928"/>
           </a:xfrm>
           <a:prstGeom prst="rect">
             <a:avLst/>
@@ -5629,7 +5630,7 @@
                 <a:latin typeface="맑은 고딕"/>
                 <a:ea typeface="맑은 고딕"/>
               </a:rPr>
-              <a:t>C1 ★★★ 1.8모듈 $1.16</a:t>
+              <a:t>★★★  module 1.75</a:t>
             </a:r>
           </a:p>
           <a:p>
@@ -5642,7 +5643,7 @@
                 <a:latin typeface="맑은 고딕"/>
                 <a:ea typeface="맑은 고딕"/>
               </a:rPr>
-              <a:t>C2 ★★ 2.5모듈 $1.49</a:t>
+              <a:t>0.38 man-month · $1.16</a:t>
             </a:r>
           </a:p>
         </p:txBody>
@@ -5655,8 +5656,8 @@
         </p:nvSpPr>
         <p:spPr>
           <a:xfrm>
-            <a:off x="6766559" y="3035808"/>
-            <a:ext cx="4663440" cy="512064"/>
+            <a:off x="7543800" y="3200400"/>
+            <a:ext cx="4251960" cy="566928"/>
           </a:xfrm>
           <a:prstGeom prst="rect">
             <a:avLst/>
@@ -5698,7 +5699,7 @@
                 <a:latin typeface="맑은 고딕"/>
                 <a:ea typeface="맑은 고딕"/>
               </a:rPr>
-              <a:t>C1 ★★★ 1.8모듈 $1.16</a:t>
+              <a:t>★★  module 2.50</a:t>
             </a:r>
           </a:p>
           <a:p>
@@ -5711,7 +5712,7 @@
                 <a:latin typeface="맑은 고딕"/>
                 <a:ea typeface="맑은 고딕"/>
               </a:rPr>
-              <a:t>C2 ★★ 2.5모듈 $1.49</a:t>
+              <a:t>0.51 man-month · $1.49</a:t>
             </a:r>
           </a:p>
         </p:txBody>
@@ -5724,8 +5725,8 @@
         </p:nvSpPr>
         <p:spPr>
           <a:xfrm>
-            <a:off x="365760" y="3566160"/>
-            <a:ext cx="1737360" cy="365760"/>
+            <a:off x="365760" y="3785616"/>
+            <a:ext cx="2926080" cy="365760"/>
           </a:xfrm>
           <a:prstGeom prst="rect">
             <a:avLst/>
@@ -5760,14 +5761,14 @@
           <a:p>
             <a:pPr algn="l"/>
             <a:r>
-              <a:rPr sz="900" b="1">
+              <a:rPr sz="1000" b="1">
                 <a:solidFill>
                   <a:srgbClr val="1A1A1A"/>
                 </a:solidFill>
                 <a:latin typeface="맑은 고딕"/>
                 <a:ea typeface="맑은 고딕"/>
               </a:rPr>
-              <a:t>별 합계 (C1 / C2)</a:t>
+              <a:t>별 합계</a:t>
             </a:r>
           </a:p>
         </p:txBody>
@@ -5780,8 +5781,8 @@
         </p:nvSpPr>
         <p:spPr>
           <a:xfrm>
-            <a:off x="2103120" y="3566160"/>
-            <a:ext cx="4663440" cy="365760"/>
+            <a:off x="3291840" y="3785616"/>
+            <a:ext cx="4251960" cy="365760"/>
           </a:xfrm>
           <a:prstGeom prst="rect">
             <a:avLst/>
@@ -5816,14 +5817,14 @@
           <a:p>
             <a:pPr algn="ctr"/>
             <a:r>
-              <a:rPr sz="1000" b="1">
+              <a:rPr sz="1100" b="1">
                 <a:solidFill>
                   <a:srgbClr val="1A1A1A"/>
                 </a:solidFill>
                 <a:latin typeface="맑은 고딕"/>
                 <a:ea typeface="맑은 고딕"/>
               </a:rPr>
-              <a:t>10 / 10</a:t>
+              <a:t>10</a:t>
             </a:r>
           </a:p>
         </p:txBody>
@@ -5836,8 +5837,8 @@
         </p:nvSpPr>
         <p:spPr>
           <a:xfrm>
-            <a:off x="6766559" y="3566160"/>
-            <a:ext cx="4663440" cy="365760"/>
+            <a:off x="7543800" y="3785616"/>
+            <a:ext cx="4251960" cy="365760"/>
           </a:xfrm>
           <a:prstGeom prst="rect">
             <a:avLst/>
@@ -5872,14 +5873,14 @@
           <a:p>
             <a:pPr algn="ctr"/>
             <a:r>
-              <a:rPr sz="1000" b="1">
+              <a:rPr sz="1100" b="1">
                 <a:solidFill>
                   <a:srgbClr val="1A1A1A"/>
                 </a:solidFill>
                 <a:latin typeface="맑은 고딕"/>
                 <a:ea typeface="맑은 고딕"/>
               </a:rPr>
-              <a:t>10 / 11</a:t>
+              <a:t>10</a:t>
             </a:r>
           </a:p>
         </p:txBody>
@@ -5892,8 +5893,575 @@
         </p:nvSpPr>
         <p:spPr>
           <a:xfrm>
-            <a:off x="365760" y="3950208"/>
-            <a:ext cx="1737360" cy="365760"/>
+            <a:off x="365760" y="4261104"/>
+            <a:ext cx="5669280" cy="1965960"/>
+          </a:xfrm>
+          <a:prstGeom prst="rect">
+            <a:avLst/>
+          </a:prstGeom>
+          <a:solidFill>
+            <a:srgbClr val="F2F2F2"/>
+          </a:solidFill>
+          <a:ln w="9525">
+            <a:solidFill>
+              <a:srgbClr val="BFBFBF"/>
+            </a:solidFill>
+          </a:ln>
+          <a:effectLst/>
+        </p:spPr>
+        <p:style>
+          <a:lnRef idx="1">
+            <a:schemeClr val="accent1"/>
+          </a:lnRef>
+          <a:fillRef idx="3">
+            <a:schemeClr val="accent1"/>
+          </a:fillRef>
+          <a:effectRef idx="2">
+            <a:schemeClr val="accent1"/>
+          </a:effectRef>
+          <a:fontRef idx="minor">
+            <a:schemeClr val="lt1"/>
+          </a:fontRef>
+        </p:style>
+        <p:txBody>
+          <a:bodyPr rtlCol="0" anchor="t" wrap="square" lIns="45720" rIns="45720" tIns="27432" bIns="27432"/>
+          <a:lstStyle/>
+          <a:p>
+            <a:pPr algn="l"/>
+            <a:r>
+              <a:rPr sz="950" b="1">
+                <a:solidFill>
+                  <a:srgbClr val="404040"/>
+                </a:solidFill>
+                <a:latin typeface="맑은 고딕"/>
+                <a:ea typeface="맑은 고딕"/>
+              </a:rPr>
+              <a:t>Trade-off와 이유</a:t>
+            </a:r>
+          </a:p>
+          <a:p>
+            <a:pPr algn="l"/>
+            <a:r>
+              <a:rPr sz="950" b="0">
+                <a:solidFill>
+                  <a:srgbClr val="404040"/>
+                </a:solidFill>
+                <a:latin typeface="맑은 고딕"/>
+                <a:ea typeface="맑은 고딕"/>
+              </a:rPr>
+              <a:t>- 성능은 C2: 데이터마다 접근 빈도·재사용·유휴를 보고 이동해, 같은 종류(KV) 안의 hot/cold를 구분</a:t>
+            </a:r>
+          </a:p>
+          <a:p>
+            <a:pPr algn="l"/>
+            <a:r>
+              <a:rPr sz="950" b="0">
+                <a:solidFill>
+                  <a:srgbClr val="404040"/>
+                </a:solidFill>
+                <a:latin typeface="맑은 고딕"/>
+                <a:ea typeface="맑은 고딕"/>
+              </a:rPr>
+              <a:t>한다. C1은 자원 압박에만 반응해 구분 못 함.</a:t>
+            </a:r>
+          </a:p>
+          <a:p>
+            <a:pPr algn="l"/>
+            <a:r>
+              <a:rPr sz="950" b="0">
+                <a:solidFill>
+                  <a:srgbClr val="404040"/>
+                </a:solidFill>
+                <a:latin typeface="맑은 고딕"/>
+                <a:ea typeface="맑은 고딕"/>
+              </a:rPr>
+              <a:t>- 비용은 C2: migration 1,339 GiB (C1 138), 링크 점유 10.5% (C1 1.6%)라 활용률(QA3) 이득이 C1을</a:t>
+            </a:r>
+          </a:p>
+          <a:p>
+            <a:pPr algn="l"/>
+            <a:r>
+              <a:rPr sz="950" b="0">
+                <a:solidFill>
+                  <a:srgbClr val="404040"/>
+                </a:solidFill>
+                <a:latin typeface="맑은 고딕"/>
+                <a:ea typeface="맑은 고딕"/>
+              </a:rPr>
+              <a:t>넘지 못함.</a:t>
+            </a:r>
+          </a:p>
+          <a:p>
+            <a:pPr algn="l"/>
+            <a:r>
+              <a:rPr sz="950" b="0">
+                <a:solidFill>
+                  <a:srgbClr val="404040"/>
+                </a:solidFill>
+                <a:latin typeface="맑은 고딕"/>
+                <a:ea typeface="맑은 고딕"/>
+              </a:rPr>
+              <a:t>- 확장성은 C1: 종류를 모르는 구조라 새 데이터 종류 추가 시 module 1개 (C2 3개).</a:t>
+            </a:r>
+          </a:p>
+          <a:p>
+            <a:pPr algn="l"/>
+            <a:r>
+              <a:rPr sz="950" b="0">
+                <a:solidFill>
+                  <a:srgbClr val="404040"/>
+                </a:solidFill>
+                <a:latin typeface="맑은 고딕"/>
+                <a:ea typeface="맑은 고딕"/>
+              </a:rPr>
+              <a:t>- 지연(QA2)은 둘 다 ★★★ 경계를 넘어 별이 같지만 값은 C2가 높다.</a:t>
+            </a:r>
+          </a:p>
+        </p:txBody>
+      </p:sp>
+      <p:sp>
+        <p:nvSpPr>
+          <p:cNvPr id="77" name="Rectangle 76"/>
+          <p:cNvSpPr/>
+          <p:nvPr/>
+        </p:nvSpPr>
+        <p:spPr>
+          <a:xfrm>
+            <a:off x="6217920" y="4261104"/>
+            <a:ext cx="5577840" cy="1965960"/>
+          </a:xfrm>
+          <a:prstGeom prst="rect">
+            <a:avLst/>
+          </a:prstGeom>
+          <a:solidFill>
+            <a:srgbClr val="E3F1E3"/>
+          </a:solidFill>
+          <a:ln w="9525">
+            <a:solidFill>
+              <a:srgbClr val="5B9B5B"/>
+            </a:solidFill>
+          </a:ln>
+          <a:effectLst/>
+        </p:spPr>
+        <p:style>
+          <a:lnRef idx="1">
+            <a:schemeClr val="accent1"/>
+          </a:lnRef>
+          <a:fillRef idx="3">
+            <a:schemeClr val="accent1"/>
+          </a:fillRef>
+          <a:effectRef idx="2">
+            <a:schemeClr val="accent1"/>
+          </a:effectRef>
+          <a:fontRef idx="minor">
+            <a:schemeClr val="lt1"/>
+          </a:fontRef>
+        </p:style>
+        <p:txBody>
+          <a:bodyPr rtlCol="0" anchor="t" wrap="square" lIns="45720" rIns="45720" tIns="27432" bIns="27432"/>
+          <a:lstStyle/>
+          <a:p>
+            <a:pPr algn="l"/>
+            <a:r>
+              <a:rPr sz="950" b="1">
+                <a:solidFill>
+                  <a:srgbClr val="1A1A1A"/>
+                </a:solidFill>
+                <a:latin typeface="맑은 고딕"/>
+                <a:ea typeface="맑은 고딕"/>
+              </a:rPr>
+              <a:t>선택: C2</a:t>
+            </a:r>
+          </a:p>
+          <a:p>
+            <a:pPr algn="l"/>
+            <a:r>
+              <a:rPr sz="950" b="0">
+                <a:solidFill>
+                  <a:srgbClr val="1A1A1A"/>
+                </a:solidFill>
+                <a:latin typeface="맑은 고딕"/>
+                <a:ea typeface="맑은 고딕"/>
+              </a:rPr>
+              <a:t>- 규칙: 별 합계가 높은 후보, 같을 때만 QA 우선순위(QA1 &gt; QA2 &gt; QA3 &gt; QA4).</a:t>
+            </a:r>
+          </a:p>
+          <a:p>
+            <a:pPr algn="l"/>
+            <a:r>
+              <a:rPr sz="950" b="0">
+                <a:solidFill>
+                  <a:srgbClr val="1A1A1A"/>
+                </a:solidFill>
+                <a:latin typeface="맑은 고딕"/>
+                <a:ea typeface="맑은 고딕"/>
+              </a:rPr>
+              <a:t>- 합계 10 대 10로 같아 QA 우선순위로 결정: QA1에서 앞선 C2.</a:t>
+            </a:r>
+          </a:p>
+          <a:p>
+            <a:pPr algn="l"/>
+            <a:r>
+              <a:rPr sz="950" b="0">
+                <a:solidFill>
+                  <a:srgbClr val="1A1A1A"/>
+                </a:solidFill>
+                <a:latin typeface="맑은 고딕"/>
+                <a:ea typeface="맑은 고딕"/>
+              </a:rPr>
+              <a:t>- 우선순위를 뒤집으면 C1.</a:t>
+            </a:r>
+          </a:p>
+          <a:p>
+            <a:pPr algn="l"/>
+            <a:r>
+              <a:rPr sz="950" b="0">
+                <a:solidFill>
+                  <a:srgbClr val="1A1A1A"/>
+                </a:solidFill>
+                <a:latin typeface="맑은 고딕"/>
+                <a:ea typeface="맑은 고딕"/>
+              </a:rPr>
+              <a:t>- 한계: [B] simulation, 별 경계(QA1 1.30, QA4 평균 집계)는 결과를 본 뒤 정함. QA4 공수·비용은 </a:t>
+            </a:r>
+          </a:p>
+          <a:p>
+            <a:pPr algn="l"/>
+            <a:r>
+              <a:rPr sz="950" b="0">
+                <a:solidFill>
+                  <a:srgbClr val="1A1A1A"/>
+                </a:solidFill>
+                <a:latin typeface="맑은 고딕"/>
+                <a:ea typeface="맑은 고딕"/>
+              </a:rPr>
+              <a:t>가정 상수 추정.</a:t>
+            </a:r>
+          </a:p>
+        </p:txBody>
+      </p:sp>
+    </p:spTree>
+  </p:cSld>
+  <p:clrMapOvr>
+    <a:masterClrMapping/>
+  </p:clrMapOvr>
+</p:sld>
+</file>
+
+<file path=ppt/slides/slide19.xml><?xml version="1.0" encoding="utf-8"?>
+<p:sld xmlns:a="http://schemas.openxmlformats.org/drawingml/2006/main" xmlns:p="http://schemas.openxmlformats.org/presentationml/2006/main" xmlns:r="http://schemas.openxmlformats.org/officeDocument/2006/relationships">
+  <p:cSld>
+    <p:spTree>
+      <p:nvGrpSpPr>
+        <p:cNvPr id="1" name=""/>
+        <p:cNvGrpSpPr/>
+        <p:nvPr/>
+      </p:nvGrpSpPr>
+      <p:grpSpPr/>
+      <p:sp>
+        <p:nvSpPr>
+          <p:cNvPr id="3" name="제목 2"/>
+          <p:cNvSpPr>
+            <a:spLocks noGrp="1"/>
+          </p:cNvSpPr>
+          <p:nvPr>
+            <p:ph type="title"/>
+          </p:nvPr>
+        </p:nvSpPr>
+        <p:spPr>
+          <a:xfrm>
+            <a:off x="234949" y="137379"/>
+            <a:ext cx="7631530" cy="365125"/>
+          </a:xfrm>
+        </p:spPr>
+        <p:txBody>
+          <a:bodyPr/>
+          <a:lstStyle/>
+          <a:p>
+            <a:r>
+              <a:rPr lang="en-US" altLang="ko-KR" dirty="0"/>
+              <a:t>DP1. 이기종 메모리 기반 Data Migration 구조 - Appendix</a:t>
+            </a:r>
+            <a:r>
+              <a:rPr lang="ko-KR" altLang="en-US" dirty="0"/>
+              <a:t/>
+            </a:r>
+            <a:r>
+              <a:rPr lang="en-US" altLang="ko-KR" dirty="0"/>
+              <a:t/>
+            </a:r>
+            <a:r>
+              <a:rPr lang="ko-KR" altLang="en-US" dirty="0"/>
+              <a:t/>
+            </a:r>
+            <a:r>
+              <a:rPr lang="en-US" altLang="ko-KR" dirty="0"/>
+              <a:t/>
+            </a:r>
+            <a:r>
+              <a:rPr lang="ko-KR" altLang="en-US" dirty="0"/>
+              <a:t/>
+            </a:r>
+          </a:p>
+        </p:txBody>
+      </p:sp>
+      <p:sp>
+        <p:nvSpPr>
+          <p:cNvPr id="5" name="직사각형 4"/>
+          <p:cNvSpPr/>
+          <p:nvPr/>
+        </p:nvSpPr>
+        <p:spPr>
+          <a:xfrm>
+            <a:off x="234949" y="596176"/>
+            <a:ext cx="11747501" cy="396603"/>
+          </a:xfrm>
+          <a:prstGeom prst="rect">
+            <a:avLst/>
+          </a:prstGeom>
+          <a:solidFill>
+            <a:schemeClr val="bg1">
+              <a:lumMod val="50000"/>
+            </a:schemeClr>
+          </a:solidFill>
+          <a:ln>
+            <a:noFill/>
+          </a:ln>
+        </p:spPr>
+        <p:style>
+          <a:lnRef idx="2">
+            <a:schemeClr val="accent1">
+              <a:shade val="50000"/>
+            </a:schemeClr>
+          </a:lnRef>
+          <a:fillRef idx="1">
+            <a:schemeClr val="accent1"/>
+          </a:fillRef>
+          <a:effectRef idx="0">
+            <a:schemeClr val="accent1"/>
+          </a:effectRef>
+          <a:fontRef idx="minor">
+            <a:schemeClr val="lt1"/>
+          </a:fontRef>
+        </p:style>
+        <p:txBody>
+          <a:bodyPr rtlCol="0" anchor="ctr"/>
+          <a:lstStyle/>
+          <a:p>
+            <a:pPr algn="ctr"/>
+            <a:endParaRPr lang="ko-KR" altLang="en-US"/>
+          </a:p>
+        </p:txBody>
+      </p:sp>
+      <p:sp>
+        <p:nvSpPr>
+          <p:cNvPr id="8" name="TextBox 7"/>
+          <p:cNvSpPr txBox="1"/>
+          <p:nvPr/>
+        </p:nvSpPr>
+        <p:spPr>
+          <a:xfrm>
+            <a:off x="469760" y="627926"/>
+            <a:ext cx="11430000" cy="307777"/>
+          </a:xfrm>
+          <a:prstGeom prst="rect">
+            <a:avLst/>
+          </a:prstGeom>
+          <a:noFill/>
+        </p:spPr>
+        <p:txBody>
+          <a:bodyPr wrap="square" rtlCol="0">
+            <a:spAutoFit/>
+          </a:bodyPr>
+          <a:lstStyle/>
+          <a:p>
+            <a:pPr lvl="0">
+              <a:defRPr/>
+            </a:pPr>
+            <a:r>
+              <a:rPr lang="ko-KR" altLang="en-US" sz="1400" b="1" dirty="0">
+                <a:solidFill>
+                  <a:schemeClr val="bg1"/>
+                </a:solidFill>
+              </a:rPr>
+              <a:t>DP1 평가에서 고려한 시나리오</a:t>
+            </a:r>
+            <a:r>
+              <a:rPr lang="en-US" altLang="ko-KR" sz="1400" b="1" dirty="0">
+                <a:solidFill>
+                  <a:schemeClr val="bg1"/>
+                </a:solidFill>
+              </a:rPr>
+              <a:t/>
+            </a:r>
+            <a:r>
+              <a:rPr lang="ko-KR" altLang="en-US" sz="1400" b="1" dirty="0">
+                <a:solidFill>
+                  <a:schemeClr val="bg1"/>
+                </a:solidFill>
+              </a:rPr>
+              <a:t/>
+            </a:r>
+            <a:r>
+              <a:rPr lang="en-US" altLang="ko-KR" sz="1400" b="1" dirty="0">
+                <a:solidFill>
+                  <a:schemeClr val="bg1"/>
+                </a:solidFill>
+              </a:rPr>
+              <a:t/>
+            </a:r>
+            <a:r>
+              <a:rPr lang="ko-KR" altLang="en-US" sz="1400" b="1" dirty="0">
+                <a:solidFill>
+                  <a:schemeClr val="bg1"/>
+                </a:solidFill>
+              </a:rPr>
+              <a:t/>
+            </a:r>
+          </a:p>
+        </p:txBody>
+      </p:sp>
+      <p:sp>
+        <p:nvSpPr>
+          <p:cNvPr id="39" name="직사각형 38"/>
+          <p:cNvSpPr/>
+          <p:nvPr/>
+        </p:nvSpPr>
+        <p:spPr>
+          <a:xfrm>
+            <a:off x="403086" y="678726"/>
+            <a:ext cx="66675" cy="216270"/>
+          </a:xfrm>
+          <a:prstGeom prst="rect">
+            <a:avLst/>
+          </a:prstGeom>
+          <a:solidFill>
+            <a:schemeClr val="bg1"/>
+          </a:solidFill>
+          <a:ln w="19050">
+            <a:noFill/>
+          </a:ln>
+        </p:spPr>
+        <p:style>
+          <a:lnRef idx="2">
+            <a:schemeClr val="accent1">
+              <a:shade val="50000"/>
+            </a:schemeClr>
+          </a:lnRef>
+          <a:fillRef idx="1">
+            <a:schemeClr val="accent1"/>
+          </a:fillRef>
+          <a:effectRef idx="0">
+            <a:schemeClr val="accent1"/>
+          </a:effectRef>
+          <a:fontRef idx="minor">
+            <a:schemeClr val="lt1"/>
+          </a:fontRef>
+        </p:style>
+        <p:txBody>
+          <a:bodyPr rtlCol="0" anchor="ctr"/>
+          <a:lstStyle/>
+          <a:p>
+            <a:pPr algn="ctr"/>
+            <a:endParaRPr lang="ko-KR" altLang="en-US" sz="1600"/>
+          </a:p>
+        </p:txBody>
+      </p:sp>
+      <p:sp>
+        <p:nvSpPr>
+          <p:cNvPr id="57" name="슬라이드 번호 개체 틀 1"/>
+          <p:cNvSpPr>
+            <a:spLocks noGrp="1"/>
+          </p:cNvSpPr>
+          <p:nvPr>
+            <p:ph type="sldNum" sz="quarter" idx="4"/>
+          </p:nvPr>
+        </p:nvSpPr>
+        <p:spPr>
+          <a:xfrm>
+            <a:off x="5620080" y="6597650"/>
+            <a:ext cx="456466" cy="209550"/>
+          </a:xfrm>
+        </p:spPr>
+        <p:txBody>
+          <a:bodyPr/>
+          <a:lstStyle/>
+          <a:p>
+            <a:fld id="{7F889C64-266A-4D07-AD8F-5B592E61CCE1}" type="slidenum">
+              <a:rPr lang="ko-KR" altLang="en-US" smtClean="0"/>
+              <a:pPr/>
+              <a:t>9</a:t>
+            </a:fld>
+            <a:endParaRPr lang="ko-KR" altLang="en-US" dirty="0"/>
+          </a:p>
+        </p:txBody>
+      </p:sp>
+      <p:sp>
+        <p:nvSpPr>
+          <p:cNvPr id="58" name="Rectangle 57"/>
+          <p:cNvSpPr/>
+          <p:nvPr/>
+        </p:nvSpPr>
+        <p:spPr>
+          <a:xfrm>
+            <a:off x="365760" y="1097280"/>
+            <a:ext cx="11430000" cy="502920"/>
+          </a:xfrm>
+          <a:prstGeom prst="rect">
+            <a:avLst/>
+          </a:prstGeom>
+          <a:solidFill>
+            <a:srgbClr val="F2F2F2"/>
+          </a:solidFill>
+          <a:ln w="9525">
+            <a:solidFill>
+              <a:srgbClr val="BFBFBF"/>
+            </a:solidFill>
+          </a:ln>
+          <a:effectLst/>
+        </p:spPr>
+        <p:style>
+          <a:lnRef idx="1">
+            <a:schemeClr val="accent1"/>
+          </a:lnRef>
+          <a:fillRef idx="3">
+            <a:schemeClr val="accent1"/>
+          </a:fillRef>
+          <a:effectRef idx="2">
+            <a:schemeClr val="accent1"/>
+          </a:effectRef>
+          <a:fontRef idx="minor">
+            <a:schemeClr val="lt1"/>
+          </a:fontRef>
+        </p:style>
+        <p:txBody>
+          <a:bodyPr rtlCol="0" anchor="t" wrap="square" lIns="45720" rIns="45720" tIns="27432" bIns="27432"/>
+          <a:lstStyle/>
+          <a:p>
+            <a:pPr algn="l"/>
+            <a:r>
+              <a:rPr sz="1000" b="1">
+                <a:solidFill>
+                  <a:srgbClr val="404040"/>
+                </a:solidFill>
+                <a:latin typeface="맑은 고딕"/>
+                <a:ea typeface="맑은 고딕"/>
+              </a:rPr>
+              <a:t>32개 시나리오를 H100과 B200에 각각 돌렸다(64쌍): 비교 가능 23쌍, 포화 8쌍, Baseline도 SLO 불가라 비교 제외 33쌍.</a:t>
+            </a:r>
+          </a:p>
+        </p:txBody>
+      </p:sp>
+      <p:sp>
+        <p:nvSpPr>
+          <p:cNvPr id="59" name="Rectangle 58"/>
+          <p:cNvSpPr/>
+          <p:nvPr/>
+        </p:nvSpPr>
+        <p:spPr>
+          <a:xfrm>
+            <a:off x="365760" y="1691640"/>
+            <a:ext cx="2651760" cy="841248"/>
           </a:xfrm>
           <a:prstGeom prst="rect">
             <a:avLst/>
@@ -5928,146 +6496,34 @@
           <a:p>
             <a:pPr algn="l"/>
             <a:r>
-              <a:rPr sz="900" b="1">
+              <a:rPr sz="1000" b="1">
                 <a:solidFill>
                   <a:srgbClr val="1A1A1A"/>
                 </a:solidFill>
                 <a:latin typeface="맑은 고딕"/>
                 <a:ea typeface="맑은 고딕"/>
               </a:rPr>
-              <a:t>선택 (우선순위 규칙)</a:t>
-            </a:r>
-          </a:p>
-        </p:txBody>
-      </p:sp>
-      <p:sp>
-        <p:nvSpPr>
-          <p:cNvPr id="77" name="Rectangle 76"/>
+              <a:t>기본 서비스 상황 (공통)</a:t>
+            </a:r>
+          </a:p>
+        </p:txBody>
+      </p:sp>
+      <p:sp>
+        <p:nvSpPr>
+          <p:cNvPr id="60" name="Rectangle 59"/>
           <p:cNvSpPr/>
           <p:nvPr/>
         </p:nvSpPr>
         <p:spPr>
           <a:xfrm>
-            <a:off x="2103120" y="3950208"/>
-            <a:ext cx="4663440" cy="365760"/>
+            <a:off x="3017520" y="1691640"/>
+            <a:ext cx="8778240" cy="841248"/>
           </a:xfrm>
           <a:prstGeom prst="rect">
             <a:avLst/>
           </a:prstGeom>
           <a:solidFill>
-            <a:srgbClr val="E3F1E3"/>
-          </a:solidFill>
-          <a:ln w="9525">
-            <a:solidFill>
-              <a:srgbClr val="5B9B5B"/>
-            </a:solidFill>
-          </a:ln>
-          <a:effectLst/>
-        </p:spPr>
-        <p:style>
-          <a:lnRef idx="1">
-            <a:schemeClr val="accent1"/>
-          </a:lnRef>
-          <a:fillRef idx="3">
-            <a:schemeClr val="accent1"/>
-          </a:fillRef>
-          <a:effectRef idx="2">
-            <a:schemeClr val="accent1"/>
-          </a:effectRef>
-          <a:fontRef idx="minor">
-            <a:schemeClr val="lt1"/>
-          </a:fontRef>
-        </p:style>
-        <p:txBody>
-          <a:bodyPr rtlCol="0" anchor="ctr" wrap="square" lIns="45720" rIns="45720" tIns="27432" bIns="27432"/>
-          <a:lstStyle/>
-          <a:p>
-            <a:pPr algn="ctr"/>
-            <a:r>
-              <a:rPr sz="1000" b="1">
-                <a:solidFill>
-                  <a:srgbClr val="1A1A1A"/>
-                </a:solidFill>
-                <a:latin typeface="맑은 고딕"/>
-                <a:ea typeface="맑은 고딕"/>
-              </a:rPr>
-              <a:t>C2 (QA1)</a:t>
-            </a:r>
-          </a:p>
-        </p:txBody>
-      </p:sp>
-      <p:sp>
-        <p:nvSpPr>
-          <p:cNvPr id="78" name="Rectangle 77"/>
-          <p:cNvSpPr/>
-          <p:nvPr/>
-        </p:nvSpPr>
-        <p:spPr>
-          <a:xfrm>
-            <a:off x="6766559" y="3950208"/>
-            <a:ext cx="4663440" cy="365760"/>
-          </a:xfrm>
-          <a:prstGeom prst="rect">
-            <a:avLst/>
-          </a:prstGeom>
-          <a:solidFill>
-            <a:srgbClr val="E3F1E3"/>
-          </a:solidFill>
-          <a:ln w="9525">
-            <a:solidFill>
-              <a:srgbClr val="5B9B5B"/>
-            </a:solidFill>
-          </a:ln>
-          <a:effectLst/>
-        </p:spPr>
-        <p:style>
-          <a:lnRef idx="1">
-            <a:schemeClr val="accent1"/>
-          </a:lnRef>
-          <a:fillRef idx="3">
-            <a:schemeClr val="accent1"/>
-          </a:fillRef>
-          <a:effectRef idx="2">
-            <a:schemeClr val="accent1"/>
-          </a:effectRef>
-          <a:fontRef idx="minor">
-            <a:schemeClr val="lt1"/>
-          </a:fontRef>
-        </p:style>
-        <p:txBody>
-          <a:bodyPr rtlCol="0" anchor="ctr" wrap="square" lIns="45720" rIns="45720" tIns="27432" bIns="27432"/>
-          <a:lstStyle/>
-          <a:p>
-            <a:pPr algn="ctr"/>
-            <a:r>
-              <a:rPr sz="1000" b="1">
-                <a:solidFill>
-                  <a:srgbClr val="1A1A1A"/>
-                </a:solidFill>
-                <a:latin typeface="맑은 고딕"/>
-                <a:ea typeface="맑은 고딕"/>
-              </a:rPr>
-              <a:t>C2 (합계)</a:t>
-            </a:r>
-          </a:p>
-        </p:txBody>
-      </p:sp>
-      <p:sp>
-        <p:nvSpPr>
-          <p:cNvPr id="79" name="Rectangle 78"/>
-          <p:cNvSpPr/>
-          <p:nvPr/>
-        </p:nvSpPr>
-        <p:spPr>
-          <a:xfrm>
-            <a:off x="365760" y="4425696"/>
-            <a:ext cx="5577840" cy="1463040"/>
-          </a:xfrm>
-          <a:prstGeom prst="rect">
-            <a:avLst/>
-          </a:prstGeom>
-          <a:solidFill>
-            <a:srgbClr val="F2F2F2"/>
+            <a:srgbClr val="FFFFFF"/>
           </a:solidFill>
           <a:ln w="9525">
             <a:solidFill>
@@ -6091,95 +6547,56 @@
           </a:fontRef>
         </p:style>
         <p:txBody>
-          <a:bodyPr rtlCol="0" anchor="t" wrap="square" lIns="45720" rIns="45720" tIns="27432" bIns="27432"/>
+          <a:bodyPr rtlCol="0" anchor="ctr" wrap="square" lIns="45720" rIns="45720" tIns="27432" bIns="27432"/>
           <a:lstStyle/>
           <a:p>
             <a:pPr algn="l"/>
             <a:r>
-              <a:rPr sz="950" b="1">
-                <a:solidFill>
-                  <a:srgbClr val="404040"/>
+              <a:rPr sz="1100" b="0">
+                <a:solidFill>
+                  <a:srgbClr val="1A1A1A"/>
                 </a:solidFill>
                 <a:latin typeface="맑은 고딕"/>
                 <a:ea typeface="맑은 고딕"/>
               </a:rPr>
-              <a:t>Trade-off</a:t>
+              <a:t>8K 토큰 입력, 256 토큰 생성, 동시 32 요청의 대화 서비스. HBM이 빠듯한 경우 / 시간이 갈수록 여유가 줄어드는 경우 / KV cache에 Lo</a:t>
             </a:r>
           </a:p>
           <a:p>
             <a:pPr algn="l"/>
             <a:r>
-              <a:rPr sz="950" b="0">
-                <a:solidFill>
-                  <a:srgbClr val="404040"/>
+              <a:rPr sz="1100" b="0">
+                <a:solidFill>
+                  <a:srgbClr val="1A1A1A"/>
                 </a:solidFill>
                 <a:latin typeface="맑은 고딕"/>
                 <a:ea typeface="맑은 고딕"/>
               </a:rPr>
-              <a:t>- C2 우세 칸: QA1@SYS-H100, QA1@SYS-B200, QA3@SYS-B200</a:t>
-            </a:r>
-          </a:p>
-          <a:p>
-            <a:pPr algn="l"/>
-            <a:r>
-              <a:rPr sz="950" b="0">
-                <a:solidFill>
-                  <a:srgbClr val="404040"/>
-                </a:solidFill>
-                <a:latin typeface="맑은 고딕"/>
-                <a:ea typeface="맑은 고딕"/>
-              </a:rPr>
-              <a:t>- C1 우세 칸: QA4@SYS-H100, QA4@SYS-B200</a:t>
-            </a:r>
-          </a:p>
-          <a:p>
-            <a:pPr algn="l"/>
-            <a:r>
-              <a:rPr sz="950" b="0">
-                <a:solidFill>
-                  <a:srgbClr val="404040"/>
-                </a:solidFill>
-                <a:latin typeface="맑은 고딕"/>
-                <a:ea typeface="맑은 고딕"/>
-              </a:rPr>
-              <a:t>- C2 비용(SYS-B200): migration 1,239 GiB (C1 110), 링크 점유 9.5% (C1 1.3%)</a:t>
-            </a:r>
-          </a:p>
-          <a:p>
-            <a:pPr algn="l"/>
-            <a:r>
-              <a:rPr sz="950" b="0">
-                <a:solidFill>
-                  <a:srgbClr val="404040"/>
-                </a:solidFill>
-                <a:latin typeface="맑은 고딕"/>
-                <a:ea typeface="맑은 고딕"/>
-              </a:rPr>
-              <a:t>- QA4 [B+C]: 평균 집계로 C1 ★★★, C2 ★★ (C2의 공수가 경계 0.5 MM를 0.006 넘음)</a:t>
-            </a:r>
-          </a:p>
-        </p:txBody>
-      </p:sp>
-      <p:sp>
-        <p:nvSpPr>
-          <p:cNvPr id="80" name="Rectangle 79"/>
+              <a:t>RA·MoE·Agent 데이터가 섞이는 경우. 결과: 두 후보 모두 Baseline과 같다.</a:t>
+            </a:r>
+          </a:p>
+        </p:txBody>
+      </p:sp>
+      <p:sp>
+        <p:nvSpPr>
+          <p:cNvPr id="61" name="Rectangle 60"/>
           <p:cNvSpPr/>
           <p:nvPr/>
         </p:nvSpPr>
         <p:spPr>
           <a:xfrm>
-            <a:off x="6126480" y="4425696"/>
-            <a:ext cx="5669280" cy="1463040"/>
+            <a:off x="365760" y="2578608"/>
+            <a:ext cx="2651760" cy="841248"/>
           </a:xfrm>
           <a:prstGeom prst="rect">
             <a:avLst/>
           </a:prstGeom>
           <a:solidFill>
-            <a:srgbClr val="E3F1E3"/>
+            <a:srgbClr val="DCE9F5"/>
           </a:solidFill>
           <a:ln w="9525">
             <a:solidFill>
-              <a:srgbClr val="5B9B5B"/>
+              <a:srgbClr val="4D7EA8"/>
             </a:solidFill>
           </a:ln>
           <a:effectLst/>
@@ -6199,82 +6616,43 @@
           </a:fontRef>
         </p:style>
         <p:txBody>
-          <a:bodyPr rtlCol="0" anchor="t" wrap="square" lIns="45720" rIns="45720" tIns="27432" bIns="27432"/>
+          <a:bodyPr rtlCol="0" anchor="ctr" wrap="square" lIns="45720" rIns="45720" tIns="27432" bIns="27432"/>
           <a:lstStyle/>
           <a:p>
             <a:pPr algn="l"/>
             <a:r>
-              <a:rPr sz="950" b="1">
+              <a:rPr sz="1000" b="1">
                 <a:solidFill>
                   <a:srgbClr val="1A1A1A"/>
                 </a:solidFill>
                 <a:latin typeface="맑은 고딕"/>
                 <a:ea typeface="맑은 고딕"/>
               </a:rPr>
-              <a:t>선택: C2</a:t>
-            </a:r>
-          </a:p>
-          <a:p>
-            <a:pPr algn="l"/>
-            <a:r>
-              <a:rPr sz="950" b="0">
-                <a:solidFill>
-                  <a:srgbClr val="1A1A1A"/>
-                </a:solidFill>
-                <a:latin typeface="맑은 고딕"/>
-                <a:ea typeface="맑은 고딕"/>
-              </a:rPr>
-              <a:t>- 규칙: 별 합계가 높은 후보. 합계가 같을 때만 QA 우선순위(QA1 &gt; QA2 &gt; QA3 &gt; QA4).</a:t>
-            </a:r>
-          </a:p>
-          <a:p>
-            <a:pPr algn="l"/>
-            <a:r>
-              <a:rPr sz="950" b="0">
-                <a:solidFill>
-                  <a:srgbClr val="1A1A1A"/>
-                </a:solidFill>
-                <a:latin typeface="맑은 고딕"/>
-                <a:ea typeface="맑은 고딕"/>
-              </a:rPr>
-              <a:t>- 시스템별 별 합계 합: C1 20, C2 21 -&gt; C2.</a:t>
-            </a:r>
-          </a:p>
-          <a:p>
-            <a:pPr algn="l"/>
-            <a:r>
-              <a:rPr sz="950" b="0">
-                <a:solidFill>
-                  <a:srgbClr val="1A1A1A"/>
-                </a:solidFill>
-                <a:latin typeface="맑은 고딕"/>
-                <a:ea typeface="맑은 고딕"/>
-              </a:rPr>
-              <a:t>- 우선순위 상태: confirmed by owner 2026-10-03</a:t>
-            </a:r>
-          </a:p>
-        </p:txBody>
-      </p:sp>
-      <p:sp>
-        <p:nvSpPr>
-          <p:cNvPr id="81" name="Rectangle 80"/>
+              <a:t>데이터 종류별</a:t>
+            </a:r>
+          </a:p>
+        </p:txBody>
+      </p:sp>
+      <p:sp>
+        <p:nvSpPr>
+          <p:cNvPr id="62" name="Rectangle 61"/>
           <p:cNvSpPr/>
           <p:nvPr/>
         </p:nvSpPr>
         <p:spPr>
           <a:xfrm>
-            <a:off x="365760" y="5980176"/>
-            <a:ext cx="11430000" cy="502920"/>
+            <a:off x="3017520" y="2578608"/>
+            <a:ext cx="8778240" cy="841248"/>
           </a:xfrm>
           <a:prstGeom prst="rect">
             <a:avLst/>
           </a:prstGeom>
           <a:solidFill>
-            <a:srgbClr val="FFF8EC"/>
+            <a:srgbClr val="FFFFFF"/>
           </a:solidFill>
           <a:ln w="9525">
             <a:solidFill>
-              <a:srgbClr val="C98A3C"/>
+              <a:srgbClr val="BFBFBF"/>
             </a:solidFill>
           </a:ln>
           <a:effectLst/>
@@ -6294,19 +6672,433 @@
           </a:fontRef>
         </p:style>
         <p:txBody>
-          <a:bodyPr rtlCol="0" anchor="t" wrap="square" lIns="45720" rIns="45720" tIns="27432" bIns="27432"/>
+          <a:bodyPr rtlCol="0" anchor="ctr" wrap="square" lIns="45720" rIns="45720" tIns="27432" bIns="27432"/>
           <a:lstStyle/>
           <a:p>
             <a:pPr algn="l"/>
             <a:r>
-              <a:rPr sz="850" b="0">
+              <a:rPr sz="1100" b="0">
                 <a:solidFill>
                   <a:srgbClr val="1A1A1A"/>
                 </a:solidFill>
                 <a:latin typeface="맑은 고딕"/>
                 <a:ea typeface="맑은 고딕"/>
               </a:rPr>
-              <a:t>한계: [B] simulation(config 기반, [A] 실측 아님). H100 규격·link 스케일 ASSUMED. QA3는 SSD-PIM이 풀의 약 75%라 U가 1~2%대(상대값으로 판정). QA4 공수·비용은 가정 상수 추정. 별 경계는 결과를 본 뒤 정한 값 포함.</a:t>
+              <a:t>대화 문맥(KV cache, 32K~512K 토큰, 동시 1~256) · 여러 고객이 쓰는 LoRA 어댑터(몇 개만 인기) · MoE expert(라우팅 쏠림) · 수 TiB 벡</a:t>
+            </a:r>
+          </a:p>
+          <a:p>
+            <a:pPr algn="l"/>
+            <a:r>
+              <a:rPr sz="1100" b="0">
+                <a:solidFill>
+                  <a:srgbClr val="1A1A1A"/>
+                </a:solidFill>
+                <a:latin typeface="맑은 고딕"/>
+                <a:ea typeface="맑은 고딕"/>
+              </a:rPr>
+              <a:t>터 DB(RAG) · 오래 보관되는 Agent 기억과 Tool 결과(드물게 재사용 / 한꺼번에 생성 후 반복 참조).</a:t>
+            </a:r>
+          </a:p>
+        </p:txBody>
+      </p:sp>
+      <p:sp>
+        <p:nvSpPr>
+          <p:cNvPr id="63" name="Rectangle 62"/>
+          <p:cNvSpPr/>
+          <p:nvPr/>
+        </p:nvSpPr>
+        <p:spPr>
+          <a:xfrm>
+            <a:off x="365760" y="3465576"/>
+            <a:ext cx="2651760" cy="841248"/>
+          </a:xfrm>
+          <a:prstGeom prst="rect">
+            <a:avLst/>
+          </a:prstGeom>
+          <a:solidFill>
+            <a:srgbClr val="DCE9F5"/>
+          </a:solidFill>
+          <a:ln w="9525">
+            <a:solidFill>
+              <a:srgbClr val="4D7EA8"/>
+            </a:solidFill>
+          </a:ln>
+          <a:effectLst/>
+        </p:spPr>
+        <p:style>
+          <a:lnRef idx="1">
+            <a:schemeClr val="accent1"/>
+          </a:lnRef>
+          <a:fillRef idx="3">
+            <a:schemeClr val="accent1"/>
+          </a:fillRef>
+          <a:effectRef idx="2">
+            <a:schemeClr val="accent1"/>
+          </a:effectRef>
+          <a:fontRef idx="minor">
+            <a:schemeClr val="lt1"/>
+          </a:fontRef>
+        </p:style>
+        <p:txBody>
+          <a:bodyPr rtlCol="0" anchor="ctr" wrap="square" lIns="45720" rIns="45720" tIns="27432" bIns="27432"/>
+          <a:lstStyle/>
+          <a:p>
+            <a:pPr algn="l"/>
+            <a:r>
+              <a:rPr sz="1000" b="1">
+                <a:solidFill>
+                  <a:srgbClr val="1A1A1A"/>
+                </a:solidFill>
+                <a:latin typeface="맑은 고딕"/>
+                <a:ea typeface="맑은 고딕"/>
+              </a:rPr>
+              <a:t>접근이 쏠리는 정도(hotness)</a:t>
+            </a:r>
+          </a:p>
+        </p:txBody>
+      </p:sp>
+      <p:sp>
+        <p:nvSpPr>
+          <p:cNvPr id="64" name="Rectangle 63"/>
+          <p:cNvSpPr/>
+          <p:nvPr/>
+        </p:nvSpPr>
+        <p:spPr>
+          <a:xfrm>
+            <a:off x="3017520" y="3465576"/>
+            <a:ext cx="8778240" cy="841248"/>
+          </a:xfrm>
+          <a:prstGeom prst="rect">
+            <a:avLst/>
+          </a:prstGeom>
+          <a:solidFill>
+            <a:srgbClr val="FFFFFF"/>
+          </a:solidFill>
+          <a:ln w="9525">
+            <a:solidFill>
+              <a:srgbClr val="BFBFBF"/>
+            </a:solidFill>
+          </a:ln>
+          <a:effectLst/>
+        </p:spPr>
+        <p:style>
+          <a:lnRef idx="1">
+            <a:schemeClr val="accent1"/>
+          </a:lnRef>
+          <a:fillRef idx="3">
+            <a:schemeClr val="accent1"/>
+          </a:fillRef>
+          <a:effectRef idx="2">
+            <a:schemeClr val="accent1"/>
+          </a:effectRef>
+          <a:fontRef idx="minor">
+            <a:schemeClr val="lt1"/>
+          </a:fontRef>
+        </p:style>
+        <p:txBody>
+          <a:bodyPr rtlCol="0" anchor="ctr" wrap="square" lIns="45720" rIns="45720" tIns="27432" bIns="27432"/>
+          <a:lstStyle/>
+          <a:p>
+            <a:pPr algn="l"/>
+            <a:r>
+              <a:rPr sz="1100" b="0">
+                <a:solidFill>
+                  <a:srgbClr val="1A1A1A"/>
+                </a:solidFill>
+                <a:latin typeface="맑은 고딕"/>
+                <a:ea typeface="맑은 고딕"/>
+              </a:rPr>
+              <a:t>소수만 인기 있는 skew · 거의 안 쓰이는 cold 데이터가 상위 메모리를 차지 · 갑자기 hot해지는 burst · hot/cold 급반전 · hot 대상이 옮겨 </a:t>
+            </a:r>
+          </a:p>
+          <a:p>
+            <a:pPr algn="l"/>
+            <a:r>
+              <a:rPr sz="1100" b="0">
+                <a:solidFill>
+                  <a:srgbClr val="1A1A1A"/>
+                </a:solidFill>
+                <a:latin typeface="맑은 고딕"/>
+                <a:ea typeface="맑은 고딕"/>
+              </a:rPr>
+              <a:t>감(최근 세션으로 이동, 사용자 그룹이 번갈아 활성, 인기 검색 shard가 바뀜). 고르게 접근되는 전용 시나리오는 아직 없음(중간 KV 기준</a:t>
+            </a:r>
+          </a:p>
+          <a:p>
+            <a:pPr algn="l"/>
+            <a:r>
+              <a:rPr sz="1100" b="0">
+                <a:solidFill>
+                  <a:srgbClr val="1A1A1A"/>
+                </a:solidFill>
+                <a:latin typeface="맑은 고딕"/>
+                <a:ea typeface="맑은 고딕"/>
+              </a:rPr>
+              <a:t>선이 대조군).</a:t>
+            </a:r>
+          </a:p>
+        </p:txBody>
+      </p:sp>
+      <p:sp>
+        <p:nvSpPr>
+          <p:cNvPr id="65" name="Rectangle 64"/>
+          <p:cNvSpPr/>
+          <p:nvPr/>
+        </p:nvSpPr>
+        <p:spPr>
+          <a:xfrm>
+            <a:off x="365760" y="4352544"/>
+            <a:ext cx="2651760" cy="841248"/>
+          </a:xfrm>
+          <a:prstGeom prst="rect">
+            <a:avLst/>
+          </a:prstGeom>
+          <a:solidFill>
+            <a:srgbClr val="DCE9F5"/>
+          </a:solidFill>
+          <a:ln w="9525">
+            <a:solidFill>
+              <a:srgbClr val="4D7EA8"/>
+            </a:solidFill>
+          </a:ln>
+          <a:effectLst/>
+        </p:spPr>
+        <p:style>
+          <a:lnRef idx="1">
+            <a:schemeClr val="accent1"/>
+          </a:lnRef>
+          <a:fillRef idx="3">
+            <a:schemeClr val="accent1"/>
+          </a:fillRef>
+          <a:effectRef idx="2">
+            <a:schemeClr val="accent1"/>
+          </a:effectRef>
+          <a:fontRef idx="minor">
+            <a:schemeClr val="lt1"/>
+          </a:fontRef>
+        </p:style>
+        <p:txBody>
+          <a:bodyPr rtlCol="0" anchor="ctr" wrap="square" lIns="45720" rIns="45720" tIns="27432" bIns="27432"/>
+          <a:lstStyle/>
+          <a:p>
+            <a:pPr algn="l"/>
+            <a:r>
+              <a:rPr sz="1000" b="1">
+                <a:solidFill>
+                  <a:srgbClr val="1A1A1A"/>
+                </a:solidFill>
+                <a:latin typeface="맑은 고딕"/>
+                <a:ea typeface="맑은 고딕"/>
+              </a:rPr>
+              <a:t>자원 조건이 바뀌는 경우</a:t>
+            </a:r>
+          </a:p>
+        </p:txBody>
+      </p:sp>
+      <p:sp>
+        <p:nvSpPr>
+          <p:cNvPr id="66" name="Rectangle 65"/>
+          <p:cNvSpPr/>
+          <p:nvPr/>
+        </p:nvSpPr>
+        <p:spPr>
+          <a:xfrm>
+            <a:off x="3017520" y="4352544"/>
+            <a:ext cx="8778240" cy="841248"/>
+          </a:xfrm>
+          <a:prstGeom prst="rect">
+            <a:avLst/>
+          </a:prstGeom>
+          <a:solidFill>
+            <a:srgbClr val="FFFFFF"/>
+          </a:solidFill>
+          <a:ln w="9525">
+            <a:solidFill>
+              <a:srgbClr val="BFBFBF"/>
+            </a:solidFill>
+          </a:ln>
+          <a:effectLst/>
+        </p:spPr>
+        <p:style>
+          <a:lnRef idx="1">
+            <a:schemeClr val="accent1"/>
+          </a:lnRef>
+          <a:fillRef idx="3">
+            <a:schemeClr val="accent1"/>
+          </a:fillRef>
+          <a:effectRef idx="2">
+            <a:schemeClr val="accent1"/>
+          </a:effectRef>
+          <a:fontRef idx="minor">
+            <a:schemeClr val="lt1"/>
+          </a:fontRef>
+        </p:style>
+        <p:txBody>
+          <a:bodyPr rtlCol="0" anchor="ctr" wrap="square" lIns="45720" rIns="45720" tIns="27432" bIns="27432"/>
+          <a:lstStyle/>
+          <a:p>
+            <a:pPr algn="l"/>
+            <a:r>
+              <a:rPr sz="1100" b="0">
+                <a:solidFill>
+                  <a:srgbClr val="1A1A1A"/>
+                </a:solidFill>
+                <a:latin typeface="맑은 고딕"/>
+                <a:ea typeface="맑은 고딕"/>
+              </a:rPr>
+              <a:t>HBM 용량 압박(고정 / 점진 증가) · HBM 대역폭 급락 · 다른 작업과 공유하는 host 링크 경합(대역폭 25%로 저하) · 6개 메모리 용량을 모</a:t>
+            </a:r>
+          </a:p>
+          <a:p>
+            <a:pPr algn="l"/>
+            <a:r>
+              <a:rPr sz="1100" b="0">
+                <a:solidFill>
+                  <a:srgbClr val="1A1A1A"/>
+                </a:solidFill>
+                <a:latin typeface="맑은 고딕"/>
+                <a:ea typeface="맑은 고딕"/>
+              </a:rPr>
+              <a:t>두 써야 하는 큰 용량 부담.</a:t>
+            </a:r>
+          </a:p>
+        </p:txBody>
+      </p:sp>
+      <p:sp>
+        <p:nvSpPr>
+          <p:cNvPr id="67" name="Rectangle 66"/>
+          <p:cNvSpPr/>
+          <p:nvPr/>
+        </p:nvSpPr>
+        <p:spPr>
+          <a:xfrm>
+            <a:off x="365760" y="5239512"/>
+            <a:ext cx="2651760" cy="841248"/>
+          </a:xfrm>
+          <a:prstGeom prst="rect">
+            <a:avLst/>
+          </a:prstGeom>
+          <a:solidFill>
+            <a:srgbClr val="DCE9F5"/>
+          </a:solidFill>
+          <a:ln w="9525">
+            <a:solidFill>
+              <a:srgbClr val="4D7EA8"/>
+            </a:solidFill>
+          </a:ln>
+          <a:effectLst/>
+        </p:spPr>
+        <p:style>
+          <a:lnRef idx="1">
+            <a:schemeClr val="accent1"/>
+          </a:lnRef>
+          <a:fillRef idx="3">
+            <a:schemeClr val="accent1"/>
+          </a:fillRef>
+          <a:effectRef idx="2">
+            <a:schemeClr val="accent1"/>
+          </a:effectRef>
+          <a:fontRef idx="minor">
+            <a:schemeClr val="lt1"/>
+          </a:fontRef>
+        </p:style>
+        <p:txBody>
+          <a:bodyPr rtlCol="0" anchor="ctr" wrap="square" lIns="45720" rIns="45720" tIns="27432" bIns="27432"/>
+          <a:lstStyle/>
+          <a:p>
+            <a:pPr algn="l"/>
+            <a:r>
+              <a:rPr sz="1000" b="1">
+                <a:solidFill>
+                  <a:srgbClr val="1A1A1A"/>
+                </a:solidFill>
+                <a:latin typeface="맑은 고딕"/>
+                <a:ea typeface="맑은 고딕"/>
+              </a:rPr>
+              <a:t>처음엔 문제없다가 나빠지는 경우 (Dynami</a:t>
+            </a:r>
+          </a:p>
+          <a:p>
+            <a:pPr algn="l"/>
+            <a:r>
+              <a:rPr sz="1000" b="1">
+                <a:solidFill>
+                  <a:srgbClr val="1A1A1A"/>
+                </a:solidFill>
+                <a:latin typeface="맑은 고딕"/>
+                <a:ea typeface="맑은 고딕"/>
+              </a:rPr>
+              <a:t>c 6개)</a:t>
+            </a:r>
+          </a:p>
+        </p:txBody>
+      </p:sp>
+      <p:sp>
+        <p:nvSpPr>
+          <p:cNvPr id="68" name="Rectangle 67"/>
+          <p:cNvSpPr/>
+          <p:nvPr/>
+        </p:nvSpPr>
+        <p:spPr>
+          <a:xfrm>
+            <a:off x="3017520" y="5239512"/>
+            <a:ext cx="8778240" cy="841248"/>
+          </a:xfrm>
+          <a:prstGeom prst="rect">
+            <a:avLst/>
+          </a:prstGeom>
+          <a:solidFill>
+            <a:srgbClr val="FFFFFF"/>
+          </a:solidFill>
+          <a:ln w="9525">
+            <a:solidFill>
+              <a:srgbClr val="BFBFBF"/>
+            </a:solidFill>
+          </a:ln>
+          <a:effectLst/>
+        </p:spPr>
+        <p:style>
+          <a:lnRef idx="1">
+            <a:schemeClr val="accent1"/>
+          </a:lnRef>
+          <a:fillRef idx="3">
+            <a:schemeClr val="accent1"/>
+          </a:fillRef>
+          <a:effectRef idx="2">
+            <a:schemeClr val="accent1"/>
+          </a:effectRef>
+          <a:fontRef idx="minor">
+            <a:schemeClr val="lt1"/>
+          </a:fontRef>
+        </p:style>
+        <p:txBody>
+          <a:bodyPr rtlCol="0" anchor="ctr" wrap="square" lIns="45720" rIns="45720" tIns="27432" bIns="27432"/>
+          <a:lstStyle/>
+          <a:p>
+            <a:pPr algn="l"/>
+            <a:r>
+              <a:rPr sz="1100" b="0">
+                <a:solidFill>
+                  <a:srgbClr val="1A1A1A"/>
+                </a:solidFill>
+                <a:latin typeface="맑은 고딕"/>
+                <a:ea typeface="맑은 고딕"/>
+              </a:rPr>
+              <a:t>Baseline이 처음엔 SLO를 만족하다 중간에 working set이 바뀐다. 예: 오래 보관만 되던 Agent 기억이 HBM을 차지한 채 채팅이 몰림 / ho</a:t>
+            </a:r>
+          </a:p>
+          <a:p>
+            <a:pPr algn="l"/>
+            <a:r>
+              <a:rPr sz="1100" b="0">
+                <a:solidFill>
+                  <a:srgbClr val="1A1A1A"/>
+                </a:solidFill>
+                <a:latin typeface="맑은 고딕"/>
+                <a:ea typeface="맑은 고딕"/>
+              </a:rPr>
+              <a:t>t 대화가 초기 세션에서 최근 세션으로 이동. Baseline의 실패 양상을 알고 설계했으므로 이득은 이 상황에 한정.</a:t>
             </a:r>
           </a:p>
         </p:txBody>

</xml_diff>

<commit_message>
DP1: link-interference model fix (migration link time reduces serving bandwidth), QA3 demoted to diagnostic, results regenerated; pre-fix results preserved
Co-Authored-By: Claude Sonnet 5.5 <noreply@anthropic.com>
Claude-Session: https://claude.ai/code/session_018inK4pZJGzYwjdk7QAyZgn
</commit_message>
<xml_diff>
--- a/doc-mk/DP1/DP1-appendix-qa-result.pptx
+++ b/doc-mk/DP1/DP1-appendix-qa-result.pptx
@@ -5009,7 +5009,7 @@
                 <a:latin typeface="맑은 고딕"/>
                 <a:ea typeface="맑은 고딕"/>
               </a:rPr>
-              <a:t>★★  x1.27 (±0.06)</a:t>
+              <a:t>★★  x1.30 (±0.06)</a:t>
             </a:r>
           </a:p>
           <a:p>
@@ -5078,7 +5078,7 @@
                 <a:latin typeface="맑은 고딕"/>
                 <a:ea typeface="맑은 고딕"/>
               </a:rPr>
-              <a:t>★★★  x1.40 (±0.04)</a:t>
+              <a:t>★★★  x1.42 (±0.05)</a:t>
             </a:r>
           </a:p>
           <a:p>
@@ -5216,7 +5216,7 @@
                 <a:latin typeface="맑은 고딕"/>
                 <a:ea typeface="맑은 고딕"/>
               </a:rPr>
-              <a:t>★★★  x1.40</a:t>
+              <a:t>★★★  x1.28</a:t>
             </a:r>
           </a:p>
           <a:p>
@@ -5229,7 +5229,7 @@
                 <a:latin typeface="맑은 고딕"/>
                 <a:ea typeface="맑은 고딕"/>
               </a:rPr>
-              <a:t>TTFT P50/P95/P99 119/318/356 ms</a:t>
+              <a:t>TTFT P50/P95/P99 119/446/1,411 ms</a:t>
             </a:r>
           </a:p>
         </p:txBody>
@@ -5285,7 +5285,7 @@
                 <a:latin typeface="맑은 고딕"/>
                 <a:ea typeface="맑은 고딕"/>
               </a:rPr>
-              <a:t>★★★  x1.66</a:t>
+              <a:t>★★★  x1.56</a:t>
             </a:r>
           </a:p>
           <a:p>
@@ -5298,7 +5298,7 @@
                 <a:latin typeface="맑은 고딕"/>
                 <a:ea typeface="맑은 고딕"/>
               </a:rPr>
-              <a:t>TTFT P50/P95/P99 118/286/382 ms</a:t>
+              <a:t>TTFT P50/P95/P99 118/335/663 ms</a:t>
             </a:r>
           </a:p>
         </p:txBody>
@@ -5354,7 +5354,7 @@
                 <a:latin typeface="맑은 고딕"/>
                 <a:ea typeface="맑은 고딕"/>
               </a:rPr>
-              <a:t>QA3 Utilization [B]</a:t>
+              <a:t>QA3 (진단, 별점 제외) [B]</a:t>
             </a:r>
           </a:p>
           <a:p>
@@ -5367,7 +5367,7 @@
                 <a:latin typeface="맑은 고딕"/>
                 <a:ea typeface="맑은 고딕"/>
               </a:rPr>
-              <a:t>전 메모리 풀 U 상대값, HBM 점유, 링크 점유</a:t>
+              <a:t>전 메모리 풀 U 상대값, 링크 점유, 이동량</a:t>
             </a:r>
           </a:p>
         </p:txBody>
@@ -5423,7 +5423,7 @@
                 <a:latin typeface="맑은 고딕"/>
                 <a:ea typeface="맑은 고딕"/>
               </a:rPr>
-              <a:t>★★  x1.16 (U 1.62%)</a:t>
+              <a:t>U x1.17 (1.68%)</a:t>
             </a:r>
           </a:p>
           <a:p>
@@ -5436,7 +5436,7 @@
                 <a:latin typeface="맑은 고딕"/>
                 <a:ea typeface="맑은 고딕"/>
               </a:rPr>
-              <a:t>HBM 54% · 링크 1.6%</a:t>
+              <a:t>링크 1.6% · 138 GiB</a:t>
             </a:r>
           </a:p>
         </p:txBody>
@@ -5492,7 +5492,7 @@
                 <a:latin typeface="맑은 고딕"/>
                 <a:ea typeface="맑은 고딕"/>
               </a:rPr>
-              <a:t>★★  x1.13 (U 1.59%)</a:t>
+              <a:t>U x1.14 (1.65%)</a:t>
             </a:r>
           </a:p>
           <a:p>
@@ -5505,7 +5505,7 @@
                 <a:latin typeface="맑은 고딕"/>
                 <a:ea typeface="맑은 고딕"/>
               </a:rPr>
-              <a:t>HBM 68% · 링크 10.5%</a:t>
+              <a:t>링크 10.5% · 1,339 GiB</a:t>
             </a:r>
           </a:p>
         </p:txBody>
@@ -5824,7 +5824,7 @@
                 <a:latin typeface="맑은 고딕"/>
                 <a:ea typeface="맑은 고딕"/>
               </a:rPr>
-              <a:t>10</a:t>
+              <a:t>8</a:t>
             </a:r>
           </a:p>
         </p:txBody>
@@ -5880,7 +5880,7 @@
                 <a:latin typeface="맑은 고딕"/>
                 <a:ea typeface="맑은 고딕"/>
               </a:rPr>
-              <a:t>10</a:t>
+              <a:t>8</a:t>
             </a:r>
           </a:p>
         </p:txBody>
@@ -5975,7 +5975,7 @@
                 <a:latin typeface="맑은 고딕"/>
                 <a:ea typeface="맑은 고딕"/>
               </a:rPr>
-              <a:t>- 비용은 C2: migration 1,339 GiB (C1 138), 링크 점유 10.5% (C1 1.6%)라 활용률(QA3) 이득이 C1을</a:t>
+              <a:t>- 비용은 C2: migration 1,339 GiB (C1 138), 링크 점유 10.5% (C1 1.6%)라 이동이 서빙 링크를 나눠 </a:t>
             </a:r>
           </a:p>
           <a:p>
@@ -5988,7 +5988,7 @@
                 <a:latin typeface="맑은 고딕"/>
                 <a:ea typeface="맑은 고딕"/>
               </a:rPr>
-              <a:t>넘지 못함.</a:t>
+              <a:t>써서 지연·처리량 이득이 줄어든다(간섭 모델 반영).</a:t>
             </a:r>
           </a:p>
           <a:p>
@@ -6083,7 +6083,7 @@
                 <a:latin typeface="맑은 고딕"/>
                 <a:ea typeface="맑은 고딕"/>
               </a:rPr>
-              <a:t>- 규칙: 별 합계가 높은 후보, 같을 때만 QA 우선순위(QA1 &gt; QA2 &gt; QA3 &gt; QA4).</a:t>
+              <a:t>- 규칙: 별 합계가 높은 후보, 같을 때만 QA 우선순위(QA1 &gt; QA2 &gt; QA4).</a:t>
             </a:r>
           </a:p>
           <a:p>
@@ -6096,7 +6096,7 @@
                 <a:latin typeface="맑은 고딕"/>
                 <a:ea typeface="맑은 고딕"/>
               </a:rPr>
-              <a:t>- 합계 10 대 10로 같아 QA 우선순위로 결정: QA1에서 앞선 C2.</a:t>
+              <a:t>- 합계 8 대 8로 같아 QA 우선순위로 결정: QA1에서 앞선 C2.</a:t>
             </a:r>
           </a:p>
           <a:p>
@@ -6447,7 +6447,7 @@
                 <a:latin typeface="맑은 고딕"/>
                 <a:ea typeface="맑은 고딕"/>
               </a:rPr>
-              <a:t>32개 시나리오를 H100과 B200에 각각 돌렸다(64쌍): 비교 가능 23쌍, 포화 8쌍, Baseline도 SLO 불가라 비교 제외 33쌍.</a:t>
+              <a:t>32개 시나리오를 H100과 B200에 각각 돌렸다(64쌍): 비교 가능 21쌍, 포화 10쌍, Baseline도 SLO 불가라 비교 제외 33쌍.</a:t>
             </a:r>
           </a:p>
         </p:txBody>

</xml_diff>

<commit_message>
DP1: QA3 = resource efficiency (goodput per cost-weighted occupancy, cost_model.py); TTFT/TPOT reported separately; results, PPT, criteria and skill updated
Co-Authored-By: Claude Sonnet 5.5 <noreply@anthropic.com>
Claude-Session: https://claude.ai/code/session_018inK4pZJGzYwjdk7QAyZgn
</commit_message>
<xml_diff>
--- a/doc-mk/DP1/DP1-appendix-qa-result.pptx
+++ b/doc-mk/DP1/DP1-appendix-qa-result.pptx
@@ -5160,7 +5160,7 @@
                 <a:latin typeface="맑은 고딕"/>
                 <a:ea typeface="맑은 고딕"/>
               </a:rPr>
-              <a:t>TTFT/TPOT 개선 배수(geomean), 중앙값 TTFT</a:t>
+              <a:t>TTFT와 TPOT 개선 배수(따로), 중앙값 TTFT</a:t>
             </a:r>
           </a:p>
         </p:txBody>
@@ -5216,7 +5216,7 @@
                 <a:latin typeface="맑은 고딕"/>
                 <a:ea typeface="맑은 고딕"/>
               </a:rPr>
-              <a:t>★★★  x1.28</a:t>
+              <a:t>★★★  x1.28 (TTFT x1.58 · TPOT x1.04)</a:t>
             </a:r>
           </a:p>
           <a:p>
@@ -5285,7 +5285,7 @@
                 <a:latin typeface="맑은 고딕"/>
                 <a:ea typeface="맑은 고딕"/>
               </a:rPr>
-              <a:t>★★★  x1.56</a:t>
+              <a:t>★★★  x1.56 (TTFT x2.18 · TPOT x1.12)</a:t>
             </a:r>
           </a:p>
           <a:p>
@@ -5354,7 +5354,7 @@
                 <a:latin typeface="맑은 고딕"/>
                 <a:ea typeface="맑은 고딕"/>
               </a:rPr>
-              <a:t>QA3 (진단, 별점 제외) [B]</a:t>
+              <a:t>QA3 Resource efficiency [B]</a:t>
             </a:r>
           </a:p>
           <a:p>
@@ -5367,7 +5367,20 @@
                 <a:latin typeface="맑은 고딕"/>
                 <a:ea typeface="맑은 고딕"/>
               </a:rPr>
-              <a:t>전 메모리 풀 U 상대값, 링크 점유, 이동량</a:t>
+              <a:t>비용 가중 점유 대비 goodput(상대), 점유 배수, HB</a:t>
+            </a:r>
+          </a:p>
+          <a:p>
+            <a:pPr algn="l"/>
+            <a:r>
+              <a:rPr sz="950" b="1">
+                <a:solidFill>
+                  <a:srgbClr val="1A1A1A"/>
+                </a:solidFill>
+                <a:latin typeface="맑은 고딕"/>
+                <a:ea typeface="맑은 고딕"/>
+              </a:rPr>
+              <a:t>M GiB</a:t>
             </a:r>
           </a:p>
         </p:txBody>
@@ -5423,7 +5436,7 @@
                 <a:latin typeface="맑은 고딕"/>
                 <a:ea typeface="맑은 고딕"/>
               </a:rPr>
-              <a:t>U x1.17 (1.68%)</a:t>
+              <a:t>★★★  x1.50 (±0.06)</a:t>
             </a:r>
           </a:p>
           <a:p>
@@ -5436,7 +5449,7 @@
                 <a:latin typeface="맑은 고딕"/>
                 <a:ea typeface="맑은 고딕"/>
               </a:rPr>
-              <a:t>링크 1.6% · 138 GiB</a:t>
+              <a:t>점유 x0.94 · HBM 237 GiB</a:t>
             </a:r>
           </a:p>
         </p:txBody>
@@ -5492,7 +5505,7 @@
                 <a:latin typeface="맑은 고딕"/>
                 <a:ea typeface="맑은 고딕"/>
               </a:rPr>
-              <a:t>U x1.14 (1.65%)</a:t>
+              <a:t>★★★  x1.42 (±0.05)</a:t>
             </a:r>
           </a:p>
           <a:p>
@@ -5505,7 +5518,7 @@
                 <a:latin typeface="맑은 고딕"/>
                 <a:ea typeface="맑은 고딕"/>
               </a:rPr>
-              <a:t>링크 10.5% · 1,339 GiB</a:t>
+              <a:t>점유 x1.04 · HBM 276 GiB</a:t>
             </a:r>
           </a:p>
         </p:txBody>
@@ -5824,7 +5837,7 @@
                 <a:latin typeface="맑은 고딕"/>
                 <a:ea typeface="맑은 고딕"/>
               </a:rPr>
-              <a:t>8</a:t>
+              <a:t>11</a:t>
             </a:r>
           </a:p>
         </p:txBody>
@@ -5880,7 +5893,7 @@
                 <a:latin typeface="맑은 고딕"/>
                 <a:ea typeface="맑은 고딕"/>
               </a:rPr>
-              <a:t>8</a:t>
+              <a:t>11</a:t>
             </a:r>
           </a:p>
         </p:txBody>
@@ -5975,7 +5988,7 @@
                 <a:latin typeface="맑은 고딕"/>
                 <a:ea typeface="맑은 고딕"/>
               </a:rPr>
-              <a:t>- 비용은 C2: migration 1,339 GiB (C1 138), 링크 점유 10.5% (C1 1.6%)라 이동이 서빙 링크를 나눠 </a:t>
+              <a:t>- 효율은 C1: 비용 가중 점유 대비 성능 C1 x1.50 대 C2 x1.42. C2는 hot 데이터를 HBM에 올려 비싼 </a:t>
             </a:r>
           </a:p>
           <a:p>
@@ -5988,7 +6001,20 @@
                 <a:latin typeface="맑은 고딕"/>
                 <a:ea typeface="맑은 고딕"/>
               </a:rPr>
-              <a:t>써서 지연·처리량 이득이 줄어든다(간섭 모델 반영).</a:t>
+              <a:t>메모리를 더 쓰고(HBM 276 GiB), C1은 싼 tier로 옮겨 비용이 줄어듦.</a:t>
+            </a:r>
+          </a:p>
+          <a:p>
+            <a:pPr algn="l"/>
+            <a:r>
+              <a:rPr sz="950" b="0">
+                <a:solidFill>
+                  <a:srgbClr val="404040"/>
+                </a:solidFill>
+                <a:latin typeface="맑은 고딕"/>
+                <a:ea typeface="맑은 고딕"/>
+              </a:rPr>
+              <a:t>- 이동 비용은 링크 간섭으로 지연에 반영(C2 migration 1,339 GiB, 링크 10.5%).</a:t>
             </a:r>
           </a:p>
           <a:p>
@@ -6014,7 +6040,20 @@
                 <a:latin typeface="맑은 고딕"/>
                 <a:ea typeface="맑은 고딕"/>
               </a:rPr>
-              <a:t>- 지연(QA2)은 둘 다 ★★★ 경계를 넘어 별이 같지만 값은 C2가 높다.</a:t>
+              <a:t>- 지연(QA2)은 둘 다 ★★★ 경계를 넘어 별이 같지만 값은 C2가 높다. TPOT은 거의 변하지 않고 개</a:t>
+            </a:r>
+          </a:p>
+          <a:p>
+            <a:pPr algn="l"/>
+            <a:r>
+              <a:rPr sz="950" b="0">
+                <a:solidFill>
+                  <a:srgbClr val="404040"/>
+                </a:solidFill>
+                <a:latin typeface="맑은 고딕"/>
+                <a:ea typeface="맑은 고딕"/>
+              </a:rPr>
+              <a:t>선은 TTFT에서 나온다.</a:t>
             </a:r>
           </a:p>
         </p:txBody>
@@ -6083,7 +6122,7 @@
                 <a:latin typeface="맑은 고딕"/>
                 <a:ea typeface="맑은 고딕"/>
               </a:rPr>
-              <a:t>- 규칙: 별 합계가 높은 후보, 같을 때만 QA 우선순위(QA1 &gt; QA2 &gt; QA4).</a:t>
+              <a:t>- 규칙: 별 합계가 높은 후보, 같을 때만 QA 우선순위(QA1 &gt; QA2 &gt; QA3 &gt; QA4).</a:t>
             </a:r>
           </a:p>
           <a:p>
@@ -6096,7 +6135,7 @@
                 <a:latin typeface="맑은 고딕"/>
                 <a:ea typeface="맑은 고딕"/>
               </a:rPr>
-              <a:t>- 합계 8 대 8로 같아 QA 우선순위로 결정: QA1에서 앞선 C2.</a:t>
+              <a:t>- 합계 11 대 11로 같아 QA 우선순위로 결정: QA1에서 앞선 C2.</a:t>
             </a:r>
           </a:p>
           <a:p>

</xml_diff>

<commit_message>
DP1: QA3 = HBM usage (resource use only, no performance term); cost-weighted occupancy auxiliary; selection now C1 by star total; docs, PPT, skill updated
Co-Authored-By: Claude Sonnet 5.5 <noreply@anthropic.com>
Claude-Session: https://claude.ai/code/session_018inK4pZJGzYwjdk7QAyZgn
</commit_message>
<xml_diff>
--- a/doc-mk/DP1/DP1-appendix-qa-result.pptx
+++ b/doc-mk/DP1/DP1-appendix-qa-result.pptx
@@ -5354,7 +5354,7 @@
                 <a:latin typeface="맑은 고딕"/>
                 <a:ea typeface="맑은 고딕"/>
               </a:rPr>
-              <a:t>QA3 Resource efficiency [B]</a:t>
+              <a:t>QA3 Resource usage [B]</a:t>
             </a:r>
           </a:p>
           <a:p>
@@ -5367,7 +5367,7 @@
                 <a:latin typeface="맑은 고딕"/>
                 <a:ea typeface="맑은 고딕"/>
               </a:rPr>
-              <a:t>비용 가중 점유 대비 goodput(상대), 점유 배수, HB</a:t>
+              <a:t>HBM 사용량 Baseline 대비(낮을수록 좋음), 줄인/</a:t>
             </a:r>
           </a:p>
           <a:p>
@@ -5380,7 +5380,7 @@
                 <a:latin typeface="맑은 고딕"/>
                 <a:ea typeface="맑은 고딕"/>
               </a:rPr>
-              <a:t>M GiB</a:t>
+              <a:t>늘린 시나리오</a:t>
             </a:r>
           </a:p>
         </p:txBody>
@@ -5436,7 +5436,7 @@
                 <a:latin typeface="맑은 고딕"/>
                 <a:ea typeface="맑은 고딕"/>
               </a:rPr>
-              <a:t>★★★  x1.50 (±0.06)</a:t>
+              <a:t>★★  HBM x0.97 (절감 1.03)</a:t>
             </a:r>
           </a:p>
           <a:p>
@@ -5449,7 +5449,7 @@
                 <a:latin typeface="맑은 고딕"/>
                 <a:ea typeface="맑은 고딕"/>
               </a:rPr>
-              <a:t>점유 x0.94 · HBM 237 GiB</a:t>
+              <a:t>9개 줄임 / 3개 늘림 · 가중 점유 x0.94</a:t>
             </a:r>
           </a:p>
         </p:txBody>
@@ -5505,7 +5505,7 @@
                 <a:latin typeface="맑은 고딕"/>
                 <a:ea typeface="맑은 고딕"/>
               </a:rPr>
-              <a:t>★★★  x1.42 (±0.05)</a:t>
+              <a:t>★  HBM x1.21 (절감 0.82)</a:t>
             </a:r>
           </a:p>
           <a:p>
@@ -5518,7 +5518,7 @@
                 <a:latin typeface="맑은 고딕"/>
                 <a:ea typeface="맑은 고딕"/>
               </a:rPr>
-              <a:t>점유 x1.04 · HBM 276 GiB</a:t>
+              <a:t>1개 줄임 / 18개 늘림 · 가중 점유 x1.04</a:t>
             </a:r>
           </a:p>
         </p:txBody>
@@ -5837,7 +5837,7 @@
                 <a:latin typeface="맑은 고딕"/>
                 <a:ea typeface="맑은 고딕"/>
               </a:rPr>
-              <a:t>11</a:t>
+              <a:t>10</a:t>
             </a:r>
           </a:p>
         </p:txBody>
@@ -5893,7 +5893,7 @@
                 <a:latin typeface="맑은 고딕"/>
                 <a:ea typeface="맑은 고딕"/>
               </a:rPr>
-              <a:t>11</a:t>
+              <a:t>9</a:t>
             </a:r>
           </a:p>
         </p:txBody>
@@ -5988,7 +5988,7 @@
                 <a:latin typeface="맑은 고딕"/>
                 <a:ea typeface="맑은 고딕"/>
               </a:rPr>
-              <a:t>- 효율은 C1: 비용 가중 점유 대비 성능 C1 x1.50 대 C2 x1.42. C2는 hot 데이터를 HBM에 올려 비싼 </a:t>
+              <a:t>- 자원 사용은 C1: HBM 사용량 C1 x0.97 대 C2 x1.21. C2는 성능을 위해 hot 데이터를 HBM에 올려 </a:t>
             </a:r>
           </a:p>
           <a:p>
@@ -6001,7 +6001,7 @@
                 <a:latin typeface="맑은 고딕"/>
                 <a:ea typeface="맑은 고딕"/>
               </a:rPr>
-              <a:t>메모리를 더 쓰고(HBM 276 GiB), C1은 싼 tier로 옮겨 비용이 줄어듦.</a:t>
+              <a:t>HBM을 더 쓰고, C1은 덜 쓰되 이득이 작음(성능과 자원은 반대 방향).</a:t>
             </a:r>
           </a:p>
           <a:p>
@@ -6109,7 +6109,7 @@
                 <a:latin typeface="맑은 고딕"/>
                 <a:ea typeface="맑은 고딕"/>
               </a:rPr>
-              <a:t>선택: C2</a:t>
+              <a:t>선택: C1</a:t>
             </a:r>
           </a:p>
           <a:p>
@@ -6135,7 +6135,7 @@
                 <a:latin typeface="맑은 고딕"/>
                 <a:ea typeface="맑은 고딕"/>
               </a:rPr>
-              <a:t>- 합계 11 대 11로 같아 QA 우선순위로 결정: QA1에서 앞선 C2.</a:t>
+              <a:t>- 별 합계가 높은 C1.</a:t>
             </a:r>
           </a:p>
           <a:p>
@@ -6161,7 +6161,7 @@
                 <a:latin typeface="맑은 고딕"/>
                 <a:ea typeface="맑은 고딕"/>
               </a:rPr>
-              <a:t>- 한계: [B] simulation, 별 경계(QA1 1.30, QA4 평균 집계)는 결과를 본 뒤 정함. QA4 공수·비용은 </a:t>
+              <a:t>- 한계: [B] simulation. 별 경계(QA1 1.30), QA3 정의, QA4 평균 집계는 결과를 본 뒤 정함. 메모리 </a:t>
             </a:r>
           </a:p>
           <a:p>
@@ -6174,7 +6174,7 @@
                 <a:latin typeface="맑은 고딕"/>
                 <a:ea typeface="맑은 고딕"/>
               </a:rPr>
-              <a:t>가정 상수 추정.</a:t>
+              <a:t>가격 가중치(QA3)와 QA4 공수·비용은 ASSUMED.</a:t>
             </a:r>
           </a:p>
         </p:txBody>

</xml_diff>

<commit_message>
Results in criteria section 10 format: quantitative metrics with (x Baseline), TTFT/TPOT separate rows, system note under table; criteria doc, template, skill, result doc and PPT updated
Co-Authored-By: Claude Sonnet 5.5 <noreply@anthropic.com>
Claude-Session: https://claude.ai/code/session_018inK4pZJGzYwjdk7QAyZgn
</commit_message>
<xml_diff>
--- a/doc-mk/DP1/DP1-appendix-qa-result.pptx
+++ b/doc-mk/DP1/DP1-appendix-qa-result.pptx
@@ -4609,7 +4609,7 @@
                   <a:schemeClr val="bg1"/>
                 </a:solidFill>
               </a:rPr>
-              <a:t>DP1 평가 결과 - QA별 후보 비교 (H100 + B200 통합)</a:t>
+              <a:t>DP1 평가 결과 - QA별 정량 metric (H100 + B200 통합)</a:t>
             </a:r>
             <a:r>
               <a:rPr lang="en-US" altLang="ko-KR" sz="1400" b="1" dirty="0">
@@ -4729,8 +4729,8 @@
         </p:nvSpPr>
         <p:spPr>
           <a:xfrm>
-            <a:off x="365760" y="1097280"/>
-            <a:ext cx="2926080" cy="310896"/>
+            <a:off x="365760" y="1051560"/>
+            <a:ext cx="2743200" cy="292608"/>
           </a:xfrm>
           <a:prstGeom prst="rect">
             <a:avLst/>
@@ -4772,7 +4772,7 @@
                 <a:latin typeface="맑은 고딕"/>
                 <a:ea typeface="맑은 고딕"/>
               </a:rPr>
-              <a:t>QA / 지표</a:t>
+              <a:t>QA / 평가 metric</a:t>
             </a:r>
           </a:p>
         </p:txBody>
@@ -4785,8 +4785,8 @@
         </p:nvSpPr>
         <p:spPr>
           <a:xfrm>
-            <a:off x="3291840" y="1097280"/>
-            <a:ext cx="4251960" cy="310896"/>
+            <a:off x="3108960" y="1051560"/>
+            <a:ext cx="1737360" cy="292608"/>
           </a:xfrm>
           <a:prstGeom prst="rect">
             <a:avLst/>
@@ -4828,7 +4828,7 @@
                 <a:latin typeface="맑은 고딕"/>
                 <a:ea typeface="맑은 고딕"/>
               </a:rPr>
-              <a:t>C1 Resource-driven</a:t>
+              <a:t>Baseline</a:t>
             </a:r>
           </a:p>
         </p:txBody>
@@ -4841,8 +4841,8 @@
         </p:nvSpPr>
         <p:spPr>
           <a:xfrm>
-            <a:off x="7543800" y="1097280"/>
-            <a:ext cx="4251960" cy="310896"/>
+            <a:off x="4846320" y="1051560"/>
+            <a:ext cx="3474720" cy="292608"/>
           </a:xfrm>
           <a:prstGeom prst="rect">
             <a:avLst/>
@@ -4884,7 +4884,7 @@
                 <a:latin typeface="맑은 고딕"/>
                 <a:ea typeface="맑은 고딕"/>
               </a:rPr>
-              <a:t>C2 Behavior-driven</a:t>
+              <a:t>C1 Resource-driven</a:t>
             </a:r>
           </a:p>
         </p:txBody>
@@ -4897,8 +4897,64 @@
         </p:nvSpPr>
         <p:spPr>
           <a:xfrm>
-            <a:off x="365760" y="1444752"/>
-            <a:ext cx="2926080" cy="566928"/>
+            <a:off x="8321040" y="1051560"/>
+            <a:ext cx="3474720" cy="292608"/>
+          </a:xfrm>
+          <a:prstGeom prst="rect">
+            <a:avLst/>
+          </a:prstGeom>
+          <a:solidFill>
+            <a:srgbClr val="1F4E79"/>
+          </a:solidFill>
+          <a:ln w="9525">
+            <a:solidFill>
+              <a:srgbClr val="1F4E79"/>
+            </a:solidFill>
+          </a:ln>
+          <a:effectLst/>
+        </p:spPr>
+        <p:style>
+          <a:lnRef idx="1">
+            <a:schemeClr val="accent1"/>
+          </a:lnRef>
+          <a:fillRef idx="3">
+            <a:schemeClr val="accent1"/>
+          </a:fillRef>
+          <a:effectRef idx="2">
+            <a:schemeClr val="accent1"/>
+          </a:effectRef>
+          <a:fontRef idx="minor">
+            <a:schemeClr val="lt1"/>
+          </a:fontRef>
+        </p:style>
+        <p:txBody>
+          <a:bodyPr rtlCol="0" anchor="ctr" wrap="square" lIns="45720" rIns="45720" tIns="27432" bIns="27432"/>
+          <a:lstStyle/>
+          <a:p>
+            <a:pPr algn="ctr"/>
+            <a:r>
+              <a:rPr sz="1000" b="1">
+                <a:solidFill>
+                  <a:srgbClr val="FFFFFF"/>
+                </a:solidFill>
+                <a:latin typeface="맑은 고딕"/>
+                <a:ea typeface="맑은 고딕"/>
+              </a:rPr>
+              <a:t>C2 Behavior-driven</a:t>
+            </a:r>
+          </a:p>
+        </p:txBody>
+      </p:sp>
+      <p:sp>
+        <p:nvSpPr>
+          <p:cNvPr id="62" name="Rectangle 61"/>
+          <p:cNvSpPr/>
+          <p:nvPr/>
+        </p:nvSpPr>
+        <p:spPr>
+          <a:xfrm>
+            <a:off x="365760" y="1362456"/>
+            <a:ext cx="2743200" cy="457200"/>
           </a:xfrm>
           <a:prstGeom prst="rect">
             <a:avLst/>
@@ -4933,41 +4989,41 @@
           <a:p>
             <a:pPr algn="l"/>
             <a:r>
-              <a:rPr sz="950" b="1">
+              <a:rPr sz="900" b="1">
                 <a:solidFill>
                   <a:srgbClr val="1A1A1A"/>
                 </a:solidFill>
                 <a:latin typeface="맑은 고딕"/>
                 <a:ea typeface="맑은 고딕"/>
               </a:rPr>
-              <a:t>QA1 Throughput [B]</a:t>
+              <a:t>QA1 Throughput</a:t>
             </a:r>
           </a:p>
           <a:p>
             <a:pPr algn="l"/>
             <a:r>
-              <a:rPr sz="950" b="1">
+              <a:rPr sz="900" b="1">
                 <a:solidFill>
                   <a:srgbClr val="1A1A1A"/>
                 </a:solidFill>
                 <a:latin typeface="맑은 고딕"/>
                 <a:ea typeface="맑은 고딕"/>
               </a:rPr>
-              <a:t>Baseline 대비 SLO goodput 배수, 승/무/패</a:t>
-            </a:r>
-          </a:p>
-        </p:txBody>
-      </p:sp>
-      <p:sp>
-        <p:nvSpPr>
-          <p:cNvPr id="62" name="Rectangle 61"/>
+              <a:t>Max SLO goodput (tok/s) ↑</a:t>
+            </a:r>
+          </a:p>
+        </p:txBody>
+      </p:sp>
+      <p:sp>
+        <p:nvSpPr>
+          <p:cNvPr id="63" name="Rectangle 62"/>
           <p:cNvSpPr/>
           <p:nvPr/>
         </p:nvSpPr>
         <p:spPr>
           <a:xfrm>
-            <a:off x="3291840" y="1444752"/>
-            <a:ext cx="4251960" cy="566928"/>
+            <a:off x="3108960" y="1362456"/>
+            <a:ext cx="1737360" cy="457200"/>
           </a:xfrm>
           <a:prstGeom prst="rect">
             <a:avLst/>
@@ -5002,41 +5058,28 @@
           <a:p>
             <a:pPr algn="ctr"/>
             <a:r>
-              <a:rPr sz="1000" b="0">
+              <a:rPr sz="950" b="0">
                 <a:solidFill>
                   <a:srgbClr val="1A1A1A"/>
                 </a:solidFill>
                 <a:latin typeface="맑은 고딕"/>
                 <a:ea typeface="맑은 고딕"/>
               </a:rPr>
-              <a:t>★★  x1.30 (±0.06)</a:t>
-            </a:r>
-          </a:p>
-          <a:p>
-            <a:pPr algn="ctr"/>
-            <a:r>
-              <a:rPr sz="1000" b="0">
-                <a:solidFill>
-                  <a:srgbClr val="1A1A1A"/>
-                </a:solidFill>
-                <a:latin typeface="맑은 고딕"/>
-                <a:ea typeface="맑은 고딕"/>
-              </a:rPr>
-              <a:t>6승 25무 0패</a:t>
-            </a:r>
-          </a:p>
-        </p:txBody>
-      </p:sp>
-      <p:sp>
-        <p:nvSpPr>
-          <p:cNvPr id="63" name="Rectangle 62"/>
+              <a:t>336</a:t>
+            </a:r>
+          </a:p>
+        </p:txBody>
+      </p:sp>
+      <p:sp>
+        <p:nvSpPr>
+          <p:cNvPr id="64" name="Rectangle 63"/>
           <p:cNvSpPr/>
           <p:nvPr/>
         </p:nvSpPr>
         <p:spPr>
           <a:xfrm>
-            <a:off x="7543800" y="1444752"/>
-            <a:ext cx="4251960" cy="566928"/>
+            <a:off x="4846320" y="1362456"/>
+            <a:ext cx="3474720" cy="457200"/>
           </a:xfrm>
           <a:prstGeom prst="rect">
             <a:avLst/>
@@ -5071,41 +5114,84 @@
           <a:p>
             <a:pPr algn="ctr"/>
             <a:r>
-              <a:rPr sz="1000" b="0">
+              <a:rPr sz="950" b="0">
                 <a:solidFill>
                   <a:srgbClr val="1A1A1A"/>
                 </a:solidFill>
                 <a:latin typeface="맑은 고딕"/>
                 <a:ea typeface="맑은 고딕"/>
               </a:rPr>
-              <a:t>★★★  x1.42 (±0.05)</a:t>
-            </a:r>
-          </a:p>
+              <a:t>★★  436 (x1.30)</a:t>
+            </a:r>
+          </a:p>
+        </p:txBody>
+      </p:sp>
+      <p:sp>
+        <p:nvSpPr>
+          <p:cNvPr id="65" name="Rectangle 64"/>
+          <p:cNvSpPr/>
+          <p:nvPr/>
+        </p:nvSpPr>
+        <p:spPr>
+          <a:xfrm>
+            <a:off x="8321040" y="1362456"/>
+            <a:ext cx="3474720" cy="457200"/>
+          </a:xfrm>
+          <a:prstGeom prst="rect">
+            <a:avLst/>
+          </a:prstGeom>
+          <a:solidFill>
+            <a:srgbClr val="FFFFFF"/>
+          </a:solidFill>
+          <a:ln w="9525">
+            <a:solidFill>
+              <a:srgbClr val="BFBFBF"/>
+            </a:solidFill>
+          </a:ln>
+          <a:effectLst/>
+        </p:spPr>
+        <p:style>
+          <a:lnRef idx="1">
+            <a:schemeClr val="accent1"/>
+          </a:lnRef>
+          <a:fillRef idx="3">
+            <a:schemeClr val="accent1"/>
+          </a:fillRef>
+          <a:effectRef idx="2">
+            <a:schemeClr val="accent1"/>
+          </a:effectRef>
+          <a:fontRef idx="minor">
+            <a:schemeClr val="lt1"/>
+          </a:fontRef>
+        </p:style>
+        <p:txBody>
+          <a:bodyPr rtlCol="0" anchor="ctr" wrap="square" lIns="45720" rIns="45720" tIns="27432" bIns="27432"/>
+          <a:lstStyle/>
           <a:p>
             <a:pPr algn="ctr"/>
             <a:r>
-              <a:rPr sz="1000" b="0">
+              <a:rPr sz="950" b="0">
                 <a:solidFill>
                   <a:srgbClr val="1A1A1A"/>
                 </a:solidFill>
                 <a:latin typeface="맑은 고딕"/>
                 <a:ea typeface="맑은 고딕"/>
               </a:rPr>
-              <a:t>10승 21무 0패</a:t>
-            </a:r>
-          </a:p>
-        </p:txBody>
-      </p:sp>
-      <p:sp>
-        <p:nvSpPr>
-          <p:cNvPr id="64" name="Rectangle 63"/>
+              <a:t>★★★  478 (x1.42)</a:t>
+            </a:r>
+          </a:p>
+        </p:txBody>
+      </p:sp>
+      <p:sp>
+        <p:nvSpPr>
+          <p:cNvPr id="66" name="Rectangle 65"/>
           <p:cNvSpPr/>
           <p:nvPr/>
         </p:nvSpPr>
         <p:spPr>
           <a:xfrm>
-            <a:off x="365760" y="2029968"/>
-            <a:ext cx="2926080" cy="566928"/>
+            <a:off x="365760" y="1837943"/>
+            <a:ext cx="2743200" cy="457200"/>
           </a:xfrm>
           <a:prstGeom prst="rect">
             <a:avLst/>
@@ -5140,41 +5226,41 @@
           <a:p>
             <a:pPr algn="l"/>
             <a:r>
-              <a:rPr sz="950" b="1">
+              <a:rPr sz="900" b="1">
                 <a:solidFill>
                   <a:srgbClr val="1A1A1A"/>
                 </a:solidFill>
                 <a:latin typeface="맑은 고딕"/>
                 <a:ea typeface="맑은 고딕"/>
               </a:rPr>
-              <a:t>QA2 Latency [B]</a:t>
+              <a:t>QA2 Latency — TTFT</a:t>
             </a:r>
           </a:p>
           <a:p>
             <a:pPr algn="l"/>
             <a:r>
-              <a:rPr sz="950" b="1">
+              <a:rPr sz="900" b="1">
                 <a:solidFill>
                   <a:srgbClr val="1A1A1A"/>
                 </a:solidFill>
                 <a:latin typeface="맑은 고딕"/>
                 <a:ea typeface="맑은 고딕"/>
               </a:rPr>
-              <a:t>TTFT와 TPOT 개선 배수(따로), 중앙값 TTFT</a:t>
-            </a:r>
-          </a:p>
-        </p:txBody>
-      </p:sp>
-      <p:sp>
-        <p:nvSpPr>
-          <p:cNvPr id="65" name="Rectangle 64"/>
+              <a:t>P99 · P50 (ms) ↓</a:t>
+            </a:r>
+          </a:p>
+        </p:txBody>
+      </p:sp>
+      <p:sp>
+        <p:nvSpPr>
+          <p:cNvPr id="67" name="Rectangle 66"/>
           <p:cNvSpPr/>
           <p:nvPr/>
         </p:nvSpPr>
         <p:spPr>
           <a:xfrm>
-            <a:off x="3291840" y="2029968"/>
-            <a:ext cx="4251960" cy="566928"/>
+            <a:off x="3108960" y="1837943"/>
+            <a:ext cx="1737360" cy="457200"/>
           </a:xfrm>
           <a:prstGeom prst="rect">
             <a:avLst/>
@@ -5209,41 +5295,28 @@
           <a:p>
             <a:pPr algn="ctr"/>
             <a:r>
-              <a:rPr sz="1000" b="0">
+              <a:rPr sz="950" b="0">
                 <a:solidFill>
                   <a:srgbClr val="1A1A1A"/>
                 </a:solidFill>
                 <a:latin typeface="맑은 고딕"/>
                 <a:ea typeface="맑은 고딕"/>
               </a:rPr>
-              <a:t>★★★  x1.28 (TTFT x1.58 · TPOT x1.04)</a:t>
-            </a:r>
-          </a:p>
-          <a:p>
-            <a:pPr algn="ctr"/>
-            <a:r>
-              <a:rPr sz="1000" b="0">
-                <a:solidFill>
-                  <a:srgbClr val="1A1A1A"/>
-                </a:solidFill>
-                <a:latin typeface="맑은 고딕"/>
-                <a:ea typeface="맑은 고딕"/>
-              </a:rPr>
-              <a:t>TTFT P50/P95/P99 119/446/1,411 ms</a:t>
-            </a:r>
-          </a:p>
-        </p:txBody>
-      </p:sp>
-      <p:sp>
-        <p:nvSpPr>
-          <p:cNvPr id="66" name="Rectangle 65"/>
+              <a:t>P99 1,084 · P50 407</a:t>
+            </a:r>
+          </a:p>
+        </p:txBody>
+      </p:sp>
+      <p:sp>
+        <p:nvSpPr>
+          <p:cNvPr id="68" name="Rectangle 67"/>
           <p:cNvSpPr/>
           <p:nvPr/>
         </p:nvSpPr>
         <p:spPr>
           <a:xfrm>
-            <a:off x="7543800" y="2029968"/>
-            <a:ext cx="4251960" cy="566928"/>
+            <a:off x="4846320" y="1837943"/>
+            <a:ext cx="3474720" cy="457200"/>
           </a:xfrm>
           <a:prstGeom prst="rect">
             <a:avLst/>
@@ -5278,41 +5351,84 @@
           <a:p>
             <a:pPr algn="ctr"/>
             <a:r>
-              <a:rPr sz="1000" b="0">
+              <a:rPr sz="950" b="0">
                 <a:solidFill>
                   <a:srgbClr val="1A1A1A"/>
                 </a:solidFill>
                 <a:latin typeface="맑은 고딕"/>
                 <a:ea typeface="맑은 고딕"/>
               </a:rPr>
-              <a:t>★★★  x1.56 (TTFT x2.18 · TPOT x1.12)</a:t>
-            </a:r>
-          </a:p>
+              <a:t>P99 1,128 (x1.04) · P50 181 (x0.44)</a:t>
+            </a:r>
+          </a:p>
+        </p:txBody>
+      </p:sp>
+      <p:sp>
+        <p:nvSpPr>
+          <p:cNvPr id="69" name="Rectangle 68"/>
+          <p:cNvSpPr/>
+          <p:nvPr/>
+        </p:nvSpPr>
+        <p:spPr>
+          <a:xfrm>
+            <a:off x="8321040" y="1837943"/>
+            <a:ext cx="3474720" cy="457200"/>
+          </a:xfrm>
+          <a:prstGeom prst="rect">
+            <a:avLst/>
+          </a:prstGeom>
+          <a:solidFill>
+            <a:srgbClr val="FFFFFF"/>
+          </a:solidFill>
+          <a:ln w="9525">
+            <a:solidFill>
+              <a:srgbClr val="BFBFBF"/>
+            </a:solidFill>
+          </a:ln>
+          <a:effectLst/>
+        </p:spPr>
+        <p:style>
+          <a:lnRef idx="1">
+            <a:schemeClr val="accent1"/>
+          </a:lnRef>
+          <a:fillRef idx="3">
+            <a:schemeClr val="accent1"/>
+          </a:fillRef>
+          <a:effectRef idx="2">
+            <a:schemeClr val="accent1"/>
+          </a:effectRef>
+          <a:fontRef idx="minor">
+            <a:schemeClr val="lt1"/>
+          </a:fontRef>
+        </p:style>
+        <p:txBody>
+          <a:bodyPr rtlCol="0" anchor="ctr" wrap="square" lIns="45720" rIns="45720" tIns="27432" bIns="27432"/>
+          <a:lstStyle/>
           <a:p>
             <a:pPr algn="ctr"/>
             <a:r>
-              <a:rPr sz="1000" b="0">
+              <a:rPr sz="950" b="0">
                 <a:solidFill>
                   <a:srgbClr val="1A1A1A"/>
                 </a:solidFill>
                 <a:latin typeface="맑은 고딕"/>
                 <a:ea typeface="맑은 고딕"/>
               </a:rPr>
-              <a:t>TTFT P50/P95/P99 118/335/663 ms</a:t>
-            </a:r>
-          </a:p>
-        </p:txBody>
-      </p:sp>
-      <p:sp>
-        <p:nvSpPr>
-          <p:cNvPr id="67" name="Rectangle 66"/>
+              <a:t>P99 785 (x0.72) · P50 118 (x0.29)</a:t>
+            </a:r>
+          </a:p>
+        </p:txBody>
+      </p:sp>
+      <p:sp>
+        <p:nvSpPr>
+          <p:cNvPr id="70" name="Rectangle 69"/>
           <p:cNvSpPr/>
           <p:nvPr/>
         </p:nvSpPr>
         <p:spPr>
           <a:xfrm>
-            <a:off x="365760" y="2615184"/>
-            <a:ext cx="2926080" cy="566928"/>
+            <a:off x="365760" y="2313432"/>
+            <a:ext cx="2743200" cy="457200"/>
           </a:xfrm>
           <a:prstGeom prst="rect">
             <a:avLst/>
@@ -5347,54 +5463,41 @@
           <a:p>
             <a:pPr algn="l"/>
             <a:r>
-              <a:rPr sz="950" b="1">
+              <a:rPr sz="900" b="1">
                 <a:solidFill>
                   <a:srgbClr val="1A1A1A"/>
                 </a:solidFill>
                 <a:latin typeface="맑은 고딕"/>
                 <a:ea typeface="맑은 고딕"/>
               </a:rPr>
-              <a:t>QA3 Resource usage [B]</a:t>
+              <a:t>QA2 Latency — TPOT</a:t>
             </a:r>
           </a:p>
           <a:p>
             <a:pPr algn="l"/>
             <a:r>
-              <a:rPr sz="950" b="1">
+              <a:rPr sz="900" b="1">
                 <a:solidFill>
                   <a:srgbClr val="1A1A1A"/>
                 </a:solidFill>
                 <a:latin typeface="맑은 고딕"/>
                 <a:ea typeface="맑은 고딕"/>
               </a:rPr>
-              <a:t>HBM 사용량 Baseline 대비(낮을수록 좋음), 줄인/</a:t>
-            </a:r>
-          </a:p>
-          <a:p>
-            <a:pPr algn="l"/>
-            <a:r>
-              <a:rPr sz="950" b="1">
-                <a:solidFill>
-                  <a:srgbClr val="1A1A1A"/>
-                </a:solidFill>
-                <a:latin typeface="맑은 고딕"/>
-                <a:ea typeface="맑은 고딕"/>
-              </a:rPr>
-              <a:t>늘린 시나리오</a:t>
-            </a:r>
-          </a:p>
-        </p:txBody>
-      </p:sp>
-      <p:sp>
-        <p:nvSpPr>
-          <p:cNvPr id="68" name="Rectangle 67"/>
+              <a:t>P99 · P50 (ms) ↓</a:t>
+            </a:r>
+          </a:p>
+        </p:txBody>
+      </p:sp>
+      <p:sp>
+        <p:nvSpPr>
+          <p:cNvPr id="71" name="Rectangle 70"/>
           <p:cNvSpPr/>
           <p:nvPr/>
         </p:nvSpPr>
         <p:spPr>
           <a:xfrm>
-            <a:off x="3291840" y="2615184"/>
-            <a:ext cx="4251960" cy="566928"/>
+            <a:off x="3108960" y="2313432"/>
+            <a:ext cx="1737360" cy="457200"/>
           </a:xfrm>
           <a:prstGeom prst="rect">
             <a:avLst/>
@@ -5429,41 +5532,28 @@
           <a:p>
             <a:pPr algn="ctr"/>
             <a:r>
-              <a:rPr sz="1000" b="0">
+              <a:rPr sz="950" b="0">
                 <a:solidFill>
                   <a:srgbClr val="1A1A1A"/>
                 </a:solidFill>
                 <a:latin typeface="맑은 고딕"/>
                 <a:ea typeface="맑은 고딕"/>
               </a:rPr>
-              <a:t>★★  HBM x0.97 (절감 1.03)</a:t>
-            </a:r>
-          </a:p>
-          <a:p>
-            <a:pPr algn="ctr"/>
-            <a:r>
-              <a:rPr sz="1000" b="0">
-                <a:solidFill>
-                  <a:srgbClr val="1A1A1A"/>
-                </a:solidFill>
-                <a:latin typeface="맑은 고딕"/>
-                <a:ea typeface="맑은 고딕"/>
-              </a:rPr>
-              <a:t>9개 줄임 / 3개 늘림 · 가중 점유 x0.94</a:t>
-            </a:r>
-          </a:p>
-        </p:txBody>
-      </p:sp>
-      <p:sp>
-        <p:nvSpPr>
-          <p:cNvPr id="69" name="Rectangle 68"/>
+              <a:t>P99 17.1 · P50 14.0</a:t>
+            </a:r>
+          </a:p>
+        </p:txBody>
+      </p:sp>
+      <p:sp>
+        <p:nvSpPr>
+          <p:cNvPr id="72" name="Rectangle 71"/>
           <p:cNvSpPr/>
           <p:nvPr/>
         </p:nvSpPr>
         <p:spPr>
           <a:xfrm>
-            <a:off x="7543800" y="2615184"/>
-            <a:ext cx="4251960" cy="566928"/>
+            <a:off x="4846320" y="2313432"/>
+            <a:ext cx="3474720" cy="457200"/>
           </a:xfrm>
           <a:prstGeom prst="rect">
             <a:avLst/>
@@ -5498,41 +5588,84 @@
           <a:p>
             <a:pPr algn="ctr"/>
             <a:r>
-              <a:rPr sz="1000" b="0">
+              <a:rPr sz="950" b="0">
                 <a:solidFill>
                   <a:srgbClr val="1A1A1A"/>
                 </a:solidFill>
                 <a:latin typeface="맑은 고딕"/>
                 <a:ea typeface="맑은 고딕"/>
               </a:rPr>
-              <a:t>★  HBM x1.21 (절감 0.82)</a:t>
-            </a:r>
-          </a:p>
+              <a:t>P99 18.3 (x1.07) · P50 12.7 (x0.91)</a:t>
+            </a:r>
+          </a:p>
+        </p:txBody>
+      </p:sp>
+      <p:sp>
+        <p:nvSpPr>
+          <p:cNvPr id="73" name="Rectangle 72"/>
+          <p:cNvSpPr/>
+          <p:nvPr/>
+        </p:nvSpPr>
+        <p:spPr>
+          <a:xfrm>
+            <a:off x="8321040" y="2313432"/>
+            <a:ext cx="3474720" cy="457200"/>
+          </a:xfrm>
+          <a:prstGeom prst="rect">
+            <a:avLst/>
+          </a:prstGeom>
+          <a:solidFill>
+            <a:srgbClr val="FFFFFF"/>
+          </a:solidFill>
+          <a:ln w="9525">
+            <a:solidFill>
+              <a:srgbClr val="BFBFBF"/>
+            </a:solidFill>
+          </a:ln>
+          <a:effectLst/>
+        </p:spPr>
+        <p:style>
+          <a:lnRef idx="1">
+            <a:schemeClr val="accent1"/>
+          </a:lnRef>
+          <a:fillRef idx="3">
+            <a:schemeClr val="accent1"/>
+          </a:fillRef>
+          <a:effectRef idx="2">
+            <a:schemeClr val="accent1"/>
+          </a:effectRef>
+          <a:fontRef idx="minor">
+            <a:schemeClr val="lt1"/>
+          </a:fontRef>
+        </p:style>
+        <p:txBody>
+          <a:bodyPr rtlCol="0" anchor="ctr" wrap="square" lIns="45720" rIns="45720" tIns="27432" bIns="27432"/>
+          <a:lstStyle/>
           <a:p>
             <a:pPr algn="ctr"/>
             <a:r>
-              <a:rPr sz="1000" b="0">
+              <a:rPr sz="950" b="0">
                 <a:solidFill>
                   <a:srgbClr val="1A1A1A"/>
                 </a:solidFill>
                 <a:latin typeface="맑은 고딕"/>
                 <a:ea typeface="맑은 고딕"/>
               </a:rPr>
-              <a:t>1개 줄임 / 18개 늘림 · 가중 점유 x1.04</a:t>
-            </a:r>
-          </a:p>
-        </p:txBody>
-      </p:sp>
-      <p:sp>
-        <p:nvSpPr>
-          <p:cNvPr id="70" name="Rectangle 69"/>
+              <a:t>P99 16.0 (x0.94) · P50 12.0 (x0.86)</a:t>
+            </a:r>
+          </a:p>
+        </p:txBody>
+      </p:sp>
+      <p:sp>
+        <p:nvSpPr>
+          <p:cNvPr id="74" name="Rectangle 73"/>
           <p:cNvSpPr/>
           <p:nvPr/>
         </p:nvSpPr>
         <p:spPr>
           <a:xfrm>
-            <a:off x="365760" y="3200400"/>
-            <a:ext cx="2926080" cy="566928"/>
+            <a:off x="365760" y="2788920"/>
+            <a:ext cx="2743200" cy="457200"/>
           </a:xfrm>
           <a:prstGeom prst="rect">
             <a:avLst/>
@@ -5567,41 +5700,41 @@
           <a:p>
             <a:pPr algn="l"/>
             <a:r>
-              <a:rPr sz="950" b="1">
+              <a:rPr sz="900" b="1">
                 <a:solidFill>
                   <a:srgbClr val="1A1A1A"/>
                 </a:solidFill>
                 <a:latin typeface="맑은 고딕"/>
                 <a:ea typeface="맑은 고딕"/>
               </a:rPr>
-              <a:t>QA4 Modifiability [B+C]</a:t>
+              <a:t>QA2 별점</a:t>
             </a:r>
           </a:p>
           <a:p>
             <a:pPr algn="l"/>
             <a:r>
-              <a:rPr sz="950" b="1">
+              <a:rPr sz="900" b="1">
                 <a:solidFill>
                   <a:srgbClr val="1A1A1A"/>
                 </a:solidFill>
                 <a:latin typeface="맑은 고딕"/>
                 <a:ea typeface="맑은 고딕"/>
               </a:rPr>
-              <a:t>변경 4종 평균: module, 공수, 에이전트 비용</a:t>
-            </a:r>
-          </a:p>
-        </p:txBody>
-      </p:sp>
-      <p:sp>
-        <p:nvSpPr>
-          <p:cNvPr id="71" name="Rectangle 70"/>
+              <a:t>6개 지표 개선 배수 geomean</a:t>
+            </a:r>
+          </a:p>
+        </p:txBody>
+      </p:sp>
+      <p:sp>
+        <p:nvSpPr>
+          <p:cNvPr id="75" name="Rectangle 74"/>
           <p:cNvSpPr/>
           <p:nvPr/>
         </p:nvSpPr>
         <p:spPr>
           <a:xfrm>
-            <a:off x="3291840" y="3200400"/>
-            <a:ext cx="4251960" cy="566928"/>
+            <a:off x="3108960" y="2788920"/>
+            <a:ext cx="1737360" cy="457200"/>
           </a:xfrm>
           <a:prstGeom prst="rect">
             <a:avLst/>
@@ -5636,41 +5769,28 @@
           <a:p>
             <a:pPr algn="ctr"/>
             <a:r>
-              <a:rPr sz="1000" b="0">
+              <a:rPr sz="950" b="0">
                 <a:solidFill>
                   <a:srgbClr val="1A1A1A"/>
                 </a:solidFill>
                 <a:latin typeface="맑은 고딕"/>
                 <a:ea typeface="맑은 고딕"/>
               </a:rPr>
-              <a:t>★★★  module 1.75</a:t>
-            </a:r>
-          </a:p>
-          <a:p>
-            <a:pPr algn="ctr"/>
-            <a:r>
-              <a:rPr sz="1000" b="0">
-                <a:solidFill>
-                  <a:srgbClr val="1A1A1A"/>
-                </a:solidFill>
-                <a:latin typeface="맑은 고딕"/>
-                <a:ea typeface="맑은 고딕"/>
-              </a:rPr>
-              <a:t>0.38 man-month · $1.16</a:t>
-            </a:r>
-          </a:p>
-        </p:txBody>
-      </p:sp>
-      <p:sp>
-        <p:nvSpPr>
-          <p:cNvPr id="72" name="Rectangle 71"/>
+              <a:t>x1.00</a:t>
+            </a:r>
+          </a:p>
+        </p:txBody>
+      </p:sp>
+      <p:sp>
+        <p:nvSpPr>
+          <p:cNvPr id="76" name="Rectangle 75"/>
           <p:cNvSpPr/>
           <p:nvPr/>
         </p:nvSpPr>
         <p:spPr>
           <a:xfrm>
-            <a:off x="7543800" y="3200400"/>
-            <a:ext cx="4251960" cy="566928"/>
+            <a:off x="4846320" y="2788920"/>
+            <a:ext cx="3474720" cy="457200"/>
           </a:xfrm>
           <a:prstGeom prst="rect">
             <a:avLst/>
@@ -5705,41 +5825,84 @@
           <a:p>
             <a:pPr algn="ctr"/>
             <a:r>
-              <a:rPr sz="1000" b="0">
+              <a:rPr sz="950" b="0">
                 <a:solidFill>
                   <a:srgbClr val="1A1A1A"/>
                 </a:solidFill>
                 <a:latin typeface="맑은 고딕"/>
                 <a:ea typeface="맑은 고딕"/>
               </a:rPr>
-              <a:t>★★  module 2.50</a:t>
-            </a:r>
-          </a:p>
+              <a:t>★★★  x1.28 (TTFT x1.58 · TPOT x1.04)</a:t>
+            </a:r>
+          </a:p>
+        </p:txBody>
+      </p:sp>
+      <p:sp>
+        <p:nvSpPr>
+          <p:cNvPr id="77" name="Rectangle 76"/>
+          <p:cNvSpPr/>
+          <p:nvPr/>
+        </p:nvSpPr>
+        <p:spPr>
+          <a:xfrm>
+            <a:off x="8321040" y="2788920"/>
+            <a:ext cx="3474720" cy="457200"/>
+          </a:xfrm>
+          <a:prstGeom prst="rect">
+            <a:avLst/>
+          </a:prstGeom>
+          <a:solidFill>
+            <a:srgbClr val="FFFFFF"/>
+          </a:solidFill>
+          <a:ln w="9525">
+            <a:solidFill>
+              <a:srgbClr val="BFBFBF"/>
+            </a:solidFill>
+          </a:ln>
+          <a:effectLst/>
+        </p:spPr>
+        <p:style>
+          <a:lnRef idx="1">
+            <a:schemeClr val="accent1"/>
+          </a:lnRef>
+          <a:fillRef idx="3">
+            <a:schemeClr val="accent1"/>
+          </a:fillRef>
+          <a:effectRef idx="2">
+            <a:schemeClr val="accent1"/>
+          </a:effectRef>
+          <a:fontRef idx="minor">
+            <a:schemeClr val="lt1"/>
+          </a:fontRef>
+        </p:style>
+        <p:txBody>
+          <a:bodyPr rtlCol="0" anchor="ctr" wrap="square" lIns="45720" rIns="45720" tIns="27432" bIns="27432"/>
+          <a:lstStyle/>
           <a:p>
             <a:pPr algn="ctr"/>
             <a:r>
-              <a:rPr sz="1000" b="0">
+              <a:rPr sz="950" b="0">
                 <a:solidFill>
                   <a:srgbClr val="1A1A1A"/>
                 </a:solidFill>
                 <a:latin typeface="맑은 고딕"/>
                 <a:ea typeface="맑은 고딕"/>
               </a:rPr>
-              <a:t>0.51 man-month · $1.49</a:t>
-            </a:r>
-          </a:p>
-        </p:txBody>
-      </p:sp>
-      <p:sp>
-        <p:nvSpPr>
-          <p:cNvPr id="73" name="Rectangle 72"/>
+              <a:t>★★★  x1.56 (TTFT x2.18 · TPOT x1.12)</a:t>
+            </a:r>
+          </a:p>
+        </p:txBody>
+      </p:sp>
+      <p:sp>
+        <p:nvSpPr>
+          <p:cNvPr id="78" name="Rectangle 77"/>
           <p:cNvSpPr/>
           <p:nvPr/>
         </p:nvSpPr>
         <p:spPr>
           <a:xfrm>
-            <a:off x="365760" y="3785616"/>
-            <a:ext cx="2926080" cy="365760"/>
+            <a:off x="365760" y="3264408"/>
+            <a:ext cx="2743200" cy="457200"/>
           </a:xfrm>
           <a:prstGeom prst="rect">
             <a:avLst/>
@@ -5774,28 +5937,41 @@
           <a:p>
             <a:pPr algn="l"/>
             <a:r>
-              <a:rPr sz="1000" b="1">
+              <a:rPr sz="900" b="1">
                 <a:solidFill>
                   <a:srgbClr val="1A1A1A"/>
                 </a:solidFill>
                 <a:latin typeface="맑은 고딕"/>
                 <a:ea typeface="맑은 고딕"/>
               </a:rPr>
-              <a:t>별 합계</a:t>
-            </a:r>
-          </a:p>
-        </p:txBody>
-      </p:sp>
-      <p:sp>
-        <p:nvSpPr>
-          <p:cNvPr id="74" name="Rectangle 73"/>
+              <a:t>QA3 Resource usage</a:t>
+            </a:r>
+          </a:p>
+          <a:p>
+            <a:pPr algn="l"/>
+            <a:r>
+              <a:rPr sz="900" b="1">
+                <a:solidFill>
+                  <a:srgbClr val="1A1A1A"/>
+                </a:solidFill>
+                <a:latin typeface="맑은 고딕"/>
+                <a:ea typeface="맑은 고딕"/>
+              </a:rPr>
+              <a:t>HBM 사용량 (GiB) ↓</a:t>
+            </a:r>
+          </a:p>
+        </p:txBody>
+      </p:sp>
+      <p:sp>
+        <p:nvSpPr>
+          <p:cNvPr id="79" name="Rectangle 78"/>
           <p:cNvSpPr/>
           <p:nvPr/>
         </p:nvSpPr>
         <p:spPr>
           <a:xfrm>
-            <a:off x="3291840" y="3785616"/>
-            <a:ext cx="4251960" cy="365760"/>
+            <a:off x="3108960" y="3264408"/>
+            <a:ext cx="1737360" cy="457200"/>
           </a:xfrm>
           <a:prstGeom prst="rect">
             <a:avLst/>
@@ -5830,28 +6006,28 @@
           <a:p>
             <a:pPr algn="ctr"/>
             <a:r>
-              <a:rPr sz="1100" b="1">
+              <a:rPr sz="950" b="0">
                 <a:solidFill>
                   <a:srgbClr val="1A1A1A"/>
                 </a:solidFill>
                 <a:latin typeface="맑은 고딕"/>
                 <a:ea typeface="맑은 고딕"/>
               </a:rPr>
-              <a:t>10</a:t>
-            </a:r>
-          </a:p>
-        </p:txBody>
-      </p:sp>
-      <p:sp>
-        <p:nvSpPr>
-          <p:cNvPr id="75" name="Rectangle 74"/>
+              <a:t>146.6</a:t>
+            </a:r>
+          </a:p>
+        </p:txBody>
+      </p:sp>
+      <p:sp>
+        <p:nvSpPr>
+          <p:cNvPr id="80" name="Rectangle 79"/>
           <p:cNvSpPr/>
           <p:nvPr/>
         </p:nvSpPr>
         <p:spPr>
           <a:xfrm>
-            <a:off x="7543800" y="3785616"/>
-            <a:ext cx="4251960" cy="365760"/>
+            <a:off x="4846320" y="3264408"/>
+            <a:ext cx="3474720" cy="457200"/>
           </a:xfrm>
           <a:prstGeom prst="rect">
             <a:avLst/>
@@ -5886,7 +6062,537 @@
           <a:p>
             <a:pPr algn="ctr"/>
             <a:r>
-              <a:rPr sz="1100" b="1">
+              <a:rPr sz="950" b="0">
+                <a:solidFill>
+                  <a:srgbClr val="1A1A1A"/>
+                </a:solidFill>
+                <a:latin typeface="맑은 고딕"/>
+                <a:ea typeface="맑은 고딕"/>
+              </a:rPr>
+              <a:t>★★  142.7 (x0.97)</a:t>
+            </a:r>
+          </a:p>
+        </p:txBody>
+      </p:sp>
+      <p:sp>
+        <p:nvSpPr>
+          <p:cNvPr id="81" name="Rectangle 80"/>
+          <p:cNvSpPr/>
+          <p:nvPr/>
+        </p:nvSpPr>
+        <p:spPr>
+          <a:xfrm>
+            <a:off x="8321040" y="3264408"/>
+            <a:ext cx="3474720" cy="457200"/>
+          </a:xfrm>
+          <a:prstGeom prst="rect">
+            <a:avLst/>
+          </a:prstGeom>
+          <a:solidFill>
+            <a:srgbClr val="FFFFFF"/>
+          </a:solidFill>
+          <a:ln w="9525">
+            <a:solidFill>
+              <a:srgbClr val="BFBFBF"/>
+            </a:solidFill>
+          </a:ln>
+          <a:effectLst/>
+        </p:spPr>
+        <p:style>
+          <a:lnRef idx="1">
+            <a:schemeClr val="accent1"/>
+          </a:lnRef>
+          <a:fillRef idx="3">
+            <a:schemeClr val="accent1"/>
+          </a:fillRef>
+          <a:effectRef idx="2">
+            <a:schemeClr val="accent1"/>
+          </a:effectRef>
+          <a:fontRef idx="minor">
+            <a:schemeClr val="lt1"/>
+          </a:fontRef>
+        </p:style>
+        <p:txBody>
+          <a:bodyPr rtlCol="0" anchor="ctr" wrap="square" lIns="45720" rIns="45720" tIns="27432" bIns="27432"/>
+          <a:lstStyle/>
+          <a:p>
+            <a:pPr algn="ctr"/>
+            <a:r>
+              <a:rPr sz="950" b="0">
+                <a:solidFill>
+                  <a:srgbClr val="1A1A1A"/>
+                </a:solidFill>
+                <a:latin typeface="맑은 고딕"/>
+                <a:ea typeface="맑은 고딕"/>
+              </a:rPr>
+              <a:t>★  178.0 (x1.21)</a:t>
+            </a:r>
+          </a:p>
+        </p:txBody>
+      </p:sp>
+      <p:sp>
+        <p:nvSpPr>
+          <p:cNvPr id="82" name="Rectangle 81"/>
+          <p:cNvSpPr/>
+          <p:nvPr/>
+        </p:nvSpPr>
+        <p:spPr>
+          <a:xfrm>
+            <a:off x="365760" y="3739896"/>
+            <a:ext cx="2743200" cy="457200"/>
+          </a:xfrm>
+          <a:prstGeom prst="rect">
+            <a:avLst/>
+          </a:prstGeom>
+          <a:solidFill>
+            <a:srgbClr val="DCE9F5"/>
+          </a:solidFill>
+          <a:ln w="9525">
+            <a:solidFill>
+              <a:srgbClr val="4D7EA8"/>
+            </a:solidFill>
+          </a:ln>
+          <a:effectLst/>
+        </p:spPr>
+        <p:style>
+          <a:lnRef idx="1">
+            <a:schemeClr val="accent1"/>
+          </a:lnRef>
+          <a:fillRef idx="3">
+            <a:schemeClr val="accent1"/>
+          </a:fillRef>
+          <a:effectRef idx="2">
+            <a:schemeClr val="accent1"/>
+          </a:effectRef>
+          <a:fontRef idx="minor">
+            <a:schemeClr val="lt1"/>
+          </a:fontRef>
+        </p:style>
+        <p:txBody>
+          <a:bodyPr rtlCol="0" anchor="ctr" wrap="square" lIns="45720" rIns="45720" tIns="27432" bIns="27432"/>
+          <a:lstStyle/>
+          <a:p>
+            <a:pPr algn="l"/>
+            <a:r>
+              <a:rPr sz="900" b="1">
+                <a:solidFill>
+                  <a:srgbClr val="1A1A1A"/>
+                </a:solidFill>
+                <a:latin typeface="맑은 고딕"/>
+                <a:ea typeface="맑은 고딕"/>
+              </a:rPr>
+              <a:t>QA4 Modifiability</a:t>
+            </a:r>
+          </a:p>
+          <a:p>
+            <a:pPr algn="l"/>
+            <a:r>
+              <a:rPr sz="900" b="1">
+                <a:solidFill>
+                  <a:srgbClr val="1A1A1A"/>
+                </a:solidFill>
+                <a:latin typeface="맑은 고딕"/>
+                <a:ea typeface="맑은 고딕"/>
+              </a:rPr>
+              <a:t>module · 공수(MM) · 에이전트 비용 ↓</a:t>
+            </a:r>
+          </a:p>
+        </p:txBody>
+      </p:sp>
+      <p:sp>
+        <p:nvSpPr>
+          <p:cNvPr id="83" name="Rectangle 82"/>
+          <p:cNvSpPr/>
+          <p:nvPr/>
+        </p:nvSpPr>
+        <p:spPr>
+          <a:xfrm>
+            <a:off x="3108960" y="3739896"/>
+            <a:ext cx="1737360" cy="457200"/>
+          </a:xfrm>
+          <a:prstGeom prst="rect">
+            <a:avLst/>
+          </a:prstGeom>
+          <a:solidFill>
+            <a:srgbClr val="FFFFFF"/>
+          </a:solidFill>
+          <a:ln w="9525">
+            <a:solidFill>
+              <a:srgbClr val="BFBFBF"/>
+            </a:solidFill>
+          </a:ln>
+          <a:effectLst/>
+        </p:spPr>
+        <p:style>
+          <a:lnRef idx="1">
+            <a:schemeClr val="accent1"/>
+          </a:lnRef>
+          <a:fillRef idx="3">
+            <a:schemeClr val="accent1"/>
+          </a:fillRef>
+          <a:effectRef idx="2">
+            <a:schemeClr val="accent1"/>
+          </a:effectRef>
+          <a:fontRef idx="minor">
+            <a:schemeClr val="lt1"/>
+          </a:fontRef>
+        </p:style>
+        <p:txBody>
+          <a:bodyPr rtlCol="0" anchor="ctr" wrap="square" lIns="45720" rIns="45720" tIns="27432" bIns="27432"/>
+          <a:lstStyle/>
+          <a:p>
+            <a:pPr algn="ctr"/>
+            <a:r>
+              <a:rPr sz="950" b="0">
+                <a:solidFill>
+                  <a:srgbClr val="1A1A1A"/>
+                </a:solidFill>
+                <a:latin typeface="맑은 고딕"/>
+                <a:ea typeface="맑은 고딕"/>
+              </a:rPr>
+              <a:t>—</a:t>
+            </a:r>
+          </a:p>
+        </p:txBody>
+      </p:sp>
+      <p:sp>
+        <p:nvSpPr>
+          <p:cNvPr id="84" name="Rectangle 83"/>
+          <p:cNvSpPr/>
+          <p:nvPr/>
+        </p:nvSpPr>
+        <p:spPr>
+          <a:xfrm>
+            <a:off x="4846320" y="3739896"/>
+            <a:ext cx="3474720" cy="457200"/>
+          </a:xfrm>
+          <a:prstGeom prst="rect">
+            <a:avLst/>
+          </a:prstGeom>
+          <a:solidFill>
+            <a:srgbClr val="FFFFFF"/>
+          </a:solidFill>
+          <a:ln w="9525">
+            <a:solidFill>
+              <a:srgbClr val="BFBFBF"/>
+            </a:solidFill>
+          </a:ln>
+          <a:effectLst/>
+        </p:spPr>
+        <p:style>
+          <a:lnRef idx="1">
+            <a:schemeClr val="accent1"/>
+          </a:lnRef>
+          <a:fillRef idx="3">
+            <a:schemeClr val="accent1"/>
+          </a:fillRef>
+          <a:effectRef idx="2">
+            <a:schemeClr val="accent1"/>
+          </a:effectRef>
+          <a:fontRef idx="minor">
+            <a:schemeClr val="lt1"/>
+          </a:fontRef>
+        </p:style>
+        <p:txBody>
+          <a:bodyPr rtlCol="0" anchor="ctr" wrap="square" lIns="45720" rIns="45720" tIns="27432" bIns="27432"/>
+          <a:lstStyle/>
+          <a:p>
+            <a:pPr algn="ctr"/>
+            <a:r>
+              <a:rPr sz="950" b="0">
+                <a:solidFill>
+                  <a:srgbClr val="1A1A1A"/>
+                </a:solidFill>
+                <a:latin typeface="맑은 고딕"/>
+                <a:ea typeface="맑은 고딕"/>
+              </a:rPr>
+              <a:t>★★★  1.75 · 0.38 · $1.16</a:t>
+            </a:r>
+          </a:p>
+        </p:txBody>
+      </p:sp>
+      <p:sp>
+        <p:nvSpPr>
+          <p:cNvPr id="85" name="Rectangle 84"/>
+          <p:cNvSpPr/>
+          <p:nvPr/>
+        </p:nvSpPr>
+        <p:spPr>
+          <a:xfrm>
+            <a:off x="8321040" y="3739896"/>
+            <a:ext cx="3474720" cy="457200"/>
+          </a:xfrm>
+          <a:prstGeom prst="rect">
+            <a:avLst/>
+          </a:prstGeom>
+          <a:solidFill>
+            <a:srgbClr val="FFFFFF"/>
+          </a:solidFill>
+          <a:ln w="9525">
+            <a:solidFill>
+              <a:srgbClr val="BFBFBF"/>
+            </a:solidFill>
+          </a:ln>
+          <a:effectLst/>
+        </p:spPr>
+        <p:style>
+          <a:lnRef idx="1">
+            <a:schemeClr val="accent1"/>
+          </a:lnRef>
+          <a:fillRef idx="3">
+            <a:schemeClr val="accent1"/>
+          </a:fillRef>
+          <a:effectRef idx="2">
+            <a:schemeClr val="accent1"/>
+          </a:effectRef>
+          <a:fontRef idx="minor">
+            <a:schemeClr val="lt1"/>
+          </a:fontRef>
+        </p:style>
+        <p:txBody>
+          <a:bodyPr rtlCol="0" anchor="ctr" wrap="square" lIns="45720" rIns="45720" tIns="27432" bIns="27432"/>
+          <a:lstStyle/>
+          <a:p>
+            <a:pPr algn="ctr"/>
+            <a:r>
+              <a:rPr sz="950" b="0">
+                <a:solidFill>
+                  <a:srgbClr val="1A1A1A"/>
+                </a:solidFill>
+                <a:latin typeface="맑은 고딕"/>
+                <a:ea typeface="맑은 고딕"/>
+              </a:rPr>
+              <a:t>★★  2.50 · 0.51 · $1.49</a:t>
+            </a:r>
+          </a:p>
+        </p:txBody>
+      </p:sp>
+      <p:sp>
+        <p:nvSpPr>
+          <p:cNvPr id="86" name="Rectangle 85"/>
+          <p:cNvSpPr/>
+          <p:nvPr/>
+        </p:nvSpPr>
+        <p:spPr>
+          <a:xfrm>
+            <a:off x="365760" y="4215383"/>
+            <a:ext cx="2743200" cy="329184"/>
+          </a:xfrm>
+          <a:prstGeom prst="rect">
+            <a:avLst/>
+          </a:prstGeom>
+          <a:solidFill>
+            <a:srgbClr val="DCE9F5"/>
+          </a:solidFill>
+          <a:ln w="9525">
+            <a:solidFill>
+              <a:srgbClr val="4D7EA8"/>
+            </a:solidFill>
+          </a:ln>
+          <a:effectLst/>
+        </p:spPr>
+        <p:style>
+          <a:lnRef idx="1">
+            <a:schemeClr val="accent1"/>
+          </a:lnRef>
+          <a:fillRef idx="3">
+            <a:schemeClr val="accent1"/>
+          </a:fillRef>
+          <a:effectRef idx="2">
+            <a:schemeClr val="accent1"/>
+          </a:effectRef>
+          <a:fontRef idx="minor">
+            <a:schemeClr val="lt1"/>
+          </a:fontRef>
+        </p:style>
+        <p:txBody>
+          <a:bodyPr rtlCol="0" anchor="ctr" wrap="square" lIns="45720" rIns="45720" tIns="27432" bIns="27432"/>
+          <a:lstStyle/>
+          <a:p>
+            <a:pPr algn="l"/>
+            <a:r>
+              <a:rPr sz="900" b="1">
+                <a:solidFill>
+                  <a:srgbClr val="1A1A1A"/>
+                </a:solidFill>
+                <a:latin typeface="맑은 고딕"/>
+                <a:ea typeface="맑은 고딕"/>
+              </a:rPr>
+              <a:t>별 합계</a:t>
+            </a:r>
+          </a:p>
+          <a:p>
+            <a:pPr algn="l"/>
+            <a:r>
+              <a:rPr sz="900" b="1">
+                <a:solidFill>
+                  <a:srgbClr val="1A1A1A"/>
+                </a:solidFill>
+                <a:latin typeface="맑은 고딕"/>
+                <a:ea typeface="맑은 고딕"/>
+              </a:rPr>
+              <a:t/>
+            </a:r>
+          </a:p>
+        </p:txBody>
+      </p:sp>
+      <p:sp>
+        <p:nvSpPr>
+          <p:cNvPr id="87" name="Rectangle 86"/>
+          <p:cNvSpPr/>
+          <p:nvPr/>
+        </p:nvSpPr>
+        <p:spPr>
+          <a:xfrm>
+            <a:off x="3108960" y="4215383"/>
+            <a:ext cx="1737360" cy="329184"/>
+          </a:xfrm>
+          <a:prstGeom prst="rect">
+            <a:avLst/>
+          </a:prstGeom>
+          <a:solidFill>
+            <a:srgbClr val="FFFFFF"/>
+          </a:solidFill>
+          <a:ln w="9525">
+            <a:solidFill>
+              <a:srgbClr val="BFBFBF"/>
+            </a:solidFill>
+          </a:ln>
+          <a:effectLst/>
+        </p:spPr>
+        <p:style>
+          <a:lnRef idx="1">
+            <a:schemeClr val="accent1"/>
+          </a:lnRef>
+          <a:fillRef idx="3">
+            <a:schemeClr val="accent1"/>
+          </a:fillRef>
+          <a:effectRef idx="2">
+            <a:schemeClr val="accent1"/>
+          </a:effectRef>
+          <a:fontRef idx="minor">
+            <a:schemeClr val="lt1"/>
+          </a:fontRef>
+        </p:style>
+        <p:txBody>
+          <a:bodyPr rtlCol="0" anchor="ctr" wrap="square" lIns="45720" rIns="45720" tIns="27432" bIns="27432"/>
+          <a:lstStyle/>
+          <a:p>
+            <a:pPr algn="ctr"/>
+            <a:r>
+              <a:rPr sz="1100" b="0">
+                <a:solidFill>
+                  <a:srgbClr val="1A1A1A"/>
+                </a:solidFill>
+                <a:latin typeface="맑은 고딕"/>
+                <a:ea typeface="맑은 고딕"/>
+              </a:rPr>
+              <a:t>—</a:t>
+            </a:r>
+          </a:p>
+        </p:txBody>
+      </p:sp>
+      <p:sp>
+        <p:nvSpPr>
+          <p:cNvPr id="88" name="Rectangle 87"/>
+          <p:cNvSpPr/>
+          <p:nvPr/>
+        </p:nvSpPr>
+        <p:spPr>
+          <a:xfrm>
+            <a:off x="4846320" y="4215383"/>
+            <a:ext cx="3474720" cy="329184"/>
+          </a:xfrm>
+          <a:prstGeom prst="rect">
+            <a:avLst/>
+          </a:prstGeom>
+          <a:solidFill>
+            <a:srgbClr val="FFFFFF"/>
+          </a:solidFill>
+          <a:ln w="9525">
+            <a:solidFill>
+              <a:srgbClr val="BFBFBF"/>
+            </a:solidFill>
+          </a:ln>
+          <a:effectLst/>
+        </p:spPr>
+        <p:style>
+          <a:lnRef idx="1">
+            <a:schemeClr val="accent1"/>
+          </a:lnRef>
+          <a:fillRef idx="3">
+            <a:schemeClr val="accent1"/>
+          </a:fillRef>
+          <a:effectRef idx="2">
+            <a:schemeClr val="accent1"/>
+          </a:effectRef>
+          <a:fontRef idx="minor">
+            <a:schemeClr val="lt1"/>
+          </a:fontRef>
+        </p:style>
+        <p:txBody>
+          <a:bodyPr rtlCol="0" anchor="ctr" wrap="square" lIns="45720" rIns="45720" tIns="27432" bIns="27432"/>
+          <a:lstStyle/>
+          <a:p>
+            <a:pPr algn="ctr"/>
+            <a:r>
+              <a:rPr sz="1100" b="0">
+                <a:solidFill>
+                  <a:srgbClr val="1A1A1A"/>
+                </a:solidFill>
+                <a:latin typeface="맑은 고딕"/>
+                <a:ea typeface="맑은 고딕"/>
+              </a:rPr>
+              <a:t>10</a:t>
+            </a:r>
+          </a:p>
+        </p:txBody>
+      </p:sp>
+      <p:sp>
+        <p:nvSpPr>
+          <p:cNvPr id="89" name="Rectangle 88"/>
+          <p:cNvSpPr/>
+          <p:nvPr/>
+        </p:nvSpPr>
+        <p:spPr>
+          <a:xfrm>
+            <a:off x="8321040" y="4215383"/>
+            <a:ext cx="3474720" cy="329184"/>
+          </a:xfrm>
+          <a:prstGeom prst="rect">
+            <a:avLst/>
+          </a:prstGeom>
+          <a:solidFill>
+            <a:srgbClr val="FFFFFF"/>
+          </a:solidFill>
+          <a:ln w="9525">
+            <a:solidFill>
+              <a:srgbClr val="BFBFBF"/>
+            </a:solidFill>
+          </a:ln>
+          <a:effectLst/>
+        </p:spPr>
+        <p:style>
+          <a:lnRef idx="1">
+            <a:schemeClr val="accent1"/>
+          </a:lnRef>
+          <a:fillRef idx="3">
+            <a:schemeClr val="accent1"/>
+          </a:fillRef>
+          <a:effectRef idx="2">
+            <a:schemeClr val="accent1"/>
+          </a:effectRef>
+          <a:fontRef idx="minor">
+            <a:schemeClr val="lt1"/>
+          </a:fontRef>
+        </p:style>
+        <p:txBody>
+          <a:bodyPr rtlCol="0" anchor="ctr" wrap="square" lIns="45720" rIns="45720" tIns="27432" bIns="27432"/>
+          <a:lstStyle/>
+          <a:p>
+            <a:pPr algn="ctr"/>
+            <a:r>
+              <a:rPr sz="1100" b="0">
                 <a:solidFill>
                   <a:srgbClr val="1A1A1A"/>
                 </a:solidFill>
@@ -5900,14 +6606,14 @@
       </p:sp>
       <p:sp>
         <p:nvSpPr>
-          <p:cNvPr id="76" name="Rectangle 75"/>
+          <p:cNvPr id="90" name="Rectangle 89"/>
           <p:cNvSpPr/>
           <p:nvPr/>
         </p:nvSpPr>
         <p:spPr>
           <a:xfrm>
-            <a:off x="365760" y="4261104"/>
-            <a:ext cx="5669280" cy="1965960"/>
+            <a:off x="365760" y="4608575"/>
+            <a:ext cx="11430000" cy="658368"/>
           </a:xfrm>
           <a:prstGeom prst="rect">
             <a:avLst/>
@@ -5942,7 +6648,89 @@
           <a:p>
             <a:pPr algn="l"/>
             <a:r>
-              <a:rPr sz="950" b="1">
+              <a:rPr sz="850" b="0">
+                <a:solidFill>
+                  <a:srgbClr val="404040"/>
+                </a:solidFill>
+                <a:latin typeface="맑은 고딕"/>
+                <a:ea typeface="맑은 고딕"/>
+              </a:rPr>
+              <a:t>평가한 시스템: SYS-H100 (H100x8 (Hopper-class), HBM3 (H100 SXM5 80GB), PCIe 5.0, DDR5-4800); SYS-B200 (B200x8 (Blackwell-class), HBM3e (B200), PCIe 5.0, DDR5-6400). 모두 6종 메모리(HBM, Custom HBM, DRAM, CXL-PNM, </a:t>
+            </a:r>
+          </a:p>
+          <a:p>
+            <a:pPr algn="l"/>
+            <a:r>
+              <a:rPr sz="850" b="0">
+                <a:solidFill>
+                  <a:srgbClr val="404040"/>
+                </a:solidFill>
+                <a:latin typeface="맑은 고딕"/>
+                <a:ea typeface="맑은 고딕"/>
+              </a:rPr>
+              <a:t>HBF, SSD-PIM)를 갖춘 8-GPU 1노드, Llama-3.1-70B BF16이며 두 시스템을 통합했다. 집계 단위는 (시나리오, 시스템) 쌍 64개 중 Baseline도 SLO를 만족하는 비교 가능 쌍(통합 21쌍: H100 9쌍, B200 12쌍). 값은 쌍별 값의 기하평균, 괄</a:t>
+            </a:r>
+          </a:p>
+          <a:p>
+            <a:pPr algn="l"/>
+            <a:r>
+              <a:rPr sz="850" b="0">
+                <a:solidFill>
+                  <a:srgbClr val="404040"/>
+                </a:solidFill>
+                <a:latin typeface="맑은 고딕"/>
+                <a:ea typeface="맑은 고딕"/>
+              </a:rPr>
+              <a:t>호는 후보 ÷ Baseline 배수(↑ 높을수록 좋음, ↓ 낮을수록 좋음)이다. Evidence [B+C].</a:t>
+            </a:r>
+          </a:p>
+        </p:txBody>
+      </p:sp>
+      <p:sp>
+        <p:nvSpPr>
+          <p:cNvPr id="91" name="Rectangle 90"/>
+          <p:cNvSpPr/>
+          <p:nvPr/>
+        </p:nvSpPr>
+        <p:spPr>
+          <a:xfrm>
+            <a:off x="365760" y="5340095"/>
+            <a:ext cx="5669280" cy="1417320"/>
+          </a:xfrm>
+          <a:prstGeom prst="rect">
+            <a:avLst/>
+          </a:prstGeom>
+          <a:solidFill>
+            <a:srgbClr val="F2F2F2"/>
+          </a:solidFill>
+          <a:ln w="9525">
+            <a:solidFill>
+              <a:srgbClr val="BFBFBF"/>
+            </a:solidFill>
+          </a:ln>
+          <a:effectLst/>
+        </p:spPr>
+        <p:style>
+          <a:lnRef idx="1">
+            <a:schemeClr val="accent1"/>
+          </a:lnRef>
+          <a:fillRef idx="3">
+            <a:schemeClr val="accent1"/>
+          </a:fillRef>
+          <a:effectRef idx="2">
+            <a:schemeClr val="accent1"/>
+          </a:effectRef>
+          <a:fontRef idx="minor">
+            <a:schemeClr val="lt1"/>
+          </a:fontRef>
+        </p:style>
+        <p:txBody>
+          <a:bodyPr rtlCol="0" anchor="t" wrap="square" lIns="45720" rIns="45720" tIns="27432" bIns="27432"/>
+          <a:lstStyle/>
+          <a:p>
+            <a:pPr algn="l"/>
+            <a:r>
+              <a:rPr sz="900" b="1">
                 <a:solidFill>
                   <a:srgbClr val="404040"/>
                 </a:solidFill>
@@ -5955,119 +6743,93 @@
           <a:p>
             <a:pPr algn="l"/>
             <a:r>
-              <a:rPr sz="950" b="0">
+              <a:rPr sz="900" b="0">
                 <a:solidFill>
                   <a:srgbClr val="404040"/>
                 </a:solidFill>
                 <a:latin typeface="맑은 고딕"/>
                 <a:ea typeface="맑은 고딕"/>
               </a:rPr>
-              <a:t>- 성능은 C2: 데이터마다 접근 빈도·재사용·유휴를 보고 이동해, 같은 종류(KV) 안의 hot/cold를 구분</a:t>
+              <a:t>- 성능은 C2: 데이터마다 접근 빈도·재사용·유휴를 보고 이동해 같은 종류(KV) 안의 hot/cold를 구분. C1은 </a:t>
             </a:r>
           </a:p>
           <a:p>
             <a:pPr algn="l"/>
             <a:r>
-              <a:rPr sz="950" b="0">
+              <a:rPr sz="900" b="0">
                 <a:solidFill>
                   <a:srgbClr val="404040"/>
                 </a:solidFill>
                 <a:latin typeface="맑은 고딕"/>
                 <a:ea typeface="맑은 고딕"/>
               </a:rPr>
-              <a:t>한다. C1은 자원 압박에만 반응해 구분 못 함.</a:t>
+              <a:t>자원 압박에만 반응.</a:t>
             </a:r>
           </a:p>
           <a:p>
             <a:pPr algn="l"/>
             <a:r>
-              <a:rPr sz="950" b="0">
+              <a:rPr sz="900" b="0">
                 <a:solidFill>
                   <a:srgbClr val="404040"/>
                 </a:solidFill>
                 <a:latin typeface="맑은 고딕"/>
                 <a:ea typeface="맑은 고딕"/>
               </a:rPr>
-              <a:t>- 자원 사용은 C1: HBM 사용량 C1 x0.97 대 C2 x1.21. C2는 성능을 위해 hot 데이터를 HBM에 올려 </a:t>
+              <a:t>- 자원은 C1: HBM 사용량 C1 x0.97 대 C2 x1.21. C2는 성능을 위해 hot 데이터를 HBM에 올림(성능과 자원</a:t>
             </a:r>
           </a:p>
           <a:p>
             <a:pPr algn="l"/>
             <a:r>
-              <a:rPr sz="950" b="0">
+              <a:rPr sz="900" b="0">
                 <a:solidFill>
                   <a:srgbClr val="404040"/>
                 </a:solidFill>
                 <a:latin typeface="맑은 고딕"/>
                 <a:ea typeface="맑은 고딕"/>
               </a:rPr>
-              <a:t>HBM을 더 쓰고, C1은 덜 쓰되 이득이 작음(성능과 자원은 반대 방향).</a:t>
+              <a:t>은 반대 방향).</a:t>
             </a:r>
           </a:p>
           <a:p>
             <a:pPr algn="l"/>
             <a:r>
-              <a:rPr sz="950" b="0">
+              <a:rPr sz="900" b="0">
                 <a:solidFill>
                   <a:srgbClr val="404040"/>
                 </a:solidFill>
                 <a:latin typeface="맑은 고딕"/>
                 <a:ea typeface="맑은 고딕"/>
               </a:rPr>
-              <a:t>- 이동 비용은 링크 간섭으로 지연에 반영(C2 migration 1,339 GiB, 링크 10.5%).</a:t>
+              <a:t>- 확장성은 C1: 새 데이터 종류 추가 시 module 1개 (C2 3개).</a:t>
             </a:r>
           </a:p>
           <a:p>
             <a:pPr algn="l"/>
             <a:r>
-              <a:rPr sz="950" b="0">
+              <a:rPr sz="900" b="0">
                 <a:solidFill>
                   <a:srgbClr val="404040"/>
                 </a:solidFill>
                 <a:latin typeface="맑은 고딕"/>
                 <a:ea typeface="맑은 고딕"/>
               </a:rPr>
-              <a:t>- 확장성은 C1: 종류를 모르는 구조라 새 데이터 종류 추가 시 module 1개 (C2 3개).</a:t>
-            </a:r>
-          </a:p>
-          <a:p>
-            <a:pPr algn="l"/>
-            <a:r>
-              <a:rPr sz="950" b="0">
-                <a:solidFill>
-                  <a:srgbClr val="404040"/>
-                </a:solidFill>
-                <a:latin typeface="맑은 고딕"/>
-                <a:ea typeface="맑은 고딕"/>
-              </a:rPr>
-              <a:t>- 지연(QA2)은 둘 다 ★★★ 경계를 넘어 별이 같지만 값은 C2가 높다. TPOT은 거의 변하지 않고 개</a:t>
-            </a:r>
-          </a:p>
-          <a:p>
-            <a:pPr algn="l"/>
-            <a:r>
-              <a:rPr sz="950" b="0">
-                <a:solidFill>
-                  <a:srgbClr val="404040"/>
-                </a:solidFill>
-                <a:latin typeface="맑은 고딕"/>
-                <a:ea typeface="맑은 고딕"/>
-              </a:rPr>
-              <a:t>선은 TTFT에서 나온다.</a:t>
-            </a:r>
-          </a:p>
-        </p:txBody>
-      </p:sp>
-      <p:sp>
-        <p:nvSpPr>
-          <p:cNvPr id="77" name="Rectangle 76"/>
+              <a:t>- 지연: C1은 TTFT P50은 줄었지만 P99는 x1.04로 개선 없음. C2는 P99도 x0.72. TPOT은 거의 불변.</a:t>
+            </a:r>
+          </a:p>
+        </p:txBody>
+      </p:sp>
+      <p:sp>
+        <p:nvSpPr>
+          <p:cNvPr id="92" name="Rectangle 91"/>
           <p:cNvSpPr/>
           <p:nvPr/>
         </p:nvSpPr>
         <p:spPr>
           <a:xfrm>
-            <a:off x="6217920" y="4261104"/>
-            <a:ext cx="5577840" cy="1965960"/>
+            <a:off x="6217920" y="5340095"/>
+            <a:ext cx="5577840" cy="1417320"/>
           </a:xfrm>
           <a:prstGeom prst="rect">
             <a:avLst/>
@@ -6102,7 +6864,7 @@
           <a:p>
             <a:pPr algn="l"/>
             <a:r>
-              <a:rPr sz="950" b="1">
+              <a:rPr sz="900" b="1">
                 <a:solidFill>
                   <a:srgbClr val="1A1A1A"/>
                 </a:solidFill>
@@ -6115,7 +6877,7 @@
           <a:p>
             <a:pPr algn="l"/>
             <a:r>
-              <a:rPr sz="950" b="0">
+              <a:rPr sz="900" b="0">
                 <a:solidFill>
                   <a:srgbClr val="1A1A1A"/>
                 </a:solidFill>
@@ -6128,53 +6890,40 @@
           <a:p>
             <a:pPr algn="l"/>
             <a:r>
-              <a:rPr sz="950" b="0">
+              <a:rPr sz="900" b="0">
                 <a:solidFill>
                   <a:srgbClr val="1A1A1A"/>
                 </a:solidFill>
                 <a:latin typeface="맑은 고딕"/>
                 <a:ea typeface="맑은 고딕"/>
               </a:rPr>
-              <a:t>- 별 합계가 높은 C1.</a:t>
+              <a:t>- 별 합계가 높은 C1 후보 (10 대 9). 합계 차이 1점이라 별 경계에 민감.</a:t>
             </a:r>
           </a:p>
           <a:p>
             <a:pPr algn="l"/>
             <a:r>
-              <a:rPr sz="950" b="0">
+              <a:rPr sz="900" b="0">
                 <a:solidFill>
                   <a:srgbClr val="1A1A1A"/>
                 </a:solidFill>
                 <a:latin typeface="맑은 고딕"/>
                 <a:ea typeface="맑은 고딕"/>
               </a:rPr>
-              <a:t>- 우선순위를 뒤집으면 C1.</a:t>
+              <a:t>- 한계: [B] simulation. QA1 경계(1.30), QA3 정의(선택을 C2에서 C1로 바꿈), QA4 평균 집계는 결과를 본 </a:t>
             </a:r>
           </a:p>
           <a:p>
             <a:pPr algn="l"/>
             <a:r>
-              <a:rPr sz="950" b="0">
+              <a:rPr sz="900" b="0">
                 <a:solidFill>
                   <a:srgbClr val="1A1A1A"/>
                 </a:solidFill>
                 <a:latin typeface="맑은 고딕"/>
                 <a:ea typeface="맑은 고딕"/>
               </a:rPr>
-              <a:t>- 한계: [B] simulation. 별 경계(QA1 1.30), QA3 정의, QA4 평균 집계는 결과를 본 뒤 정함. 메모리 </a:t>
-            </a:r>
-          </a:p>
-          <a:p>
-            <a:pPr algn="l"/>
-            <a:r>
-              <a:rPr sz="950" b="0">
-                <a:solidFill>
-                  <a:srgbClr val="1A1A1A"/>
-                </a:solidFill>
-                <a:latin typeface="맑은 고딕"/>
-                <a:ea typeface="맑은 고딕"/>
-              </a:rPr>
-              <a:t>가격 가중치(QA3)와 QA4 공수·비용은 ASSUMED.</a:t>
+              <a:t>뒤 정함. QA4 공수·비용은 ASSUMED.</a:t>
             </a:r>
           </a:p>
         </p:txBody>

</xml_diff>

<commit_message>
DP1 results deck: result table + brief systems, per-QA reasons with evidence (2 slides), covered scenarios; skill H15 updated
Co-Authored-By: Claude Sonnet 5.5 <noreply@anthropic.com>
Claude-Session: https://claude.ai/code/session_018inK4pZJGzYwjdk7QAyZgn
</commit_message>
<xml_diff>
--- a/doc-mk/DP1/DP1-appendix-qa-result.pptx
+++ b/doc-mk/DP1/DP1-appendix-qa-result.pptx
@@ -10,6 +10,8 @@
   <p:sldIdLst>
     <p:sldId id="650" r:id="rId24"/>
     <p:sldId id="651" r:id="rId25"/>
+    <p:sldId id="652" r:id="rId26"/>
+    <p:sldId id="653" r:id="rId27"/>
   </p:sldIdLst>
   <p:sldSz cx="12192000" cy="6858000"/>
   <p:notesSz cx="6858000" cy="9144000"/>
@@ -6612,8 +6614,8 @@
         </p:nvSpPr>
         <p:spPr>
           <a:xfrm>
-            <a:off x="365760" y="4608575"/>
-            <a:ext cx="11430000" cy="658368"/>
+            <a:off x="365760" y="4617720"/>
+            <a:ext cx="11430000" cy="868680"/>
           </a:xfrm>
           <a:prstGeom prst="rect">
             <a:avLst/>
@@ -6648,40 +6650,27 @@
           <a:p>
             <a:pPr algn="l"/>
             <a:r>
-              <a:rPr sz="850" b="0">
+              <a:rPr sz="900" b="1">
                 <a:solidFill>
                   <a:srgbClr val="404040"/>
                 </a:solidFill>
                 <a:latin typeface="맑은 고딕"/>
                 <a:ea typeface="맑은 고딕"/>
               </a:rPr>
-              <a:t>평가한 시스템: SYS-H100 (H100x8 (Hopper-class), HBM3 (H100 SXM5 80GB), PCIe 5.0, DDR5-4800); SYS-B200 (B200x8 (Blackwell-class), HBM3e (B200), PCIe 5.0, DDR5-6400). 모두 6종 메모리(HBM, Custom HBM, DRAM, CXL-PNM, </a:t>
+              <a:t>시스템: H100x8 (HBM3, PCIe 5.0, DDR5-4800) + B200x8 (HBM3e, PCIe 5.0, DDR5-6400). 6종 메모리(HBM, Custom HBM, DRAM, CXL-PNM, HBF, SSD-PIM)를 갖춘 8-GPU 1노드, Llama-3.1-70B BF16.</a:t>
             </a:r>
           </a:p>
           <a:p>
             <a:pPr algn="l"/>
             <a:r>
-              <a:rPr sz="850" b="0">
+              <a:rPr sz="900" b="0">
                 <a:solidFill>
                   <a:srgbClr val="404040"/>
                 </a:solidFill>
                 <a:latin typeface="맑은 고딕"/>
                 <a:ea typeface="맑은 고딕"/>
               </a:rPr>
-              <a:t>HBF, SSD-PIM)를 갖춘 8-GPU 1노드, Llama-3.1-70B BF16이며 두 시스템을 통합했다. 집계 단위는 (시나리오, 시스템) 쌍 64개 중 Baseline도 SLO를 만족하는 비교 가능 쌍(통합 21쌍: H100 9쌍, B200 12쌍). 값은 쌍별 값의 기하평균, 괄</a:t>
-            </a:r>
-          </a:p>
-          <a:p>
-            <a:pPr algn="l"/>
-            <a:r>
-              <a:rPr sz="850" b="0">
-                <a:solidFill>
-                  <a:srgbClr val="404040"/>
-                </a:solidFill>
-                <a:latin typeface="맑은 고딕"/>
-                <a:ea typeface="맑은 고딕"/>
-              </a:rPr>
-              <a:t>호는 후보 ÷ Baseline 배수(↑ 높을수록 좋음, ↓ 낮을수록 좋음)이다. Evidence [B+C].</a:t>
+              <a:t>시나리오: 32개 x 2시스템 = 64쌍 중 비교 가능 21쌍 기준(포화 10, Baseline도 SLO 불가 33쌍 제외). 값은 쌍별 값의 기하평균, 괄호는 후보 ÷ Baseline(↑ 높을수록 좋음, ↓ 낮을수록 좋음). Evidence [B+C].</a:t>
             </a:r>
           </a:p>
         </p:txBody>
@@ -6694,142 +6683,8 @@
         </p:nvSpPr>
         <p:spPr>
           <a:xfrm>
-            <a:off x="365760" y="5340095"/>
-            <a:ext cx="5669280" cy="1417320"/>
-          </a:xfrm>
-          <a:prstGeom prst="rect">
-            <a:avLst/>
-          </a:prstGeom>
-          <a:solidFill>
-            <a:srgbClr val="F2F2F2"/>
-          </a:solidFill>
-          <a:ln w="9525">
-            <a:solidFill>
-              <a:srgbClr val="BFBFBF"/>
-            </a:solidFill>
-          </a:ln>
-          <a:effectLst/>
-        </p:spPr>
-        <p:style>
-          <a:lnRef idx="1">
-            <a:schemeClr val="accent1"/>
-          </a:lnRef>
-          <a:fillRef idx="3">
-            <a:schemeClr val="accent1"/>
-          </a:fillRef>
-          <a:effectRef idx="2">
-            <a:schemeClr val="accent1"/>
-          </a:effectRef>
-          <a:fontRef idx="minor">
-            <a:schemeClr val="lt1"/>
-          </a:fontRef>
-        </p:style>
-        <p:txBody>
-          <a:bodyPr rtlCol="0" anchor="t" wrap="square" lIns="45720" rIns="45720" tIns="27432" bIns="27432"/>
-          <a:lstStyle/>
-          <a:p>
-            <a:pPr algn="l"/>
-            <a:r>
-              <a:rPr sz="900" b="1">
-                <a:solidFill>
-                  <a:srgbClr val="404040"/>
-                </a:solidFill>
-                <a:latin typeface="맑은 고딕"/>
-                <a:ea typeface="맑은 고딕"/>
-              </a:rPr>
-              <a:t>Trade-off와 이유</a:t>
-            </a:r>
-          </a:p>
-          <a:p>
-            <a:pPr algn="l"/>
-            <a:r>
-              <a:rPr sz="900" b="0">
-                <a:solidFill>
-                  <a:srgbClr val="404040"/>
-                </a:solidFill>
-                <a:latin typeface="맑은 고딕"/>
-                <a:ea typeface="맑은 고딕"/>
-              </a:rPr>
-              <a:t>- 성능은 C2: 데이터마다 접근 빈도·재사용·유휴를 보고 이동해 같은 종류(KV) 안의 hot/cold를 구분. C1은 </a:t>
-            </a:r>
-          </a:p>
-          <a:p>
-            <a:pPr algn="l"/>
-            <a:r>
-              <a:rPr sz="900" b="0">
-                <a:solidFill>
-                  <a:srgbClr val="404040"/>
-                </a:solidFill>
-                <a:latin typeface="맑은 고딕"/>
-                <a:ea typeface="맑은 고딕"/>
-              </a:rPr>
-              <a:t>자원 압박에만 반응.</a:t>
-            </a:r>
-          </a:p>
-          <a:p>
-            <a:pPr algn="l"/>
-            <a:r>
-              <a:rPr sz="900" b="0">
-                <a:solidFill>
-                  <a:srgbClr val="404040"/>
-                </a:solidFill>
-                <a:latin typeface="맑은 고딕"/>
-                <a:ea typeface="맑은 고딕"/>
-              </a:rPr>
-              <a:t>- 자원은 C1: HBM 사용량 C1 x0.97 대 C2 x1.21. C2는 성능을 위해 hot 데이터를 HBM에 올림(성능과 자원</a:t>
-            </a:r>
-          </a:p>
-          <a:p>
-            <a:pPr algn="l"/>
-            <a:r>
-              <a:rPr sz="900" b="0">
-                <a:solidFill>
-                  <a:srgbClr val="404040"/>
-                </a:solidFill>
-                <a:latin typeface="맑은 고딕"/>
-                <a:ea typeface="맑은 고딕"/>
-              </a:rPr>
-              <a:t>은 반대 방향).</a:t>
-            </a:r>
-          </a:p>
-          <a:p>
-            <a:pPr algn="l"/>
-            <a:r>
-              <a:rPr sz="900" b="0">
-                <a:solidFill>
-                  <a:srgbClr val="404040"/>
-                </a:solidFill>
-                <a:latin typeface="맑은 고딕"/>
-                <a:ea typeface="맑은 고딕"/>
-              </a:rPr>
-              <a:t>- 확장성은 C1: 새 데이터 종류 추가 시 module 1개 (C2 3개).</a:t>
-            </a:r>
-          </a:p>
-          <a:p>
-            <a:pPr algn="l"/>
-            <a:r>
-              <a:rPr sz="900" b="0">
-                <a:solidFill>
-                  <a:srgbClr val="404040"/>
-                </a:solidFill>
-                <a:latin typeface="맑은 고딕"/>
-                <a:ea typeface="맑은 고딕"/>
-              </a:rPr>
-              <a:t>- 지연: C1은 TTFT P50은 줄었지만 P99는 x1.04로 개선 없음. C2는 P99도 x0.72. TPOT은 거의 불변.</a:t>
-            </a:r>
-          </a:p>
-        </p:txBody>
-      </p:sp>
-      <p:sp>
-        <p:nvSpPr>
-          <p:cNvPr id="92" name="Rectangle 91"/>
-          <p:cNvSpPr/>
-          <p:nvPr/>
-        </p:nvSpPr>
-        <p:spPr>
-          <a:xfrm>
-            <a:off x="6217920" y="5340095"/>
-            <a:ext cx="5577840" cy="1417320"/>
+            <a:off x="365760" y="5559552"/>
+            <a:ext cx="11430000" cy="731520"/>
           </a:xfrm>
           <a:prstGeom prst="rect">
             <a:avLst/>
@@ -6871,7 +6726,7 @@
                 <a:latin typeface="맑은 고딕"/>
                 <a:ea typeface="맑은 고딕"/>
               </a:rPr>
-              <a:t>선택: C1</a:t>
+              <a:t>선택: C1  —  별 합계가 높은 C1 후보 (10 대 9). 합계 차이 1점이라 별 경계에 민감하다.</a:t>
             </a:r>
           </a:p>
           <a:p>
@@ -6884,46 +6739,7 @@
                 <a:latin typeface="맑은 고딕"/>
                 <a:ea typeface="맑은 고딕"/>
               </a:rPr>
-              <a:t>- 규칙: 별 합계가 높은 후보, 같을 때만 QA 우선순위(QA1 &gt; QA2 &gt; QA3 &gt; QA4).</a:t>
-            </a:r>
-          </a:p>
-          <a:p>
-            <a:pPr algn="l"/>
-            <a:r>
-              <a:rPr sz="900" b="0">
-                <a:solidFill>
-                  <a:srgbClr val="1A1A1A"/>
-                </a:solidFill>
-                <a:latin typeface="맑은 고딕"/>
-                <a:ea typeface="맑은 고딕"/>
-              </a:rPr>
-              <a:t>- 별 합계가 높은 C1 후보 (10 대 9). 합계 차이 1점이라 별 경계에 민감.</a:t>
-            </a:r>
-          </a:p>
-          <a:p>
-            <a:pPr algn="l"/>
-            <a:r>
-              <a:rPr sz="900" b="0">
-                <a:solidFill>
-                  <a:srgbClr val="1A1A1A"/>
-                </a:solidFill>
-                <a:latin typeface="맑은 고딕"/>
-                <a:ea typeface="맑은 고딕"/>
-              </a:rPr>
-              <a:t>- 한계: [B] simulation. QA1 경계(1.30), QA3 정의(선택을 C2에서 C1로 바꿈), QA4 평균 집계는 결과를 본 </a:t>
-            </a:r>
-          </a:p>
-          <a:p>
-            <a:pPr algn="l"/>
-            <a:r>
-              <a:rPr sz="900" b="0">
-                <a:solidFill>
-                  <a:srgbClr val="1A1A1A"/>
-                </a:solidFill>
-                <a:latin typeface="맑은 고딕"/>
-                <a:ea typeface="맑은 고딕"/>
-              </a:rPr>
-              <a:t>뒤 정함. QA4 공수·비용은 ASSUMED.</a:t>
+              <a:t>한계: [B] simulation, 별 경계(QA1 1.30)와 QA3 정의(선택을 C2에서 C1로 바꿈), QA4 평균 집계는 결과를 본 뒤 정함. QA4 공수·비용은 ASSUMED.</a:t>
             </a:r>
           </a:p>
         </p:txBody>
@@ -7072,7 +6888,7 @@
                   <a:schemeClr val="bg1"/>
                 </a:solidFill>
               </a:rPr>
-              <a:t>DP1 평가에서 고려한 시나리오</a:t>
+              <a:t>DP1 평가 결과 - QA별로 왜 이런 값이 나왔나 (1/2: 처리량, 지연)</a:t>
             </a:r>
             <a:r>
               <a:rPr lang="en-US" altLang="ko-KR" sz="1400" b="1" dirty="0">
@@ -7192,8 +7008,353 @@
         </p:nvSpPr>
         <p:spPr>
           <a:xfrm>
-            <a:off x="365760" y="1097280"/>
-            <a:ext cx="11430000" cy="502920"/>
+            <a:off x="365760" y="1051560"/>
+            <a:ext cx="2651760" cy="292608"/>
+          </a:xfrm>
+          <a:prstGeom prst="rect">
+            <a:avLst/>
+          </a:prstGeom>
+          <a:solidFill>
+            <a:srgbClr val="1F4E79"/>
+          </a:solidFill>
+          <a:ln w="9525">
+            <a:solidFill>
+              <a:srgbClr val="1F4E79"/>
+            </a:solidFill>
+          </a:ln>
+          <a:effectLst/>
+        </p:spPr>
+        <p:style>
+          <a:lnRef idx="1">
+            <a:schemeClr val="accent1"/>
+          </a:lnRef>
+          <a:fillRef idx="3">
+            <a:schemeClr val="accent1"/>
+          </a:fillRef>
+          <a:effectRef idx="2">
+            <a:schemeClr val="accent1"/>
+          </a:effectRef>
+          <a:fontRef idx="minor">
+            <a:schemeClr val="lt1"/>
+          </a:fontRef>
+        </p:style>
+        <p:txBody>
+          <a:bodyPr rtlCol="0" anchor="ctr" wrap="square" lIns="45720" rIns="45720" tIns="27432" bIns="27432"/>
+          <a:lstStyle/>
+          <a:p>
+            <a:pPr algn="ctr"/>
+            <a:r>
+              <a:rPr sz="1000" b="1">
+                <a:solidFill>
+                  <a:srgbClr val="FFFFFF"/>
+                </a:solidFill>
+                <a:latin typeface="맑은 고딕"/>
+                <a:ea typeface="맑은 고딕"/>
+              </a:rPr>
+              <a:t>QA / 수치</a:t>
+            </a:r>
+          </a:p>
+        </p:txBody>
+      </p:sp>
+      <p:sp>
+        <p:nvSpPr>
+          <p:cNvPr id="59" name="Rectangle 58"/>
+          <p:cNvSpPr/>
+          <p:nvPr/>
+        </p:nvSpPr>
+        <p:spPr>
+          <a:xfrm>
+            <a:off x="3017520" y="1051560"/>
+            <a:ext cx="5943600" cy="292608"/>
+          </a:xfrm>
+          <a:prstGeom prst="rect">
+            <a:avLst/>
+          </a:prstGeom>
+          <a:solidFill>
+            <a:srgbClr val="1F4E79"/>
+          </a:solidFill>
+          <a:ln w="9525">
+            <a:solidFill>
+              <a:srgbClr val="1F4E79"/>
+            </a:solidFill>
+          </a:ln>
+          <a:effectLst/>
+        </p:spPr>
+        <p:style>
+          <a:lnRef idx="1">
+            <a:schemeClr val="accent1"/>
+          </a:lnRef>
+          <a:fillRef idx="3">
+            <a:schemeClr val="accent1"/>
+          </a:fillRef>
+          <a:effectRef idx="2">
+            <a:schemeClr val="accent1"/>
+          </a:effectRef>
+          <a:fontRef idx="minor">
+            <a:schemeClr val="lt1"/>
+          </a:fontRef>
+        </p:style>
+        <p:txBody>
+          <a:bodyPr rtlCol="0" anchor="ctr" wrap="square" lIns="45720" rIns="45720" tIns="27432" bIns="27432"/>
+          <a:lstStyle/>
+          <a:p>
+            <a:pPr algn="ctr"/>
+            <a:r>
+              <a:rPr sz="1000" b="1">
+                <a:solidFill>
+                  <a:srgbClr val="FFFFFF"/>
+                </a:solidFill>
+                <a:latin typeface="맑은 고딕"/>
+                <a:ea typeface="맑은 고딕"/>
+              </a:rPr>
+              <a:t>왜 이런 값이 나왔나</a:t>
+            </a:r>
+          </a:p>
+        </p:txBody>
+      </p:sp>
+      <p:sp>
+        <p:nvSpPr>
+          <p:cNvPr id="60" name="Rectangle 59"/>
+          <p:cNvSpPr/>
+          <p:nvPr/>
+        </p:nvSpPr>
+        <p:spPr>
+          <a:xfrm>
+            <a:off x="8961120" y="1051560"/>
+            <a:ext cx="2834640" cy="292608"/>
+          </a:xfrm>
+          <a:prstGeom prst="rect">
+            <a:avLst/>
+          </a:prstGeom>
+          <a:solidFill>
+            <a:srgbClr val="1F4E79"/>
+          </a:solidFill>
+          <a:ln w="9525">
+            <a:solidFill>
+              <a:srgbClr val="1F4E79"/>
+            </a:solidFill>
+          </a:ln>
+          <a:effectLst/>
+        </p:spPr>
+        <p:style>
+          <a:lnRef idx="1">
+            <a:schemeClr val="accent1"/>
+          </a:lnRef>
+          <a:fillRef idx="3">
+            <a:schemeClr val="accent1"/>
+          </a:fillRef>
+          <a:effectRef idx="2">
+            <a:schemeClr val="accent1"/>
+          </a:effectRef>
+          <a:fontRef idx="minor">
+            <a:schemeClr val="lt1"/>
+          </a:fontRef>
+        </p:style>
+        <p:txBody>
+          <a:bodyPr rtlCol="0" anchor="ctr" wrap="square" lIns="45720" rIns="45720" tIns="27432" bIns="27432"/>
+          <a:lstStyle/>
+          <a:p>
+            <a:pPr algn="ctr"/>
+            <a:r>
+              <a:rPr sz="1000" b="1">
+                <a:solidFill>
+                  <a:srgbClr val="FFFFFF"/>
+                </a:solidFill>
+                <a:latin typeface="맑은 고딕"/>
+                <a:ea typeface="맑은 고딕"/>
+              </a:rPr>
+              <a:t>근거 (시나리오·측정값)</a:t>
+            </a:r>
+          </a:p>
+        </p:txBody>
+      </p:sp>
+      <p:sp>
+        <p:nvSpPr>
+          <p:cNvPr id="61" name="Rectangle 60"/>
+          <p:cNvSpPr/>
+          <p:nvPr/>
+        </p:nvSpPr>
+        <p:spPr>
+          <a:xfrm>
+            <a:off x="365760" y="1371600"/>
+            <a:ext cx="2651760" cy="1600200"/>
+          </a:xfrm>
+          <a:prstGeom prst="rect">
+            <a:avLst/>
+          </a:prstGeom>
+          <a:solidFill>
+            <a:srgbClr val="DCE9F5"/>
+          </a:solidFill>
+          <a:ln w="9525">
+            <a:solidFill>
+              <a:srgbClr val="4D7EA8"/>
+            </a:solidFill>
+          </a:ln>
+          <a:effectLst/>
+        </p:spPr>
+        <p:style>
+          <a:lnRef idx="1">
+            <a:schemeClr val="accent1"/>
+          </a:lnRef>
+          <a:fillRef idx="3">
+            <a:schemeClr val="accent1"/>
+          </a:fillRef>
+          <a:effectRef idx="2">
+            <a:schemeClr val="accent1"/>
+          </a:effectRef>
+          <a:fontRef idx="minor">
+            <a:schemeClr val="lt1"/>
+          </a:fontRef>
+        </p:style>
+        <p:txBody>
+          <a:bodyPr rtlCol="0" anchor="ctr" wrap="square" lIns="45720" rIns="45720" tIns="27432" bIns="27432"/>
+          <a:lstStyle/>
+          <a:p>
+            <a:pPr algn="l"/>
+            <a:r>
+              <a:rPr sz="950" b="1">
+                <a:solidFill>
+                  <a:srgbClr val="1A1A1A"/>
+                </a:solidFill>
+                <a:latin typeface="맑은 고딕"/>
+                <a:ea typeface="맑은 고딕"/>
+              </a:rPr>
+              <a:t>QA1 처리량</a:t>
+            </a:r>
+          </a:p>
+          <a:p>
+            <a:pPr algn="l"/>
+            <a:r>
+              <a:rPr sz="950" b="1">
+                <a:solidFill>
+                  <a:srgbClr val="1A1A1A"/>
+                </a:solidFill>
+                <a:latin typeface="맑은 고딕"/>
+                <a:ea typeface="맑은 고딕"/>
+              </a:rPr>
+              <a:t>C1 x1.30 · C2 x1.42</a:t>
+            </a:r>
+          </a:p>
+        </p:txBody>
+      </p:sp>
+      <p:sp>
+        <p:nvSpPr>
+          <p:cNvPr id="62" name="Rectangle 61"/>
+          <p:cNvSpPr/>
+          <p:nvPr/>
+        </p:nvSpPr>
+        <p:spPr>
+          <a:xfrm>
+            <a:off x="3017520" y="1371600"/>
+            <a:ext cx="5943600" cy="1600200"/>
+          </a:xfrm>
+          <a:prstGeom prst="rect">
+            <a:avLst/>
+          </a:prstGeom>
+          <a:solidFill>
+            <a:srgbClr val="FFFFFF"/>
+          </a:solidFill>
+          <a:ln w="9525">
+            <a:solidFill>
+              <a:srgbClr val="BFBFBF"/>
+            </a:solidFill>
+          </a:ln>
+          <a:effectLst/>
+        </p:spPr>
+        <p:style>
+          <a:lnRef idx="1">
+            <a:schemeClr val="accent1"/>
+          </a:lnRef>
+          <a:fillRef idx="3">
+            <a:schemeClr val="accent1"/>
+          </a:fillRef>
+          <a:effectRef idx="2">
+            <a:schemeClr val="accent1"/>
+          </a:effectRef>
+          <a:fontRef idx="minor">
+            <a:schemeClr val="lt1"/>
+          </a:fontRef>
+        </p:style>
+        <p:txBody>
+          <a:bodyPr rtlCol="0" anchor="ctr" wrap="square" lIns="45720" rIns="45720" tIns="27432" bIns="27432"/>
+          <a:lstStyle/>
+          <a:p>
+            <a:pPr algn="l"/>
+            <a:r>
+              <a:rPr sz="950" b="0">
+                <a:solidFill>
+                  <a:srgbClr val="1A1A1A"/>
+                </a:solidFill>
+                <a:latin typeface="맑은 고딕"/>
+                <a:ea typeface="맑은 고딕"/>
+              </a:rPr>
+              <a:t>- 비교 가능·포화 31쌍 중 C1 25쌍, C2 21쌍은 Baseline과 같다. Baseline이 이미 SLO를 만족하면 올릴 </a:t>
+            </a:r>
+          </a:p>
+          <a:p>
+            <a:pPr algn="l"/>
+            <a:r>
+              <a:rPr sz="950" b="0">
+                <a:solidFill>
+                  <a:srgbClr val="1A1A1A"/>
+                </a:solidFill>
+                <a:latin typeface="맑은 고딕"/>
+                <a:ea typeface="맑은 고딕"/>
+              </a:rPr>
+              <a:t>여지가 없기 때문이다 (공통 시나리오 x1.00).</a:t>
+            </a:r>
+          </a:p>
+          <a:p>
+            <a:pPr algn="l"/>
+            <a:r>
+              <a:rPr sz="950" b="0">
+                <a:solidFill>
+                  <a:srgbClr val="1A1A1A"/>
+                </a:solidFill>
+                <a:latin typeface="맑은 고딕"/>
+                <a:ea typeface="맑은 고딕"/>
+              </a:rPr>
+              <a:t>- 이득은 hot 대상이 시간에 따라 옮겨 가는 Dynamic 시나리오에 집중된다 (승 C1 6, C2 10쌍).</a:t>
+            </a:r>
+          </a:p>
+          <a:p>
+            <a:pPr algn="l"/>
+            <a:r>
+              <a:rPr sz="950" b="0">
+                <a:solidFill>
+                  <a:srgbClr val="1A1A1A"/>
+                </a:solidFill>
+                <a:latin typeface="맑은 고딕"/>
+                <a:ea typeface="맑은 고딕"/>
+              </a:rPr>
+              <a:t>- C2는 데이터마다 접근 빈도·재사용·유휴를 보고 이동해 같은 종류(KV) 안의 hot/cold를 구분한다. C1은 </a:t>
+            </a:r>
+          </a:p>
+          <a:p>
+            <a:pPr algn="l"/>
+            <a:r>
+              <a:rPr sz="950" b="0">
+                <a:solidFill>
+                  <a:srgbClr val="1A1A1A"/>
+                </a:solidFill>
+                <a:latin typeface="맑은 고딕"/>
+                <a:ea typeface="맑은 고딕"/>
+              </a:rPr>
+              <a:t>자원 압박에만 반응해 구분하지 못한다.</a:t>
+            </a:r>
+          </a:p>
+        </p:txBody>
+      </p:sp>
+      <p:sp>
+        <p:nvSpPr>
+          <p:cNvPr id="63" name="Rectangle 62"/>
+          <p:cNvSpPr/>
+          <p:nvPr/>
+        </p:nvSpPr>
+        <p:spPr>
+          <a:xfrm>
+            <a:off x="8961120" y="1371600"/>
+            <a:ext cx="2834640" cy="1600200"/>
           </a:xfrm>
           <a:prstGeom prst="rect">
             <a:avLst/>
@@ -7223,33 +7384,59 @@
           </a:fontRef>
         </p:style>
         <p:txBody>
-          <a:bodyPr rtlCol="0" anchor="t" wrap="square" lIns="45720" rIns="45720" tIns="27432" bIns="27432"/>
+          <a:bodyPr rtlCol="0" anchor="ctr" wrap="square" lIns="45720" rIns="45720" tIns="27432" bIns="27432"/>
           <a:lstStyle/>
           <a:p>
             <a:pPr algn="l"/>
             <a:r>
-              <a:rPr sz="1000" b="1">
+              <a:rPr sz="850" b="1">
                 <a:solidFill>
                   <a:srgbClr val="404040"/>
                 </a:solidFill>
                 <a:latin typeface="맑은 고딕"/>
                 <a:ea typeface="맑은 고딕"/>
               </a:rPr>
-              <a:t>32개 시나리오를 H100과 B200에 각각 돌렸다(64쌍): 비교 가능 21쌍, 포화 10쌍, Baseline도 SLO 불가라 비교 제외 33쌍.</a:t>
-            </a:r>
-          </a:p>
-        </p:txBody>
-      </p:sp>
-      <p:sp>
-        <p:nvSpPr>
-          <p:cNvPr id="59" name="Rectangle 58"/>
+              <a:t>dyn_kv_hotset_recency_shift (B200): C1 x1.11, C2 x2.62</a:t>
+            </a:r>
+          </a:p>
+          <a:p>
+            <a:pPr algn="l"/>
+            <a:r>
+              <a:rPr sz="850" b="0">
+                <a:solidFill>
+                  <a:srgbClr val="404040"/>
+                </a:solidFill>
+                <a:latin typeface="맑은 고딕"/>
+                <a:ea typeface="맑은 고딕"/>
+              </a:rPr>
+              <a:t>. 이동량 C1 70 GiB 대 C2 2,210 GiB.</a:t>
+            </a:r>
+          </a:p>
+          <a:p>
+            <a:pPr algn="l"/>
+            <a:r>
+              <a:rPr sz="850" b="0">
+                <a:solidFill>
+                  <a:srgbClr val="404040"/>
+                </a:solidFill>
+                <a:latin typeface="맑은 고딕"/>
+                <a:ea typeface="맑은 고딕"/>
+              </a:rPr>
+              <a:t>공통 cb_kv_8k_b32: 모두 x1.00</a:t>
+            </a:r>
+          </a:p>
+        </p:txBody>
+      </p:sp>
+      <p:sp>
+        <p:nvSpPr>
+          <p:cNvPr id="64" name="Rectangle 63"/>
           <p:cNvSpPr/>
           <p:nvPr/>
         </p:nvSpPr>
         <p:spPr>
           <a:xfrm>
-            <a:off x="365760" y="1691640"/>
-            <a:ext cx="2651760" cy="841248"/>
+            <a:off x="365760" y="3017520"/>
+            <a:ext cx="2651760" cy="1508760"/>
           </a:xfrm>
           <a:prstGeom prst="rect">
             <a:avLst/>
@@ -7284,28 +7471,54 @@
           <a:p>
             <a:pPr algn="l"/>
             <a:r>
-              <a:rPr sz="1000" b="1">
+              <a:rPr sz="950" b="1">
                 <a:solidFill>
                   <a:srgbClr val="1A1A1A"/>
                 </a:solidFill>
                 <a:latin typeface="맑은 고딕"/>
                 <a:ea typeface="맑은 고딕"/>
               </a:rPr>
-              <a:t>기본 서비스 상황 (공통)</a:t>
-            </a:r>
-          </a:p>
-        </p:txBody>
-      </p:sp>
-      <p:sp>
-        <p:nvSpPr>
-          <p:cNvPr id="60" name="Rectangle 59"/>
+              <a:t>QA2 TTFT</a:t>
+            </a:r>
+          </a:p>
+          <a:p>
+            <a:pPr algn="l"/>
+            <a:r>
+              <a:rPr sz="950" b="1">
+                <a:solidFill>
+                  <a:srgbClr val="1A1A1A"/>
+                </a:solidFill>
+                <a:latin typeface="맑은 고딕"/>
+                <a:ea typeface="맑은 고딕"/>
+              </a:rPr>
+              <a:t>P50 C1 x0.44 · C2 x0.29</a:t>
+            </a:r>
+          </a:p>
+          <a:p>
+            <a:pPr algn="l"/>
+            <a:r>
+              <a:rPr sz="950" b="1">
+                <a:solidFill>
+                  <a:srgbClr val="1A1A1A"/>
+                </a:solidFill>
+                <a:latin typeface="맑은 고딕"/>
+                <a:ea typeface="맑은 고딕"/>
+              </a:rPr>
+              <a:t>P99 C1 x1.04 · C2 x0.72</a:t>
+            </a:r>
+          </a:p>
+        </p:txBody>
+      </p:sp>
+      <p:sp>
+        <p:nvSpPr>
+          <p:cNvPr id="65" name="Rectangle 64"/>
           <p:cNvSpPr/>
           <p:nvPr/>
         </p:nvSpPr>
         <p:spPr>
           <a:xfrm>
-            <a:off x="3017520" y="1691640"/>
-            <a:ext cx="8778240" cy="841248"/>
+            <a:off x="3017520" y="3017520"/>
+            <a:ext cx="5943600" cy="1508760"/>
           </a:xfrm>
           <a:prstGeom prst="rect">
             <a:avLst/>
@@ -7340,41 +7553,175 @@
           <a:p>
             <a:pPr algn="l"/>
             <a:r>
-              <a:rPr sz="1100" b="0">
+              <a:rPr sz="950" b="0">
                 <a:solidFill>
                   <a:srgbClr val="1A1A1A"/>
                 </a:solidFill>
                 <a:latin typeface="맑은 고딕"/>
                 <a:ea typeface="맑은 고딕"/>
               </a:rPr>
-              <a:t>8K 토큰 입력, 256 토큰 생성, 동시 32 요청의 대화 서비스. HBM이 빠듯한 경우 / 시간이 갈수록 여유가 줄어드는 경우 / KV cache에 Lo</a:t>
+              <a:t>- P50이 크게 줄어드는 가장 큰 이유로 보이는 것: hot 데이터가 느린 tier(DRAM/HBF)에서 HBM으로 올라</a:t>
             </a:r>
           </a:p>
           <a:p>
             <a:pPr algn="l"/>
             <a:r>
-              <a:rPr sz="1100" b="0">
+              <a:rPr sz="950" b="0">
                 <a:solidFill>
                   <a:srgbClr val="1A1A1A"/>
                 </a:solidFill>
                 <a:latin typeface="맑은 고딕"/>
                 <a:ea typeface="맑은 고딕"/>
               </a:rPr>
-              <a:t>RA·MoE·Agent 데이터가 섞이는 경우. 결과: 두 후보 모두 Baseline과 같다.</a:t>
-            </a:r>
-          </a:p>
-        </p:txBody>
-      </p:sp>
-      <p:sp>
-        <p:nvSpPr>
-          <p:cNvPr id="61" name="Rectangle 60"/>
+              <a:t>가 첫 토큰 전 복원 대기가 줄어든다(요청 단위로 분해하지는 않았다).</a:t>
+            </a:r>
+          </a:p>
+          <a:p>
+            <a:pPr algn="l"/>
+            <a:r>
+              <a:rPr sz="950" b="0">
+                <a:solidFill>
+                  <a:srgbClr val="1A1A1A"/>
+                </a:solidFill>
+                <a:latin typeface="맑은 고딕"/>
+                <a:ea typeface="맑은 고딕"/>
+              </a:rPr>
+              <a:t>- C1의 P99는 개선이 없다(x1.04). 진단한 `cb_kv_8k_b32`에서는 C1이 DRAM 링크 포화 신호에 반응해 </a:t>
+            </a:r>
+          </a:p>
+          <a:p>
+            <a:pPr algn="l"/>
+            <a:r>
+              <a:rPr sz="950" b="0">
+                <a:solidFill>
+                  <a:srgbClr val="1A1A1A"/>
+                </a:solidFill>
+                <a:latin typeface="맑은 고딕"/>
+                <a:ea typeface="맑은 고딕"/>
+              </a:rPr>
+              <a:t>이득 없는 재배치를 하고 그 이동이 링크를 나눠 써 꼬리가 늘었다(다른 시나리오의 원인은 분해하지 않</a:t>
+            </a:r>
+          </a:p>
+          <a:p>
+            <a:pPr algn="l"/>
+            <a:r>
+              <a:rPr sz="950" b="0">
+                <a:solidFill>
+                  <a:srgbClr val="1A1A1A"/>
+                </a:solidFill>
+                <a:latin typeface="맑은 고딕"/>
+                <a:ea typeface="맑은 고딕"/>
+              </a:rPr>
+              <a:t>음). C2는 hot 데이터를 HBM으로 올리는 이동이라 꼬리도 줄었다(x0.72).</a:t>
+            </a:r>
+          </a:p>
+          <a:p>
+            <a:pPr algn="l"/>
+            <a:r>
+              <a:rPr sz="950" b="0">
+                <a:solidFill>
+                  <a:srgbClr val="1A1A1A"/>
+                </a:solidFill>
+                <a:latin typeface="맑은 고딕"/>
+                <a:ea typeface="맑은 고딕"/>
+              </a:rPr>
+              <a:t>- 이동이 같은 링크의 서빙 대역폭을 나눠 쓰는 간섭 모델을 반영했다.</a:t>
+            </a:r>
+          </a:p>
+        </p:txBody>
+      </p:sp>
+      <p:sp>
+        <p:nvSpPr>
+          <p:cNvPr id="66" name="Rectangle 65"/>
           <p:cNvSpPr/>
           <p:nvPr/>
         </p:nvSpPr>
         <p:spPr>
           <a:xfrm>
-            <a:off x="365760" y="2578608"/>
-            <a:ext cx="2651760" cy="841248"/>
+            <a:off x="8961120" y="3017520"/>
+            <a:ext cx="2834640" cy="1508760"/>
+          </a:xfrm>
+          <a:prstGeom prst="rect">
+            <a:avLst/>
+          </a:prstGeom>
+          <a:solidFill>
+            <a:srgbClr val="F2F2F2"/>
+          </a:solidFill>
+          <a:ln w="9525">
+            <a:solidFill>
+              <a:srgbClr val="BFBFBF"/>
+            </a:solidFill>
+          </a:ln>
+          <a:effectLst/>
+        </p:spPr>
+        <p:style>
+          <a:lnRef idx="1">
+            <a:schemeClr val="accent1"/>
+          </a:lnRef>
+          <a:fillRef idx="3">
+            <a:schemeClr val="accent1"/>
+          </a:fillRef>
+          <a:effectRef idx="2">
+            <a:schemeClr val="accent1"/>
+          </a:effectRef>
+          <a:fontRef idx="minor">
+            <a:schemeClr val="lt1"/>
+          </a:fontRef>
+        </p:style>
+        <p:txBody>
+          <a:bodyPr rtlCol="0" anchor="ctr" wrap="square" lIns="45720" rIns="45720" tIns="27432" bIns="27432"/>
+          <a:lstStyle/>
+          <a:p>
+            <a:pPr algn="l"/>
+            <a:r>
+              <a:rPr sz="850" b="1">
+                <a:solidFill>
+                  <a:srgbClr val="404040"/>
+                </a:solidFill>
+                <a:latin typeface="맑은 고딕"/>
+                <a:ea typeface="맑은 고딕"/>
+              </a:rPr>
+              <a:t>cb_kv_8k_b32 (B200) TTFT P99: Baseline 337 ms, C1 1,</a:t>
+            </a:r>
+          </a:p>
+          <a:p>
+            <a:pPr algn="l"/>
+            <a:r>
+              <a:rPr sz="850" b="0">
+                <a:solidFill>
+                  <a:srgbClr val="404040"/>
+                </a:solidFill>
+                <a:latin typeface="맑은 고딕"/>
+                <a:ea typeface="맑은 고딕"/>
+              </a:rPr>
+              <a:t>308, C2 389.</a:t>
+            </a:r>
+          </a:p>
+          <a:p>
+            <a:pPr algn="l"/>
+            <a:r>
+              <a:rPr sz="850" b="0">
+                <a:solidFill>
+                  <a:srgbClr val="404040"/>
+                </a:solidFill>
+                <a:latin typeface="맑은 고딕"/>
+                <a:ea typeface="맑은 고딕"/>
+              </a:rPr>
+              <a:t>C1은 재배치 17회(231 GiB), C2는 승격 76회</a:t>
+            </a:r>
+          </a:p>
+        </p:txBody>
+      </p:sp>
+      <p:sp>
+        <p:nvSpPr>
+          <p:cNvPr id="67" name="Rectangle 66"/>
+          <p:cNvSpPr/>
+          <p:nvPr/>
+        </p:nvSpPr>
+        <p:spPr>
+          <a:xfrm>
+            <a:off x="365760" y="4572000"/>
+            <a:ext cx="2651760" cy="1234440"/>
           </a:xfrm>
           <a:prstGeom prst="rect">
             <a:avLst/>
@@ -7409,28 +7756,41 @@
           <a:p>
             <a:pPr algn="l"/>
             <a:r>
-              <a:rPr sz="1000" b="1">
+              <a:rPr sz="950" b="1">
                 <a:solidFill>
                   <a:srgbClr val="1A1A1A"/>
                 </a:solidFill>
                 <a:latin typeface="맑은 고딕"/>
                 <a:ea typeface="맑은 고딕"/>
               </a:rPr>
-              <a:t>데이터 종류별</a:t>
-            </a:r>
-          </a:p>
-        </p:txBody>
-      </p:sp>
-      <p:sp>
-        <p:nvSpPr>
-          <p:cNvPr id="62" name="Rectangle 61"/>
+              <a:t>QA2 TPOT</a:t>
+            </a:r>
+          </a:p>
+          <a:p>
+            <a:pPr algn="l"/>
+            <a:r>
+              <a:rPr sz="950" b="1">
+                <a:solidFill>
+                  <a:srgbClr val="1A1A1A"/>
+                </a:solidFill>
+                <a:latin typeface="맑은 고딕"/>
+                <a:ea typeface="맑은 고딕"/>
+              </a:rPr>
+              <a:t>P99 C1 x1.07 · C2 x0.94</a:t>
+            </a:r>
+          </a:p>
+        </p:txBody>
+      </p:sp>
+      <p:sp>
+        <p:nvSpPr>
+          <p:cNvPr id="68" name="Rectangle 67"/>
           <p:cNvSpPr/>
           <p:nvPr/>
         </p:nvSpPr>
         <p:spPr>
           <a:xfrm>
-            <a:off x="3017520" y="2578608"/>
-            <a:ext cx="8778240" cy="841248"/>
+            <a:off x="3017520" y="4572000"/>
+            <a:ext cx="5943600" cy="1234440"/>
           </a:xfrm>
           <a:prstGeom prst="rect">
             <a:avLst/>
@@ -7465,41 +7825,586 @@
           <a:p>
             <a:pPr algn="l"/>
             <a:r>
-              <a:rPr sz="1100" b="0">
+              <a:rPr sz="950" b="0">
                 <a:solidFill>
                   <a:srgbClr val="1A1A1A"/>
                 </a:solidFill>
                 <a:latin typeface="맑은 고딕"/>
                 <a:ea typeface="맑은 고딕"/>
               </a:rPr>
-              <a:t>대화 문맥(KV cache, 32K~512K 토큰, 동시 1~256) · 여러 고객이 쓰는 LoRA 어댑터(몇 개만 인기) · MoE expert(라우팅 쏠림) · 수 TiB 벡</a:t>
+              <a:t>- 거의 변하지 않는다. TPOT는 매 토큰 디코드가 HBM 대역폭에 묶여 정해지고, DP1은 데이터 위치만 바</a:t>
             </a:r>
           </a:p>
           <a:p>
             <a:pPr algn="l"/>
             <a:r>
-              <a:rPr sz="1100" b="0">
+              <a:rPr sz="950" b="0">
                 <a:solidFill>
                   <a:srgbClr val="1A1A1A"/>
                 </a:solidFill>
                 <a:latin typeface="맑은 고딕"/>
                 <a:ea typeface="맑은 고딕"/>
               </a:rPr>
-              <a:t>터 DB(RAG) · 오래 보관되는 Agent 기억과 Tool 결과(드물게 재사용 / 한꺼번에 생성 후 반복 참조).</a:t>
-            </a:r>
-          </a:p>
-        </p:txBody>
-      </p:sp>
-      <p:sp>
-        <p:nvSpPr>
-          <p:cNvPr id="63" name="Rectangle 62"/>
+              <a:t>꾸지 디코드 방식은 바꾸지 못한다. Baseline의 TPOT P99가 17.1 ms로 SLO(50 ms)보다 훨씬 낮아 개선 </a:t>
+            </a:r>
+          </a:p>
+          <a:p>
+            <a:pPr algn="l"/>
+            <a:r>
+              <a:rPr sz="950" b="0">
+                <a:solidFill>
+                  <a:srgbClr val="1A1A1A"/>
+                </a:solidFill>
+                <a:latin typeface="맑은 고딕"/>
+                <a:ea typeface="맑은 고딕"/>
+              </a:rPr>
+              <a:t>여지도 작다.</a:t>
+            </a:r>
+          </a:p>
+          <a:p>
+            <a:pPr algn="l"/>
+            <a:r>
+              <a:rPr sz="950" b="0">
+                <a:solidFill>
+                  <a:srgbClr val="1A1A1A"/>
+                </a:solidFill>
+                <a:latin typeface="맑은 고딕"/>
+                <a:ea typeface="맑은 고딕"/>
+              </a:rPr>
+              <a:t>- 개선이 있다면 KV가 HBM 밖에 있어 복원 비용이 TPOT에 섞이는 경우뿐이다. LoRA·MoE expert가 원격</a:t>
+            </a:r>
+          </a:p>
+          <a:p>
+            <a:pPr algn="l"/>
+            <a:r>
+              <a:rPr sz="950" b="0">
+                <a:solidFill>
+                  <a:srgbClr val="1A1A1A"/>
+                </a:solidFill>
+                <a:latin typeface="맑은 고딕"/>
+                <a:ea typeface="맑은 고딕"/>
+              </a:rPr>
+              <a:t>에 있을 때도 영향이 있으나 이번 비교 가능 시나리오에는 거의 없다(Baseline도 SLO 불가).</a:t>
+            </a:r>
+          </a:p>
+        </p:txBody>
+      </p:sp>
+      <p:sp>
+        <p:nvSpPr>
+          <p:cNvPr id="69" name="Rectangle 68"/>
           <p:cNvSpPr/>
           <p:nvPr/>
         </p:nvSpPr>
         <p:spPr>
           <a:xfrm>
-            <a:off x="365760" y="3465576"/>
-            <a:ext cx="2651760" cy="841248"/>
+            <a:off x="8961120" y="4572000"/>
+            <a:ext cx="2834640" cy="1234440"/>
+          </a:xfrm>
+          <a:prstGeom prst="rect">
+            <a:avLst/>
+          </a:prstGeom>
+          <a:solidFill>
+            <a:srgbClr val="F2F2F2"/>
+          </a:solidFill>
+          <a:ln w="9525">
+            <a:solidFill>
+              <a:srgbClr val="BFBFBF"/>
+            </a:solidFill>
+          </a:ln>
+          <a:effectLst/>
+        </p:spPr>
+        <p:style>
+          <a:lnRef idx="1">
+            <a:schemeClr val="accent1"/>
+          </a:lnRef>
+          <a:fillRef idx="3">
+            <a:schemeClr val="accent1"/>
+          </a:fillRef>
+          <a:effectRef idx="2">
+            <a:schemeClr val="accent1"/>
+          </a:effectRef>
+          <a:fontRef idx="minor">
+            <a:schemeClr val="lt1"/>
+          </a:fontRef>
+        </p:style>
+        <p:txBody>
+          <a:bodyPr rtlCol="0" anchor="ctr" wrap="square" lIns="45720" rIns="45720" tIns="27432" bIns="27432"/>
+          <a:lstStyle/>
+          <a:p>
+            <a:pPr algn="l"/>
+            <a:r>
+              <a:rPr sz="850" b="1">
+                <a:solidFill>
+                  <a:srgbClr val="404040"/>
+                </a:solidFill>
+                <a:latin typeface="맑은 고딕"/>
+                <a:ea typeface="맑은 고딕"/>
+              </a:rPr>
+              <a:t>Baseline TPOT P99 geomean 17.1 ms, SLO 50 ms</a:t>
+            </a:r>
+          </a:p>
+          <a:p>
+            <a:pPr algn="l"/>
+            <a:r>
+              <a:rPr sz="850" b="0">
+                <a:solidFill>
+                  <a:srgbClr val="404040"/>
+                </a:solidFill>
+                <a:latin typeface="맑은 고딕"/>
+                <a:ea typeface="맑은 고딕"/>
+              </a:rPr>
+              <a:t>LoRA·MoE 시나리오는 Baseline이 TPOT SLO를 못 맞춰 비</a:t>
+            </a:r>
+          </a:p>
+          <a:p>
+            <a:pPr algn="l"/>
+            <a:r>
+              <a:rPr sz="850" b="0">
+                <a:solidFill>
+                  <a:srgbClr val="404040"/>
+                </a:solidFill>
+                <a:latin typeface="맑은 고딕"/>
+                <a:ea typeface="맑은 고딕"/>
+              </a:rPr>
+              <a:t>교에서 제외</a:t>
+            </a:r>
+          </a:p>
+        </p:txBody>
+      </p:sp>
+    </p:spTree>
+  </p:cSld>
+  <p:clrMapOvr>
+    <a:masterClrMapping/>
+  </p:clrMapOvr>
+</p:sld>
+</file>
+
+<file path=ppt/slides/slide20.xml><?xml version="1.0" encoding="utf-8"?>
+<p:sld xmlns:a="http://schemas.openxmlformats.org/drawingml/2006/main" xmlns:p="http://schemas.openxmlformats.org/presentationml/2006/main" xmlns:r="http://schemas.openxmlformats.org/officeDocument/2006/relationships">
+  <p:cSld>
+    <p:spTree>
+      <p:nvGrpSpPr>
+        <p:cNvPr id="1" name=""/>
+        <p:cNvGrpSpPr/>
+        <p:nvPr/>
+      </p:nvGrpSpPr>
+      <p:grpSpPr/>
+      <p:sp>
+        <p:nvSpPr>
+          <p:cNvPr id="3" name="제목 2"/>
+          <p:cNvSpPr>
+            <a:spLocks noGrp="1"/>
+          </p:cNvSpPr>
+          <p:nvPr>
+            <p:ph type="title"/>
+          </p:nvPr>
+        </p:nvSpPr>
+        <p:spPr>
+          <a:xfrm>
+            <a:off x="234949" y="137379"/>
+            <a:ext cx="7631530" cy="365125"/>
+          </a:xfrm>
+        </p:spPr>
+        <p:txBody>
+          <a:bodyPr/>
+          <a:lstStyle/>
+          <a:p>
+            <a:r>
+              <a:rPr lang="en-US" altLang="ko-KR" dirty="0"/>
+              <a:t>DP1. 이기종 메모리 기반 Data Migration 구조 - Appendix</a:t>
+            </a:r>
+            <a:r>
+              <a:rPr lang="ko-KR" altLang="en-US" dirty="0"/>
+              <a:t/>
+            </a:r>
+            <a:r>
+              <a:rPr lang="en-US" altLang="ko-KR" dirty="0"/>
+              <a:t/>
+            </a:r>
+            <a:r>
+              <a:rPr lang="ko-KR" altLang="en-US" dirty="0"/>
+              <a:t/>
+            </a:r>
+            <a:r>
+              <a:rPr lang="en-US" altLang="ko-KR" dirty="0"/>
+              <a:t/>
+            </a:r>
+            <a:r>
+              <a:rPr lang="ko-KR" altLang="en-US" dirty="0"/>
+              <a:t/>
+            </a:r>
+          </a:p>
+        </p:txBody>
+      </p:sp>
+      <p:sp>
+        <p:nvSpPr>
+          <p:cNvPr id="5" name="직사각형 4"/>
+          <p:cNvSpPr/>
+          <p:nvPr/>
+        </p:nvSpPr>
+        <p:spPr>
+          <a:xfrm>
+            <a:off x="234949" y="596176"/>
+            <a:ext cx="11747501" cy="396603"/>
+          </a:xfrm>
+          <a:prstGeom prst="rect">
+            <a:avLst/>
+          </a:prstGeom>
+          <a:solidFill>
+            <a:schemeClr val="bg1">
+              <a:lumMod val="50000"/>
+            </a:schemeClr>
+          </a:solidFill>
+          <a:ln>
+            <a:noFill/>
+          </a:ln>
+        </p:spPr>
+        <p:style>
+          <a:lnRef idx="2">
+            <a:schemeClr val="accent1">
+              <a:shade val="50000"/>
+            </a:schemeClr>
+          </a:lnRef>
+          <a:fillRef idx="1">
+            <a:schemeClr val="accent1"/>
+          </a:fillRef>
+          <a:effectRef idx="0">
+            <a:schemeClr val="accent1"/>
+          </a:effectRef>
+          <a:fontRef idx="minor">
+            <a:schemeClr val="lt1"/>
+          </a:fontRef>
+        </p:style>
+        <p:txBody>
+          <a:bodyPr rtlCol="0" anchor="ctr"/>
+          <a:lstStyle/>
+          <a:p>
+            <a:pPr algn="ctr"/>
+            <a:endParaRPr lang="ko-KR" altLang="en-US"/>
+          </a:p>
+        </p:txBody>
+      </p:sp>
+      <p:sp>
+        <p:nvSpPr>
+          <p:cNvPr id="8" name="TextBox 7"/>
+          <p:cNvSpPr txBox="1"/>
+          <p:nvPr/>
+        </p:nvSpPr>
+        <p:spPr>
+          <a:xfrm>
+            <a:off x="469760" y="627926"/>
+            <a:ext cx="11430000" cy="307777"/>
+          </a:xfrm>
+          <a:prstGeom prst="rect">
+            <a:avLst/>
+          </a:prstGeom>
+          <a:noFill/>
+        </p:spPr>
+        <p:txBody>
+          <a:bodyPr wrap="square" rtlCol="0">
+            <a:spAutoFit/>
+          </a:bodyPr>
+          <a:lstStyle/>
+          <a:p>
+            <a:pPr lvl="0">
+              <a:defRPr/>
+            </a:pPr>
+            <a:r>
+              <a:rPr lang="ko-KR" altLang="en-US" sz="1400" b="1" dirty="0">
+                <a:solidFill>
+                  <a:schemeClr val="bg1"/>
+                </a:solidFill>
+              </a:rPr>
+              <a:t>DP1 평가 결과 - QA별로 왜 이런 값이 나왔나 (2/2: 자원, 확장성)</a:t>
+            </a:r>
+            <a:r>
+              <a:rPr lang="en-US" altLang="ko-KR" sz="1400" b="1" dirty="0">
+                <a:solidFill>
+                  <a:schemeClr val="bg1"/>
+                </a:solidFill>
+              </a:rPr>
+              <a:t/>
+            </a:r>
+            <a:r>
+              <a:rPr lang="ko-KR" altLang="en-US" sz="1400" b="1" dirty="0">
+                <a:solidFill>
+                  <a:schemeClr val="bg1"/>
+                </a:solidFill>
+              </a:rPr>
+              <a:t/>
+            </a:r>
+            <a:r>
+              <a:rPr lang="en-US" altLang="ko-KR" sz="1400" b="1" dirty="0">
+                <a:solidFill>
+                  <a:schemeClr val="bg1"/>
+                </a:solidFill>
+              </a:rPr>
+              <a:t/>
+            </a:r>
+            <a:r>
+              <a:rPr lang="ko-KR" altLang="en-US" sz="1400" b="1" dirty="0">
+                <a:solidFill>
+                  <a:schemeClr val="bg1"/>
+                </a:solidFill>
+              </a:rPr>
+              <a:t/>
+            </a:r>
+          </a:p>
+        </p:txBody>
+      </p:sp>
+      <p:sp>
+        <p:nvSpPr>
+          <p:cNvPr id="39" name="직사각형 38"/>
+          <p:cNvSpPr/>
+          <p:nvPr/>
+        </p:nvSpPr>
+        <p:spPr>
+          <a:xfrm>
+            <a:off x="403086" y="678726"/>
+            <a:ext cx="66675" cy="216270"/>
+          </a:xfrm>
+          <a:prstGeom prst="rect">
+            <a:avLst/>
+          </a:prstGeom>
+          <a:solidFill>
+            <a:schemeClr val="bg1"/>
+          </a:solidFill>
+          <a:ln w="19050">
+            <a:noFill/>
+          </a:ln>
+        </p:spPr>
+        <p:style>
+          <a:lnRef idx="2">
+            <a:schemeClr val="accent1">
+              <a:shade val="50000"/>
+            </a:schemeClr>
+          </a:lnRef>
+          <a:fillRef idx="1">
+            <a:schemeClr val="accent1"/>
+          </a:fillRef>
+          <a:effectRef idx="0">
+            <a:schemeClr val="accent1"/>
+          </a:effectRef>
+          <a:fontRef idx="minor">
+            <a:schemeClr val="lt1"/>
+          </a:fontRef>
+        </p:style>
+        <p:txBody>
+          <a:bodyPr rtlCol="0" anchor="ctr"/>
+          <a:lstStyle/>
+          <a:p>
+            <a:pPr algn="ctr"/>
+            <a:endParaRPr lang="ko-KR" altLang="en-US" sz="1600"/>
+          </a:p>
+        </p:txBody>
+      </p:sp>
+      <p:sp>
+        <p:nvSpPr>
+          <p:cNvPr id="57" name="슬라이드 번호 개체 틀 1"/>
+          <p:cNvSpPr>
+            <a:spLocks noGrp="1"/>
+          </p:cNvSpPr>
+          <p:nvPr>
+            <p:ph type="sldNum" sz="quarter" idx="4"/>
+          </p:nvPr>
+        </p:nvSpPr>
+        <p:spPr>
+          <a:xfrm>
+            <a:off x="5620080" y="6597650"/>
+            <a:ext cx="456466" cy="209550"/>
+          </a:xfrm>
+        </p:spPr>
+        <p:txBody>
+          <a:bodyPr/>
+          <a:lstStyle/>
+          <a:p>
+            <a:fld id="{7F889C64-266A-4D07-AD8F-5B592E61CCE1}" type="slidenum">
+              <a:rPr lang="ko-KR" altLang="en-US" smtClean="0"/>
+              <a:pPr/>
+              <a:t>9</a:t>
+            </a:fld>
+            <a:endParaRPr lang="ko-KR" altLang="en-US" dirty="0"/>
+          </a:p>
+        </p:txBody>
+      </p:sp>
+      <p:sp>
+        <p:nvSpPr>
+          <p:cNvPr id="58" name="Rectangle 57"/>
+          <p:cNvSpPr/>
+          <p:nvPr/>
+        </p:nvSpPr>
+        <p:spPr>
+          <a:xfrm>
+            <a:off x="365760" y="1051560"/>
+            <a:ext cx="2651760" cy="292608"/>
+          </a:xfrm>
+          <a:prstGeom prst="rect">
+            <a:avLst/>
+          </a:prstGeom>
+          <a:solidFill>
+            <a:srgbClr val="1F4E79"/>
+          </a:solidFill>
+          <a:ln w="9525">
+            <a:solidFill>
+              <a:srgbClr val="1F4E79"/>
+            </a:solidFill>
+          </a:ln>
+          <a:effectLst/>
+        </p:spPr>
+        <p:style>
+          <a:lnRef idx="1">
+            <a:schemeClr val="accent1"/>
+          </a:lnRef>
+          <a:fillRef idx="3">
+            <a:schemeClr val="accent1"/>
+          </a:fillRef>
+          <a:effectRef idx="2">
+            <a:schemeClr val="accent1"/>
+          </a:effectRef>
+          <a:fontRef idx="minor">
+            <a:schemeClr val="lt1"/>
+          </a:fontRef>
+        </p:style>
+        <p:txBody>
+          <a:bodyPr rtlCol="0" anchor="ctr" wrap="square" lIns="45720" rIns="45720" tIns="27432" bIns="27432"/>
+          <a:lstStyle/>
+          <a:p>
+            <a:pPr algn="ctr"/>
+            <a:r>
+              <a:rPr sz="1000" b="1">
+                <a:solidFill>
+                  <a:srgbClr val="FFFFFF"/>
+                </a:solidFill>
+                <a:latin typeface="맑은 고딕"/>
+                <a:ea typeface="맑은 고딕"/>
+              </a:rPr>
+              <a:t>QA / 수치</a:t>
+            </a:r>
+          </a:p>
+        </p:txBody>
+      </p:sp>
+      <p:sp>
+        <p:nvSpPr>
+          <p:cNvPr id="59" name="Rectangle 58"/>
+          <p:cNvSpPr/>
+          <p:nvPr/>
+        </p:nvSpPr>
+        <p:spPr>
+          <a:xfrm>
+            <a:off x="3017520" y="1051560"/>
+            <a:ext cx="5943600" cy="292608"/>
+          </a:xfrm>
+          <a:prstGeom prst="rect">
+            <a:avLst/>
+          </a:prstGeom>
+          <a:solidFill>
+            <a:srgbClr val="1F4E79"/>
+          </a:solidFill>
+          <a:ln w="9525">
+            <a:solidFill>
+              <a:srgbClr val="1F4E79"/>
+            </a:solidFill>
+          </a:ln>
+          <a:effectLst/>
+        </p:spPr>
+        <p:style>
+          <a:lnRef idx="1">
+            <a:schemeClr val="accent1"/>
+          </a:lnRef>
+          <a:fillRef idx="3">
+            <a:schemeClr val="accent1"/>
+          </a:fillRef>
+          <a:effectRef idx="2">
+            <a:schemeClr val="accent1"/>
+          </a:effectRef>
+          <a:fontRef idx="minor">
+            <a:schemeClr val="lt1"/>
+          </a:fontRef>
+        </p:style>
+        <p:txBody>
+          <a:bodyPr rtlCol="0" anchor="ctr" wrap="square" lIns="45720" rIns="45720" tIns="27432" bIns="27432"/>
+          <a:lstStyle/>
+          <a:p>
+            <a:pPr algn="ctr"/>
+            <a:r>
+              <a:rPr sz="1000" b="1">
+                <a:solidFill>
+                  <a:srgbClr val="FFFFFF"/>
+                </a:solidFill>
+                <a:latin typeface="맑은 고딕"/>
+                <a:ea typeface="맑은 고딕"/>
+              </a:rPr>
+              <a:t>왜 이런 값이 나왔나</a:t>
+            </a:r>
+          </a:p>
+        </p:txBody>
+      </p:sp>
+      <p:sp>
+        <p:nvSpPr>
+          <p:cNvPr id="60" name="Rectangle 59"/>
+          <p:cNvSpPr/>
+          <p:nvPr/>
+        </p:nvSpPr>
+        <p:spPr>
+          <a:xfrm>
+            <a:off x="8961120" y="1051560"/>
+            <a:ext cx="2834640" cy="292608"/>
+          </a:xfrm>
+          <a:prstGeom prst="rect">
+            <a:avLst/>
+          </a:prstGeom>
+          <a:solidFill>
+            <a:srgbClr val="1F4E79"/>
+          </a:solidFill>
+          <a:ln w="9525">
+            <a:solidFill>
+              <a:srgbClr val="1F4E79"/>
+            </a:solidFill>
+          </a:ln>
+          <a:effectLst/>
+        </p:spPr>
+        <p:style>
+          <a:lnRef idx="1">
+            <a:schemeClr val="accent1"/>
+          </a:lnRef>
+          <a:fillRef idx="3">
+            <a:schemeClr val="accent1"/>
+          </a:fillRef>
+          <a:effectRef idx="2">
+            <a:schemeClr val="accent1"/>
+          </a:effectRef>
+          <a:fontRef idx="minor">
+            <a:schemeClr val="lt1"/>
+          </a:fontRef>
+        </p:style>
+        <p:txBody>
+          <a:bodyPr rtlCol="0" anchor="ctr" wrap="square" lIns="45720" rIns="45720" tIns="27432" bIns="27432"/>
+          <a:lstStyle/>
+          <a:p>
+            <a:pPr algn="ctr"/>
+            <a:r>
+              <a:rPr sz="1000" b="1">
+                <a:solidFill>
+                  <a:srgbClr val="FFFFFF"/>
+                </a:solidFill>
+                <a:latin typeface="맑은 고딕"/>
+                <a:ea typeface="맑은 고딕"/>
+              </a:rPr>
+              <a:t>근거 (시나리오·측정값)</a:t>
+            </a:r>
+          </a:p>
+        </p:txBody>
+      </p:sp>
+      <p:sp>
+        <p:nvSpPr>
+          <p:cNvPr id="61" name="Rectangle 60"/>
+          <p:cNvSpPr/>
+          <p:nvPr/>
+        </p:nvSpPr>
+        <p:spPr>
+          <a:xfrm>
+            <a:off x="365760" y="1371600"/>
+            <a:ext cx="2651760" cy="1737360"/>
           </a:xfrm>
           <a:prstGeom prst="rect">
             <a:avLst/>
@@ -7534,28 +8439,67 @@
           <a:p>
             <a:pPr algn="l"/>
             <a:r>
-              <a:rPr sz="1000" b="1">
+              <a:rPr sz="950" b="1">
                 <a:solidFill>
                   <a:srgbClr val="1A1A1A"/>
                 </a:solidFill>
                 <a:latin typeface="맑은 고딕"/>
                 <a:ea typeface="맑은 고딕"/>
               </a:rPr>
-              <a:t>접근이 쏠리는 정도(hotness)</a:t>
-            </a:r>
-          </a:p>
-        </p:txBody>
-      </p:sp>
-      <p:sp>
-        <p:nvSpPr>
-          <p:cNvPr id="64" name="Rectangle 63"/>
+              <a:t>QA3 자원 사용 (HBM)</a:t>
+            </a:r>
+          </a:p>
+          <a:p>
+            <a:pPr algn="l"/>
+            <a:r>
+              <a:rPr sz="950" b="1">
+                <a:solidFill>
+                  <a:srgbClr val="1A1A1A"/>
+                </a:solidFill>
+                <a:latin typeface="맑은 고딕"/>
+                <a:ea typeface="맑은 고딕"/>
+              </a:rPr>
+              <a:t>C1 x0.97 · C2 x1.21</a:t>
+            </a:r>
+          </a:p>
+          <a:p>
+            <a:pPr algn="l"/>
+            <a:r>
+              <a:rPr sz="950" b="1">
+                <a:solidFill>
+                  <a:srgbClr val="1A1A1A"/>
+                </a:solidFill>
+                <a:latin typeface="맑은 고딕"/>
+                <a:ea typeface="맑은 고딕"/>
+              </a:rPr>
+              <a:t>(HBM을 줄인/늘린 시나리오 C1 9/3, C2 1/1</a:t>
+            </a:r>
+          </a:p>
+          <a:p>
+            <a:pPr algn="l"/>
+            <a:r>
+              <a:rPr sz="950" b="1">
+                <a:solidFill>
+                  <a:srgbClr val="1A1A1A"/>
+                </a:solidFill>
+                <a:latin typeface="맑은 고딕"/>
+                <a:ea typeface="맑은 고딕"/>
+              </a:rPr>
+              <a:t>8)</a:t>
+            </a:r>
+          </a:p>
+        </p:txBody>
+      </p:sp>
+      <p:sp>
+        <p:nvSpPr>
+          <p:cNvPr id="62" name="Rectangle 61"/>
           <p:cNvSpPr/>
           <p:nvPr/>
         </p:nvSpPr>
         <p:spPr>
           <a:xfrm>
-            <a:off x="3017520" y="3465576"/>
-            <a:ext cx="8778240" cy="841248"/>
+            <a:off x="3017520" y="1371600"/>
+            <a:ext cx="5943600" cy="1737360"/>
           </a:xfrm>
           <a:prstGeom prst="rect">
             <a:avLst/>
@@ -7590,54 +8534,201 @@
           <a:p>
             <a:pPr algn="l"/>
             <a:r>
-              <a:rPr sz="1100" b="0">
+              <a:rPr sz="950" b="0">
                 <a:solidFill>
                   <a:srgbClr val="1A1A1A"/>
                 </a:solidFill>
                 <a:latin typeface="맑은 고딕"/>
                 <a:ea typeface="맑은 고딕"/>
               </a:rPr>
-              <a:t>소수만 인기 있는 skew · 거의 안 쓰이는 cold 데이터가 상위 메모리를 차지 · 갑자기 hot해지는 burst · hot/cold 급반전 · hot 대상이 옮겨 </a:t>
+              <a:t>- 이동은 데이터 총량을 바꾸지 않고 어느 메모리에 두느냐만 바꾼다. 그래서 전 메모리 합 점유는 후보와</a:t>
             </a:r>
           </a:p>
           <a:p>
             <a:pPr algn="l"/>
             <a:r>
-              <a:rPr sz="1100" b="0">
+              <a:rPr sz="950" b="0">
                 <a:solidFill>
                   <a:srgbClr val="1A1A1A"/>
                 </a:solidFill>
                 <a:latin typeface="맑은 고딕"/>
                 <a:ea typeface="맑은 고딕"/>
               </a:rPr>
-              <a:t>감(최근 세션으로 이동, 사용자 그룹이 번갈아 활성, 인기 검색 shard가 바뀜). 고르게 접근되는 전용 시나리오는 아직 없음(중간 KV 기준</a:t>
+              <a:t>무관하고, 'HBM에 얼마나 두는가'가 차이를 만든다.</a:t>
             </a:r>
           </a:p>
           <a:p>
             <a:pPr algn="l"/>
             <a:r>
-              <a:rPr sz="1100" b="0">
+              <a:rPr sz="950" b="0">
                 <a:solidFill>
                   <a:srgbClr val="1A1A1A"/>
                 </a:solidFill>
                 <a:latin typeface="맑은 고딕"/>
                 <a:ea typeface="맑은 고딕"/>
               </a:rPr>
-              <a:t>선이 대조군).</a:t>
-            </a:r>
-          </a:p>
-        </p:txBody>
-      </p:sp>
-      <p:sp>
-        <p:nvSpPr>
-          <p:cNvPr id="65" name="Rectangle 64"/>
+              <a:t>- C2는 성능을 위해 hot 데이터를 HBM으로 올려 HBM 사용이 늘어난다(비교 가능 21쌍 중 18쌍에서 증</a:t>
+            </a:r>
+          </a:p>
+          <a:p>
+            <a:pPr algn="l"/>
+            <a:r>
+              <a:rPr sz="950" b="0">
+                <a:solidFill>
+                  <a:srgbClr val="1A1A1A"/>
+                </a:solidFill>
+                <a:latin typeface="맑은 고딕"/>
+                <a:ea typeface="맑은 고딕"/>
+              </a:rPr>
+              <a:t>가). C1은 HBM 압박이 있으면 데이터를 내리고(HBM 감소), DRAM 링크가 포화로 보일 때는 DRAM에서 </a:t>
+            </a:r>
+          </a:p>
+          <a:p>
+            <a:pPr algn="l"/>
+            <a:r>
+              <a:rPr sz="950" b="0">
+                <a:solidFill>
+                  <a:srgbClr val="1A1A1A"/>
+                </a:solidFill>
+                <a:latin typeface="맑은 고딕"/>
+                <a:ea typeface="맑은 고딕"/>
+              </a:rPr>
+              <a:t>더 싼 HBF로 옮겨 HBM 사용을 늘리지 않는다.</a:t>
+            </a:r>
+          </a:p>
+          <a:p>
+            <a:pPr algn="l"/>
+            <a:r>
+              <a:rPr sz="950" b="0">
+                <a:solidFill>
+                  <a:srgbClr val="1A1A1A"/>
+                </a:solidFill>
+                <a:latin typeface="맑은 고딕"/>
+                <a:ea typeface="맑은 고딕"/>
+              </a:rPr>
+              <a:t>- 성능과 자원은 반대 방향이다: C2는 성능을 얻는 대신 HBM을 더 쓰고, C1은 덜 쓰되 성능 이득이 작다.</a:t>
+            </a:r>
+          </a:p>
+          <a:p>
+            <a:pPr algn="l"/>
+            <a:r>
+              <a:rPr sz="950" b="0">
+                <a:solidFill>
+                  <a:srgbClr val="1A1A1A"/>
+                </a:solidFill>
+                <a:latin typeface="맑은 고딕"/>
+                <a:ea typeface="맑은 고딕"/>
+              </a:rPr>
+              <a:t>- 보조 지표: 비용 가중 점유(DRAM 대비 상대 가격, ASSUMED) C1 x0.94, C2 x1.04로 같은 방향.</a:t>
+            </a:r>
+          </a:p>
+        </p:txBody>
+      </p:sp>
+      <p:sp>
+        <p:nvSpPr>
+          <p:cNvPr id="63" name="Rectangle 62"/>
           <p:cNvSpPr/>
           <p:nvPr/>
         </p:nvSpPr>
         <p:spPr>
           <a:xfrm>
-            <a:off x="365760" y="4352544"/>
-            <a:ext cx="2651760" cy="841248"/>
+            <a:off x="8961120" y="1371600"/>
+            <a:ext cx="2834640" cy="1737360"/>
+          </a:xfrm>
+          <a:prstGeom prst="rect">
+            <a:avLst/>
+          </a:prstGeom>
+          <a:solidFill>
+            <a:srgbClr val="F2F2F2"/>
+          </a:solidFill>
+          <a:ln w="9525">
+            <a:solidFill>
+              <a:srgbClr val="BFBFBF"/>
+            </a:solidFill>
+          </a:ln>
+          <a:effectLst/>
+        </p:spPr>
+        <p:style>
+          <a:lnRef idx="1">
+            <a:schemeClr val="accent1"/>
+          </a:lnRef>
+          <a:fillRef idx="3">
+            <a:schemeClr val="accent1"/>
+          </a:fillRef>
+          <a:effectRef idx="2">
+            <a:schemeClr val="accent1"/>
+          </a:effectRef>
+          <a:fontRef idx="minor">
+            <a:schemeClr val="lt1"/>
+          </a:fontRef>
+        </p:style>
+        <p:txBody>
+          <a:bodyPr rtlCol="0" anchor="ctr" wrap="square" lIns="45720" rIns="45720" tIns="27432" bIns="27432"/>
+          <a:lstStyle/>
+          <a:p>
+            <a:pPr algn="l"/>
+            <a:r>
+              <a:rPr sz="850" b="1">
+                <a:solidFill>
+                  <a:srgbClr val="404040"/>
+                </a:solidFill>
+                <a:latin typeface="맑은 고딕"/>
+                <a:ea typeface="맑은 고딕"/>
+              </a:rPr>
+              <a:t>cb_kv_8k_b32 (B200) HBM 사용: Baseline 72 GiB, C1 7</a:t>
+            </a:r>
+          </a:p>
+          <a:p>
+            <a:pPr algn="l"/>
+            <a:r>
+              <a:rPr sz="850" b="0">
+                <a:solidFill>
+                  <a:srgbClr val="404040"/>
+                </a:solidFill>
+                <a:latin typeface="맑은 고딕"/>
+                <a:ea typeface="맑은 고딕"/>
+              </a:rPr>
+              <a:t>2, C2 98</a:t>
+            </a:r>
+          </a:p>
+          <a:p>
+            <a:pPr algn="l"/>
+            <a:r>
+              <a:rPr sz="850" b="0">
+                <a:solidFill>
+                  <a:srgbClr val="404040"/>
+                </a:solidFill>
+                <a:latin typeface="맑은 고딕"/>
+                <a:ea typeface="맑은 고딕"/>
+              </a:rPr>
+              <a:t>정의 이력: 활용률 -&gt; 풀 -&gt; 성능÷비용 -&gt; HBM 사용량. 마</a:t>
+            </a:r>
+          </a:p>
+          <a:p>
+            <a:pPr algn="l"/>
+            <a:r>
+              <a:rPr sz="850" b="0">
+                <a:solidFill>
+                  <a:srgbClr val="404040"/>
+                </a:solidFill>
+                <a:latin typeface="맑은 고딕"/>
+                <a:ea typeface="맑은 고딕"/>
+              </a:rPr>
+              <a:t>지막 변경으로 선택이 C2에서 C1로 바뀜</a:t>
+            </a:r>
+          </a:p>
+        </p:txBody>
+      </p:sp>
+      <p:sp>
+        <p:nvSpPr>
+          <p:cNvPr id="64" name="Rectangle 63"/>
+          <p:cNvSpPr/>
+          <p:nvPr/>
+        </p:nvSpPr>
+        <p:spPr>
+          <a:xfrm>
+            <a:off x="365760" y="3154680"/>
+            <a:ext cx="2651760" cy="1600200"/>
           </a:xfrm>
           <a:prstGeom prst="rect">
             <a:avLst/>
@@ -7672,28 +8763,67 @@
           <a:p>
             <a:pPr algn="l"/>
             <a:r>
-              <a:rPr sz="1000" b="1">
+              <a:rPr sz="950" b="1">
                 <a:solidFill>
                   <a:srgbClr val="1A1A1A"/>
                 </a:solidFill>
                 <a:latin typeface="맑은 고딕"/>
                 <a:ea typeface="맑은 고딕"/>
               </a:rPr>
-              <a:t>자원 조건이 바뀌는 경우</a:t>
-            </a:r>
-          </a:p>
-        </p:txBody>
-      </p:sp>
-      <p:sp>
-        <p:nvSpPr>
-          <p:cNvPr id="66" name="Rectangle 65"/>
+              <a:t>QA4 확장성</a:t>
+            </a:r>
+          </a:p>
+          <a:p>
+            <a:pPr algn="l"/>
+            <a:r>
+              <a:rPr sz="950" b="1">
+                <a:solidFill>
+                  <a:srgbClr val="1A1A1A"/>
+                </a:solidFill>
+                <a:latin typeface="맑은 고딕"/>
+                <a:ea typeface="맑은 고딕"/>
+              </a:rPr>
+              <a:t>C1 module 1.75 · C2 2.50</a:t>
+            </a:r>
+          </a:p>
+          <a:p>
+            <a:pPr algn="l"/>
+            <a:r>
+              <a:rPr sz="950" b="1">
+                <a:solidFill>
+                  <a:srgbClr val="1A1A1A"/>
+                </a:solidFill>
+                <a:latin typeface="맑은 고딕"/>
+                <a:ea typeface="맑은 고딕"/>
+              </a:rPr>
+              <a:t>공수 0.38 vs 0.51 MM</a:t>
+            </a:r>
+          </a:p>
+          <a:p>
+            <a:pPr algn="l"/>
+            <a:r>
+              <a:rPr sz="950" b="1">
+                <a:solidFill>
+                  <a:srgbClr val="1A1A1A"/>
+                </a:solidFill>
+                <a:latin typeface="맑은 고딕"/>
+                <a:ea typeface="맑은 고딕"/>
+              </a:rPr>
+              <a:t>에이전트 비용 $1.16 vs $1.49</a:t>
+            </a:r>
+          </a:p>
+        </p:txBody>
+      </p:sp>
+      <p:sp>
+        <p:nvSpPr>
+          <p:cNvPr id="65" name="Rectangle 64"/>
           <p:cNvSpPr/>
           <p:nvPr/>
         </p:nvSpPr>
         <p:spPr>
           <a:xfrm>
-            <a:off x="3017520" y="4352544"/>
-            <a:ext cx="8778240" cy="841248"/>
+            <a:off x="3017520" y="3154680"/>
+            <a:ext cx="5943600" cy="1600200"/>
           </a:xfrm>
           <a:prstGeom prst="rect">
             <a:avLst/>
@@ -7728,27 +8858,174 @@
           <a:p>
             <a:pPr algn="l"/>
             <a:r>
-              <a:rPr sz="1100" b="0">
+              <a:rPr sz="950" b="0">
                 <a:solidFill>
                   <a:srgbClr val="1A1A1A"/>
                 </a:solidFill>
                 <a:latin typeface="맑은 고딕"/>
                 <a:ea typeface="맑은 고딕"/>
               </a:rPr>
-              <a:t>HBM 용량 압박(고정 / 점진 증가) · HBM 대역폭 급락 · 다른 작업과 공유하는 host 링크 경합(대역폭 25%로 저하) · 6개 메모리 용량을 모</a:t>
+              <a:t>- 변경 시나리오 4종(새 메모리, 새 데이터 종류, 정책 교체, 새 event)을 시뮬레이터 복사본에 실제로 구</a:t>
             </a:r>
           </a:p>
           <a:p>
             <a:pPr algn="l"/>
             <a:r>
-              <a:rPr sz="1100" b="0">
+              <a:rPr sz="950" b="0">
                 <a:solidFill>
                   <a:srgbClr val="1A1A1A"/>
                 </a:solidFill>
                 <a:latin typeface="맑은 고딕"/>
                 <a:ea typeface="맑은 고딕"/>
               </a:rPr>
-              <a:t>두 써야 하는 큰 용량 부담.</a:t>
+              <a:t>현해 module 수를 쟀다.</a:t>
+            </a:r>
+          </a:p>
+          <a:p>
+            <a:pPr algn="l"/>
+            <a:r>
+              <a:rPr sz="950" b="0">
+                <a:solidFill>
+                  <a:srgbClr val="1A1A1A"/>
+                </a:solidFill>
+                <a:latin typeface="맑은 고딕"/>
+                <a:ea typeface="맑은 고딕"/>
+              </a:rPr>
+              <a:t>- C1은 데이터 종류를 모르는 구조라 새 데이터 종류를 추가해도 고칠 곳이 거의 없다. C2는 종류별 특성</a:t>
+            </a:r>
+          </a:p>
+          <a:p>
+            <a:pPr algn="l"/>
+            <a:r>
+              <a:rPr sz="950" b="0">
+                <a:solidFill>
+                  <a:srgbClr val="1A1A1A"/>
+                </a:solidFill>
+                <a:latin typeface="맑은 고딕"/>
+                <a:ea typeface="맑은 고딕"/>
+              </a:rPr>
+              <a:t>과 선호 목록을 알고 있어 새 데이터 종류는 module 3개, 새 메모리는 선호 목록에 올려야 쓰이므로 2개</a:t>
+            </a:r>
+          </a:p>
+          <a:p>
+            <a:pPr algn="l"/>
+            <a:r>
+              <a:rPr sz="950" b="0">
+                <a:solidFill>
+                  <a:srgbClr val="1A1A1A"/>
+                </a:solidFill>
+                <a:latin typeface="맑은 고딕"/>
+                <a:ea typeface="맑은 고딕"/>
+              </a:rPr>
+              <a:t>를 고친다.</a:t>
+            </a:r>
+          </a:p>
+          <a:p>
+            <a:pPr algn="l"/>
+            <a:r>
+              <a:rPr sz="950" b="0">
+                <a:solidFill>
+                  <a:srgbClr val="1A1A1A"/>
+                </a:solidFill>
+                <a:latin typeface="맑은 고딕"/>
+                <a:ea typeface="맑은 고딕"/>
+              </a:rPr>
+              <a:t>- 정책 교체와 새 event 추가는 두 후보가 같다(공유 module). 공수·비용은 가정 상수로 계산한 추정이다.</a:t>
+            </a:r>
+          </a:p>
+        </p:txBody>
+      </p:sp>
+      <p:sp>
+        <p:nvSpPr>
+          <p:cNvPr id="66" name="Rectangle 65"/>
+          <p:cNvSpPr/>
+          <p:nvPr/>
+        </p:nvSpPr>
+        <p:spPr>
+          <a:xfrm>
+            <a:off x="8961120" y="3154680"/>
+            <a:ext cx="2834640" cy="1600200"/>
+          </a:xfrm>
+          <a:prstGeom prst="rect">
+            <a:avLst/>
+          </a:prstGeom>
+          <a:solidFill>
+            <a:srgbClr val="F2F2F2"/>
+          </a:solidFill>
+          <a:ln w="9525">
+            <a:solidFill>
+              <a:srgbClr val="BFBFBF"/>
+            </a:solidFill>
+          </a:ln>
+          <a:effectLst/>
+        </p:spPr>
+        <p:style>
+          <a:lnRef idx="1">
+            <a:schemeClr val="accent1"/>
+          </a:lnRef>
+          <a:fillRef idx="3">
+            <a:schemeClr val="accent1"/>
+          </a:fillRef>
+          <a:effectRef idx="2">
+            <a:schemeClr val="accent1"/>
+          </a:effectRef>
+          <a:fontRef idx="minor">
+            <a:schemeClr val="lt1"/>
+          </a:fontRef>
+        </p:style>
+        <p:txBody>
+          <a:bodyPr rtlCol="0" anchor="ctr" wrap="square" lIns="45720" rIns="45720" tIns="27432" bIns="27432"/>
+          <a:lstStyle/>
+          <a:p>
+            <a:pPr algn="l"/>
+            <a:r>
+              <a:rPr sz="850" b="1">
+                <a:solidFill>
+                  <a:srgbClr val="404040"/>
+                </a:solidFill>
+                <a:latin typeface="맑은 고딕"/>
+                <a:ea typeface="맑은 고딕"/>
+              </a:rPr>
+              <a:t>새 메모리: C1 1 / C2 2</a:t>
+            </a:r>
+          </a:p>
+          <a:p>
+            <a:pPr algn="l"/>
+            <a:r>
+              <a:rPr sz="850" b="0">
+                <a:solidFill>
+                  <a:srgbClr val="404040"/>
+                </a:solidFill>
+                <a:latin typeface="맑은 고딕"/>
+                <a:ea typeface="맑은 고딕"/>
+              </a:rPr>
+              <a:t>새 데이터 종류: C1 1 / C2 3</a:t>
+            </a:r>
+          </a:p>
+          <a:p>
+            <a:pPr algn="l"/>
+            <a:r>
+              <a:rPr sz="850" b="0">
+                <a:solidFill>
+                  <a:srgbClr val="404040"/>
+                </a:solidFill>
+                <a:latin typeface="맑은 고딕"/>
+                <a:ea typeface="맑은 고딕"/>
+              </a:rPr>
+              <a:t>정책 교체: 2 / 2</a:t>
+            </a:r>
+          </a:p>
+          <a:p>
+            <a:pPr algn="l"/>
+            <a:r>
+              <a:rPr sz="850" b="0">
+                <a:solidFill>
+                  <a:srgbClr val="404040"/>
+                </a:solidFill>
+                <a:latin typeface="맑은 고딕"/>
+                <a:ea typeface="맑은 고딕"/>
+              </a:rPr>
+              <a:t>새 event: 3 / 3</a:t>
             </a:r>
           </a:p>
         </p:txBody>
@@ -7761,8 +9038,8 @@
         </p:nvSpPr>
         <p:spPr>
           <a:xfrm>
-            <a:off x="365760" y="5239512"/>
-            <a:ext cx="2651760" cy="841248"/>
+            <a:off x="365760" y="4800600"/>
+            <a:ext cx="2651760" cy="1005840"/>
           </a:xfrm>
           <a:prstGeom prst="rect">
             <a:avLst/>
@@ -7797,27 +9074,27 @@
           <a:p>
             <a:pPr algn="l"/>
             <a:r>
-              <a:rPr sz="1000" b="1">
+              <a:rPr sz="950" b="1">
                 <a:solidFill>
                   <a:srgbClr val="1A1A1A"/>
                 </a:solidFill>
                 <a:latin typeface="맑은 고딕"/>
                 <a:ea typeface="맑은 고딕"/>
               </a:rPr>
-              <a:t>처음엔 문제없다가 나빠지는 경우 (Dynami</a:t>
+              <a:t>결론: trade-off</a:t>
             </a:r>
           </a:p>
           <a:p>
             <a:pPr algn="l"/>
             <a:r>
-              <a:rPr sz="1000" b="1">
+              <a:rPr sz="950" b="1">
                 <a:solidFill>
                   <a:srgbClr val="1A1A1A"/>
                 </a:solidFill>
                 <a:latin typeface="맑은 고딕"/>
                 <a:ea typeface="맑은 고딕"/>
               </a:rPr>
-              <a:t>c 6개)</a:t>
+              <a:t>성능 C2, 자원·확장성 C1</a:t>
             </a:r>
           </a:p>
         </p:txBody>
@@ -7830,8 +9107,8 @@
         </p:nvSpPr>
         <p:spPr>
           <a:xfrm>
-            <a:off x="3017520" y="5239512"/>
-            <a:ext cx="8778240" cy="841248"/>
+            <a:off x="3017520" y="4800600"/>
+            <a:ext cx="5943600" cy="1005840"/>
           </a:xfrm>
           <a:prstGeom prst="rect">
             <a:avLst/>
@@ -7866,20 +9143,1078 @@
           <a:p>
             <a:pPr algn="l"/>
             <a:r>
-              <a:rPr sz="1100" b="0">
+              <a:rPr sz="950" b="0">
                 <a:solidFill>
                   <a:srgbClr val="1A1A1A"/>
                 </a:solidFill>
                 <a:latin typeface="맑은 고딕"/>
                 <a:ea typeface="맑은 고딕"/>
               </a:rPr>
+              <a:t>- C2는 처리량(x1.42)과 지연에서 앞서는 대신 HBM을 더 쓰고(x1.21) 구조 변경 비용이 크다. C1은 반대</a:t>
+            </a:r>
+          </a:p>
+          <a:p>
+            <a:pPr algn="l"/>
+            <a:r>
+              <a:rPr sz="950" b="0">
+                <a:solidFill>
+                  <a:srgbClr val="1A1A1A"/>
+                </a:solidFill>
+                <a:latin typeface="맑은 고딕"/>
+                <a:ea typeface="맑은 고딕"/>
+              </a:rPr>
+              <a:t>다.</a:t>
+            </a:r>
+          </a:p>
+          <a:p>
+            <a:pPr algn="l"/>
+            <a:r>
+              <a:rPr sz="950" b="0">
+                <a:solidFill>
+                  <a:srgbClr val="1A1A1A"/>
+                </a:solidFill>
+                <a:latin typeface="맑은 고딕"/>
+                <a:ea typeface="맑은 고딕"/>
+              </a:rPr>
+              <a:t>- 별 합계는 C1 10, C2 9로 근소해 선택(C1)은 별 경계와 QA 정의에 민감하다.</a:t>
+            </a:r>
+          </a:p>
+        </p:txBody>
+      </p:sp>
+      <p:sp>
+        <p:nvSpPr>
+          <p:cNvPr id="69" name="Rectangle 68"/>
+          <p:cNvSpPr/>
+          <p:nvPr/>
+        </p:nvSpPr>
+        <p:spPr>
+          <a:xfrm>
+            <a:off x="8961120" y="4800600"/>
+            <a:ext cx="2834640" cy="1005840"/>
+          </a:xfrm>
+          <a:prstGeom prst="rect">
+            <a:avLst/>
+          </a:prstGeom>
+          <a:solidFill>
+            <a:srgbClr val="F2F2F2"/>
+          </a:solidFill>
+          <a:ln w="9525">
+            <a:solidFill>
+              <a:srgbClr val="BFBFBF"/>
+            </a:solidFill>
+          </a:ln>
+          <a:effectLst/>
+        </p:spPr>
+        <p:style>
+          <a:lnRef idx="1">
+            <a:schemeClr val="accent1"/>
+          </a:lnRef>
+          <a:fillRef idx="3">
+            <a:schemeClr val="accent1"/>
+          </a:fillRef>
+          <a:effectRef idx="2">
+            <a:schemeClr val="accent1"/>
+          </a:effectRef>
+          <a:fontRef idx="minor">
+            <a:schemeClr val="lt1"/>
+          </a:fontRef>
+        </p:style>
+        <p:txBody>
+          <a:bodyPr rtlCol="0" anchor="ctr" wrap="square" lIns="45720" rIns="45720" tIns="27432" bIns="27432"/>
+          <a:lstStyle/>
+          <a:p>
+            <a:pPr algn="l"/>
+            <a:r>
+              <a:rPr sz="850" b="1">
+                <a:solidFill>
+                  <a:srgbClr val="404040"/>
+                </a:solidFill>
+                <a:latin typeface="맑은 고딕"/>
+                <a:ea typeface="맑은 고딕"/>
+              </a:rPr>
+              <a:t>TTFT P99: C1 개선 없음, C2 x0.72</a:t>
+            </a:r>
+          </a:p>
+          <a:p>
+            <a:pPr algn="l"/>
+            <a:r>
+              <a:rPr sz="850" b="0">
+                <a:solidFill>
+                  <a:srgbClr val="404040"/>
+                </a:solidFill>
+                <a:latin typeface="맑은 고딕"/>
+                <a:ea typeface="맑은 고딕"/>
+              </a:rPr>
+              <a:t>TPOT: 두 후보 모두 거의 불변</a:t>
+            </a:r>
+          </a:p>
+        </p:txBody>
+      </p:sp>
+    </p:spTree>
+  </p:cSld>
+  <p:clrMapOvr>
+    <a:masterClrMapping/>
+  </p:clrMapOvr>
+</p:sld>
+</file>
+
+<file path=ppt/slides/slide21.xml><?xml version="1.0" encoding="utf-8"?>
+<p:sld xmlns:a="http://schemas.openxmlformats.org/drawingml/2006/main" xmlns:p="http://schemas.openxmlformats.org/presentationml/2006/main" xmlns:r="http://schemas.openxmlformats.org/officeDocument/2006/relationships">
+  <p:cSld>
+    <p:spTree>
+      <p:nvGrpSpPr>
+        <p:cNvPr id="1" name=""/>
+        <p:cNvGrpSpPr/>
+        <p:nvPr/>
+      </p:nvGrpSpPr>
+      <p:grpSpPr/>
+      <p:sp>
+        <p:nvSpPr>
+          <p:cNvPr id="3" name="제목 2"/>
+          <p:cNvSpPr>
+            <a:spLocks noGrp="1"/>
+          </p:cNvSpPr>
+          <p:nvPr>
+            <p:ph type="title"/>
+          </p:nvPr>
+        </p:nvSpPr>
+        <p:spPr>
+          <a:xfrm>
+            <a:off x="234949" y="137379"/>
+            <a:ext cx="7631530" cy="365125"/>
+          </a:xfrm>
+        </p:spPr>
+        <p:txBody>
+          <a:bodyPr/>
+          <a:lstStyle/>
+          <a:p>
+            <a:r>
+              <a:rPr lang="en-US" altLang="ko-KR" dirty="0"/>
+              <a:t>DP1. 이기종 메모리 기반 Data Migration 구조 - Appendix</a:t>
+            </a:r>
+            <a:r>
+              <a:rPr lang="ko-KR" altLang="en-US" dirty="0"/>
+              <a:t/>
+            </a:r>
+            <a:r>
+              <a:rPr lang="en-US" altLang="ko-KR" dirty="0"/>
+              <a:t/>
+            </a:r>
+            <a:r>
+              <a:rPr lang="ko-KR" altLang="en-US" dirty="0"/>
+              <a:t/>
+            </a:r>
+            <a:r>
+              <a:rPr lang="en-US" altLang="ko-KR" dirty="0"/>
+              <a:t/>
+            </a:r>
+            <a:r>
+              <a:rPr lang="ko-KR" altLang="en-US" dirty="0"/>
+              <a:t/>
+            </a:r>
+          </a:p>
+        </p:txBody>
+      </p:sp>
+      <p:sp>
+        <p:nvSpPr>
+          <p:cNvPr id="5" name="직사각형 4"/>
+          <p:cNvSpPr/>
+          <p:nvPr/>
+        </p:nvSpPr>
+        <p:spPr>
+          <a:xfrm>
+            <a:off x="234949" y="596176"/>
+            <a:ext cx="11747501" cy="396603"/>
+          </a:xfrm>
+          <a:prstGeom prst="rect">
+            <a:avLst/>
+          </a:prstGeom>
+          <a:solidFill>
+            <a:schemeClr val="bg1">
+              <a:lumMod val="50000"/>
+            </a:schemeClr>
+          </a:solidFill>
+          <a:ln>
+            <a:noFill/>
+          </a:ln>
+        </p:spPr>
+        <p:style>
+          <a:lnRef idx="2">
+            <a:schemeClr val="accent1">
+              <a:shade val="50000"/>
+            </a:schemeClr>
+          </a:lnRef>
+          <a:fillRef idx="1">
+            <a:schemeClr val="accent1"/>
+          </a:fillRef>
+          <a:effectRef idx="0">
+            <a:schemeClr val="accent1"/>
+          </a:effectRef>
+          <a:fontRef idx="minor">
+            <a:schemeClr val="lt1"/>
+          </a:fontRef>
+        </p:style>
+        <p:txBody>
+          <a:bodyPr rtlCol="0" anchor="ctr"/>
+          <a:lstStyle/>
+          <a:p>
+            <a:pPr algn="ctr"/>
+            <a:endParaRPr lang="ko-KR" altLang="en-US"/>
+          </a:p>
+        </p:txBody>
+      </p:sp>
+      <p:sp>
+        <p:nvSpPr>
+          <p:cNvPr id="8" name="TextBox 7"/>
+          <p:cNvSpPr txBox="1"/>
+          <p:nvPr/>
+        </p:nvSpPr>
+        <p:spPr>
+          <a:xfrm>
+            <a:off x="469760" y="627926"/>
+            <a:ext cx="11430000" cy="307777"/>
+          </a:xfrm>
+          <a:prstGeom prst="rect">
+            <a:avLst/>
+          </a:prstGeom>
+          <a:noFill/>
+        </p:spPr>
+        <p:txBody>
+          <a:bodyPr wrap="square" rtlCol="0">
+            <a:spAutoFit/>
+          </a:bodyPr>
+          <a:lstStyle/>
+          <a:p>
+            <a:pPr lvl="0">
+              <a:defRPr/>
+            </a:pPr>
+            <a:r>
+              <a:rPr lang="ko-KR" altLang="en-US" sz="1400" b="1" dirty="0">
+                <a:solidFill>
+                  <a:schemeClr val="bg1"/>
+                </a:solidFill>
+              </a:rPr>
+              <a:t>DP1 평가에서 고려한 시나리오</a:t>
+            </a:r>
+            <a:r>
+              <a:rPr lang="en-US" altLang="ko-KR" sz="1400" b="1" dirty="0">
+                <a:solidFill>
+                  <a:schemeClr val="bg1"/>
+                </a:solidFill>
+              </a:rPr>
+              <a:t/>
+            </a:r>
+            <a:r>
+              <a:rPr lang="ko-KR" altLang="en-US" sz="1400" b="1" dirty="0">
+                <a:solidFill>
+                  <a:schemeClr val="bg1"/>
+                </a:solidFill>
+              </a:rPr>
+              <a:t/>
+            </a:r>
+            <a:r>
+              <a:rPr lang="en-US" altLang="ko-KR" sz="1400" b="1" dirty="0">
+                <a:solidFill>
+                  <a:schemeClr val="bg1"/>
+                </a:solidFill>
+              </a:rPr>
+              <a:t/>
+            </a:r>
+            <a:r>
+              <a:rPr lang="ko-KR" altLang="en-US" sz="1400" b="1" dirty="0">
+                <a:solidFill>
+                  <a:schemeClr val="bg1"/>
+                </a:solidFill>
+              </a:rPr>
+              <a:t/>
+            </a:r>
+          </a:p>
+        </p:txBody>
+      </p:sp>
+      <p:sp>
+        <p:nvSpPr>
+          <p:cNvPr id="39" name="직사각형 38"/>
+          <p:cNvSpPr/>
+          <p:nvPr/>
+        </p:nvSpPr>
+        <p:spPr>
+          <a:xfrm>
+            <a:off x="403086" y="678726"/>
+            <a:ext cx="66675" cy="216270"/>
+          </a:xfrm>
+          <a:prstGeom prst="rect">
+            <a:avLst/>
+          </a:prstGeom>
+          <a:solidFill>
+            <a:schemeClr val="bg1"/>
+          </a:solidFill>
+          <a:ln w="19050">
+            <a:noFill/>
+          </a:ln>
+        </p:spPr>
+        <p:style>
+          <a:lnRef idx="2">
+            <a:schemeClr val="accent1">
+              <a:shade val="50000"/>
+            </a:schemeClr>
+          </a:lnRef>
+          <a:fillRef idx="1">
+            <a:schemeClr val="accent1"/>
+          </a:fillRef>
+          <a:effectRef idx="0">
+            <a:schemeClr val="accent1"/>
+          </a:effectRef>
+          <a:fontRef idx="minor">
+            <a:schemeClr val="lt1"/>
+          </a:fontRef>
+        </p:style>
+        <p:txBody>
+          <a:bodyPr rtlCol="0" anchor="ctr"/>
+          <a:lstStyle/>
+          <a:p>
+            <a:pPr algn="ctr"/>
+            <a:endParaRPr lang="ko-KR" altLang="en-US" sz="1600"/>
+          </a:p>
+        </p:txBody>
+      </p:sp>
+      <p:sp>
+        <p:nvSpPr>
+          <p:cNvPr id="57" name="슬라이드 번호 개체 틀 1"/>
+          <p:cNvSpPr>
+            <a:spLocks noGrp="1"/>
+          </p:cNvSpPr>
+          <p:nvPr>
+            <p:ph type="sldNum" sz="quarter" idx="4"/>
+          </p:nvPr>
+        </p:nvSpPr>
+        <p:spPr>
+          <a:xfrm>
+            <a:off x="5620080" y="6597650"/>
+            <a:ext cx="456466" cy="209550"/>
+          </a:xfrm>
+        </p:spPr>
+        <p:txBody>
+          <a:bodyPr/>
+          <a:lstStyle/>
+          <a:p>
+            <a:fld id="{7F889C64-266A-4D07-AD8F-5B592E61CCE1}" type="slidenum">
+              <a:rPr lang="ko-KR" altLang="en-US" smtClean="0"/>
+              <a:pPr/>
+              <a:t>9</a:t>
+            </a:fld>
+            <a:endParaRPr lang="ko-KR" altLang="en-US" dirty="0"/>
+          </a:p>
+        </p:txBody>
+      </p:sp>
+      <p:sp>
+        <p:nvSpPr>
+          <p:cNvPr id="58" name="Rectangle 57"/>
+          <p:cNvSpPr/>
+          <p:nvPr/>
+        </p:nvSpPr>
+        <p:spPr>
+          <a:xfrm>
+            <a:off x="365760" y="1097280"/>
+            <a:ext cx="11430000" cy="548640"/>
+          </a:xfrm>
+          <a:prstGeom prst="rect">
+            <a:avLst/>
+          </a:prstGeom>
+          <a:solidFill>
+            <a:srgbClr val="F2F2F2"/>
+          </a:solidFill>
+          <a:ln w="9525">
+            <a:solidFill>
+              <a:srgbClr val="BFBFBF"/>
+            </a:solidFill>
+          </a:ln>
+          <a:effectLst/>
+        </p:spPr>
+        <p:style>
+          <a:lnRef idx="1">
+            <a:schemeClr val="accent1"/>
+          </a:lnRef>
+          <a:fillRef idx="3">
+            <a:schemeClr val="accent1"/>
+          </a:fillRef>
+          <a:effectRef idx="2">
+            <a:schemeClr val="accent1"/>
+          </a:effectRef>
+          <a:fontRef idx="minor">
+            <a:schemeClr val="lt1"/>
+          </a:fontRef>
+        </p:style>
+        <p:txBody>
+          <a:bodyPr rtlCol="0" anchor="t" wrap="square" lIns="45720" rIns="45720" tIns="27432" bIns="27432"/>
+          <a:lstStyle/>
+          <a:p>
+            <a:pPr algn="l"/>
+            <a:r>
+              <a:rPr sz="1000" b="1">
+                <a:solidFill>
+                  <a:srgbClr val="404040"/>
+                </a:solidFill>
+                <a:latin typeface="맑은 고딕"/>
+                <a:ea typeface="맑은 고딕"/>
+              </a:rPr>
+              <a:t>32개 시나리오를 H100과 B200에 각각 돌렸다(64쌍). Common 3개 (쌍: 비교 5, 포화 1, 불가 0) · DP1 Stress 23개 (쌍: 비교 8, 포화 9, 불가 29) · DP1 Dynamic 6개 (쌍: 비교 8, 포화 0, 불가 </a:t>
+            </a:r>
+          </a:p>
+          <a:p>
+            <a:pPr algn="l"/>
+            <a:r>
+              <a:rPr sz="1000" b="0">
+                <a:solidFill>
+                  <a:srgbClr val="404040"/>
+                </a:solidFill>
+                <a:latin typeface="맑은 고딕"/>
+                <a:ea typeface="맑은 고딕"/>
+              </a:rPr>
+              <a:t>4). 비교 불가 쌍은 결과에서 빼지 않고 별도 표시했다.</a:t>
+            </a:r>
+          </a:p>
+        </p:txBody>
+      </p:sp>
+      <p:sp>
+        <p:nvSpPr>
+          <p:cNvPr id="59" name="Rectangle 58"/>
+          <p:cNvSpPr/>
+          <p:nvPr/>
+        </p:nvSpPr>
+        <p:spPr>
+          <a:xfrm>
+            <a:off x="365760" y="1737360"/>
+            <a:ext cx="2651760" cy="841248"/>
+          </a:xfrm>
+          <a:prstGeom prst="rect">
+            <a:avLst/>
+          </a:prstGeom>
+          <a:solidFill>
+            <a:srgbClr val="DCE9F5"/>
+          </a:solidFill>
+          <a:ln w="9525">
+            <a:solidFill>
+              <a:srgbClr val="4D7EA8"/>
+            </a:solidFill>
+          </a:ln>
+          <a:effectLst/>
+        </p:spPr>
+        <p:style>
+          <a:lnRef idx="1">
+            <a:schemeClr val="accent1"/>
+          </a:lnRef>
+          <a:fillRef idx="3">
+            <a:schemeClr val="accent1"/>
+          </a:fillRef>
+          <a:effectRef idx="2">
+            <a:schemeClr val="accent1"/>
+          </a:effectRef>
+          <a:fontRef idx="minor">
+            <a:schemeClr val="lt1"/>
+          </a:fontRef>
+        </p:style>
+        <p:txBody>
+          <a:bodyPr rtlCol="0" anchor="ctr" wrap="square" lIns="45720" rIns="45720" tIns="27432" bIns="27432"/>
+          <a:lstStyle/>
+          <a:p>
+            <a:pPr algn="l"/>
+            <a:r>
+              <a:rPr sz="1000" b="1">
+                <a:solidFill>
+                  <a:srgbClr val="1A1A1A"/>
+                </a:solidFill>
+                <a:latin typeface="맑은 고딕"/>
+                <a:ea typeface="맑은 고딕"/>
+              </a:rPr>
+              <a:t>기본 서비스 상황 (공통)</a:t>
+            </a:r>
+          </a:p>
+        </p:txBody>
+      </p:sp>
+      <p:sp>
+        <p:nvSpPr>
+          <p:cNvPr id="60" name="Rectangle 59"/>
+          <p:cNvSpPr/>
+          <p:nvPr/>
+        </p:nvSpPr>
+        <p:spPr>
+          <a:xfrm>
+            <a:off x="3017520" y="1737360"/>
+            <a:ext cx="8778240" cy="841248"/>
+          </a:xfrm>
+          <a:prstGeom prst="rect">
+            <a:avLst/>
+          </a:prstGeom>
+          <a:solidFill>
+            <a:srgbClr val="FFFFFF"/>
+          </a:solidFill>
+          <a:ln w="9525">
+            <a:solidFill>
+              <a:srgbClr val="BFBFBF"/>
+            </a:solidFill>
+          </a:ln>
+          <a:effectLst/>
+        </p:spPr>
+        <p:style>
+          <a:lnRef idx="1">
+            <a:schemeClr val="accent1"/>
+          </a:lnRef>
+          <a:fillRef idx="3">
+            <a:schemeClr val="accent1"/>
+          </a:fillRef>
+          <a:effectRef idx="2">
+            <a:schemeClr val="accent1"/>
+          </a:effectRef>
+          <a:fontRef idx="minor">
+            <a:schemeClr val="lt1"/>
+          </a:fontRef>
+        </p:style>
+        <p:txBody>
+          <a:bodyPr rtlCol="0" anchor="ctr" wrap="square" lIns="45720" rIns="45720" tIns="27432" bIns="27432"/>
+          <a:lstStyle/>
+          <a:p>
+            <a:pPr algn="l"/>
+            <a:r>
+              <a:rPr sz="1050" b="0">
+                <a:solidFill>
+                  <a:srgbClr val="1A1A1A"/>
+                </a:solidFill>
+                <a:latin typeface="맑은 고딕"/>
+                <a:ea typeface="맑은 고딕"/>
+              </a:rPr>
+              <a:t>8K 토큰 입력, 256 토큰 생성, 동시 32 요청의 대화 서비스. HBM이 빠듯한 경우 / 시간이 갈수록 여유가 줄어드는 경우 / KV cache에 Lo</a:t>
+            </a:r>
+          </a:p>
+          <a:p>
+            <a:pPr algn="l"/>
+            <a:r>
+              <a:rPr sz="1050" b="0">
+                <a:solidFill>
+                  <a:srgbClr val="1A1A1A"/>
+                </a:solidFill>
+                <a:latin typeface="맑은 고딕"/>
+                <a:ea typeface="맑은 고딕"/>
+              </a:rPr>
+              <a:t>RA·MoE·Agent 데이터가 섞이는 경우. 결과: 두 후보 모두 처리량은 Baseline과 같다.</a:t>
+            </a:r>
+          </a:p>
+        </p:txBody>
+      </p:sp>
+      <p:sp>
+        <p:nvSpPr>
+          <p:cNvPr id="61" name="Rectangle 60"/>
+          <p:cNvSpPr/>
+          <p:nvPr/>
+        </p:nvSpPr>
+        <p:spPr>
+          <a:xfrm>
+            <a:off x="365760" y="2624328"/>
+            <a:ext cx="2651760" cy="841248"/>
+          </a:xfrm>
+          <a:prstGeom prst="rect">
+            <a:avLst/>
+          </a:prstGeom>
+          <a:solidFill>
+            <a:srgbClr val="DCE9F5"/>
+          </a:solidFill>
+          <a:ln w="9525">
+            <a:solidFill>
+              <a:srgbClr val="4D7EA8"/>
+            </a:solidFill>
+          </a:ln>
+          <a:effectLst/>
+        </p:spPr>
+        <p:style>
+          <a:lnRef idx="1">
+            <a:schemeClr val="accent1"/>
+          </a:lnRef>
+          <a:fillRef idx="3">
+            <a:schemeClr val="accent1"/>
+          </a:fillRef>
+          <a:effectRef idx="2">
+            <a:schemeClr val="accent1"/>
+          </a:effectRef>
+          <a:fontRef idx="minor">
+            <a:schemeClr val="lt1"/>
+          </a:fontRef>
+        </p:style>
+        <p:txBody>
+          <a:bodyPr rtlCol="0" anchor="ctr" wrap="square" lIns="45720" rIns="45720" tIns="27432" bIns="27432"/>
+          <a:lstStyle/>
+          <a:p>
+            <a:pPr algn="l"/>
+            <a:r>
+              <a:rPr sz="1000" b="1">
+                <a:solidFill>
+                  <a:srgbClr val="1A1A1A"/>
+                </a:solidFill>
+                <a:latin typeface="맑은 고딕"/>
+                <a:ea typeface="맑은 고딕"/>
+              </a:rPr>
+              <a:t>데이터 종류별</a:t>
+            </a:r>
+          </a:p>
+        </p:txBody>
+      </p:sp>
+      <p:sp>
+        <p:nvSpPr>
+          <p:cNvPr id="62" name="Rectangle 61"/>
+          <p:cNvSpPr/>
+          <p:nvPr/>
+        </p:nvSpPr>
+        <p:spPr>
+          <a:xfrm>
+            <a:off x="3017520" y="2624328"/>
+            <a:ext cx="8778240" cy="841248"/>
+          </a:xfrm>
+          <a:prstGeom prst="rect">
+            <a:avLst/>
+          </a:prstGeom>
+          <a:solidFill>
+            <a:srgbClr val="FFFFFF"/>
+          </a:solidFill>
+          <a:ln w="9525">
+            <a:solidFill>
+              <a:srgbClr val="BFBFBF"/>
+            </a:solidFill>
+          </a:ln>
+          <a:effectLst/>
+        </p:spPr>
+        <p:style>
+          <a:lnRef idx="1">
+            <a:schemeClr val="accent1"/>
+          </a:lnRef>
+          <a:fillRef idx="3">
+            <a:schemeClr val="accent1"/>
+          </a:fillRef>
+          <a:effectRef idx="2">
+            <a:schemeClr val="accent1"/>
+          </a:effectRef>
+          <a:fontRef idx="minor">
+            <a:schemeClr val="lt1"/>
+          </a:fontRef>
+        </p:style>
+        <p:txBody>
+          <a:bodyPr rtlCol="0" anchor="ctr" wrap="square" lIns="45720" rIns="45720" tIns="27432" bIns="27432"/>
+          <a:lstStyle/>
+          <a:p>
+            <a:pPr algn="l"/>
+            <a:r>
+              <a:rPr sz="1050" b="0">
+                <a:solidFill>
+                  <a:srgbClr val="1A1A1A"/>
+                </a:solidFill>
+                <a:latin typeface="맑은 고딕"/>
+                <a:ea typeface="맑은 고딕"/>
+              </a:rPr>
+              <a:t>대화 문맥(KV cache, 32K~512K 토큰, 동시 1~256) · 여러 고객이 쓰는 LoRA 어댑터(몇 개만 인기) · MoE expert(라우팅 쏠림) · 수 TiB 벡</a:t>
+            </a:r>
+          </a:p>
+          <a:p>
+            <a:pPr algn="l"/>
+            <a:r>
+              <a:rPr sz="1050" b="0">
+                <a:solidFill>
+                  <a:srgbClr val="1A1A1A"/>
+                </a:solidFill>
+                <a:latin typeface="맑은 고딕"/>
+                <a:ea typeface="맑은 고딕"/>
+              </a:rPr>
+              <a:t>터 DB(RAG) · 오래 보관되는 Agent 기억과 Tool 결과(드물게 재사용 / 한꺼번에 생성 후 반복 참조).</a:t>
+            </a:r>
+          </a:p>
+        </p:txBody>
+      </p:sp>
+      <p:sp>
+        <p:nvSpPr>
+          <p:cNvPr id="63" name="Rectangle 62"/>
+          <p:cNvSpPr/>
+          <p:nvPr/>
+        </p:nvSpPr>
+        <p:spPr>
+          <a:xfrm>
+            <a:off x="365760" y="3511296"/>
+            <a:ext cx="2651760" cy="841248"/>
+          </a:xfrm>
+          <a:prstGeom prst="rect">
+            <a:avLst/>
+          </a:prstGeom>
+          <a:solidFill>
+            <a:srgbClr val="DCE9F5"/>
+          </a:solidFill>
+          <a:ln w="9525">
+            <a:solidFill>
+              <a:srgbClr val="4D7EA8"/>
+            </a:solidFill>
+          </a:ln>
+          <a:effectLst/>
+        </p:spPr>
+        <p:style>
+          <a:lnRef idx="1">
+            <a:schemeClr val="accent1"/>
+          </a:lnRef>
+          <a:fillRef idx="3">
+            <a:schemeClr val="accent1"/>
+          </a:fillRef>
+          <a:effectRef idx="2">
+            <a:schemeClr val="accent1"/>
+          </a:effectRef>
+          <a:fontRef idx="minor">
+            <a:schemeClr val="lt1"/>
+          </a:fontRef>
+        </p:style>
+        <p:txBody>
+          <a:bodyPr rtlCol="0" anchor="ctr" wrap="square" lIns="45720" rIns="45720" tIns="27432" bIns="27432"/>
+          <a:lstStyle/>
+          <a:p>
+            <a:pPr algn="l"/>
+            <a:r>
+              <a:rPr sz="1000" b="1">
+                <a:solidFill>
+                  <a:srgbClr val="1A1A1A"/>
+                </a:solidFill>
+                <a:latin typeface="맑은 고딕"/>
+                <a:ea typeface="맑은 고딕"/>
+              </a:rPr>
+              <a:t>접근이 쏠리는 정도(hotness)</a:t>
+            </a:r>
+          </a:p>
+        </p:txBody>
+      </p:sp>
+      <p:sp>
+        <p:nvSpPr>
+          <p:cNvPr id="64" name="Rectangle 63"/>
+          <p:cNvSpPr/>
+          <p:nvPr/>
+        </p:nvSpPr>
+        <p:spPr>
+          <a:xfrm>
+            <a:off x="3017520" y="3511296"/>
+            <a:ext cx="8778240" cy="841248"/>
+          </a:xfrm>
+          <a:prstGeom prst="rect">
+            <a:avLst/>
+          </a:prstGeom>
+          <a:solidFill>
+            <a:srgbClr val="FFFFFF"/>
+          </a:solidFill>
+          <a:ln w="9525">
+            <a:solidFill>
+              <a:srgbClr val="BFBFBF"/>
+            </a:solidFill>
+          </a:ln>
+          <a:effectLst/>
+        </p:spPr>
+        <p:style>
+          <a:lnRef idx="1">
+            <a:schemeClr val="accent1"/>
+          </a:lnRef>
+          <a:fillRef idx="3">
+            <a:schemeClr val="accent1"/>
+          </a:fillRef>
+          <a:effectRef idx="2">
+            <a:schemeClr val="accent1"/>
+          </a:effectRef>
+          <a:fontRef idx="minor">
+            <a:schemeClr val="lt1"/>
+          </a:fontRef>
+        </p:style>
+        <p:txBody>
+          <a:bodyPr rtlCol="0" anchor="ctr" wrap="square" lIns="45720" rIns="45720" tIns="27432" bIns="27432"/>
+          <a:lstStyle/>
+          <a:p>
+            <a:pPr algn="l"/>
+            <a:r>
+              <a:rPr sz="1050" b="0">
+                <a:solidFill>
+                  <a:srgbClr val="1A1A1A"/>
+                </a:solidFill>
+                <a:latin typeface="맑은 고딕"/>
+                <a:ea typeface="맑은 고딕"/>
+              </a:rPr>
+              <a:t>소수만 인기 있는 skew · 거의 안 쓰이는 cold 데이터가 상위 메모리를 차지 · 갑자기 hot해지는 burst · hot/cold 급반전 · hot 대상이 옮겨 </a:t>
+            </a:r>
+          </a:p>
+          <a:p>
+            <a:pPr algn="l"/>
+            <a:r>
+              <a:rPr sz="1050" b="0">
+                <a:solidFill>
+                  <a:srgbClr val="1A1A1A"/>
+                </a:solidFill>
+                <a:latin typeface="맑은 고딕"/>
+                <a:ea typeface="맑은 고딕"/>
+              </a:rPr>
+              <a:t>감(최근 세션으로 이동, 사용자 그룹이 번갈아 활성, 인기 검색 shard가 바뀜). 고르게 접근되는 전용 시나리오는 아직 없음(중간 KV 기준</a:t>
+            </a:r>
+          </a:p>
+          <a:p>
+            <a:pPr algn="l"/>
+            <a:r>
+              <a:rPr sz="1050" b="0">
+                <a:solidFill>
+                  <a:srgbClr val="1A1A1A"/>
+                </a:solidFill>
+                <a:latin typeface="맑은 고딕"/>
+                <a:ea typeface="맑은 고딕"/>
+              </a:rPr>
+              <a:t>선이 대조군).</a:t>
+            </a:r>
+          </a:p>
+        </p:txBody>
+      </p:sp>
+      <p:sp>
+        <p:nvSpPr>
+          <p:cNvPr id="65" name="Rectangle 64"/>
+          <p:cNvSpPr/>
+          <p:nvPr/>
+        </p:nvSpPr>
+        <p:spPr>
+          <a:xfrm>
+            <a:off x="365760" y="4398264"/>
+            <a:ext cx="2651760" cy="841248"/>
+          </a:xfrm>
+          <a:prstGeom prst="rect">
+            <a:avLst/>
+          </a:prstGeom>
+          <a:solidFill>
+            <a:srgbClr val="DCE9F5"/>
+          </a:solidFill>
+          <a:ln w="9525">
+            <a:solidFill>
+              <a:srgbClr val="4D7EA8"/>
+            </a:solidFill>
+          </a:ln>
+          <a:effectLst/>
+        </p:spPr>
+        <p:style>
+          <a:lnRef idx="1">
+            <a:schemeClr val="accent1"/>
+          </a:lnRef>
+          <a:fillRef idx="3">
+            <a:schemeClr val="accent1"/>
+          </a:fillRef>
+          <a:effectRef idx="2">
+            <a:schemeClr val="accent1"/>
+          </a:effectRef>
+          <a:fontRef idx="minor">
+            <a:schemeClr val="lt1"/>
+          </a:fontRef>
+        </p:style>
+        <p:txBody>
+          <a:bodyPr rtlCol="0" anchor="ctr" wrap="square" lIns="45720" rIns="45720" tIns="27432" bIns="27432"/>
+          <a:lstStyle/>
+          <a:p>
+            <a:pPr algn="l"/>
+            <a:r>
+              <a:rPr sz="1000" b="1">
+                <a:solidFill>
+                  <a:srgbClr val="1A1A1A"/>
+                </a:solidFill>
+                <a:latin typeface="맑은 고딕"/>
+                <a:ea typeface="맑은 고딕"/>
+              </a:rPr>
+              <a:t>자원 조건이 바뀌는 경우</a:t>
+            </a:r>
+          </a:p>
+        </p:txBody>
+      </p:sp>
+      <p:sp>
+        <p:nvSpPr>
+          <p:cNvPr id="66" name="Rectangle 65"/>
+          <p:cNvSpPr/>
+          <p:nvPr/>
+        </p:nvSpPr>
+        <p:spPr>
+          <a:xfrm>
+            <a:off x="3017520" y="4398264"/>
+            <a:ext cx="8778240" cy="841248"/>
+          </a:xfrm>
+          <a:prstGeom prst="rect">
+            <a:avLst/>
+          </a:prstGeom>
+          <a:solidFill>
+            <a:srgbClr val="FFFFFF"/>
+          </a:solidFill>
+          <a:ln w="9525">
+            <a:solidFill>
+              <a:srgbClr val="BFBFBF"/>
+            </a:solidFill>
+          </a:ln>
+          <a:effectLst/>
+        </p:spPr>
+        <p:style>
+          <a:lnRef idx="1">
+            <a:schemeClr val="accent1"/>
+          </a:lnRef>
+          <a:fillRef idx="3">
+            <a:schemeClr val="accent1"/>
+          </a:fillRef>
+          <a:effectRef idx="2">
+            <a:schemeClr val="accent1"/>
+          </a:effectRef>
+          <a:fontRef idx="minor">
+            <a:schemeClr val="lt1"/>
+          </a:fontRef>
+        </p:style>
+        <p:txBody>
+          <a:bodyPr rtlCol="0" anchor="ctr" wrap="square" lIns="45720" rIns="45720" tIns="27432" bIns="27432"/>
+          <a:lstStyle/>
+          <a:p>
+            <a:pPr algn="l"/>
+            <a:r>
+              <a:rPr sz="1050" b="0">
+                <a:solidFill>
+                  <a:srgbClr val="1A1A1A"/>
+                </a:solidFill>
+                <a:latin typeface="맑은 고딕"/>
+                <a:ea typeface="맑은 고딕"/>
+              </a:rPr>
+              <a:t>HBM 용량 압박(고정 / 점진 증가) · HBM 대역폭 급락 · 다른 작업과 공유하는 host 링크 경합(대역폭 25%로 저하) · 6개 메모리 용량을 모</a:t>
+            </a:r>
+          </a:p>
+          <a:p>
+            <a:pPr algn="l"/>
+            <a:r>
+              <a:rPr sz="1050" b="0">
+                <a:solidFill>
+                  <a:srgbClr val="1A1A1A"/>
+                </a:solidFill>
+                <a:latin typeface="맑은 고딕"/>
+                <a:ea typeface="맑은 고딕"/>
+              </a:rPr>
+              <a:t>두 써야 하는 큰 용량 부담.</a:t>
+            </a:r>
+          </a:p>
+        </p:txBody>
+      </p:sp>
+      <p:sp>
+        <p:nvSpPr>
+          <p:cNvPr id="67" name="Rectangle 66"/>
+          <p:cNvSpPr/>
+          <p:nvPr/>
+        </p:nvSpPr>
+        <p:spPr>
+          <a:xfrm>
+            <a:off x="365760" y="5285231"/>
+            <a:ext cx="2651760" cy="841248"/>
+          </a:xfrm>
+          <a:prstGeom prst="rect">
+            <a:avLst/>
+          </a:prstGeom>
+          <a:solidFill>
+            <a:srgbClr val="DCE9F5"/>
+          </a:solidFill>
+          <a:ln w="9525">
+            <a:solidFill>
+              <a:srgbClr val="4D7EA8"/>
+            </a:solidFill>
+          </a:ln>
+          <a:effectLst/>
+        </p:spPr>
+        <p:style>
+          <a:lnRef idx="1">
+            <a:schemeClr val="accent1"/>
+          </a:lnRef>
+          <a:fillRef idx="3">
+            <a:schemeClr val="accent1"/>
+          </a:fillRef>
+          <a:effectRef idx="2">
+            <a:schemeClr val="accent1"/>
+          </a:effectRef>
+          <a:fontRef idx="minor">
+            <a:schemeClr val="lt1"/>
+          </a:fontRef>
+        </p:style>
+        <p:txBody>
+          <a:bodyPr rtlCol="0" anchor="ctr" wrap="square" lIns="45720" rIns="45720" tIns="27432" bIns="27432"/>
+          <a:lstStyle/>
+          <a:p>
+            <a:pPr algn="l"/>
+            <a:r>
+              <a:rPr sz="1000" b="1">
+                <a:solidFill>
+                  <a:srgbClr val="1A1A1A"/>
+                </a:solidFill>
+                <a:latin typeface="맑은 고딕"/>
+                <a:ea typeface="맑은 고딕"/>
+              </a:rPr>
+              <a:t>처음엔 문제없다가 나빠지는 경우 (Dynami</a:t>
+            </a:r>
+          </a:p>
+          <a:p>
+            <a:pPr algn="l"/>
+            <a:r>
+              <a:rPr sz="1000" b="1">
+                <a:solidFill>
+                  <a:srgbClr val="1A1A1A"/>
+                </a:solidFill>
+                <a:latin typeface="맑은 고딕"/>
+                <a:ea typeface="맑은 고딕"/>
+              </a:rPr>
+              <a:t>c 6개)</a:t>
+            </a:r>
+          </a:p>
+        </p:txBody>
+      </p:sp>
+      <p:sp>
+        <p:nvSpPr>
+          <p:cNvPr id="68" name="Rectangle 67"/>
+          <p:cNvSpPr/>
+          <p:nvPr/>
+        </p:nvSpPr>
+        <p:spPr>
+          <a:xfrm>
+            <a:off x="3017520" y="5285231"/>
+            <a:ext cx="8778240" cy="841248"/>
+          </a:xfrm>
+          <a:prstGeom prst="rect">
+            <a:avLst/>
+          </a:prstGeom>
+          <a:solidFill>
+            <a:srgbClr val="FFFFFF"/>
+          </a:solidFill>
+          <a:ln w="9525">
+            <a:solidFill>
+              <a:srgbClr val="BFBFBF"/>
+            </a:solidFill>
+          </a:ln>
+          <a:effectLst/>
+        </p:spPr>
+        <p:style>
+          <a:lnRef idx="1">
+            <a:schemeClr val="accent1"/>
+          </a:lnRef>
+          <a:fillRef idx="3">
+            <a:schemeClr val="accent1"/>
+          </a:fillRef>
+          <a:effectRef idx="2">
+            <a:schemeClr val="accent1"/>
+          </a:effectRef>
+          <a:fontRef idx="minor">
+            <a:schemeClr val="lt1"/>
+          </a:fontRef>
+        </p:style>
+        <p:txBody>
+          <a:bodyPr rtlCol="0" anchor="ctr" wrap="square" lIns="45720" rIns="45720" tIns="27432" bIns="27432"/>
+          <a:lstStyle/>
+          <a:p>
+            <a:pPr algn="l"/>
+            <a:r>
+              <a:rPr sz="1050" b="0">
+                <a:solidFill>
+                  <a:srgbClr val="1A1A1A"/>
+                </a:solidFill>
+                <a:latin typeface="맑은 고딕"/>
+                <a:ea typeface="맑은 고딕"/>
+              </a:rPr>
               <a:t>Baseline이 처음엔 SLO를 만족하다 중간에 working set이 바뀐다. 예: 오래 보관만 되던 Agent 기억이 HBM을 차지한 채 채팅이 몰림 / ho</a:t>
             </a:r>
           </a:p>
           <a:p>
             <a:pPr algn="l"/>
             <a:r>
-              <a:rPr sz="1100" b="0">
+              <a:rPr sz="1050" b="0">
                 <a:solidFill>
                   <a:srgbClr val="1A1A1A"/>
                 </a:solidFill>

</xml_diff>

<commit_message>
Systems: memory configuration slide (capacity, host link, BW, compute capability), Samsung Custom HBM(ScHBM) naming, memory line in result doc
Co-Authored-By: Claude Sonnet 5.5 <noreply@anthropic.com>
Claude-Session: https://claude.ai/code/session_018inK4pZJGzYwjdk7QAyZgn
</commit_message>
<xml_diff>
--- a/doc-mk/DP1/DP1-appendix-qa-result.pptx
+++ b/doc-mk/DP1/DP1-appendix-qa-result.pptx
@@ -12,6 +12,7 @@
     <p:sldId id="651" r:id="rId25"/>
     <p:sldId id="652" r:id="rId26"/>
     <p:sldId id="653" r:id="rId27"/>
+    <p:sldId id="654" r:id="rId28"/>
   </p:sldIdLst>
   <p:sldSz cx="12192000" cy="6858000"/>
   <p:notesSz cx="6858000" cy="9144000"/>
@@ -6657,7 +6658,7 @@
                 <a:latin typeface="맑은 고딕"/>
                 <a:ea typeface="맑은 고딕"/>
               </a:rPr>
-              <a:t>시스템: H100x8 (HBM3, PCIe 5.0, DDR5-4800) + B200x8 (HBM3e, PCIe 5.0, DDR5-6400). 6종 메모리(HBM, Custom HBM, DRAM, CXL-PNM, HBF, SSD-PIM)를 갖춘 8-GPU 1노드, Llama-3.1-70B BF16.</a:t>
+              <a:t>시스템: H100x8 (HBM3, PCIe 5.0, DDR5-4800) + B200x8 (HBM3e, PCIe 5.0, DDR5-6400). 8-GPU 1노드, Llama-3.1-70B BF16. 6종 메모리 구성은 다음 장.</a:t>
             </a:r>
           </a:p>
           <a:p>
@@ -6888,7 +6889,7 @@
                   <a:schemeClr val="bg1"/>
                 </a:solidFill>
               </a:rPr>
-              <a:t>DP1 평가 결과 - QA별로 왜 이런 값이 나왔나 (1/2: 처리량, 지연)</a:t>
+              <a:t>DP1 평가 시스템 - 메모리 구성 (H100x8 / B200x8, 값이 다르면 H100 / B200)</a:t>
             </a:r>
             <a:r>
               <a:rPr lang="en-US" altLang="ko-KR" sz="1400" b="1" dirty="0">
@@ -7009,7 +7010,7 @@
         <p:spPr>
           <a:xfrm>
             <a:off x="365760" y="1051560"/>
-            <a:ext cx="2651760" cy="292608"/>
+            <a:ext cx="1920240" cy="292608"/>
           </a:xfrm>
           <a:prstGeom prst="rect">
             <a:avLst/>
@@ -7051,7 +7052,7 @@
                 <a:latin typeface="맑은 고딕"/>
                 <a:ea typeface="맑은 고딕"/>
               </a:rPr>
-              <a:t>QA / 수치</a:t>
+              <a:t>메모리</a:t>
             </a:r>
           </a:p>
         </p:txBody>
@@ -7064,8 +7065,8 @@
         </p:nvSpPr>
         <p:spPr>
           <a:xfrm>
-            <a:off x="3017520" y="1051560"/>
-            <a:ext cx="5943600" cy="292608"/>
+            <a:off x="2286000" y="1051560"/>
+            <a:ext cx="1463040" cy="292608"/>
           </a:xfrm>
           <a:prstGeom prst="rect">
             <a:avLst/>
@@ -7107,7 +7108,7 @@
                 <a:latin typeface="맑은 고딕"/>
                 <a:ea typeface="맑은 고딕"/>
               </a:rPr>
-              <a:t>왜 이런 값이 나왔나</a:t>
+              <a:t>용량</a:t>
             </a:r>
           </a:p>
         </p:txBody>
@@ -7120,8 +7121,8 @@
         </p:nvSpPr>
         <p:spPr>
           <a:xfrm>
-            <a:off x="8961120" y="1051560"/>
-            <a:ext cx="2834640" cy="292608"/>
+            <a:off x="3749039" y="1051560"/>
+            <a:ext cx="2651760" cy="292608"/>
           </a:xfrm>
           <a:prstGeom prst="rect">
             <a:avLst/>
@@ -7163,7 +7164,7 @@
                 <a:latin typeface="맑은 고딕"/>
                 <a:ea typeface="맑은 고딕"/>
               </a:rPr>
-              <a:t>근거 (시나리오·측정값)</a:t>
+              <a:t>연결 (host와)</a:t>
             </a:r>
           </a:p>
         </p:txBody>
@@ -7176,8 +7177,120 @@
         </p:nvSpPr>
         <p:spPr>
           <a:xfrm>
+            <a:off x="6400800" y="1051560"/>
+            <a:ext cx="2011680" cy="292608"/>
+          </a:xfrm>
+          <a:prstGeom prst="rect">
+            <a:avLst/>
+          </a:prstGeom>
+          <a:solidFill>
+            <a:srgbClr val="1F4E79"/>
+          </a:solidFill>
+          <a:ln w="9525">
+            <a:solidFill>
+              <a:srgbClr val="1F4E79"/>
+            </a:solidFill>
+          </a:ln>
+          <a:effectLst/>
+        </p:spPr>
+        <p:style>
+          <a:lnRef idx="1">
+            <a:schemeClr val="accent1"/>
+          </a:lnRef>
+          <a:fillRef idx="3">
+            <a:schemeClr val="accent1"/>
+          </a:fillRef>
+          <a:effectRef idx="2">
+            <a:schemeClr val="accent1"/>
+          </a:effectRef>
+          <a:fontRef idx="minor">
+            <a:schemeClr val="lt1"/>
+          </a:fontRef>
+        </p:style>
+        <p:txBody>
+          <a:bodyPr rtlCol="0" anchor="ctr" wrap="square" lIns="45720" rIns="45720" tIns="27432" bIns="27432"/>
+          <a:lstStyle/>
+          <a:p>
+            <a:pPr algn="ctr"/>
+            <a:r>
+              <a:rPr sz="1000" b="1">
+                <a:solidFill>
+                  <a:srgbClr val="FFFFFF"/>
+                </a:solidFill>
+                <a:latin typeface="맑은 고딕"/>
+                <a:ea typeface="맑은 고딕"/>
+              </a:rPr>
+              <a:t>대역폭 (외부 / 내부)</a:t>
+            </a:r>
+          </a:p>
+        </p:txBody>
+      </p:sp>
+      <p:sp>
+        <p:nvSpPr>
+          <p:cNvPr id="62" name="Rectangle 61"/>
+          <p:cNvSpPr/>
+          <p:nvPr/>
+        </p:nvSpPr>
+        <p:spPr>
+          <a:xfrm>
+            <a:off x="8412480" y="1051560"/>
+            <a:ext cx="3383280" cy="292608"/>
+          </a:xfrm>
+          <a:prstGeom prst="rect">
+            <a:avLst/>
+          </a:prstGeom>
+          <a:solidFill>
+            <a:srgbClr val="1F4E79"/>
+          </a:solidFill>
+          <a:ln w="9525">
+            <a:solidFill>
+              <a:srgbClr val="1F4E79"/>
+            </a:solidFill>
+          </a:ln>
+          <a:effectLst/>
+        </p:spPr>
+        <p:style>
+          <a:lnRef idx="1">
+            <a:schemeClr val="accent1"/>
+          </a:lnRef>
+          <a:fillRef idx="3">
+            <a:schemeClr val="accent1"/>
+          </a:fillRef>
+          <a:effectRef idx="2">
+            <a:schemeClr val="accent1"/>
+          </a:effectRef>
+          <a:fontRef idx="minor">
+            <a:schemeClr val="lt1"/>
+          </a:fontRef>
+        </p:style>
+        <p:txBody>
+          <a:bodyPr rtlCol="0" anchor="ctr" wrap="square" lIns="45720" rIns="45720" tIns="27432" bIns="27432"/>
+          <a:lstStyle/>
+          <a:p>
+            <a:pPr algn="ctr"/>
+            <a:r>
+              <a:rPr sz="1000" b="1">
+                <a:solidFill>
+                  <a:srgbClr val="FFFFFF"/>
+                </a:solidFill>
+                <a:latin typeface="맑은 고딕"/>
+                <a:ea typeface="맑은 고딕"/>
+              </a:rPr>
+              <a:t>연산 능력 (FP16)과 지원 연산</a:t>
+            </a:r>
+          </a:p>
+        </p:txBody>
+      </p:sp>
+      <p:sp>
+        <p:nvSpPr>
+          <p:cNvPr id="63" name="Rectangle 62"/>
+          <p:cNvSpPr/>
+          <p:nvPr/>
+        </p:nvSpPr>
+        <p:spPr>
+          <a:xfrm>
             <a:off x="365760" y="1371600"/>
-            <a:ext cx="2651760" cy="1600200"/>
+            <a:ext cx="1920240" cy="566928"/>
           </a:xfrm>
           <a:prstGeom prst="rect">
             <a:avLst/>
@@ -7219,34 +7332,21 @@
                 <a:latin typeface="맑은 고딕"/>
                 <a:ea typeface="맑은 고딕"/>
               </a:rPr>
-              <a:t>QA1 처리량</a:t>
-            </a:r>
-          </a:p>
-          <a:p>
-            <a:pPr algn="l"/>
-            <a:r>
-              <a:rPr sz="950" b="1">
-                <a:solidFill>
-                  <a:srgbClr val="1A1A1A"/>
-                </a:solidFill>
-                <a:latin typeface="맑은 고딕"/>
-                <a:ea typeface="맑은 고딕"/>
-              </a:rPr>
-              <a:t>C1 x1.30 · C2 x1.42</a:t>
-            </a:r>
-          </a:p>
-        </p:txBody>
-      </p:sp>
-      <p:sp>
-        <p:nvSpPr>
-          <p:cNvPr id="62" name="Rectangle 61"/>
+              <a:t>HBM</a:t>
+            </a:r>
+          </a:p>
+        </p:txBody>
+      </p:sp>
+      <p:sp>
+        <p:nvSpPr>
+          <p:cNvPr id="64" name="Rectangle 63"/>
           <p:cNvSpPr/>
           <p:nvPr/>
         </p:nvSpPr>
         <p:spPr>
           <a:xfrm>
-            <a:off x="3017520" y="1371600"/>
-            <a:ext cx="5943600" cy="1600200"/>
+            <a:off x="2286000" y="1371600"/>
+            <a:ext cx="1463040" cy="566928"/>
           </a:xfrm>
           <a:prstGeom prst="rect">
             <a:avLst/>
@@ -7288,7 +7388,7 @@
                 <a:latin typeface="맑은 고딕"/>
                 <a:ea typeface="맑은 고딕"/>
               </a:rPr>
-              <a:t>- 비교 가능·포화 31쌍 중 C1 25쌍, C2 21쌍은 Baseline과 같다. Baseline이 이미 SLO를 만족하면 올릴 </a:t>
+              <a:t>640 GiB / 1,536 GiB (G</a:t>
             </a:r>
           </a:p>
           <a:p>
@@ -7301,66 +7401,27 @@
                 <a:latin typeface="맑은 고딕"/>
                 <a:ea typeface="맑은 고딕"/>
               </a:rPr>
-              <a:t>여지가 없기 때문이다 (공통 시나리오 x1.00).</a:t>
-            </a:r>
-          </a:p>
-          <a:p>
-            <a:pPr algn="l"/>
-            <a:r>
-              <a:rPr sz="950" b="0">
-                <a:solidFill>
-                  <a:srgbClr val="1A1A1A"/>
-                </a:solidFill>
-                <a:latin typeface="맑은 고딕"/>
-                <a:ea typeface="맑은 고딕"/>
-              </a:rPr>
-              <a:t>- 이득은 hot 대상이 시간에 따라 옮겨 가는 Dynamic 시나리오에 집중된다 (승 C1 6, C2 10쌍).</a:t>
-            </a:r>
-          </a:p>
-          <a:p>
-            <a:pPr algn="l"/>
-            <a:r>
-              <a:rPr sz="950" b="0">
-                <a:solidFill>
-                  <a:srgbClr val="1A1A1A"/>
-                </a:solidFill>
-                <a:latin typeface="맑은 고딕"/>
-                <a:ea typeface="맑은 고딕"/>
-              </a:rPr>
-              <a:t>- C2는 데이터마다 접근 빈도·재사용·유휴를 보고 이동해 같은 종류(KV) 안의 hot/cold를 구분한다. C1은 </a:t>
-            </a:r>
-          </a:p>
-          <a:p>
-            <a:pPr algn="l"/>
-            <a:r>
-              <a:rPr sz="950" b="0">
-                <a:solidFill>
-                  <a:srgbClr val="1A1A1A"/>
-                </a:solidFill>
-                <a:latin typeface="맑은 고딕"/>
-                <a:ea typeface="맑은 고딕"/>
-              </a:rPr>
-              <a:t>자원 압박에만 반응해 구분하지 못한다.</a:t>
-            </a:r>
-          </a:p>
-        </p:txBody>
-      </p:sp>
-      <p:sp>
-        <p:nvSpPr>
-          <p:cNvPr id="63" name="Rectangle 62"/>
+              <a:t>PU 8장 합)</a:t>
+            </a:r>
+          </a:p>
+        </p:txBody>
+      </p:sp>
+      <p:sp>
+        <p:nvSpPr>
+          <p:cNvPr id="65" name="Rectangle 64"/>
           <p:cNvSpPr/>
           <p:nvPr/>
         </p:nvSpPr>
         <p:spPr>
           <a:xfrm>
-            <a:off x="8961120" y="1371600"/>
-            <a:ext cx="2834640" cy="1600200"/>
-          </a:xfrm>
-          <a:prstGeom prst="rect">
-            <a:avLst/>
-          </a:prstGeom>
-          <a:solidFill>
-            <a:srgbClr val="F2F2F2"/>
+            <a:off x="3749039" y="1371600"/>
+            <a:ext cx="2651760" cy="566928"/>
+          </a:xfrm>
+          <a:prstGeom prst="rect">
+            <a:avLst/>
+          </a:prstGeom>
+          <a:solidFill>
+            <a:srgbClr val="FFFFFF"/>
           </a:solidFill>
           <a:ln w="9525">
             <a:solidFill>
@@ -7389,54 +7450,140 @@
           <a:p>
             <a:pPr algn="l"/>
             <a:r>
-              <a:rPr sz="850" b="1">
-                <a:solidFill>
-                  <a:srgbClr val="404040"/>
-                </a:solidFill>
-                <a:latin typeface="맑은 고딕"/>
-                <a:ea typeface="맑은 고딕"/>
-              </a:rPr>
-              <a:t>dyn_kv_hotset_recency_shift (B200): C1 x1.11, C2 x2.62</a:t>
-            </a:r>
-          </a:p>
-          <a:p>
-            <a:pPr algn="l"/>
-            <a:r>
-              <a:rPr sz="850" b="0">
-                <a:solidFill>
-                  <a:srgbClr val="404040"/>
-                </a:solidFill>
-                <a:latin typeface="맑은 고딕"/>
-                <a:ea typeface="맑은 고딕"/>
-              </a:rPr>
-              <a:t>. 이동량 C1 70 GiB 대 C2 2,210 GiB.</a:t>
-            </a:r>
-          </a:p>
-          <a:p>
-            <a:pPr algn="l"/>
-            <a:r>
-              <a:rPr sz="850" b="0">
-                <a:solidFill>
-                  <a:srgbClr val="404040"/>
-                </a:solidFill>
-                <a:latin typeface="맑은 고딕"/>
-                <a:ea typeface="맑은 고딕"/>
-              </a:rPr>
-              <a:t>공통 cb_kv_8k_b32: 모두 x1.00</a:t>
-            </a:r>
-          </a:p>
-        </p:txBody>
-      </p:sp>
-      <p:sp>
-        <p:nvSpPr>
-          <p:cNvPr id="64" name="Rectangle 63"/>
+              <a:rPr sz="950" b="0">
+                <a:solidFill>
+                  <a:srgbClr val="1A1A1A"/>
+                </a:solidFill>
+                <a:latin typeface="맑은 고딕"/>
+                <a:ea typeface="맑은 고딕"/>
+              </a:rPr>
+              <a:t>GPU 온패키지</a:t>
+            </a:r>
+          </a:p>
+        </p:txBody>
+      </p:sp>
+      <p:sp>
+        <p:nvSpPr>
+          <p:cNvPr id="66" name="Rectangle 65"/>
           <p:cNvSpPr/>
           <p:nvPr/>
         </p:nvSpPr>
         <p:spPr>
           <a:xfrm>
-            <a:off x="365760" y="3017520"/>
-            <a:ext cx="2651760" cy="1508760"/>
+            <a:off x="6400800" y="1371600"/>
+            <a:ext cx="2011680" cy="566928"/>
+          </a:xfrm>
+          <a:prstGeom prst="rect">
+            <a:avLst/>
+          </a:prstGeom>
+          <a:solidFill>
+            <a:srgbClr val="FFFFFF"/>
+          </a:solidFill>
+          <a:ln w="9525">
+            <a:solidFill>
+              <a:srgbClr val="BFBFBF"/>
+            </a:solidFill>
+          </a:ln>
+          <a:effectLst/>
+        </p:spPr>
+        <p:style>
+          <a:lnRef idx="1">
+            <a:schemeClr val="accent1"/>
+          </a:lnRef>
+          <a:fillRef idx="3">
+            <a:schemeClr val="accent1"/>
+          </a:fillRef>
+          <a:effectRef idx="2">
+            <a:schemeClr val="accent1"/>
+          </a:effectRef>
+          <a:fontRef idx="minor">
+            <a:schemeClr val="lt1"/>
+          </a:fontRef>
+        </p:style>
+        <p:txBody>
+          <a:bodyPr rtlCol="0" anchor="ctr" wrap="square" lIns="45720" rIns="45720" tIns="27432" bIns="27432"/>
+          <a:lstStyle/>
+          <a:p>
+            <a:pPr algn="l"/>
+            <a:r>
+              <a:rPr sz="950" b="0">
+                <a:solidFill>
+                  <a:srgbClr val="1A1A1A"/>
+                </a:solidFill>
+                <a:latin typeface="맑은 고딕"/>
+                <a:ea typeface="맑은 고딕"/>
+              </a:rPr>
+              <a:t>26,800 / 64,000 GB/s (GPU 합)</a:t>
+            </a:r>
+          </a:p>
+        </p:txBody>
+      </p:sp>
+      <p:sp>
+        <p:nvSpPr>
+          <p:cNvPr id="67" name="Rectangle 66"/>
+          <p:cNvSpPr/>
+          <p:nvPr/>
+        </p:nvSpPr>
+        <p:spPr>
+          <a:xfrm>
+            <a:off x="8412480" y="1371600"/>
+            <a:ext cx="3383280" cy="566928"/>
+          </a:xfrm>
+          <a:prstGeom prst="rect">
+            <a:avLst/>
+          </a:prstGeom>
+          <a:solidFill>
+            <a:srgbClr val="FFFFFF"/>
+          </a:solidFill>
+          <a:ln w="9525">
+            <a:solidFill>
+              <a:srgbClr val="BFBFBF"/>
+            </a:solidFill>
+          </a:ln>
+          <a:effectLst/>
+        </p:spPr>
+        <p:style>
+          <a:lnRef idx="1">
+            <a:schemeClr val="accent1"/>
+          </a:lnRef>
+          <a:fillRef idx="3">
+            <a:schemeClr val="accent1"/>
+          </a:fillRef>
+          <a:effectRef idx="2">
+            <a:schemeClr val="accent1"/>
+          </a:effectRef>
+          <a:fontRef idx="minor">
+            <a:schemeClr val="lt1"/>
+          </a:fontRef>
+        </p:style>
+        <p:txBody>
+          <a:bodyPr rtlCol="0" anchor="ctr" wrap="square" lIns="45720" rIns="45720" tIns="27432" bIns="27432"/>
+          <a:lstStyle/>
+          <a:p>
+            <a:pPr algn="l"/>
+            <a:r>
+              <a:rPr sz="950" b="0">
+                <a:solidFill>
+                  <a:srgbClr val="1A1A1A"/>
+                </a:solidFill>
+                <a:latin typeface="맑은 고딕"/>
+                <a:ea typeface="맑은 고딕"/>
+              </a:rPr>
+              <a:t>—  (GPU가 attention·FFN 실행)</a:t>
+            </a:r>
+          </a:p>
+        </p:txBody>
+      </p:sp>
+      <p:sp>
+        <p:nvSpPr>
+          <p:cNvPr id="68" name="Rectangle 67"/>
+          <p:cNvSpPr/>
+          <p:nvPr/>
+        </p:nvSpPr>
+        <p:spPr>
+          <a:xfrm>
+            <a:off x="365760" y="1956816"/>
+            <a:ext cx="1920240" cy="566928"/>
           </a:xfrm>
           <a:prstGeom prst="rect">
             <a:avLst/>
@@ -7478,47 +7625,21 @@
                 <a:latin typeface="맑은 고딕"/>
                 <a:ea typeface="맑은 고딕"/>
               </a:rPr>
-              <a:t>QA2 TTFT</a:t>
-            </a:r>
-          </a:p>
-          <a:p>
-            <a:pPr algn="l"/>
-            <a:r>
-              <a:rPr sz="950" b="1">
-                <a:solidFill>
-                  <a:srgbClr val="1A1A1A"/>
-                </a:solidFill>
-                <a:latin typeface="맑은 고딕"/>
-                <a:ea typeface="맑은 고딕"/>
-              </a:rPr>
-              <a:t>P50 C1 x0.44 · C2 x0.29</a:t>
-            </a:r>
-          </a:p>
-          <a:p>
-            <a:pPr algn="l"/>
-            <a:r>
-              <a:rPr sz="950" b="1">
-                <a:solidFill>
-                  <a:srgbClr val="1A1A1A"/>
-                </a:solidFill>
-                <a:latin typeface="맑은 고딕"/>
-                <a:ea typeface="맑은 고딕"/>
-              </a:rPr>
-              <a:t>P99 C1 x1.04 · C2 x0.72</a:t>
-            </a:r>
-          </a:p>
-        </p:txBody>
-      </p:sp>
-      <p:sp>
-        <p:nvSpPr>
-          <p:cNvPr id="65" name="Rectangle 64"/>
+              <a:t>Samsung Custom HBM (ScHBM)</a:t>
+            </a:r>
+          </a:p>
+        </p:txBody>
+      </p:sp>
+      <p:sp>
+        <p:nvSpPr>
+          <p:cNvPr id="69" name="Rectangle 68"/>
           <p:cNvSpPr/>
           <p:nvPr/>
         </p:nvSpPr>
         <p:spPr>
           <a:xfrm>
-            <a:off x="3017520" y="3017520"/>
-            <a:ext cx="5943600" cy="1508760"/>
+            <a:off x="2286000" y="1956816"/>
+            <a:ext cx="1463040" cy="566928"/>
           </a:xfrm>
           <a:prstGeom prst="rect">
             <a:avLst/>
@@ -7560,7 +7681,7 @@
                 <a:latin typeface="맑은 고딕"/>
                 <a:ea typeface="맑은 고딕"/>
               </a:rPr>
-              <a:t>- P50이 크게 줄어드는 가장 큰 이유로 보이는 것: hot 데이터가 느린 tier(DRAM/HBF)에서 HBM으로 올라</a:t>
+              <a:t>160 GiB / 384 GiB (노</a:t>
             </a:r>
           </a:p>
           <a:p>
@@ -7573,79 +7694,27 @@
                 <a:latin typeface="맑은 고딕"/>
                 <a:ea typeface="맑은 고딕"/>
               </a:rPr>
-              <a:t>가 첫 토큰 전 복원 대기가 줄어든다(요청 단위로 분해하지는 않았다).</a:t>
-            </a:r>
-          </a:p>
-          <a:p>
-            <a:pPr algn="l"/>
-            <a:r>
-              <a:rPr sz="950" b="0">
-                <a:solidFill>
-                  <a:srgbClr val="1A1A1A"/>
-                </a:solidFill>
-                <a:latin typeface="맑은 고딕"/>
-                <a:ea typeface="맑은 고딕"/>
-              </a:rPr>
-              <a:t>- C1의 P99는 개선이 없다(x1.04). 진단한 `cb_kv_8k_b32`에서는 C1이 DRAM 링크 포화 신호에 반응해 </a:t>
-            </a:r>
-          </a:p>
-          <a:p>
-            <a:pPr algn="l"/>
-            <a:r>
-              <a:rPr sz="950" b="0">
-                <a:solidFill>
-                  <a:srgbClr val="1A1A1A"/>
-                </a:solidFill>
-                <a:latin typeface="맑은 고딕"/>
-                <a:ea typeface="맑은 고딕"/>
-              </a:rPr>
-              <a:t>이득 없는 재배치를 하고 그 이동이 링크를 나눠 써 꼬리가 늘었다(다른 시나리오의 원인은 분해하지 않</a:t>
-            </a:r>
-          </a:p>
-          <a:p>
-            <a:pPr algn="l"/>
-            <a:r>
-              <a:rPr sz="950" b="0">
-                <a:solidFill>
-                  <a:srgbClr val="1A1A1A"/>
-                </a:solidFill>
-                <a:latin typeface="맑은 고딕"/>
-                <a:ea typeface="맑은 고딕"/>
-              </a:rPr>
-              <a:t>음). C2는 hot 데이터를 HBM으로 올리는 이동이라 꼬리도 줄었다(x0.72).</a:t>
-            </a:r>
-          </a:p>
-          <a:p>
-            <a:pPr algn="l"/>
-            <a:r>
-              <a:rPr sz="950" b="0">
-                <a:solidFill>
-                  <a:srgbClr val="1A1A1A"/>
-                </a:solidFill>
-                <a:latin typeface="맑은 고딕"/>
-                <a:ea typeface="맑은 고딕"/>
-              </a:rPr>
-              <a:t>- 이동이 같은 링크의 서빙 대역폭을 나눠 쓰는 간섭 모델을 반영했다.</a:t>
-            </a:r>
-          </a:p>
-        </p:txBody>
-      </p:sp>
-      <p:sp>
-        <p:nvSpPr>
-          <p:cNvPr id="66" name="Rectangle 65"/>
+              <a:t>드 1개)</a:t>
+            </a:r>
+          </a:p>
+        </p:txBody>
+      </p:sp>
+      <p:sp>
+        <p:nvSpPr>
+          <p:cNvPr id="70" name="Rectangle 69"/>
           <p:cNvSpPr/>
           <p:nvPr/>
         </p:nvSpPr>
         <p:spPr>
           <a:xfrm>
-            <a:off x="8961120" y="3017520"/>
-            <a:ext cx="2834640" cy="1508760"/>
-          </a:xfrm>
-          <a:prstGeom prst="rect">
-            <a:avLst/>
-          </a:prstGeom>
-          <a:solidFill>
-            <a:srgbClr val="F2F2F2"/>
+            <a:off x="3749039" y="1956816"/>
+            <a:ext cx="2651760" cy="566928"/>
+          </a:xfrm>
+          <a:prstGeom prst="rect">
+            <a:avLst/>
+          </a:prstGeom>
+          <a:solidFill>
+            <a:srgbClr val="FFFFFF"/>
           </a:solidFill>
           <a:ln w="9525">
             <a:solidFill>
@@ -7674,54 +7743,166 @@
           <a:p>
             <a:pPr algn="l"/>
             <a:r>
-              <a:rPr sz="850" b="1">
-                <a:solidFill>
-                  <a:srgbClr val="404040"/>
-                </a:solidFill>
-                <a:latin typeface="맑은 고딕"/>
-                <a:ea typeface="맑은 고딕"/>
-              </a:rPr>
-              <a:t>cb_kv_8k_b32 (B200) TTFT P99: Baseline 337 ms, C1 1,</a:t>
-            </a:r>
-          </a:p>
-          <a:p>
-            <a:pPr algn="l"/>
-            <a:r>
-              <a:rPr sz="850" b="0">
-                <a:solidFill>
-                  <a:srgbClr val="404040"/>
-                </a:solidFill>
-                <a:latin typeface="맑은 고딕"/>
-                <a:ea typeface="맑은 고딕"/>
-              </a:rPr>
-              <a:t>308, C2 389.</a:t>
-            </a:r>
-          </a:p>
-          <a:p>
-            <a:pPr algn="l"/>
-            <a:r>
-              <a:rPr sz="850" b="0">
-                <a:solidFill>
-                  <a:srgbClr val="404040"/>
-                </a:solidFill>
-                <a:latin typeface="맑은 고딕"/>
-                <a:ea typeface="맑은 고딕"/>
-              </a:rPr>
-              <a:t>C1은 재배치 17회(231 GiB), C2는 승격 76회</a:t>
-            </a:r>
-          </a:p>
-        </p:txBody>
-      </p:sp>
-      <p:sp>
-        <p:nvSpPr>
-          <p:cNvPr id="67" name="Rectangle 66"/>
+              <a:rPr sz="950" b="0">
+                <a:solidFill>
+                  <a:srgbClr val="1A1A1A"/>
+                </a:solidFill>
+                <a:latin typeface="맑은 고딕"/>
+                <a:ea typeface="맑은 고딕"/>
+              </a:rPr>
+              <a:t>CPU와 PCIe 5.0 x16, GPU→host→ScHBM 2</a:t>
+            </a:r>
+          </a:p>
+          <a:p>
+            <a:pPr algn="l"/>
+            <a:r>
+              <a:rPr sz="950" b="0">
+                <a:solidFill>
+                  <a:srgbClr val="1A1A1A"/>
+                </a:solidFill>
+                <a:latin typeface="맑은 고딕"/>
+                <a:ea typeface="맑은 고딕"/>
+              </a:rPr>
+              <a:t>홉 (GPU 직접 접근 불가)</a:t>
+            </a:r>
+          </a:p>
+        </p:txBody>
+      </p:sp>
+      <p:sp>
+        <p:nvSpPr>
+          <p:cNvPr id="71" name="Rectangle 70"/>
           <p:cNvSpPr/>
           <p:nvPr/>
         </p:nvSpPr>
         <p:spPr>
           <a:xfrm>
-            <a:off x="365760" y="4572000"/>
-            <a:ext cx="2651760" cy="1234440"/>
+            <a:off x="6400800" y="1956816"/>
+            <a:ext cx="2011680" cy="566928"/>
+          </a:xfrm>
+          <a:prstGeom prst="rect">
+            <a:avLst/>
+          </a:prstGeom>
+          <a:solidFill>
+            <a:srgbClr val="FFFFFF"/>
+          </a:solidFill>
+          <a:ln w="9525">
+            <a:solidFill>
+              <a:srgbClr val="BFBFBF"/>
+            </a:solidFill>
+          </a:ln>
+          <a:effectLst/>
+        </p:spPr>
+        <p:style>
+          <a:lnRef idx="1">
+            <a:schemeClr val="accent1"/>
+          </a:lnRef>
+          <a:fillRef idx="3">
+            <a:schemeClr val="accent1"/>
+          </a:fillRef>
+          <a:effectRef idx="2">
+            <a:schemeClr val="accent1"/>
+          </a:effectRef>
+          <a:fontRef idx="minor">
+            <a:schemeClr val="lt1"/>
+          </a:fontRef>
+        </p:style>
+        <p:txBody>
+          <a:bodyPr rtlCol="0" anchor="ctr" wrap="square" lIns="45720" rIns="45720" tIns="27432" bIns="27432"/>
+          <a:lstStyle/>
+          <a:p>
+            <a:pPr algn="l"/>
+            <a:r>
+              <a:rPr sz="950" b="0">
+                <a:solidFill>
+                  <a:srgbClr val="1A1A1A"/>
+                </a:solidFill>
+                <a:latin typeface="맑은 고딕"/>
+                <a:ea typeface="맑은 고딕"/>
+              </a:rPr>
+              <a:t>63 GB/s / 6,700 / 16,000 GB/s</a:t>
+            </a:r>
+          </a:p>
+        </p:txBody>
+      </p:sp>
+      <p:sp>
+        <p:nvSpPr>
+          <p:cNvPr id="72" name="Rectangle 71"/>
+          <p:cNvSpPr/>
+          <p:nvPr/>
+        </p:nvSpPr>
+        <p:spPr>
+          <a:xfrm>
+            <a:off x="8412480" y="1956816"/>
+            <a:ext cx="3383280" cy="566928"/>
+          </a:xfrm>
+          <a:prstGeom prst="rect">
+            <a:avLst/>
+          </a:prstGeom>
+          <a:solidFill>
+            <a:srgbClr val="FFFFFF"/>
+          </a:solidFill>
+          <a:ln w="9525">
+            <a:solidFill>
+              <a:srgbClr val="BFBFBF"/>
+            </a:solidFill>
+          </a:ln>
+          <a:effectLst/>
+        </p:spPr>
+        <p:style>
+          <a:lnRef idx="1">
+            <a:schemeClr val="accent1"/>
+          </a:lnRef>
+          <a:fillRef idx="3">
+            <a:schemeClr val="accent1"/>
+          </a:fillRef>
+          <a:effectRef idx="2">
+            <a:schemeClr val="accent1"/>
+          </a:effectRef>
+          <a:fontRef idx="minor">
+            <a:schemeClr val="lt1"/>
+          </a:fontRef>
+        </p:style>
+        <p:txBody>
+          <a:bodyPr rtlCol="0" anchor="ctr" wrap="square" lIns="45720" rIns="45720" tIns="27432" bIns="27432"/>
+          <a:lstStyle/>
+          <a:p>
+            <a:pPr algn="l"/>
+            <a:r>
+              <a:rPr sz="950" b="0">
+                <a:solidFill>
+                  <a:srgbClr val="1A1A1A"/>
+                </a:solidFill>
+                <a:latin typeface="맑은 고딕"/>
+                <a:ea typeface="맑은 고딕"/>
+              </a:rPr>
+              <a:t>197.8 / 450 TFLOPS · QK_GEMM, SOFTMAX, AV_GEMM, C</a:t>
+            </a:r>
+          </a:p>
+          <a:p>
+            <a:pPr algn="l"/>
+            <a:r>
+              <a:rPr sz="950" b="0">
+                <a:solidFill>
+                  <a:srgbClr val="1A1A1A"/>
+                </a:solidFill>
+                <a:latin typeface="맑은 고딕"/>
+                <a:ea typeface="맑은 고딕"/>
+              </a:rPr>
+              <a:t>AUSAL_MASK (attention 오프로드)</a:t>
+            </a:r>
+          </a:p>
+        </p:txBody>
+      </p:sp>
+      <p:sp>
+        <p:nvSpPr>
+          <p:cNvPr id="73" name="Rectangle 72"/>
+          <p:cNvSpPr/>
+          <p:nvPr/>
+        </p:nvSpPr>
+        <p:spPr>
+          <a:xfrm>
+            <a:off x="365760" y="2542032"/>
+            <a:ext cx="1920240" cy="566928"/>
           </a:xfrm>
           <a:prstGeom prst="rect">
             <a:avLst/>
@@ -7763,34 +7944,21 @@
                 <a:latin typeface="맑은 고딕"/>
                 <a:ea typeface="맑은 고딕"/>
               </a:rPr>
-              <a:t>QA2 TPOT</a:t>
-            </a:r>
-          </a:p>
-          <a:p>
-            <a:pPr algn="l"/>
-            <a:r>
-              <a:rPr sz="950" b="1">
-                <a:solidFill>
-                  <a:srgbClr val="1A1A1A"/>
-                </a:solidFill>
-                <a:latin typeface="맑은 고딕"/>
-                <a:ea typeface="맑은 고딕"/>
-              </a:rPr>
-              <a:t>P99 C1 x1.07 · C2 x0.94</a:t>
-            </a:r>
-          </a:p>
-        </p:txBody>
-      </p:sp>
-      <p:sp>
-        <p:nvSpPr>
-          <p:cNvPr id="68" name="Rectangle 67"/>
+              <a:t>CXL-PNM</a:t>
+            </a:r>
+          </a:p>
+        </p:txBody>
+      </p:sp>
+      <p:sp>
+        <p:nvSpPr>
+          <p:cNvPr id="74" name="Rectangle 73"/>
           <p:cNvSpPr/>
           <p:nvPr/>
         </p:nvSpPr>
         <p:spPr>
           <a:xfrm>
-            <a:off x="3017520" y="4572000"/>
-            <a:ext cx="5943600" cy="1234440"/>
+            <a:off x="2286000" y="2542032"/>
+            <a:ext cx="1463040" cy="566928"/>
           </a:xfrm>
           <a:prstGeom prst="rect">
             <a:avLst/>
@@ -7832,79 +8000,27 @@
                 <a:latin typeface="맑은 고딕"/>
                 <a:ea typeface="맑은 고딕"/>
               </a:rPr>
-              <a:t>- 거의 변하지 않는다. TPOT는 매 토큰 디코드가 HBM 대역폭에 묶여 정해지고, DP1은 데이터 위치만 바</a:t>
-            </a:r>
-          </a:p>
-          <a:p>
-            <a:pPr algn="l"/>
-            <a:r>
-              <a:rPr sz="950" b="0">
-                <a:solidFill>
-                  <a:srgbClr val="1A1A1A"/>
-                </a:solidFill>
-                <a:latin typeface="맑은 고딕"/>
-                <a:ea typeface="맑은 고딕"/>
-              </a:rPr>
-              <a:t>꾸지 디코드 방식은 바꾸지 못한다. Baseline의 TPOT P99가 17.1 ms로 SLO(50 ms)보다 훨씬 낮아 개선 </a:t>
-            </a:r>
-          </a:p>
-          <a:p>
-            <a:pPr algn="l"/>
-            <a:r>
-              <a:rPr sz="950" b="0">
-                <a:solidFill>
-                  <a:srgbClr val="1A1A1A"/>
-                </a:solidFill>
-                <a:latin typeface="맑은 고딕"/>
-                <a:ea typeface="맑은 고딕"/>
-              </a:rPr>
-              <a:t>여지도 작다.</a:t>
-            </a:r>
-          </a:p>
-          <a:p>
-            <a:pPr algn="l"/>
-            <a:r>
-              <a:rPr sz="950" b="0">
-                <a:solidFill>
-                  <a:srgbClr val="1A1A1A"/>
-                </a:solidFill>
-                <a:latin typeface="맑은 고딕"/>
-                <a:ea typeface="맑은 고딕"/>
-              </a:rPr>
-              <a:t>- 개선이 있다면 KV가 HBM 밖에 있어 복원 비용이 TPOT에 섞이는 경우뿐이다. LoRA·MoE expert가 원격</a:t>
-            </a:r>
-          </a:p>
-          <a:p>
-            <a:pPr algn="l"/>
-            <a:r>
-              <a:rPr sz="950" b="0">
-                <a:solidFill>
-                  <a:srgbClr val="1A1A1A"/>
-                </a:solidFill>
-                <a:latin typeface="맑은 고딕"/>
-                <a:ea typeface="맑은 고딕"/>
-              </a:rPr>
-              <a:t>에 있을 때도 영향이 있으나 이번 비교 가능 시나리오에는 거의 없다(Baseline도 SLO 불가).</a:t>
-            </a:r>
-          </a:p>
-        </p:txBody>
-      </p:sp>
-      <p:sp>
-        <p:nvSpPr>
-          <p:cNvPr id="69" name="Rectangle 68"/>
+              <a:t>512 GiB (내부 DRAM)</a:t>
+            </a:r>
+          </a:p>
+        </p:txBody>
+      </p:sp>
+      <p:sp>
+        <p:nvSpPr>
+          <p:cNvPr id="75" name="Rectangle 74"/>
           <p:cNvSpPr/>
           <p:nvPr/>
         </p:nvSpPr>
         <p:spPr>
           <a:xfrm>
-            <a:off x="8961120" y="4572000"/>
-            <a:ext cx="2834640" cy="1234440"/>
-          </a:xfrm>
-          <a:prstGeom prst="rect">
-            <a:avLst/>
-          </a:prstGeom>
-          <a:solidFill>
-            <a:srgbClr val="F2F2F2"/>
+            <a:off x="3749039" y="2542032"/>
+            <a:ext cx="2651760" cy="566928"/>
+          </a:xfrm>
+          <a:prstGeom prst="rect">
+            <a:avLst/>
+          </a:prstGeom>
+          <a:solidFill>
+            <a:srgbClr val="FFFFFF"/>
           </a:solidFill>
           <a:ln w="9525">
             <a:solidFill>
@@ -7933,40 +8049,1074 @@
           <a:p>
             <a:pPr algn="l"/>
             <a:r>
-              <a:rPr sz="850" b="1">
+              <a:rPr sz="950" b="0">
+                <a:solidFill>
+                  <a:srgbClr val="1A1A1A"/>
+                </a:solidFill>
+                <a:latin typeface="맑은 고딕"/>
+                <a:ea typeface="맑은 고딕"/>
+              </a:rPr>
+              <a:t>CXL 2.0 (PCIe 5.0 PHY), host 경유</a:t>
+            </a:r>
+          </a:p>
+        </p:txBody>
+      </p:sp>
+      <p:sp>
+        <p:nvSpPr>
+          <p:cNvPr id="76" name="Rectangle 75"/>
+          <p:cNvSpPr/>
+          <p:nvPr/>
+        </p:nvSpPr>
+        <p:spPr>
+          <a:xfrm>
+            <a:off x="6400800" y="2542032"/>
+            <a:ext cx="2011680" cy="566928"/>
+          </a:xfrm>
+          <a:prstGeom prst="rect">
+            <a:avLst/>
+          </a:prstGeom>
+          <a:solidFill>
+            <a:srgbClr val="FFFFFF"/>
+          </a:solidFill>
+          <a:ln w="9525">
+            <a:solidFill>
+              <a:srgbClr val="BFBFBF"/>
+            </a:solidFill>
+          </a:ln>
+          <a:effectLst/>
+        </p:spPr>
+        <p:style>
+          <a:lnRef idx="1">
+            <a:schemeClr val="accent1"/>
+          </a:lnRef>
+          <a:fillRef idx="3">
+            <a:schemeClr val="accent1"/>
+          </a:fillRef>
+          <a:effectRef idx="2">
+            <a:schemeClr val="accent1"/>
+          </a:effectRef>
+          <a:fontRef idx="minor">
+            <a:schemeClr val="lt1"/>
+          </a:fontRef>
+        </p:style>
+        <p:txBody>
+          <a:bodyPr rtlCol="0" anchor="ctr" wrap="square" lIns="45720" rIns="45720" tIns="27432" bIns="27432"/>
+          <a:lstStyle/>
+          <a:p>
+            <a:pPr algn="l"/>
+            <a:r>
+              <a:rPr sz="950" b="0">
+                <a:solidFill>
+                  <a:srgbClr val="1A1A1A"/>
+                </a:solidFill>
+                <a:latin typeface="맑은 고딕"/>
+                <a:ea typeface="맑은 고딕"/>
+              </a:rPr>
+              <a:t>63 GB/s / 400 GB/s</a:t>
+            </a:r>
+          </a:p>
+        </p:txBody>
+      </p:sp>
+      <p:sp>
+        <p:nvSpPr>
+          <p:cNvPr id="77" name="Rectangle 76"/>
+          <p:cNvSpPr/>
+          <p:nvPr/>
+        </p:nvSpPr>
+        <p:spPr>
+          <a:xfrm>
+            <a:off x="8412480" y="2542032"/>
+            <a:ext cx="3383280" cy="566928"/>
+          </a:xfrm>
+          <a:prstGeom prst="rect">
+            <a:avLst/>
+          </a:prstGeom>
+          <a:solidFill>
+            <a:srgbClr val="FFFFFF"/>
+          </a:solidFill>
+          <a:ln w="9525">
+            <a:solidFill>
+              <a:srgbClr val="BFBFBF"/>
+            </a:solidFill>
+          </a:ln>
+          <a:effectLst/>
+        </p:spPr>
+        <p:style>
+          <a:lnRef idx="1">
+            <a:schemeClr val="accent1"/>
+          </a:lnRef>
+          <a:fillRef idx="3">
+            <a:schemeClr val="accent1"/>
+          </a:fillRef>
+          <a:effectRef idx="2">
+            <a:schemeClr val="accent1"/>
+          </a:effectRef>
+          <a:fontRef idx="minor">
+            <a:schemeClr val="lt1"/>
+          </a:fontRef>
+        </p:style>
+        <p:txBody>
+          <a:bodyPr rtlCol="0" anchor="ctr" wrap="square" lIns="45720" rIns="45720" tIns="27432" bIns="27432"/>
+          <a:lstStyle/>
+          <a:p>
+            <a:pPr algn="l"/>
+            <a:r>
+              <a:rPr sz="950" b="0">
+                <a:solidFill>
+                  <a:srgbClr val="1A1A1A"/>
+                </a:solidFill>
+                <a:latin typeface="맑은 고딕"/>
+                <a:ea typeface="맑은 고딕"/>
+              </a:rPr>
+              <a:t>3.28 TFLOPS · QK_GEMM, SOFTMAX, AV_GEMM, CAUSAL_</a:t>
+            </a:r>
+          </a:p>
+          <a:p>
+            <a:pPr algn="l"/>
+            <a:r>
+              <a:rPr sz="950" b="0">
+                <a:solidFill>
+                  <a:srgbClr val="1A1A1A"/>
+                </a:solidFill>
+                <a:latin typeface="맑은 고딕"/>
+                <a:ea typeface="맑은 고딕"/>
+              </a:rPr>
+              <a:t>MASK (attention 오프로드)</a:t>
+            </a:r>
+          </a:p>
+        </p:txBody>
+      </p:sp>
+      <p:sp>
+        <p:nvSpPr>
+          <p:cNvPr id="78" name="Rectangle 77"/>
+          <p:cNvSpPr/>
+          <p:nvPr/>
+        </p:nvSpPr>
+        <p:spPr>
+          <a:xfrm>
+            <a:off x="365760" y="3127248"/>
+            <a:ext cx="1920240" cy="566928"/>
+          </a:xfrm>
+          <a:prstGeom prst="rect">
+            <a:avLst/>
+          </a:prstGeom>
+          <a:solidFill>
+            <a:srgbClr val="DCE9F5"/>
+          </a:solidFill>
+          <a:ln w="9525">
+            <a:solidFill>
+              <a:srgbClr val="4D7EA8"/>
+            </a:solidFill>
+          </a:ln>
+          <a:effectLst/>
+        </p:spPr>
+        <p:style>
+          <a:lnRef idx="1">
+            <a:schemeClr val="accent1"/>
+          </a:lnRef>
+          <a:fillRef idx="3">
+            <a:schemeClr val="accent1"/>
+          </a:fillRef>
+          <a:effectRef idx="2">
+            <a:schemeClr val="accent1"/>
+          </a:effectRef>
+          <a:fontRef idx="minor">
+            <a:schemeClr val="lt1"/>
+          </a:fontRef>
+        </p:style>
+        <p:txBody>
+          <a:bodyPr rtlCol="0" anchor="ctr" wrap="square" lIns="45720" rIns="45720" tIns="27432" bIns="27432"/>
+          <a:lstStyle/>
+          <a:p>
+            <a:pPr algn="l"/>
+            <a:r>
+              <a:rPr sz="950" b="1">
+                <a:solidFill>
+                  <a:srgbClr val="1A1A1A"/>
+                </a:solidFill>
+                <a:latin typeface="맑은 고딕"/>
+                <a:ea typeface="맑은 고딕"/>
+              </a:rPr>
+              <a:t>DRAM (host)</a:t>
+            </a:r>
+          </a:p>
+        </p:txBody>
+      </p:sp>
+      <p:sp>
+        <p:nvSpPr>
+          <p:cNvPr id="79" name="Rectangle 78"/>
+          <p:cNvSpPr/>
+          <p:nvPr/>
+        </p:nvSpPr>
+        <p:spPr>
+          <a:xfrm>
+            <a:off x="2286000" y="3127248"/>
+            <a:ext cx="1463040" cy="566928"/>
+          </a:xfrm>
+          <a:prstGeom prst="rect">
+            <a:avLst/>
+          </a:prstGeom>
+          <a:solidFill>
+            <a:srgbClr val="FFFFFF"/>
+          </a:solidFill>
+          <a:ln w="9525">
+            <a:solidFill>
+              <a:srgbClr val="BFBFBF"/>
+            </a:solidFill>
+          </a:ln>
+          <a:effectLst/>
+        </p:spPr>
+        <p:style>
+          <a:lnRef idx="1">
+            <a:schemeClr val="accent1"/>
+          </a:lnRef>
+          <a:fillRef idx="3">
+            <a:schemeClr val="accent1"/>
+          </a:fillRef>
+          <a:effectRef idx="2">
+            <a:schemeClr val="accent1"/>
+          </a:effectRef>
+          <a:fontRef idx="minor">
+            <a:schemeClr val="lt1"/>
+          </a:fontRef>
+        </p:style>
+        <p:txBody>
+          <a:bodyPr rtlCol="0" anchor="ctr" wrap="square" lIns="45720" rIns="45720" tIns="27432" bIns="27432"/>
+          <a:lstStyle/>
+          <a:p>
+            <a:pPr algn="l"/>
+            <a:r>
+              <a:rPr sz="950" b="0">
+                <a:solidFill>
+                  <a:srgbClr val="1A1A1A"/>
+                </a:solidFill>
+                <a:latin typeface="맑은 고딕"/>
+                <a:ea typeface="맑은 고딕"/>
+              </a:rPr>
+              <a:t>1 TiB</a:t>
+            </a:r>
+          </a:p>
+        </p:txBody>
+      </p:sp>
+      <p:sp>
+        <p:nvSpPr>
+          <p:cNvPr id="80" name="Rectangle 79"/>
+          <p:cNvSpPr/>
+          <p:nvPr/>
+        </p:nvSpPr>
+        <p:spPr>
+          <a:xfrm>
+            <a:off x="3749039" y="3127248"/>
+            <a:ext cx="2651760" cy="566928"/>
+          </a:xfrm>
+          <a:prstGeom prst="rect">
+            <a:avLst/>
+          </a:prstGeom>
+          <a:solidFill>
+            <a:srgbClr val="FFFFFF"/>
+          </a:solidFill>
+          <a:ln w="9525">
+            <a:solidFill>
+              <a:srgbClr val="BFBFBF"/>
+            </a:solidFill>
+          </a:ln>
+          <a:effectLst/>
+        </p:spPr>
+        <p:style>
+          <a:lnRef idx="1">
+            <a:schemeClr val="accent1"/>
+          </a:lnRef>
+          <a:fillRef idx="3">
+            <a:schemeClr val="accent1"/>
+          </a:fillRef>
+          <a:effectRef idx="2">
+            <a:schemeClr val="accent1"/>
+          </a:effectRef>
+          <a:fontRef idx="minor">
+            <a:schemeClr val="lt1"/>
+          </a:fontRef>
+        </p:style>
+        <p:txBody>
+          <a:bodyPr rtlCol="0" anchor="ctr" wrap="square" lIns="45720" rIns="45720" tIns="27432" bIns="27432"/>
+          <a:lstStyle/>
+          <a:p>
+            <a:pPr algn="l"/>
+            <a:r>
+              <a:rPr sz="950" b="0">
+                <a:solidFill>
+                  <a:srgbClr val="1A1A1A"/>
+                </a:solidFill>
+                <a:latin typeface="맑은 고딕"/>
+                <a:ea typeface="맑은 고딕"/>
+              </a:rPr>
+              <a:t>GPU와 PCIe 5.0 x16 (DDR5)</a:t>
+            </a:r>
+          </a:p>
+        </p:txBody>
+      </p:sp>
+      <p:sp>
+        <p:nvSpPr>
+          <p:cNvPr id="81" name="Rectangle 80"/>
+          <p:cNvSpPr/>
+          <p:nvPr/>
+        </p:nvSpPr>
+        <p:spPr>
+          <a:xfrm>
+            <a:off x="6400800" y="3127248"/>
+            <a:ext cx="2011680" cy="566928"/>
+          </a:xfrm>
+          <a:prstGeom prst="rect">
+            <a:avLst/>
+          </a:prstGeom>
+          <a:solidFill>
+            <a:srgbClr val="FFFFFF"/>
+          </a:solidFill>
+          <a:ln w="9525">
+            <a:solidFill>
+              <a:srgbClr val="BFBFBF"/>
+            </a:solidFill>
+          </a:ln>
+          <a:effectLst/>
+        </p:spPr>
+        <p:style>
+          <a:lnRef idx="1">
+            <a:schemeClr val="accent1"/>
+          </a:lnRef>
+          <a:fillRef idx="3">
+            <a:schemeClr val="accent1"/>
+          </a:fillRef>
+          <a:effectRef idx="2">
+            <a:schemeClr val="accent1"/>
+          </a:effectRef>
+          <a:fontRef idx="minor">
+            <a:schemeClr val="lt1"/>
+          </a:fontRef>
+        </p:style>
+        <p:txBody>
+          <a:bodyPr rtlCol="0" anchor="ctr" wrap="square" lIns="45720" rIns="45720" tIns="27432" bIns="27432"/>
+          <a:lstStyle/>
+          <a:p>
+            <a:pPr algn="l"/>
+            <a:r>
+              <a:rPr sz="950" b="0">
+                <a:solidFill>
+                  <a:srgbClr val="1A1A1A"/>
+                </a:solidFill>
+                <a:latin typeface="맑은 고딕"/>
+                <a:ea typeface="맑은 고딕"/>
+              </a:rPr>
+              <a:t>64 GB/s / 300 / 400 GB/s</a:t>
+            </a:r>
+          </a:p>
+        </p:txBody>
+      </p:sp>
+      <p:sp>
+        <p:nvSpPr>
+          <p:cNvPr id="82" name="Rectangle 81"/>
+          <p:cNvSpPr/>
+          <p:nvPr/>
+        </p:nvSpPr>
+        <p:spPr>
+          <a:xfrm>
+            <a:off x="8412480" y="3127248"/>
+            <a:ext cx="3383280" cy="566928"/>
+          </a:xfrm>
+          <a:prstGeom prst="rect">
+            <a:avLst/>
+          </a:prstGeom>
+          <a:solidFill>
+            <a:srgbClr val="FFFFFF"/>
+          </a:solidFill>
+          <a:ln w="9525">
+            <a:solidFill>
+              <a:srgbClr val="BFBFBF"/>
+            </a:solidFill>
+          </a:ln>
+          <a:effectLst/>
+        </p:spPr>
+        <p:style>
+          <a:lnRef idx="1">
+            <a:schemeClr val="accent1"/>
+          </a:lnRef>
+          <a:fillRef idx="3">
+            <a:schemeClr val="accent1"/>
+          </a:fillRef>
+          <a:effectRef idx="2">
+            <a:schemeClr val="accent1"/>
+          </a:effectRef>
+          <a:fontRef idx="minor">
+            <a:schemeClr val="lt1"/>
+          </a:fontRef>
+        </p:style>
+        <p:txBody>
+          <a:bodyPr rtlCol="0" anchor="ctr" wrap="square" lIns="45720" rIns="45720" tIns="27432" bIns="27432"/>
+          <a:lstStyle/>
+          <a:p>
+            <a:pPr algn="l"/>
+            <a:r>
+              <a:rPr sz="950" b="0">
+                <a:solidFill>
+                  <a:srgbClr val="1A1A1A"/>
+                </a:solidFill>
+                <a:latin typeface="맑은 고딕"/>
+                <a:ea typeface="맑은 고딕"/>
+              </a:rPr>
+              <a:t>—</a:t>
+            </a:r>
+          </a:p>
+        </p:txBody>
+      </p:sp>
+      <p:sp>
+        <p:nvSpPr>
+          <p:cNvPr id="83" name="Rectangle 82"/>
+          <p:cNvSpPr/>
+          <p:nvPr/>
+        </p:nvSpPr>
+        <p:spPr>
+          <a:xfrm>
+            <a:off x="365760" y="3712464"/>
+            <a:ext cx="1920240" cy="566928"/>
+          </a:xfrm>
+          <a:prstGeom prst="rect">
+            <a:avLst/>
+          </a:prstGeom>
+          <a:solidFill>
+            <a:srgbClr val="DCE9F5"/>
+          </a:solidFill>
+          <a:ln w="9525">
+            <a:solidFill>
+              <a:srgbClr val="4D7EA8"/>
+            </a:solidFill>
+          </a:ln>
+          <a:effectLst/>
+        </p:spPr>
+        <p:style>
+          <a:lnRef idx="1">
+            <a:schemeClr val="accent1"/>
+          </a:lnRef>
+          <a:fillRef idx="3">
+            <a:schemeClr val="accent1"/>
+          </a:fillRef>
+          <a:effectRef idx="2">
+            <a:schemeClr val="accent1"/>
+          </a:effectRef>
+          <a:fontRef idx="minor">
+            <a:schemeClr val="lt1"/>
+          </a:fontRef>
+        </p:style>
+        <p:txBody>
+          <a:bodyPr rtlCol="0" anchor="ctr" wrap="square" lIns="45720" rIns="45720" tIns="27432" bIns="27432"/>
+          <a:lstStyle/>
+          <a:p>
+            <a:pPr algn="l"/>
+            <a:r>
+              <a:rPr sz="950" b="1">
+                <a:solidFill>
+                  <a:srgbClr val="1A1A1A"/>
+                </a:solidFill>
+                <a:latin typeface="맑은 고딕"/>
+                <a:ea typeface="맑은 고딕"/>
+              </a:rPr>
+              <a:t>HBF</a:t>
+            </a:r>
+          </a:p>
+        </p:txBody>
+      </p:sp>
+      <p:sp>
+        <p:nvSpPr>
+          <p:cNvPr id="84" name="Rectangle 83"/>
+          <p:cNvSpPr/>
+          <p:nvPr/>
+        </p:nvSpPr>
+        <p:spPr>
+          <a:xfrm>
+            <a:off x="2286000" y="3712464"/>
+            <a:ext cx="1463040" cy="566928"/>
+          </a:xfrm>
+          <a:prstGeom prst="rect">
+            <a:avLst/>
+          </a:prstGeom>
+          <a:solidFill>
+            <a:srgbClr val="FFFFFF"/>
+          </a:solidFill>
+          <a:ln w="9525">
+            <a:solidFill>
+              <a:srgbClr val="BFBFBF"/>
+            </a:solidFill>
+          </a:ln>
+          <a:effectLst/>
+        </p:spPr>
+        <p:style>
+          <a:lnRef idx="1">
+            <a:schemeClr val="accent1"/>
+          </a:lnRef>
+          <a:fillRef idx="3">
+            <a:schemeClr val="accent1"/>
+          </a:fillRef>
+          <a:effectRef idx="2">
+            <a:schemeClr val="accent1"/>
+          </a:effectRef>
+          <a:fontRef idx="minor">
+            <a:schemeClr val="lt1"/>
+          </a:fontRef>
+        </p:style>
+        <p:txBody>
+          <a:bodyPr rtlCol="0" anchor="ctr" wrap="square" lIns="45720" rIns="45720" tIns="27432" bIns="27432"/>
+          <a:lstStyle/>
+          <a:p>
+            <a:pPr algn="l"/>
+            <a:r>
+              <a:rPr sz="950" b="0">
+                <a:solidFill>
+                  <a:srgbClr val="1A1A1A"/>
+                </a:solidFill>
+                <a:latin typeface="맑은 고딕"/>
+                <a:ea typeface="맑은 고딕"/>
+              </a:rPr>
+              <a:t>2 TiB</a:t>
+            </a:r>
+          </a:p>
+        </p:txBody>
+      </p:sp>
+      <p:sp>
+        <p:nvSpPr>
+          <p:cNvPr id="85" name="Rectangle 84"/>
+          <p:cNvSpPr/>
+          <p:nvPr/>
+        </p:nvSpPr>
+        <p:spPr>
+          <a:xfrm>
+            <a:off x="3749039" y="3712464"/>
+            <a:ext cx="2651760" cy="566928"/>
+          </a:xfrm>
+          <a:prstGeom prst="rect">
+            <a:avLst/>
+          </a:prstGeom>
+          <a:solidFill>
+            <a:srgbClr val="FFFFFF"/>
+          </a:solidFill>
+          <a:ln w="9525">
+            <a:solidFill>
+              <a:srgbClr val="BFBFBF"/>
+            </a:solidFill>
+          </a:ln>
+          <a:effectLst/>
+        </p:spPr>
+        <p:style>
+          <a:lnRef idx="1">
+            <a:schemeClr val="accent1"/>
+          </a:lnRef>
+          <a:fillRef idx="3">
+            <a:schemeClr val="accent1"/>
+          </a:fillRef>
+          <a:effectRef idx="2">
+            <a:schemeClr val="accent1"/>
+          </a:effectRef>
+          <a:fontRef idx="minor">
+            <a:schemeClr val="lt1"/>
+          </a:fontRef>
+        </p:style>
+        <p:txBody>
+          <a:bodyPr rtlCol="0" anchor="ctr" wrap="square" lIns="45720" rIns="45720" tIns="27432" bIns="27432"/>
+          <a:lstStyle/>
+          <a:p>
+            <a:pPr algn="l"/>
+            <a:r>
+              <a:rPr sz="950" b="0">
+                <a:solidFill>
+                  <a:srgbClr val="1A1A1A"/>
+                </a:solidFill>
+                <a:latin typeface="맑은 고딕"/>
+                <a:ea typeface="맑은 고딕"/>
+              </a:rPr>
+              <a:t>GPU 직접 접근 (UCIe), PCIe 아님</a:t>
+            </a:r>
+          </a:p>
+        </p:txBody>
+      </p:sp>
+      <p:sp>
+        <p:nvSpPr>
+          <p:cNvPr id="86" name="Rectangle 85"/>
+          <p:cNvSpPr/>
+          <p:nvPr/>
+        </p:nvSpPr>
+        <p:spPr>
+          <a:xfrm>
+            <a:off x="6400800" y="3712464"/>
+            <a:ext cx="2011680" cy="566928"/>
+          </a:xfrm>
+          <a:prstGeom prst="rect">
+            <a:avLst/>
+          </a:prstGeom>
+          <a:solidFill>
+            <a:srgbClr val="FFFFFF"/>
+          </a:solidFill>
+          <a:ln w="9525">
+            <a:solidFill>
+              <a:srgbClr val="BFBFBF"/>
+            </a:solidFill>
+          </a:ln>
+          <a:effectLst/>
+        </p:spPr>
+        <p:style>
+          <a:lnRef idx="1">
+            <a:schemeClr val="accent1"/>
+          </a:lnRef>
+          <a:fillRef idx="3">
+            <a:schemeClr val="accent1"/>
+          </a:fillRef>
+          <a:effectRef idx="2">
+            <a:schemeClr val="accent1"/>
+          </a:effectRef>
+          <a:fontRef idx="minor">
+            <a:schemeClr val="lt1"/>
+          </a:fontRef>
+        </p:style>
+        <p:txBody>
+          <a:bodyPr rtlCol="0" anchor="ctr" wrap="square" lIns="45720" rIns="45720" tIns="27432" bIns="27432"/>
+          <a:lstStyle/>
+          <a:p>
+            <a:pPr algn="l"/>
+            <a:r>
+              <a:rPr sz="950" b="0">
+                <a:solidFill>
+                  <a:srgbClr val="1A1A1A"/>
+                </a:solidFill>
+                <a:latin typeface="맑은 고딕"/>
+                <a:ea typeface="맑은 고딕"/>
+              </a:rPr>
+              <a:t>읽기 1,000 GB/s, 쓰기 50 GB/s</a:t>
+            </a:r>
+          </a:p>
+        </p:txBody>
+      </p:sp>
+      <p:sp>
+        <p:nvSpPr>
+          <p:cNvPr id="87" name="Rectangle 86"/>
+          <p:cNvSpPr/>
+          <p:nvPr/>
+        </p:nvSpPr>
+        <p:spPr>
+          <a:xfrm>
+            <a:off x="8412480" y="3712464"/>
+            <a:ext cx="3383280" cy="566928"/>
+          </a:xfrm>
+          <a:prstGeom prst="rect">
+            <a:avLst/>
+          </a:prstGeom>
+          <a:solidFill>
+            <a:srgbClr val="FFFFFF"/>
+          </a:solidFill>
+          <a:ln w="9525">
+            <a:solidFill>
+              <a:srgbClr val="BFBFBF"/>
+            </a:solidFill>
+          </a:ln>
+          <a:effectLst/>
+        </p:spPr>
+        <p:style>
+          <a:lnRef idx="1">
+            <a:schemeClr val="accent1"/>
+          </a:lnRef>
+          <a:fillRef idx="3">
+            <a:schemeClr val="accent1"/>
+          </a:fillRef>
+          <a:effectRef idx="2">
+            <a:schemeClr val="accent1"/>
+          </a:effectRef>
+          <a:fontRef idx="minor">
+            <a:schemeClr val="lt1"/>
+          </a:fontRef>
+        </p:style>
+        <p:txBody>
+          <a:bodyPr rtlCol="0" anchor="ctr" wrap="square" lIns="45720" rIns="45720" tIns="27432" bIns="27432"/>
+          <a:lstStyle/>
+          <a:p>
+            <a:pPr algn="l"/>
+            <a:r>
+              <a:rPr sz="950" b="0">
+                <a:solidFill>
+                  <a:srgbClr val="1A1A1A"/>
+                </a:solidFill>
+                <a:latin typeface="맑은 고딕"/>
+                <a:ea typeface="맑은 고딕"/>
+              </a:rPr>
+              <a:t>—</a:t>
+            </a:r>
+          </a:p>
+        </p:txBody>
+      </p:sp>
+      <p:sp>
+        <p:nvSpPr>
+          <p:cNvPr id="88" name="Rectangle 87"/>
+          <p:cNvSpPr/>
+          <p:nvPr/>
+        </p:nvSpPr>
+        <p:spPr>
+          <a:xfrm>
+            <a:off x="365760" y="4297680"/>
+            <a:ext cx="1920240" cy="566928"/>
+          </a:xfrm>
+          <a:prstGeom prst="rect">
+            <a:avLst/>
+          </a:prstGeom>
+          <a:solidFill>
+            <a:srgbClr val="DCE9F5"/>
+          </a:solidFill>
+          <a:ln w="9525">
+            <a:solidFill>
+              <a:srgbClr val="4D7EA8"/>
+            </a:solidFill>
+          </a:ln>
+          <a:effectLst/>
+        </p:spPr>
+        <p:style>
+          <a:lnRef idx="1">
+            <a:schemeClr val="accent1"/>
+          </a:lnRef>
+          <a:fillRef idx="3">
+            <a:schemeClr val="accent1"/>
+          </a:fillRef>
+          <a:effectRef idx="2">
+            <a:schemeClr val="accent1"/>
+          </a:effectRef>
+          <a:fontRef idx="minor">
+            <a:schemeClr val="lt1"/>
+          </a:fontRef>
+        </p:style>
+        <p:txBody>
+          <a:bodyPr rtlCol="0" anchor="ctr" wrap="square" lIns="45720" rIns="45720" tIns="27432" bIns="27432"/>
+          <a:lstStyle/>
+          <a:p>
+            <a:pPr algn="l"/>
+            <a:r>
+              <a:rPr sz="950" b="1">
+                <a:solidFill>
+                  <a:srgbClr val="1A1A1A"/>
+                </a:solidFill>
+                <a:latin typeface="맑은 고딕"/>
+                <a:ea typeface="맑은 고딕"/>
+              </a:rPr>
+              <a:t>SSD-PIM</a:t>
+            </a:r>
+          </a:p>
+        </p:txBody>
+      </p:sp>
+      <p:sp>
+        <p:nvSpPr>
+          <p:cNvPr id="89" name="Rectangle 88"/>
+          <p:cNvSpPr/>
+          <p:nvPr/>
+        </p:nvSpPr>
+        <p:spPr>
+          <a:xfrm>
+            <a:off x="2286000" y="4297680"/>
+            <a:ext cx="1463040" cy="566928"/>
+          </a:xfrm>
+          <a:prstGeom prst="rect">
+            <a:avLst/>
+          </a:prstGeom>
+          <a:solidFill>
+            <a:srgbClr val="FFFFFF"/>
+          </a:solidFill>
+          <a:ln w="9525">
+            <a:solidFill>
+              <a:srgbClr val="BFBFBF"/>
+            </a:solidFill>
+          </a:ln>
+          <a:effectLst/>
+        </p:spPr>
+        <p:style>
+          <a:lnRef idx="1">
+            <a:schemeClr val="accent1"/>
+          </a:lnRef>
+          <a:fillRef idx="3">
+            <a:schemeClr val="accent1"/>
+          </a:fillRef>
+          <a:effectRef idx="2">
+            <a:schemeClr val="accent1"/>
+          </a:effectRef>
+          <a:fontRef idx="minor">
+            <a:schemeClr val="lt1"/>
+          </a:fontRef>
+        </p:style>
+        <p:txBody>
+          <a:bodyPr rtlCol="0" anchor="ctr" wrap="square" lIns="45720" rIns="45720" tIns="27432" bIns="27432"/>
+          <a:lstStyle/>
+          <a:p>
+            <a:pPr algn="l"/>
+            <a:r>
+              <a:rPr sz="950" b="0">
+                <a:solidFill>
+                  <a:srgbClr val="1A1A1A"/>
+                </a:solidFill>
+                <a:latin typeface="맑은 고딕"/>
+                <a:ea typeface="맑은 고딕"/>
+              </a:rPr>
+              <a:t>16 TiB</a:t>
+            </a:r>
+          </a:p>
+        </p:txBody>
+      </p:sp>
+      <p:sp>
+        <p:nvSpPr>
+          <p:cNvPr id="90" name="Rectangle 89"/>
+          <p:cNvSpPr/>
+          <p:nvPr/>
+        </p:nvSpPr>
+        <p:spPr>
+          <a:xfrm>
+            <a:off x="3749039" y="4297680"/>
+            <a:ext cx="2651760" cy="566928"/>
+          </a:xfrm>
+          <a:prstGeom prst="rect">
+            <a:avLst/>
+          </a:prstGeom>
+          <a:solidFill>
+            <a:srgbClr val="FFFFFF"/>
+          </a:solidFill>
+          <a:ln w="9525">
+            <a:solidFill>
+              <a:srgbClr val="BFBFBF"/>
+            </a:solidFill>
+          </a:ln>
+          <a:effectLst/>
+        </p:spPr>
+        <p:style>
+          <a:lnRef idx="1">
+            <a:schemeClr val="accent1"/>
+          </a:lnRef>
+          <a:fillRef idx="3">
+            <a:schemeClr val="accent1"/>
+          </a:fillRef>
+          <a:effectRef idx="2">
+            <a:schemeClr val="accent1"/>
+          </a:effectRef>
+          <a:fontRef idx="minor">
+            <a:schemeClr val="lt1"/>
+          </a:fontRef>
+        </p:style>
+        <p:txBody>
+          <a:bodyPr rtlCol="0" anchor="ctr" wrap="square" lIns="45720" rIns="45720" tIns="27432" bIns="27432"/>
+          <a:lstStyle/>
+          <a:p>
+            <a:pPr algn="l"/>
+            <a:r>
+              <a:rPr sz="950" b="0">
+                <a:solidFill>
+                  <a:srgbClr val="1A1A1A"/>
+                </a:solidFill>
+                <a:latin typeface="맑은 고딕"/>
+                <a:ea typeface="맑은 고딕"/>
+              </a:rPr>
+              <a:t>NVMe PCIe 5.0 x4</a:t>
+            </a:r>
+          </a:p>
+        </p:txBody>
+      </p:sp>
+      <p:sp>
+        <p:nvSpPr>
+          <p:cNvPr id="91" name="Rectangle 90"/>
+          <p:cNvSpPr/>
+          <p:nvPr/>
+        </p:nvSpPr>
+        <p:spPr>
+          <a:xfrm>
+            <a:off x="6400800" y="4297680"/>
+            <a:ext cx="2011680" cy="566928"/>
+          </a:xfrm>
+          <a:prstGeom prst="rect">
+            <a:avLst/>
+          </a:prstGeom>
+          <a:solidFill>
+            <a:srgbClr val="FFFFFF"/>
+          </a:solidFill>
+          <a:ln w="9525">
+            <a:solidFill>
+              <a:srgbClr val="BFBFBF"/>
+            </a:solidFill>
+          </a:ln>
+          <a:effectLst/>
+        </p:spPr>
+        <p:style>
+          <a:lnRef idx="1">
+            <a:schemeClr val="accent1"/>
+          </a:lnRef>
+          <a:fillRef idx="3">
+            <a:schemeClr val="accent1"/>
+          </a:fillRef>
+          <a:effectRef idx="2">
+            <a:schemeClr val="accent1"/>
+          </a:effectRef>
+          <a:fontRef idx="minor">
+            <a:schemeClr val="lt1"/>
+          </a:fontRef>
+        </p:style>
+        <p:txBody>
+          <a:bodyPr rtlCol="0" anchor="ctr" wrap="square" lIns="45720" rIns="45720" tIns="27432" bIns="27432"/>
+          <a:lstStyle/>
+          <a:p>
+            <a:pPr algn="l"/>
+            <a:r>
+              <a:rPr sz="950" b="0">
+                <a:solidFill>
+                  <a:srgbClr val="1A1A1A"/>
+                </a:solidFill>
+                <a:latin typeface="맑은 고딕"/>
+                <a:ea typeface="맑은 고딕"/>
+              </a:rPr>
+              <a:t>16 GB/s / 200 GB/s</a:t>
+            </a:r>
+          </a:p>
+        </p:txBody>
+      </p:sp>
+      <p:sp>
+        <p:nvSpPr>
+          <p:cNvPr id="92" name="Rectangle 91"/>
+          <p:cNvSpPr/>
+          <p:nvPr/>
+        </p:nvSpPr>
+        <p:spPr>
+          <a:xfrm>
+            <a:off x="8412480" y="4297680"/>
+            <a:ext cx="3383280" cy="566928"/>
+          </a:xfrm>
+          <a:prstGeom prst="rect">
+            <a:avLst/>
+          </a:prstGeom>
+          <a:solidFill>
+            <a:srgbClr val="FFFFFF"/>
+          </a:solidFill>
+          <a:ln w="9525">
+            <a:solidFill>
+              <a:srgbClr val="BFBFBF"/>
+            </a:solidFill>
+          </a:ln>
+          <a:effectLst/>
+        </p:spPr>
+        <p:style>
+          <a:lnRef idx="1">
+            <a:schemeClr val="accent1"/>
+          </a:lnRef>
+          <a:fillRef idx="3">
+            <a:schemeClr val="accent1"/>
+          </a:fillRef>
+          <a:effectRef idx="2">
+            <a:schemeClr val="accent1"/>
+          </a:effectRef>
+          <a:fontRef idx="minor">
+            <a:schemeClr val="lt1"/>
+          </a:fontRef>
+        </p:style>
+        <p:txBody>
+          <a:bodyPr rtlCol="0" anchor="ctr" wrap="square" lIns="45720" rIns="45720" tIns="27432" bIns="27432"/>
+          <a:lstStyle/>
+          <a:p>
+            <a:pPr algn="l"/>
+            <a:r>
+              <a:rPr sz="950" b="0">
+                <a:solidFill>
+                  <a:srgbClr val="1A1A1A"/>
+                </a:solidFill>
+                <a:latin typeface="맑은 고딕"/>
+                <a:ea typeface="맑은 고딕"/>
+              </a:rPr>
+              <a:t>2 TFLOPS · GEMV (벡터 DB 유사도 계산만)</a:t>
+            </a:r>
+          </a:p>
+        </p:txBody>
+      </p:sp>
+      <p:sp>
+        <p:nvSpPr>
+          <p:cNvPr id="93" name="Rectangle 92"/>
+          <p:cNvSpPr/>
+          <p:nvPr/>
+        </p:nvSpPr>
+        <p:spPr>
+          <a:xfrm>
+            <a:off x="365760" y="4956048"/>
+            <a:ext cx="11430000" cy="1417320"/>
+          </a:xfrm>
+          <a:prstGeom prst="rect">
+            <a:avLst/>
+          </a:prstGeom>
+          <a:solidFill>
+            <a:srgbClr val="F2F2F2"/>
+          </a:solidFill>
+          <a:ln w="9525">
+            <a:solidFill>
+              <a:srgbClr val="BFBFBF"/>
+            </a:solidFill>
+          </a:ln>
+          <a:effectLst/>
+        </p:spPr>
+        <p:style>
+          <a:lnRef idx="1">
+            <a:schemeClr val="accent1"/>
+          </a:lnRef>
+          <a:fillRef idx="3">
+            <a:schemeClr val="accent1"/>
+          </a:fillRef>
+          <a:effectRef idx="2">
+            <a:schemeClr val="accent1"/>
+          </a:effectRef>
+          <a:fontRef idx="minor">
+            <a:schemeClr val="lt1"/>
+          </a:fontRef>
+        </p:style>
+        <p:txBody>
+          <a:bodyPr rtlCol="0" anchor="t" wrap="square" lIns="45720" rIns="45720" tIns="27432" bIns="27432"/>
+          <a:lstStyle/>
+          <a:p>
+            <a:pPr algn="l"/>
+            <a:r>
+              <a:rPr sz="900" b="1">
                 <a:solidFill>
                   <a:srgbClr val="404040"/>
                 </a:solidFill>
                 <a:latin typeface="맑은 고딕"/>
                 <a:ea typeface="맑은 고딕"/>
               </a:rPr>
-              <a:t>Baseline TPOT P99 geomean 17.1 ms, SLO 50 ms</a:t>
-            </a:r>
-          </a:p>
-          <a:p>
-            <a:pPr algn="l"/>
-            <a:r>
-              <a:rPr sz="850" b="0">
+              <a:t>시뮬레이션 반영: 용량, 외부·내부 대역폭, 지연, 쓰기 대역폭, 연산 능력과 지원 연산을 모두 쓴다. attention을 오프로드할 수 있는 tier는 4개 연산(QK_GEMM, SOFTMAX, AV_GEMM, CAUSAL_MASK)과 연산 능력을 모두 가</a:t>
+            </a:r>
+          </a:p>
+          <a:p>
+            <a:pPr algn="l"/>
+            <a:r>
+              <a:rPr sz="900" b="0">
                 <a:solidFill>
                   <a:srgbClr val="404040"/>
                 </a:solidFill>
                 <a:latin typeface="맑은 고딕"/>
                 <a:ea typeface="맑은 고딕"/>
               </a:rPr>
-              <a:t>LoRA·MoE 시나리오는 Baseline이 TPOT SLO를 못 맞춰 비</a:t>
-            </a:r>
-          </a:p>
-          <a:p>
-            <a:pPr algn="l"/>
-            <a:r>
-              <a:rPr sz="850" b="0">
+              <a:t>진 ScHBM과 CXL-PNM뿐이며, 그때의 지연은 max(내부 BW 기반 읽기 시간, 연산 시간) + 활성 전송 + layer별 왕복으로 계산한다. SSD-PIM은 GEMV로 벡터 DB 유사도 계산에만 쓴다.</a:t>
+            </a:r>
+          </a:p>
+          <a:p>
+            <a:pPr algn="l"/>
+            <a:r>
+              <a:rPr sz="900" b="0">
                 <a:solidFill>
                   <a:srgbClr val="404040"/>
                 </a:solidFill>
                 <a:latin typeface="맑은 고딕"/>
                 <a:ea typeface="맑은 고딕"/>
               </a:rPr>
-              <a:t>교에서 제외</a:t>
+              <a:t>미반영: HBF의 쓰기 증폭(3.0)과 endurance(100 PB), PCIe/CXL 프로토콜 오버헤드(링크는 이론 대역폭), 전력.</a:t>
+            </a:r>
+          </a:p>
+          <a:p>
+            <a:pPr algn="l"/>
+            <a:r>
+              <a:rPr sz="900" b="0">
+                <a:solidFill>
+                  <a:srgbClr val="404040"/>
+                </a:solidFill>
+                <a:latin typeface="맑은 고딕"/>
+                <a:ea typeface="맑은 고딕"/>
+              </a:rPr>
+              <a:t>값의 출처: ScHBM 용량·내부 BW·연산은 페어링 GPU 상대 규칙(용량 2배, 내부 BW 2배, 연산 20%), CXL-PNM 연산(FP32 1.64 TFLOPS의 2배), HBF·SSD-PIM 일부 값은 ASSUMED. 상세: system-specs.md</a:t>
             </a:r>
           </a:p>
         </p:txBody>
@@ -8115,7 +9265,7 @@
                   <a:schemeClr val="bg1"/>
                 </a:solidFill>
               </a:rPr>
-              <a:t>DP1 평가 결과 - QA별로 왜 이런 값이 나왔나 (2/2: 자원, 확장성)</a:t>
+              <a:t>DP1 평가 결과 - QA별로 왜 이런 값이 나왔나 (1/2: 처리량, 지연)</a:t>
             </a:r>
             <a:r>
               <a:rPr lang="en-US" altLang="ko-KR" sz="1400" b="1" dirty="0">
@@ -8404,7 +9554,7 @@
         <p:spPr>
           <a:xfrm>
             <a:off x="365760" y="1371600"/>
-            <a:ext cx="2651760" cy="1737360"/>
+            <a:ext cx="2651760" cy="1600200"/>
           </a:xfrm>
           <a:prstGeom prst="rect">
             <a:avLst/>
@@ -8446,7 +9596,7 @@
                 <a:latin typeface="맑은 고딕"/>
                 <a:ea typeface="맑은 고딕"/>
               </a:rPr>
-              <a:t>QA3 자원 사용 (HBM)</a:t>
+              <a:t>QA1 처리량</a:t>
             </a:r>
           </a:p>
           <a:p>
@@ -8459,33 +9609,7 @@
                 <a:latin typeface="맑은 고딕"/>
                 <a:ea typeface="맑은 고딕"/>
               </a:rPr>
-              <a:t>C1 x0.97 · C2 x1.21</a:t>
-            </a:r>
-          </a:p>
-          <a:p>
-            <a:pPr algn="l"/>
-            <a:r>
-              <a:rPr sz="950" b="1">
-                <a:solidFill>
-                  <a:srgbClr val="1A1A1A"/>
-                </a:solidFill>
-                <a:latin typeface="맑은 고딕"/>
-                <a:ea typeface="맑은 고딕"/>
-              </a:rPr>
-              <a:t>(HBM을 줄인/늘린 시나리오 C1 9/3, C2 1/1</a:t>
-            </a:r>
-          </a:p>
-          <a:p>
-            <a:pPr algn="l"/>
-            <a:r>
-              <a:rPr sz="950" b="1">
-                <a:solidFill>
-                  <a:srgbClr val="1A1A1A"/>
-                </a:solidFill>
-                <a:latin typeface="맑은 고딕"/>
-                <a:ea typeface="맑은 고딕"/>
-              </a:rPr>
-              <a:t>8)</a:t>
+              <a:t>C1 x1.30 · C2 x1.42</a:t>
             </a:r>
           </a:p>
         </p:txBody>
@@ -8499,7 +9623,7 @@
         <p:spPr>
           <a:xfrm>
             <a:off x="3017520" y="1371600"/>
-            <a:ext cx="5943600" cy="1737360"/>
+            <a:ext cx="5943600" cy="1600200"/>
           </a:xfrm>
           <a:prstGeom prst="rect">
             <a:avLst/>
@@ -8541,7 +9665,7 @@
                 <a:latin typeface="맑은 고딕"/>
                 <a:ea typeface="맑은 고딕"/>
               </a:rPr>
-              <a:t>- 이동은 데이터 총량을 바꾸지 않고 어느 메모리에 두느냐만 바꾼다. 그래서 전 메모리 합 점유는 후보와</a:t>
+              <a:t>- 비교 가능·포화 31쌍 중 C1 25쌍, C2 21쌍은 Baseline과 같다. Baseline이 이미 SLO를 만족하면 올릴 </a:t>
             </a:r>
           </a:p>
           <a:p>
@@ -8554,7 +9678,7 @@
                 <a:latin typeface="맑은 고딕"/>
                 <a:ea typeface="맑은 고딕"/>
               </a:rPr>
-              <a:t>무관하고, 'HBM에 얼마나 두는가'가 차이를 만든다.</a:t>
+              <a:t>여지가 없기 때문이다 (공통 시나리오 x1.00).</a:t>
             </a:r>
           </a:p>
           <a:p>
@@ -8567,7 +9691,7 @@
                 <a:latin typeface="맑은 고딕"/>
                 <a:ea typeface="맑은 고딕"/>
               </a:rPr>
-              <a:t>- C2는 성능을 위해 hot 데이터를 HBM으로 올려 HBM 사용이 늘어난다(비교 가능 21쌍 중 18쌍에서 증</a:t>
+              <a:t>- 이득은 hot 대상이 시간에 따라 옮겨 가는 Dynamic 시나리오에 집중된다 (승 C1 6, C2 10쌍).</a:t>
             </a:r>
           </a:p>
           <a:p>
@@ -8580,7 +9704,7 @@
                 <a:latin typeface="맑은 고딕"/>
                 <a:ea typeface="맑은 고딕"/>
               </a:rPr>
-              <a:t>가). C1은 HBM 압박이 있으면 데이터를 내리고(HBM 감소), DRAM 링크가 포화로 보일 때는 DRAM에서 </a:t>
+              <a:t>- C2는 데이터마다 접근 빈도·재사용·유휴를 보고 이동해 같은 종류(KV) 안의 hot/cold를 구분한다. C1은 </a:t>
             </a:r>
           </a:p>
           <a:p>
@@ -8593,33 +9717,7 @@
                 <a:latin typeface="맑은 고딕"/>
                 <a:ea typeface="맑은 고딕"/>
               </a:rPr>
-              <a:t>더 싼 HBF로 옮겨 HBM 사용을 늘리지 않는다.</a:t>
-            </a:r>
-          </a:p>
-          <a:p>
-            <a:pPr algn="l"/>
-            <a:r>
-              <a:rPr sz="950" b="0">
-                <a:solidFill>
-                  <a:srgbClr val="1A1A1A"/>
-                </a:solidFill>
-                <a:latin typeface="맑은 고딕"/>
-                <a:ea typeface="맑은 고딕"/>
-              </a:rPr>
-              <a:t>- 성능과 자원은 반대 방향이다: C2는 성능을 얻는 대신 HBM을 더 쓰고, C1은 덜 쓰되 성능 이득이 작다.</a:t>
-            </a:r>
-          </a:p>
-          <a:p>
-            <a:pPr algn="l"/>
-            <a:r>
-              <a:rPr sz="950" b="0">
-                <a:solidFill>
-                  <a:srgbClr val="1A1A1A"/>
-                </a:solidFill>
-                <a:latin typeface="맑은 고딕"/>
-                <a:ea typeface="맑은 고딕"/>
-              </a:rPr>
-              <a:t>- 보조 지표: 비용 가중 점유(DRAM 대비 상대 가격, ASSUMED) C1 x0.94, C2 x1.04로 같은 방향.</a:t>
+              <a:t>자원 압박에만 반응해 구분하지 못한다.</a:t>
             </a:r>
           </a:p>
         </p:txBody>
@@ -8633,7 +9731,7 @@
         <p:spPr>
           <a:xfrm>
             <a:off x="8961120" y="1371600"/>
-            <a:ext cx="2834640" cy="1737360"/>
+            <a:ext cx="2834640" cy="1600200"/>
           </a:xfrm>
           <a:prstGeom prst="rect">
             <a:avLst/>
@@ -8675,7 +9773,7 @@
                 <a:latin typeface="맑은 고딕"/>
                 <a:ea typeface="맑은 고딕"/>
               </a:rPr>
-              <a:t>cb_kv_8k_b32 (B200) HBM 사용: Baseline 72 GiB, C1 7</a:t>
+              <a:t>dyn_kv_hotset_recency_shift (B200): C1 x1.11, C2 x2.62</a:t>
             </a:r>
           </a:p>
           <a:p>
@@ -8688,7 +9786,7 @@
                 <a:latin typeface="맑은 고딕"/>
                 <a:ea typeface="맑은 고딕"/>
               </a:rPr>
-              <a:t>2, C2 98</a:t>
+              <a:t>. 이동량 C1 70 GiB 대 C2 2,210 GiB.</a:t>
             </a:r>
           </a:p>
           <a:p>
@@ -8701,20 +9799,7 @@
                 <a:latin typeface="맑은 고딕"/>
                 <a:ea typeface="맑은 고딕"/>
               </a:rPr>
-              <a:t>정의 이력: 활용률 -&gt; 풀 -&gt; 성능÷비용 -&gt; HBM 사용량. 마</a:t>
-            </a:r>
-          </a:p>
-          <a:p>
-            <a:pPr algn="l"/>
-            <a:r>
-              <a:rPr sz="850" b="0">
-                <a:solidFill>
-                  <a:srgbClr val="404040"/>
-                </a:solidFill>
-                <a:latin typeface="맑은 고딕"/>
-                <a:ea typeface="맑은 고딕"/>
-              </a:rPr>
-              <a:t>지막 변경으로 선택이 C2에서 C1로 바뀜</a:t>
+              <a:t>공통 cb_kv_8k_b32: 모두 x1.00</a:t>
             </a:r>
           </a:p>
         </p:txBody>
@@ -8727,8 +9812,8 @@
         </p:nvSpPr>
         <p:spPr>
           <a:xfrm>
-            <a:off x="365760" y="3154680"/>
-            <a:ext cx="2651760" cy="1600200"/>
+            <a:off x="365760" y="3017520"/>
+            <a:ext cx="2651760" cy="1508760"/>
           </a:xfrm>
           <a:prstGeom prst="rect">
             <a:avLst/>
@@ -8770,7 +9855,7 @@
                 <a:latin typeface="맑은 고딕"/>
                 <a:ea typeface="맑은 고딕"/>
               </a:rPr>
-              <a:t>QA4 확장성</a:t>
+              <a:t>QA2 TTFT</a:t>
             </a:r>
           </a:p>
           <a:p>
@@ -8783,7 +9868,7 @@
                 <a:latin typeface="맑은 고딕"/>
                 <a:ea typeface="맑은 고딕"/>
               </a:rPr>
-              <a:t>C1 module 1.75 · C2 2.50</a:t>
+              <a:t>P50 C1 x0.44 · C2 x0.29</a:t>
             </a:r>
           </a:p>
           <a:p>
@@ -8796,20 +9881,7 @@
                 <a:latin typeface="맑은 고딕"/>
                 <a:ea typeface="맑은 고딕"/>
               </a:rPr>
-              <a:t>공수 0.38 vs 0.51 MM</a:t>
-            </a:r>
-          </a:p>
-          <a:p>
-            <a:pPr algn="l"/>
-            <a:r>
-              <a:rPr sz="950" b="1">
-                <a:solidFill>
-                  <a:srgbClr val="1A1A1A"/>
-                </a:solidFill>
-                <a:latin typeface="맑은 고딕"/>
-                <a:ea typeface="맑은 고딕"/>
-              </a:rPr>
-              <a:t>에이전트 비용 $1.16 vs $1.49</a:t>
+              <a:t>P99 C1 x1.04 · C2 x0.72</a:t>
             </a:r>
           </a:p>
         </p:txBody>
@@ -8822,8 +9894,8 @@
         </p:nvSpPr>
         <p:spPr>
           <a:xfrm>
-            <a:off x="3017520" y="3154680"/>
-            <a:ext cx="5943600" cy="1600200"/>
+            <a:off x="3017520" y="3017520"/>
+            <a:ext cx="5943600" cy="1508760"/>
           </a:xfrm>
           <a:prstGeom prst="rect">
             <a:avLst/>
@@ -8865,7 +9937,7 @@
                 <a:latin typeface="맑은 고딕"/>
                 <a:ea typeface="맑은 고딕"/>
               </a:rPr>
-              <a:t>- 변경 시나리오 4종(새 메모리, 새 데이터 종류, 정책 교체, 새 event)을 시뮬레이터 복사본에 실제로 구</a:t>
+              <a:t>- P50이 크게 줄어드는 가장 큰 이유로 보이는 것: hot 데이터가 느린 tier(DRAM/HBF)에서 HBM으로 올라</a:t>
             </a:r>
           </a:p>
           <a:p>
@@ -8878,7 +9950,7 @@
                 <a:latin typeface="맑은 고딕"/>
                 <a:ea typeface="맑은 고딕"/>
               </a:rPr>
-              <a:t>현해 module 수를 쟀다.</a:t>
+              <a:t>가 첫 토큰 전 복원 대기가 줄어든다(요청 단위로 분해하지는 않았다).</a:t>
             </a:r>
           </a:p>
           <a:p>
@@ -8891,7 +9963,7 @@
                 <a:latin typeface="맑은 고딕"/>
                 <a:ea typeface="맑은 고딕"/>
               </a:rPr>
-              <a:t>- C1은 데이터 종류를 모르는 구조라 새 데이터 종류를 추가해도 고칠 곳이 거의 없다. C2는 종류별 특성</a:t>
+              <a:t>- C1의 P99는 개선이 없다(x1.04). 진단한 `cb_kv_8k_b32`에서는 C1이 DRAM 링크 포화 신호에 반응해 </a:t>
             </a:r>
           </a:p>
           <a:p>
@@ -8904,7 +9976,7 @@
                 <a:latin typeface="맑은 고딕"/>
                 <a:ea typeface="맑은 고딕"/>
               </a:rPr>
-              <a:t>과 선호 목록을 알고 있어 새 데이터 종류는 module 3개, 새 메모리는 선호 목록에 올려야 쓰이므로 2개</a:t>
+              <a:t>이득 없는 재배치를 하고 그 이동이 링크를 나눠 써 꼬리가 늘었다(다른 시나리오의 원인은 분해하지 않</a:t>
             </a:r>
           </a:p>
           <a:p>
@@ -8917,7 +9989,7 @@
                 <a:latin typeface="맑은 고딕"/>
                 <a:ea typeface="맑은 고딕"/>
               </a:rPr>
-              <a:t>를 고친다.</a:t>
+              <a:t>음). C2는 hot 데이터를 HBM으로 올리는 이동이라 꼬리도 줄었다(x0.72).</a:t>
             </a:r>
           </a:p>
           <a:p>
@@ -8930,7 +10002,7 @@
                 <a:latin typeface="맑은 고딕"/>
                 <a:ea typeface="맑은 고딕"/>
               </a:rPr>
-              <a:t>- 정책 교체와 새 event 추가는 두 후보가 같다(공유 module). 공수·비용은 가정 상수로 계산한 추정이다.</a:t>
+              <a:t>- 이동이 같은 링크의 서빙 대역폭을 나눠 쓰는 간섭 모델을 반영했다.</a:t>
             </a:r>
           </a:p>
         </p:txBody>
@@ -8943,8 +10015,8 @@
         </p:nvSpPr>
         <p:spPr>
           <a:xfrm>
-            <a:off x="8961120" y="3154680"/>
-            <a:ext cx="2834640" cy="1600200"/>
+            <a:off x="8961120" y="3017520"/>
+            <a:ext cx="2834640" cy="1508760"/>
           </a:xfrm>
           <a:prstGeom prst="rect">
             <a:avLst/>
@@ -8986,7 +10058,7 @@
                 <a:latin typeface="맑은 고딕"/>
                 <a:ea typeface="맑은 고딕"/>
               </a:rPr>
-              <a:t>새 메모리: C1 1 / C2 2</a:t>
+              <a:t>cb_kv_8k_b32 (B200) TTFT P99: Baseline 337 ms, C1 1,</a:t>
             </a:r>
           </a:p>
           <a:p>
@@ -8999,7 +10071,7 @@
                 <a:latin typeface="맑은 고딕"/>
                 <a:ea typeface="맑은 고딕"/>
               </a:rPr>
-              <a:t>새 데이터 종류: C1 1 / C2 3</a:t>
+              <a:t>308, C2 389.</a:t>
             </a:r>
           </a:p>
           <a:p>
@@ -9012,20 +10084,7 @@
                 <a:latin typeface="맑은 고딕"/>
                 <a:ea typeface="맑은 고딕"/>
               </a:rPr>
-              <a:t>정책 교체: 2 / 2</a:t>
-            </a:r>
-          </a:p>
-          <a:p>
-            <a:pPr algn="l"/>
-            <a:r>
-              <a:rPr sz="850" b="0">
-                <a:solidFill>
-                  <a:srgbClr val="404040"/>
-                </a:solidFill>
-                <a:latin typeface="맑은 고딕"/>
-                <a:ea typeface="맑은 고딕"/>
-              </a:rPr>
-              <a:t>새 event: 3 / 3</a:t>
+              <a:t>C1은 재배치 17회(231 GiB), C2는 승격 76회</a:t>
             </a:r>
           </a:p>
         </p:txBody>
@@ -9038,8 +10097,8 @@
         </p:nvSpPr>
         <p:spPr>
           <a:xfrm>
-            <a:off x="365760" y="4800600"/>
-            <a:ext cx="2651760" cy="1005840"/>
+            <a:off x="365760" y="4572000"/>
+            <a:ext cx="2651760" cy="1234440"/>
           </a:xfrm>
           <a:prstGeom prst="rect">
             <a:avLst/>
@@ -9081,7 +10140,7 @@
                 <a:latin typeface="맑은 고딕"/>
                 <a:ea typeface="맑은 고딕"/>
               </a:rPr>
-              <a:t>결론: trade-off</a:t>
+              <a:t>QA2 TPOT</a:t>
             </a:r>
           </a:p>
           <a:p>
@@ -9094,7 +10153,7 @@
                 <a:latin typeface="맑은 고딕"/>
                 <a:ea typeface="맑은 고딕"/>
               </a:rPr>
-              <a:t>성능 C2, 자원·확장성 C1</a:t>
+              <a:t>P99 C1 x1.07 · C2 x0.94</a:t>
             </a:r>
           </a:p>
         </p:txBody>
@@ -9107,8 +10166,8 @@
         </p:nvSpPr>
         <p:spPr>
           <a:xfrm>
-            <a:off x="3017520" y="4800600"/>
-            <a:ext cx="5943600" cy="1005840"/>
+            <a:off x="3017520" y="4572000"/>
+            <a:ext cx="5943600" cy="1234440"/>
           </a:xfrm>
           <a:prstGeom prst="rect">
             <a:avLst/>
@@ -9150,7 +10209,7 @@
                 <a:latin typeface="맑은 고딕"/>
                 <a:ea typeface="맑은 고딕"/>
               </a:rPr>
-              <a:t>- C2는 처리량(x1.42)과 지연에서 앞서는 대신 HBM을 더 쓰고(x1.21) 구조 변경 비용이 크다. C1은 반대</a:t>
+              <a:t>- 거의 변하지 않는다. TPOT는 매 토큰 디코드가 HBM 대역폭에 묶여 정해지고, DP1은 데이터 위치만 바</a:t>
             </a:r>
           </a:p>
           <a:p>
@@ -9163,7 +10222,7 @@
                 <a:latin typeface="맑은 고딕"/>
                 <a:ea typeface="맑은 고딕"/>
               </a:rPr>
-              <a:t>다.</a:t>
+              <a:t>꾸지 디코드 방식은 바꾸지 못한다. Baseline의 TPOT P99가 17.1 ms로 SLO(50 ms)보다 훨씬 낮아 개선 </a:t>
             </a:r>
           </a:p>
           <a:p>
@@ -9176,7 +10235,33 @@
                 <a:latin typeface="맑은 고딕"/>
                 <a:ea typeface="맑은 고딕"/>
               </a:rPr>
-              <a:t>- 별 합계는 C1 10, C2 9로 근소해 선택(C1)은 별 경계와 QA 정의에 민감하다.</a:t>
+              <a:t>여지도 작다.</a:t>
+            </a:r>
+          </a:p>
+          <a:p>
+            <a:pPr algn="l"/>
+            <a:r>
+              <a:rPr sz="950" b="0">
+                <a:solidFill>
+                  <a:srgbClr val="1A1A1A"/>
+                </a:solidFill>
+                <a:latin typeface="맑은 고딕"/>
+                <a:ea typeface="맑은 고딕"/>
+              </a:rPr>
+              <a:t>- 개선이 있다면 KV가 HBM 밖에 있어 복원 비용이 TPOT에 섞이는 경우뿐이다. LoRA·MoE expert가 원격</a:t>
+            </a:r>
+          </a:p>
+          <a:p>
+            <a:pPr algn="l"/>
+            <a:r>
+              <a:rPr sz="950" b="0">
+                <a:solidFill>
+                  <a:srgbClr val="1A1A1A"/>
+                </a:solidFill>
+                <a:latin typeface="맑은 고딕"/>
+                <a:ea typeface="맑은 고딕"/>
+              </a:rPr>
+              <a:t>에 있을 때도 영향이 있으나 이번 비교 가능 시나리오에는 거의 없다(Baseline도 SLO 불가).</a:t>
             </a:r>
           </a:p>
         </p:txBody>
@@ -9189,8 +10274,8 @@
         </p:nvSpPr>
         <p:spPr>
           <a:xfrm>
-            <a:off x="8961120" y="4800600"/>
-            <a:ext cx="2834640" cy="1005840"/>
+            <a:off x="8961120" y="4572000"/>
+            <a:ext cx="2834640" cy="1234440"/>
           </a:xfrm>
           <a:prstGeom prst="rect">
             <a:avLst/>
@@ -9232,7 +10317,7 @@
                 <a:latin typeface="맑은 고딕"/>
                 <a:ea typeface="맑은 고딕"/>
               </a:rPr>
-              <a:t>TTFT P99: C1 개선 없음, C2 x0.72</a:t>
+              <a:t>Baseline TPOT P99 geomean 17.1 ms, SLO 50 ms</a:t>
             </a:r>
           </a:p>
           <a:p>
@@ -9245,7 +10330,20 @@
                 <a:latin typeface="맑은 고딕"/>
                 <a:ea typeface="맑은 고딕"/>
               </a:rPr>
-              <a:t>TPOT: 두 후보 모두 거의 불변</a:t>
+              <a:t>LoRA·MoE 시나리오는 Baseline이 TPOT SLO를 못 맞춰 비</a:t>
+            </a:r>
+          </a:p>
+          <a:p>
+            <a:pPr algn="l"/>
+            <a:r>
+              <a:rPr sz="850" b="0">
+                <a:solidFill>
+                  <a:srgbClr val="404040"/>
+                </a:solidFill>
+                <a:latin typeface="맑은 고딕"/>
+                <a:ea typeface="맑은 고딕"/>
+              </a:rPr>
+              <a:t>교에서 제외</a:t>
             </a:r>
           </a:p>
         </p:txBody>
@@ -9259,6 +10357,1285 @@
 </file>
 
 <file path=ppt/slides/slide21.xml><?xml version="1.0" encoding="utf-8"?>
+<p:sld xmlns:a="http://schemas.openxmlformats.org/drawingml/2006/main" xmlns:p="http://schemas.openxmlformats.org/presentationml/2006/main" xmlns:r="http://schemas.openxmlformats.org/officeDocument/2006/relationships">
+  <p:cSld>
+    <p:spTree>
+      <p:nvGrpSpPr>
+        <p:cNvPr id="1" name=""/>
+        <p:cNvGrpSpPr/>
+        <p:nvPr/>
+      </p:nvGrpSpPr>
+      <p:grpSpPr/>
+      <p:sp>
+        <p:nvSpPr>
+          <p:cNvPr id="3" name="제목 2"/>
+          <p:cNvSpPr>
+            <a:spLocks noGrp="1"/>
+          </p:cNvSpPr>
+          <p:nvPr>
+            <p:ph type="title"/>
+          </p:nvPr>
+        </p:nvSpPr>
+        <p:spPr>
+          <a:xfrm>
+            <a:off x="234949" y="137379"/>
+            <a:ext cx="7631530" cy="365125"/>
+          </a:xfrm>
+        </p:spPr>
+        <p:txBody>
+          <a:bodyPr/>
+          <a:lstStyle/>
+          <a:p>
+            <a:r>
+              <a:rPr lang="en-US" altLang="ko-KR" dirty="0"/>
+              <a:t>DP1. 이기종 메모리 기반 Data Migration 구조 - Appendix</a:t>
+            </a:r>
+            <a:r>
+              <a:rPr lang="ko-KR" altLang="en-US" dirty="0"/>
+              <a:t/>
+            </a:r>
+            <a:r>
+              <a:rPr lang="en-US" altLang="ko-KR" dirty="0"/>
+              <a:t/>
+            </a:r>
+            <a:r>
+              <a:rPr lang="ko-KR" altLang="en-US" dirty="0"/>
+              <a:t/>
+            </a:r>
+            <a:r>
+              <a:rPr lang="en-US" altLang="ko-KR" dirty="0"/>
+              <a:t/>
+            </a:r>
+            <a:r>
+              <a:rPr lang="ko-KR" altLang="en-US" dirty="0"/>
+              <a:t/>
+            </a:r>
+          </a:p>
+        </p:txBody>
+      </p:sp>
+      <p:sp>
+        <p:nvSpPr>
+          <p:cNvPr id="5" name="직사각형 4"/>
+          <p:cNvSpPr/>
+          <p:nvPr/>
+        </p:nvSpPr>
+        <p:spPr>
+          <a:xfrm>
+            <a:off x="234949" y="596176"/>
+            <a:ext cx="11747501" cy="396603"/>
+          </a:xfrm>
+          <a:prstGeom prst="rect">
+            <a:avLst/>
+          </a:prstGeom>
+          <a:solidFill>
+            <a:schemeClr val="bg1">
+              <a:lumMod val="50000"/>
+            </a:schemeClr>
+          </a:solidFill>
+          <a:ln>
+            <a:noFill/>
+          </a:ln>
+        </p:spPr>
+        <p:style>
+          <a:lnRef idx="2">
+            <a:schemeClr val="accent1">
+              <a:shade val="50000"/>
+            </a:schemeClr>
+          </a:lnRef>
+          <a:fillRef idx="1">
+            <a:schemeClr val="accent1"/>
+          </a:fillRef>
+          <a:effectRef idx="0">
+            <a:schemeClr val="accent1"/>
+          </a:effectRef>
+          <a:fontRef idx="minor">
+            <a:schemeClr val="lt1"/>
+          </a:fontRef>
+        </p:style>
+        <p:txBody>
+          <a:bodyPr rtlCol="0" anchor="ctr"/>
+          <a:lstStyle/>
+          <a:p>
+            <a:pPr algn="ctr"/>
+            <a:endParaRPr lang="ko-KR" altLang="en-US"/>
+          </a:p>
+        </p:txBody>
+      </p:sp>
+      <p:sp>
+        <p:nvSpPr>
+          <p:cNvPr id="8" name="TextBox 7"/>
+          <p:cNvSpPr txBox="1"/>
+          <p:nvPr/>
+        </p:nvSpPr>
+        <p:spPr>
+          <a:xfrm>
+            <a:off x="469760" y="627926"/>
+            <a:ext cx="11430000" cy="307777"/>
+          </a:xfrm>
+          <a:prstGeom prst="rect">
+            <a:avLst/>
+          </a:prstGeom>
+          <a:noFill/>
+        </p:spPr>
+        <p:txBody>
+          <a:bodyPr wrap="square" rtlCol="0">
+            <a:spAutoFit/>
+          </a:bodyPr>
+          <a:lstStyle/>
+          <a:p>
+            <a:pPr lvl="0">
+              <a:defRPr/>
+            </a:pPr>
+            <a:r>
+              <a:rPr lang="ko-KR" altLang="en-US" sz="1400" b="1" dirty="0">
+                <a:solidFill>
+                  <a:schemeClr val="bg1"/>
+                </a:solidFill>
+              </a:rPr>
+              <a:t>DP1 평가 결과 - QA별로 왜 이런 값이 나왔나 (2/2: 자원, 확장성)</a:t>
+            </a:r>
+            <a:r>
+              <a:rPr lang="en-US" altLang="ko-KR" sz="1400" b="1" dirty="0">
+                <a:solidFill>
+                  <a:schemeClr val="bg1"/>
+                </a:solidFill>
+              </a:rPr>
+              <a:t/>
+            </a:r>
+            <a:r>
+              <a:rPr lang="ko-KR" altLang="en-US" sz="1400" b="1" dirty="0">
+                <a:solidFill>
+                  <a:schemeClr val="bg1"/>
+                </a:solidFill>
+              </a:rPr>
+              <a:t/>
+            </a:r>
+            <a:r>
+              <a:rPr lang="en-US" altLang="ko-KR" sz="1400" b="1" dirty="0">
+                <a:solidFill>
+                  <a:schemeClr val="bg1"/>
+                </a:solidFill>
+              </a:rPr>
+              <a:t/>
+            </a:r>
+            <a:r>
+              <a:rPr lang="ko-KR" altLang="en-US" sz="1400" b="1" dirty="0">
+                <a:solidFill>
+                  <a:schemeClr val="bg1"/>
+                </a:solidFill>
+              </a:rPr>
+              <a:t/>
+            </a:r>
+          </a:p>
+        </p:txBody>
+      </p:sp>
+      <p:sp>
+        <p:nvSpPr>
+          <p:cNvPr id="39" name="직사각형 38"/>
+          <p:cNvSpPr/>
+          <p:nvPr/>
+        </p:nvSpPr>
+        <p:spPr>
+          <a:xfrm>
+            <a:off x="403086" y="678726"/>
+            <a:ext cx="66675" cy="216270"/>
+          </a:xfrm>
+          <a:prstGeom prst="rect">
+            <a:avLst/>
+          </a:prstGeom>
+          <a:solidFill>
+            <a:schemeClr val="bg1"/>
+          </a:solidFill>
+          <a:ln w="19050">
+            <a:noFill/>
+          </a:ln>
+        </p:spPr>
+        <p:style>
+          <a:lnRef idx="2">
+            <a:schemeClr val="accent1">
+              <a:shade val="50000"/>
+            </a:schemeClr>
+          </a:lnRef>
+          <a:fillRef idx="1">
+            <a:schemeClr val="accent1"/>
+          </a:fillRef>
+          <a:effectRef idx="0">
+            <a:schemeClr val="accent1"/>
+          </a:effectRef>
+          <a:fontRef idx="minor">
+            <a:schemeClr val="lt1"/>
+          </a:fontRef>
+        </p:style>
+        <p:txBody>
+          <a:bodyPr rtlCol="0" anchor="ctr"/>
+          <a:lstStyle/>
+          <a:p>
+            <a:pPr algn="ctr"/>
+            <a:endParaRPr lang="ko-KR" altLang="en-US" sz="1600"/>
+          </a:p>
+        </p:txBody>
+      </p:sp>
+      <p:sp>
+        <p:nvSpPr>
+          <p:cNvPr id="57" name="슬라이드 번호 개체 틀 1"/>
+          <p:cNvSpPr>
+            <a:spLocks noGrp="1"/>
+          </p:cNvSpPr>
+          <p:nvPr>
+            <p:ph type="sldNum" sz="quarter" idx="4"/>
+          </p:nvPr>
+        </p:nvSpPr>
+        <p:spPr>
+          <a:xfrm>
+            <a:off x="5620080" y="6597650"/>
+            <a:ext cx="456466" cy="209550"/>
+          </a:xfrm>
+        </p:spPr>
+        <p:txBody>
+          <a:bodyPr/>
+          <a:lstStyle/>
+          <a:p>
+            <a:fld id="{7F889C64-266A-4D07-AD8F-5B592E61CCE1}" type="slidenum">
+              <a:rPr lang="ko-KR" altLang="en-US" smtClean="0"/>
+              <a:pPr/>
+              <a:t>9</a:t>
+            </a:fld>
+            <a:endParaRPr lang="ko-KR" altLang="en-US" dirty="0"/>
+          </a:p>
+        </p:txBody>
+      </p:sp>
+      <p:sp>
+        <p:nvSpPr>
+          <p:cNvPr id="58" name="Rectangle 57"/>
+          <p:cNvSpPr/>
+          <p:nvPr/>
+        </p:nvSpPr>
+        <p:spPr>
+          <a:xfrm>
+            <a:off x="365760" y="1051560"/>
+            <a:ext cx="2651760" cy="292608"/>
+          </a:xfrm>
+          <a:prstGeom prst="rect">
+            <a:avLst/>
+          </a:prstGeom>
+          <a:solidFill>
+            <a:srgbClr val="1F4E79"/>
+          </a:solidFill>
+          <a:ln w="9525">
+            <a:solidFill>
+              <a:srgbClr val="1F4E79"/>
+            </a:solidFill>
+          </a:ln>
+          <a:effectLst/>
+        </p:spPr>
+        <p:style>
+          <a:lnRef idx="1">
+            <a:schemeClr val="accent1"/>
+          </a:lnRef>
+          <a:fillRef idx="3">
+            <a:schemeClr val="accent1"/>
+          </a:fillRef>
+          <a:effectRef idx="2">
+            <a:schemeClr val="accent1"/>
+          </a:effectRef>
+          <a:fontRef idx="minor">
+            <a:schemeClr val="lt1"/>
+          </a:fontRef>
+        </p:style>
+        <p:txBody>
+          <a:bodyPr rtlCol="0" anchor="ctr" wrap="square" lIns="45720" rIns="45720" tIns="27432" bIns="27432"/>
+          <a:lstStyle/>
+          <a:p>
+            <a:pPr algn="ctr"/>
+            <a:r>
+              <a:rPr sz="1000" b="1">
+                <a:solidFill>
+                  <a:srgbClr val="FFFFFF"/>
+                </a:solidFill>
+                <a:latin typeface="맑은 고딕"/>
+                <a:ea typeface="맑은 고딕"/>
+              </a:rPr>
+              <a:t>QA / 수치</a:t>
+            </a:r>
+          </a:p>
+        </p:txBody>
+      </p:sp>
+      <p:sp>
+        <p:nvSpPr>
+          <p:cNvPr id="59" name="Rectangle 58"/>
+          <p:cNvSpPr/>
+          <p:nvPr/>
+        </p:nvSpPr>
+        <p:spPr>
+          <a:xfrm>
+            <a:off x="3017520" y="1051560"/>
+            <a:ext cx="5943600" cy="292608"/>
+          </a:xfrm>
+          <a:prstGeom prst="rect">
+            <a:avLst/>
+          </a:prstGeom>
+          <a:solidFill>
+            <a:srgbClr val="1F4E79"/>
+          </a:solidFill>
+          <a:ln w="9525">
+            <a:solidFill>
+              <a:srgbClr val="1F4E79"/>
+            </a:solidFill>
+          </a:ln>
+          <a:effectLst/>
+        </p:spPr>
+        <p:style>
+          <a:lnRef idx="1">
+            <a:schemeClr val="accent1"/>
+          </a:lnRef>
+          <a:fillRef idx="3">
+            <a:schemeClr val="accent1"/>
+          </a:fillRef>
+          <a:effectRef idx="2">
+            <a:schemeClr val="accent1"/>
+          </a:effectRef>
+          <a:fontRef idx="minor">
+            <a:schemeClr val="lt1"/>
+          </a:fontRef>
+        </p:style>
+        <p:txBody>
+          <a:bodyPr rtlCol="0" anchor="ctr" wrap="square" lIns="45720" rIns="45720" tIns="27432" bIns="27432"/>
+          <a:lstStyle/>
+          <a:p>
+            <a:pPr algn="ctr"/>
+            <a:r>
+              <a:rPr sz="1000" b="1">
+                <a:solidFill>
+                  <a:srgbClr val="FFFFFF"/>
+                </a:solidFill>
+                <a:latin typeface="맑은 고딕"/>
+                <a:ea typeface="맑은 고딕"/>
+              </a:rPr>
+              <a:t>왜 이런 값이 나왔나</a:t>
+            </a:r>
+          </a:p>
+        </p:txBody>
+      </p:sp>
+      <p:sp>
+        <p:nvSpPr>
+          <p:cNvPr id="60" name="Rectangle 59"/>
+          <p:cNvSpPr/>
+          <p:nvPr/>
+        </p:nvSpPr>
+        <p:spPr>
+          <a:xfrm>
+            <a:off x="8961120" y="1051560"/>
+            <a:ext cx="2834640" cy="292608"/>
+          </a:xfrm>
+          <a:prstGeom prst="rect">
+            <a:avLst/>
+          </a:prstGeom>
+          <a:solidFill>
+            <a:srgbClr val="1F4E79"/>
+          </a:solidFill>
+          <a:ln w="9525">
+            <a:solidFill>
+              <a:srgbClr val="1F4E79"/>
+            </a:solidFill>
+          </a:ln>
+          <a:effectLst/>
+        </p:spPr>
+        <p:style>
+          <a:lnRef idx="1">
+            <a:schemeClr val="accent1"/>
+          </a:lnRef>
+          <a:fillRef idx="3">
+            <a:schemeClr val="accent1"/>
+          </a:fillRef>
+          <a:effectRef idx="2">
+            <a:schemeClr val="accent1"/>
+          </a:effectRef>
+          <a:fontRef idx="minor">
+            <a:schemeClr val="lt1"/>
+          </a:fontRef>
+        </p:style>
+        <p:txBody>
+          <a:bodyPr rtlCol="0" anchor="ctr" wrap="square" lIns="45720" rIns="45720" tIns="27432" bIns="27432"/>
+          <a:lstStyle/>
+          <a:p>
+            <a:pPr algn="ctr"/>
+            <a:r>
+              <a:rPr sz="1000" b="1">
+                <a:solidFill>
+                  <a:srgbClr val="FFFFFF"/>
+                </a:solidFill>
+                <a:latin typeface="맑은 고딕"/>
+                <a:ea typeface="맑은 고딕"/>
+              </a:rPr>
+              <a:t>근거 (시나리오·측정값)</a:t>
+            </a:r>
+          </a:p>
+        </p:txBody>
+      </p:sp>
+      <p:sp>
+        <p:nvSpPr>
+          <p:cNvPr id="61" name="Rectangle 60"/>
+          <p:cNvSpPr/>
+          <p:nvPr/>
+        </p:nvSpPr>
+        <p:spPr>
+          <a:xfrm>
+            <a:off x="365760" y="1371600"/>
+            <a:ext cx="2651760" cy="1737360"/>
+          </a:xfrm>
+          <a:prstGeom prst="rect">
+            <a:avLst/>
+          </a:prstGeom>
+          <a:solidFill>
+            <a:srgbClr val="DCE9F5"/>
+          </a:solidFill>
+          <a:ln w="9525">
+            <a:solidFill>
+              <a:srgbClr val="4D7EA8"/>
+            </a:solidFill>
+          </a:ln>
+          <a:effectLst/>
+        </p:spPr>
+        <p:style>
+          <a:lnRef idx="1">
+            <a:schemeClr val="accent1"/>
+          </a:lnRef>
+          <a:fillRef idx="3">
+            <a:schemeClr val="accent1"/>
+          </a:fillRef>
+          <a:effectRef idx="2">
+            <a:schemeClr val="accent1"/>
+          </a:effectRef>
+          <a:fontRef idx="minor">
+            <a:schemeClr val="lt1"/>
+          </a:fontRef>
+        </p:style>
+        <p:txBody>
+          <a:bodyPr rtlCol="0" anchor="ctr" wrap="square" lIns="45720" rIns="45720" tIns="27432" bIns="27432"/>
+          <a:lstStyle/>
+          <a:p>
+            <a:pPr algn="l"/>
+            <a:r>
+              <a:rPr sz="950" b="1">
+                <a:solidFill>
+                  <a:srgbClr val="1A1A1A"/>
+                </a:solidFill>
+                <a:latin typeface="맑은 고딕"/>
+                <a:ea typeface="맑은 고딕"/>
+              </a:rPr>
+              <a:t>QA3 자원 사용 (HBM)</a:t>
+            </a:r>
+          </a:p>
+          <a:p>
+            <a:pPr algn="l"/>
+            <a:r>
+              <a:rPr sz="950" b="1">
+                <a:solidFill>
+                  <a:srgbClr val="1A1A1A"/>
+                </a:solidFill>
+                <a:latin typeface="맑은 고딕"/>
+                <a:ea typeface="맑은 고딕"/>
+              </a:rPr>
+              <a:t>C1 x0.97 · C2 x1.21</a:t>
+            </a:r>
+          </a:p>
+          <a:p>
+            <a:pPr algn="l"/>
+            <a:r>
+              <a:rPr sz="950" b="1">
+                <a:solidFill>
+                  <a:srgbClr val="1A1A1A"/>
+                </a:solidFill>
+                <a:latin typeface="맑은 고딕"/>
+                <a:ea typeface="맑은 고딕"/>
+              </a:rPr>
+              <a:t>(HBM을 줄인/늘린 시나리오 C1 9/3, C2 1/1</a:t>
+            </a:r>
+          </a:p>
+          <a:p>
+            <a:pPr algn="l"/>
+            <a:r>
+              <a:rPr sz="950" b="1">
+                <a:solidFill>
+                  <a:srgbClr val="1A1A1A"/>
+                </a:solidFill>
+                <a:latin typeface="맑은 고딕"/>
+                <a:ea typeface="맑은 고딕"/>
+              </a:rPr>
+              <a:t>8)</a:t>
+            </a:r>
+          </a:p>
+        </p:txBody>
+      </p:sp>
+      <p:sp>
+        <p:nvSpPr>
+          <p:cNvPr id="62" name="Rectangle 61"/>
+          <p:cNvSpPr/>
+          <p:nvPr/>
+        </p:nvSpPr>
+        <p:spPr>
+          <a:xfrm>
+            <a:off x="3017520" y="1371600"/>
+            <a:ext cx="5943600" cy="1737360"/>
+          </a:xfrm>
+          <a:prstGeom prst="rect">
+            <a:avLst/>
+          </a:prstGeom>
+          <a:solidFill>
+            <a:srgbClr val="FFFFFF"/>
+          </a:solidFill>
+          <a:ln w="9525">
+            <a:solidFill>
+              <a:srgbClr val="BFBFBF"/>
+            </a:solidFill>
+          </a:ln>
+          <a:effectLst/>
+        </p:spPr>
+        <p:style>
+          <a:lnRef idx="1">
+            <a:schemeClr val="accent1"/>
+          </a:lnRef>
+          <a:fillRef idx="3">
+            <a:schemeClr val="accent1"/>
+          </a:fillRef>
+          <a:effectRef idx="2">
+            <a:schemeClr val="accent1"/>
+          </a:effectRef>
+          <a:fontRef idx="minor">
+            <a:schemeClr val="lt1"/>
+          </a:fontRef>
+        </p:style>
+        <p:txBody>
+          <a:bodyPr rtlCol="0" anchor="ctr" wrap="square" lIns="45720" rIns="45720" tIns="27432" bIns="27432"/>
+          <a:lstStyle/>
+          <a:p>
+            <a:pPr algn="l"/>
+            <a:r>
+              <a:rPr sz="950" b="0">
+                <a:solidFill>
+                  <a:srgbClr val="1A1A1A"/>
+                </a:solidFill>
+                <a:latin typeface="맑은 고딕"/>
+                <a:ea typeface="맑은 고딕"/>
+              </a:rPr>
+              <a:t>- 이동은 데이터 총량을 바꾸지 않고 어느 메모리에 두느냐만 바꾼다. 그래서 전 메모리 합 점유는 후보와</a:t>
+            </a:r>
+          </a:p>
+          <a:p>
+            <a:pPr algn="l"/>
+            <a:r>
+              <a:rPr sz="950" b="0">
+                <a:solidFill>
+                  <a:srgbClr val="1A1A1A"/>
+                </a:solidFill>
+                <a:latin typeface="맑은 고딕"/>
+                <a:ea typeface="맑은 고딕"/>
+              </a:rPr>
+              <a:t>무관하고, 'HBM에 얼마나 두는가'가 차이를 만든다.</a:t>
+            </a:r>
+          </a:p>
+          <a:p>
+            <a:pPr algn="l"/>
+            <a:r>
+              <a:rPr sz="950" b="0">
+                <a:solidFill>
+                  <a:srgbClr val="1A1A1A"/>
+                </a:solidFill>
+                <a:latin typeface="맑은 고딕"/>
+                <a:ea typeface="맑은 고딕"/>
+              </a:rPr>
+              <a:t>- C2는 성능을 위해 hot 데이터를 HBM으로 올려 HBM 사용이 늘어난다(비교 가능 21쌍 중 18쌍에서 증</a:t>
+            </a:r>
+          </a:p>
+          <a:p>
+            <a:pPr algn="l"/>
+            <a:r>
+              <a:rPr sz="950" b="0">
+                <a:solidFill>
+                  <a:srgbClr val="1A1A1A"/>
+                </a:solidFill>
+                <a:latin typeface="맑은 고딕"/>
+                <a:ea typeface="맑은 고딕"/>
+              </a:rPr>
+              <a:t>가). C1은 HBM 압박이 있으면 데이터를 내리고(HBM 감소), DRAM 링크가 포화로 보일 때는 DRAM에서 </a:t>
+            </a:r>
+          </a:p>
+          <a:p>
+            <a:pPr algn="l"/>
+            <a:r>
+              <a:rPr sz="950" b="0">
+                <a:solidFill>
+                  <a:srgbClr val="1A1A1A"/>
+                </a:solidFill>
+                <a:latin typeface="맑은 고딕"/>
+                <a:ea typeface="맑은 고딕"/>
+              </a:rPr>
+              <a:t>더 싼 HBF로 옮겨 HBM 사용을 늘리지 않는다.</a:t>
+            </a:r>
+          </a:p>
+          <a:p>
+            <a:pPr algn="l"/>
+            <a:r>
+              <a:rPr sz="950" b="0">
+                <a:solidFill>
+                  <a:srgbClr val="1A1A1A"/>
+                </a:solidFill>
+                <a:latin typeface="맑은 고딕"/>
+                <a:ea typeface="맑은 고딕"/>
+              </a:rPr>
+              <a:t>- 성능과 자원은 반대 방향이다: C2는 성능을 얻는 대신 HBM을 더 쓰고, C1은 덜 쓰되 성능 이득이 작다.</a:t>
+            </a:r>
+          </a:p>
+          <a:p>
+            <a:pPr algn="l"/>
+            <a:r>
+              <a:rPr sz="950" b="0">
+                <a:solidFill>
+                  <a:srgbClr val="1A1A1A"/>
+                </a:solidFill>
+                <a:latin typeface="맑은 고딕"/>
+                <a:ea typeface="맑은 고딕"/>
+              </a:rPr>
+              <a:t>- 보조 지표: 비용 가중 점유(DRAM 대비 상대 가격, ASSUMED) C1 x0.94, C2 x1.04로 같은 방향.</a:t>
+            </a:r>
+          </a:p>
+        </p:txBody>
+      </p:sp>
+      <p:sp>
+        <p:nvSpPr>
+          <p:cNvPr id="63" name="Rectangle 62"/>
+          <p:cNvSpPr/>
+          <p:nvPr/>
+        </p:nvSpPr>
+        <p:spPr>
+          <a:xfrm>
+            <a:off x="8961120" y="1371600"/>
+            <a:ext cx="2834640" cy="1737360"/>
+          </a:xfrm>
+          <a:prstGeom prst="rect">
+            <a:avLst/>
+          </a:prstGeom>
+          <a:solidFill>
+            <a:srgbClr val="F2F2F2"/>
+          </a:solidFill>
+          <a:ln w="9525">
+            <a:solidFill>
+              <a:srgbClr val="BFBFBF"/>
+            </a:solidFill>
+          </a:ln>
+          <a:effectLst/>
+        </p:spPr>
+        <p:style>
+          <a:lnRef idx="1">
+            <a:schemeClr val="accent1"/>
+          </a:lnRef>
+          <a:fillRef idx="3">
+            <a:schemeClr val="accent1"/>
+          </a:fillRef>
+          <a:effectRef idx="2">
+            <a:schemeClr val="accent1"/>
+          </a:effectRef>
+          <a:fontRef idx="minor">
+            <a:schemeClr val="lt1"/>
+          </a:fontRef>
+        </p:style>
+        <p:txBody>
+          <a:bodyPr rtlCol="0" anchor="ctr" wrap="square" lIns="45720" rIns="45720" tIns="27432" bIns="27432"/>
+          <a:lstStyle/>
+          <a:p>
+            <a:pPr algn="l"/>
+            <a:r>
+              <a:rPr sz="850" b="1">
+                <a:solidFill>
+                  <a:srgbClr val="404040"/>
+                </a:solidFill>
+                <a:latin typeface="맑은 고딕"/>
+                <a:ea typeface="맑은 고딕"/>
+              </a:rPr>
+              <a:t>cb_kv_8k_b32 (B200) HBM 사용: Baseline 72 GiB, C1 7</a:t>
+            </a:r>
+          </a:p>
+          <a:p>
+            <a:pPr algn="l"/>
+            <a:r>
+              <a:rPr sz="850" b="0">
+                <a:solidFill>
+                  <a:srgbClr val="404040"/>
+                </a:solidFill>
+                <a:latin typeface="맑은 고딕"/>
+                <a:ea typeface="맑은 고딕"/>
+              </a:rPr>
+              <a:t>2, C2 98</a:t>
+            </a:r>
+          </a:p>
+          <a:p>
+            <a:pPr algn="l"/>
+            <a:r>
+              <a:rPr sz="850" b="0">
+                <a:solidFill>
+                  <a:srgbClr val="404040"/>
+                </a:solidFill>
+                <a:latin typeface="맑은 고딕"/>
+                <a:ea typeface="맑은 고딕"/>
+              </a:rPr>
+              <a:t>정의 이력: 활용률 -&gt; 풀 -&gt; 성능÷비용 -&gt; HBM 사용량. 마</a:t>
+            </a:r>
+          </a:p>
+          <a:p>
+            <a:pPr algn="l"/>
+            <a:r>
+              <a:rPr sz="850" b="0">
+                <a:solidFill>
+                  <a:srgbClr val="404040"/>
+                </a:solidFill>
+                <a:latin typeface="맑은 고딕"/>
+                <a:ea typeface="맑은 고딕"/>
+              </a:rPr>
+              <a:t>지막 변경으로 선택이 C2에서 C1로 바뀜</a:t>
+            </a:r>
+          </a:p>
+        </p:txBody>
+      </p:sp>
+      <p:sp>
+        <p:nvSpPr>
+          <p:cNvPr id="64" name="Rectangle 63"/>
+          <p:cNvSpPr/>
+          <p:nvPr/>
+        </p:nvSpPr>
+        <p:spPr>
+          <a:xfrm>
+            <a:off x="365760" y="3154680"/>
+            <a:ext cx="2651760" cy="1600200"/>
+          </a:xfrm>
+          <a:prstGeom prst="rect">
+            <a:avLst/>
+          </a:prstGeom>
+          <a:solidFill>
+            <a:srgbClr val="DCE9F5"/>
+          </a:solidFill>
+          <a:ln w="9525">
+            <a:solidFill>
+              <a:srgbClr val="4D7EA8"/>
+            </a:solidFill>
+          </a:ln>
+          <a:effectLst/>
+        </p:spPr>
+        <p:style>
+          <a:lnRef idx="1">
+            <a:schemeClr val="accent1"/>
+          </a:lnRef>
+          <a:fillRef idx="3">
+            <a:schemeClr val="accent1"/>
+          </a:fillRef>
+          <a:effectRef idx="2">
+            <a:schemeClr val="accent1"/>
+          </a:effectRef>
+          <a:fontRef idx="minor">
+            <a:schemeClr val="lt1"/>
+          </a:fontRef>
+        </p:style>
+        <p:txBody>
+          <a:bodyPr rtlCol="0" anchor="ctr" wrap="square" lIns="45720" rIns="45720" tIns="27432" bIns="27432"/>
+          <a:lstStyle/>
+          <a:p>
+            <a:pPr algn="l"/>
+            <a:r>
+              <a:rPr sz="950" b="1">
+                <a:solidFill>
+                  <a:srgbClr val="1A1A1A"/>
+                </a:solidFill>
+                <a:latin typeface="맑은 고딕"/>
+                <a:ea typeface="맑은 고딕"/>
+              </a:rPr>
+              <a:t>QA4 확장성</a:t>
+            </a:r>
+          </a:p>
+          <a:p>
+            <a:pPr algn="l"/>
+            <a:r>
+              <a:rPr sz="950" b="1">
+                <a:solidFill>
+                  <a:srgbClr val="1A1A1A"/>
+                </a:solidFill>
+                <a:latin typeface="맑은 고딕"/>
+                <a:ea typeface="맑은 고딕"/>
+              </a:rPr>
+              <a:t>C1 module 1.75 · C2 2.50</a:t>
+            </a:r>
+          </a:p>
+          <a:p>
+            <a:pPr algn="l"/>
+            <a:r>
+              <a:rPr sz="950" b="1">
+                <a:solidFill>
+                  <a:srgbClr val="1A1A1A"/>
+                </a:solidFill>
+                <a:latin typeface="맑은 고딕"/>
+                <a:ea typeface="맑은 고딕"/>
+              </a:rPr>
+              <a:t>공수 0.38 vs 0.51 MM</a:t>
+            </a:r>
+          </a:p>
+          <a:p>
+            <a:pPr algn="l"/>
+            <a:r>
+              <a:rPr sz="950" b="1">
+                <a:solidFill>
+                  <a:srgbClr val="1A1A1A"/>
+                </a:solidFill>
+                <a:latin typeface="맑은 고딕"/>
+                <a:ea typeface="맑은 고딕"/>
+              </a:rPr>
+              <a:t>에이전트 비용 $1.16 vs $1.49</a:t>
+            </a:r>
+          </a:p>
+        </p:txBody>
+      </p:sp>
+      <p:sp>
+        <p:nvSpPr>
+          <p:cNvPr id="65" name="Rectangle 64"/>
+          <p:cNvSpPr/>
+          <p:nvPr/>
+        </p:nvSpPr>
+        <p:spPr>
+          <a:xfrm>
+            <a:off x="3017520" y="3154680"/>
+            <a:ext cx="5943600" cy="1600200"/>
+          </a:xfrm>
+          <a:prstGeom prst="rect">
+            <a:avLst/>
+          </a:prstGeom>
+          <a:solidFill>
+            <a:srgbClr val="FFFFFF"/>
+          </a:solidFill>
+          <a:ln w="9525">
+            <a:solidFill>
+              <a:srgbClr val="BFBFBF"/>
+            </a:solidFill>
+          </a:ln>
+          <a:effectLst/>
+        </p:spPr>
+        <p:style>
+          <a:lnRef idx="1">
+            <a:schemeClr val="accent1"/>
+          </a:lnRef>
+          <a:fillRef idx="3">
+            <a:schemeClr val="accent1"/>
+          </a:fillRef>
+          <a:effectRef idx="2">
+            <a:schemeClr val="accent1"/>
+          </a:effectRef>
+          <a:fontRef idx="minor">
+            <a:schemeClr val="lt1"/>
+          </a:fontRef>
+        </p:style>
+        <p:txBody>
+          <a:bodyPr rtlCol="0" anchor="ctr" wrap="square" lIns="45720" rIns="45720" tIns="27432" bIns="27432"/>
+          <a:lstStyle/>
+          <a:p>
+            <a:pPr algn="l"/>
+            <a:r>
+              <a:rPr sz="950" b="0">
+                <a:solidFill>
+                  <a:srgbClr val="1A1A1A"/>
+                </a:solidFill>
+                <a:latin typeface="맑은 고딕"/>
+                <a:ea typeface="맑은 고딕"/>
+              </a:rPr>
+              <a:t>- 변경 시나리오 4종(새 메모리, 새 데이터 종류, 정책 교체, 새 event)을 시뮬레이터 복사본에 실제로 구</a:t>
+            </a:r>
+          </a:p>
+          <a:p>
+            <a:pPr algn="l"/>
+            <a:r>
+              <a:rPr sz="950" b="0">
+                <a:solidFill>
+                  <a:srgbClr val="1A1A1A"/>
+                </a:solidFill>
+                <a:latin typeface="맑은 고딕"/>
+                <a:ea typeface="맑은 고딕"/>
+              </a:rPr>
+              <a:t>현해 module 수를 쟀다.</a:t>
+            </a:r>
+          </a:p>
+          <a:p>
+            <a:pPr algn="l"/>
+            <a:r>
+              <a:rPr sz="950" b="0">
+                <a:solidFill>
+                  <a:srgbClr val="1A1A1A"/>
+                </a:solidFill>
+                <a:latin typeface="맑은 고딕"/>
+                <a:ea typeface="맑은 고딕"/>
+              </a:rPr>
+              <a:t>- C1은 데이터 종류를 모르는 구조라 새 데이터 종류를 추가해도 고칠 곳이 거의 없다. C2는 종류별 특성</a:t>
+            </a:r>
+          </a:p>
+          <a:p>
+            <a:pPr algn="l"/>
+            <a:r>
+              <a:rPr sz="950" b="0">
+                <a:solidFill>
+                  <a:srgbClr val="1A1A1A"/>
+                </a:solidFill>
+                <a:latin typeface="맑은 고딕"/>
+                <a:ea typeface="맑은 고딕"/>
+              </a:rPr>
+              <a:t>과 선호 목록을 알고 있어 새 데이터 종류는 module 3개, 새 메모리는 선호 목록에 올려야 쓰이므로 2개</a:t>
+            </a:r>
+          </a:p>
+          <a:p>
+            <a:pPr algn="l"/>
+            <a:r>
+              <a:rPr sz="950" b="0">
+                <a:solidFill>
+                  <a:srgbClr val="1A1A1A"/>
+                </a:solidFill>
+                <a:latin typeface="맑은 고딕"/>
+                <a:ea typeface="맑은 고딕"/>
+              </a:rPr>
+              <a:t>를 고친다.</a:t>
+            </a:r>
+          </a:p>
+          <a:p>
+            <a:pPr algn="l"/>
+            <a:r>
+              <a:rPr sz="950" b="0">
+                <a:solidFill>
+                  <a:srgbClr val="1A1A1A"/>
+                </a:solidFill>
+                <a:latin typeface="맑은 고딕"/>
+                <a:ea typeface="맑은 고딕"/>
+              </a:rPr>
+              <a:t>- 정책 교체와 새 event 추가는 두 후보가 같다(공유 module). 공수·비용은 가정 상수로 계산한 추정이다.</a:t>
+            </a:r>
+          </a:p>
+        </p:txBody>
+      </p:sp>
+      <p:sp>
+        <p:nvSpPr>
+          <p:cNvPr id="66" name="Rectangle 65"/>
+          <p:cNvSpPr/>
+          <p:nvPr/>
+        </p:nvSpPr>
+        <p:spPr>
+          <a:xfrm>
+            <a:off x="8961120" y="3154680"/>
+            <a:ext cx="2834640" cy="1600200"/>
+          </a:xfrm>
+          <a:prstGeom prst="rect">
+            <a:avLst/>
+          </a:prstGeom>
+          <a:solidFill>
+            <a:srgbClr val="F2F2F2"/>
+          </a:solidFill>
+          <a:ln w="9525">
+            <a:solidFill>
+              <a:srgbClr val="BFBFBF"/>
+            </a:solidFill>
+          </a:ln>
+          <a:effectLst/>
+        </p:spPr>
+        <p:style>
+          <a:lnRef idx="1">
+            <a:schemeClr val="accent1"/>
+          </a:lnRef>
+          <a:fillRef idx="3">
+            <a:schemeClr val="accent1"/>
+          </a:fillRef>
+          <a:effectRef idx="2">
+            <a:schemeClr val="accent1"/>
+          </a:effectRef>
+          <a:fontRef idx="minor">
+            <a:schemeClr val="lt1"/>
+          </a:fontRef>
+        </p:style>
+        <p:txBody>
+          <a:bodyPr rtlCol="0" anchor="ctr" wrap="square" lIns="45720" rIns="45720" tIns="27432" bIns="27432"/>
+          <a:lstStyle/>
+          <a:p>
+            <a:pPr algn="l"/>
+            <a:r>
+              <a:rPr sz="850" b="1">
+                <a:solidFill>
+                  <a:srgbClr val="404040"/>
+                </a:solidFill>
+                <a:latin typeface="맑은 고딕"/>
+                <a:ea typeface="맑은 고딕"/>
+              </a:rPr>
+              <a:t>새 메모리: C1 1 / C2 2</a:t>
+            </a:r>
+          </a:p>
+          <a:p>
+            <a:pPr algn="l"/>
+            <a:r>
+              <a:rPr sz="850" b="0">
+                <a:solidFill>
+                  <a:srgbClr val="404040"/>
+                </a:solidFill>
+                <a:latin typeface="맑은 고딕"/>
+                <a:ea typeface="맑은 고딕"/>
+              </a:rPr>
+              <a:t>새 데이터 종류: C1 1 / C2 3</a:t>
+            </a:r>
+          </a:p>
+          <a:p>
+            <a:pPr algn="l"/>
+            <a:r>
+              <a:rPr sz="850" b="0">
+                <a:solidFill>
+                  <a:srgbClr val="404040"/>
+                </a:solidFill>
+                <a:latin typeface="맑은 고딕"/>
+                <a:ea typeface="맑은 고딕"/>
+              </a:rPr>
+              <a:t>정책 교체: 2 / 2</a:t>
+            </a:r>
+          </a:p>
+          <a:p>
+            <a:pPr algn="l"/>
+            <a:r>
+              <a:rPr sz="850" b="0">
+                <a:solidFill>
+                  <a:srgbClr val="404040"/>
+                </a:solidFill>
+                <a:latin typeface="맑은 고딕"/>
+                <a:ea typeface="맑은 고딕"/>
+              </a:rPr>
+              <a:t>새 event: 3 / 3</a:t>
+            </a:r>
+          </a:p>
+        </p:txBody>
+      </p:sp>
+      <p:sp>
+        <p:nvSpPr>
+          <p:cNvPr id="67" name="Rectangle 66"/>
+          <p:cNvSpPr/>
+          <p:nvPr/>
+        </p:nvSpPr>
+        <p:spPr>
+          <a:xfrm>
+            <a:off x="365760" y="4800600"/>
+            <a:ext cx="2651760" cy="1005840"/>
+          </a:xfrm>
+          <a:prstGeom prst="rect">
+            <a:avLst/>
+          </a:prstGeom>
+          <a:solidFill>
+            <a:srgbClr val="DCE9F5"/>
+          </a:solidFill>
+          <a:ln w="9525">
+            <a:solidFill>
+              <a:srgbClr val="4D7EA8"/>
+            </a:solidFill>
+          </a:ln>
+          <a:effectLst/>
+        </p:spPr>
+        <p:style>
+          <a:lnRef idx="1">
+            <a:schemeClr val="accent1"/>
+          </a:lnRef>
+          <a:fillRef idx="3">
+            <a:schemeClr val="accent1"/>
+          </a:fillRef>
+          <a:effectRef idx="2">
+            <a:schemeClr val="accent1"/>
+          </a:effectRef>
+          <a:fontRef idx="minor">
+            <a:schemeClr val="lt1"/>
+          </a:fontRef>
+        </p:style>
+        <p:txBody>
+          <a:bodyPr rtlCol="0" anchor="ctr" wrap="square" lIns="45720" rIns="45720" tIns="27432" bIns="27432"/>
+          <a:lstStyle/>
+          <a:p>
+            <a:pPr algn="l"/>
+            <a:r>
+              <a:rPr sz="950" b="1">
+                <a:solidFill>
+                  <a:srgbClr val="1A1A1A"/>
+                </a:solidFill>
+                <a:latin typeface="맑은 고딕"/>
+                <a:ea typeface="맑은 고딕"/>
+              </a:rPr>
+              <a:t>결론: trade-off</a:t>
+            </a:r>
+          </a:p>
+          <a:p>
+            <a:pPr algn="l"/>
+            <a:r>
+              <a:rPr sz="950" b="1">
+                <a:solidFill>
+                  <a:srgbClr val="1A1A1A"/>
+                </a:solidFill>
+                <a:latin typeface="맑은 고딕"/>
+                <a:ea typeface="맑은 고딕"/>
+              </a:rPr>
+              <a:t>성능 C2, 자원·확장성 C1</a:t>
+            </a:r>
+          </a:p>
+        </p:txBody>
+      </p:sp>
+      <p:sp>
+        <p:nvSpPr>
+          <p:cNvPr id="68" name="Rectangle 67"/>
+          <p:cNvSpPr/>
+          <p:nvPr/>
+        </p:nvSpPr>
+        <p:spPr>
+          <a:xfrm>
+            <a:off x="3017520" y="4800600"/>
+            <a:ext cx="5943600" cy="1005840"/>
+          </a:xfrm>
+          <a:prstGeom prst="rect">
+            <a:avLst/>
+          </a:prstGeom>
+          <a:solidFill>
+            <a:srgbClr val="FFFFFF"/>
+          </a:solidFill>
+          <a:ln w="9525">
+            <a:solidFill>
+              <a:srgbClr val="BFBFBF"/>
+            </a:solidFill>
+          </a:ln>
+          <a:effectLst/>
+        </p:spPr>
+        <p:style>
+          <a:lnRef idx="1">
+            <a:schemeClr val="accent1"/>
+          </a:lnRef>
+          <a:fillRef idx="3">
+            <a:schemeClr val="accent1"/>
+          </a:fillRef>
+          <a:effectRef idx="2">
+            <a:schemeClr val="accent1"/>
+          </a:effectRef>
+          <a:fontRef idx="minor">
+            <a:schemeClr val="lt1"/>
+          </a:fontRef>
+        </p:style>
+        <p:txBody>
+          <a:bodyPr rtlCol="0" anchor="ctr" wrap="square" lIns="45720" rIns="45720" tIns="27432" bIns="27432"/>
+          <a:lstStyle/>
+          <a:p>
+            <a:pPr algn="l"/>
+            <a:r>
+              <a:rPr sz="950" b="0">
+                <a:solidFill>
+                  <a:srgbClr val="1A1A1A"/>
+                </a:solidFill>
+                <a:latin typeface="맑은 고딕"/>
+                <a:ea typeface="맑은 고딕"/>
+              </a:rPr>
+              <a:t>- C2는 처리량(x1.42)과 지연에서 앞서는 대신 HBM을 더 쓰고(x1.21) 구조 변경 비용이 크다. C1은 반대</a:t>
+            </a:r>
+          </a:p>
+          <a:p>
+            <a:pPr algn="l"/>
+            <a:r>
+              <a:rPr sz="950" b="0">
+                <a:solidFill>
+                  <a:srgbClr val="1A1A1A"/>
+                </a:solidFill>
+                <a:latin typeface="맑은 고딕"/>
+                <a:ea typeface="맑은 고딕"/>
+              </a:rPr>
+              <a:t>다.</a:t>
+            </a:r>
+          </a:p>
+          <a:p>
+            <a:pPr algn="l"/>
+            <a:r>
+              <a:rPr sz="950" b="0">
+                <a:solidFill>
+                  <a:srgbClr val="1A1A1A"/>
+                </a:solidFill>
+                <a:latin typeface="맑은 고딕"/>
+                <a:ea typeface="맑은 고딕"/>
+              </a:rPr>
+              <a:t>- 별 합계는 C1 10, C2 9로 근소해 선택(C1)은 별 경계와 QA 정의에 민감하다.</a:t>
+            </a:r>
+          </a:p>
+        </p:txBody>
+      </p:sp>
+      <p:sp>
+        <p:nvSpPr>
+          <p:cNvPr id="69" name="Rectangle 68"/>
+          <p:cNvSpPr/>
+          <p:nvPr/>
+        </p:nvSpPr>
+        <p:spPr>
+          <a:xfrm>
+            <a:off x="8961120" y="4800600"/>
+            <a:ext cx="2834640" cy="1005840"/>
+          </a:xfrm>
+          <a:prstGeom prst="rect">
+            <a:avLst/>
+          </a:prstGeom>
+          <a:solidFill>
+            <a:srgbClr val="F2F2F2"/>
+          </a:solidFill>
+          <a:ln w="9525">
+            <a:solidFill>
+              <a:srgbClr val="BFBFBF"/>
+            </a:solidFill>
+          </a:ln>
+          <a:effectLst/>
+        </p:spPr>
+        <p:style>
+          <a:lnRef idx="1">
+            <a:schemeClr val="accent1"/>
+          </a:lnRef>
+          <a:fillRef idx="3">
+            <a:schemeClr val="accent1"/>
+          </a:fillRef>
+          <a:effectRef idx="2">
+            <a:schemeClr val="accent1"/>
+          </a:effectRef>
+          <a:fontRef idx="minor">
+            <a:schemeClr val="lt1"/>
+          </a:fontRef>
+        </p:style>
+        <p:txBody>
+          <a:bodyPr rtlCol="0" anchor="ctr" wrap="square" lIns="45720" rIns="45720" tIns="27432" bIns="27432"/>
+          <a:lstStyle/>
+          <a:p>
+            <a:pPr algn="l"/>
+            <a:r>
+              <a:rPr sz="850" b="1">
+                <a:solidFill>
+                  <a:srgbClr val="404040"/>
+                </a:solidFill>
+                <a:latin typeface="맑은 고딕"/>
+                <a:ea typeface="맑은 고딕"/>
+              </a:rPr>
+              <a:t>TTFT P99: C1 개선 없음, C2 x0.72</a:t>
+            </a:r>
+          </a:p>
+          <a:p>
+            <a:pPr algn="l"/>
+            <a:r>
+              <a:rPr sz="850" b="0">
+                <a:solidFill>
+                  <a:srgbClr val="404040"/>
+                </a:solidFill>
+                <a:latin typeface="맑은 고딕"/>
+                <a:ea typeface="맑은 고딕"/>
+              </a:rPr>
+              <a:t>TPOT: 두 후보 모두 거의 불변</a:t>
+            </a:r>
+          </a:p>
+        </p:txBody>
+      </p:sp>
+    </p:spTree>
+  </p:cSld>
+  <p:clrMapOvr>
+    <a:masterClrMapping/>
+  </p:clrMapOvr>
+</p:sld>
+</file>
+
+<file path=ppt/slides/slide22.xml><?xml version="1.0" encoding="utf-8"?>
 <p:sld xmlns:a="http://schemas.openxmlformats.org/drawingml/2006/main" xmlns:p="http://schemas.openxmlformats.org/presentationml/2006/main" xmlns:r="http://schemas.openxmlformats.org/officeDocument/2006/relationships">
   <p:cSld>
     <p:spTree>

</xml_diff>

<commit_message>
DP1: C1 Data-Memory Affinity ablation, GPU FP16 reference on system slide, C1-based tactics slide
Co-Authored-By: Claude Sonnet 5.5 <noreply@anthropic.com>
Claude-Session: https://claude.ai/code/session_018inK4pZJGzYwjdk7QAyZgn
</commit_message>
<xml_diff>
--- a/doc-mk/DP1/DP1-appendix-qa-result.pptx
+++ b/doc-mk/DP1/DP1-appendix-qa-result.pptx
@@ -13,6 +13,7 @@
     <p:sldId id="652" r:id="rId26"/>
     <p:sldId id="653" r:id="rId27"/>
     <p:sldId id="654" r:id="rId28"/>
+    <p:sldId id="655" r:id="rId29"/>
   </p:sldIdLst>
   <p:sldSz cx="12192000" cy="6858000"/>
   <p:notesSz cx="6858000" cy="9144000"/>
@@ -7569,7 +7570,20 @@
                 <a:latin typeface="맑은 고딕"/>
                 <a:ea typeface="맑은 고딕"/>
               </a:rPr>
-              <a:t>—  (GPU가 attention·FFN 실행)</a:t>
+              <a:t>GPU FP16 dense 989 / 2,250 TFLOPS/GPU (참고, 8장 합 </a:t>
+            </a:r>
+          </a:p>
+          <a:p>
+            <a:pPr algn="l"/>
+            <a:r>
+              <a:rPr sz="950" b="0">
+                <a:solidFill>
+                  <a:srgbClr val="1A1A1A"/>
+                </a:solidFill>
+                <a:latin typeface="맑은 고딕"/>
+                <a:ea typeface="맑은 고딕"/>
+              </a:rPr>
+              <a:t>7,912 / 18,000) · GPU가 attention·FFN 실행</a:t>
             </a:r>
           </a:p>
         </p:txBody>
@@ -7875,7 +7889,7 @@
                 <a:latin typeface="맑은 고딕"/>
                 <a:ea typeface="맑은 고딕"/>
               </a:rPr>
-              <a:t>197.8 / 450 TFLOPS · QK_GEMM, SOFTMAX, AV_GEMM, C</a:t>
+              <a:t>197.8 / 450 TFLOPS (GPU 1장의 20%) · QK_GEMM, SOFT</a:t>
             </a:r>
           </a:p>
           <a:p>
@@ -7888,7 +7902,7 @@
                 <a:latin typeface="맑은 고딕"/>
                 <a:ea typeface="맑은 고딕"/>
               </a:rPr>
-              <a:t>AUSAL_MASK (attention 오프로드)</a:t>
+              <a:t>MAX, AV_GEMM, CAUSAL_MASK (attention 오프로드)</a:t>
             </a:r>
           </a:p>
         </p:txBody>
@@ -8168,7 +8182,7 @@
                 <a:latin typeface="맑은 고딕"/>
                 <a:ea typeface="맑은 고딕"/>
               </a:rPr>
-              <a:t>3.28 TFLOPS · QK_GEMM, SOFTMAX, AV_GEMM, CAUSAL_</a:t>
+              <a:t>3.28 TFLOPS (GPU 1장의 0.33% / 0.15%) · QK_GEMM, SO</a:t>
             </a:r>
           </a:p>
           <a:p>
@@ -8181,7 +8195,7 @@
                 <a:latin typeface="맑은 고딕"/>
                 <a:ea typeface="맑은 고딕"/>
               </a:rPr>
-              <a:t>MASK (attention 오프로드)</a:t>
+              <a:t>FTMAX, AV_GEMM, CAUSAL_MASK (attention 오프로드)</a:t>
             </a:r>
           </a:p>
         </p:txBody>
@@ -9021,7 +9035,20 @@
                 <a:latin typeface="맑은 고딕"/>
                 <a:ea typeface="맑은 고딕"/>
               </a:rPr>
-              <a:t>2 TFLOPS · GEMV (벡터 DB 유사도 계산만)</a:t>
+              <a:t>2 TFLOPS (GPU 1장의 0.2% / 0.089%) · GEMV (벡터 DB 유</a:t>
+            </a:r>
+          </a:p>
+          <a:p>
+            <a:pPr algn="l"/>
+            <a:r>
+              <a:rPr sz="950" b="0">
+                <a:solidFill>
+                  <a:srgbClr val="1A1A1A"/>
+                </a:solidFill>
+                <a:latin typeface="맑은 고딕"/>
+                <a:ea typeface="맑은 고딕"/>
+              </a:rPr>
+              <a:t>사도 계산만)</a:t>
             </a:r>
           </a:p>
         </p:txBody>
@@ -11636,6 +11663,2783 @@
 </file>
 
 <file path=ppt/slides/slide22.xml><?xml version="1.0" encoding="utf-8"?>
+<p:sld xmlns:a="http://schemas.openxmlformats.org/drawingml/2006/main" xmlns:p="http://schemas.openxmlformats.org/presentationml/2006/main" xmlns:r="http://schemas.openxmlformats.org/officeDocument/2006/relationships">
+  <p:cSld>
+    <p:spTree>
+      <p:nvGrpSpPr>
+        <p:cNvPr id="1" name=""/>
+        <p:cNvGrpSpPr/>
+        <p:nvPr/>
+      </p:nvGrpSpPr>
+      <p:grpSpPr/>
+      <p:sp>
+        <p:nvSpPr>
+          <p:cNvPr id="3" name="제목 2"/>
+          <p:cNvSpPr>
+            <a:spLocks noGrp="1"/>
+          </p:cNvSpPr>
+          <p:nvPr>
+            <p:ph type="title"/>
+          </p:nvPr>
+        </p:nvSpPr>
+        <p:spPr>
+          <a:xfrm>
+            <a:off x="234949" y="137379"/>
+            <a:ext cx="7631530" cy="365125"/>
+          </a:xfrm>
+        </p:spPr>
+        <p:txBody>
+          <a:bodyPr/>
+          <a:lstStyle/>
+          <a:p>
+            <a:r>
+              <a:rPr lang="en-US" altLang="ko-KR" dirty="0"/>
+              <a:t>DP1. 이기종 메모리 기반 Data Migration 구조 - Appendix</a:t>
+            </a:r>
+            <a:r>
+              <a:rPr lang="ko-KR" altLang="en-US" dirty="0"/>
+              <a:t/>
+            </a:r>
+            <a:r>
+              <a:rPr lang="en-US" altLang="ko-KR" dirty="0"/>
+              <a:t/>
+            </a:r>
+            <a:r>
+              <a:rPr lang="ko-KR" altLang="en-US" dirty="0"/>
+              <a:t/>
+            </a:r>
+            <a:r>
+              <a:rPr lang="en-US" altLang="ko-KR" dirty="0"/>
+              <a:t/>
+            </a:r>
+            <a:r>
+              <a:rPr lang="ko-KR" altLang="en-US" dirty="0"/>
+              <a:t/>
+            </a:r>
+          </a:p>
+        </p:txBody>
+      </p:sp>
+      <p:sp>
+        <p:nvSpPr>
+          <p:cNvPr id="5" name="직사각형 4"/>
+          <p:cNvSpPr/>
+          <p:nvPr/>
+        </p:nvSpPr>
+        <p:spPr>
+          <a:xfrm>
+            <a:off x="234949" y="596176"/>
+            <a:ext cx="11747501" cy="396603"/>
+          </a:xfrm>
+          <a:prstGeom prst="rect">
+            <a:avLst/>
+          </a:prstGeom>
+          <a:solidFill>
+            <a:schemeClr val="bg1">
+              <a:lumMod val="50000"/>
+            </a:schemeClr>
+          </a:solidFill>
+          <a:ln>
+            <a:noFill/>
+          </a:ln>
+        </p:spPr>
+        <p:style>
+          <a:lnRef idx="2">
+            <a:schemeClr val="accent1">
+              <a:shade val="50000"/>
+            </a:schemeClr>
+          </a:lnRef>
+          <a:fillRef idx="1">
+            <a:schemeClr val="accent1"/>
+          </a:fillRef>
+          <a:effectRef idx="0">
+            <a:schemeClr val="accent1"/>
+          </a:effectRef>
+          <a:fontRef idx="minor">
+            <a:schemeClr val="lt1"/>
+          </a:fontRef>
+        </p:style>
+        <p:txBody>
+          <a:bodyPr rtlCol="0" anchor="ctr"/>
+          <a:lstStyle/>
+          <a:p>
+            <a:pPr algn="ctr"/>
+            <a:endParaRPr lang="ko-KR" altLang="en-US"/>
+          </a:p>
+        </p:txBody>
+      </p:sp>
+      <p:sp>
+        <p:nvSpPr>
+          <p:cNvPr id="8" name="TextBox 7"/>
+          <p:cNvSpPr txBox="1"/>
+          <p:nvPr/>
+        </p:nvSpPr>
+        <p:spPr>
+          <a:xfrm>
+            <a:off x="469760" y="627926"/>
+            <a:ext cx="11430000" cy="307777"/>
+          </a:xfrm>
+          <a:prstGeom prst="rect">
+            <a:avLst/>
+          </a:prstGeom>
+          <a:noFill/>
+        </p:spPr>
+        <p:txBody>
+          <a:bodyPr wrap="square" rtlCol="0">
+            <a:spAutoFit/>
+          </a:bodyPr>
+          <a:lstStyle/>
+          <a:p>
+            <a:pPr lvl="0">
+              <a:defRPr/>
+            </a:pPr>
+            <a:r>
+              <a:rPr lang="ko-KR" altLang="en-US" sz="1400" b="1" dirty="0">
+                <a:solidFill>
+                  <a:schemeClr val="bg1"/>
+                </a:solidFill>
+              </a:rPr>
+              <a:t>C1의 Data-Memory Affinity 효과 - 제거 변형 비교 (H100 + B200 통합)</a:t>
+            </a:r>
+            <a:r>
+              <a:rPr lang="en-US" altLang="ko-KR" sz="1400" b="1" dirty="0">
+                <a:solidFill>
+                  <a:schemeClr val="bg1"/>
+                </a:solidFill>
+              </a:rPr>
+              <a:t/>
+            </a:r>
+            <a:r>
+              <a:rPr lang="ko-KR" altLang="en-US" sz="1400" b="1" dirty="0">
+                <a:solidFill>
+                  <a:schemeClr val="bg1"/>
+                </a:solidFill>
+              </a:rPr>
+              <a:t/>
+            </a:r>
+            <a:r>
+              <a:rPr lang="en-US" altLang="ko-KR" sz="1400" b="1" dirty="0">
+                <a:solidFill>
+                  <a:schemeClr val="bg1"/>
+                </a:solidFill>
+              </a:rPr>
+              <a:t/>
+            </a:r>
+            <a:r>
+              <a:rPr lang="ko-KR" altLang="en-US" sz="1400" b="1" dirty="0">
+                <a:solidFill>
+                  <a:schemeClr val="bg1"/>
+                </a:solidFill>
+              </a:rPr>
+              <a:t/>
+            </a:r>
+          </a:p>
+        </p:txBody>
+      </p:sp>
+      <p:sp>
+        <p:nvSpPr>
+          <p:cNvPr id="39" name="직사각형 38"/>
+          <p:cNvSpPr/>
+          <p:nvPr/>
+        </p:nvSpPr>
+        <p:spPr>
+          <a:xfrm>
+            <a:off x="403086" y="678726"/>
+            <a:ext cx="66675" cy="216270"/>
+          </a:xfrm>
+          <a:prstGeom prst="rect">
+            <a:avLst/>
+          </a:prstGeom>
+          <a:solidFill>
+            <a:schemeClr val="bg1"/>
+          </a:solidFill>
+          <a:ln w="19050">
+            <a:noFill/>
+          </a:ln>
+        </p:spPr>
+        <p:style>
+          <a:lnRef idx="2">
+            <a:schemeClr val="accent1">
+              <a:shade val="50000"/>
+            </a:schemeClr>
+          </a:lnRef>
+          <a:fillRef idx="1">
+            <a:schemeClr val="accent1"/>
+          </a:fillRef>
+          <a:effectRef idx="0">
+            <a:schemeClr val="accent1"/>
+          </a:effectRef>
+          <a:fontRef idx="minor">
+            <a:schemeClr val="lt1"/>
+          </a:fontRef>
+        </p:style>
+        <p:txBody>
+          <a:bodyPr rtlCol="0" anchor="ctr"/>
+          <a:lstStyle/>
+          <a:p>
+            <a:pPr algn="ctr"/>
+            <a:endParaRPr lang="ko-KR" altLang="en-US" sz="1600"/>
+          </a:p>
+        </p:txBody>
+      </p:sp>
+      <p:sp>
+        <p:nvSpPr>
+          <p:cNvPr id="57" name="슬라이드 번호 개체 틀 1"/>
+          <p:cNvSpPr>
+            <a:spLocks noGrp="1"/>
+          </p:cNvSpPr>
+          <p:nvPr>
+            <p:ph type="sldNum" sz="quarter" idx="4"/>
+          </p:nvPr>
+        </p:nvSpPr>
+        <p:spPr>
+          <a:xfrm>
+            <a:off x="5620080" y="6597650"/>
+            <a:ext cx="456466" cy="209550"/>
+          </a:xfrm>
+        </p:spPr>
+        <p:txBody>
+          <a:bodyPr/>
+          <a:lstStyle/>
+          <a:p>
+            <a:fld id="{7F889C64-266A-4D07-AD8F-5B592E61CCE1}" type="slidenum">
+              <a:rPr lang="ko-KR" altLang="en-US" smtClean="0"/>
+              <a:pPr/>
+              <a:t>9</a:t>
+            </a:fld>
+            <a:endParaRPr lang="ko-KR" altLang="en-US" dirty="0"/>
+          </a:p>
+        </p:txBody>
+      </p:sp>
+      <p:sp>
+        <p:nvSpPr>
+          <p:cNvPr id="58" name="Rectangle 57"/>
+          <p:cNvSpPr/>
+          <p:nvPr/>
+        </p:nvSpPr>
+        <p:spPr>
+          <a:xfrm>
+            <a:off x="365760" y="1051560"/>
+            <a:ext cx="2560320" cy="292608"/>
+          </a:xfrm>
+          <a:prstGeom prst="rect">
+            <a:avLst/>
+          </a:prstGeom>
+          <a:solidFill>
+            <a:srgbClr val="1F4E79"/>
+          </a:solidFill>
+          <a:ln w="9525">
+            <a:solidFill>
+              <a:srgbClr val="1F4E79"/>
+            </a:solidFill>
+          </a:ln>
+          <a:effectLst/>
+        </p:spPr>
+        <p:style>
+          <a:lnRef idx="1">
+            <a:schemeClr val="accent1"/>
+          </a:lnRef>
+          <a:fillRef idx="3">
+            <a:schemeClr val="accent1"/>
+          </a:fillRef>
+          <a:effectRef idx="2">
+            <a:schemeClr val="accent1"/>
+          </a:effectRef>
+          <a:fontRef idx="minor">
+            <a:schemeClr val="lt1"/>
+          </a:fontRef>
+        </p:style>
+        <p:txBody>
+          <a:bodyPr rtlCol="0" anchor="ctr" wrap="square" lIns="45720" rIns="45720" tIns="27432" bIns="27432"/>
+          <a:lstStyle/>
+          <a:p>
+            <a:pPr algn="ctr"/>
+            <a:r>
+              <a:rPr sz="1000" b="1">
+                <a:solidFill>
+                  <a:srgbClr val="FFFFFF"/>
+                </a:solidFill>
+                <a:latin typeface="맑은 고딕"/>
+                <a:ea typeface="맑은 고딕"/>
+              </a:rPr>
+              <a:t>지표</a:t>
+            </a:r>
+          </a:p>
+        </p:txBody>
+      </p:sp>
+      <p:sp>
+        <p:nvSpPr>
+          <p:cNvPr id="59" name="Rectangle 58"/>
+          <p:cNvSpPr/>
+          <p:nvPr/>
+        </p:nvSpPr>
+        <p:spPr>
+          <a:xfrm>
+            <a:off x="2926080" y="1051560"/>
+            <a:ext cx="1371600" cy="292608"/>
+          </a:xfrm>
+          <a:prstGeom prst="rect">
+            <a:avLst/>
+          </a:prstGeom>
+          <a:solidFill>
+            <a:srgbClr val="1F4E79"/>
+          </a:solidFill>
+          <a:ln w="9525">
+            <a:solidFill>
+              <a:srgbClr val="1F4E79"/>
+            </a:solidFill>
+          </a:ln>
+          <a:effectLst/>
+        </p:spPr>
+        <p:style>
+          <a:lnRef idx="1">
+            <a:schemeClr val="accent1"/>
+          </a:lnRef>
+          <a:fillRef idx="3">
+            <a:schemeClr val="accent1"/>
+          </a:fillRef>
+          <a:effectRef idx="2">
+            <a:schemeClr val="accent1"/>
+          </a:effectRef>
+          <a:fontRef idx="minor">
+            <a:schemeClr val="lt1"/>
+          </a:fontRef>
+        </p:style>
+        <p:txBody>
+          <a:bodyPr rtlCol="0" anchor="ctr" wrap="square" lIns="45720" rIns="45720" tIns="27432" bIns="27432"/>
+          <a:lstStyle/>
+          <a:p>
+            <a:pPr algn="ctr"/>
+            <a:r>
+              <a:rPr sz="1000" b="1">
+                <a:solidFill>
+                  <a:srgbClr val="FFFFFF"/>
+                </a:solidFill>
+                <a:latin typeface="맑은 고딕"/>
+                <a:ea typeface="맑은 고딕"/>
+              </a:rPr>
+              <a:t>Baseline</a:t>
+            </a:r>
+          </a:p>
+        </p:txBody>
+      </p:sp>
+      <p:sp>
+        <p:nvSpPr>
+          <p:cNvPr id="60" name="Rectangle 59"/>
+          <p:cNvSpPr/>
+          <p:nvPr/>
+        </p:nvSpPr>
+        <p:spPr>
+          <a:xfrm>
+            <a:off x="4297680" y="1051560"/>
+            <a:ext cx="2468880" cy="292608"/>
+          </a:xfrm>
+          <a:prstGeom prst="rect">
+            <a:avLst/>
+          </a:prstGeom>
+          <a:solidFill>
+            <a:srgbClr val="1F4E79"/>
+          </a:solidFill>
+          <a:ln w="9525">
+            <a:solidFill>
+              <a:srgbClr val="1F4E79"/>
+            </a:solidFill>
+          </a:ln>
+          <a:effectLst/>
+        </p:spPr>
+        <p:style>
+          <a:lnRef idx="1">
+            <a:schemeClr val="accent1"/>
+          </a:lnRef>
+          <a:fillRef idx="3">
+            <a:schemeClr val="accent1"/>
+          </a:fillRef>
+          <a:effectRef idx="2">
+            <a:schemeClr val="accent1"/>
+          </a:effectRef>
+          <a:fontRef idx="minor">
+            <a:schemeClr val="lt1"/>
+          </a:fontRef>
+        </p:style>
+        <p:txBody>
+          <a:bodyPr rtlCol="0" anchor="ctr" wrap="square" lIns="45720" rIns="45720" tIns="27432" bIns="27432"/>
+          <a:lstStyle/>
+          <a:p>
+            <a:pPr algn="ctr"/>
+            <a:r>
+              <a:rPr sz="1000" b="1">
+                <a:solidFill>
+                  <a:srgbClr val="FFFFFF"/>
+                </a:solidFill>
+                <a:latin typeface="맑은 고딕"/>
+                <a:ea typeface="맑은 고딕"/>
+              </a:rPr>
+              <a:t>C1 affinity 제거</a:t>
+            </a:r>
+          </a:p>
+        </p:txBody>
+      </p:sp>
+      <p:sp>
+        <p:nvSpPr>
+          <p:cNvPr id="61" name="Rectangle 60"/>
+          <p:cNvSpPr/>
+          <p:nvPr/>
+        </p:nvSpPr>
+        <p:spPr>
+          <a:xfrm>
+            <a:off x="6766560" y="1051560"/>
+            <a:ext cx="2468880" cy="292608"/>
+          </a:xfrm>
+          <a:prstGeom prst="rect">
+            <a:avLst/>
+          </a:prstGeom>
+          <a:solidFill>
+            <a:srgbClr val="1F4E79"/>
+          </a:solidFill>
+          <a:ln w="9525">
+            <a:solidFill>
+              <a:srgbClr val="1F4E79"/>
+            </a:solidFill>
+          </a:ln>
+          <a:effectLst/>
+        </p:spPr>
+        <p:style>
+          <a:lnRef idx="1">
+            <a:schemeClr val="accent1"/>
+          </a:lnRef>
+          <a:fillRef idx="3">
+            <a:schemeClr val="accent1"/>
+          </a:fillRef>
+          <a:effectRef idx="2">
+            <a:schemeClr val="accent1"/>
+          </a:effectRef>
+          <a:fontRef idx="minor">
+            <a:schemeClr val="lt1"/>
+          </a:fontRef>
+        </p:style>
+        <p:txBody>
+          <a:bodyPr rtlCol="0" anchor="ctr" wrap="square" lIns="45720" rIns="45720" tIns="27432" bIns="27432"/>
+          <a:lstStyle/>
+          <a:p>
+            <a:pPr algn="ctr"/>
+            <a:r>
+              <a:rPr sz="1000" b="1">
+                <a:solidFill>
+                  <a:srgbClr val="FFFFFF"/>
+                </a:solidFill>
+                <a:latin typeface="맑은 고딕"/>
+                <a:ea typeface="맑은 고딕"/>
+              </a:rPr>
+              <a:t>C1 (affinity 포함, 평가 대상)</a:t>
+            </a:r>
+          </a:p>
+        </p:txBody>
+      </p:sp>
+      <p:sp>
+        <p:nvSpPr>
+          <p:cNvPr id="62" name="Rectangle 61"/>
+          <p:cNvSpPr/>
+          <p:nvPr/>
+        </p:nvSpPr>
+        <p:spPr>
+          <a:xfrm>
+            <a:off x="9235440" y="1051560"/>
+            <a:ext cx="2560320" cy="292608"/>
+          </a:xfrm>
+          <a:prstGeom prst="rect">
+            <a:avLst/>
+          </a:prstGeom>
+          <a:solidFill>
+            <a:srgbClr val="1F4E79"/>
+          </a:solidFill>
+          <a:ln w="9525">
+            <a:solidFill>
+              <a:srgbClr val="1F4E79"/>
+            </a:solidFill>
+          </a:ln>
+          <a:effectLst/>
+        </p:spPr>
+        <p:style>
+          <a:lnRef idx="1">
+            <a:schemeClr val="accent1"/>
+          </a:lnRef>
+          <a:fillRef idx="3">
+            <a:schemeClr val="accent1"/>
+          </a:fillRef>
+          <a:effectRef idx="2">
+            <a:schemeClr val="accent1"/>
+          </a:effectRef>
+          <a:fontRef idx="minor">
+            <a:schemeClr val="lt1"/>
+          </a:fontRef>
+        </p:style>
+        <p:txBody>
+          <a:bodyPr rtlCol="0" anchor="ctr" wrap="square" lIns="45720" rIns="45720" tIns="27432" bIns="27432"/>
+          <a:lstStyle/>
+          <a:p>
+            <a:pPr algn="ctr"/>
+            <a:r>
+              <a:rPr sz="1000" b="1">
+                <a:solidFill>
+                  <a:srgbClr val="FFFFFF"/>
+                </a:solidFill>
+                <a:latin typeface="맑은 고딕"/>
+                <a:ea typeface="맑은 고딕"/>
+              </a:rPr>
+              <a:t>C2</a:t>
+            </a:r>
+          </a:p>
+        </p:txBody>
+      </p:sp>
+      <p:sp>
+        <p:nvSpPr>
+          <p:cNvPr id="63" name="Rectangle 62"/>
+          <p:cNvSpPr/>
+          <p:nvPr/>
+        </p:nvSpPr>
+        <p:spPr>
+          <a:xfrm>
+            <a:off x="365760" y="1371600"/>
+            <a:ext cx="2560320" cy="365760"/>
+          </a:xfrm>
+          <a:prstGeom prst="rect">
+            <a:avLst/>
+          </a:prstGeom>
+          <a:solidFill>
+            <a:srgbClr val="DCE9F5"/>
+          </a:solidFill>
+          <a:ln w="9525">
+            <a:solidFill>
+              <a:srgbClr val="4D7EA8"/>
+            </a:solidFill>
+          </a:ln>
+          <a:effectLst/>
+        </p:spPr>
+        <p:style>
+          <a:lnRef idx="1">
+            <a:schemeClr val="accent1"/>
+          </a:lnRef>
+          <a:fillRef idx="3">
+            <a:schemeClr val="accent1"/>
+          </a:fillRef>
+          <a:effectRef idx="2">
+            <a:schemeClr val="accent1"/>
+          </a:effectRef>
+          <a:fontRef idx="minor">
+            <a:schemeClr val="lt1"/>
+          </a:fontRef>
+        </p:style>
+        <p:txBody>
+          <a:bodyPr rtlCol="0" anchor="ctr" wrap="square" lIns="45720" rIns="45720" tIns="27432" bIns="27432"/>
+          <a:lstStyle/>
+          <a:p>
+            <a:pPr algn="l"/>
+            <a:r>
+              <a:rPr sz="950" b="1">
+                <a:solidFill>
+                  <a:srgbClr val="1A1A1A"/>
+                </a:solidFill>
+                <a:latin typeface="맑은 고딕"/>
+                <a:ea typeface="맑은 고딕"/>
+              </a:rPr>
+              <a:t>QA1 goodput (tok/s) ↑</a:t>
+            </a:r>
+          </a:p>
+        </p:txBody>
+      </p:sp>
+      <p:sp>
+        <p:nvSpPr>
+          <p:cNvPr id="64" name="Rectangle 63"/>
+          <p:cNvSpPr/>
+          <p:nvPr/>
+        </p:nvSpPr>
+        <p:spPr>
+          <a:xfrm>
+            <a:off x="2926080" y="1371600"/>
+            <a:ext cx="1371600" cy="365760"/>
+          </a:xfrm>
+          <a:prstGeom prst="rect">
+            <a:avLst/>
+          </a:prstGeom>
+          <a:solidFill>
+            <a:srgbClr val="FFFFFF"/>
+          </a:solidFill>
+          <a:ln w="9525">
+            <a:solidFill>
+              <a:srgbClr val="BFBFBF"/>
+            </a:solidFill>
+          </a:ln>
+          <a:effectLst/>
+        </p:spPr>
+        <p:style>
+          <a:lnRef idx="1">
+            <a:schemeClr val="accent1"/>
+          </a:lnRef>
+          <a:fillRef idx="3">
+            <a:schemeClr val="accent1"/>
+          </a:fillRef>
+          <a:effectRef idx="2">
+            <a:schemeClr val="accent1"/>
+          </a:effectRef>
+          <a:fontRef idx="minor">
+            <a:schemeClr val="lt1"/>
+          </a:fontRef>
+        </p:style>
+        <p:txBody>
+          <a:bodyPr rtlCol="0" anchor="ctr" wrap="square" lIns="45720" rIns="45720" tIns="27432" bIns="27432"/>
+          <a:lstStyle/>
+          <a:p>
+            <a:pPr algn="ctr"/>
+            <a:r>
+              <a:rPr sz="950" b="0">
+                <a:solidFill>
+                  <a:srgbClr val="1A1A1A"/>
+                </a:solidFill>
+                <a:latin typeface="맑은 고딕"/>
+                <a:ea typeface="맑은 고딕"/>
+              </a:rPr>
+              <a:t>336</a:t>
+            </a:r>
+          </a:p>
+        </p:txBody>
+      </p:sp>
+      <p:sp>
+        <p:nvSpPr>
+          <p:cNvPr id="65" name="Rectangle 64"/>
+          <p:cNvSpPr/>
+          <p:nvPr/>
+        </p:nvSpPr>
+        <p:spPr>
+          <a:xfrm>
+            <a:off x="4297680" y="1371600"/>
+            <a:ext cx="2468880" cy="365760"/>
+          </a:xfrm>
+          <a:prstGeom prst="rect">
+            <a:avLst/>
+          </a:prstGeom>
+          <a:solidFill>
+            <a:srgbClr val="FFFFFF"/>
+          </a:solidFill>
+          <a:ln w="9525">
+            <a:solidFill>
+              <a:srgbClr val="BFBFBF"/>
+            </a:solidFill>
+          </a:ln>
+          <a:effectLst/>
+        </p:spPr>
+        <p:style>
+          <a:lnRef idx="1">
+            <a:schemeClr val="accent1"/>
+          </a:lnRef>
+          <a:fillRef idx="3">
+            <a:schemeClr val="accent1"/>
+          </a:fillRef>
+          <a:effectRef idx="2">
+            <a:schemeClr val="accent1"/>
+          </a:effectRef>
+          <a:fontRef idx="minor">
+            <a:schemeClr val="lt1"/>
+          </a:fontRef>
+        </p:style>
+        <p:txBody>
+          <a:bodyPr rtlCol="0" anchor="ctr" wrap="square" lIns="45720" rIns="45720" tIns="27432" bIns="27432"/>
+          <a:lstStyle/>
+          <a:p>
+            <a:pPr algn="ctr"/>
+            <a:r>
+              <a:rPr sz="950" b="0">
+                <a:solidFill>
+                  <a:srgbClr val="1A1A1A"/>
+                </a:solidFill>
+                <a:latin typeface="맑은 고딕"/>
+                <a:ea typeface="맑은 고딕"/>
+              </a:rPr>
+              <a:t>★★  354 (x1.05)</a:t>
+            </a:r>
+          </a:p>
+        </p:txBody>
+      </p:sp>
+      <p:sp>
+        <p:nvSpPr>
+          <p:cNvPr id="66" name="Rectangle 65"/>
+          <p:cNvSpPr/>
+          <p:nvPr/>
+        </p:nvSpPr>
+        <p:spPr>
+          <a:xfrm>
+            <a:off x="6766560" y="1371600"/>
+            <a:ext cx="2468880" cy="365760"/>
+          </a:xfrm>
+          <a:prstGeom prst="rect">
+            <a:avLst/>
+          </a:prstGeom>
+          <a:solidFill>
+            <a:srgbClr val="FFFFFF"/>
+          </a:solidFill>
+          <a:ln w="9525">
+            <a:solidFill>
+              <a:srgbClr val="BFBFBF"/>
+            </a:solidFill>
+          </a:ln>
+          <a:effectLst/>
+        </p:spPr>
+        <p:style>
+          <a:lnRef idx="1">
+            <a:schemeClr val="accent1"/>
+          </a:lnRef>
+          <a:fillRef idx="3">
+            <a:schemeClr val="accent1"/>
+          </a:fillRef>
+          <a:effectRef idx="2">
+            <a:schemeClr val="accent1"/>
+          </a:effectRef>
+          <a:fontRef idx="minor">
+            <a:schemeClr val="lt1"/>
+          </a:fontRef>
+        </p:style>
+        <p:txBody>
+          <a:bodyPr rtlCol="0" anchor="ctr" wrap="square" lIns="45720" rIns="45720" tIns="27432" bIns="27432"/>
+          <a:lstStyle/>
+          <a:p>
+            <a:pPr algn="ctr"/>
+            <a:r>
+              <a:rPr sz="950" b="0">
+                <a:solidFill>
+                  <a:srgbClr val="1A1A1A"/>
+                </a:solidFill>
+                <a:latin typeface="맑은 고딕"/>
+                <a:ea typeface="맑은 고딕"/>
+              </a:rPr>
+              <a:t>★★  436 (x1.30)</a:t>
+            </a:r>
+          </a:p>
+        </p:txBody>
+      </p:sp>
+      <p:sp>
+        <p:nvSpPr>
+          <p:cNvPr id="67" name="Rectangle 66"/>
+          <p:cNvSpPr/>
+          <p:nvPr/>
+        </p:nvSpPr>
+        <p:spPr>
+          <a:xfrm>
+            <a:off x="9235440" y="1371600"/>
+            <a:ext cx="2560320" cy="365760"/>
+          </a:xfrm>
+          <a:prstGeom prst="rect">
+            <a:avLst/>
+          </a:prstGeom>
+          <a:solidFill>
+            <a:srgbClr val="FFFFFF"/>
+          </a:solidFill>
+          <a:ln w="9525">
+            <a:solidFill>
+              <a:srgbClr val="BFBFBF"/>
+            </a:solidFill>
+          </a:ln>
+          <a:effectLst/>
+        </p:spPr>
+        <p:style>
+          <a:lnRef idx="1">
+            <a:schemeClr val="accent1"/>
+          </a:lnRef>
+          <a:fillRef idx="3">
+            <a:schemeClr val="accent1"/>
+          </a:fillRef>
+          <a:effectRef idx="2">
+            <a:schemeClr val="accent1"/>
+          </a:effectRef>
+          <a:fontRef idx="minor">
+            <a:schemeClr val="lt1"/>
+          </a:fontRef>
+        </p:style>
+        <p:txBody>
+          <a:bodyPr rtlCol="0" anchor="ctr" wrap="square" lIns="45720" rIns="45720" tIns="27432" bIns="27432"/>
+          <a:lstStyle/>
+          <a:p>
+            <a:pPr algn="ctr"/>
+            <a:r>
+              <a:rPr sz="950" b="0">
+                <a:solidFill>
+                  <a:srgbClr val="1A1A1A"/>
+                </a:solidFill>
+                <a:latin typeface="맑은 고딕"/>
+                <a:ea typeface="맑은 고딕"/>
+              </a:rPr>
+              <a:t>★★★  478 (x1.42)</a:t>
+            </a:r>
+          </a:p>
+        </p:txBody>
+      </p:sp>
+      <p:sp>
+        <p:nvSpPr>
+          <p:cNvPr id="68" name="Rectangle 67"/>
+          <p:cNvSpPr/>
+          <p:nvPr/>
+        </p:nvSpPr>
+        <p:spPr>
+          <a:xfrm>
+            <a:off x="365760" y="1755648"/>
+            <a:ext cx="2560320" cy="365760"/>
+          </a:xfrm>
+          <a:prstGeom prst="rect">
+            <a:avLst/>
+          </a:prstGeom>
+          <a:solidFill>
+            <a:srgbClr val="DCE9F5"/>
+          </a:solidFill>
+          <a:ln w="9525">
+            <a:solidFill>
+              <a:srgbClr val="4D7EA8"/>
+            </a:solidFill>
+          </a:ln>
+          <a:effectLst/>
+        </p:spPr>
+        <p:style>
+          <a:lnRef idx="1">
+            <a:schemeClr val="accent1"/>
+          </a:lnRef>
+          <a:fillRef idx="3">
+            <a:schemeClr val="accent1"/>
+          </a:fillRef>
+          <a:effectRef idx="2">
+            <a:schemeClr val="accent1"/>
+          </a:effectRef>
+          <a:fontRef idx="minor">
+            <a:schemeClr val="lt1"/>
+          </a:fontRef>
+        </p:style>
+        <p:txBody>
+          <a:bodyPr rtlCol="0" anchor="ctr" wrap="square" lIns="45720" rIns="45720" tIns="27432" bIns="27432"/>
+          <a:lstStyle/>
+          <a:p>
+            <a:pPr algn="l"/>
+            <a:r>
+              <a:rPr sz="950" b="1">
+                <a:solidFill>
+                  <a:srgbClr val="1A1A1A"/>
+                </a:solidFill>
+                <a:latin typeface="맑은 고딕"/>
+                <a:ea typeface="맑은 고딕"/>
+              </a:rPr>
+              <a:t>QA2 TTFT P99 (ms) ↓</a:t>
+            </a:r>
+          </a:p>
+        </p:txBody>
+      </p:sp>
+      <p:sp>
+        <p:nvSpPr>
+          <p:cNvPr id="69" name="Rectangle 68"/>
+          <p:cNvSpPr/>
+          <p:nvPr/>
+        </p:nvSpPr>
+        <p:spPr>
+          <a:xfrm>
+            <a:off x="2926080" y="1755648"/>
+            <a:ext cx="1371600" cy="365760"/>
+          </a:xfrm>
+          <a:prstGeom prst="rect">
+            <a:avLst/>
+          </a:prstGeom>
+          <a:solidFill>
+            <a:srgbClr val="FFFFFF"/>
+          </a:solidFill>
+          <a:ln w="9525">
+            <a:solidFill>
+              <a:srgbClr val="BFBFBF"/>
+            </a:solidFill>
+          </a:ln>
+          <a:effectLst/>
+        </p:spPr>
+        <p:style>
+          <a:lnRef idx="1">
+            <a:schemeClr val="accent1"/>
+          </a:lnRef>
+          <a:fillRef idx="3">
+            <a:schemeClr val="accent1"/>
+          </a:fillRef>
+          <a:effectRef idx="2">
+            <a:schemeClr val="accent1"/>
+          </a:effectRef>
+          <a:fontRef idx="minor">
+            <a:schemeClr val="lt1"/>
+          </a:fontRef>
+        </p:style>
+        <p:txBody>
+          <a:bodyPr rtlCol="0" anchor="ctr" wrap="square" lIns="45720" rIns="45720" tIns="27432" bIns="27432"/>
+          <a:lstStyle/>
+          <a:p>
+            <a:pPr algn="ctr"/>
+            <a:r>
+              <a:rPr sz="950" b="0">
+                <a:solidFill>
+                  <a:srgbClr val="1A1A1A"/>
+                </a:solidFill>
+                <a:latin typeface="맑은 고딕"/>
+                <a:ea typeface="맑은 고딕"/>
+              </a:rPr>
+              <a:t>1,084</a:t>
+            </a:r>
+          </a:p>
+        </p:txBody>
+      </p:sp>
+      <p:sp>
+        <p:nvSpPr>
+          <p:cNvPr id="70" name="Rectangle 69"/>
+          <p:cNvSpPr/>
+          <p:nvPr/>
+        </p:nvSpPr>
+        <p:spPr>
+          <a:xfrm>
+            <a:off x="4297680" y="1755648"/>
+            <a:ext cx="2468880" cy="365760"/>
+          </a:xfrm>
+          <a:prstGeom prst="rect">
+            <a:avLst/>
+          </a:prstGeom>
+          <a:solidFill>
+            <a:srgbClr val="FFFFFF"/>
+          </a:solidFill>
+          <a:ln w="9525">
+            <a:solidFill>
+              <a:srgbClr val="BFBFBF"/>
+            </a:solidFill>
+          </a:ln>
+          <a:effectLst/>
+        </p:spPr>
+        <p:style>
+          <a:lnRef idx="1">
+            <a:schemeClr val="accent1"/>
+          </a:lnRef>
+          <a:fillRef idx="3">
+            <a:schemeClr val="accent1"/>
+          </a:fillRef>
+          <a:effectRef idx="2">
+            <a:schemeClr val="accent1"/>
+          </a:effectRef>
+          <a:fontRef idx="minor">
+            <a:schemeClr val="lt1"/>
+          </a:fontRef>
+        </p:style>
+        <p:txBody>
+          <a:bodyPr rtlCol="0" anchor="ctr" wrap="square" lIns="45720" rIns="45720" tIns="27432" bIns="27432"/>
+          <a:lstStyle/>
+          <a:p>
+            <a:pPr algn="ctr"/>
+            <a:r>
+              <a:rPr sz="950" b="0">
+                <a:solidFill>
+                  <a:srgbClr val="1A1A1A"/>
+                </a:solidFill>
+                <a:latin typeface="맑은 고딕"/>
+                <a:ea typeface="맑은 고딕"/>
+              </a:rPr>
+              <a:t>1,372 (x1.27)</a:t>
+            </a:r>
+          </a:p>
+        </p:txBody>
+      </p:sp>
+      <p:sp>
+        <p:nvSpPr>
+          <p:cNvPr id="71" name="Rectangle 70"/>
+          <p:cNvSpPr/>
+          <p:nvPr/>
+        </p:nvSpPr>
+        <p:spPr>
+          <a:xfrm>
+            <a:off x="6766560" y="1755648"/>
+            <a:ext cx="2468880" cy="365760"/>
+          </a:xfrm>
+          <a:prstGeom prst="rect">
+            <a:avLst/>
+          </a:prstGeom>
+          <a:solidFill>
+            <a:srgbClr val="FFFFFF"/>
+          </a:solidFill>
+          <a:ln w="9525">
+            <a:solidFill>
+              <a:srgbClr val="BFBFBF"/>
+            </a:solidFill>
+          </a:ln>
+          <a:effectLst/>
+        </p:spPr>
+        <p:style>
+          <a:lnRef idx="1">
+            <a:schemeClr val="accent1"/>
+          </a:lnRef>
+          <a:fillRef idx="3">
+            <a:schemeClr val="accent1"/>
+          </a:fillRef>
+          <a:effectRef idx="2">
+            <a:schemeClr val="accent1"/>
+          </a:effectRef>
+          <a:fontRef idx="minor">
+            <a:schemeClr val="lt1"/>
+          </a:fontRef>
+        </p:style>
+        <p:txBody>
+          <a:bodyPr rtlCol="0" anchor="ctr" wrap="square" lIns="45720" rIns="45720" tIns="27432" bIns="27432"/>
+          <a:lstStyle/>
+          <a:p>
+            <a:pPr algn="ctr"/>
+            <a:r>
+              <a:rPr sz="950" b="0">
+                <a:solidFill>
+                  <a:srgbClr val="1A1A1A"/>
+                </a:solidFill>
+                <a:latin typeface="맑은 고딕"/>
+                <a:ea typeface="맑은 고딕"/>
+              </a:rPr>
+              <a:t>1,128 (x1.04)</a:t>
+            </a:r>
+          </a:p>
+        </p:txBody>
+      </p:sp>
+      <p:sp>
+        <p:nvSpPr>
+          <p:cNvPr id="72" name="Rectangle 71"/>
+          <p:cNvSpPr/>
+          <p:nvPr/>
+        </p:nvSpPr>
+        <p:spPr>
+          <a:xfrm>
+            <a:off x="9235440" y="1755648"/>
+            <a:ext cx="2560320" cy="365760"/>
+          </a:xfrm>
+          <a:prstGeom prst="rect">
+            <a:avLst/>
+          </a:prstGeom>
+          <a:solidFill>
+            <a:srgbClr val="FFFFFF"/>
+          </a:solidFill>
+          <a:ln w="9525">
+            <a:solidFill>
+              <a:srgbClr val="BFBFBF"/>
+            </a:solidFill>
+          </a:ln>
+          <a:effectLst/>
+        </p:spPr>
+        <p:style>
+          <a:lnRef idx="1">
+            <a:schemeClr val="accent1"/>
+          </a:lnRef>
+          <a:fillRef idx="3">
+            <a:schemeClr val="accent1"/>
+          </a:fillRef>
+          <a:effectRef idx="2">
+            <a:schemeClr val="accent1"/>
+          </a:effectRef>
+          <a:fontRef idx="minor">
+            <a:schemeClr val="lt1"/>
+          </a:fontRef>
+        </p:style>
+        <p:txBody>
+          <a:bodyPr rtlCol="0" anchor="ctr" wrap="square" lIns="45720" rIns="45720" tIns="27432" bIns="27432"/>
+          <a:lstStyle/>
+          <a:p>
+            <a:pPr algn="ctr"/>
+            <a:r>
+              <a:rPr sz="950" b="0">
+                <a:solidFill>
+                  <a:srgbClr val="1A1A1A"/>
+                </a:solidFill>
+                <a:latin typeface="맑은 고딕"/>
+                <a:ea typeface="맑은 고딕"/>
+              </a:rPr>
+              <a:t>785 (x0.72)</a:t>
+            </a:r>
+          </a:p>
+        </p:txBody>
+      </p:sp>
+      <p:sp>
+        <p:nvSpPr>
+          <p:cNvPr id="73" name="Rectangle 72"/>
+          <p:cNvSpPr/>
+          <p:nvPr/>
+        </p:nvSpPr>
+        <p:spPr>
+          <a:xfrm>
+            <a:off x="365760" y="2139696"/>
+            <a:ext cx="2560320" cy="365760"/>
+          </a:xfrm>
+          <a:prstGeom prst="rect">
+            <a:avLst/>
+          </a:prstGeom>
+          <a:solidFill>
+            <a:srgbClr val="DCE9F5"/>
+          </a:solidFill>
+          <a:ln w="9525">
+            <a:solidFill>
+              <a:srgbClr val="4D7EA8"/>
+            </a:solidFill>
+          </a:ln>
+          <a:effectLst/>
+        </p:spPr>
+        <p:style>
+          <a:lnRef idx="1">
+            <a:schemeClr val="accent1"/>
+          </a:lnRef>
+          <a:fillRef idx="3">
+            <a:schemeClr val="accent1"/>
+          </a:fillRef>
+          <a:effectRef idx="2">
+            <a:schemeClr val="accent1"/>
+          </a:effectRef>
+          <a:fontRef idx="minor">
+            <a:schemeClr val="lt1"/>
+          </a:fontRef>
+        </p:style>
+        <p:txBody>
+          <a:bodyPr rtlCol="0" anchor="ctr" wrap="square" lIns="45720" rIns="45720" tIns="27432" bIns="27432"/>
+          <a:lstStyle/>
+          <a:p>
+            <a:pPr algn="l"/>
+            <a:r>
+              <a:rPr sz="950" b="1">
+                <a:solidFill>
+                  <a:srgbClr val="1A1A1A"/>
+                </a:solidFill>
+                <a:latin typeface="맑은 고딕"/>
+                <a:ea typeface="맑은 고딕"/>
+              </a:rPr>
+              <a:t>QA2 TPOT P99 (ms) ↓</a:t>
+            </a:r>
+          </a:p>
+        </p:txBody>
+      </p:sp>
+      <p:sp>
+        <p:nvSpPr>
+          <p:cNvPr id="74" name="Rectangle 73"/>
+          <p:cNvSpPr/>
+          <p:nvPr/>
+        </p:nvSpPr>
+        <p:spPr>
+          <a:xfrm>
+            <a:off x="2926080" y="2139696"/>
+            <a:ext cx="1371600" cy="365760"/>
+          </a:xfrm>
+          <a:prstGeom prst="rect">
+            <a:avLst/>
+          </a:prstGeom>
+          <a:solidFill>
+            <a:srgbClr val="FFFFFF"/>
+          </a:solidFill>
+          <a:ln w="9525">
+            <a:solidFill>
+              <a:srgbClr val="BFBFBF"/>
+            </a:solidFill>
+          </a:ln>
+          <a:effectLst/>
+        </p:spPr>
+        <p:style>
+          <a:lnRef idx="1">
+            <a:schemeClr val="accent1"/>
+          </a:lnRef>
+          <a:fillRef idx="3">
+            <a:schemeClr val="accent1"/>
+          </a:fillRef>
+          <a:effectRef idx="2">
+            <a:schemeClr val="accent1"/>
+          </a:effectRef>
+          <a:fontRef idx="minor">
+            <a:schemeClr val="lt1"/>
+          </a:fontRef>
+        </p:style>
+        <p:txBody>
+          <a:bodyPr rtlCol="0" anchor="ctr" wrap="square" lIns="45720" rIns="45720" tIns="27432" bIns="27432"/>
+          <a:lstStyle/>
+          <a:p>
+            <a:pPr algn="ctr"/>
+            <a:r>
+              <a:rPr sz="950" b="0">
+                <a:solidFill>
+                  <a:srgbClr val="1A1A1A"/>
+                </a:solidFill>
+                <a:latin typeface="맑은 고딕"/>
+                <a:ea typeface="맑은 고딕"/>
+              </a:rPr>
+              <a:t>17.1</a:t>
+            </a:r>
+          </a:p>
+        </p:txBody>
+      </p:sp>
+      <p:sp>
+        <p:nvSpPr>
+          <p:cNvPr id="75" name="Rectangle 74"/>
+          <p:cNvSpPr/>
+          <p:nvPr/>
+        </p:nvSpPr>
+        <p:spPr>
+          <a:xfrm>
+            <a:off x="4297680" y="2139696"/>
+            <a:ext cx="2468880" cy="365760"/>
+          </a:xfrm>
+          <a:prstGeom prst="rect">
+            <a:avLst/>
+          </a:prstGeom>
+          <a:solidFill>
+            <a:srgbClr val="FFFFFF"/>
+          </a:solidFill>
+          <a:ln w="9525">
+            <a:solidFill>
+              <a:srgbClr val="BFBFBF"/>
+            </a:solidFill>
+          </a:ln>
+          <a:effectLst/>
+        </p:spPr>
+        <p:style>
+          <a:lnRef idx="1">
+            <a:schemeClr val="accent1"/>
+          </a:lnRef>
+          <a:fillRef idx="3">
+            <a:schemeClr val="accent1"/>
+          </a:fillRef>
+          <a:effectRef idx="2">
+            <a:schemeClr val="accent1"/>
+          </a:effectRef>
+          <a:fontRef idx="minor">
+            <a:schemeClr val="lt1"/>
+          </a:fontRef>
+        </p:style>
+        <p:txBody>
+          <a:bodyPr rtlCol="0" anchor="ctr" wrap="square" lIns="45720" rIns="45720" tIns="27432" bIns="27432"/>
+          <a:lstStyle/>
+          <a:p>
+            <a:pPr algn="ctr"/>
+            <a:r>
+              <a:rPr sz="950" b="0">
+                <a:solidFill>
+                  <a:srgbClr val="1A1A1A"/>
+                </a:solidFill>
+                <a:latin typeface="맑은 고딕"/>
+                <a:ea typeface="맑은 고딕"/>
+              </a:rPr>
+              <a:t>18.2 (x1.06)</a:t>
+            </a:r>
+          </a:p>
+        </p:txBody>
+      </p:sp>
+      <p:sp>
+        <p:nvSpPr>
+          <p:cNvPr id="76" name="Rectangle 75"/>
+          <p:cNvSpPr/>
+          <p:nvPr/>
+        </p:nvSpPr>
+        <p:spPr>
+          <a:xfrm>
+            <a:off x="6766560" y="2139696"/>
+            <a:ext cx="2468880" cy="365760"/>
+          </a:xfrm>
+          <a:prstGeom prst="rect">
+            <a:avLst/>
+          </a:prstGeom>
+          <a:solidFill>
+            <a:srgbClr val="FFFFFF"/>
+          </a:solidFill>
+          <a:ln w="9525">
+            <a:solidFill>
+              <a:srgbClr val="BFBFBF"/>
+            </a:solidFill>
+          </a:ln>
+          <a:effectLst/>
+        </p:spPr>
+        <p:style>
+          <a:lnRef idx="1">
+            <a:schemeClr val="accent1"/>
+          </a:lnRef>
+          <a:fillRef idx="3">
+            <a:schemeClr val="accent1"/>
+          </a:fillRef>
+          <a:effectRef idx="2">
+            <a:schemeClr val="accent1"/>
+          </a:effectRef>
+          <a:fontRef idx="minor">
+            <a:schemeClr val="lt1"/>
+          </a:fontRef>
+        </p:style>
+        <p:txBody>
+          <a:bodyPr rtlCol="0" anchor="ctr" wrap="square" lIns="45720" rIns="45720" tIns="27432" bIns="27432"/>
+          <a:lstStyle/>
+          <a:p>
+            <a:pPr algn="ctr"/>
+            <a:r>
+              <a:rPr sz="950" b="0">
+                <a:solidFill>
+                  <a:srgbClr val="1A1A1A"/>
+                </a:solidFill>
+                <a:latin typeface="맑은 고딕"/>
+                <a:ea typeface="맑은 고딕"/>
+              </a:rPr>
+              <a:t>18.3 (x1.07)</a:t>
+            </a:r>
+          </a:p>
+        </p:txBody>
+      </p:sp>
+      <p:sp>
+        <p:nvSpPr>
+          <p:cNvPr id="77" name="Rectangle 76"/>
+          <p:cNvSpPr/>
+          <p:nvPr/>
+        </p:nvSpPr>
+        <p:spPr>
+          <a:xfrm>
+            <a:off x="9235440" y="2139696"/>
+            <a:ext cx="2560320" cy="365760"/>
+          </a:xfrm>
+          <a:prstGeom prst="rect">
+            <a:avLst/>
+          </a:prstGeom>
+          <a:solidFill>
+            <a:srgbClr val="FFFFFF"/>
+          </a:solidFill>
+          <a:ln w="9525">
+            <a:solidFill>
+              <a:srgbClr val="BFBFBF"/>
+            </a:solidFill>
+          </a:ln>
+          <a:effectLst/>
+        </p:spPr>
+        <p:style>
+          <a:lnRef idx="1">
+            <a:schemeClr val="accent1"/>
+          </a:lnRef>
+          <a:fillRef idx="3">
+            <a:schemeClr val="accent1"/>
+          </a:fillRef>
+          <a:effectRef idx="2">
+            <a:schemeClr val="accent1"/>
+          </a:effectRef>
+          <a:fontRef idx="minor">
+            <a:schemeClr val="lt1"/>
+          </a:fontRef>
+        </p:style>
+        <p:txBody>
+          <a:bodyPr rtlCol="0" anchor="ctr" wrap="square" lIns="45720" rIns="45720" tIns="27432" bIns="27432"/>
+          <a:lstStyle/>
+          <a:p>
+            <a:pPr algn="ctr"/>
+            <a:r>
+              <a:rPr sz="950" b="0">
+                <a:solidFill>
+                  <a:srgbClr val="1A1A1A"/>
+                </a:solidFill>
+                <a:latin typeface="맑은 고딕"/>
+                <a:ea typeface="맑은 고딕"/>
+              </a:rPr>
+              <a:t>16.0 (x0.94)</a:t>
+            </a:r>
+          </a:p>
+        </p:txBody>
+      </p:sp>
+      <p:sp>
+        <p:nvSpPr>
+          <p:cNvPr id="78" name="Rectangle 77"/>
+          <p:cNvSpPr/>
+          <p:nvPr/>
+        </p:nvSpPr>
+        <p:spPr>
+          <a:xfrm>
+            <a:off x="365760" y="2523744"/>
+            <a:ext cx="2560320" cy="365760"/>
+          </a:xfrm>
+          <a:prstGeom prst="rect">
+            <a:avLst/>
+          </a:prstGeom>
+          <a:solidFill>
+            <a:srgbClr val="DCE9F5"/>
+          </a:solidFill>
+          <a:ln w="9525">
+            <a:solidFill>
+              <a:srgbClr val="4D7EA8"/>
+            </a:solidFill>
+          </a:ln>
+          <a:effectLst/>
+        </p:spPr>
+        <p:style>
+          <a:lnRef idx="1">
+            <a:schemeClr val="accent1"/>
+          </a:lnRef>
+          <a:fillRef idx="3">
+            <a:schemeClr val="accent1"/>
+          </a:fillRef>
+          <a:effectRef idx="2">
+            <a:schemeClr val="accent1"/>
+          </a:effectRef>
+          <a:fontRef idx="minor">
+            <a:schemeClr val="lt1"/>
+          </a:fontRef>
+        </p:style>
+        <p:txBody>
+          <a:bodyPr rtlCol="0" anchor="ctr" wrap="square" lIns="45720" rIns="45720" tIns="27432" bIns="27432"/>
+          <a:lstStyle/>
+          <a:p>
+            <a:pPr algn="l"/>
+            <a:r>
+              <a:rPr sz="950" b="1">
+                <a:solidFill>
+                  <a:srgbClr val="1A1A1A"/>
+                </a:solidFill>
+                <a:latin typeface="맑은 고딕"/>
+                <a:ea typeface="맑은 고딕"/>
+              </a:rPr>
+              <a:t>QA2 별점 (개선 배수)</a:t>
+            </a:r>
+          </a:p>
+        </p:txBody>
+      </p:sp>
+      <p:sp>
+        <p:nvSpPr>
+          <p:cNvPr id="79" name="Rectangle 78"/>
+          <p:cNvSpPr/>
+          <p:nvPr/>
+        </p:nvSpPr>
+        <p:spPr>
+          <a:xfrm>
+            <a:off x="2926080" y="2523744"/>
+            <a:ext cx="1371600" cy="365760"/>
+          </a:xfrm>
+          <a:prstGeom prst="rect">
+            <a:avLst/>
+          </a:prstGeom>
+          <a:solidFill>
+            <a:srgbClr val="FFFFFF"/>
+          </a:solidFill>
+          <a:ln w="9525">
+            <a:solidFill>
+              <a:srgbClr val="BFBFBF"/>
+            </a:solidFill>
+          </a:ln>
+          <a:effectLst/>
+        </p:spPr>
+        <p:style>
+          <a:lnRef idx="1">
+            <a:schemeClr val="accent1"/>
+          </a:lnRef>
+          <a:fillRef idx="3">
+            <a:schemeClr val="accent1"/>
+          </a:fillRef>
+          <a:effectRef idx="2">
+            <a:schemeClr val="accent1"/>
+          </a:effectRef>
+          <a:fontRef idx="minor">
+            <a:schemeClr val="lt1"/>
+          </a:fontRef>
+        </p:style>
+        <p:txBody>
+          <a:bodyPr rtlCol="0" anchor="ctr" wrap="square" lIns="45720" rIns="45720" tIns="27432" bIns="27432"/>
+          <a:lstStyle/>
+          <a:p>
+            <a:pPr algn="ctr"/>
+            <a:r>
+              <a:rPr sz="950" b="0">
+                <a:solidFill>
+                  <a:srgbClr val="1A1A1A"/>
+                </a:solidFill>
+                <a:latin typeface="맑은 고딕"/>
+                <a:ea typeface="맑은 고딕"/>
+              </a:rPr>
+              <a:t>x1.00</a:t>
+            </a:r>
+          </a:p>
+        </p:txBody>
+      </p:sp>
+      <p:sp>
+        <p:nvSpPr>
+          <p:cNvPr id="80" name="Rectangle 79"/>
+          <p:cNvSpPr/>
+          <p:nvPr/>
+        </p:nvSpPr>
+        <p:spPr>
+          <a:xfrm>
+            <a:off x="4297680" y="2523744"/>
+            <a:ext cx="2468880" cy="365760"/>
+          </a:xfrm>
+          <a:prstGeom prst="rect">
+            <a:avLst/>
+          </a:prstGeom>
+          <a:solidFill>
+            <a:srgbClr val="FFFFFF"/>
+          </a:solidFill>
+          <a:ln w="9525">
+            <a:solidFill>
+              <a:srgbClr val="BFBFBF"/>
+            </a:solidFill>
+          </a:ln>
+          <a:effectLst/>
+        </p:spPr>
+        <p:style>
+          <a:lnRef idx="1">
+            <a:schemeClr val="accent1"/>
+          </a:lnRef>
+          <a:fillRef idx="3">
+            <a:schemeClr val="accent1"/>
+          </a:fillRef>
+          <a:effectRef idx="2">
+            <a:schemeClr val="accent1"/>
+          </a:effectRef>
+          <a:fontRef idx="minor">
+            <a:schemeClr val="lt1"/>
+          </a:fontRef>
+        </p:style>
+        <p:txBody>
+          <a:bodyPr rtlCol="0" anchor="ctr" wrap="square" lIns="45720" rIns="45720" tIns="27432" bIns="27432"/>
+          <a:lstStyle/>
+          <a:p>
+            <a:pPr algn="ctr"/>
+            <a:r>
+              <a:rPr sz="950" b="0">
+                <a:solidFill>
+                  <a:srgbClr val="1A1A1A"/>
+                </a:solidFill>
+                <a:latin typeface="맑은 고딕"/>
+                <a:ea typeface="맑은 고딕"/>
+              </a:rPr>
+              <a:t>★★  x1.07</a:t>
+            </a:r>
+          </a:p>
+        </p:txBody>
+      </p:sp>
+      <p:sp>
+        <p:nvSpPr>
+          <p:cNvPr id="81" name="Rectangle 80"/>
+          <p:cNvSpPr/>
+          <p:nvPr/>
+        </p:nvSpPr>
+        <p:spPr>
+          <a:xfrm>
+            <a:off x="6766560" y="2523744"/>
+            <a:ext cx="2468880" cy="365760"/>
+          </a:xfrm>
+          <a:prstGeom prst="rect">
+            <a:avLst/>
+          </a:prstGeom>
+          <a:solidFill>
+            <a:srgbClr val="FFFFFF"/>
+          </a:solidFill>
+          <a:ln w="9525">
+            <a:solidFill>
+              <a:srgbClr val="BFBFBF"/>
+            </a:solidFill>
+          </a:ln>
+          <a:effectLst/>
+        </p:spPr>
+        <p:style>
+          <a:lnRef idx="1">
+            <a:schemeClr val="accent1"/>
+          </a:lnRef>
+          <a:fillRef idx="3">
+            <a:schemeClr val="accent1"/>
+          </a:fillRef>
+          <a:effectRef idx="2">
+            <a:schemeClr val="accent1"/>
+          </a:effectRef>
+          <a:fontRef idx="minor">
+            <a:schemeClr val="lt1"/>
+          </a:fontRef>
+        </p:style>
+        <p:txBody>
+          <a:bodyPr rtlCol="0" anchor="ctr" wrap="square" lIns="45720" rIns="45720" tIns="27432" bIns="27432"/>
+          <a:lstStyle/>
+          <a:p>
+            <a:pPr algn="ctr"/>
+            <a:r>
+              <a:rPr sz="950" b="0">
+                <a:solidFill>
+                  <a:srgbClr val="1A1A1A"/>
+                </a:solidFill>
+                <a:latin typeface="맑은 고딕"/>
+                <a:ea typeface="맑은 고딕"/>
+              </a:rPr>
+              <a:t>★★★  x1.28</a:t>
+            </a:r>
+          </a:p>
+        </p:txBody>
+      </p:sp>
+      <p:sp>
+        <p:nvSpPr>
+          <p:cNvPr id="82" name="Rectangle 81"/>
+          <p:cNvSpPr/>
+          <p:nvPr/>
+        </p:nvSpPr>
+        <p:spPr>
+          <a:xfrm>
+            <a:off x="9235440" y="2523744"/>
+            <a:ext cx="2560320" cy="365760"/>
+          </a:xfrm>
+          <a:prstGeom prst="rect">
+            <a:avLst/>
+          </a:prstGeom>
+          <a:solidFill>
+            <a:srgbClr val="FFFFFF"/>
+          </a:solidFill>
+          <a:ln w="9525">
+            <a:solidFill>
+              <a:srgbClr val="BFBFBF"/>
+            </a:solidFill>
+          </a:ln>
+          <a:effectLst/>
+        </p:spPr>
+        <p:style>
+          <a:lnRef idx="1">
+            <a:schemeClr val="accent1"/>
+          </a:lnRef>
+          <a:fillRef idx="3">
+            <a:schemeClr val="accent1"/>
+          </a:fillRef>
+          <a:effectRef idx="2">
+            <a:schemeClr val="accent1"/>
+          </a:effectRef>
+          <a:fontRef idx="minor">
+            <a:schemeClr val="lt1"/>
+          </a:fontRef>
+        </p:style>
+        <p:txBody>
+          <a:bodyPr rtlCol="0" anchor="ctr" wrap="square" lIns="45720" rIns="45720" tIns="27432" bIns="27432"/>
+          <a:lstStyle/>
+          <a:p>
+            <a:pPr algn="ctr"/>
+            <a:r>
+              <a:rPr sz="950" b="0">
+                <a:solidFill>
+                  <a:srgbClr val="1A1A1A"/>
+                </a:solidFill>
+                <a:latin typeface="맑은 고딕"/>
+                <a:ea typeface="맑은 고딕"/>
+              </a:rPr>
+              <a:t>★★★  x1.56</a:t>
+            </a:r>
+          </a:p>
+        </p:txBody>
+      </p:sp>
+      <p:sp>
+        <p:nvSpPr>
+          <p:cNvPr id="83" name="Rectangle 82"/>
+          <p:cNvSpPr/>
+          <p:nvPr/>
+        </p:nvSpPr>
+        <p:spPr>
+          <a:xfrm>
+            <a:off x="365760" y="2907791"/>
+            <a:ext cx="2560320" cy="365760"/>
+          </a:xfrm>
+          <a:prstGeom prst="rect">
+            <a:avLst/>
+          </a:prstGeom>
+          <a:solidFill>
+            <a:srgbClr val="DCE9F5"/>
+          </a:solidFill>
+          <a:ln w="9525">
+            <a:solidFill>
+              <a:srgbClr val="4D7EA8"/>
+            </a:solidFill>
+          </a:ln>
+          <a:effectLst/>
+        </p:spPr>
+        <p:style>
+          <a:lnRef idx="1">
+            <a:schemeClr val="accent1"/>
+          </a:lnRef>
+          <a:fillRef idx="3">
+            <a:schemeClr val="accent1"/>
+          </a:fillRef>
+          <a:effectRef idx="2">
+            <a:schemeClr val="accent1"/>
+          </a:effectRef>
+          <a:fontRef idx="minor">
+            <a:schemeClr val="lt1"/>
+          </a:fontRef>
+        </p:style>
+        <p:txBody>
+          <a:bodyPr rtlCol="0" anchor="ctr" wrap="square" lIns="45720" rIns="45720" tIns="27432" bIns="27432"/>
+          <a:lstStyle/>
+          <a:p>
+            <a:pPr algn="l"/>
+            <a:r>
+              <a:rPr sz="950" b="1">
+                <a:solidFill>
+                  <a:srgbClr val="1A1A1A"/>
+                </a:solidFill>
+                <a:latin typeface="맑은 고딕"/>
+                <a:ea typeface="맑은 고딕"/>
+              </a:rPr>
+              <a:t>QA3 HBM 사용량 (GiB) ↓</a:t>
+            </a:r>
+          </a:p>
+        </p:txBody>
+      </p:sp>
+      <p:sp>
+        <p:nvSpPr>
+          <p:cNvPr id="84" name="Rectangle 83"/>
+          <p:cNvSpPr/>
+          <p:nvPr/>
+        </p:nvSpPr>
+        <p:spPr>
+          <a:xfrm>
+            <a:off x="2926080" y="2907791"/>
+            <a:ext cx="1371600" cy="365760"/>
+          </a:xfrm>
+          <a:prstGeom prst="rect">
+            <a:avLst/>
+          </a:prstGeom>
+          <a:solidFill>
+            <a:srgbClr val="FFFFFF"/>
+          </a:solidFill>
+          <a:ln w="9525">
+            <a:solidFill>
+              <a:srgbClr val="BFBFBF"/>
+            </a:solidFill>
+          </a:ln>
+          <a:effectLst/>
+        </p:spPr>
+        <p:style>
+          <a:lnRef idx="1">
+            <a:schemeClr val="accent1"/>
+          </a:lnRef>
+          <a:fillRef idx="3">
+            <a:schemeClr val="accent1"/>
+          </a:fillRef>
+          <a:effectRef idx="2">
+            <a:schemeClr val="accent1"/>
+          </a:effectRef>
+          <a:fontRef idx="minor">
+            <a:schemeClr val="lt1"/>
+          </a:fontRef>
+        </p:style>
+        <p:txBody>
+          <a:bodyPr rtlCol="0" anchor="ctr" wrap="square" lIns="45720" rIns="45720" tIns="27432" bIns="27432"/>
+          <a:lstStyle/>
+          <a:p>
+            <a:pPr algn="ctr"/>
+            <a:r>
+              <a:rPr sz="950" b="0">
+                <a:solidFill>
+                  <a:srgbClr val="1A1A1A"/>
+                </a:solidFill>
+                <a:latin typeface="맑은 고딕"/>
+                <a:ea typeface="맑은 고딕"/>
+              </a:rPr>
+              <a:t>146.6</a:t>
+            </a:r>
+          </a:p>
+        </p:txBody>
+      </p:sp>
+      <p:sp>
+        <p:nvSpPr>
+          <p:cNvPr id="85" name="Rectangle 84"/>
+          <p:cNvSpPr/>
+          <p:nvPr/>
+        </p:nvSpPr>
+        <p:spPr>
+          <a:xfrm>
+            <a:off x="4297680" y="2907791"/>
+            <a:ext cx="2468880" cy="365760"/>
+          </a:xfrm>
+          <a:prstGeom prst="rect">
+            <a:avLst/>
+          </a:prstGeom>
+          <a:solidFill>
+            <a:srgbClr val="FFFFFF"/>
+          </a:solidFill>
+          <a:ln w="9525">
+            <a:solidFill>
+              <a:srgbClr val="BFBFBF"/>
+            </a:solidFill>
+          </a:ln>
+          <a:effectLst/>
+        </p:spPr>
+        <p:style>
+          <a:lnRef idx="1">
+            <a:schemeClr val="accent1"/>
+          </a:lnRef>
+          <a:fillRef idx="3">
+            <a:schemeClr val="accent1"/>
+          </a:fillRef>
+          <a:effectRef idx="2">
+            <a:schemeClr val="accent1"/>
+          </a:effectRef>
+          <a:fontRef idx="minor">
+            <a:schemeClr val="lt1"/>
+          </a:fontRef>
+        </p:style>
+        <p:txBody>
+          <a:bodyPr rtlCol="0" anchor="ctr" wrap="square" lIns="45720" rIns="45720" tIns="27432" bIns="27432"/>
+          <a:lstStyle/>
+          <a:p>
+            <a:pPr algn="ctr"/>
+            <a:r>
+              <a:rPr sz="950" b="0">
+                <a:solidFill>
+                  <a:srgbClr val="1A1A1A"/>
+                </a:solidFill>
+                <a:latin typeface="맑은 고딕"/>
+                <a:ea typeface="맑은 고딕"/>
+              </a:rPr>
+              <a:t>★★  144.6 (x0.99)</a:t>
+            </a:r>
+          </a:p>
+        </p:txBody>
+      </p:sp>
+      <p:sp>
+        <p:nvSpPr>
+          <p:cNvPr id="86" name="Rectangle 85"/>
+          <p:cNvSpPr/>
+          <p:nvPr/>
+        </p:nvSpPr>
+        <p:spPr>
+          <a:xfrm>
+            <a:off x="6766560" y="2907791"/>
+            <a:ext cx="2468880" cy="365760"/>
+          </a:xfrm>
+          <a:prstGeom prst="rect">
+            <a:avLst/>
+          </a:prstGeom>
+          <a:solidFill>
+            <a:srgbClr val="FFFFFF"/>
+          </a:solidFill>
+          <a:ln w="9525">
+            <a:solidFill>
+              <a:srgbClr val="BFBFBF"/>
+            </a:solidFill>
+          </a:ln>
+          <a:effectLst/>
+        </p:spPr>
+        <p:style>
+          <a:lnRef idx="1">
+            <a:schemeClr val="accent1"/>
+          </a:lnRef>
+          <a:fillRef idx="3">
+            <a:schemeClr val="accent1"/>
+          </a:fillRef>
+          <a:effectRef idx="2">
+            <a:schemeClr val="accent1"/>
+          </a:effectRef>
+          <a:fontRef idx="minor">
+            <a:schemeClr val="lt1"/>
+          </a:fontRef>
+        </p:style>
+        <p:txBody>
+          <a:bodyPr rtlCol="0" anchor="ctr" wrap="square" lIns="45720" rIns="45720" tIns="27432" bIns="27432"/>
+          <a:lstStyle/>
+          <a:p>
+            <a:pPr algn="ctr"/>
+            <a:r>
+              <a:rPr sz="950" b="0">
+                <a:solidFill>
+                  <a:srgbClr val="1A1A1A"/>
+                </a:solidFill>
+                <a:latin typeface="맑은 고딕"/>
+                <a:ea typeface="맑은 고딕"/>
+              </a:rPr>
+              <a:t>★★  142.7 (x0.97)</a:t>
+            </a:r>
+          </a:p>
+        </p:txBody>
+      </p:sp>
+      <p:sp>
+        <p:nvSpPr>
+          <p:cNvPr id="87" name="Rectangle 86"/>
+          <p:cNvSpPr/>
+          <p:nvPr/>
+        </p:nvSpPr>
+        <p:spPr>
+          <a:xfrm>
+            <a:off x="9235440" y="2907791"/>
+            <a:ext cx="2560320" cy="365760"/>
+          </a:xfrm>
+          <a:prstGeom prst="rect">
+            <a:avLst/>
+          </a:prstGeom>
+          <a:solidFill>
+            <a:srgbClr val="FFFFFF"/>
+          </a:solidFill>
+          <a:ln w="9525">
+            <a:solidFill>
+              <a:srgbClr val="BFBFBF"/>
+            </a:solidFill>
+          </a:ln>
+          <a:effectLst/>
+        </p:spPr>
+        <p:style>
+          <a:lnRef idx="1">
+            <a:schemeClr val="accent1"/>
+          </a:lnRef>
+          <a:fillRef idx="3">
+            <a:schemeClr val="accent1"/>
+          </a:fillRef>
+          <a:effectRef idx="2">
+            <a:schemeClr val="accent1"/>
+          </a:effectRef>
+          <a:fontRef idx="minor">
+            <a:schemeClr val="lt1"/>
+          </a:fontRef>
+        </p:style>
+        <p:txBody>
+          <a:bodyPr rtlCol="0" anchor="ctr" wrap="square" lIns="45720" rIns="45720" tIns="27432" bIns="27432"/>
+          <a:lstStyle/>
+          <a:p>
+            <a:pPr algn="ctr"/>
+            <a:r>
+              <a:rPr sz="950" b="0">
+                <a:solidFill>
+                  <a:srgbClr val="1A1A1A"/>
+                </a:solidFill>
+                <a:latin typeface="맑은 고딕"/>
+                <a:ea typeface="맑은 고딕"/>
+              </a:rPr>
+              <a:t>★  178.0 (x1.21)</a:t>
+            </a:r>
+          </a:p>
+        </p:txBody>
+      </p:sp>
+      <p:sp>
+        <p:nvSpPr>
+          <p:cNvPr id="88" name="Rectangle 87"/>
+          <p:cNvSpPr/>
+          <p:nvPr/>
+        </p:nvSpPr>
+        <p:spPr>
+          <a:xfrm>
+            <a:off x="365760" y="3291839"/>
+            <a:ext cx="2560320" cy="365760"/>
+          </a:xfrm>
+          <a:prstGeom prst="rect">
+            <a:avLst/>
+          </a:prstGeom>
+          <a:solidFill>
+            <a:srgbClr val="DCE9F5"/>
+          </a:solidFill>
+          <a:ln w="9525">
+            <a:solidFill>
+              <a:srgbClr val="4D7EA8"/>
+            </a:solidFill>
+          </a:ln>
+          <a:effectLst/>
+        </p:spPr>
+        <p:style>
+          <a:lnRef idx="1">
+            <a:schemeClr val="accent1"/>
+          </a:lnRef>
+          <a:fillRef idx="3">
+            <a:schemeClr val="accent1"/>
+          </a:fillRef>
+          <a:effectRef idx="2">
+            <a:schemeClr val="accent1"/>
+          </a:effectRef>
+          <a:fontRef idx="minor">
+            <a:schemeClr val="lt1"/>
+          </a:fontRef>
+        </p:style>
+        <p:txBody>
+          <a:bodyPr rtlCol="0" anchor="ctr" wrap="square" lIns="45720" rIns="45720" tIns="27432" bIns="27432"/>
+          <a:lstStyle/>
+          <a:p>
+            <a:pPr algn="l"/>
+            <a:r>
+              <a:rPr sz="950" b="1">
+                <a:solidFill>
+                  <a:srgbClr val="1A1A1A"/>
+                </a:solidFill>
+                <a:latin typeface="맑은 고딕"/>
+                <a:ea typeface="맑은 고딕"/>
+              </a:rPr>
+              <a:t>Baseline 대비 승/무/패</a:t>
+            </a:r>
+          </a:p>
+        </p:txBody>
+      </p:sp>
+      <p:sp>
+        <p:nvSpPr>
+          <p:cNvPr id="89" name="Rectangle 88"/>
+          <p:cNvSpPr/>
+          <p:nvPr/>
+        </p:nvSpPr>
+        <p:spPr>
+          <a:xfrm>
+            <a:off x="2926080" y="3291839"/>
+            <a:ext cx="1371600" cy="365760"/>
+          </a:xfrm>
+          <a:prstGeom prst="rect">
+            <a:avLst/>
+          </a:prstGeom>
+          <a:solidFill>
+            <a:srgbClr val="FFFFFF"/>
+          </a:solidFill>
+          <a:ln w="9525">
+            <a:solidFill>
+              <a:srgbClr val="BFBFBF"/>
+            </a:solidFill>
+          </a:ln>
+          <a:effectLst/>
+        </p:spPr>
+        <p:style>
+          <a:lnRef idx="1">
+            <a:schemeClr val="accent1"/>
+          </a:lnRef>
+          <a:fillRef idx="3">
+            <a:schemeClr val="accent1"/>
+          </a:fillRef>
+          <a:effectRef idx="2">
+            <a:schemeClr val="accent1"/>
+          </a:effectRef>
+          <a:fontRef idx="minor">
+            <a:schemeClr val="lt1"/>
+          </a:fontRef>
+        </p:style>
+        <p:txBody>
+          <a:bodyPr rtlCol="0" anchor="ctr" wrap="square" lIns="45720" rIns="45720" tIns="27432" bIns="27432"/>
+          <a:lstStyle/>
+          <a:p>
+            <a:pPr algn="ctr"/>
+            <a:r>
+              <a:rPr sz="950" b="0">
+                <a:solidFill>
+                  <a:srgbClr val="1A1A1A"/>
+                </a:solidFill>
+                <a:latin typeface="맑은 고딕"/>
+                <a:ea typeface="맑은 고딕"/>
+              </a:rPr>
+              <a:t>—</a:t>
+            </a:r>
+          </a:p>
+        </p:txBody>
+      </p:sp>
+      <p:sp>
+        <p:nvSpPr>
+          <p:cNvPr id="90" name="Rectangle 89"/>
+          <p:cNvSpPr/>
+          <p:nvPr/>
+        </p:nvSpPr>
+        <p:spPr>
+          <a:xfrm>
+            <a:off x="4297680" y="3291839"/>
+            <a:ext cx="2468880" cy="365760"/>
+          </a:xfrm>
+          <a:prstGeom prst="rect">
+            <a:avLst/>
+          </a:prstGeom>
+          <a:solidFill>
+            <a:srgbClr val="FFFFFF"/>
+          </a:solidFill>
+          <a:ln w="9525">
+            <a:solidFill>
+              <a:srgbClr val="BFBFBF"/>
+            </a:solidFill>
+          </a:ln>
+          <a:effectLst/>
+        </p:spPr>
+        <p:style>
+          <a:lnRef idx="1">
+            <a:schemeClr val="accent1"/>
+          </a:lnRef>
+          <a:fillRef idx="3">
+            <a:schemeClr val="accent1"/>
+          </a:fillRef>
+          <a:effectRef idx="2">
+            <a:schemeClr val="accent1"/>
+          </a:effectRef>
+          <a:fontRef idx="minor">
+            <a:schemeClr val="lt1"/>
+          </a:fontRef>
+        </p:style>
+        <p:txBody>
+          <a:bodyPr rtlCol="0" anchor="ctr" wrap="square" lIns="45720" rIns="45720" tIns="27432" bIns="27432"/>
+          <a:lstStyle/>
+          <a:p>
+            <a:pPr algn="ctr"/>
+            <a:r>
+              <a:rPr sz="950" b="0">
+                <a:solidFill>
+                  <a:srgbClr val="1A1A1A"/>
+                </a:solidFill>
+                <a:latin typeface="맑은 고딕"/>
+                <a:ea typeface="맑은 고딕"/>
+              </a:rPr>
+              <a:t>2승 29무 0패</a:t>
+            </a:r>
+          </a:p>
+        </p:txBody>
+      </p:sp>
+      <p:sp>
+        <p:nvSpPr>
+          <p:cNvPr id="91" name="Rectangle 90"/>
+          <p:cNvSpPr/>
+          <p:nvPr/>
+        </p:nvSpPr>
+        <p:spPr>
+          <a:xfrm>
+            <a:off x="6766560" y="3291839"/>
+            <a:ext cx="2468880" cy="365760"/>
+          </a:xfrm>
+          <a:prstGeom prst="rect">
+            <a:avLst/>
+          </a:prstGeom>
+          <a:solidFill>
+            <a:srgbClr val="FFFFFF"/>
+          </a:solidFill>
+          <a:ln w="9525">
+            <a:solidFill>
+              <a:srgbClr val="BFBFBF"/>
+            </a:solidFill>
+          </a:ln>
+          <a:effectLst/>
+        </p:spPr>
+        <p:style>
+          <a:lnRef idx="1">
+            <a:schemeClr val="accent1"/>
+          </a:lnRef>
+          <a:fillRef idx="3">
+            <a:schemeClr val="accent1"/>
+          </a:fillRef>
+          <a:effectRef idx="2">
+            <a:schemeClr val="accent1"/>
+          </a:effectRef>
+          <a:fontRef idx="minor">
+            <a:schemeClr val="lt1"/>
+          </a:fontRef>
+        </p:style>
+        <p:txBody>
+          <a:bodyPr rtlCol="0" anchor="ctr" wrap="square" lIns="45720" rIns="45720" tIns="27432" bIns="27432"/>
+          <a:lstStyle/>
+          <a:p>
+            <a:pPr algn="ctr"/>
+            <a:r>
+              <a:rPr sz="950" b="0">
+                <a:solidFill>
+                  <a:srgbClr val="1A1A1A"/>
+                </a:solidFill>
+                <a:latin typeface="맑은 고딕"/>
+                <a:ea typeface="맑은 고딕"/>
+              </a:rPr>
+              <a:t>6승 25무 0패</a:t>
+            </a:r>
+          </a:p>
+        </p:txBody>
+      </p:sp>
+      <p:sp>
+        <p:nvSpPr>
+          <p:cNvPr id="92" name="Rectangle 91"/>
+          <p:cNvSpPr/>
+          <p:nvPr/>
+        </p:nvSpPr>
+        <p:spPr>
+          <a:xfrm>
+            <a:off x="9235440" y="3291839"/>
+            <a:ext cx="2560320" cy="365760"/>
+          </a:xfrm>
+          <a:prstGeom prst="rect">
+            <a:avLst/>
+          </a:prstGeom>
+          <a:solidFill>
+            <a:srgbClr val="FFFFFF"/>
+          </a:solidFill>
+          <a:ln w="9525">
+            <a:solidFill>
+              <a:srgbClr val="BFBFBF"/>
+            </a:solidFill>
+          </a:ln>
+          <a:effectLst/>
+        </p:spPr>
+        <p:style>
+          <a:lnRef idx="1">
+            <a:schemeClr val="accent1"/>
+          </a:lnRef>
+          <a:fillRef idx="3">
+            <a:schemeClr val="accent1"/>
+          </a:fillRef>
+          <a:effectRef idx="2">
+            <a:schemeClr val="accent1"/>
+          </a:effectRef>
+          <a:fontRef idx="minor">
+            <a:schemeClr val="lt1"/>
+          </a:fontRef>
+        </p:style>
+        <p:txBody>
+          <a:bodyPr rtlCol="0" anchor="ctr" wrap="square" lIns="45720" rIns="45720" tIns="27432" bIns="27432"/>
+          <a:lstStyle/>
+          <a:p>
+            <a:pPr algn="ctr"/>
+            <a:r>
+              <a:rPr sz="950" b="0">
+                <a:solidFill>
+                  <a:srgbClr val="1A1A1A"/>
+                </a:solidFill>
+                <a:latin typeface="맑은 고딕"/>
+                <a:ea typeface="맑은 고딕"/>
+              </a:rPr>
+              <a:t>10승 21무 0패</a:t>
+            </a:r>
+          </a:p>
+        </p:txBody>
+      </p:sp>
+      <p:sp>
+        <p:nvSpPr>
+          <p:cNvPr id="93" name="Rectangle 92"/>
+          <p:cNvSpPr/>
+          <p:nvPr/>
+        </p:nvSpPr>
+        <p:spPr>
+          <a:xfrm>
+            <a:off x="365760" y="3675887"/>
+            <a:ext cx="2560320" cy="365760"/>
+          </a:xfrm>
+          <a:prstGeom prst="rect">
+            <a:avLst/>
+          </a:prstGeom>
+          <a:solidFill>
+            <a:srgbClr val="DCE9F5"/>
+          </a:solidFill>
+          <a:ln w="9525">
+            <a:solidFill>
+              <a:srgbClr val="4D7EA8"/>
+            </a:solidFill>
+          </a:ln>
+          <a:effectLst/>
+        </p:spPr>
+        <p:style>
+          <a:lnRef idx="1">
+            <a:schemeClr val="accent1"/>
+          </a:lnRef>
+          <a:fillRef idx="3">
+            <a:schemeClr val="accent1"/>
+          </a:fillRef>
+          <a:effectRef idx="2">
+            <a:schemeClr val="accent1"/>
+          </a:effectRef>
+          <a:fontRef idx="minor">
+            <a:schemeClr val="lt1"/>
+          </a:fontRef>
+        </p:style>
+        <p:txBody>
+          <a:bodyPr rtlCol="0" anchor="ctr" wrap="square" lIns="45720" rIns="45720" tIns="27432" bIns="27432"/>
+          <a:lstStyle/>
+          <a:p>
+            <a:pPr algn="l"/>
+            <a:r>
+              <a:rPr sz="950" b="1">
+                <a:solidFill>
+                  <a:srgbClr val="1A1A1A"/>
+                </a:solidFill>
+                <a:latin typeface="맑은 고딕"/>
+                <a:ea typeface="맑은 고딕"/>
+              </a:rPr>
+              <a:t>별 합계 → 선택</a:t>
+            </a:r>
+          </a:p>
+        </p:txBody>
+      </p:sp>
+      <p:sp>
+        <p:nvSpPr>
+          <p:cNvPr id="94" name="Rectangle 93"/>
+          <p:cNvSpPr/>
+          <p:nvPr/>
+        </p:nvSpPr>
+        <p:spPr>
+          <a:xfrm>
+            <a:off x="2926080" y="3675887"/>
+            <a:ext cx="1371600" cy="365760"/>
+          </a:xfrm>
+          <a:prstGeom prst="rect">
+            <a:avLst/>
+          </a:prstGeom>
+          <a:solidFill>
+            <a:srgbClr val="FFFFFF"/>
+          </a:solidFill>
+          <a:ln w="9525">
+            <a:solidFill>
+              <a:srgbClr val="BFBFBF"/>
+            </a:solidFill>
+          </a:ln>
+          <a:effectLst/>
+        </p:spPr>
+        <p:style>
+          <a:lnRef idx="1">
+            <a:schemeClr val="accent1"/>
+          </a:lnRef>
+          <a:fillRef idx="3">
+            <a:schemeClr val="accent1"/>
+          </a:fillRef>
+          <a:effectRef idx="2">
+            <a:schemeClr val="accent1"/>
+          </a:effectRef>
+          <a:fontRef idx="minor">
+            <a:schemeClr val="lt1"/>
+          </a:fontRef>
+        </p:style>
+        <p:txBody>
+          <a:bodyPr rtlCol="0" anchor="ctr" wrap="square" lIns="45720" rIns="45720" tIns="27432" bIns="27432"/>
+          <a:lstStyle/>
+          <a:p>
+            <a:pPr algn="ctr"/>
+            <a:r>
+              <a:rPr sz="950" b="0">
+                <a:solidFill>
+                  <a:srgbClr val="1A1A1A"/>
+                </a:solidFill>
+                <a:latin typeface="맑은 고딕"/>
+                <a:ea typeface="맑은 고딕"/>
+              </a:rPr>
+              <a:t>—</a:t>
+            </a:r>
+          </a:p>
+        </p:txBody>
+      </p:sp>
+      <p:sp>
+        <p:nvSpPr>
+          <p:cNvPr id="95" name="Rectangle 94"/>
+          <p:cNvSpPr/>
+          <p:nvPr/>
+        </p:nvSpPr>
+        <p:spPr>
+          <a:xfrm>
+            <a:off x="4297680" y="3675887"/>
+            <a:ext cx="2468880" cy="365760"/>
+          </a:xfrm>
+          <a:prstGeom prst="rect">
+            <a:avLst/>
+          </a:prstGeom>
+          <a:solidFill>
+            <a:srgbClr val="E3F1E3"/>
+          </a:solidFill>
+          <a:ln w="9525">
+            <a:solidFill>
+              <a:srgbClr val="5B9B5B"/>
+            </a:solidFill>
+          </a:ln>
+          <a:effectLst/>
+        </p:spPr>
+        <p:style>
+          <a:lnRef idx="1">
+            <a:schemeClr val="accent1"/>
+          </a:lnRef>
+          <a:fillRef idx="3">
+            <a:schemeClr val="accent1"/>
+          </a:fillRef>
+          <a:effectRef idx="2">
+            <a:schemeClr val="accent1"/>
+          </a:effectRef>
+          <a:fontRef idx="minor">
+            <a:schemeClr val="lt1"/>
+          </a:fontRef>
+        </p:style>
+        <p:txBody>
+          <a:bodyPr rtlCol="0" anchor="ctr" wrap="square" lIns="45720" rIns="45720" tIns="27432" bIns="27432"/>
+          <a:lstStyle/>
+          <a:p>
+            <a:pPr algn="ctr"/>
+            <a:r>
+              <a:rPr sz="950" b="1">
+                <a:solidFill>
+                  <a:srgbClr val="1A1A1A"/>
+                </a:solidFill>
+                <a:latin typeface="맑은 고딕"/>
+                <a:ea typeface="맑은 고딕"/>
+              </a:rPr>
+              <a:t>9 → C2 (동점, 우선순위 QA1)</a:t>
+            </a:r>
+          </a:p>
+        </p:txBody>
+      </p:sp>
+      <p:sp>
+        <p:nvSpPr>
+          <p:cNvPr id="96" name="Rectangle 95"/>
+          <p:cNvSpPr/>
+          <p:nvPr/>
+        </p:nvSpPr>
+        <p:spPr>
+          <a:xfrm>
+            <a:off x="6766560" y="3675887"/>
+            <a:ext cx="2468880" cy="365760"/>
+          </a:xfrm>
+          <a:prstGeom prst="rect">
+            <a:avLst/>
+          </a:prstGeom>
+          <a:solidFill>
+            <a:srgbClr val="E3F1E3"/>
+          </a:solidFill>
+          <a:ln w="9525">
+            <a:solidFill>
+              <a:srgbClr val="5B9B5B"/>
+            </a:solidFill>
+          </a:ln>
+          <a:effectLst/>
+        </p:spPr>
+        <p:style>
+          <a:lnRef idx="1">
+            <a:schemeClr val="accent1"/>
+          </a:lnRef>
+          <a:fillRef idx="3">
+            <a:schemeClr val="accent1"/>
+          </a:fillRef>
+          <a:effectRef idx="2">
+            <a:schemeClr val="accent1"/>
+          </a:effectRef>
+          <a:fontRef idx="minor">
+            <a:schemeClr val="lt1"/>
+          </a:fontRef>
+        </p:style>
+        <p:txBody>
+          <a:bodyPr rtlCol="0" anchor="ctr" wrap="square" lIns="45720" rIns="45720" tIns="27432" bIns="27432"/>
+          <a:lstStyle/>
+          <a:p>
+            <a:pPr algn="ctr"/>
+            <a:r>
+              <a:rPr sz="950" b="1">
+                <a:solidFill>
+                  <a:srgbClr val="1A1A1A"/>
+                </a:solidFill>
+                <a:latin typeface="맑은 고딕"/>
+                <a:ea typeface="맑은 고딕"/>
+              </a:rPr>
+              <a:t>10 → C1 (합계)</a:t>
+            </a:r>
+          </a:p>
+        </p:txBody>
+      </p:sp>
+      <p:sp>
+        <p:nvSpPr>
+          <p:cNvPr id="97" name="Rectangle 96"/>
+          <p:cNvSpPr/>
+          <p:nvPr/>
+        </p:nvSpPr>
+        <p:spPr>
+          <a:xfrm>
+            <a:off x="9235440" y="3675887"/>
+            <a:ext cx="2560320" cy="365760"/>
+          </a:xfrm>
+          <a:prstGeom prst="rect">
+            <a:avLst/>
+          </a:prstGeom>
+          <a:solidFill>
+            <a:srgbClr val="FFFFFF"/>
+          </a:solidFill>
+          <a:ln w="9525">
+            <a:solidFill>
+              <a:srgbClr val="BFBFBF"/>
+            </a:solidFill>
+          </a:ln>
+          <a:effectLst/>
+        </p:spPr>
+        <p:style>
+          <a:lnRef idx="1">
+            <a:schemeClr val="accent1"/>
+          </a:lnRef>
+          <a:fillRef idx="3">
+            <a:schemeClr val="accent1"/>
+          </a:fillRef>
+          <a:effectRef idx="2">
+            <a:schemeClr val="accent1"/>
+          </a:effectRef>
+          <a:fontRef idx="minor">
+            <a:schemeClr val="lt1"/>
+          </a:fontRef>
+        </p:style>
+        <p:txBody>
+          <a:bodyPr rtlCol="0" anchor="ctr" wrap="square" lIns="45720" rIns="45720" tIns="27432" bIns="27432"/>
+          <a:lstStyle/>
+          <a:p>
+            <a:pPr algn="ctr"/>
+            <a:r>
+              <a:rPr sz="950" b="1">
+                <a:solidFill>
+                  <a:srgbClr val="1A1A1A"/>
+                </a:solidFill>
+                <a:latin typeface="맑은 고딕"/>
+                <a:ea typeface="맑은 고딕"/>
+              </a:rPr>
+              <a:t>9</a:t>
+            </a:r>
+          </a:p>
+        </p:txBody>
+      </p:sp>
+      <p:sp>
+        <p:nvSpPr>
+          <p:cNvPr id="98" name="Rectangle 97"/>
+          <p:cNvSpPr/>
+          <p:nvPr/>
+        </p:nvSpPr>
+        <p:spPr>
+          <a:xfrm>
+            <a:off x="365760" y="4151375"/>
+            <a:ext cx="5669280" cy="2240280"/>
+          </a:xfrm>
+          <a:prstGeom prst="rect">
+            <a:avLst/>
+          </a:prstGeom>
+          <a:solidFill>
+            <a:srgbClr val="E3F1E3"/>
+          </a:solidFill>
+          <a:ln w="9525">
+            <a:solidFill>
+              <a:srgbClr val="5B9B5B"/>
+            </a:solidFill>
+          </a:ln>
+          <a:effectLst/>
+        </p:spPr>
+        <p:style>
+          <a:lnRef idx="1">
+            <a:schemeClr val="accent1"/>
+          </a:lnRef>
+          <a:fillRef idx="3">
+            <a:schemeClr val="accent1"/>
+          </a:fillRef>
+          <a:effectRef idx="2">
+            <a:schemeClr val="accent1"/>
+          </a:effectRef>
+          <a:fontRef idx="minor">
+            <a:schemeClr val="lt1"/>
+          </a:fontRef>
+        </p:style>
+        <p:txBody>
+          <a:bodyPr rtlCol="0" anchor="t" wrap="square" lIns="45720" rIns="45720" tIns="27432" bIns="27432"/>
+          <a:lstStyle/>
+          <a:p>
+            <a:pPr algn="l"/>
+            <a:r>
+              <a:rPr sz="950" b="1">
+                <a:solidFill>
+                  <a:srgbClr val="1A1A1A"/>
+                </a:solidFill>
+                <a:latin typeface="맑은 고딕"/>
+                <a:ea typeface="맑은 고딕"/>
+              </a:rPr>
+              <a:t>보완 설계 스토리: affinity 추가</a:t>
+            </a:r>
+          </a:p>
+          <a:p>
+            <a:pPr algn="l"/>
+            <a:r>
+              <a:rPr sz="950" b="0">
+                <a:solidFill>
+                  <a:srgbClr val="1A1A1A"/>
+                </a:solidFill>
+                <a:latin typeface="맑은 고딕"/>
+                <a:ea typeface="맑은 고딕"/>
+              </a:rPr>
+              <a:t>- affinity가 없는 C1은 자원 압박에만 반응한다. 처리량 x1.05, TTFT P99 x1.27(악화)로 C2(x1.42)에 </a:t>
+            </a:r>
+          </a:p>
+          <a:p>
+            <a:pPr algn="l"/>
+            <a:r>
+              <a:rPr sz="950" b="0">
+                <a:solidFill>
+                  <a:srgbClr val="1A1A1A"/>
+                </a:solidFill>
+                <a:latin typeface="맑은 고딕"/>
+                <a:ea typeface="맑은 고딕"/>
+              </a:rPr>
+              <a:t>크게 못 미치고, 별 합계가 동점이라 우선순위로 C2가 선택된다.</a:t>
+            </a:r>
+          </a:p>
+          <a:p>
+            <a:pPr algn="l"/>
+            <a:r>
+              <a:rPr sz="950" b="0">
+                <a:solidFill>
+                  <a:srgbClr val="1A1A1A"/>
+                </a:solidFill>
+                <a:latin typeface="맑은 고딕"/>
+                <a:ea typeface="맑은 고딕"/>
+              </a:rPr>
+              <a:t>- 정적 Data-Memory Affinity를 추가하면(힌트와 접근 비용 추정으로 'HBM에 있어야 SLO를 만족하는</a:t>
+            </a:r>
+          </a:p>
+          <a:p>
+            <a:pPr algn="l"/>
+            <a:r>
+              <a:rPr sz="950" b="0">
+                <a:solidFill>
+                  <a:srgbClr val="1A1A1A"/>
+                </a:solidFill>
+                <a:latin typeface="맑은 고딕"/>
+                <a:ea typeface="맑은 고딕"/>
+              </a:rPr>
+              <a:t>' 객체를 승격, 필요하면 교환) 처리량 x1.30, QA2 ★★★이 되어 합계 10 대 9로 C1이 선택된다.</a:t>
+            </a:r>
+          </a:p>
+          <a:p>
+            <a:pPr algn="l"/>
+            <a:r>
+              <a:rPr sz="950" b="0">
+                <a:solidFill>
+                  <a:srgbClr val="1A1A1A"/>
+                </a:solidFill>
+                <a:latin typeface="맑은 고딕"/>
+                <a:ea typeface="맑은 고딕"/>
+              </a:rPr>
+              <a:t>- 효과의 출처는 정적 승격 pass다: 점수만 제거 x1.299(변화 없음), 승격 제거 x1.053.</a:t>
+            </a:r>
+          </a:p>
+          <a:p>
+            <a:pPr algn="l"/>
+            <a:r>
+              <a:rPr sz="950" b="0">
+                <a:solidFill>
+                  <a:srgbClr val="1A1A1A"/>
+                </a:solidFill>
+                <a:latin typeface="맑은 고딕"/>
+                <a:ea typeface="맑은 고딕"/>
+              </a:rPr>
+              <a:t>- 승격은 두 후보가 공유하는 접근 비용 추정기(operation class·shape 힌트)에 의존한다.</a:t>
+            </a:r>
+          </a:p>
+        </p:txBody>
+      </p:sp>
+      <p:sp>
+        <p:nvSpPr>
+          <p:cNvPr id="99" name="Rectangle 98"/>
+          <p:cNvSpPr/>
+          <p:nvPr/>
+        </p:nvSpPr>
+        <p:spPr>
+          <a:xfrm>
+            <a:off x="6217920" y="4151375"/>
+            <a:ext cx="5577840" cy="2240280"/>
+          </a:xfrm>
+          <a:prstGeom prst="rect">
+            <a:avLst/>
+          </a:prstGeom>
+          <a:solidFill>
+            <a:srgbClr val="F2F2F2"/>
+          </a:solidFill>
+          <a:ln w="9525">
+            <a:solidFill>
+              <a:srgbClr val="BFBFBF"/>
+            </a:solidFill>
+          </a:ln>
+          <a:effectLst/>
+        </p:spPr>
+        <p:style>
+          <a:lnRef idx="1">
+            <a:schemeClr val="accent1"/>
+          </a:lnRef>
+          <a:fillRef idx="3">
+            <a:schemeClr val="accent1"/>
+          </a:fillRef>
+          <a:effectRef idx="2">
+            <a:schemeClr val="accent1"/>
+          </a:effectRef>
+          <a:fontRef idx="minor">
+            <a:schemeClr val="lt1"/>
+          </a:fontRef>
+        </p:style>
+        <p:txBody>
+          <a:bodyPr rtlCol="0" anchor="t" wrap="square" lIns="45720" rIns="45720" tIns="27432" bIns="27432"/>
+          <a:lstStyle/>
+          <a:p>
+            <a:pPr algn="l"/>
+            <a:r>
+              <a:rPr sz="950" b="1">
+                <a:solidFill>
+                  <a:srgbClr val="404040"/>
+                </a:solidFill>
+                <a:latin typeface="맑은 고딕"/>
+                <a:ea typeface="맑은 고딕"/>
+              </a:rPr>
+              <a:t>한계 (솔직하게)</a:t>
+            </a:r>
+          </a:p>
+          <a:p>
+            <a:pPr algn="l"/>
+            <a:r>
+              <a:rPr sz="950" b="0">
+                <a:solidFill>
+                  <a:srgbClr val="404040"/>
+                </a:solidFill>
+                <a:latin typeface="맑은 고딕"/>
+                <a:ea typeface="맑은 고딕"/>
+              </a:rPr>
+              <a:t>- affinity를 넣어도 C1 처리량(x1.30)은 C2(x1.42)보다 낮다. 격차를 약 66% 줄였지만 C2를 이기지</a:t>
+            </a:r>
+          </a:p>
+          <a:p>
+            <a:pPr algn="l"/>
+            <a:r>
+              <a:rPr sz="950" b="0">
+                <a:solidFill>
+                  <a:srgbClr val="404040"/>
+                </a:solidFill>
+                <a:latin typeface="맑은 고딕"/>
+                <a:ea typeface="맑은 고딕"/>
+              </a:rPr>
+              <a:t>는 못한다.</a:t>
+            </a:r>
+          </a:p>
+          <a:p>
+            <a:pPr algn="l"/>
+            <a:r>
+              <a:rPr sz="950" b="0">
+                <a:solidFill>
+                  <a:srgbClr val="404040"/>
+                </a:solidFill>
+                <a:latin typeface="맑은 고딕"/>
+                <a:ea typeface="맑은 고딕"/>
+              </a:rPr>
+              <a:t>- 선택이 C1로 바뀐 것은 QA3(HBM x0.97 대 C2 x1.21)·QA4 우위와 QA2 별 경계(x1.28 vs 1.25)에</a:t>
+            </a:r>
+          </a:p>
+          <a:p>
+            <a:pPr algn="l"/>
+            <a:r>
+              <a:rPr sz="950" b="0">
+                <a:solidFill>
+                  <a:srgbClr val="404040"/>
+                </a:solidFill>
+                <a:latin typeface="맑은 고딕"/>
+                <a:ea typeface="맑은 고딕"/>
+              </a:rPr>
+              <a:t>서 온다. 합계 차이 1점이라 경계에 민감하다.</a:t>
+            </a:r>
+          </a:p>
+          <a:p>
+            <a:pPr algn="l"/>
+            <a:r>
+              <a:rPr sz="950" b="0">
+                <a:solidFill>
+                  <a:srgbClr val="404040"/>
+                </a:solidFill>
+                <a:latin typeface="맑은 고딕"/>
+                <a:ea typeface="맑은 고딕"/>
+              </a:rPr>
+              <a:t>- affinity 제거 변형에서도 QA4 별은 C1 ★★★로 같게 두었다(affinity 모듈은 C1 설계에 원래 포함)</a:t>
+            </a:r>
+          </a:p>
+          <a:p>
+            <a:pPr algn="l"/>
+            <a:r>
+              <a:rPr sz="950" b="0">
+                <a:solidFill>
+                  <a:srgbClr val="404040"/>
+                </a:solidFill>
+                <a:latin typeface="맑은 고딕"/>
+                <a:ea typeface="맑은 고딕"/>
+              </a:rPr>
+              <a:t>.</a:t>
+            </a:r>
+          </a:p>
+          <a:p>
+            <a:pPr algn="l"/>
+            <a:r>
+              <a:rPr sz="950" b="0">
+                <a:solidFill>
+                  <a:srgbClr val="404040"/>
+                </a:solidFill>
+                <a:latin typeface="맑은 고딕"/>
+                <a:ea typeface="맑은 고딕"/>
+              </a:rPr>
+              <a:t>- 대조군(affinity 포함 재실행)은 본 결과와 정확히 일치. 5 seed, 동일 시나리오. 4.7절 참고.</a:t>
+            </a:r>
+          </a:p>
+        </p:txBody>
+      </p:sp>
+    </p:spTree>
+  </p:cSld>
+  <p:clrMapOvr>
+    <a:masterClrMapping/>
+  </p:clrMapOvr>
+</p:sld>
+</file>
+
+<file path=ppt/slides/slide23.xml><?xml version="1.0" encoding="utf-8"?>
 <p:sld xmlns:a="http://schemas.openxmlformats.org/drawingml/2006/main" xmlns:p="http://schemas.openxmlformats.org/presentationml/2006/main" xmlns:r="http://schemas.openxmlformats.org/officeDocument/2006/relationships">
   <p:cSld>
     <p:spTree>

</xml_diff>

<commit_message>
DP1: loop iteration 4 results (TTFT P99 tail, burst cap sweep), star-edge basis (qa-criteria §J), result doc 4.8/4.9, PPT slides
Co-Authored-By: Claude Sonnet 5.5 <noreply@anthropic.com>
Claude-Session: https://claude.ai/code/session_018inK4pZJGzYwjdk7QAyZgn
</commit_message>
<xml_diff>
--- a/doc-mk/DP1/DP1-appendix-qa-result.pptx
+++ b/doc-mk/DP1/DP1-appendix-qa-result.pptx
@@ -14,6 +14,8 @@
     <p:sldId id="653" r:id="rId27"/>
     <p:sldId id="654" r:id="rId28"/>
     <p:sldId id="655" r:id="rId29"/>
+    <p:sldId id="656" r:id="rId30"/>
+    <p:sldId id="657" r:id="rId31"/>
   </p:sldIdLst>
   <p:sldSz cx="12192000" cy="6858000"/>
   <p:notesSz cx="6858000" cy="9144000"/>
@@ -14575,6 +14577,2790 @@
                   <a:schemeClr val="bg1"/>
                 </a:solidFill>
               </a:rPr>
+              <a:t>TTFT P99 꼬리 악화 (Baseline-regression loop 4) - 이득과 같은 메커니즘</a:t>
+            </a:r>
+            <a:r>
+              <a:rPr lang="en-US" altLang="ko-KR" sz="1400" b="1" dirty="0">
+                <a:solidFill>
+                  <a:schemeClr val="bg1"/>
+                </a:solidFill>
+              </a:rPr>
+              <a:t/>
+            </a:r>
+            <a:r>
+              <a:rPr lang="ko-KR" altLang="en-US" sz="1400" b="1" dirty="0">
+                <a:solidFill>
+                  <a:schemeClr val="bg1"/>
+                </a:solidFill>
+              </a:rPr>
+              <a:t/>
+            </a:r>
+            <a:r>
+              <a:rPr lang="en-US" altLang="ko-KR" sz="1400" b="1" dirty="0">
+                <a:solidFill>
+                  <a:schemeClr val="bg1"/>
+                </a:solidFill>
+              </a:rPr>
+              <a:t/>
+            </a:r>
+            <a:r>
+              <a:rPr lang="ko-KR" altLang="en-US" sz="1400" b="1" dirty="0">
+                <a:solidFill>
+                  <a:schemeClr val="bg1"/>
+                </a:solidFill>
+              </a:rPr>
+              <a:t/>
+            </a:r>
+          </a:p>
+        </p:txBody>
+      </p:sp>
+      <p:sp>
+        <p:nvSpPr>
+          <p:cNvPr id="39" name="직사각형 38"/>
+          <p:cNvSpPr/>
+          <p:nvPr/>
+        </p:nvSpPr>
+        <p:spPr>
+          <a:xfrm>
+            <a:off x="403086" y="678726"/>
+            <a:ext cx="66675" cy="216270"/>
+          </a:xfrm>
+          <a:prstGeom prst="rect">
+            <a:avLst/>
+          </a:prstGeom>
+          <a:solidFill>
+            <a:schemeClr val="bg1"/>
+          </a:solidFill>
+          <a:ln w="19050">
+            <a:noFill/>
+          </a:ln>
+        </p:spPr>
+        <p:style>
+          <a:lnRef idx="2">
+            <a:schemeClr val="accent1">
+              <a:shade val="50000"/>
+            </a:schemeClr>
+          </a:lnRef>
+          <a:fillRef idx="1">
+            <a:schemeClr val="accent1"/>
+          </a:fillRef>
+          <a:effectRef idx="0">
+            <a:schemeClr val="accent1"/>
+          </a:effectRef>
+          <a:fontRef idx="minor">
+            <a:schemeClr val="lt1"/>
+          </a:fontRef>
+        </p:style>
+        <p:txBody>
+          <a:bodyPr rtlCol="0" anchor="ctr"/>
+          <a:lstStyle/>
+          <a:p>
+            <a:pPr algn="ctr"/>
+            <a:endParaRPr lang="ko-KR" altLang="en-US" sz="1600"/>
+          </a:p>
+        </p:txBody>
+      </p:sp>
+      <p:sp>
+        <p:nvSpPr>
+          <p:cNvPr id="57" name="슬라이드 번호 개체 틀 1"/>
+          <p:cNvSpPr>
+            <a:spLocks noGrp="1"/>
+          </p:cNvSpPr>
+          <p:nvPr>
+            <p:ph type="sldNum" sz="quarter" idx="4"/>
+          </p:nvPr>
+        </p:nvSpPr>
+        <p:spPr>
+          <a:xfrm>
+            <a:off x="5620080" y="6597650"/>
+            <a:ext cx="456466" cy="209550"/>
+          </a:xfrm>
+        </p:spPr>
+        <p:txBody>
+          <a:bodyPr/>
+          <a:lstStyle/>
+          <a:p>
+            <a:fld id="{7F889C64-266A-4D07-AD8F-5B592E61CCE1}" type="slidenum">
+              <a:rPr lang="ko-KR" altLang="en-US" smtClean="0"/>
+              <a:pPr/>
+              <a:t>9</a:t>
+            </a:fld>
+            <a:endParaRPr lang="ko-KR" altLang="en-US" dirty="0"/>
+          </a:p>
+        </p:txBody>
+      </p:sp>
+      <p:sp>
+        <p:nvSpPr>
+          <p:cNvPr id="58" name="Rectangle 57"/>
+          <p:cNvSpPr/>
+          <p:nvPr/>
+        </p:nvSpPr>
+        <p:spPr>
+          <a:xfrm>
+            <a:off x="365760" y="1051560"/>
+            <a:ext cx="1737360" cy="292608"/>
+          </a:xfrm>
+          <a:prstGeom prst="rect">
+            <a:avLst/>
+          </a:prstGeom>
+          <a:solidFill>
+            <a:srgbClr val="1F4E79"/>
+          </a:solidFill>
+          <a:ln w="9525">
+            <a:solidFill>
+              <a:srgbClr val="1F4E79"/>
+            </a:solidFill>
+          </a:ln>
+          <a:effectLst/>
+        </p:spPr>
+        <p:style>
+          <a:lnRef idx="1">
+            <a:schemeClr val="accent1"/>
+          </a:lnRef>
+          <a:fillRef idx="3">
+            <a:schemeClr val="accent1"/>
+          </a:fillRef>
+          <a:effectRef idx="2">
+            <a:schemeClr val="accent1"/>
+          </a:effectRef>
+          <a:fontRef idx="minor">
+            <a:schemeClr val="lt1"/>
+          </a:fontRef>
+        </p:style>
+        <p:txBody>
+          <a:bodyPr rtlCol="0" anchor="ctr" wrap="square" lIns="45720" rIns="45720" tIns="27432" bIns="27432"/>
+          <a:lstStyle/>
+          <a:p>
+            <a:pPr algn="ctr"/>
+            <a:r>
+              <a:rPr sz="1000" b="1">
+                <a:solidFill>
+                  <a:srgbClr val="FFFFFF"/>
+                </a:solidFill>
+                <a:latin typeface="맑은 고딕"/>
+                <a:ea typeface="맑은 고딕"/>
+              </a:rPr>
+              <a:t>burst 용량 (s)</a:t>
+            </a:r>
+          </a:p>
+        </p:txBody>
+      </p:sp>
+      <p:sp>
+        <p:nvSpPr>
+          <p:cNvPr id="59" name="Rectangle 58"/>
+          <p:cNvSpPr/>
+          <p:nvPr/>
+        </p:nvSpPr>
+        <p:spPr>
+          <a:xfrm>
+            <a:off x="2103120" y="1051560"/>
+            <a:ext cx="4572000" cy="292608"/>
+          </a:xfrm>
+          <a:prstGeom prst="rect">
+            <a:avLst/>
+          </a:prstGeom>
+          <a:solidFill>
+            <a:srgbClr val="1F4E79"/>
+          </a:solidFill>
+          <a:ln w="9525">
+            <a:solidFill>
+              <a:srgbClr val="1F4E79"/>
+            </a:solidFill>
+          </a:ln>
+          <a:effectLst/>
+        </p:spPr>
+        <p:style>
+          <a:lnRef idx="1">
+            <a:schemeClr val="accent1"/>
+          </a:lnRef>
+          <a:fillRef idx="3">
+            <a:schemeClr val="accent1"/>
+          </a:fillRef>
+          <a:effectRef idx="2">
+            <a:schemeClr val="accent1"/>
+          </a:effectRef>
+          <a:fontRef idx="minor">
+            <a:schemeClr val="lt1"/>
+          </a:fontRef>
+        </p:style>
+        <p:txBody>
+          <a:bodyPr rtlCol="0" anchor="ctr" wrap="square" lIns="45720" rIns="45720" tIns="27432" bIns="27432"/>
+          <a:lstStyle/>
+          <a:p>
+            <a:pPr algn="ctr"/>
+            <a:r>
+              <a:rPr sz="1000" b="1">
+                <a:solidFill>
+                  <a:srgbClr val="FFFFFF"/>
+                </a:solidFill>
+                <a:latin typeface="맑은 고딕"/>
+                <a:ea typeface="맑은 고딕"/>
+              </a:rPr>
+              <a:t>C1: QA1 (x) / TTFT P99 악화 쌍 / 최악 쌍</a:t>
+            </a:r>
+          </a:p>
+        </p:txBody>
+      </p:sp>
+      <p:sp>
+        <p:nvSpPr>
+          <p:cNvPr id="60" name="Rectangle 59"/>
+          <p:cNvSpPr/>
+          <p:nvPr/>
+        </p:nvSpPr>
+        <p:spPr>
+          <a:xfrm>
+            <a:off x="6675120" y="1051560"/>
+            <a:ext cx="5120640" cy="292608"/>
+          </a:xfrm>
+          <a:prstGeom prst="rect">
+            <a:avLst/>
+          </a:prstGeom>
+          <a:solidFill>
+            <a:srgbClr val="1F4E79"/>
+          </a:solidFill>
+          <a:ln w="9525">
+            <a:solidFill>
+              <a:srgbClr val="1F4E79"/>
+            </a:solidFill>
+          </a:ln>
+          <a:effectLst/>
+        </p:spPr>
+        <p:style>
+          <a:lnRef idx="1">
+            <a:schemeClr val="accent1"/>
+          </a:lnRef>
+          <a:fillRef idx="3">
+            <a:schemeClr val="accent1"/>
+          </a:fillRef>
+          <a:effectRef idx="2">
+            <a:schemeClr val="accent1"/>
+          </a:effectRef>
+          <a:fontRef idx="minor">
+            <a:schemeClr val="lt1"/>
+          </a:fontRef>
+        </p:style>
+        <p:txBody>
+          <a:bodyPr rtlCol="0" anchor="ctr" wrap="square" lIns="45720" rIns="45720" tIns="27432" bIns="27432"/>
+          <a:lstStyle/>
+          <a:p>
+            <a:pPr algn="ctr"/>
+            <a:r>
+              <a:rPr sz="1000" b="1">
+                <a:solidFill>
+                  <a:srgbClr val="FFFFFF"/>
+                </a:solidFill>
+                <a:latin typeface="맑은 고딕"/>
+                <a:ea typeface="맑은 고딕"/>
+              </a:rPr>
+              <a:t>C2: QA1 (x) / TTFT P99 악화 쌍 / 최악 쌍</a:t>
+            </a:r>
+          </a:p>
+        </p:txBody>
+      </p:sp>
+      <p:sp>
+        <p:nvSpPr>
+          <p:cNvPr id="61" name="Rectangle 60"/>
+          <p:cNvSpPr/>
+          <p:nvPr/>
+        </p:nvSpPr>
+        <p:spPr>
+          <a:xfrm>
+            <a:off x="365760" y="1371600"/>
+            <a:ext cx="1737360" cy="365760"/>
+          </a:xfrm>
+          <a:prstGeom prst="rect">
+            <a:avLst/>
+          </a:prstGeom>
+          <a:solidFill>
+            <a:srgbClr val="DCE9F5"/>
+          </a:solidFill>
+          <a:ln w="9525">
+            <a:solidFill>
+              <a:srgbClr val="4D7EA8"/>
+            </a:solidFill>
+          </a:ln>
+          <a:effectLst/>
+        </p:spPr>
+        <p:style>
+          <a:lnRef idx="1">
+            <a:schemeClr val="accent1"/>
+          </a:lnRef>
+          <a:fillRef idx="3">
+            <a:schemeClr val="accent1"/>
+          </a:fillRef>
+          <a:effectRef idx="2">
+            <a:schemeClr val="accent1"/>
+          </a:effectRef>
+          <a:fontRef idx="minor">
+            <a:schemeClr val="lt1"/>
+          </a:fontRef>
+        </p:style>
+        <p:txBody>
+          <a:bodyPr rtlCol="0" anchor="ctr" wrap="square" lIns="45720" rIns="45720" tIns="27432" bIns="27432"/>
+          <a:lstStyle/>
+          <a:p>
+            <a:pPr algn="ctr"/>
+            <a:r>
+              <a:rPr sz="950" b="1">
+                <a:solidFill>
+                  <a:srgbClr val="1A1A1A"/>
+                </a:solidFill>
+                <a:latin typeface="맑은 고딕"/>
+                <a:ea typeface="맑은 고딕"/>
+              </a:rPr>
+              <a:t>2.0 (현재)</a:t>
+            </a:r>
+          </a:p>
+        </p:txBody>
+      </p:sp>
+      <p:sp>
+        <p:nvSpPr>
+          <p:cNvPr id="62" name="Rectangle 61"/>
+          <p:cNvSpPr/>
+          <p:nvPr/>
+        </p:nvSpPr>
+        <p:spPr>
+          <a:xfrm>
+            <a:off x="2103120" y="1371600"/>
+            <a:ext cx="4572000" cy="365760"/>
+          </a:xfrm>
+          <a:prstGeom prst="rect">
+            <a:avLst/>
+          </a:prstGeom>
+          <a:solidFill>
+            <a:srgbClr val="FFFFFF"/>
+          </a:solidFill>
+          <a:ln w="9525">
+            <a:solidFill>
+              <a:srgbClr val="BFBFBF"/>
+            </a:solidFill>
+          </a:ln>
+          <a:effectLst/>
+        </p:spPr>
+        <p:style>
+          <a:lnRef idx="1">
+            <a:schemeClr val="accent1"/>
+          </a:lnRef>
+          <a:fillRef idx="3">
+            <a:schemeClr val="accent1"/>
+          </a:fillRef>
+          <a:effectRef idx="2">
+            <a:schemeClr val="accent1"/>
+          </a:effectRef>
+          <a:fontRef idx="minor">
+            <a:schemeClr val="lt1"/>
+          </a:fontRef>
+        </p:style>
+        <p:txBody>
+          <a:bodyPr rtlCol="0" anchor="ctr" wrap="square" lIns="45720" rIns="45720" tIns="27432" bIns="27432"/>
+          <a:lstStyle/>
+          <a:p>
+            <a:pPr algn="ctr"/>
+            <a:r>
+              <a:rPr sz="950" b="0">
+                <a:solidFill>
+                  <a:srgbClr val="1A1A1A"/>
+                </a:solidFill>
+                <a:latin typeface="맑은 고딕"/>
+                <a:ea typeface="맑은 고딕"/>
+              </a:rPr>
+              <a:t>x1.30 / 6쌍 / x4.32</a:t>
+            </a:r>
+          </a:p>
+        </p:txBody>
+      </p:sp>
+      <p:sp>
+        <p:nvSpPr>
+          <p:cNvPr id="63" name="Rectangle 62"/>
+          <p:cNvSpPr/>
+          <p:nvPr/>
+        </p:nvSpPr>
+        <p:spPr>
+          <a:xfrm>
+            <a:off x="6675120" y="1371600"/>
+            <a:ext cx="5120640" cy="365760"/>
+          </a:xfrm>
+          <a:prstGeom prst="rect">
+            <a:avLst/>
+          </a:prstGeom>
+          <a:solidFill>
+            <a:srgbClr val="FFFFFF"/>
+          </a:solidFill>
+          <a:ln w="9525">
+            <a:solidFill>
+              <a:srgbClr val="BFBFBF"/>
+            </a:solidFill>
+          </a:ln>
+          <a:effectLst/>
+        </p:spPr>
+        <p:style>
+          <a:lnRef idx="1">
+            <a:schemeClr val="accent1"/>
+          </a:lnRef>
+          <a:fillRef idx="3">
+            <a:schemeClr val="accent1"/>
+          </a:fillRef>
+          <a:effectRef idx="2">
+            <a:schemeClr val="accent1"/>
+          </a:effectRef>
+          <a:fontRef idx="minor">
+            <a:schemeClr val="lt1"/>
+          </a:fontRef>
+        </p:style>
+        <p:txBody>
+          <a:bodyPr rtlCol="0" anchor="ctr" wrap="square" lIns="45720" rIns="45720" tIns="27432" bIns="27432"/>
+          <a:lstStyle/>
+          <a:p>
+            <a:pPr algn="ctr"/>
+            <a:r>
+              <a:rPr sz="950" b="0">
+                <a:solidFill>
+                  <a:srgbClr val="1A1A1A"/>
+                </a:solidFill>
+                <a:latin typeface="맑은 고딕"/>
+                <a:ea typeface="맑은 고딕"/>
+              </a:rPr>
+              <a:t>x1.42 / 5쌍 / x1.30</a:t>
+            </a:r>
+          </a:p>
+        </p:txBody>
+      </p:sp>
+      <p:sp>
+        <p:nvSpPr>
+          <p:cNvPr id="64" name="Rectangle 63"/>
+          <p:cNvSpPr/>
+          <p:nvPr/>
+        </p:nvSpPr>
+        <p:spPr>
+          <a:xfrm>
+            <a:off x="365760" y="1755648"/>
+            <a:ext cx="1737360" cy="365760"/>
+          </a:xfrm>
+          <a:prstGeom prst="rect">
+            <a:avLst/>
+          </a:prstGeom>
+          <a:solidFill>
+            <a:srgbClr val="DCE9F5"/>
+          </a:solidFill>
+          <a:ln w="9525">
+            <a:solidFill>
+              <a:srgbClr val="4D7EA8"/>
+            </a:solidFill>
+          </a:ln>
+          <a:effectLst/>
+        </p:spPr>
+        <p:style>
+          <a:lnRef idx="1">
+            <a:schemeClr val="accent1"/>
+          </a:lnRef>
+          <a:fillRef idx="3">
+            <a:schemeClr val="accent1"/>
+          </a:fillRef>
+          <a:effectRef idx="2">
+            <a:schemeClr val="accent1"/>
+          </a:effectRef>
+          <a:fontRef idx="minor">
+            <a:schemeClr val="lt1"/>
+          </a:fontRef>
+        </p:style>
+        <p:txBody>
+          <a:bodyPr rtlCol="0" anchor="ctr" wrap="square" lIns="45720" rIns="45720" tIns="27432" bIns="27432"/>
+          <a:lstStyle/>
+          <a:p>
+            <a:pPr algn="ctr"/>
+            <a:r>
+              <a:rPr sz="950" b="1">
+                <a:solidFill>
+                  <a:srgbClr val="1A1A1A"/>
+                </a:solidFill>
+                <a:latin typeface="맑은 고딕"/>
+                <a:ea typeface="맑은 고딕"/>
+              </a:rPr>
+              <a:t>1.0</a:t>
+            </a:r>
+          </a:p>
+        </p:txBody>
+      </p:sp>
+      <p:sp>
+        <p:nvSpPr>
+          <p:cNvPr id="65" name="Rectangle 64"/>
+          <p:cNvSpPr/>
+          <p:nvPr/>
+        </p:nvSpPr>
+        <p:spPr>
+          <a:xfrm>
+            <a:off x="2103120" y="1755648"/>
+            <a:ext cx="4572000" cy="365760"/>
+          </a:xfrm>
+          <a:prstGeom prst="rect">
+            <a:avLst/>
+          </a:prstGeom>
+          <a:solidFill>
+            <a:srgbClr val="FFFFFF"/>
+          </a:solidFill>
+          <a:ln w="9525">
+            <a:solidFill>
+              <a:srgbClr val="BFBFBF"/>
+            </a:solidFill>
+          </a:ln>
+          <a:effectLst/>
+        </p:spPr>
+        <p:style>
+          <a:lnRef idx="1">
+            <a:schemeClr val="accent1"/>
+          </a:lnRef>
+          <a:fillRef idx="3">
+            <a:schemeClr val="accent1"/>
+          </a:fillRef>
+          <a:effectRef idx="2">
+            <a:schemeClr val="accent1"/>
+          </a:effectRef>
+          <a:fontRef idx="minor">
+            <a:schemeClr val="lt1"/>
+          </a:fontRef>
+        </p:style>
+        <p:txBody>
+          <a:bodyPr rtlCol="0" anchor="ctr" wrap="square" lIns="45720" rIns="45720" tIns="27432" bIns="27432"/>
+          <a:lstStyle/>
+          <a:p>
+            <a:pPr algn="ctr"/>
+            <a:r>
+              <a:rPr sz="950" b="0">
+                <a:solidFill>
+                  <a:srgbClr val="1A1A1A"/>
+                </a:solidFill>
+                <a:latin typeface="맑은 고딕"/>
+                <a:ea typeface="맑은 고딕"/>
+              </a:rPr>
+              <a:t>x1.21 / 6쌍 / x2.61</a:t>
+            </a:r>
+          </a:p>
+        </p:txBody>
+      </p:sp>
+      <p:sp>
+        <p:nvSpPr>
+          <p:cNvPr id="66" name="Rectangle 65"/>
+          <p:cNvSpPr/>
+          <p:nvPr/>
+        </p:nvSpPr>
+        <p:spPr>
+          <a:xfrm>
+            <a:off x="6675120" y="1755648"/>
+            <a:ext cx="5120640" cy="365760"/>
+          </a:xfrm>
+          <a:prstGeom prst="rect">
+            <a:avLst/>
+          </a:prstGeom>
+          <a:solidFill>
+            <a:srgbClr val="FFFFFF"/>
+          </a:solidFill>
+          <a:ln w="9525">
+            <a:solidFill>
+              <a:srgbClr val="BFBFBF"/>
+            </a:solidFill>
+          </a:ln>
+          <a:effectLst/>
+        </p:spPr>
+        <p:style>
+          <a:lnRef idx="1">
+            <a:schemeClr val="accent1"/>
+          </a:lnRef>
+          <a:fillRef idx="3">
+            <a:schemeClr val="accent1"/>
+          </a:fillRef>
+          <a:effectRef idx="2">
+            <a:schemeClr val="accent1"/>
+          </a:effectRef>
+          <a:fontRef idx="minor">
+            <a:schemeClr val="lt1"/>
+          </a:fontRef>
+        </p:style>
+        <p:txBody>
+          <a:bodyPr rtlCol="0" anchor="ctr" wrap="square" lIns="45720" rIns="45720" tIns="27432" bIns="27432"/>
+          <a:lstStyle/>
+          <a:p>
+            <a:pPr algn="ctr"/>
+            <a:r>
+              <a:rPr sz="950" b="0">
+                <a:solidFill>
+                  <a:srgbClr val="1A1A1A"/>
+                </a:solidFill>
+                <a:latin typeface="맑은 고딕"/>
+                <a:ea typeface="맑은 고딕"/>
+              </a:rPr>
+              <a:t>x1.21 / 5쌍 / x1.24</a:t>
+            </a:r>
+          </a:p>
+        </p:txBody>
+      </p:sp>
+      <p:sp>
+        <p:nvSpPr>
+          <p:cNvPr id="67" name="Rectangle 66"/>
+          <p:cNvSpPr/>
+          <p:nvPr/>
+        </p:nvSpPr>
+        <p:spPr>
+          <a:xfrm>
+            <a:off x="365760" y="2139696"/>
+            <a:ext cx="1737360" cy="365760"/>
+          </a:xfrm>
+          <a:prstGeom prst="rect">
+            <a:avLst/>
+          </a:prstGeom>
+          <a:solidFill>
+            <a:srgbClr val="DCE9F5"/>
+          </a:solidFill>
+          <a:ln w="9525">
+            <a:solidFill>
+              <a:srgbClr val="4D7EA8"/>
+            </a:solidFill>
+          </a:ln>
+          <a:effectLst/>
+        </p:spPr>
+        <p:style>
+          <a:lnRef idx="1">
+            <a:schemeClr val="accent1"/>
+          </a:lnRef>
+          <a:fillRef idx="3">
+            <a:schemeClr val="accent1"/>
+          </a:fillRef>
+          <a:effectRef idx="2">
+            <a:schemeClr val="accent1"/>
+          </a:effectRef>
+          <a:fontRef idx="minor">
+            <a:schemeClr val="lt1"/>
+          </a:fontRef>
+        </p:style>
+        <p:txBody>
+          <a:bodyPr rtlCol="0" anchor="ctr" wrap="square" lIns="45720" rIns="45720" tIns="27432" bIns="27432"/>
+          <a:lstStyle/>
+          <a:p>
+            <a:pPr algn="ctr"/>
+            <a:r>
+              <a:rPr sz="950" b="1">
+                <a:solidFill>
+                  <a:srgbClr val="1A1A1A"/>
+                </a:solidFill>
+                <a:latin typeface="맑은 고딕"/>
+                <a:ea typeface="맑은 고딕"/>
+              </a:rPr>
+              <a:t>0.5</a:t>
+            </a:r>
+          </a:p>
+        </p:txBody>
+      </p:sp>
+      <p:sp>
+        <p:nvSpPr>
+          <p:cNvPr id="68" name="Rectangle 67"/>
+          <p:cNvSpPr/>
+          <p:nvPr/>
+        </p:nvSpPr>
+        <p:spPr>
+          <a:xfrm>
+            <a:off x="2103120" y="2139696"/>
+            <a:ext cx="4572000" cy="365760"/>
+          </a:xfrm>
+          <a:prstGeom prst="rect">
+            <a:avLst/>
+          </a:prstGeom>
+          <a:solidFill>
+            <a:srgbClr val="FFFFFF"/>
+          </a:solidFill>
+          <a:ln w="9525">
+            <a:solidFill>
+              <a:srgbClr val="BFBFBF"/>
+            </a:solidFill>
+          </a:ln>
+          <a:effectLst/>
+        </p:spPr>
+        <p:style>
+          <a:lnRef idx="1">
+            <a:schemeClr val="accent1"/>
+          </a:lnRef>
+          <a:fillRef idx="3">
+            <a:schemeClr val="accent1"/>
+          </a:fillRef>
+          <a:effectRef idx="2">
+            <a:schemeClr val="accent1"/>
+          </a:effectRef>
+          <a:fontRef idx="minor">
+            <a:schemeClr val="lt1"/>
+          </a:fontRef>
+        </p:style>
+        <p:txBody>
+          <a:bodyPr rtlCol="0" anchor="ctr" wrap="square" lIns="45720" rIns="45720" tIns="27432" bIns="27432"/>
+          <a:lstStyle/>
+          <a:p>
+            <a:pPr algn="ctr"/>
+            <a:r>
+              <a:rPr sz="950" b="0">
+                <a:solidFill>
+                  <a:srgbClr val="1A1A1A"/>
+                </a:solidFill>
+                <a:latin typeface="맑은 고딕"/>
+                <a:ea typeface="맑은 고딕"/>
+              </a:rPr>
+              <a:t>x1.00 / 3쌍 / x1.20</a:t>
+            </a:r>
+          </a:p>
+        </p:txBody>
+      </p:sp>
+      <p:sp>
+        <p:nvSpPr>
+          <p:cNvPr id="69" name="Rectangle 68"/>
+          <p:cNvSpPr/>
+          <p:nvPr/>
+        </p:nvSpPr>
+        <p:spPr>
+          <a:xfrm>
+            <a:off x="6675120" y="2139696"/>
+            <a:ext cx="5120640" cy="365760"/>
+          </a:xfrm>
+          <a:prstGeom prst="rect">
+            <a:avLst/>
+          </a:prstGeom>
+          <a:solidFill>
+            <a:srgbClr val="FFFFFF"/>
+          </a:solidFill>
+          <a:ln w="9525">
+            <a:solidFill>
+              <a:srgbClr val="BFBFBF"/>
+            </a:solidFill>
+          </a:ln>
+          <a:effectLst/>
+        </p:spPr>
+        <p:style>
+          <a:lnRef idx="1">
+            <a:schemeClr val="accent1"/>
+          </a:lnRef>
+          <a:fillRef idx="3">
+            <a:schemeClr val="accent1"/>
+          </a:fillRef>
+          <a:effectRef idx="2">
+            <a:schemeClr val="accent1"/>
+          </a:effectRef>
+          <a:fontRef idx="minor">
+            <a:schemeClr val="lt1"/>
+          </a:fontRef>
+        </p:style>
+        <p:txBody>
+          <a:bodyPr rtlCol="0" anchor="ctr" wrap="square" lIns="45720" rIns="45720" tIns="27432" bIns="27432"/>
+          <a:lstStyle/>
+          <a:p>
+            <a:pPr algn="ctr"/>
+            <a:r>
+              <a:rPr sz="950" b="0">
+                <a:solidFill>
+                  <a:srgbClr val="1A1A1A"/>
+                </a:solidFill>
+                <a:latin typeface="맑은 고딕"/>
+                <a:ea typeface="맑은 고딕"/>
+              </a:rPr>
+              <a:t>x1.02 / 4쌍 / x1.23</a:t>
+            </a:r>
+          </a:p>
+        </p:txBody>
+      </p:sp>
+      <p:sp>
+        <p:nvSpPr>
+          <p:cNvPr id="70" name="Rectangle 69"/>
+          <p:cNvSpPr/>
+          <p:nvPr/>
+        </p:nvSpPr>
+        <p:spPr>
+          <a:xfrm>
+            <a:off x="365760" y="2523744"/>
+            <a:ext cx="1737360" cy="365760"/>
+          </a:xfrm>
+          <a:prstGeom prst="rect">
+            <a:avLst/>
+          </a:prstGeom>
+          <a:solidFill>
+            <a:srgbClr val="DCE9F5"/>
+          </a:solidFill>
+          <a:ln w="9525">
+            <a:solidFill>
+              <a:srgbClr val="4D7EA8"/>
+            </a:solidFill>
+          </a:ln>
+          <a:effectLst/>
+        </p:spPr>
+        <p:style>
+          <a:lnRef idx="1">
+            <a:schemeClr val="accent1"/>
+          </a:lnRef>
+          <a:fillRef idx="3">
+            <a:schemeClr val="accent1"/>
+          </a:fillRef>
+          <a:effectRef idx="2">
+            <a:schemeClr val="accent1"/>
+          </a:effectRef>
+          <a:fontRef idx="minor">
+            <a:schemeClr val="lt1"/>
+          </a:fontRef>
+        </p:style>
+        <p:txBody>
+          <a:bodyPr rtlCol="0" anchor="ctr" wrap="square" lIns="45720" rIns="45720" tIns="27432" bIns="27432"/>
+          <a:lstStyle/>
+          <a:p>
+            <a:pPr algn="ctr"/>
+            <a:r>
+              <a:rPr sz="950" b="1">
+                <a:solidFill>
+                  <a:srgbClr val="1A1A1A"/>
+                </a:solidFill>
+                <a:latin typeface="맑은 고딕"/>
+                <a:ea typeface="맑은 고딕"/>
+              </a:rPr>
+              <a:t>0.25</a:t>
+            </a:r>
+          </a:p>
+        </p:txBody>
+      </p:sp>
+      <p:sp>
+        <p:nvSpPr>
+          <p:cNvPr id="71" name="Rectangle 70"/>
+          <p:cNvSpPr/>
+          <p:nvPr/>
+        </p:nvSpPr>
+        <p:spPr>
+          <a:xfrm>
+            <a:off x="2103120" y="2523744"/>
+            <a:ext cx="4572000" cy="365760"/>
+          </a:xfrm>
+          <a:prstGeom prst="rect">
+            <a:avLst/>
+          </a:prstGeom>
+          <a:solidFill>
+            <a:srgbClr val="FFFFFF"/>
+          </a:solidFill>
+          <a:ln w="9525">
+            <a:solidFill>
+              <a:srgbClr val="BFBFBF"/>
+            </a:solidFill>
+          </a:ln>
+          <a:effectLst/>
+        </p:spPr>
+        <p:style>
+          <a:lnRef idx="1">
+            <a:schemeClr val="accent1"/>
+          </a:lnRef>
+          <a:fillRef idx="3">
+            <a:schemeClr val="accent1"/>
+          </a:fillRef>
+          <a:effectRef idx="2">
+            <a:schemeClr val="accent1"/>
+          </a:effectRef>
+          <a:fontRef idx="minor">
+            <a:schemeClr val="lt1"/>
+          </a:fontRef>
+        </p:style>
+        <p:txBody>
+          <a:bodyPr rtlCol="0" anchor="ctr" wrap="square" lIns="45720" rIns="45720" tIns="27432" bIns="27432"/>
+          <a:lstStyle/>
+          <a:p>
+            <a:pPr algn="ctr"/>
+            <a:r>
+              <a:rPr sz="950" b="0">
+                <a:solidFill>
+                  <a:srgbClr val="1A1A1A"/>
+                </a:solidFill>
+                <a:latin typeface="맑은 고딕"/>
+                <a:ea typeface="맑은 고딕"/>
+              </a:rPr>
+              <a:t>x1.00 / 0쌍 / x1.00</a:t>
+            </a:r>
+          </a:p>
+        </p:txBody>
+      </p:sp>
+      <p:sp>
+        <p:nvSpPr>
+          <p:cNvPr id="72" name="Rectangle 71"/>
+          <p:cNvSpPr/>
+          <p:nvPr/>
+        </p:nvSpPr>
+        <p:spPr>
+          <a:xfrm>
+            <a:off x="6675120" y="2523744"/>
+            <a:ext cx="5120640" cy="365760"/>
+          </a:xfrm>
+          <a:prstGeom prst="rect">
+            <a:avLst/>
+          </a:prstGeom>
+          <a:solidFill>
+            <a:srgbClr val="FFFFFF"/>
+          </a:solidFill>
+          <a:ln w="9525">
+            <a:solidFill>
+              <a:srgbClr val="BFBFBF"/>
+            </a:solidFill>
+          </a:ln>
+          <a:effectLst/>
+        </p:spPr>
+        <p:style>
+          <a:lnRef idx="1">
+            <a:schemeClr val="accent1"/>
+          </a:lnRef>
+          <a:fillRef idx="3">
+            <a:schemeClr val="accent1"/>
+          </a:fillRef>
+          <a:effectRef idx="2">
+            <a:schemeClr val="accent1"/>
+          </a:effectRef>
+          <a:fontRef idx="minor">
+            <a:schemeClr val="lt1"/>
+          </a:fontRef>
+        </p:style>
+        <p:txBody>
+          <a:bodyPr rtlCol="0" anchor="ctr" wrap="square" lIns="45720" rIns="45720" tIns="27432" bIns="27432"/>
+          <a:lstStyle/>
+          <a:p>
+            <a:pPr algn="ctr"/>
+            <a:r>
+              <a:rPr sz="950" b="0">
+                <a:solidFill>
+                  <a:srgbClr val="1A1A1A"/>
+                </a:solidFill>
+                <a:latin typeface="맑은 고딕"/>
+                <a:ea typeface="맑은 고딕"/>
+              </a:rPr>
+              <a:t>x1.00 / 6쌍 / x1.17</a:t>
+            </a:r>
+          </a:p>
+        </p:txBody>
+      </p:sp>
+      <p:sp>
+        <p:nvSpPr>
+          <p:cNvPr id="73" name="Rectangle 72"/>
+          <p:cNvSpPr/>
+          <p:nvPr/>
+        </p:nvSpPr>
+        <p:spPr>
+          <a:xfrm>
+            <a:off x="365760" y="2999232"/>
+            <a:ext cx="5669280" cy="2743200"/>
+          </a:xfrm>
+          <a:prstGeom prst="rect">
+            <a:avLst/>
+          </a:prstGeom>
+          <a:solidFill>
+            <a:srgbClr val="E3F1E3"/>
+          </a:solidFill>
+          <a:ln w="9525">
+            <a:solidFill>
+              <a:srgbClr val="5B9B5B"/>
+            </a:solidFill>
+          </a:ln>
+          <a:effectLst/>
+        </p:spPr>
+        <p:style>
+          <a:lnRef idx="1">
+            <a:schemeClr val="accent1"/>
+          </a:lnRef>
+          <a:fillRef idx="3">
+            <a:schemeClr val="accent1"/>
+          </a:fillRef>
+          <a:effectRef idx="2">
+            <a:schemeClr val="accent1"/>
+          </a:effectRef>
+          <a:fontRef idx="minor">
+            <a:schemeClr val="lt1"/>
+          </a:fontRef>
+        </p:style>
+        <p:txBody>
+          <a:bodyPr rtlCol="0" anchor="t" wrap="square" lIns="45720" rIns="45720" tIns="27432" bIns="27432"/>
+          <a:lstStyle/>
+          <a:p>
+            <a:pPr algn="l"/>
+            <a:r>
+              <a:rPr sz="950" b="1">
+                <a:solidFill>
+                  <a:srgbClr val="1A1A1A"/>
+                </a:solidFill>
+                <a:latin typeface="맑은 고딕"/>
+                <a:ea typeface="맑은 고딕"/>
+              </a:rPr>
+              <a:t>무슨 일이 일어나나 (21쌍, H100+B200)</a:t>
+            </a:r>
+          </a:p>
+          <a:p>
+            <a:pPr algn="l"/>
+            <a:r>
+              <a:rPr sz="950" b="0">
+                <a:solidFill>
+                  <a:srgbClr val="1A1A1A"/>
+                </a:solidFill>
+                <a:latin typeface="맑은 고딕"/>
+                <a:ea typeface="맑은 고딕"/>
+              </a:rPr>
+              <a:t>- 현재 설정에서 TTFT P99가 Baseline보다 나쁜 쌍: C1 6개, C2 5개. C1 최악은 Common cb_kv_8k_b</a:t>
+            </a:r>
+          </a:p>
+          <a:p>
+            <a:pPr algn="l"/>
+            <a:r>
+              <a:rPr sz="950" b="0">
+                <a:solidFill>
+                  <a:srgbClr val="1A1A1A"/>
+                </a:solidFill>
+                <a:latin typeface="맑은 고딕"/>
+                <a:ea typeface="맑은 고딕"/>
+              </a:rPr>
+              <a:t>32(H100 x4.15, B200 x3.88).</a:t>
+            </a:r>
+          </a:p>
+          <a:p>
+            <a:pPr algn="l"/>
+            <a:r>
+              <a:rPr sz="950" b="0">
+                <a:solidFill>
+                  <a:srgbClr val="1A1A1A"/>
+                </a:solidFill>
+                <a:latin typeface="맑은 고딕"/>
+                <a:ea typeface="맑은 고딕"/>
+              </a:rPr>
+              <a:t>- 같은 쌍에서 TTFT P50은 개선(x0.32~0.67)된다: 중앙값은 좋아지고 꼬리가 나빠진다.</a:t>
+            </a:r>
+          </a:p>
+          <a:p>
+            <a:pPr algn="l"/>
+            <a:r>
+              <a:rPr sz="950" b="0">
+                <a:solidFill>
+                  <a:srgbClr val="1A1A1A"/>
+                </a:solidFill>
+                <a:latin typeface="맑은 고딕"/>
+                <a:ea typeface="맑은 고딕"/>
+              </a:rPr>
+              <a:t>- 꼬리는 이동된 객체가 아니라 DRAM에 남은 KV의 첫 응답이다. C1이 초반 20% 구간에 15 GiB급 이</a:t>
+            </a:r>
+          </a:p>
+          <a:p>
+            <a:pPr algn="l"/>
+            <a:r>
+              <a:rPr sz="950" b="0">
+                <a:solidFill>
+                  <a:srgbClr val="1A1A1A"/>
+                </a:solidFill>
+                <a:latin typeface="맑은 고딕"/>
+                <a:ea typeface="맑은 고딕"/>
+              </a:rPr>
+              <a:t>동 19건을 몰아 보내 DRAM 링크 서빙 대역폭이 0.10배까지 떨어지고, 그 구간 접근 2.5%가 P99를 </a:t>
+            </a:r>
+          </a:p>
+          <a:p>
+            <a:pPr algn="l"/>
+            <a:r>
+              <a:rPr sz="950" b="0">
+                <a:solidFill>
+                  <a:srgbClr val="1A1A1A"/>
+                </a:solidFill>
+                <a:latin typeface="맑은 고딕"/>
+                <a:ea typeface="맑은 고딕"/>
+              </a:rPr>
+              <a:t>정한다.</a:t>
+            </a:r>
+          </a:p>
+        </p:txBody>
+      </p:sp>
+      <p:sp>
+        <p:nvSpPr>
+          <p:cNvPr id="74" name="Rectangle 73"/>
+          <p:cNvSpPr/>
+          <p:nvPr/>
+        </p:nvSpPr>
+        <p:spPr>
+          <a:xfrm>
+            <a:off x="6217920" y="2999232"/>
+            <a:ext cx="5577840" cy="2743200"/>
+          </a:xfrm>
+          <a:prstGeom prst="rect">
+            <a:avLst/>
+          </a:prstGeom>
+          <a:solidFill>
+            <a:srgbClr val="F2F2F2"/>
+          </a:solidFill>
+          <a:ln w="9525">
+            <a:solidFill>
+              <a:srgbClr val="BFBFBF"/>
+            </a:solidFill>
+          </a:ln>
+          <a:effectLst/>
+        </p:spPr>
+        <p:style>
+          <a:lnRef idx="1">
+            <a:schemeClr val="accent1"/>
+          </a:lnRef>
+          <a:fillRef idx="3">
+            <a:schemeClr val="accent1"/>
+          </a:fillRef>
+          <a:effectRef idx="2">
+            <a:schemeClr val="accent1"/>
+          </a:effectRef>
+          <a:fontRef idx="minor">
+            <a:schemeClr val="lt1"/>
+          </a:fontRef>
+        </p:style>
+        <p:txBody>
+          <a:bodyPr rtlCol="0" anchor="t" wrap="square" lIns="45720" rIns="45720" tIns="27432" bIns="27432"/>
+          <a:lstStyle/>
+          <a:p>
+            <a:pPr algn="l"/>
+            <a:r>
+              <a:rPr sz="950" b="1">
+                <a:solidFill>
+                  <a:srgbClr val="404040"/>
+                </a:solidFill>
+                <a:latin typeface="맑은 고딕"/>
+                <a:ea typeface="맑은 고딕"/>
+              </a:rPr>
+              <a:t>결론과 한계</a:t>
+            </a:r>
+          </a:p>
+          <a:p>
+            <a:pPr algn="l"/>
+            <a:r>
+              <a:rPr sz="950" b="0">
+                <a:solidFill>
+                  <a:srgbClr val="404040"/>
+                </a:solidFill>
+                <a:latin typeface="맑은 고딕"/>
+                <a:ea typeface="맑은 고딕"/>
+              </a:rPr>
+              <a:t>- burst 용량을 줄이면 꼬리가 줄지만 이득도 같이 사라진다(0.5 s: C1 QA1 x1.00, 0.25 s: C1이 Ba</a:t>
+            </a:r>
+          </a:p>
+          <a:p>
+            <a:pPr algn="l"/>
+            <a:r>
+              <a:rPr sz="950" b="0">
+                <a:solidFill>
+                  <a:srgbClr val="404040"/>
+                </a:solidFill>
+                <a:latin typeface="맑은 고딕"/>
+                <a:ea typeface="맑은 고딕"/>
+              </a:rPr>
+              <a:t>seline과 동일). 용량 상수 하나로 둘을 동시에 얻지 못한다.</a:t>
+            </a:r>
+          </a:p>
+          <a:p>
+            <a:pPr algn="l"/>
+            <a:r>
+              <a:rPr sz="950" b="0">
+                <a:solidFill>
+                  <a:srgbClr val="404040"/>
+                </a:solidFill>
+                <a:latin typeface="맑은 고딕"/>
+                <a:ea typeface="맑은 고딕"/>
+              </a:rPr>
+              <a:t>- 기본값은 유지했다. 필요한 것은 큰 이동을 여러 tick에 나누는 staged 이동과 이동 중 접근에 대</a:t>
+            </a:r>
+          </a:p>
+          <a:p>
+            <a:pPr algn="l"/>
+            <a:r>
+              <a:rPr sz="950" b="0">
+                <a:solidFill>
+                  <a:srgbClr val="404040"/>
+                </a:solidFill>
+                <a:latin typeface="맑은 고딕"/>
+                <a:ea typeface="맑은 고딕"/>
+              </a:rPr>
+              <a:t>한 do-no-harm 검사이며 보완 설계 택틱([C], 미구현)이다.</a:t>
+            </a:r>
+          </a:p>
+          <a:p>
+            <a:pPr algn="l"/>
+            <a:r>
+              <a:rPr sz="950" b="0">
+                <a:solidFill>
+                  <a:srgbClr val="404040"/>
+                </a:solidFill>
+                <a:latin typeface="맑은 고딕"/>
+                <a:ea typeface="맑은 고딕"/>
+              </a:rPr>
+              <a:t>- 한계: 링크 간섭이 평균장 근사(대역폭 배율)라 꼬리가 과대일 수 있다. 사전 판정 규칙이 '이득이 </a:t>
+            </a:r>
+          </a:p>
+          <a:p>
+            <a:pPr algn="l"/>
+            <a:r>
+              <a:rPr sz="950" b="0">
+                <a:solidFill>
+                  <a:srgbClr val="404040"/>
+                </a:solidFill>
+                <a:latin typeface="맑은 고딕"/>
+                <a:ea typeface="맑은 고딕"/>
+              </a:rPr>
+              <a:t>0인 퇴화 해'를 허용하는 결함이 있었음을 loop-log에 기록했다.</a:t>
+            </a:r>
+          </a:p>
+        </p:txBody>
+      </p:sp>
+    </p:spTree>
+  </p:cSld>
+  <p:clrMapOvr>
+    <a:masterClrMapping/>
+  </p:clrMapOvr>
+</p:sld>
+</file>
+
+<file path=ppt/slides/slide24.xml><?xml version="1.0" encoding="utf-8"?>
+<p:sld xmlns:a="http://schemas.openxmlformats.org/drawingml/2006/main" xmlns:p="http://schemas.openxmlformats.org/presentationml/2006/main" xmlns:r="http://schemas.openxmlformats.org/officeDocument/2006/relationships">
+  <p:cSld>
+    <p:spTree>
+      <p:nvGrpSpPr>
+        <p:cNvPr id="1" name=""/>
+        <p:cNvGrpSpPr/>
+        <p:nvPr/>
+      </p:nvGrpSpPr>
+      <p:grpSpPr/>
+      <p:sp>
+        <p:nvSpPr>
+          <p:cNvPr id="3" name="제목 2"/>
+          <p:cNvSpPr>
+            <a:spLocks noGrp="1"/>
+          </p:cNvSpPr>
+          <p:nvPr>
+            <p:ph type="title"/>
+          </p:nvPr>
+        </p:nvSpPr>
+        <p:spPr>
+          <a:xfrm>
+            <a:off x="234949" y="137379"/>
+            <a:ext cx="7631530" cy="365125"/>
+          </a:xfrm>
+        </p:spPr>
+        <p:txBody>
+          <a:bodyPr/>
+          <a:lstStyle/>
+          <a:p>
+            <a:r>
+              <a:rPr lang="en-US" altLang="ko-KR" dirty="0"/>
+              <a:t>DP1. 이기종 메모리 기반 Data Migration 구조 - Appendix</a:t>
+            </a:r>
+            <a:r>
+              <a:rPr lang="ko-KR" altLang="en-US" dirty="0"/>
+              <a:t/>
+            </a:r>
+            <a:r>
+              <a:rPr lang="en-US" altLang="ko-KR" dirty="0"/>
+              <a:t/>
+            </a:r>
+            <a:r>
+              <a:rPr lang="ko-KR" altLang="en-US" dirty="0"/>
+              <a:t/>
+            </a:r>
+            <a:r>
+              <a:rPr lang="en-US" altLang="ko-KR" dirty="0"/>
+              <a:t/>
+            </a:r>
+            <a:r>
+              <a:rPr lang="ko-KR" altLang="en-US" dirty="0"/>
+              <a:t/>
+            </a:r>
+          </a:p>
+        </p:txBody>
+      </p:sp>
+      <p:sp>
+        <p:nvSpPr>
+          <p:cNvPr id="5" name="직사각형 4"/>
+          <p:cNvSpPr/>
+          <p:nvPr/>
+        </p:nvSpPr>
+        <p:spPr>
+          <a:xfrm>
+            <a:off x="234949" y="596176"/>
+            <a:ext cx="11747501" cy="396603"/>
+          </a:xfrm>
+          <a:prstGeom prst="rect">
+            <a:avLst/>
+          </a:prstGeom>
+          <a:solidFill>
+            <a:schemeClr val="bg1">
+              <a:lumMod val="50000"/>
+            </a:schemeClr>
+          </a:solidFill>
+          <a:ln>
+            <a:noFill/>
+          </a:ln>
+        </p:spPr>
+        <p:style>
+          <a:lnRef idx="2">
+            <a:schemeClr val="accent1">
+              <a:shade val="50000"/>
+            </a:schemeClr>
+          </a:lnRef>
+          <a:fillRef idx="1">
+            <a:schemeClr val="accent1"/>
+          </a:fillRef>
+          <a:effectRef idx="0">
+            <a:schemeClr val="accent1"/>
+          </a:effectRef>
+          <a:fontRef idx="minor">
+            <a:schemeClr val="lt1"/>
+          </a:fontRef>
+        </p:style>
+        <p:txBody>
+          <a:bodyPr rtlCol="0" anchor="ctr"/>
+          <a:lstStyle/>
+          <a:p>
+            <a:pPr algn="ctr"/>
+            <a:endParaRPr lang="ko-KR" altLang="en-US"/>
+          </a:p>
+        </p:txBody>
+      </p:sp>
+      <p:sp>
+        <p:nvSpPr>
+          <p:cNvPr id="8" name="TextBox 7"/>
+          <p:cNvSpPr txBox="1"/>
+          <p:nvPr/>
+        </p:nvSpPr>
+        <p:spPr>
+          <a:xfrm>
+            <a:off x="469760" y="627926"/>
+            <a:ext cx="11430000" cy="307777"/>
+          </a:xfrm>
+          <a:prstGeom prst="rect">
+            <a:avLst/>
+          </a:prstGeom>
+          <a:noFill/>
+        </p:spPr>
+        <p:txBody>
+          <a:bodyPr wrap="square" rtlCol="0">
+            <a:spAutoFit/>
+          </a:bodyPr>
+          <a:lstStyle/>
+          <a:p>
+            <a:pPr lvl="0">
+              <a:defRPr/>
+            </a:pPr>
+            <a:r>
+              <a:rPr lang="ko-KR" altLang="en-US" sz="1400" b="1" dirty="0">
+                <a:solidFill>
+                  <a:schemeClr val="bg1"/>
+                </a:solidFill>
+              </a:rPr>
+              <a:t>별점 경계의 근거 - 하한은 측정, 상한은 환산 + 정책 선택</a:t>
+            </a:r>
+            <a:r>
+              <a:rPr lang="en-US" altLang="ko-KR" sz="1400" b="1" dirty="0">
+                <a:solidFill>
+                  <a:schemeClr val="bg1"/>
+                </a:solidFill>
+              </a:rPr>
+              <a:t/>
+            </a:r>
+            <a:r>
+              <a:rPr lang="ko-KR" altLang="en-US" sz="1400" b="1" dirty="0">
+                <a:solidFill>
+                  <a:schemeClr val="bg1"/>
+                </a:solidFill>
+              </a:rPr>
+              <a:t/>
+            </a:r>
+            <a:r>
+              <a:rPr lang="en-US" altLang="ko-KR" sz="1400" b="1" dirty="0">
+                <a:solidFill>
+                  <a:schemeClr val="bg1"/>
+                </a:solidFill>
+              </a:rPr>
+              <a:t/>
+            </a:r>
+            <a:r>
+              <a:rPr lang="ko-KR" altLang="en-US" sz="1400" b="1" dirty="0">
+                <a:solidFill>
+                  <a:schemeClr val="bg1"/>
+                </a:solidFill>
+              </a:rPr>
+              <a:t/>
+            </a:r>
+          </a:p>
+        </p:txBody>
+      </p:sp>
+      <p:sp>
+        <p:nvSpPr>
+          <p:cNvPr id="39" name="직사각형 38"/>
+          <p:cNvSpPr/>
+          <p:nvPr/>
+        </p:nvSpPr>
+        <p:spPr>
+          <a:xfrm>
+            <a:off x="403086" y="678726"/>
+            <a:ext cx="66675" cy="216270"/>
+          </a:xfrm>
+          <a:prstGeom prst="rect">
+            <a:avLst/>
+          </a:prstGeom>
+          <a:solidFill>
+            <a:schemeClr val="bg1"/>
+          </a:solidFill>
+          <a:ln w="19050">
+            <a:noFill/>
+          </a:ln>
+        </p:spPr>
+        <p:style>
+          <a:lnRef idx="2">
+            <a:schemeClr val="accent1">
+              <a:shade val="50000"/>
+            </a:schemeClr>
+          </a:lnRef>
+          <a:fillRef idx="1">
+            <a:schemeClr val="accent1"/>
+          </a:fillRef>
+          <a:effectRef idx="0">
+            <a:schemeClr val="accent1"/>
+          </a:effectRef>
+          <a:fontRef idx="minor">
+            <a:schemeClr val="lt1"/>
+          </a:fontRef>
+        </p:style>
+        <p:txBody>
+          <a:bodyPr rtlCol="0" anchor="ctr"/>
+          <a:lstStyle/>
+          <a:p>
+            <a:pPr algn="ctr"/>
+            <a:endParaRPr lang="ko-KR" altLang="en-US" sz="1600"/>
+          </a:p>
+        </p:txBody>
+      </p:sp>
+      <p:sp>
+        <p:nvSpPr>
+          <p:cNvPr id="57" name="슬라이드 번호 개체 틀 1"/>
+          <p:cNvSpPr>
+            <a:spLocks noGrp="1"/>
+          </p:cNvSpPr>
+          <p:nvPr>
+            <p:ph type="sldNum" sz="quarter" idx="4"/>
+          </p:nvPr>
+        </p:nvSpPr>
+        <p:spPr>
+          <a:xfrm>
+            <a:off x="5620080" y="6597650"/>
+            <a:ext cx="456466" cy="209550"/>
+          </a:xfrm>
+        </p:spPr>
+        <p:txBody>
+          <a:bodyPr/>
+          <a:lstStyle/>
+          <a:p>
+            <a:fld id="{7F889C64-266A-4D07-AD8F-5B592E61CCE1}" type="slidenum">
+              <a:rPr lang="ko-KR" altLang="en-US" smtClean="0"/>
+              <a:pPr/>
+              <a:t>9</a:t>
+            </a:fld>
+            <a:endParaRPr lang="ko-KR" altLang="en-US" dirty="0"/>
+          </a:p>
+        </p:txBody>
+      </p:sp>
+      <p:sp>
+        <p:nvSpPr>
+          <p:cNvPr id="58" name="Rectangle 57"/>
+          <p:cNvSpPr/>
+          <p:nvPr/>
+        </p:nvSpPr>
+        <p:spPr>
+          <a:xfrm>
+            <a:off x="365760" y="1051560"/>
+            <a:ext cx="1188720" cy="292608"/>
+          </a:xfrm>
+          <a:prstGeom prst="rect">
+            <a:avLst/>
+          </a:prstGeom>
+          <a:solidFill>
+            <a:srgbClr val="1F4E79"/>
+          </a:solidFill>
+          <a:ln w="9525">
+            <a:solidFill>
+              <a:srgbClr val="1F4E79"/>
+            </a:solidFill>
+          </a:ln>
+          <a:effectLst/>
+        </p:spPr>
+        <p:style>
+          <a:lnRef idx="1">
+            <a:schemeClr val="accent1"/>
+          </a:lnRef>
+          <a:fillRef idx="3">
+            <a:schemeClr val="accent1"/>
+          </a:fillRef>
+          <a:effectRef idx="2">
+            <a:schemeClr val="accent1"/>
+          </a:effectRef>
+          <a:fontRef idx="minor">
+            <a:schemeClr val="lt1"/>
+          </a:fontRef>
+        </p:style>
+        <p:txBody>
+          <a:bodyPr rtlCol="0" anchor="ctr" wrap="square" lIns="45720" rIns="45720" tIns="27432" bIns="27432"/>
+          <a:lstStyle/>
+          <a:p>
+            <a:pPr algn="ctr"/>
+            <a:r>
+              <a:rPr sz="1000" b="1">
+                <a:solidFill>
+                  <a:srgbClr val="FFFFFF"/>
+                </a:solidFill>
+                <a:latin typeface="맑은 고딕"/>
+                <a:ea typeface="맑은 고딕"/>
+              </a:rPr>
+              <a:t>QA</a:t>
+            </a:r>
+          </a:p>
+        </p:txBody>
+      </p:sp>
+      <p:sp>
+        <p:nvSpPr>
+          <p:cNvPr id="59" name="Rectangle 58"/>
+          <p:cNvSpPr/>
+          <p:nvPr/>
+        </p:nvSpPr>
+        <p:spPr>
+          <a:xfrm>
+            <a:off x="1554480" y="1051560"/>
+            <a:ext cx="4206240" cy="292608"/>
+          </a:xfrm>
+          <a:prstGeom prst="rect">
+            <a:avLst/>
+          </a:prstGeom>
+          <a:solidFill>
+            <a:srgbClr val="1F4E79"/>
+          </a:solidFill>
+          <a:ln w="9525">
+            <a:solidFill>
+              <a:srgbClr val="1F4E79"/>
+            </a:solidFill>
+          </a:ln>
+          <a:effectLst/>
+        </p:spPr>
+        <p:style>
+          <a:lnRef idx="1">
+            <a:schemeClr val="accent1"/>
+          </a:lnRef>
+          <a:fillRef idx="3">
+            <a:schemeClr val="accent1"/>
+          </a:fillRef>
+          <a:effectRef idx="2">
+            <a:schemeClr val="accent1"/>
+          </a:effectRef>
+          <a:fontRef idx="minor">
+            <a:schemeClr val="lt1"/>
+          </a:fontRef>
+        </p:style>
+        <p:txBody>
+          <a:bodyPr rtlCol="0" anchor="ctr" wrap="square" lIns="45720" rIns="45720" tIns="27432" bIns="27432"/>
+          <a:lstStyle/>
+          <a:p>
+            <a:pPr algn="ctr"/>
+            <a:r>
+              <a:rPr sz="1000" b="1">
+                <a:solidFill>
+                  <a:srgbClr val="FFFFFF"/>
+                </a:solidFill>
+                <a:latin typeface="맑은 고딕"/>
+                <a:ea typeface="맑은 고딕"/>
+              </a:rPr>
+              <a:t>하한 (★/★★) 근거: Baseline끼리 비교한 잡음 대역</a:t>
+            </a:r>
+          </a:p>
+        </p:txBody>
+      </p:sp>
+      <p:sp>
+        <p:nvSpPr>
+          <p:cNvPr id="60" name="Rectangle 59"/>
+          <p:cNvSpPr/>
+          <p:nvPr/>
+        </p:nvSpPr>
+        <p:spPr>
+          <a:xfrm>
+            <a:off x="5760720" y="1051560"/>
+            <a:ext cx="1005840" cy="292608"/>
+          </a:xfrm>
+          <a:prstGeom prst="rect">
+            <a:avLst/>
+          </a:prstGeom>
+          <a:solidFill>
+            <a:srgbClr val="1F4E79"/>
+          </a:solidFill>
+          <a:ln w="9525">
+            <a:solidFill>
+              <a:srgbClr val="1F4E79"/>
+            </a:solidFill>
+          </a:ln>
+          <a:effectLst/>
+        </p:spPr>
+        <p:style>
+          <a:lnRef idx="1">
+            <a:schemeClr val="accent1"/>
+          </a:lnRef>
+          <a:fillRef idx="3">
+            <a:schemeClr val="accent1"/>
+          </a:fillRef>
+          <a:effectRef idx="2">
+            <a:schemeClr val="accent1"/>
+          </a:effectRef>
+          <a:fontRef idx="minor">
+            <a:schemeClr val="lt1"/>
+          </a:fontRef>
+        </p:style>
+        <p:txBody>
+          <a:bodyPr rtlCol="0" anchor="ctr" wrap="square" lIns="45720" rIns="45720" tIns="27432" bIns="27432"/>
+          <a:lstStyle/>
+          <a:p>
+            <a:pPr algn="ctr"/>
+            <a:r>
+              <a:rPr sz="1000" b="1">
+                <a:solidFill>
+                  <a:srgbClr val="FFFFFF"/>
+                </a:solidFill>
+                <a:latin typeface="맑은 고딕"/>
+                <a:ea typeface="맑은 고딕"/>
+              </a:rPr>
+              <a:t>현재 하한</a:t>
+            </a:r>
+          </a:p>
+        </p:txBody>
+      </p:sp>
+      <p:sp>
+        <p:nvSpPr>
+          <p:cNvPr id="61" name="Rectangle 60"/>
+          <p:cNvSpPr/>
+          <p:nvPr/>
+        </p:nvSpPr>
+        <p:spPr>
+          <a:xfrm>
+            <a:off x="6766560" y="1051560"/>
+            <a:ext cx="5029200" cy="292608"/>
+          </a:xfrm>
+          <a:prstGeom prst="rect">
+            <a:avLst/>
+          </a:prstGeom>
+          <a:solidFill>
+            <a:srgbClr val="1F4E79"/>
+          </a:solidFill>
+          <a:ln w="9525">
+            <a:solidFill>
+              <a:srgbClr val="1F4E79"/>
+            </a:solidFill>
+          </a:ln>
+          <a:effectLst/>
+        </p:spPr>
+        <p:style>
+          <a:lnRef idx="1">
+            <a:schemeClr val="accent1"/>
+          </a:lnRef>
+          <a:fillRef idx="3">
+            <a:schemeClr val="accent1"/>
+          </a:fillRef>
+          <a:effectRef idx="2">
+            <a:schemeClr val="accent1"/>
+          </a:effectRef>
+          <a:fontRef idx="minor">
+            <a:schemeClr val="lt1"/>
+          </a:fontRef>
+        </p:style>
+        <p:txBody>
+          <a:bodyPr rtlCol="0" anchor="ctr" wrap="square" lIns="45720" rIns="45720" tIns="27432" bIns="27432"/>
+          <a:lstStyle/>
+          <a:p>
+            <a:pPr algn="ctr"/>
+            <a:r>
+              <a:rPr sz="1000" b="1">
+                <a:solidFill>
+                  <a:srgbClr val="FFFFFF"/>
+                </a:solidFill>
+                <a:latin typeface="맑은 고딕"/>
+                <a:ea typeface="맑은 고딕"/>
+              </a:rPr>
+              <a:t>상한 (★★/★★★) 환산</a:t>
+            </a:r>
+          </a:p>
+        </p:txBody>
+      </p:sp>
+      <p:sp>
+        <p:nvSpPr>
+          <p:cNvPr id="62" name="Rectangle 61"/>
+          <p:cNvSpPr/>
+          <p:nvPr/>
+        </p:nvSpPr>
+        <p:spPr>
+          <a:xfrm>
+            <a:off x="365760" y="1371600"/>
+            <a:ext cx="1188720" cy="566928"/>
+          </a:xfrm>
+          <a:prstGeom prst="rect">
+            <a:avLst/>
+          </a:prstGeom>
+          <a:solidFill>
+            <a:srgbClr val="DCE9F5"/>
+          </a:solidFill>
+          <a:ln w="9525">
+            <a:solidFill>
+              <a:srgbClr val="4D7EA8"/>
+            </a:solidFill>
+          </a:ln>
+          <a:effectLst/>
+        </p:spPr>
+        <p:style>
+          <a:lnRef idx="1">
+            <a:schemeClr val="accent1"/>
+          </a:lnRef>
+          <a:fillRef idx="3">
+            <a:schemeClr val="accent1"/>
+          </a:fillRef>
+          <a:effectRef idx="2">
+            <a:schemeClr val="accent1"/>
+          </a:effectRef>
+          <a:fontRef idx="minor">
+            <a:schemeClr val="lt1"/>
+          </a:fontRef>
+        </p:style>
+        <p:txBody>
+          <a:bodyPr rtlCol="0" anchor="ctr" wrap="square" lIns="45720" rIns="45720" tIns="27432" bIns="27432"/>
+          <a:lstStyle/>
+          <a:p>
+            <a:pPr algn="l"/>
+            <a:r>
+              <a:rPr sz="950" b="1">
+                <a:solidFill>
+                  <a:srgbClr val="1A1A1A"/>
+                </a:solidFill>
+                <a:latin typeface="맑은 고딕"/>
+                <a:ea typeface="맑은 고딕"/>
+              </a:rPr>
+              <a:t>QA1 처리량</a:t>
+            </a:r>
+          </a:p>
+        </p:txBody>
+      </p:sp>
+      <p:sp>
+        <p:nvSpPr>
+          <p:cNvPr id="63" name="Rectangle 62"/>
+          <p:cNvSpPr/>
+          <p:nvPr/>
+        </p:nvSpPr>
+        <p:spPr>
+          <a:xfrm>
+            <a:off x="1554480" y="1371600"/>
+            <a:ext cx="4206240" cy="566928"/>
+          </a:xfrm>
+          <a:prstGeom prst="rect">
+            <a:avLst/>
+          </a:prstGeom>
+          <a:solidFill>
+            <a:srgbClr val="FFFFFF"/>
+          </a:solidFill>
+          <a:ln w="9525">
+            <a:solidFill>
+              <a:srgbClr val="BFBFBF"/>
+            </a:solidFill>
+          </a:ln>
+          <a:effectLst/>
+        </p:spPr>
+        <p:style>
+          <a:lnRef idx="1">
+            <a:schemeClr val="accent1"/>
+          </a:lnRef>
+          <a:fillRef idx="3">
+            <a:schemeClr val="accent1"/>
+          </a:fillRef>
+          <a:effectRef idx="2">
+            <a:schemeClr val="accent1"/>
+          </a:effectRef>
+          <a:fontRef idx="minor">
+            <a:schemeClr val="lt1"/>
+          </a:fontRef>
+        </p:style>
+        <p:txBody>
+          <a:bodyPr rtlCol="0" anchor="ctr" wrap="square" lIns="45720" rIns="45720" tIns="27432" bIns="27432"/>
+          <a:lstStyle/>
+          <a:p>
+            <a:pPr algn="l"/>
+            <a:r>
+              <a:rPr sz="950" b="0">
+                <a:solidFill>
+                  <a:srgbClr val="1A1A1A"/>
+                </a:solidFill>
+                <a:latin typeface="맑은 고딕"/>
+                <a:ea typeface="맑은 고딕"/>
+              </a:rPr>
+              <a:t>잡음 범위 0.968 ~ 1.033 (sd 0.020, 20개 비교)</a:t>
+            </a:r>
+          </a:p>
+        </p:txBody>
+      </p:sp>
+      <p:sp>
+        <p:nvSpPr>
+          <p:cNvPr id="64" name="Rectangle 63"/>
+          <p:cNvSpPr/>
+          <p:nvPr/>
+        </p:nvSpPr>
+        <p:spPr>
+          <a:xfrm>
+            <a:off x="5760720" y="1371600"/>
+            <a:ext cx="1005840" cy="566928"/>
+          </a:xfrm>
+          <a:prstGeom prst="rect">
+            <a:avLst/>
+          </a:prstGeom>
+          <a:solidFill>
+            <a:srgbClr val="FFFFFF"/>
+          </a:solidFill>
+          <a:ln w="9525">
+            <a:solidFill>
+              <a:srgbClr val="BFBFBF"/>
+            </a:solidFill>
+          </a:ln>
+          <a:effectLst/>
+        </p:spPr>
+        <p:style>
+          <a:lnRef idx="1">
+            <a:schemeClr val="accent1"/>
+          </a:lnRef>
+          <a:fillRef idx="3">
+            <a:schemeClr val="accent1"/>
+          </a:fillRef>
+          <a:effectRef idx="2">
+            <a:schemeClr val="accent1"/>
+          </a:effectRef>
+          <a:fontRef idx="minor">
+            <a:schemeClr val="lt1"/>
+          </a:fontRef>
+        </p:style>
+        <p:txBody>
+          <a:bodyPr rtlCol="0" anchor="ctr" wrap="square" lIns="45720" rIns="45720" tIns="27432" bIns="27432"/>
+          <a:lstStyle/>
+          <a:p>
+            <a:pPr algn="ctr"/>
+            <a:r>
+              <a:rPr sz="950" b="1">
+                <a:solidFill>
+                  <a:srgbClr val="1A1A1A"/>
+                </a:solidFill>
+                <a:latin typeface="맑은 고딕"/>
+                <a:ea typeface="맑은 고딕"/>
+              </a:rPr>
+              <a:t>0.97</a:t>
+            </a:r>
+          </a:p>
+        </p:txBody>
+      </p:sp>
+      <p:sp>
+        <p:nvSpPr>
+          <p:cNvPr id="65" name="Rectangle 64"/>
+          <p:cNvSpPr/>
+          <p:nvPr/>
+        </p:nvSpPr>
+        <p:spPr>
+          <a:xfrm>
+            <a:off x="6766560" y="1371600"/>
+            <a:ext cx="5029200" cy="566928"/>
+          </a:xfrm>
+          <a:prstGeom prst="rect">
+            <a:avLst/>
+          </a:prstGeom>
+          <a:solidFill>
+            <a:srgbClr val="FFFFFF"/>
+          </a:solidFill>
+          <a:ln w="9525">
+            <a:solidFill>
+              <a:srgbClr val="BFBFBF"/>
+            </a:solidFill>
+          </a:ln>
+          <a:effectLst/>
+        </p:spPr>
+        <p:style>
+          <a:lnRef idx="1">
+            <a:schemeClr val="accent1"/>
+          </a:lnRef>
+          <a:fillRef idx="3">
+            <a:schemeClr val="accent1"/>
+          </a:fillRef>
+          <a:effectRef idx="2">
+            <a:schemeClr val="accent1"/>
+          </a:effectRef>
+          <a:fontRef idx="minor">
+            <a:schemeClr val="lt1"/>
+          </a:fontRef>
+        </p:style>
+        <p:txBody>
+          <a:bodyPr rtlCol="0" anchor="ctr" wrap="square" lIns="45720" rIns="45720" tIns="27432" bIns="27432"/>
+          <a:lstStyle/>
+          <a:p>
+            <a:pPr algn="l"/>
+            <a:r>
+              <a:rPr sz="900" b="0">
+                <a:solidFill>
+                  <a:srgbClr val="1A1A1A"/>
+                </a:solidFill>
+                <a:latin typeface="맑은 고딕"/>
+                <a:ea typeface="맑은 고딕"/>
+              </a:rPr>
+              <a:t>x1.30 = 23% 하드웨어 절감 = 8-GPU 노드에서 약 1.85 GPU (x1.14가 1 GPU)</a:t>
+            </a:r>
+          </a:p>
+        </p:txBody>
+      </p:sp>
+      <p:sp>
+        <p:nvSpPr>
+          <p:cNvPr id="66" name="Rectangle 65"/>
+          <p:cNvSpPr/>
+          <p:nvPr/>
+        </p:nvSpPr>
+        <p:spPr>
+          <a:xfrm>
+            <a:off x="365760" y="1975104"/>
+            <a:ext cx="1188720" cy="566928"/>
+          </a:xfrm>
+          <a:prstGeom prst="rect">
+            <a:avLst/>
+          </a:prstGeom>
+          <a:solidFill>
+            <a:srgbClr val="DCE9F5"/>
+          </a:solidFill>
+          <a:ln w="9525">
+            <a:solidFill>
+              <a:srgbClr val="4D7EA8"/>
+            </a:solidFill>
+          </a:ln>
+          <a:effectLst/>
+        </p:spPr>
+        <p:style>
+          <a:lnRef idx="1">
+            <a:schemeClr val="accent1"/>
+          </a:lnRef>
+          <a:fillRef idx="3">
+            <a:schemeClr val="accent1"/>
+          </a:fillRef>
+          <a:effectRef idx="2">
+            <a:schemeClr val="accent1"/>
+          </a:effectRef>
+          <a:fontRef idx="minor">
+            <a:schemeClr val="lt1"/>
+          </a:fontRef>
+        </p:style>
+        <p:txBody>
+          <a:bodyPr rtlCol="0" anchor="ctr" wrap="square" lIns="45720" rIns="45720" tIns="27432" bIns="27432"/>
+          <a:lstStyle/>
+          <a:p>
+            <a:pPr algn="l"/>
+            <a:r>
+              <a:rPr sz="950" b="1">
+                <a:solidFill>
+                  <a:srgbClr val="1A1A1A"/>
+                </a:solidFill>
+                <a:latin typeface="맑은 고딕"/>
+                <a:ea typeface="맑은 고딕"/>
+              </a:rPr>
+              <a:t>QA2 latency</a:t>
+            </a:r>
+          </a:p>
+        </p:txBody>
+      </p:sp>
+      <p:sp>
+        <p:nvSpPr>
+          <p:cNvPr id="67" name="Rectangle 66"/>
+          <p:cNvSpPr/>
+          <p:nvPr/>
+        </p:nvSpPr>
+        <p:spPr>
+          <a:xfrm>
+            <a:off x="1554480" y="1975104"/>
+            <a:ext cx="4206240" cy="566928"/>
+          </a:xfrm>
+          <a:prstGeom prst="rect">
+            <a:avLst/>
+          </a:prstGeom>
+          <a:solidFill>
+            <a:srgbClr val="FFFFFF"/>
+          </a:solidFill>
+          <a:ln w="9525">
+            <a:solidFill>
+              <a:srgbClr val="BFBFBF"/>
+            </a:solidFill>
+          </a:ln>
+          <a:effectLst/>
+        </p:spPr>
+        <p:style>
+          <a:lnRef idx="1">
+            <a:schemeClr val="accent1"/>
+          </a:lnRef>
+          <a:fillRef idx="3">
+            <a:schemeClr val="accent1"/>
+          </a:fillRef>
+          <a:effectRef idx="2">
+            <a:schemeClr val="accent1"/>
+          </a:effectRef>
+          <a:fontRef idx="minor">
+            <a:schemeClr val="lt1"/>
+          </a:fontRef>
+        </p:style>
+        <p:txBody>
+          <a:bodyPr rtlCol="0" anchor="ctr" wrap="square" lIns="45720" rIns="45720" tIns="27432" bIns="27432"/>
+          <a:lstStyle/>
+          <a:p>
+            <a:pPr algn="l"/>
+            <a:r>
+              <a:rPr sz="950" b="0">
+                <a:solidFill>
+                  <a:srgbClr val="1A1A1A"/>
+                </a:solidFill>
+                <a:latin typeface="맑은 고딕"/>
+                <a:ea typeface="맑은 고딕"/>
+              </a:rPr>
+              <a:t>잡음 범위 0.973 ~ 1.028 (sd 0.016, 20개 비교)</a:t>
+            </a:r>
+          </a:p>
+        </p:txBody>
+      </p:sp>
+      <p:sp>
+        <p:nvSpPr>
+          <p:cNvPr id="68" name="Rectangle 67"/>
+          <p:cNvSpPr/>
+          <p:nvPr/>
+        </p:nvSpPr>
+        <p:spPr>
+          <a:xfrm>
+            <a:off x="5760720" y="1975104"/>
+            <a:ext cx="1005840" cy="566928"/>
+          </a:xfrm>
+          <a:prstGeom prst="rect">
+            <a:avLst/>
+          </a:prstGeom>
+          <a:solidFill>
+            <a:srgbClr val="FFFFFF"/>
+          </a:solidFill>
+          <a:ln w="9525">
+            <a:solidFill>
+              <a:srgbClr val="BFBFBF"/>
+            </a:solidFill>
+          </a:ln>
+          <a:effectLst/>
+        </p:spPr>
+        <p:style>
+          <a:lnRef idx="1">
+            <a:schemeClr val="accent1"/>
+          </a:lnRef>
+          <a:fillRef idx="3">
+            <a:schemeClr val="accent1"/>
+          </a:fillRef>
+          <a:effectRef idx="2">
+            <a:schemeClr val="accent1"/>
+          </a:effectRef>
+          <a:fontRef idx="minor">
+            <a:schemeClr val="lt1"/>
+          </a:fontRef>
+        </p:style>
+        <p:txBody>
+          <a:bodyPr rtlCol="0" anchor="ctr" wrap="square" lIns="45720" rIns="45720" tIns="27432" bIns="27432"/>
+          <a:lstStyle/>
+          <a:p>
+            <a:pPr algn="ctr"/>
+            <a:r>
+              <a:rPr sz="950" b="1">
+                <a:solidFill>
+                  <a:srgbClr val="1A1A1A"/>
+                </a:solidFill>
+                <a:latin typeface="맑은 고딕"/>
+                <a:ea typeface="맑은 고딕"/>
+              </a:rPr>
+              <a:t>0.95</a:t>
+            </a:r>
+          </a:p>
+        </p:txBody>
+      </p:sp>
+      <p:sp>
+        <p:nvSpPr>
+          <p:cNvPr id="69" name="Rectangle 68"/>
+          <p:cNvSpPr/>
+          <p:nvPr/>
+        </p:nvSpPr>
+        <p:spPr>
+          <a:xfrm>
+            <a:off x="6766560" y="1975104"/>
+            <a:ext cx="5029200" cy="566928"/>
+          </a:xfrm>
+          <a:prstGeom prst="rect">
+            <a:avLst/>
+          </a:prstGeom>
+          <a:solidFill>
+            <a:srgbClr val="FFFFFF"/>
+          </a:solidFill>
+          <a:ln w="9525">
+            <a:solidFill>
+              <a:srgbClr val="BFBFBF"/>
+            </a:solidFill>
+          </a:ln>
+          <a:effectLst/>
+        </p:spPr>
+        <p:style>
+          <a:lnRef idx="1">
+            <a:schemeClr val="accent1"/>
+          </a:lnRef>
+          <a:fillRef idx="3">
+            <a:schemeClr val="accent1"/>
+          </a:fillRef>
+          <a:effectRef idx="2">
+            <a:schemeClr val="accent1"/>
+          </a:effectRef>
+          <a:fontRef idx="minor">
+            <a:schemeClr val="lt1"/>
+          </a:fontRef>
+        </p:style>
+        <p:txBody>
+          <a:bodyPr rtlCol="0" anchor="ctr" wrap="square" lIns="45720" rIns="45720" tIns="27432" bIns="27432"/>
+          <a:lstStyle/>
+          <a:p>
+            <a:pPr algn="l"/>
+            <a:r>
+              <a:rPr sz="900" b="0">
+                <a:solidFill>
+                  <a:srgbClr val="1A1A1A"/>
+                </a:solidFill>
+                <a:latin typeface="맑은 고딕"/>
+                <a:ea typeface="맑은 고딕"/>
+              </a:rPr>
+              <a:t>x1.25 = latency 20% 감소 (TTFT P99 1,084 -&gt; 867 ms, TPOT P99 17.1 -&gt; 13.7 ms)</a:t>
+            </a:r>
+          </a:p>
+        </p:txBody>
+      </p:sp>
+      <p:sp>
+        <p:nvSpPr>
+          <p:cNvPr id="70" name="Rectangle 69"/>
+          <p:cNvSpPr/>
+          <p:nvPr/>
+        </p:nvSpPr>
+        <p:spPr>
+          <a:xfrm>
+            <a:off x="365760" y="2578608"/>
+            <a:ext cx="1188720" cy="566928"/>
+          </a:xfrm>
+          <a:prstGeom prst="rect">
+            <a:avLst/>
+          </a:prstGeom>
+          <a:solidFill>
+            <a:srgbClr val="DCE9F5"/>
+          </a:solidFill>
+          <a:ln w="9525">
+            <a:solidFill>
+              <a:srgbClr val="4D7EA8"/>
+            </a:solidFill>
+          </a:ln>
+          <a:effectLst/>
+        </p:spPr>
+        <p:style>
+          <a:lnRef idx="1">
+            <a:schemeClr val="accent1"/>
+          </a:lnRef>
+          <a:fillRef idx="3">
+            <a:schemeClr val="accent1"/>
+          </a:fillRef>
+          <a:effectRef idx="2">
+            <a:schemeClr val="accent1"/>
+          </a:effectRef>
+          <a:fontRef idx="minor">
+            <a:schemeClr val="lt1"/>
+          </a:fontRef>
+        </p:style>
+        <p:txBody>
+          <a:bodyPr rtlCol="0" anchor="ctr" wrap="square" lIns="45720" rIns="45720" tIns="27432" bIns="27432"/>
+          <a:lstStyle/>
+          <a:p>
+            <a:pPr algn="l"/>
+            <a:r>
+              <a:rPr sz="950" b="1">
+                <a:solidFill>
+                  <a:srgbClr val="1A1A1A"/>
+                </a:solidFill>
+                <a:latin typeface="맑은 고딕"/>
+                <a:ea typeface="맑은 고딕"/>
+              </a:rPr>
+              <a:t>QA3 HBM 절감</a:t>
+            </a:r>
+          </a:p>
+        </p:txBody>
+      </p:sp>
+      <p:sp>
+        <p:nvSpPr>
+          <p:cNvPr id="71" name="Rectangle 70"/>
+          <p:cNvSpPr/>
+          <p:nvPr/>
+        </p:nvSpPr>
+        <p:spPr>
+          <a:xfrm>
+            <a:off x="1554480" y="2578608"/>
+            <a:ext cx="4206240" cy="566928"/>
+          </a:xfrm>
+          <a:prstGeom prst="rect">
+            <a:avLst/>
+          </a:prstGeom>
+          <a:solidFill>
+            <a:srgbClr val="FFFFFF"/>
+          </a:solidFill>
+          <a:ln w="9525">
+            <a:solidFill>
+              <a:srgbClr val="BFBFBF"/>
+            </a:solidFill>
+          </a:ln>
+          <a:effectLst/>
+        </p:spPr>
+        <p:style>
+          <a:lnRef idx="1">
+            <a:schemeClr val="accent1"/>
+          </a:lnRef>
+          <a:fillRef idx="3">
+            <a:schemeClr val="accent1"/>
+          </a:fillRef>
+          <a:effectRef idx="2">
+            <a:schemeClr val="accent1"/>
+          </a:effectRef>
+          <a:fontRef idx="minor">
+            <a:schemeClr val="lt1"/>
+          </a:fontRef>
+        </p:style>
+        <p:txBody>
+          <a:bodyPr rtlCol="0" anchor="ctr" wrap="square" lIns="45720" rIns="45720" tIns="27432" bIns="27432"/>
+          <a:lstStyle/>
+          <a:p>
+            <a:pPr algn="l"/>
+            <a:r>
+              <a:rPr sz="950" b="0">
+                <a:solidFill>
+                  <a:srgbClr val="1A1A1A"/>
+                </a:solidFill>
+                <a:latin typeface="맑은 고딕"/>
+                <a:ea typeface="맑은 고딕"/>
+              </a:rPr>
+              <a:t>잡음 범위 0.984 ~ 1.016 (sd 0.009, 20개 비교)</a:t>
+            </a:r>
+          </a:p>
+        </p:txBody>
+      </p:sp>
+      <p:sp>
+        <p:nvSpPr>
+          <p:cNvPr id="72" name="Rectangle 71"/>
+          <p:cNvSpPr/>
+          <p:nvPr/>
+        </p:nvSpPr>
+        <p:spPr>
+          <a:xfrm>
+            <a:off x="5760720" y="2578608"/>
+            <a:ext cx="1005840" cy="566928"/>
+          </a:xfrm>
+          <a:prstGeom prst="rect">
+            <a:avLst/>
+          </a:prstGeom>
+          <a:solidFill>
+            <a:srgbClr val="FFFFFF"/>
+          </a:solidFill>
+          <a:ln w="9525">
+            <a:solidFill>
+              <a:srgbClr val="BFBFBF"/>
+            </a:solidFill>
+          </a:ln>
+          <a:effectLst/>
+        </p:spPr>
+        <p:style>
+          <a:lnRef idx="1">
+            <a:schemeClr val="accent1"/>
+          </a:lnRef>
+          <a:fillRef idx="3">
+            <a:schemeClr val="accent1"/>
+          </a:fillRef>
+          <a:effectRef idx="2">
+            <a:schemeClr val="accent1"/>
+          </a:effectRef>
+          <a:fontRef idx="minor">
+            <a:schemeClr val="lt1"/>
+          </a:fontRef>
+        </p:style>
+        <p:txBody>
+          <a:bodyPr rtlCol="0" anchor="ctr" wrap="square" lIns="45720" rIns="45720" tIns="27432" bIns="27432"/>
+          <a:lstStyle/>
+          <a:p>
+            <a:pPr algn="ctr"/>
+            <a:r>
+              <a:rPr sz="950" b="1">
+                <a:solidFill>
+                  <a:srgbClr val="1A1A1A"/>
+                </a:solidFill>
+                <a:latin typeface="맑은 고딕"/>
+                <a:ea typeface="맑은 고딕"/>
+              </a:rPr>
+              <a:t>0.95</a:t>
+            </a:r>
+          </a:p>
+        </p:txBody>
+      </p:sp>
+      <p:sp>
+        <p:nvSpPr>
+          <p:cNvPr id="73" name="Rectangle 72"/>
+          <p:cNvSpPr/>
+          <p:nvPr/>
+        </p:nvSpPr>
+        <p:spPr>
+          <a:xfrm>
+            <a:off x="6766560" y="2578608"/>
+            <a:ext cx="5029200" cy="566928"/>
+          </a:xfrm>
+          <a:prstGeom prst="rect">
+            <a:avLst/>
+          </a:prstGeom>
+          <a:solidFill>
+            <a:srgbClr val="FFFFFF"/>
+          </a:solidFill>
+          <a:ln w="9525">
+            <a:solidFill>
+              <a:srgbClr val="BFBFBF"/>
+            </a:solidFill>
+          </a:ln>
+          <a:effectLst/>
+        </p:spPr>
+        <p:style>
+          <a:lnRef idx="1">
+            <a:schemeClr val="accent1"/>
+          </a:lnRef>
+          <a:fillRef idx="3">
+            <a:schemeClr val="accent1"/>
+          </a:fillRef>
+          <a:effectRef idx="2">
+            <a:schemeClr val="accent1"/>
+          </a:effectRef>
+          <a:fontRef idx="minor">
+            <a:schemeClr val="lt1"/>
+          </a:fontRef>
+        </p:style>
+        <p:txBody>
+          <a:bodyPr rtlCol="0" anchor="ctr" wrap="square" lIns="45720" rIns="45720" tIns="27432" bIns="27432"/>
+          <a:lstStyle/>
+          <a:p>
+            <a:pPr algn="l"/>
+            <a:r>
+              <a:rPr sz="900" b="0">
+                <a:solidFill>
+                  <a:srgbClr val="1A1A1A"/>
+                </a:solidFill>
+                <a:latin typeface="맑은 고딕"/>
+                <a:ea typeface="맑은 고딕"/>
+              </a:rPr>
+              <a:t>x1.25 = HBM 20% 감소 (146.6 GiB 중 약 29 GiB, 8K KV object 약 1.6개)</a:t>
+            </a:r>
+          </a:p>
+        </p:txBody>
+      </p:sp>
+      <p:sp>
+        <p:nvSpPr>
+          <p:cNvPr id="74" name="Rectangle 73"/>
+          <p:cNvSpPr/>
+          <p:nvPr/>
+        </p:nvSpPr>
+        <p:spPr>
+          <a:xfrm>
+            <a:off x="365760" y="3273552"/>
+            <a:ext cx="5669280" cy="2468880"/>
+          </a:xfrm>
+          <a:prstGeom prst="rect">
+            <a:avLst/>
+          </a:prstGeom>
+          <a:solidFill>
+            <a:srgbClr val="E3F1E3"/>
+          </a:solidFill>
+          <a:ln w="9525">
+            <a:solidFill>
+              <a:srgbClr val="5B9B5B"/>
+            </a:solidFill>
+          </a:ln>
+          <a:effectLst/>
+        </p:spPr>
+        <p:style>
+          <a:lnRef idx="1">
+            <a:schemeClr val="accent1"/>
+          </a:lnRef>
+          <a:fillRef idx="3">
+            <a:schemeClr val="accent1"/>
+          </a:fillRef>
+          <a:effectRef idx="2">
+            <a:schemeClr val="accent1"/>
+          </a:effectRef>
+          <a:fontRef idx="minor">
+            <a:schemeClr val="lt1"/>
+          </a:fontRef>
+        </p:style>
+        <p:txBody>
+          <a:bodyPr rtlCol="0" anchor="t" wrap="square" lIns="45720" rIns="45720" tIns="27432" bIns="27432"/>
+          <a:lstStyle/>
+          <a:p>
+            <a:pPr algn="l"/>
+            <a:r>
+              <a:rPr sz="950" b="1">
+                <a:solidFill>
+                  <a:srgbClr val="1A1A1A"/>
+                </a:solidFill>
+                <a:latin typeface="맑은 고딕"/>
+                <a:ea typeface="맑은 고딕"/>
+              </a:rPr>
+              <a:t>무엇이 근거 있고 무엇이 선택인가</a:t>
+            </a:r>
+          </a:p>
+          <a:p>
+            <a:pPr algn="l"/>
+            <a:r>
+              <a:rPr sz="950" b="0">
+                <a:solidFill>
+                  <a:srgbClr val="1A1A1A"/>
+                </a:solidFill>
+                <a:latin typeface="맑은 고딕"/>
+                <a:ea typeface="맑은 고딕"/>
+              </a:rPr>
+              <a:t>- 하한: QA1 0.97은 Baseline끼리 비교해도 나오는 잡음의 아래 끝과 같다(측정). QA2/QA3의 0.95는</a:t>
+            </a:r>
+          </a:p>
+          <a:p>
+            <a:pPr algn="l"/>
+            <a:r>
+              <a:rPr sz="950" b="0">
+                <a:solidFill>
+                  <a:srgbClr val="1A1A1A"/>
+                </a:solidFill>
+                <a:latin typeface="맑은 고딕"/>
+                <a:ea typeface="맑은 고딕"/>
+              </a:rPr>
+              <a:t>잡음(0.97/0.98)보다 느슨하지만 조여도 현재 별은 바뀌지 않는다.</a:t>
+            </a:r>
+          </a:p>
+          <a:p>
+            <a:pPr algn="l"/>
+            <a:r>
+              <a:rPr sz="950" b="0">
+                <a:solidFill>
+                  <a:srgbClr val="1A1A1A"/>
+                </a:solidFill>
+                <a:latin typeface="맑은 고딕"/>
+                <a:ea typeface="맑은 고딕"/>
+              </a:rPr>
+              <a:t>- 상한: 잡음(약 3%)으로는 정해지지 않는다. '도입 가치가 있는 크기'라는 정책 선택이며 위 환산으</a:t>
+            </a:r>
+          </a:p>
+          <a:p>
+            <a:pPr algn="l"/>
+            <a:r>
+              <a:rPr sz="950" b="0">
+                <a:solidFill>
+                  <a:srgbClr val="1A1A1A"/>
+                </a:solidFill>
+                <a:latin typeface="맑은 고딕"/>
+                <a:ea typeface="맑은 고딕"/>
+              </a:rPr>
+              <a:t>로 의미만 붙였다.</a:t>
+            </a:r>
+          </a:p>
+          <a:p>
+            <a:pPr algn="l"/>
+            <a:r>
+              <a:rPr sz="950" b="0">
+                <a:solidFill>
+                  <a:srgbClr val="1A1A1A"/>
+                </a:solidFill>
+                <a:latin typeface="맑은 고딕"/>
+                <a:ea typeface="맑은 고딕"/>
+              </a:rPr>
+              <a:t>- QA1 상한 1.30은 결과를 본 뒤 정한 값(defined_after_first_look)이고 1.25와 환산 차이가 작다(1.6 </a:t>
+            </a:r>
+          </a:p>
+          <a:p>
+            <a:pPr algn="l"/>
+            <a:r>
+              <a:rPr sz="950" b="0">
+                <a:solidFill>
+                  <a:srgbClr val="1A1A1A"/>
+                </a:solidFill>
+                <a:latin typeface="맑은 고딕"/>
+                <a:ea typeface="맑은 고딕"/>
+              </a:rPr>
+              <a:t>GPU 대 1.85 GPU).</a:t>
+            </a:r>
+          </a:p>
+        </p:txBody>
+      </p:sp>
+      <p:sp>
+        <p:nvSpPr>
+          <p:cNvPr id="75" name="Rectangle 74"/>
+          <p:cNvSpPr/>
+          <p:nvPr/>
+        </p:nvSpPr>
+        <p:spPr>
+          <a:xfrm>
+            <a:off x="6217920" y="3273552"/>
+            <a:ext cx="5577840" cy="2468880"/>
+          </a:xfrm>
+          <a:prstGeom prst="rect">
+            <a:avLst/>
+          </a:prstGeom>
+          <a:solidFill>
+            <a:srgbClr val="F2F2F2"/>
+          </a:solidFill>
+          <a:ln w="9525">
+            <a:solidFill>
+              <a:srgbClr val="BFBFBF"/>
+            </a:solidFill>
+          </a:ln>
+          <a:effectLst/>
+        </p:spPr>
+        <p:style>
+          <a:lnRef idx="1">
+            <a:schemeClr val="accent1"/>
+          </a:lnRef>
+          <a:fillRef idx="3">
+            <a:schemeClr val="accent1"/>
+          </a:fillRef>
+          <a:effectRef idx="2">
+            <a:schemeClr val="accent1"/>
+          </a:effectRef>
+          <a:fontRef idx="minor">
+            <a:schemeClr val="lt1"/>
+          </a:fontRef>
+        </p:style>
+        <p:txBody>
+          <a:bodyPr rtlCol="0" anchor="t" wrap="square" lIns="45720" rIns="45720" tIns="27432" bIns="27432"/>
+          <a:lstStyle/>
+          <a:p>
+            <a:pPr algn="l"/>
+            <a:r>
+              <a:rPr sz="950" b="1">
+                <a:solidFill>
+                  <a:srgbClr val="404040"/>
+                </a:solidFill>
+                <a:latin typeface="맑은 고딕"/>
+                <a:ea typeface="맑은 고딕"/>
+              </a:rPr>
+              <a:t>선택이 상한에 얼마나 민감한가 (상한을 QA1/2/3에 같게 적용)</a:t>
+            </a:r>
+          </a:p>
+          <a:p>
+            <a:pPr algn="l"/>
+            <a:r>
+              <a:rPr sz="950" b="0">
+                <a:solidFill>
+                  <a:srgbClr val="404040"/>
+                </a:solidFill>
+                <a:latin typeface="맑은 고딕"/>
+                <a:ea typeface="맑은 고딕"/>
+              </a:rPr>
+              <a:t>- 상한 1.10~1.25: C1 11점 대 C2 9점 -&gt; C1 선택</a:t>
+            </a:r>
+          </a:p>
+          <a:p>
+            <a:pPr algn="l"/>
+            <a:r>
+              <a:rPr sz="950" b="0">
+                <a:solidFill>
+                  <a:srgbClr val="404040"/>
+                </a:solidFill>
+                <a:latin typeface="맑은 고딕"/>
+                <a:ea typeface="맑은 고딕"/>
+              </a:rPr>
+              <a:t>- 상한 1.30~1.40: 둘 다 9점 동점, QA1 우선순위로 C2 선택</a:t>
+            </a:r>
+          </a:p>
+          <a:p>
+            <a:pPr algn="l"/>
+            <a:r>
+              <a:rPr sz="950" b="0">
+                <a:solidFill>
+                  <a:srgbClr val="404040"/>
+                </a:solidFill>
+                <a:latin typeface="맑은 고딕"/>
+                <a:ea typeface="맑은 고딕"/>
+              </a:rPr>
+              <a:t>- 상한 1.45 이상: C1 9점 대 C2 8점 이하 -&gt; C1 선택</a:t>
+            </a:r>
+          </a:p>
+          <a:p>
+            <a:pPr algn="l"/>
+            <a:r>
+              <a:rPr sz="950" b="0">
+                <a:solidFill>
+                  <a:srgbClr val="404040"/>
+                </a:solidFill>
+                <a:latin typeface="맑은 고딕"/>
+                <a:ea typeface="맑은 고딕"/>
+              </a:rPr>
+              <a:t>- 현재 공식 경계는 C1의 QA1(x1.298)과 0.2% 차이라 선택은 경계에 민감하다. 상한을 하드웨어 </a:t>
+            </a:r>
+          </a:p>
+          <a:p>
+            <a:pPr algn="l"/>
+            <a:r>
+              <a:rPr sz="950" b="0">
+                <a:solidFill>
+                  <a:srgbClr val="404040"/>
+                </a:solidFill>
+                <a:latin typeface="맑은 고딕"/>
+                <a:ea typeface="맑은 고딕"/>
+              </a:rPr>
+              <a:t>환산(예: 1 GPU = x1.14, 2 GPU = x1.33)으로 고정할지는 소유자 결정 사항이다. 근거 문서: qa-crit</a:t>
+            </a:r>
+          </a:p>
+          <a:p>
+            <a:pPr algn="l"/>
+            <a:r>
+              <a:rPr sz="950" b="0">
+                <a:solidFill>
+                  <a:srgbClr val="404040"/>
+                </a:solidFill>
+                <a:latin typeface="맑은 고딕"/>
+                <a:ea typeface="맑은 고딕"/>
+              </a:rPr>
+              <a:t>eria-dp1.md §J.</a:t>
+            </a:r>
+          </a:p>
+        </p:txBody>
+      </p:sp>
+    </p:spTree>
+  </p:cSld>
+  <p:clrMapOvr>
+    <a:masterClrMapping/>
+  </p:clrMapOvr>
+</p:sld>
+</file>
+
+<file path=ppt/slides/slide25.xml><?xml version="1.0" encoding="utf-8"?>
+<p:sld xmlns:a="http://schemas.openxmlformats.org/drawingml/2006/main" xmlns:p="http://schemas.openxmlformats.org/presentationml/2006/main" xmlns:r="http://schemas.openxmlformats.org/officeDocument/2006/relationships">
+  <p:cSld>
+    <p:spTree>
+      <p:nvGrpSpPr>
+        <p:cNvPr id="1" name=""/>
+        <p:cNvGrpSpPr/>
+        <p:nvPr/>
+      </p:nvGrpSpPr>
+      <p:grpSpPr/>
+      <p:sp>
+        <p:nvSpPr>
+          <p:cNvPr id="3" name="제목 2"/>
+          <p:cNvSpPr>
+            <a:spLocks noGrp="1"/>
+          </p:cNvSpPr>
+          <p:nvPr>
+            <p:ph type="title"/>
+          </p:nvPr>
+        </p:nvSpPr>
+        <p:spPr>
+          <a:xfrm>
+            <a:off x="234949" y="137379"/>
+            <a:ext cx="7631530" cy="365125"/>
+          </a:xfrm>
+        </p:spPr>
+        <p:txBody>
+          <a:bodyPr/>
+          <a:lstStyle/>
+          <a:p>
+            <a:r>
+              <a:rPr lang="en-US" altLang="ko-KR" dirty="0"/>
+              <a:t>DP1. 이기종 메모리 기반 Data Migration 구조 - Appendix</a:t>
+            </a:r>
+            <a:r>
+              <a:rPr lang="ko-KR" altLang="en-US" dirty="0"/>
+              <a:t/>
+            </a:r>
+            <a:r>
+              <a:rPr lang="en-US" altLang="ko-KR" dirty="0"/>
+              <a:t/>
+            </a:r>
+            <a:r>
+              <a:rPr lang="ko-KR" altLang="en-US" dirty="0"/>
+              <a:t/>
+            </a:r>
+            <a:r>
+              <a:rPr lang="en-US" altLang="ko-KR" dirty="0"/>
+              <a:t/>
+            </a:r>
+            <a:r>
+              <a:rPr lang="ko-KR" altLang="en-US" dirty="0"/>
+              <a:t/>
+            </a:r>
+          </a:p>
+        </p:txBody>
+      </p:sp>
+      <p:sp>
+        <p:nvSpPr>
+          <p:cNvPr id="5" name="직사각형 4"/>
+          <p:cNvSpPr/>
+          <p:nvPr/>
+        </p:nvSpPr>
+        <p:spPr>
+          <a:xfrm>
+            <a:off x="234949" y="596176"/>
+            <a:ext cx="11747501" cy="396603"/>
+          </a:xfrm>
+          <a:prstGeom prst="rect">
+            <a:avLst/>
+          </a:prstGeom>
+          <a:solidFill>
+            <a:schemeClr val="bg1">
+              <a:lumMod val="50000"/>
+            </a:schemeClr>
+          </a:solidFill>
+          <a:ln>
+            <a:noFill/>
+          </a:ln>
+        </p:spPr>
+        <p:style>
+          <a:lnRef idx="2">
+            <a:schemeClr val="accent1">
+              <a:shade val="50000"/>
+            </a:schemeClr>
+          </a:lnRef>
+          <a:fillRef idx="1">
+            <a:schemeClr val="accent1"/>
+          </a:fillRef>
+          <a:effectRef idx="0">
+            <a:schemeClr val="accent1"/>
+          </a:effectRef>
+          <a:fontRef idx="minor">
+            <a:schemeClr val="lt1"/>
+          </a:fontRef>
+        </p:style>
+        <p:txBody>
+          <a:bodyPr rtlCol="0" anchor="ctr"/>
+          <a:lstStyle/>
+          <a:p>
+            <a:pPr algn="ctr"/>
+            <a:endParaRPr lang="ko-KR" altLang="en-US"/>
+          </a:p>
+        </p:txBody>
+      </p:sp>
+      <p:sp>
+        <p:nvSpPr>
+          <p:cNvPr id="8" name="TextBox 7"/>
+          <p:cNvSpPr txBox="1"/>
+          <p:nvPr/>
+        </p:nvSpPr>
+        <p:spPr>
+          <a:xfrm>
+            <a:off x="469760" y="627926"/>
+            <a:ext cx="11430000" cy="307777"/>
+          </a:xfrm>
+          <a:prstGeom prst="rect">
+            <a:avLst/>
+          </a:prstGeom>
+          <a:noFill/>
+        </p:spPr>
+        <p:txBody>
+          <a:bodyPr wrap="square" rtlCol="0">
+            <a:spAutoFit/>
+          </a:bodyPr>
+          <a:lstStyle/>
+          <a:p>
+            <a:pPr lvl="0">
+              <a:defRPr/>
+            </a:pPr>
+            <a:r>
+              <a:rPr lang="ko-KR" altLang="en-US" sz="1400" b="1" dirty="0">
+                <a:solidFill>
+                  <a:schemeClr val="bg1"/>
+                </a:solidFill>
+              </a:rPr>
               <a:t>DP1 평가에서 고려한 시나리오</a:t>
             </a:r>
             <a:r>

</xml_diff>

<commit_message>
DP1: Oracle-ideal reference, QA1 capture-ratio star basis with literature (x=80%), result doc 4.10, PPT slide
Co-Authored-By: Claude Sonnet 5.5 <noreply@anthropic.com>
Claude-Session: https://claude.ai/code/session_018inK4pZJGzYwjdk7QAyZgn
</commit_message>
<xml_diff>
--- a/doc-mk/DP1/DP1-appendix-qa-result.pptx
+++ b/doc-mk/DP1/DP1-appendix-qa-result.pptx
@@ -16,6 +16,7 @@
     <p:sldId id="655" r:id="rId29"/>
     <p:sldId id="656" r:id="rId30"/>
     <p:sldId id="657" r:id="rId31"/>
+    <p:sldId id="658" r:id="rId32"/>
   </p:sldIdLst>
   <p:sldSz cx="12192000" cy="6858000"/>
   <p:notesSz cx="6858000" cy="9144000"/>
@@ -17361,6 +17362,1577 @@
                   <a:schemeClr val="bg1"/>
                 </a:solidFill>
               </a:rPr>
+              <a:t>QA1 별 기준의 문헌 근거 - Oracle 대비 이득 달성률</a:t>
+            </a:r>
+            <a:r>
+              <a:rPr lang="en-US" altLang="ko-KR" sz="1400" b="1" dirty="0">
+                <a:solidFill>
+                  <a:schemeClr val="bg1"/>
+                </a:solidFill>
+              </a:rPr>
+              <a:t/>
+            </a:r>
+            <a:r>
+              <a:rPr lang="ko-KR" altLang="en-US" sz="1400" b="1" dirty="0">
+                <a:solidFill>
+                  <a:schemeClr val="bg1"/>
+                </a:solidFill>
+              </a:rPr>
+              <a:t/>
+            </a:r>
+            <a:r>
+              <a:rPr lang="en-US" altLang="ko-KR" sz="1400" b="1" dirty="0">
+                <a:solidFill>
+                  <a:schemeClr val="bg1"/>
+                </a:solidFill>
+              </a:rPr>
+              <a:t/>
+            </a:r>
+            <a:r>
+              <a:rPr lang="ko-KR" altLang="en-US" sz="1400" b="1" dirty="0">
+                <a:solidFill>
+                  <a:schemeClr val="bg1"/>
+                </a:solidFill>
+              </a:rPr>
+              <a:t/>
+            </a:r>
+          </a:p>
+        </p:txBody>
+      </p:sp>
+      <p:sp>
+        <p:nvSpPr>
+          <p:cNvPr id="39" name="직사각형 38"/>
+          <p:cNvSpPr/>
+          <p:nvPr/>
+        </p:nvSpPr>
+        <p:spPr>
+          <a:xfrm>
+            <a:off x="403086" y="678726"/>
+            <a:ext cx="66675" cy="216270"/>
+          </a:xfrm>
+          <a:prstGeom prst="rect">
+            <a:avLst/>
+          </a:prstGeom>
+          <a:solidFill>
+            <a:schemeClr val="bg1"/>
+          </a:solidFill>
+          <a:ln w="19050">
+            <a:noFill/>
+          </a:ln>
+        </p:spPr>
+        <p:style>
+          <a:lnRef idx="2">
+            <a:schemeClr val="accent1">
+              <a:shade val="50000"/>
+            </a:schemeClr>
+          </a:lnRef>
+          <a:fillRef idx="1">
+            <a:schemeClr val="accent1"/>
+          </a:fillRef>
+          <a:effectRef idx="0">
+            <a:schemeClr val="accent1"/>
+          </a:effectRef>
+          <a:fontRef idx="minor">
+            <a:schemeClr val="lt1"/>
+          </a:fontRef>
+        </p:style>
+        <p:txBody>
+          <a:bodyPr rtlCol="0" anchor="ctr"/>
+          <a:lstStyle/>
+          <a:p>
+            <a:pPr algn="ctr"/>
+            <a:endParaRPr lang="ko-KR" altLang="en-US" sz="1600"/>
+          </a:p>
+        </p:txBody>
+      </p:sp>
+      <p:sp>
+        <p:nvSpPr>
+          <p:cNvPr id="57" name="슬라이드 번호 개체 틀 1"/>
+          <p:cNvSpPr>
+            <a:spLocks noGrp="1"/>
+          </p:cNvSpPr>
+          <p:nvPr>
+            <p:ph type="sldNum" sz="quarter" idx="4"/>
+          </p:nvPr>
+        </p:nvSpPr>
+        <p:spPr>
+          <a:xfrm>
+            <a:off x="5620080" y="6597650"/>
+            <a:ext cx="456466" cy="209550"/>
+          </a:xfrm>
+        </p:spPr>
+        <p:txBody>
+          <a:bodyPr/>
+          <a:lstStyle/>
+          <a:p>
+            <a:fld id="{7F889C64-266A-4D07-AD8F-5B592E61CCE1}" type="slidenum">
+              <a:rPr lang="ko-KR" altLang="en-US" smtClean="0"/>
+              <a:pPr/>
+              <a:t>9</a:t>
+            </a:fld>
+            <a:endParaRPr lang="ko-KR" altLang="en-US" dirty="0"/>
+          </a:p>
+        </p:txBody>
+      </p:sp>
+      <p:sp>
+        <p:nvSpPr>
+          <p:cNvPr id="58" name="Rectangle 57"/>
+          <p:cNvSpPr/>
+          <p:nvPr/>
+        </p:nvSpPr>
+        <p:spPr>
+          <a:xfrm>
+            <a:off x="365760" y="1051560"/>
+            <a:ext cx="1463040" cy="292608"/>
+          </a:xfrm>
+          <a:prstGeom prst="rect">
+            <a:avLst/>
+          </a:prstGeom>
+          <a:solidFill>
+            <a:srgbClr val="1F4E79"/>
+          </a:solidFill>
+          <a:ln w="9525">
+            <a:solidFill>
+              <a:srgbClr val="1F4E79"/>
+            </a:solidFill>
+          </a:ln>
+          <a:effectLst/>
+        </p:spPr>
+        <p:style>
+          <a:lnRef idx="1">
+            <a:schemeClr val="accent1"/>
+          </a:lnRef>
+          <a:fillRef idx="3">
+            <a:schemeClr val="accent1"/>
+          </a:fillRef>
+          <a:effectRef idx="2">
+            <a:schemeClr val="accent1"/>
+          </a:effectRef>
+          <a:fontRef idx="minor">
+            <a:schemeClr val="lt1"/>
+          </a:fontRef>
+        </p:style>
+        <p:txBody>
+          <a:bodyPr rtlCol="0" anchor="ctr" wrap="square" lIns="45720" rIns="45720" tIns="27432" bIns="27432"/>
+          <a:lstStyle/>
+          <a:p>
+            <a:pPr algn="ctr"/>
+            <a:r>
+              <a:rPr sz="1000" b="1">
+                <a:solidFill>
+                  <a:srgbClr val="FFFFFF"/>
+                </a:solidFill>
+                <a:latin typeface="맑은 고딕"/>
+                <a:ea typeface="맑은 고딕"/>
+              </a:rPr>
+              <a:t>후보</a:t>
+            </a:r>
+          </a:p>
+        </p:txBody>
+      </p:sp>
+      <p:sp>
+        <p:nvSpPr>
+          <p:cNvPr id="59" name="Rectangle 58"/>
+          <p:cNvSpPr/>
+          <p:nvPr/>
+        </p:nvSpPr>
+        <p:spPr>
+          <a:xfrm>
+            <a:off x="1828800" y="1051560"/>
+            <a:ext cx="2011680" cy="292608"/>
+          </a:xfrm>
+          <a:prstGeom prst="rect">
+            <a:avLst/>
+          </a:prstGeom>
+          <a:solidFill>
+            <a:srgbClr val="1F4E79"/>
+          </a:solidFill>
+          <a:ln w="9525">
+            <a:solidFill>
+              <a:srgbClr val="1F4E79"/>
+            </a:solidFill>
+          </a:ln>
+          <a:effectLst/>
+        </p:spPr>
+        <p:style>
+          <a:lnRef idx="1">
+            <a:schemeClr val="accent1"/>
+          </a:lnRef>
+          <a:fillRef idx="3">
+            <a:schemeClr val="accent1"/>
+          </a:fillRef>
+          <a:effectRef idx="2">
+            <a:schemeClr val="accent1"/>
+          </a:effectRef>
+          <a:fontRef idx="minor">
+            <a:schemeClr val="lt1"/>
+          </a:fontRef>
+        </p:style>
+        <p:txBody>
+          <a:bodyPr rtlCol="0" anchor="ctr" wrap="square" lIns="45720" rIns="45720" tIns="27432" bIns="27432"/>
+          <a:lstStyle/>
+          <a:p>
+            <a:pPr algn="ctr"/>
+            <a:r>
+              <a:rPr sz="1000" b="1">
+                <a:solidFill>
+                  <a:srgbClr val="FFFFFF"/>
+                </a:solidFill>
+                <a:latin typeface="맑은 고딕"/>
+                <a:ea typeface="맑은 고딕"/>
+              </a:rPr>
+              <a:t>pooled 달성률</a:t>
+            </a:r>
+          </a:p>
+        </p:txBody>
+      </p:sp>
+      <p:sp>
+        <p:nvSpPr>
+          <p:cNvPr id="60" name="Rectangle 59"/>
+          <p:cNvSpPr/>
+          <p:nvPr/>
+        </p:nvSpPr>
+        <p:spPr>
+          <a:xfrm>
+            <a:off x="3840480" y="1051560"/>
+            <a:ext cx="1828800" cy="292608"/>
+          </a:xfrm>
+          <a:prstGeom prst="rect">
+            <a:avLst/>
+          </a:prstGeom>
+          <a:solidFill>
+            <a:srgbClr val="1F4E79"/>
+          </a:solidFill>
+          <a:ln w="9525">
+            <a:solidFill>
+              <a:srgbClr val="1F4E79"/>
+            </a:solidFill>
+          </a:ln>
+          <a:effectLst/>
+        </p:spPr>
+        <p:style>
+          <a:lnRef idx="1">
+            <a:schemeClr val="accent1"/>
+          </a:lnRef>
+          <a:fillRef idx="3">
+            <a:schemeClr val="accent1"/>
+          </a:fillRef>
+          <a:effectRef idx="2">
+            <a:schemeClr val="accent1"/>
+          </a:effectRef>
+          <a:fontRef idx="minor">
+            <a:schemeClr val="lt1"/>
+          </a:fontRef>
+        </p:style>
+        <p:txBody>
+          <a:bodyPr rtlCol="0" anchor="ctr" wrap="square" lIns="45720" rIns="45720" tIns="27432" bIns="27432"/>
+          <a:lstStyle/>
+          <a:p>
+            <a:pPr algn="ctr"/>
+            <a:r>
+              <a:rPr sz="1000" b="1">
+                <a:solidFill>
+                  <a:srgbClr val="FFFFFF"/>
+                </a:solidFill>
+                <a:latin typeface="맑은 고딕"/>
+                <a:ea typeface="맑은 고딕"/>
+              </a:rPr>
+              <a:t>쌍별 평균</a:t>
+            </a:r>
+          </a:p>
+        </p:txBody>
+      </p:sp>
+      <p:sp>
+        <p:nvSpPr>
+          <p:cNvPr id="61" name="Rectangle 60"/>
+          <p:cNvSpPr/>
+          <p:nvPr/>
+        </p:nvSpPr>
+        <p:spPr>
+          <a:xfrm>
+            <a:off x="5669280" y="1051560"/>
+            <a:ext cx="1828800" cy="292608"/>
+          </a:xfrm>
+          <a:prstGeom prst="rect">
+            <a:avLst/>
+          </a:prstGeom>
+          <a:solidFill>
+            <a:srgbClr val="1F4E79"/>
+          </a:solidFill>
+          <a:ln w="9525">
+            <a:solidFill>
+              <a:srgbClr val="1F4E79"/>
+            </a:solidFill>
+          </a:ln>
+          <a:effectLst/>
+        </p:spPr>
+        <p:style>
+          <a:lnRef idx="1">
+            <a:schemeClr val="accent1"/>
+          </a:lnRef>
+          <a:fillRef idx="3">
+            <a:schemeClr val="accent1"/>
+          </a:fillRef>
+          <a:effectRef idx="2">
+            <a:schemeClr val="accent1"/>
+          </a:effectRef>
+          <a:fontRef idx="minor">
+            <a:schemeClr val="lt1"/>
+          </a:fontRef>
+        </p:style>
+        <p:txBody>
+          <a:bodyPr rtlCol="0" anchor="ctr" wrap="square" lIns="45720" rIns="45720" tIns="27432" bIns="27432"/>
+          <a:lstStyle/>
+          <a:p>
+            <a:pPr algn="ctr"/>
+            <a:r>
+              <a:rPr sz="1000" b="1">
+                <a:solidFill>
+                  <a:srgbClr val="FFFFFF"/>
+                </a:solidFill>
+                <a:latin typeface="맑은 고딕"/>
+                <a:ea typeface="맑은 고딕"/>
+              </a:rPr>
+              <a:t>Oracle 초과 쌍</a:t>
+            </a:r>
+          </a:p>
+        </p:txBody>
+      </p:sp>
+      <p:sp>
+        <p:nvSpPr>
+          <p:cNvPr id="62" name="Rectangle 61"/>
+          <p:cNvSpPr/>
+          <p:nvPr/>
+        </p:nvSpPr>
+        <p:spPr>
+          <a:xfrm>
+            <a:off x="7498079" y="1051560"/>
+            <a:ext cx="2011680" cy="292608"/>
+          </a:xfrm>
+          <a:prstGeom prst="rect">
+            <a:avLst/>
+          </a:prstGeom>
+          <a:solidFill>
+            <a:srgbClr val="1F4E79"/>
+          </a:solidFill>
+          <a:ln w="9525">
+            <a:solidFill>
+              <a:srgbClr val="1F4E79"/>
+            </a:solidFill>
+          </a:ln>
+          <a:effectLst/>
+        </p:spPr>
+        <p:style>
+          <a:lnRef idx="1">
+            <a:schemeClr val="accent1"/>
+          </a:lnRef>
+          <a:fillRef idx="3">
+            <a:schemeClr val="accent1"/>
+          </a:fillRef>
+          <a:effectRef idx="2">
+            <a:schemeClr val="accent1"/>
+          </a:effectRef>
+          <a:fontRef idx="minor">
+            <a:schemeClr val="lt1"/>
+          </a:fontRef>
+        </p:style>
+        <p:txBody>
+          <a:bodyPr rtlCol="0" anchor="ctr" wrap="square" lIns="45720" rIns="45720" tIns="27432" bIns="27432"/>
+          <a:lstStyle/>
+          <a:p>
+            <a:pPr algn="ctr"/>
+            <a:r>
+              <a:rPr sz="1000" b="1">
+                <a:solidFill>
+                  <a:srgbClr val="FFFFFF"/>
+                </a:solidFill>
+                <a:latin typeface="맑은 고딕"/>
+                <a:ea typeface="맑은 고딕"/>
+              </a:rPr>
+              <a:t>QA1 별 (x = 80%)</a:t>
+            </a:r>
+          </a:p>
+        </p:txBody>
+      </p:sp>
+      <p:sp>
+        <p:nvSpPr>
+          <p:cNvPr id="63" name="Rectangle 62"/>
+          <p:cNvSpPr/>
+          <p:nvPr/>
+        </p:nvSpPr>
+        <p:spPr>
+          <a:xfrm>
+            <a:off x="9509760" y="1051560"/>
+            <a:ext cx="2286000" cy="292608"/>
+          </a:xfrm>
+          <a:prstGeom prst="rect">
+            <a:avLst/>
+          </a:prstGeom>
+          <a:solidFill>
+            <a:srgbClr val="1F4E79"/>
+          </a:solidFill>
+          <a:ln w="9525">
+            <a:solidFill>
+              <a:srgbClr val="1F4E79"/>
+            </a:solidFill>
+          </a:ln>
+          <a:effectLst/>
+        </p:spPr>
+        <p:style>
+          <a:lnRef idx="1">
+            <a:schemeClr val="accent1"/>
+          </a:lnRef>
+          <a:fillRef idx="3">
+            <a:schemeClr val="accent1"/>
+          </a:fillRef>
+          <a:effectRef idx="2">
+            <a:schemeClr val="accent1"/>
+          </a:effectRef>
+          <a:fontRef idx="minor">
+            <a:schemeClr val="lt1"/>
+          </a:fontRef>
+        </p:style>
+        <p:txBody>
+          <a:bodyPr rtlCol="0" anchor="ctr" wrap="square" lIns="45720" rIns="45720" tIns="27432" bIns="27432"/>
+          <a:lstStyle/>
+          <a:p>
+            <a:pPr algn="ctr"/>
+            <a:r>
+              <a:rPr sz="1000" b="1">
+                <a:solidFill>
+                  <a:srgbClr val="FFFFFF"/>
+                </a:solidFill>
+                <a:latin typeface="맑은 고딕"/>
+                <a:ea typeface="맑은 고딕"/>
+              </a:rPr>
+              <a:t>현재 공식 별</a:t>
+            </a:r>
+          </a:p>
+        </p:txBody>
+      </p:sp>
+      <p:sp>
+        <p:nvSpPr>
+          <p:cNvPr id="64" name="Rectangle 63"/>
+          <p:cNvSpPr/>
+          <p:nvPr/>
+        </p:nvSpPr>
+        <p:spPr>
+          <a:xfrm>
+            <a:off x="365760" y="1371600"/>
+            <a:ext cx="1463040" cy="365760"/>
+          </a:xfrm>
+          <a:prstGeom prst="rect">
+            <a:avLst/>
+          </a:prstGeom>
+          <a:solidFill>
+            <a:srgbClr val="FFFFFF"/>
+          </a:solidFill>
+          <a:ln w="9525">
+            <a:solidFill>
+              <a:srgbClr val="BFBFBF"/>
+            </a:solidFill>
+          </a:ln>
+          <a:effectLst/>
+        </p:spPr>
+        <p:style>
+          <a:lnRef idx="1">
+            <a:schemeClr val="accent1"/>
+          </a:lnRef>
+          <a:fillRef idx="3">
+            <a:schemeClr val="accent1"/>
+          </a:fillRef>
+          <a:effectRef idx="2">
+            <a:schemeClr val="accent1"/>
+          </a:effectRef>
+          <a:fontRef idx="minor">
+            <a:schemeClr val="lt1"/>
+          </a:fontRef>
+        </p:style>
+        <p:txBody>
+          <a:bodyPr rtlCol="0" anchor="ctr" wrap="square" lIns="45720" rIns="45720" tIns="27432" bIns="27432"/>
+          <a:lstStyle/>
+          <a:p>
+            <a:pPr algn="ctr"/>
+            <a:r>
+              <a:rPr sz="950" b="1">
+                <a:solidFill>
+                  <a:srgbClr val="1A1A1A"/>
+                </a:solidFill>
+                <a:latin typeface="맑은 고딕"/>
+                <a:ea typeface="맑은 고딕"/>
+              </a:rPr>
+              <a:t>C1</a:t>
+            </a:r>
+          </a:p>
+        </p:txBody>
+      </p:sp>
+      <p:sp>
+        <p:nvSpPr>
+          <p:cNvPr id="65" name="Rectangle 64"/>
+          <p:cNvSpPr/>
+          <p:nvPr/>
+        </p:nvSpPr>
+        <p:spPr>
+          <a:xfrm>
+            <a:off x="1828800" y="1371600"/>
+            <a:ext cx="2011680" cy="365760"/>
+          </a:xfrm>
+          <a:prstGeom prst="rect">
+            <a:avLst/>
+          </a:prstGeom>
+          <a:solidFill>
+            <a:srgbClr val="FFFFFF"/>
+          </a:solidFill>
+          <a:ln w="9525">
+            <a:solidFill>
+              <a:srgbClr val="BFBFBF"/>
+            </a:solidFill>
+          </a:ln>
+          <a:effectLst/>
+        </p:spPr>
+        <p:style>
+          <a:lnRef idx="1">
+            <a:schemeClr val="accent1"/>
+          </a:lnRef>
+          <a:fillRef idx="3">
+            <a:schemeClr val="accent1"/>
+          </a:fillRef>
+          <a:effectRef idx="2">
+            <a:schemeClr val="accent1"/>
+          </a:effectRef>
+          <a:fontRef idx="minor">
+            <a:schemeClr val="lt1"/>
+          </a:fontRef>
+        </p:style>
+        <p:txBody>
+          <a:bodyPr rtlCol="0" anchor="ctr" wrap="square" lIns="45720" rIns="45720" tIns="27432" bIns="27432"/>
+          <a:lstStyle/>
+          <a:p>
+            <a:pPr algn="ctr"/>
+            <a:r>
+              <a:rPr sz="950" b="0">
+                <a:solidFill>
+                  <a:srgbClr val="1A1A1A"/>
+                </a:solidFill>
+                <a:latin typeface="맑은 고딕"/>
+                <a:ea typeface="맑은 고딕"/>
+              </a:rPr>
+              <a:t>0.62</a:t>
+            </a:r>
+          </a:p>
+        </p:txBody>
+      </p:sp>
+      <p:sp>
+        <p:nvSpPr>
+          <p:cNvPr id="66" name="Rectangle 65"/>
+          <p:cNvSpPr/>
+          <p:nvPr/>
+        </p:nvSpPr>
+        <p:spPr>
+          <a:xfrm>
+            <a:off x="3840480" y="1371600"/>
+            <a:ext cx="1828800" cy="365760"/>
+          </a:xfrm>
+          <a:prstGeom prst="rect">
+            <a:avLst/>
+          </a:prstGeom>
+          <a:solidFill>
+            <a:srgbClr val="FFFFFF"/>
+          </a:solidFill>
+          <a:ln w="9525">
+            <a:solidFill>
+              <a:srgbClr val="BFBFBF"/>
+            </a:solidFill>
+          </a:ln>
+          <a:effectLst/>
+        </p:spPr>
+        <p:style>
+          <a:lnRef idx="1">
+            <a:schemeClr val="accent1"/>
+          </a:lnRef>
+          <a:fillRef idx="3">
+            <a:schemeClr val="accent1"/>
+          </a:fillRef>
+          <a:effectRef idx="2">
+            <a:schemeClr val="accent1"/>
+          </a:effectRef>
+          <a:fontRef idx="minor">
+            <a:schemeClr val="lt1"/>
+          </a:fontRef>
+        </p:style>
+        <p:txBody>
+          <a:bodyPr rtlCol="0" anchor="ctr" wrap="square" lIns="45720" rIns="45720" tIns="27432" bIns="27432"/>
+          <a:lstStyle/>
+          <a:p>
+            <a:pPr algn="ctr"/>
+            <a:r>
+              <a:rPr sz="950" b="0">
+                <a:solidFill>
+                  <a:srgbClr val="1A1A1A"/>
+                </a:solidFill>
+                <a:latin typeface="맑은 고딕"/>
+                <a:ea typeface="맑은 고딕"/>
+              </a:rPr>
+              <a:t>0.59</a:t>
+            </a:r>
+          </a:p>
+        </p:txBody>
+      </p:sp>
+      <p:sp>
+        <p:nvSpPr>
+          <p:cNvPr id="67" name="Rectangle 66"/>
+          <p:cNvSpPr/>
+          <p:nvPr/>
+        </p:nvSpPr>
+        <p:spPr>
+          <a:xfrm>
+            <a:off x="5669280" y="1371600"/>
+            <a:ext cx="1828800" cy="365760"/>
+          </a:xfrm>
+          <a:prstGeom prst="rect">
+            <a:avLst/>
+          </a:prstGeom>
+          <a:solidFill>
+            <a:srgbClr val="FFFFFF"/>
+          </a:solidFill>
+          <a:ln w="9525">
+            <a:solidFill>
+              <a:srgbClr val="BFBFBF"/>
+            </a:solidFill>
+          </a:ln>
+          <a:effectLst/>
+        </p:spPr>
+        <p:style>
+          <a:lnRef idx="1">
+            <a:schemeClr val="accent1"/>
+          </a:lnRef>
+          <a:fillRef idx="3">
+            <a:schemeClr val="accent1"/>
+          </a:fillRef>
+          <a:effectRef idx="2">
+            <a:schemeClr val="accent1"/>
+          </a:effectRef>
+          <a:fontRef idx="minor">
+            <a:schemeClr val="lt1"/>
+          </a:fontRef>
+        </p:style>
+        <p:txBody>
+          <a:bodyPr rtlCol="0" anchor="ctr" wrap="square" lIns="45720" rIns="45720" tIns="27432" bIns="27432"/>
+          <a:lstStyle/>
+          <a:p>
+            <a:pPr algn="ctr"/>
+            <a:r>
+              <a:rPr sz="950" b="0">
+                <a:solidFill>
+                  <a:srgbClr val="1A1A1A"/>
+                </a:solidFill>
+                <a:latin typeface="맑은 고딕"/>
+                <a:ea typeface="맑은 고딕"/>
+              </a:rPr>
+              <a:t>0</a:t>
+            </a:r>
+          </a:p>
+        </p:txBody>
+      </p:sp>
+      <p:sp>
+        <p:nvSpPr>
+          <p:cNvPr id="68" name="Rectangle 67"/>
+          <p:cNvSpPr/>
+          <p:nvPr/>
+        </p:nvSpPr>
+        <p:spPr>
+          <a:xfrm>
+            <a:off x="7498079" y="1371600"/>
+            <a:ext cx="2011680" cy="365760"/>
+          </a:xfrm>
+          <a:prstGeom prst="rect">
+            <a:avLst/>
+          </a:prstGeom>
+          <a:solidFill>
+            <a:srgbClr val="FFFFFF"/>
+          </a:solidFill>
+          <a:ln w="9525">
+            <a:solidFill>
+              <a:srgbClr val="BFBFBF"/>
+            </a:solidFill>
+          </a:ln>
+          <a:effectLst/>
+        </p:spPr>
+        <p:style>
+          <a:lnRef idx="1">
+            <a:schemeClr val="accent1"/>
+          </a:lnRef>
+          <a:fillRef idx="3">
+            <a:schemeClr val="accent1"/>
+          </a:fillRef>
+          <a:effectRef idx="2">
+            <a:schemeClr val="accent1"/>
+          </a:effectRef>
+          <a:fontRef idx="minor">
+            <a:schemeClr val="lt1"/>
+          </a:fontRef>
+        </p:style>
+        <p:txBody>
+          <a:bodyPr rtlCol="0" anchor="ctr" wrap="square" lIns="45720" rIns="45720" tIns="27432" bIns="27432"/>
+          <a:lstStyle/>
+          <a:p>
+            <a:pPr algn="ctr"/>
+            <a:r>
+              <a:rPr sz="950" b="1">
+                <a:solidFill>
+                  <a:srgbClr val="1A1A1A"/>
+                </a:solidFill>
+                <a:latin typeface="맑은 고딕"/>
+                <a:ea typeface="맑은 고딕"/>
+              </a:rPr>
+              <a:t>★★</a:t>
+            </a:r>
+          </a:p>
+        </p:txBody>
+      </p:sp>
+      <p:sp>
+        <p:nvSpPr>
+          <p:cNvPr id="69" name="Rectangle 68"/>
+          <p:cNvSpPr/>
+          <p:nvPr/>
+        </p:nvSpPr>
+        <p:spPr>
+          <a:xfrm>
+            <a:off x="9509760" y="1371600"/>
+            <a:ext cx="2286000" cy="365760"/>
+          </a:xfrm>
+          <a:prstGeom prst="rect">
+            <a:avLst/>
+          </a:prstGeom>
+          <a:solidFill>
+            <a:srgbClr val="FFFFFF"/>
+          </a:solidFill>
+          <a:ln w="9525">
+            <a:solidFill>
+              <a:srgbClr val="BFBFBF"/>
+            </a:solidFill>
+          </a:ln>
+          <a:effectLst/>
+        </p:spPr>
+        <p:style>
+          <a:lnRef idx="1">
+            <a:schemeClr val="accent1"/>
+          </a:lnRef>
+          <a:fillRef idx="3">
+            <a:schemeClr val="accent1"/>
+          </a:fillRef>
+          <a:effectRef idx="2">
+            <a:schemeClr val="accent1"/>
+          </a:effectRef>
+          <a:fontRef idx="minor">
+            <a:schemeClr val="lt1"/>
+          </a:fontRef>
+        </p:style>
+        <p:txBody>
+          <a:bodyPr rtlCol="0" anchor="ctr" wrap="square" lIns="45720" rIns="45720" tIns="27432" bIns="27432"/>
+          <a:lstStyle/>
+          <a:p>
+            <a:pPr algn="ctr"/>
+            <a:r>
+              <a:rPr sz="950" b="0">
+                <a:solidFill>
+                  <a:srgbClr val="1A1A1A"/>
+                </a:solidFill>
+                <a:latin typeface="맑은 고딕"/>
+                <a:ea typeface="맑은 고딕"/>
+              </a:rPr>
+              <a:t>★★ (x1.298)</a:t>
+            </a:r>
+          </a:p>
+        </p:txBody>
+      </p:sp>
+      <p:sp>
+        <p:nvSpPr>
+          <p:cNvPr id="70" name="Rectangle 69"/>
+          <p:cNvSpPr/>
+          <p:nvPr/>
+        </p:nvSpPr>
+        <p:spPr>
+          <a:xfrm>
+            <a:off x="365760" y="1755648"/>
+            <a:ext cx="1463040" cy="365760"/>
+          </a:xfrm>
+          <a:prstGeom prst="rect">
+            <a:avLst/>
+          </a:prstGeom>
+          <a:solidFill>
+            <a:srgbClr val="FFFFFF"/>
+          </a:solidFill>
+          <a:ln w="9525">
+            <a:solidFill>
+              <a:srgbClr val="BFBFBF"/>
+            </a:solidFill>
+          </a:ln>
+          <a:effectLst/>
+        </p:spPr>
+        <p:style>
+          <a:lnRef idx="1">
+            <a:schemeClr val="accent1"/>
+          </a:lnRef>
+          <a:fillRef idx="3">
+            <a:schemeClr val="accent1"/>
+          </a:fillRef>
+          <a:effectRef idx="2">
+            <a:schemeClr val="accent1"/>
+          </a:effectRef>
+          <a:fontRef idx="minor">
+            <a:schemeClr val="lt1"/>
+          </a:fontRef>
+        </p:style>
+        <p:txBody>
+          <a:bodyPr rtlCol="0" anchor="ctr" wrap="square" lIns="45720" rIns="45720" tIns="27432" bIns="27432"/>
+          <a:lstStyle/>
+          <a:p>
+            <a:pPr algn="ctr"/>
+            <a:r>
+              <a:rPr sz="950" b="1">
+                <a:solidFill>
+                  <a:srgbClr val="1A1A1A"/>
+                </a:solidFill>
+                <a:latin typeface="맑은 고딕"/>
+                <a:ea typeface="맑은 고딕"/>
+              </a:rPr>
+              <a:t>C2</a:t>
+            </a:r>
+          </a:p>
+        </p:txBody>
+      </p:sp>
+      <p:sp>
+        <p:nvSpPr>
+          <p:cNvPr id="71" name="Rectangle 70"/>
+          <p:cNvSpPr/>
+          <p:nvPr/>
+        </p:nvSpPr>
+        <p:spPr>
+          <a:xfrm>
+            <a:off x="1828800" y="1755648"/>
+            <a:ext cx="2011680" cy="365760"/>
+          </a:xfrm>
+          <a:prstGeom prst="rect">
+            <a:avLst/>
+          </a:prstGeom>
+          <a:solidFill>
+            <a:srgbClr val="FFFFFF"/>
+          </a:solidFill>
+          <a:ln w="9525">
+            <a:solidFill>
+              <a:srgbClr val="BFBFBF"/>
+            </a:solidFill>
+          </a:ln>
+          <a:effectLst/>
+        </p:spPr>
+        <p:style>
+          <a:lnRef idx="1">
+            <a:schemeClr val="accent1"/>
+          </a:lnRef>
+          <a:fillRef idx="3">
+            <a:schemeClr val="accent1"/>
+          </a:fillRef>
+          <a:effectRef idx="2">
+            <a:schemeClr val="accent1"/>
+          </a:effectRef>
+          <a:fontRef idx="minor">
+            <a:schemeClr val="lt1"/>
+          </a:fontRef>
+        </p:style>
+        <p:txBody>
+          <a:bodyPr rtlCol="0" anchor="ctr" wrap="square" lIns="45720" rIns="45720" tIns="27432" bIns="27432"/>
+          <a:lstStyle/>
+          <a:p>
+            <a:pPr algn="ctr"/>
+            <a:r>
+              <a:rPr sz="950" b="0">
+                <a:solidFill>
+                  <a:srgbClr val="1A1A1A"/>
+                </a:solidFill>
+                <a:latin typeface="맑은 고딕"/>
+                <a:ea typeface="맑은 고딕"/>
+              </a:rPr>
+              <a:t>0.83</a:t>
+            </a:r>
+          </a:p>
+        </p:txBody>
+      </p:sp>
+      <p:sp>
+        <p:nvSpPr>
+          <p:cNvPr id="72" name="Rectangle 71"/>
+          <p:cNvSpPr/>
+          <p:nvPr/>
+        </p:nvSpPr>
+        <p:spPr>
+          <a:xfrm>
+            <a:off x="3840480" y="1755648"/>
+            <a:ext cx="1828800" cy="365760"/>
+          </a:xfrm>
+          <a:prstGeom prst="rect">
+            <a:avLst/>
+          </a:prstGeom>
+          <a:solidFill>
+            <a:srgbClr val="FFFFFF"/>
+          </a:solidFill>
+          <a:ln w="9525">
+            <a:solidFill>
+              <a:srgbClr val="BFBFBF"/>
+            </a:solidFill>
+          </a:ln>
+          <a:effectLst/>
+        </p:spPr>
+        <p:style>
+          <a:lnRef idx="1">
+            <a:schemeClr val="accent1"/>
+          </a:lnRef>
+          <a:fillRef idx="3">
+            <a:schemeClr val="accent1"/>
+          </a:fillRef>
+          <a:effectRef idx="2">
+            <a:schemeClr val="accent1"/>
+          </a:effectRef>
+          <a:fontRef idx="minor">
+            <a:schemeClr val="lt1"/>
+          </a:fontRef>
+        </p:style>
+        <p:txBody>
+          <a:bodyPr rtlCol="0" anchor="ctr" wrap="square" lIns="45720" rIns="45720" tIns="27432" bIns="27432"/>
+          <a:lstStyle/>
+          <a:p>
+            <a:pPr algn="ctr"/>
+            <a:r>
+              <a:rPr sz="950" b="0">
+                <a:solidFill>
+                  <a:srgbClr val="1A1A1A"/>
+                </a:solidFill>
+                <a:latin typeface="맑은 고딕"/>
+                <a:ea typeface="맑은 고딕"/>
+              </a:rPr>
+              <a:t>0.75</a:t>
+            </a:r>
+          </a:p>
+        </p:txBody>
+      </p:sp>
+      <p:sp>
+        <p:nvSpPr>
+          <p:cNvPr id="73" name="Rectangle 72"/>
+          <p:cNvSpPr/>
+          <p:nvPr/>
+        </p:nvSpPr>
+        <p:spPr>
+          <a:xfrm>
+            <a:off x="5669280" y="1755648"/>
+            <a:ext cx="1828800" cy="365760"/>
+          </a:xfrm>
+          <a:prstGeom prst="rect">
+            <a:avLst/>
+          </a:prstGeom>
+          <a:solidFill>
+            <a:srgbClr val="FFFFFF"/>
+          </a:solidFill>
+          <a:ln w="9525">
+            <a:solidFill>
+              <a:srgbClr val="BFBFBF"/>
+            </a:solidFill>
+          </a:ln>
+          <a:effectLst/>
+        </p:spPr>
+        <p:style>
+          <a:lnRef idx="1">
+            <a:schemeClr val="accent1"/>
+          </a:lnRef>
+          <a:fillRef idx="3">
+            <a:schemeClr val="accent1"/>
+          </a:fillRef>
+          <a:effectRef idx="2">
+            <a:schemeClr val="accent1"/>
+          </a:effectRef>
+          <a:fontRef idx="minor">
+            <a:schemeClr val="lt1"/>
+          </a:fontRef>
+        </p:style>
+        <p:txBody>
+          <a:bodyPr rtlCol="0" anchor="ctr" wrap="square" lIns="45720" rIns="45720" tIns="27432" bIns="27432"/>
+          <a:lstStyle/>
+          <a:p>
+            <a:pPr algn="ctr"/>
+            <a:r>
+              <a:rPr sz="950" b="0">
+                <a:solidFill>
+                  <a:srgbClr val="1A1A1A"/>
+                </a:solidFill>
+                <a:latin typeface="맑은 고딕"/>
+                <a:ea typeface="맑은 고딕"/>
+              </a:rPr>
+              <a:t>1</a:t>
+            </a:r>
+          </a:p>
+        </p:txBody>
+      </p:sp>
+      <p:sp>
+        <p:nvSpPr>
+          <p:cNvPr id="74" name="Rectangle 73"/>
+          <p:cNvSpPr/>
+          <p:nvPr/>
+        </p:nvSpPr>
+        <p:spPr>
+          <a:xfrm>
+            <a:off x="7498079" y="1755648"/>
+            <a:ext cx="2011680" cy="365760"/>
+          </a:xfrm>
+          <a:prstGeom prst="rect">
+            <a:avLst/>
+          </a:prstGeom>
+          <a:solidFill>
+            <a:srgbClr val="FFFFFF"/>
+          </a:solidFill>
+          <a:ln w="9525">
+            <a:solidFill>
+              <a:srgbClr val="BFBFBF"/>
+            </a:solidFill>
+          </a:ln>
+          <a:effectLst/>
+        </p:spPr>
+        <p:style>
+          <a:lnRef idx="1">
+            <a:schemeClr val="accent1"/>
+          </a:lnRef>
+          <a:fillRef idx="3">
+            <a:schemeClr val="accent1"/>
+          </a:fillRef>
+          <a:effectRef idx="2">
+            <a:schemeClr val="accent1"/>
+          </a:effectRef>
+          <a:fontRef idx="minor">
+            <a:schemeClr val="lt1"/>
+          </a:fontRef>
+        </p:style>
+        <p:txBody>
+          <a:bodyPr rtlCol="0" anchor="ctr" wrap="square" lIns="45720" rIns="45720" tIns="27432" bIns="27432"/>
+          <a:lstStyle/>
+          <a:p>
+            <a:pPr algn="ctr"/>
+            <a:r>
+              <a:rPr sz="950" b="1">
+                <a:solidFill>
+                  <a:srgbClr val="1A1A1A"/>
+                </a:solidFill>
+                <a:latin typeface="맑은 고딕"/>
+                <a:ea typeface="맑은 고딕"/>
+              </a:rPr>
+              <a:t>★★★</a:t>
+            </a:r>
+          </a:p>
+        </p:txBody>
+      </p:sp>
+      <p:sp>
+        <p:nvSpPr>
+          <p:cNvPr id="75" name="Rectangle 74"/>
+          <p:cNvSpPr/>
+          <p:nvPr/>
+        </p:nvSpPr>
+        <p:spPr>
+          <a:xfrm>
+            <a:off x="9509760" y="1755648"/>
+            <a:ext cx="2286000" cy="365760"/>
+          </a:xfrm>
+          <a:prstGeom prst="rect">
+            <a:avLst/>
+          </a:prstGeom>
+          <a:solidFill>
+            <a:srgbClr val="FFFFFF"/>
+          </a:solidFill>
+          <a:ln w="9525">
+            <a:solidFill>
+              <a:srgbClr val="BFBFBF"/>
+            </a:solidFill>
+          </a:ln>
+          <a:effectLst/>
+        </p:spPr>
+        <p:style>
+          <a:lnRef idx="1">
+            <a:schemeClr val="accent1"/>
+          </a:lnRef>
+          <a:fillRef idx="3">
+            <a:schemeClr val="accent1"/>
+          </a:fillRef>
+          <a:effectRef idx="2">
+            <a:schemeClr val="accent1"/>
+          </a:effectRef>
+          <a:fontRef idx="minor">
+            <a:schemeClr val="lt1"/>
+          </a:fontRef>
+        </p:style>
+        <p:txBody>
+          <a:bodyPr rtlCol="0" anchor="ctr" wrap="square" lIns="45720" rIns="45720" tIns="27432" bIns="27432"/>
+          <a:lstStyle/>
+          <a:p>
+            <a:pPr algn="ctr"/>
+            <a:r>
+              <a:rPr sz="950" b="0">
+                <a:solidFill>
+                  <a:srgbClr val="1A1A1A"/>
+                </a:solidFill>
+                <a:latin typeface="맑은 고딕"/>
+                <a:ea typeface="맑은 고딕"/>
+              </a:rPr>
+              <a:t>★★★ (x1.422)</a:t>
+            </a:r>
+          </a:p>
+        </p:txBody>
+      </p:sp>
+      <p:sp>
+        <p:nvSpPr>
+          <p:cNvPr id="76" name="Rectangle 75"/>
+          <p:cNvSpPr/>
+          <p:nvPr/>
+        </p:nvSpPr>
+        <p:spPr>
+          <a:xfrm>
+            <a:off x="365760" y="2286000"/>
+            <a:ext cx="5669280" cy="3840480"/>
+          </a:xfrm>
+          <a:prstGeom prst="rect">
+            <a:avLst/>
+          </a:prstGeom>
+          <a:solidFill>
+            <a:srgbClr val="E3F1E3"/>
+          </a:solidFill>
+          <a:ln w="9525">
+            <a:solidFill>
+              <a:srgbClr val="5B9B5B"/>
+            </a:solidFill>
+          </a:ln>
+          <a:effectLst/>
+        </p:spPr>
+        <p:style>
+          <a:lnRef idx="1">
+            <a:schemeClr val="accent1"/>
+          </a:lnRef>
+          <a:fillRef idx="3">
+            <a:schemeClr val="accent1"/>
+          </a:fillRef>
+          <a:effectRef idx="2">
+            <a:schemeClr val="accent1"/>
+          </a:effectRef>
+          <a:fontRef idx="minor">
+            <a:schemeClr val="lt1"/>
+          </a:fontRef>
+        </p:style>
+        <p:txBody>
+          <a:bodyPr rtlCol="0" anchor="t" wrap="square" lIns="45720" rIns="45720" tIns="27432" bIns="27432"/>
+          <a:lstStyle/>
+          <a:p>
+            <a:pPr algn="l"/>
+            <a:r>
+              <a:rPr sz="950" b="1">
+                <a:solidFill>
+                  <a:srgbClr val="1A1A1A"/>
+                </a:solidFill>
+                <a:latin typeface="맑은 고딕"/>
+                <a:ea typeface="맑은 고딕"/>
+              </a:rPr>
+              <a:t>정의와 x의 근거</a:t>
+            </a:r>
+          </a:p>
+          <a:p>
+            <a:pPr algn="l"/>
+            <a:r>
+              <a:rPr sz="950" b="0">
+                <a:solidFill>
+                  <a:srgbClr val="1A1A1A"/>
+                </a:solidFill>
+                <a:latin typeface="맑은 고딕"/>
+                <a:ea typeface="맑은 고딕"/>
+              </a:rPr>
+              <a:t>- 달성률 = (후보 - Baseline) / (Oracle - Baseline), 시나리오 쌍마다. Oracle = 미래 접근률 완전 정보 </a:t>
+            </a:r>
+          </a:p>
+          <a:p>
+            <a:pPr algn="l"/>
+            <a:r>
+              <a:rPr sz="950" b="0">
+                <a:solidFill>
+                  <a:srgbClr val="1A1A1A"/>
+                </a:solidFill>
+                <a:latin typeface="맑은 고딕"/>
+                <a:ea typeface="맑은 고딕"/>
+              </a:rPr>
+              <a:t>+ 무비용 즉시 이동을 준 정책(Oracle-ideal, 증명된 최적은 아님). 개선 여지 3.3% 이하인 쌍은 제외(</a:t>
+            </a:r>
+          </a:p>
+          <a:p>
+            <a:pPr algn="l"/>
+            <a:r>
+              <a:rPr sz="950" b="0">
+                <a:solidFill>
+                  <a:srgbClr val="1A1A1A"/>
+                </a:solidFill>
+                <a:latin typeface="맑은 고딕"/>
+                <a:ea typeface="맑은 고딕"/>
+              </a:rPr>
+              <a:t>비교 가능 21쌍 중 10쌍 사용).</a:t>
+            </a:r>
+          </a:p>
+          <a:p>
+            <a:pPr algn="l"/>
+            <a:r>
+              <a:rPr sz="950" b="0">
+                <a:solidFill>
+                  <a:srgbClr val="1A1A1A"/>
+                </a:solidFill>
+                <a:latin typeface="맑은 고딕"/>
+                <a:ea typeface="맑은 고딕"/>
+              </a:rPr>
+              <a:t>- x = 80%: 문헌의 이득 달성률 {57, 75, 87, 95}%의 중앙값 81%를 반올림. Mockingjay(HPCA'22) Ta</a:t>
+            </a:r>
+          </a:p>
+          <a:p>
+            <a:pPr algn="l"/>
+            <a:r>
+              <a:rPr sz="950" b="0">
+                <a:solidFill>
+                  <a:srgbClr val="1A1A1A"/>
+                </a:solidFill>
+                <a:latin typeface="맑은 고딕"/>
+                <a:ea typeface="맑은 고딕"/>
+              </a:rPr>
+              <a:t>ble I: SHiP 57%, Hawkeye 75%, Mockingjay 95%(Belady MIN 대비 IPC 개선), ARMS(arXiv 2508.0441</a:t>
+            </a:r>
+          </a:p>
+          <a:p>
+            <a:pPr algn="l"/>
+            <a:r>
+              <a:rPr sz="950" b="0">
+                <a:solidFill>
+                  <a:srgbClr val="1A1A1A"/>
+                </a:solidFill>
+                <a:latin typeface="맑은 고딕"/>
+                <a:ea typeface="맑은 고딕"/>
+              </a:rPr>
+              <a:t>7): 튜닝 최적의 97% 이상 -&gt; 87% 이상(환산).</a:t>
+            </a:r>
+          </a:p>
+          <a:p>
+            <a:pPr algn="l"/>
+            <a:r>
+              <a:rPr sz="950" b="0">
+                <a:solidFill>
+                  <a:srgbClr val="1A1A1A"/>
+                </a:solidFill>
+                <a:latin typeface="맑은 고딕"/>
+                <a:ea typeface="맑은 고딕"/>
+              </a:rPr>
+              <a:t>- ★/★★ 경계는 기존 잡음 기준(Baseline 대비 0.97) 유지.</a:t>
+            </a:r>
+          </a:p>
+        </p:txBody>
+      </p:sp>
+      <p:sp>
+        <p:nvSpPr>
+          <p:cNvPr id="77" name="Rectangle 76"/>
+          <p:cNvSpPr/>
+          <p:nvPr/>
+        </p:nvSpPr>
+        <p:spPr>
+          <a:xfrm>
+            <a:off x="6217920" y="2286000"/>
+            <a:ext cx="5577840" cy="3840480"/>
+          </a:xfrm>
+          <a:prstGeom prst="rect">
+            <a:avLst/>
+          </a:prstGeom>
+          <a:solidFill>
+            <a:srgbClr val="F2F2F2"/>
+          </a:solidFill>
+          <a:ln w="9525">
+            <a:solidFill>
+              <a:srgbClr val="BFBFBF"/>
+            </a:solidFill>
+          </a:ln>
+          <a:effectLst/>
+        </p:spPr>
+        <p:style>
+          <a:lnRef idx="1">
+            <a:schemeClr val="accent1"/>
+          </a:lnRef>
+          <a:fillRef idx="3">
+            <a:schemeClr val="accent1"/>
+          </a:fillRef>
+          <a:effectRef idx="2">
+            <a:schemeClr val="accent1"/>
+          </a:effectRef>
+          <a:fontRef idx="minor">
+            <a:schemeClr val="lt1"/>
+          </a:fontRef>
+        </p:style>
+        <p:txBody>
+          <a:bodyPr rtlCol="0" anchor="t" wrap="square" lIns="45720" rIns="45720" tIns="27432" bIns="27432"/>
+          <a:lstStyle/>
+          <a:p>
+            <a:pPr algn="l"/>
+            <a:r>
+              <a:rPr sz="950" b="1">
+                <a:solidFill>
+                  <a:srgbClr val="404040"/>
+                </a:solidFill>
+                <a:latin typeface="맑은 고딕"/>
+                <a:ea typeface="맑은 고딕"/>
+              </a:rPr>
+              <a:t>솔직한 한계</a:t>
+            </a:r>
+          </a:p>
+          <a:p>
+            <a:pPr algn="l"/>
+            <a:r>
+              <a:rPr sz="950" b="0">
+                <a:solidFill>
+                  <a:srgbClr val="404040"/>
+                </a:solidFill>
+                <a:latin typeface="맑은 고딕"/>
+                <a:ea typeface="맑은 고딕"/>
+              </a:rPr>
+              <a:t>- 문헌은 CPU 캐시 교체와 tiered memory 연구다. LLM 서빙에 직접 해당하는 이득 달성률 문헌은 </a:t>
+            </a:r>
+          </a:p>
+          <a:p>
+            <a:pPr algn="l"/>
+            <a:r>
+              <a:rPr sz="950" b="0">
+                <a:solidFill>
+                  <a:srgbClr val="404040"/>
+                </a:solidFill>
+                <a:latin typeface="맑은 고딕"/>
+                <a:ea typeface="맑은 고딕"/>
+              </a:rPr>
+              <a:t>찾지 못했다. LLM KV 연구(arXiv 2609.16215)는 대역폭이 경합하면 oracle prefetch도 이득이 없었</a:t>
+            </a:r>
+          </a:p>
+          <a:p>
+            <a:pPr algn="l"/>
+            <a:r>
+              <a:rPr sz="950" b="0">
+                <a:solidFill>
+                  <a:srgbClr val="404040"/>
+                </a:solidFill>
+                <a:latin typeface="맑은 고딕"/>
+                <a:ea typeface="맑은 고딕"/>
+              </a:rPr>
+              <a:t>다고 보고했고, 이는 우리 링크 간섭 결과와 같은 방향이다.</a:t>
+            </a:r>
+          </a:p>
+          <a:p>
+            <a:pPr algn="l"/>
+            <a:r>
+              <a:rPr sz="950" b="0">
+                <a:solidFill>
+                  <a:srgbClr val="404040"/>
+                </a:solidFill>
+                <a:latin typeface="맑은 고딕"/>
+                <a:ea typeface="맑은 고딕"/>
+              </a:rPr>
+              <a:t>- 쌍 10개뿐이라 부트스트랩 95% 구간이 C1 0.33~0.87, C2 0.70~0.93으로 겹친다. C2가 더 가깝</a:t>
+            </a:r>
+          </a:p>
+          <a:p>
+            <a:pPr algn="l"/>
+            <a:r>
+              <a:rPr sz="950" b="0">
+                <a:solidFill>
+                  <a:srgbClr val="404040"/>
+                </a:solidFill>
+                <a:latin typeface="맑은 고딕"/>
+                <a:ea typeface="맑은 고딕"/>
+              </a:rPr>
+              <a:t>다고 단정할 수 없다.</a:t>
+            </a:r>
+          </a:p>
+          <a:p>
+            <a:pPr algn="l"/>
+            <a:r>
+              <a:rPr sz="950" b="0">
+                <a:solidFill>
+                  <a:srgbClr val="404040"/>
+                </a:solidFill>
+                <a:latin typeface="맑은 고딕"/>
+                <a:ea typeface="맑은 고딕"/>
+              </a:rPr>
+              <a:t>- 쌍별 평균을 쓰면 C2는 0.75로 ★★이다(pooled는 문헌의 관례). 두 방식 모두 선택은 C1.</a:t>
+            </a:r>
+          </a:p>
+          <a:p>
+            <a:pPr algn="l"/>
+            <a:r>
+              <a:rPr sz="950" b="0">
+                <a:solidFill>
+                  <a:srgbClr val="404040"/>
+                </a:solidFill>
+                <a:latin typeface="맑은 고딕"/>
+                <a:ea typeface="맑은 고딕"/>
+              </a:rPr>
+              <a:t>- QA2(Oracle을 넘는 쌍 6개)와 QA3(Oracle 미정의)에는 적용하지 않았다. 출처 5개와 제외 사유: q</a:t>
+            </a:r>
+          </a:p>
+          <a:p>
+            <a:pPr algn="l"/>
+            <a:r>
+              <a:rPr sz="950" b="0">
+                <a:solidFill>
+                  <a:srgbClr val="404040"/>
+                </a:solidFill>
+                <a:latin typeface="맑은 고딕"/>
+                <a:ea typeface="맑은 고딕"/>
+              </a:rPr>
+              <a:t>a-capture-literature.md.</a:t>
+            </a:r>
+          </a:p>
+        </p:txBody>
+      </p:sp>
+    </p:spTree>
+  </p:cSld>
+  <p:clrMapOvr>
+    <a:masterClrMapping/>
+  </p:clrMapOvr>
+</p:sld>
+</file>
+
+<file path=ppt/slides/slide26.xml><?xml version="1.0" encoding="utf-8"?>
+<p:sld xmlns:a="http://schemas.openxmlformats.org/drawingml/2006/main" xmlns:p="http://schemas.openxmlformats.org/presentationml/2006/main" xmlns:r="http://schemas.openxmlformats.org/officeDocument/2006/relationships">
+  <p:cSld>
+    <p:spTree>
+      <p:nvGrpSpPr>
+        <p:cNvPr id="1" name=""/>
+        <p:cNvGrpSpPr/>
+        <p:nvPr/>
+      </p:nvGrpSpPr>
+      <p:grpSpPr/>
+      <p:sp>
+        <p:nvSpPr>
+          <p:cNvPr id="3" name="제목 2"/>
+          <p:cNvSpPr>
+            <a:spLocks noGrp="1"/>
+          </p:cNvSpPr>
+          <p:nvPr>
+            <p:ph type="title"/>
+          </p:nvPr>
+        </p:nvSpPr>
+        <p:spPr>
+          <a:xfrm>
+            <a:off x="234949" y="137379"/>
+            <a:ext cx="7631530" cy="365125"/>
+          </a:xfrm>
+        </p:spPr>
+        <p:txBody>
+          <a:bodyPr/>
+          <a:lstStyle/>
+          <a:p>
+            <a:r>
+              <a:rPr lang="en-US" altLang="ko-KR" dirty="0"/>
+              <a:t>DP1. 이기종 메모리 기반 Data Migration 구조 - Appendix</a:t>
+            </a:r>
+            <a:r>
+              <a:rPr lang="ko-KR" altLang="en-US" dirty="0"/>
+              <a:t/>
+            </a:r>
+            <a:r>
+              <a:rPr lang="en-US" altLang="ko-KR" dirty="0"/>
+              <a:t/>
+            </a:r>
+            <a:r>
+              <a:rPr lang="ko-KR" altLang="en-US" dirty="0"/>
+              <a:t/>
+            </a:r>
+            <a:r>
+              <a:rPr lang="en-US" altLang="ko-KR" dirty="0"/>
+              <a:t/>
+            </a:r>
+            <a:r>
+              <a:rPr lang="ko-KR" altLang="en-US" dirty="0"/>
+              <a:t/>
+            </a:r>
+          </a:p>
+        </p:txBody>
+      </p:sp>
+      <p:sp>
+        <p:nvSpPr>
+          <p:cNvPr id="5" name="직사각형 4"/>
+          <p:cNvSpPr/>
+          <p:nvPr/>
+        </p:nvSpPr>
+        <p:spPr>
+          <a:xfrm>
+            <a:off x="234949" y="596176"/>
+            <a:ext cx="11747501" cy="396603"/>
+          </a:xfrm>
+          <a:prstGeom prst="rect">
+            <a:avLst/>
+          </a:prstGeom>
+          <a:solidFill>
+            <a:schemeClr val="bg1">
+              <a:lumMod val="50000"/>
+            </a:schemeClr>
+          </a:solidFill>
+          <a:ln>
+            <a:noFill/>
+          </a:ln>
+        </p:spPr>
+        <p:style>
+          <a:lnRef idx="2">
+            <a:schemeClr val="accent1">
+              <a:shade val="50000"/>
+            </a:schemeClr>
+          </a:lnRef>
+          <a:fillRef idx="1">
+            <a:schemeClr val="accent1"/>
+          </a:fillRef>
+          <a:effectRef idx="0">
+            <a:schemeClr val="accent1"/>
+          </a:effectRef>
+          <a:fontRef idx="minor">
+            <a:schemeClr val="lt1"/>
+          </a:fontRef>
+        </p:style>
+        <p:txBody>
+          <a:bodyPr rtlCol="0" anchor="ctr"/>
+          <a:lstStyle/>
+          <a:p>
+            <a:pPr algn="ctr"/>
+            <a:endParaRPr lang="ko-KR" altLang="en-US"/>
+          </a:p>
+        </p:txBody>
+      </p:sp>
+      <p:sp>
+        <p:nvSpPr>
+          <p:cNvPr id="8" name="TextBox 7"/>
+          <p:cNvSpPr txBox="1"/>
+          <p:nvPr/>
+        </p:nvSpPr>
+        <p:spPr>
+          <a:xfrm>
+            <a:off x="469760" y="627926"/>
+            <a:ext cx="11430000" cy="307777"/>
+          </a:xfrm>
+          <a:prstGeom prst="rect">
+            <a:avLst/>
+          </a:prstGeom>
+          <a:noFill/>
+        </p:spPr>
+        <p:txBody>
+          <a:bodyPr wrap="square" rtlCol="0">
+            <a:spAutoFit/>
+          </a:bodyPr>
+          <a:lstStyle/>
+          <a:p>
+            <a:pPr lvl="0">
+              <a:defRPr/>
+            </a:pPr>
+            <a:r>
+              <a:rPr lang="ko-KR" altLang="en-US" sz="1400" b="1" dirty="0">
+                <a:solidFill>
+                  <a:schemeClr val="bg1"/>
+                </a:solidFill>
+              </a:rPr>
               <a:t>DP1 평가에서 고려한 시나리오</a:t>
             </a:r>
             <a:r>

</xml_diff>

<commit_message>
DP1: rating v6 - QA1/QA2/QA3 stars by Oracle capture ratio (Oracle-ideal/Oracle-lean), merged star-criteria slide, result doc and ablation narrative updated
Co-Authored-By: Claude Sonnet 5.5 <noreply@anthropic.com>
Claude-Session: https://claude.ai/code/session_018inK4pZJGzYwjdk7QAyZgn
</commit_message>
<xml_diff>
--- a/doc-mk/DP1/DP1-appendix-qa-result.pptx
+++ b/doc-mk/DP1/DP1-appendix-qa-result.pptx
@@ -16,7 +16,6 @@
     <p:sldId id="655" r:id="rId29"/>
     <p:sldId id="656" r:id="rId30"/>
     <p:sldId id="657" r:id="rId31"/>
-    <p:sldId id="658" r:id="rId32"/>
   </p:sldIdLst>
   <p:sldSz cx="12192000" cy="6858000"/>
   <p:notesSz cx="6858000" cy="9144000"/>
@@ -5839,7 +5838,7 @@
                 <a:latin typeface="맑은 고딕"/>
                 <a:ea typeface="맑은 고딕"/>
               </a:rPr>
-              <a:t>★★★  x1.28 (TTFT x1.58 · TPOT x1.04)</a:t>
+              <a:t>★★  x1.28 (TTFT x1.58 · TPOT x1.04)</a:t>
             </a:r>
           </a:p>
         </p:txBody>
@@ -5895,7 +5894,7 @@
                 <a:latin typeface="맑은 고딕"/>
                 <a:ea typeface="맑은 고딕"/>
               </a:rPr>
-              <a:t>★★★  x1.56 (TTFT x2.18 · TPOT x1.12)</a:t>
+              <a:t>★★  x1.56 (TTFT x2.18 · TPOT x1.12)</a:t>
             </a:r>
           </a:p>
         </p:txBody>
@@ -6550,7 +6549,7 @@
                 <a:latin typeface="맑은 고딕"/>
                 <a:ea typeface="맑은 고딕"/>
               </a:rPr>
-              <a:t>10</a:t>
+              <a:t>9</a:t>
             </a:r>
           </a:p>
         </p:txBody>
@@ -6606,7 +6605,7 @@
                 <a:latin typeface="맑은 고딕"/>
                 <a:ea typeface="맑은 고딕"/>
               </a:rPr>
-              <a:t>9</a:t>
+              <a:t>8</a:t>
             </a:r>
           </a:p>
         </p:txBody>
@@ -6731,7 +6730,7 @@
                 <a:latin typeface="맑은 고딕"/>
                 <a:ea typeface="맑은 고딕"/>
               </a:rPr>
-              <a:t>선택: C1  —  별 합계가 높은 C1 후보 (10 대 9). 합계 차이 1점이라 별 경계에 민감하다.</a:t>
+              <a:t>선택: C1  —  별 합계가 높은 C1 후보 (9 대 8). 합계 차이 1점이라 별 경계에 민감하다.</a:t>
             </a:r>
           </a:p>
           <a:p>
@@ -6744,7 +6743,7 @@
                 <a:latin typeface="맑은 고딕"/>
                 <a:ea typeface="맑은 고딕"/>
               </a:rPr>
-              <a:t>한계: [B] simulation, 별 경계(QA1 1.30)와 QA3 정의(선택을 C2에서 C1로 바꿈), QA4 평균 집계는 결과를 본 뒤 정함. QA4 공수·비용은 ASSUMED.</a:t>
+              <a:t>한계: [B] simulation. 별 기준(Oracle 달성률 80%, 집계 방식, QA2·QA3 Oracle)과 QA3 정의(선택을 C2에서 C1로 바꿈), QA4 평균 집계는 결과를 본 뒤 정함. QA4 공수·비용은 ASSUMED.</a:t>
             </a:r>
           </a:p>
         </p:txBody>
@@ -11583,7 +11582,7 @@
                 <a:latin typeface="맑은 고딕"/>
                 <a:ea typeface="맑은 고딕"/>
               </a:rPr>
-              <a:t>- 별 합계는 C1 10, C2 9로 근소해 선택(C1)은 별 경계와 QA 정의에 민감하다.</a:t>
+              <a:t>- 별 합계는 C1 9, C2 8로 근소해 선택(C1)은 별 경계와 QA 정의에 민감하다.</a:t>
             </a:r>
           </a:p>
         </p:txBody>
@@ -13252,7 +13251,7 @@
                 <a:latin typeface="맑은 고딕"/>
                 <a:ea typeface="맑은 고딕"/>
               </a:rPr>
-              <a:t>★★★  x1.28</a:t>
+              <a:t>★★  x1.28</a:t>
             </a:r>
           </a:p>
         </p:txBody>
@@ -13308,7 +13307,7 @@
                 <a:latin typeface="맑은 고딕"/>
                 <a:ea typeface="맑은 고딕"/>
               </a:rPr>
-              <a:t>★★★  x1.56</a:t>
+              <a:t>★★  x1.56</a:t>
             </a:r>
           </a:p>
         </p:txBody>
@@ -14036,7 +14035,7 @@
                 <a:latin typeface="맑은 고딕"/>
                 <a:ea typeface="맑은 고딕"/>
               </a:rPr>
-              <a:t>9 → C2 (동점, 우선순위 QA1)</a:t>
+              <a:t>9 → C1 (합계)</a:t>
             </a:r>
           </a:p>
         </p:txBody>
@@ -14092,7 +14091,7 @@
                 <a:latin typeface="맑은 고딕"/>
                 <a:ea typeface="맑은 고딕"/>
               </a:rPr>
-              <a:t>10 → C1 (합계)</a:t>
+              <a:t>9 → C1 (합계)</a:t>
             </a:r>
           </a:p>
         </p:txBody>
@@ -14148,7 +14147,7 @@
                 <a:latin typeface="맑은 고딕"/>
                 <a:ea typeface="맑은 고딕"/>
               </a:rPr>
-              <a:t>9</a:t>
+              <a:t>8</a:t>
             </a:r>
           </a:p>
         </p:txBody>
@@ -14204,7 +14203,7 @@
                 <a:latin typeface="맑은 고딕"/>
                 <a:ea typeface="맑은 고딕"/>
               </a:rPr>
-              <a:t>보완 설계 스토리: affinity 추가</a:t>
+              <a:t>보완 설계: affinity 추가의 효과</a:t>
             </a:r>
           </a:p>
           <a:p>
@@ -14217,7 +14216,7 @@
                 <a:latin typeface="맑은 고딕"/>
                 <a:ea typeface="맑은 고딕"/>
               </a:rPr>
-              <a:t>- affinity가 없는 C1은 자원 압박에만 반응한다. 처리량 x1.05, TTFT P99 x1.27(악화)로 C2(x1.42)에 </a:t>
+              <a:t>- affinity가 없는 C1은 자원 압박에만 반응한다. 처리량 x1.05(Oracle 달성률 13%), TTFT P99 x1.27(</a:t>
             </a:r>
           </a:p>
           <a:p>
@@ -14230,7 +14229,7 @@
                 <a:latin typeface="맑은 고딕"/>
                 <a:ea typeface="맑은 고딕"/>
               </a:rPr>
-              <a:t>크게 못 미치고, 별 합계가 동점이라 우선순위로 C2가 선택된다.</a:t>
+              <a:t>악화), 승/무/패 2/29/0로 C2(x1.42, 달성률 83%)에 크게 못 미친다.</a:t>
             </a:r>
           </a:p>
           <a:p>
@@ -14256,7 +14255,7 @@
                 <a:latin typeface="맑은 고딕"/>
                 <a:ea typeface="맑은 고딕"/>
               </a:rPr>
-              <a:t>' 객체를 승격, 필요하면 교환) 처리량 x1.30, QA2 ★★★이 되어 합계 10 대 9로 C1이 선택된다.</a:t>
+              <a:t>' 객체를 승격, 필요하면 교환) 처리량 x1.30(달성률 62%), 승/무/패 6/25/0가 된다.</a:t>
             </a:r>
           </a:p>
           <a:p>
@@ -14377,7 +14376,7 @@
                 <a:latin typeface="맑은 고딕"/>
                 <a:ea typeface="맑은 고딕"/>
               </a:rPr>
-              <a:t>- 선택이 C1로 바뀐 것은 QA3(HBM x0.97 대 C2 x1.21)·QA4 우위와 QA2 별 경계(x1.28 vs 1.25)에</a:t>
+              <a:t>- **별(v6)로는 affinity 제거가 선택을 바꾸지 못한다**: 두 변형 모두 QA1~3이 ★★로 같고 합계 </a:t>
             </a:r>
           </a:p>
           <a:p>
@@ -14390,7 +14389,20 @@
                 <a:latin typeface="맑은 고딕"/>
                 <a:ea typeface="맑은 고딕"/>
               </a:rPr>
-              <a:t>서 온다. 합계 차이 1점이라 경계에 민감하다.</a:t>
+              <a:t>C1 9(제거)/9(포함) 대 C2 8라 둘 다 C1 선택. 3단계 별이 값의 차이를 가린다. 이전 기준(v5)에서</a:t>
+            </a:r>
+          </a:p>
+          <a:p>
+            <a:pPr algn="l"/>
+            <a:r>
+              <a:rPr sz="950" b="0">
+                <a:solidFill>
+                  <a:srgbClr val="404040"/>
+                </a:solidFill>
+                <a:latin typeface="맑은 고딕"/>
+                <a:ea typeface="맑은 고딕"/>
+              </a:rPr>
+              <a:t>는 QA2 ★★★ 경계 때문에 제거 시 동점(C2 선택)이었으나 경계 선택의 효과였다.</a:t>
             </a:r>
           </a:p>
           <a:p>
@@ -15942,7 +15954,7 @@
                   <a:schemeClr val="bg1"/>
                 </a:solidFill>
               </a:rPr>
-              <a:t>별점 경계의 근거 - 하한은 측정, 상한은 환산 + 정책 선택</a:t>
+              <a:t>별점 기준과 근거 (v6: Oracle 이득 달성률)</a:t>
             </a:r>
             <a:r>
               <a:rPr lang="en-US" altLang="ko-KR" sz="1400" b="1" dirty="0">
@@ -16062,8 +16074,8 @@
         </p:nvSpPr>
         <p:spPr>
           <a:xfrm>
-            <a:off x="365760" y="1051560"/>
-            <a:ext cx="1188720" cy="292608"/>
+            <a:off x="320040" y="1024128"/>
+            <a:ext cx="777240" cy="274320"/>
           </a:xfrm>
           <a:prstGeom prst="rect">
             <a:avLst/>
@@ -16098,7 +16110,7 @@
           <a:p>
             <a:pPr algn="ctr"/>
             <a:r>
-              <a:rPr sz="1000" b="1">
+              <a:rPr sz="950" b="1">
                 <a:solidFill>
                   <a:srgbClr val="FFFFFF"/>
                 </a:solidFill>
@@ -16118,8 +16130,8 @@
         </p:nvSpPr>
         <p:spPr>
           <a:xfrm>
-            <a:off x="1554480" y="1051560"/>
-            <a:ext cx="4206240" cy="292608"/>
+            <a:off x="1097280" y="1024128"/>
+            <a:ext cx="2514600" cy="274320"/>
           </a:xfrm>
           <a:prstGeom prst="rect">
             <a:avLst/>
@@ -16154,14 +16166,14 @@
           <a:p>
             <a:pPr algn="ctr"/>
             <a:r>
-              <a:rPr sz="1000" b="1">
+              <a:rPr sz="950" b="1">
                 <a:solidFill>
                   <a:srgbClr val="FFFFFF"/>
                 </a:solidFill>
                 <a:latin typeface="맑은 고딕"/>
                 <a:ea typeface="맑은 고딕"/>
               </a:rPr>
-              <a:t>하한 (★/★★) 근거: Baseline끼리 비교한 잡음 대역</a:t>
+              <a:t>평가 지표 / Oracle(이론적 상한)</a:t>
             </a:r>
           </a:p>
         </p:txBody>
@@ -16174,8 +16186,8 @@
         </p:nvSpPr>
         <p:spPr>
           <a:xfrm>
-            <a:off x="5760720" y="1051560"/>
-            <a:ext cx="1005840" cy="292608"/>
+            <a:off x="3611880" y="1024128"/>
+            <a:ext cx="1691640" cy="274320"/>
           </a:xfrm>
           <a:prstGeom prst="rect">
             <a:avLst/>
@@ -16210,14 +16222,14 @@
           <a:p>
             <a:pPr algn="ctr"/>
             <a:r>
-              <a:rPr sz="1000" b="1">
+              <a:rPr sz="950" b="1">
                 <a:solidFill>
                   <a:srgbClr val="FFFFFF"/>
                 </a:solidFill>
                 <a:latin typeface="맑은 고딕"/>
                 <a:ea typeface="맑은 고딕"/>
               </a:rPr>
-              <a:t>현재 하한</a:t>
+              <a:t>★ (1개)</a:t>
             </a:r>
           </a:p>
         </p:txBody>
@@ -16230,8 +16242,8 @@
         </p:nvSpPr>
         <p:spPr>
           <a:xfrm>
-            <a:off x="6766560" y="1051560"/>
-            <a:ext cx="5029200" cy="292608"/>
+            <a:off x="5303520" y="1024128"/>
+            <a:ext cx="1920240" cy="274320"/>
           </a:xfrm>
           <a:prstGeom prst="rect">
             <a:avLst/>
@@ -16266,14 +16278,14 @@
           <a:p>
             <a:pPr algn="ctr"/>
             <a:r>
-              <a:rPr sz="1000" b="1">
+              <a:rPr sz="950" b="1">
                 <a:solidFill>
                   <a:srgbClr val="FFFFFF"/>
                 </a:solidFill>
                 <a:latin typeface="맑은 고딕"/>
                 <a:ea typeface="맑은 고딕"/>
               </a:rPr>
-              <a:t>상한 (★★/★★★) 환산</a:t>
+              <a:t>★★ (2개)</a:t>
             </a:r>
           </a:p>
         </p:txBody>
@@ -16286,8 +16298,176 @@
         </p:nvSpPr>
         <p:spPr>
           <a:xfrm>
-            <a:off x="365760" y="1371600"/>
-            <a:ext cx="1188720" cy="566928"/>
+            <a:off x="7223760" y="1024128"/>
+            <a:ext cx="1600200" cy="274320"/>
+          </a:xfrm>
+          <a:prstGeom prst="rect">
+            <a:avLst/>
+          </a:prstGeom>
+          <a:solidFill>
+            <a:srgbClr val="1F4E79"/>
+          </a:solidFill>
+          <a:ln w="9525">
+            <a:solidFill>
+              <a:srgbClr val="1F4E79"/>
+            </a:solidFill>
+          </a:ln>
+          <a:effectLst/>
+        </p:spPr>
+        <p:style>
+          <a:lnRef idx="1">
+            <a:schemeClr val="accent1"/>
+          </a:lnRef>
+          <a:fillRef idx="3">
+            <a:schemeClr val="accent1"/>
+          </a:fillRef>
+          <a:effectRef idx="2">
+            <a:schemeClr val="accent1"/>
+          </a:effectRef>
+          <a:fontRef idx="minor">
+            <a:schemeClr val="lt1"/>
+          </a:fontRef>
+        </p:style>
+        <p:txBody>
+          <a:bodyPr rtlCol="0" anchor="ctr" wrap="square" lIns="45720" rIns="45720" tIns="27432" bIns="27432"/>
+          <a:lstStyle/>
+          <a:p>
+            <a:pPr algn="ctr"/>
+            <a:r>
+              <a:rPr sz="950" b="1">
+                <a:solidFill>
+                  <a:srgbClr val="FFFFFF"/>
+                </a:solidFill>
+                <a:latin typeface="맑은 고딕"/>
+                <a:ea typeface="맑은 고딕"/>
+              </a:rPr>
+              <a:t>★★★ (3개)</a:t>
+            </a:r>
+          </a:p>
+        </p:txBody>
+      </p:sp>
+      <p:sp>
+        <p:nvSpPr>
+          <p:cNvPr id="63" name="Rectangle 62"/>
+          <p:cNvSpPr/>
+          <p:nvPr/>
+        </p:nvSpPr>
+        <p:spPr>
+          <a:xfrm>
+            <a:off x="8823960" y="1024128"/>
+            <a:ext cx="1965960" cy="274320"/>
+          </a:xfrm>
+          <a:prstGeom prst="rect">
+            <a:avLst/>
+          </a:prstGeom>
+          <a:solidFill>
+            <a:srgbClr val="1F4E79"/>
+          </a:solidFill>
+          <a:ln w="9525">
+            <a:solidFill>
+              <a:srgbClr val="1F4E79"/>
+            </a:solidFill>
+          </a:ln>
+          <a:effectLst/>
+        </p:spPr>
+        <p:style>
+          <a:lnRef idx="1">
+            <a:schemeClr val="accent1"/>
+          </a:lnRef>
+          <a:fillRef idx="3">
+            <a:schemeClr val="accent1"/>
+          </a:fillRef>
+          <a:effectRef idx="2">
+            <a:schemeClr val="accent1"/>
+          </a:effectRef>
+          <a:fontRef idx="minor">
+            <a:schemeClr val="lt1"/>
+          </a:fontRef>
+        </p:style>
+        <p:txBody>
+          <a:bodyPr rtlCol="0" anchor="ctr" wrap="square" lIns="45720" rIns="45720" tIns="27432" bIns="27432"/>
+          <a:lstStyle/>
+          <a:p>
+            <a:pPr algn="ctr"/>
+            <a:r>
+              <a:rPr sz="950" b="1">
+                <a:solidFill>
+                  <a:srgbClr val="FFFFFF"/>
+                </a:solidFill>
+                <a:latin typeface="맑은 고딕"/>
+                <a:ea typeface="맑은 고딕"/>
+              </a:rPr>
+              <a:t>왜 이 기준인가</a:t>
+            </a:r>
+          </a:p>
+        </p:txBody>
+      </p:sp>
+      <p:sp>
+        <p:nvSpPr>
+          <p:cNvPr id="64" name="Rectangle 63"/>
+          <p:cNvSpPr/>
+          <p:nvPr/>
+        </p:nvSpPr>
+        <p:spPr>
+          <a:xfrm>
+            <a:off x="10789920" y="1024128"/>
+            <a:ext cx="1097280" cy="274320"/>
+          </a:xfrm>
+          <a:prstGeom prst="rect">
+            <a:avLst/>
+          </a:prstGeom>
+          <a:solidFill>
+            <a:srgbClr val="1F4E79"/>
+          </a:solidFill>
+          <a:ln w="9525">
+            <a:solidFill>
+              <a:srgbClr val="1F4E79"/>
+            </a:solidFill>
+          </a:ln>
+          <a:effectLst/>
+        </p:spPr>
+        <p:style>
+          <a:lnRef idx="1">
+            <a:schemeClr val="accent1"/>
+          </a:lnRef>
+          <a:fillRef idx="3">
+            <a:schemeClr val="accent1"/>
+          </a:fillRef>
+          <a:effectRef idx="2">
+            <a:schemeClr val="accent1"/>
+          </a:effectRef>
+          <a:fontRef idx="minor">
+            <a:schemeClr val="lt1"/>
+          </a:fontRef>
+        </p:style>
+        <p:txBody>
+          <a:bodyPr rtlCol="0" anchor="ctr" wrap="square" lIns="45720" rIns="45720" tIns="27432" bIns="27432"/>
+          <a:lstStyle/>
+          <a:p>
+            <a:pPr algn="ctr"/>
+            <a:r>
+              <a:rPr sz="950" b="1">
+                <a:solidFill>
+                  <a:srgbClr val="FFFFFF"/>
+                </a:solidFill>
+                <a:latin typeface="맑은 고딕"/>
+                <a:ea typeface="맑은 고딕"/>
+              </a:rPr>
+              <a:t>C1 / C2 결과</a:t>
+            </a:r>
+          </a:p>
+        </p:txBody>
+      </p:sp>
+      <p:sp>
+        <p:nvSpPr>
+          <p:cNvPr id="65" name="Rectangle 64"/>
+          <p:cNvSpPr/>
+          <p:nvPr/>
+        </p:nvSpPr>
+        <p:spPr>
+          <a:xfrm>
+            <a:off x="320040" y="1325880"/>
+            <a:ext cx="777240" cy="786384"/>
           </a:xfrm>
           <a:prstGeom prst="rect">
             <a:avLst/>
@@ -16320,30 +16500,43 @@
           <a:bodyPr rtlCol="0" anchor="ctr" wrap="square" lIns="45720" rIns="45720" tIns="27432" bIns="27432"/>
           <a:lstStyle/>
           <a:p>
-            <a:pPr algn="l"/>
-            <a:r>
-              <a:rPr sz="950" b="1">
-                <a:solidFill>
-                  <a:srgbClr val="1A1A1A"/>
-                </a:solidFill>
-                <a:latin typeface="맑은 고딕"/>
-                <a:ea typeface="맑은 고딕"/>
-              </a:rPr>
-              <a:t>QA1 처리량</a:t>
-            </a:r>
-          </a:p>
-        </p:txBody>
-      </p:sp>
-      <p:sp>
-        <p:nvSpPr>
-          <p:cNvPr id="63" name="Rectangle 62"/>
-          <p:cNvSpPr/>
-          <p:nvPr/>
-        </p:nvSpPr>
-        <p:spPr>
-          <a:xfrm>
-            <a:off x="1554480" y="1371600"/>
-            <a:ext cx="4206240" cy="566928"/>
+            <a:pPr algn="ctr"/>
+            <a:r>
+              <a:rPr sz="800" b="1">
+                <a:solidFill>
+                  <a:srgbClr val="1A1A1A"/>
+                </a:solidFill>
+                <a:latin typeface="맑은 고딕"/>
+                <a:ea typeface="맑은 고딕"/>
+              </a:rPr>
+              <a:t>QA1</a:t>
+            </a:r>
+          </a:p>
+          <a:p>
+            <a:pPr algn="ctr"/>
+            <a:r>
+              <a:rPr sz="800" b="1">
+                <a:solidFill>
+                  <a:srgbClr val="1A1A1A"/>
+                </a:solidFill>
+                <a:latin typeface="맑은 고딕"/>
+                <a:ea typeface="맑은 고딕"/>
+              </a:rPr>
+              <a:t>처리량</a:t>
+            </a:r>
+          </a:p>
+        </p:txBody>
+      </p:sp>
+      <p:sp>
+        <p:nvSpPr>
+          <p:cNvPr id="66" name="Rectangle 65"/>
+          <p:cNvSpPr/>
+          <p:nvPr/>
+        </p:nvSpPr>
+        <p:spPr>
+          <a:xfrm>
+            <a:off x="1097280" y="1325880"/>
+            <a:ext cx="2514600" cy="786384"/>
           </a:xfrm>
           <a:prstGeom prst="rect">
             <a:avLst/>
@@ -16378,28 +16571,54 @@
           <a:p>
             <a:pPr algn="l"/>
             <a:r>
-              <a:rPr sz="950" b="0">
-                <a:solidFill>
-                  <a:srgbClr val="1A1A1A"/>
-                </a:solidFill>
-                <a:latin typeface="맑은 고딕"/>
-                <a:ea typeface="맑은 고딕"/>
-              </a:rPr>
-              <a:t>잡음 범위 0.968 ~ 1.033 (sd 0.020, 20개 비교)</a:t>
-            </a:r>
-          </a:p>
-        </p:txBody>
-      </p:sp>
-      <p:sp>
-        <p:nvSpPr>
-          <p:cNvPr id="64" name="Rectangle 63"/>
-          <p:cNvSpPr/>
-          <p:nvPr/>
-        </p:nvSpPr>
-        <p:spPr>
-          <a:xfrm>
-            <a:off x="5760720" y="1371600"/>
-            <a:ext cx="1005840" cy="566928"/>
+              <a:rPr sz="800" b="0">
+                <a:solidFill>
+                  <a:srgbClr val="1A1A1A"/>
+                </a:solidFill>
+                <a:latin typeface="맑은 고딕"/>
+                <a:ea typeface="맑은 고딕"/>
+              </a:rPr>
+              <a:t>Max SLO goodput의 Baseline 대비 배수</a:t>
+            </a:r>
+          </a:p>
+          <a:p>
+            <a:pPr algn="l"/>
+            <a:r>
+              <a:rPr sz="800" b="0">
+                <a:solidFill>
+                  <a:srgbClr val="1A1A1A"/>
+                </a:solidFill>
+                <a:latin typeface="맑은 고딕"/>
+                <a:ea typeface="맑은 고딕"/>
+              </a:rPr>
+              <a:t>Oracle-ideal: 미래 접근률을 알고 이동 비용이 0인 </a:t>
+            </a:r>
+          </a:p>
+          <a:p>
+            <a:pPr algn="l"/>
+            <a:r>
+              <a:rPr sz="800" b="0">
+                <a:solidFill>
+                  <a:srgbClr val="1A1A1A"/>
+                </a:solidFill>
+                <a:latin typeface="맑은 고딕"/>
+                <a:ea typeface="맑은 고딕"/>
+              </a:rPr>
+              <a:t>정책</a:t>
+            </a:r>
+          </a:p>
+        </p:txBody>
+      </p:sp>
+      <p:sp>
+        <p:nvSpPr>
+          <p:cNvPr id="67" name="Rectangle 66"/>
+          <p:cNvSpPr/>
+          <p:nvPr/>
+        </p:nvSpPr>
+        <p:spPr>
+          <a:xfrm>
+            <a:off x="3611880" y="1325880"/>
+            <a:ext cx="1691640" cy="786384"/>
           </a:xfrm>
           <a:prstGeom prst="rect">
             <a:avLst/>
@@ -16432,30 +16651,388 @@
           <a:bodyPr rtlCol="0" anchor="ctr" wrap="square" lIns="45720" rIns="45720" tIns="27432" bIns="27432"/>
           <a:lstStyle/>
           <a:p>
+            <a:pPr algn="l"/>
+            <a:r>
+              <a:rPr sz="800" b="0">
+                <a:solidFill>
+                  <a:srgbClr val="1A1A1A"/>
+                </a:solidFill>
+                <a:latin typeface="맑은 고딕"/>
+                <a:ea typeface="맑은 고딕"/>
+              </a:rPr>
+              <a:t>Baseline의 0.97배 미만 (Baselin</a:t>
+            </a:r>
+          </a:p>
+          <a:p>
+            <a:pPr algn="l"/>
+            <a:r>
+              <a:rPr sz="800" b="0">
+                <a:solidFill>
+                  <a:srgbClr val="1A1A1A"/>
+                </a:solidFill>
+                <a:latin typeface="맑은 고딕"/>
+                <a:ea typeface="맑은 고딕"/>
+              </a:rPr>
+              <a:t>e보다 느림)</a:t>
+            </a:r>
+          </a:p>
+        </p:txBody>
+      </p:sp>
+      <p:sp>
+        <p:nvSpPr>
+          <p:cNvPr id="68" name="Rectangle 67"/>
+          <p:cNvSpPr/>
+          <p:nvPr/>
+        </p:nvSpPr>
+        <p:spPr>
+          <a:xfrm>
+            <a:off x="5303520" y="1325880"/>
+            <a:ext cx="1920240" cy="786384"/>
+          </a:xfrm>
+          <a:prstGeom prst="rect">
+            <a:avLst/>
+          </a:prstGeom>
+          <a:solidFill>
+            <a:srgbClr val="FFFFFF"/>
+          </a:solidFill>
+          <a:ln w="9525">
+            <a:solidFill>
+              <a:srgbClr val="BFBFBF"/>
+            </a:solidFill>
+          </a:ln>
+          <a:effectLst/>
+        </p:spPr>
+        <p:style>
+          <a:lnRef idx="1">
+            <a:schemeClr val="accent1"/>
+          </a:lnRef>
+          <a:fillRef idx="3">
+            <a:schemeClr val="accent1"/>
+          </a:fillRef>
+          <a:effectRef idx="2">
+            <a:schemeClr val="accent1"/>
+          </a:effectRef>
+          <a:fontRef idx="minor">
+            <a:schemeClr val="lt1"/>
+          </a:fontRef>
+        </p:style>
+        <p:txBody>
+          <a:bodyPr rtlCol="0" anchor="ctr" wrap="square" lIns="45720" rIns="45720" tIns="27432" bIns="27432"/>
+          <a:lstStyle/>
+          <a:p>
+            <a:pPr algn="l"/>
+            <a:r>
+              <a:rPr sz="800" b="0">
+                <a:solidFill>
+                  <a:srgbClr val="1A1A1A"/>
+                </a:solidFill>
+                <a:latin typeface="맑은 고딕"/>
+                <a:ea typeface="맑은 고딕"/>
+              </a:rPr>
+              <a:t>0.97배 이상이고 Oracle 이득의 80% </a:t>
+            </a:r>
+          </a:p>
+          <a:p>
+            <a:pPr algn="l"/>
+            <a:r>
+              <a:rPr sz="800" b="0">
+                <a:solidFill>
+                  <a:srgbClr val="1A1A1A"/>
+                </a:solidFill>
+                <a:latin typeface="맑은 고딕"/>
+                <a:ea typeface="맑은 고딕"/>
+              </a:rPr>
+              <a:t>미만</a:t>
+            </a:r>
+          </a:p>
+        </p:txBody>
+      </p:sp>
+      <p:sp>
+        <p:nvSpPr>
+          <p:cNvPr id="69" name="Rectangle 68"/>
+          <p:cNvSpPr/>
+          <p:nvPr/>
+        </p:nvSpPr>
+        <p:spPr>
+          <a:xfrm>
+            <a:off x="7223760" y="1325880"/>
+            <a:ext cx="1600200" cy="786384"/>
+          </a:xfrm>
+          <a:prstGeom prst="rect">
+            <a:avLst/>
+          </a:prstGeom>
+          <a:solidFill>
+            <a:srgbClr val="FFFFFF"/>
+          </a:solidFill>
+          <a:ln w="9525">
+            <a:solidFill>
+              <a:srgbClr val="BFBFBF"/>
+            </a:solidFill>
+          </a:ln>
+          <a:effectLst/>
+        </p:spPr>
+        <p:style>
+          <a:lnRef idx="1">
+            <a:schemeClr val="accent1"/>
+          </a:lnRef>
+          <a:fillRef idx="3">
+            <a:schemeClr val="accent1"/>
+          </a:fillRef>
+          <a:effectRef idx="2">
+            <a:schemeClr val="accent1"/>
+          </a:effectRef>
+          <a:fontRef idx="minor">
+            <a:schemeClr val="lt1"/>
+          </a:fontRef>
+        </p:style>
+        <p:txBody>
+          <a:bodyPr rtlCol="0" anchor="ctr" wrap="square" lIns="45720" rIns="45720" tIns="27432" bIns="27432"/>
+          <a:lstStyle/>
+          <a:p>
+            <a:pPr algn="l"/>
+            <a:r>
+              <a:rPr sz="800" b="0">
+                <a:solidFill>
+                  <a:srgbClr val="1A1A1A"/>
+                </a:solidFill>
+                <a:latin typeface="맑은 고딕"/>
+                <a:ea typeface="맑은 고딕"/>
+              </a:rPr>
+              <a:t>Oracle 이득의 80% 이상</a:t>
+            </a:r>
+          </a:p>
+        </p:txBody>
+      </p:sp>
+      <p:sp>
+        <p:nvSpPr>
+          <p:cNvPr id="70" name="Rectangle 69"/>
+          <p:cNvSpPr/>
+          <p:nvPr/>
+        </p:nvSpPr>
+        <p:spPr>
+          <a:xfrm>
+            <a:off x="8823960" y="1325880"/>
+            <a:ext cx="1965960" cy="786384"/>
+          </a:xfrm>
+          <a:prstGeom prst="rect">
+            <a:avLst/>
+          </a:prstGeom>
+          <a:solidFill>
+            <a:srgbClr val="FFFFFF"/>
+          </a:solidFill>
+          <a:ln w="9525">
+            <a:solidFill>
+              <a:srgbClr val="BFBFBF"/>
+            </a:solidFill>
+          </a:ln>
+          <a:effectLst/>
+        </p:spPr>
+        <p:style>
+          <a:lnRef idx="1">
+            <a:schemeClr val="accent1"/>
+          </a:lnRef>
+          <a:fillRef idx="3">
+            <a:schemeClr val="accent1"/>
+          </a:fillRef>
+          <a:effectRef idx="2">
+            <a:schemeClr val="accent1"/>
+          </a:effectRef>
+          <a:fontRef idx="minor">
+            <a:schemeClr val="lt1"/>
+          </a:fontRef>
+        </p:style>
+        <p:txBody>
+          <a:bodyPr rtlCol="0" anchor="ctr" wrap="square" lIns="45720" rIns="45720" tIns="27432" bIns="27432"/>
+          <a:lstStyle/>
+          <a:p>
+            <a:pPr algn="l"/>
+            <a:r>
+              <a:rPr sz="800" b="0">
+                <a:solidFill>
+                  <a:srgbClr val="1A1A1A"/>
+                </a:solidFill>
+                <a:latin typeface="맑은 고딕"/>
+                <a:ea typeface="맑은 고딕"/>
+              </a:rPr>
+              <a:t>★/★★: Baseline끼리 비교해도 0.968</a:t>
+            </a:r>
+          </a:p>
+          <a:p>
+            <a:pPr algn="l"/>
+            <a:r>
+              <a:rPr sz="800" b="0">
+                <a:solidFill>
+                  <a:srgbClr val="1A1A1A"/>
+                </a:solidFill>
+                <a:latin typeface="맑은 고딕"/>
+                <a:ea typeface="맑은 고딕"/>
+              </a:rPr>
+              <a:t>~1.033배 흔들림(측정). ★★★: 문헌 </a:t>
+            </a:r>
+          </a:p>
+          <a:p>
+            <a:pPr algn="l"/>
+            <a:r>
+              <a:rPr sz="800" b="0">
+                <a:solidFill>
+                  <a:srgbClr val="1A1A1A"/>
+                </a:solidFill>
+                <a:latin typeface="맑은 고딕"/>
+                <a:ea typeface="맑은 고딕"/>
+              </a:rPr>
+              <a:t>달성률 중앙값 81%</a:t>
+            </a:r>
+          </a:p>
+        </p:txBody>
+      </p:sp>
+      <p:sp>
+        <p:nvSpPr>
+          <p:cNvPr id="71" name="Rectangle 70"/>
+          <p:cNvSpPr/>
+          <p:nvPr/>
+        </p:nvSpPr>
+        <p:spPr>
+          <a:xfrm>
+            <a:off x="10789920" y="1325880"/>
+            <a:ext cx="1097280" cy="786384"/>
+          </a:xfrm>
+          <a:prstGeom prst="rect">
+            <a:avLst/>
+          </a:prstGeom>
+          <a:solidFill>
+            <a:srgbClr val="FFFFFF"/>
+          </a:solidFill>
+          <a:ln w="9525">
+            <a:solidFill>
+              <a:srgbClr val="BFBFBF"/>
+            </a:solidFill>
+          </a:ln>
+          <a:effectLst/>
+        </p:spPr>
+        <p:style>
+          <a:lnRef idx="1">
+            <a:schemeClr val="accent1"/>
+          </a:lnRef>
+          <a:fillRef idx="3">
+            <a:schemeClr val="accent1"/>
+          </a:fillRef>
+          <a:effectRef idx="2">
+            <a:schemeClr val="accent1"/>
+          </a:effectRef>
+          <a:fontRef idx="minor">
+            <a:schemeClr val="lt1"/>
+          </a:fontRef>
+        </p:style>
+        <p:txBody>
+          <a:bodyPr rtlCol="0" anchor="ctr" wrap="square" lIns="45720" rIns="45720" tIns="27432" bIns="27432"/>
+          <a:lstStyle/>
+          <a:p>
             <a:pPr algn="ctr"/>
             <a:r>
-              <a:rPr sz="950" b="1">
-                <a:solidFill>
-                  <a:srgbClr val="1A1A1A"/>
-                </a:solidFill>
-                <a:latin typeface="맑은 고딕"/>
-                <a:ea typeface="맑은 고딕"/>
-              </a:rPr>
-              <a:t>0.97</a:t>
-            </a:r>
-          </a:p>
-        </p:txBody>
-      </p:sp>
-      <p:sp>
-        <p:nvSpPr>
-          <p:cNvPr id="65" name="Rectangle 64"/>
-          <p:cNvSpPr/>
-          <p:nvPr/>
-        </p:nvSpPr>
-        <p:spPr>
-          <a:xfrm>
-            <a:off x="6766560" y="1371600"/>
-            <a:ext cx="5029200" cy="566928"/>
+              <a:rPr sz="800" b="0">
+                <a:solidFill>
+                  <a:srgbClr val="1A1A1A"/>
+                </a:solidFill>
+                <a:latin typeface="맑은 고딕"/>
+                <a:ea typeface="맑은 고딕"/>
+              </a:rPr>
+              <a:t>C1 ★★ 62%</a:t>
+            </a:r>
+          </a:p>
+          <a:p>
+            <a:pPr algn="ctr"/>
+            <a:r>
+              <a:rPr sz="800" b="0">
+                <a:solidFill>
+                  <a:srgbClr val="1A1A1A"/>
+                </a:solidFill>
+                <a:latin typeface="맑은 고딕"/>
+                <a:ea typeface="맑은 고딕"/>
+              </a:rPr>
+              <a:t>C2 ★★★ 83%</a:t>
+            </a:r>
+          </a:p>
+        </p:txBody>
+      </p:sp>
+      <p:sp>
+        <p:nvSpPr>
+          <p:cNvPr id="72" name="Rectangle 71"/>
+          <p:cNvSpPr/>
+          <p:nvPr/>
+        </p:nvSpPr>
+        <p:spPr>
+          <a:xfrm>
+            <a:off x="320040" y="2139696"/>
+            <a:ext cx="777240" cy="786384"/>
+          </a:xfrm>
+          <a:prstGeom prst="rect">
+            <a:avLst/>
+          </a:prstGeom>
+          <a:solidFill>
+            <a:srgbClr val="DCE9F5"/>
+          </a:solidFill>
+          <a:ln w="9525">
+            <a:solidFill>
+              <a:srgbClr val="4D7EA8"/>
+            </a:solidFill>
+          </a:ln>
+          <a:effectLst/>
+        </p:spPr>
+        <p:style>
+          <a:lnRef idx="1">
+            <a:schemeClr val="accent1"/>
+          </a:lnRef>
+          <a:fillRef idx="3">
+            <a:schemeClr val="accent1"/>
+          </a:fillRef>
+          <a:effectRef idx="2">
+            <a:schemeClr val="accent1"/>
+          </a:effectRef>
+          <a:fontRef idx="minor">
+            <a:schemeClr val="lt1"/>
+          </a:fontRef>
+        </p:style>
+        <p:txBody>
+          <a:bodyPr rtlCol="0" anchor="ctr" wrap="square" lIns="45720" rIns="45720" tIns="27432" bIns="27432"/>
+          <a:lstStyle/>
+          <a:p>
+            <a:pPr algn="ctr"/>
+            <a:r>
+              <a:rPr sz="800" b="1">
+                <a:solidFill>
+                  <a:srgbClr val="1A1A1A"/>
+                </a:solidFill>
+                <a:latin typeface="맑은 고딕"/>
+                <a:ea typeface="맑은 고딕"/>
+              </a:rPr>
+              <a:t>QA2</a:t>
+            </a:r>
+          </a:p>
+          <a:p>
+            <a:pPr algn="ctr"/>
+            <a:r>
+              <a:rPr sz="800" b="1">
+                <a:solidFill>
+                  <a:srgbClr val="1A1A1A"/>
+                </a:solidFill>
+                <a:latin typeface="맑은 고딕"/>
+                <a:ea typeface="맑은 고딕"/>
+              </a:rPr>
+              <a:t>지연</a:t>
+            </a:r>
+          </a:p>
+        </p:txBody>
+      </p:sp>
+      <p:sp>
+        <p:nvSpPr>
+          <p:cNvPr id="73" name="Rectangle 72"/>
+          <p:cNvSpPr/>
+          <p:nvPr/>
+        </p:nvSpPr>
+        <p:spPr>
+          <a:xfrm>
+            <a:off x="1097280" y="2139696"/>
+            <a:ext cx="2514600" cy="786384"/>
           </a:xfrm>
           <a:prstGeom prst="rect">
             <a:avLst/>
@@ -16490,28 +17067,412 @@
           <a:p>
             <a:pPr algn="l"/>
             <a:r>
-              <a:rPr sz="900" b="0">
-                <a:solidFill>
-                  <a:srgbClr val="1A1A1A"/>
-                </a:solidFill>
-                <a:latin typeface="맑은 고딕"/>
-                <a:ea typeface="맑은 고딕"/>
-              </a:rPr>
-              <a:t>x1.30 = 23% 하드웨어 절감 = 8-GPU 노드에서 약 1.85 GPU (x1.14가 1 GPU)</a:t>
-            </a:r>
-          </a:p>
-        </p:txBody>
-      </p:sp>
-      <p:sp>
-        <p:nvSpPr>
-          <p:cNvPr id="66" name="Rectangle 65"/>
-          <p:cNvSpPr/>
-          <p:nvPr/>
-        </p:nvSpPr>
-        <p:spPr>
-          <a:xfrm>
-            <a:off x="365760" y="1975104"/>
-            <a:ext cx="1188720" cy="566928"/>
+              <a:rPr sz="800" b="0">
+                <a:solidFill>
+                  <a:srgbClr val="1A1A1A"/>
+                </a:solidFill>
+                <a:latin typeface="맑은 고딕"/>
+                <a:ea typeface="맑은 고딕"/>
+              </a:rPr>
+              <a:t>TTFT·TPOT x P50/95/99 6개 지표 개선 배수(Basel</a:t>
+            </a:r>
+          </a:p>
+          <a:p>
+            <a:pPr algn="l"/>
+            <a:r>
+              <a:rPr sz="800" b="0">
+                <a:solidFill>
+                  <a:srgbClr val="1A1A1A"/>
+                </a:solidFill>
+                <a:latin typeface="맑은 고딕"/>
+                <a:ea typeface="맑은 고딕"/>
+              </a:rPr>
+              <a:t>ine÷후보) 평균</a:t>
+            </a:r>
+          </a:p>
+          <a:p>
+            <a:pPr algn="l"/>
+            <a:r>
+              <a:rPr sz="800" b="0">
+                <a:solidFill>
+                  <a:srgbClr val="1A1A1A"/>
+                </a:solidFill>
+                <a:latin typeface="맑은 고딕"/>
+                <a:ea typeface="맑은 고딕"/>
+              </a:rPr>
+              <a:t>Oracle-lean: 접근된 객체를 이동 비용 없이 HBM에</a:t>
+            </a:r>
+          </a:p>
+          <a:p>
+            <a:pPr algn="l"/>
+            <a:r>
+              <a:rPr sz="800" b="0">
+                <a:solidFill>
+                  <a:srgbClr val="1A1A1A"/>
+                </a:solidFill>
+                <a:latin typeface="맑은 고딕"/>
+                <a:ea typeface="맑은 고딕"/>
+              </a:rPr>
+              <a:t>두는 정책</a:t>
+            </a:r>
+          </a:p>
+        </p:txBody>
+      </p:sp>
+      <p:sp>
+        <p:nvSpPr>
+          <p:cNvPr id="74" name="Rectangle 73"/>
+          <p:cNvSpPr/>
+          <p:nvPr/>
+        </p:nvSpPr>
+        <p:spPr>
+          <a:xfrm>
+            <a:off x="3611880" y="2139696"/>
+            <a:ext cx="1691640" cy="786384"/>
+          </a:xfrm>
+          <a:prstGeom prst="rect">
+            <a:avLst/>
+          </a:prstGeom>
+          <a:solidFill>
+            <a:srgbClr val="FFFFFF"/>
+          </a:solidFill>
+          <a:ln w="9525">
+            <a:solidFill>
+              <a:srgbClr val="BFBFBF"/>
+            </a:solidFill>
+          </a:ln>
+          <a:effectLst/>
+        </p:spPr>
+        <p:style>
+          <a:lnRef idx="1">
+            <a:schemeClr val="accent1"/>
+          </a:lnRef>
+          <a:fillRef idx="3">
+            <a:schemeClr val="accent1"/>
+          </a:fillRef>
+          <a:effectRef idx="2">
+            <a:schemeClr val="accent1"/>
+          </a:effectRef>
+          <a:fontRef idx="minor">
+            <a:schemeClr val="lt1"/>
+          </a:fontRef>
+        </p:style>
+        <p:txBody>
+          <a:bodyPr rtlCol="0" anchor="ctr" wrap="square" lIns="45720" rIns="45720" tIns="27432" bIns="27432"/>
+          <a:lstStyle/>
+          <a:p>
+            <a:pPr algn="l"/>
+            <a:r>
+              <a:rPr sz="800" b="0">
+                <a:solidFill>
+                  <a:srgbClr val="1A1A1A"/>
+                </a:solidFill>
+                <a:latin typeface="맑은 고딕"/>
+                <a:ea typeface="맑은 고딕"/>
+              </a:rPr>
+              <a:t>0.95배 미만 (지연이 5%+ 나빠짐</a:t>
+            </a:r>
+          </a:p>
+          <a:p>
+            <a:pPr algn="l"/>
+            <a:r>
+              <a:rPr sz="800" b="0">
+                <a:solidFill>
+                  <a:srgbClr val="1A1A1A"/>
+                </a:solidFill>
+                <a:latin typeface="맑은 고딕"/>
+                <a:ea typeface="맑은 고딕"/>
+              </a:rPr>
+              <a:t>)</a:t>
+            </a:r>
+          </a:p>
+        </p:txBody>
+      </p:sp>
+      <p:sp>
+        <p:nvSpPr>
+          <p:cNvPr id="75" name="Rectangle 74"/>
+          <p:cNvSpPr/>
+          <p:nvPr/>
+        </p:nvSpPr>
+        <p:spPr>
+          <a:xfrm>
+            <a:off x="5303520" y="2139696"/>
+            <a:ext cx="1920240" cy="786384"/>
+          </a:xfrm>
+          <a:prstGeom prst="rect">
+            <a:avLst/>
+          </a:prstGeom>
+          <a:solidFill>
+            <a:srgbClr val="FFFFFF"/>
+          </a:solidFill>
+          <a:ln w="9525">
+            <a:solidFill>
+              <a:srgbClr val="BFBFBF"/>
+            </a:solidFill>
+          </a:ln>
+          <a:effectLst/>
+        </p:spPr>
+        <p:style>
+          <a:lnRef idx="1">
+            <a:schemeClr val="accent1"/>
+          </a:lnRef>
+          <a:fillRef idx="3">
+            <a:schemeClr val="accent1"/>
+          </a:fillRef>
+          <a:effectRef idx="2">
+            <a:schemeClr val="accent1"/>
+          </a:effectRef>
+          <a:fontRef idx="minor">
+            <a:schemeClr val="lt1"/>
+          </a:fontRef>
+        </p:style>
+        <p:txBody>
+          <a:bodyPr rtlCol="0" anchor="ctr" wrap="square" lIns="45720" rIns="45720" tIns="27432" bIns="27432"/>
+          <a:lstStyle/>
+          <a:p>
+            <a:pPr algn="l"/>
+            <a:r>
+              <a:rPr sz="800" b="0">
+                <a:solidFill>
+                  <a:srgbClr val="1A1A1A"/>
+                </a:solidFill>
+                <a:latin typeface="맑은 고딕"/>
+                <a:ea typeface="맑은 고딕"/>
+              </a:rPr>
+              <a:t>0.95배 이상이고 Oracle 이득의 80% </a:t>
+            </a:r>
+          </a:p>
+          <a:p>
+            <a:pPr algn="l"/>
+            <a:r>
+              <a:rPr sz="800" b="0">
+                <a:solidFill>
+                  <a:srgbClr val="1A1A1A"/>
+                </a:solidFill>
+                <a:latin typeface="맑은 고딕"/>
+                <a:ea typeface="맑은 고딕"/>
+              </a:rPr>
+              <a:t>미만</a:t>
+            </a:r>
+          </a:p>
+        </p:txBody>
+      </p:sp>
+      <p:sp>
+        <p:nvSpPr>
+          <p:cNvPr id="76" name="Rectangle 75"/>
+          <p:cNvSpPr/>
+          <p:nvPr/>
+        </p:nvSpPr>
+        <p:spPr>
+          <a:xfrm>
+            <a:off x="7223760" y="2139696"/>
+            <a:ext cx="1600200" cy="786384"/>
+          </a:xfrm>
+          <a:prstGeom prst="rect">
+            <a:avLst/>
+          </a:prstGeom>
+          <a:solidFill>
+            <a:srgbClr val="FFFFFF"/>
+          </a:solidFill>
+          <a:ln w="9525">
+            <a:solidFill>
+              <a:srgbClr val="BFBFBF"/>
+            </a:solidFill>
+          </a:ln>
+          <a:effectLst/>
+        </p:spPr>
+        <p:style>
+          <a:lnRef idx="1">
+            <a:schemeClr val="accent1"/>
+          </a:lnRef>
+          <a:fillRef idx="3">
+            <a:schemeClr val="accent1"/>
+          </a:fillRef>
+          <a:effectRef idx="2">
+            <a:schemeClr val="accent1"/>
+          </a:effectRef>
+          <a:fontRef idx="minor">
+            <a:schemeClr val="lt1"/>
+          </a:fontRef>
+        </p:style>
+        <p:txBody>
+          <a:bodyPr rtlCol="0" anchor="ctr" wrap="square" lIns="45720" rIns="45720" tIns="27432" bIns="27432"/>
+          <a:lstStyle/>
+          <a:p>
+            <a:pPr algn="l"/>
+            <a:r>
+              <a:rPr sz="800" b="0">
+                <a:solidFill>
+                  <a:srgbClr val="1A1A1A"/>
+                </a:solidFill>
+                <a:latin typeface="맑은 고딕"/>
+                <a:ea typeface="맑은 고딕"/>
+              </a:rPr>
+              <a:t>Oracle 이득의 80% 이상</a:t>
+            </a:r>
+          </a:p>
+        </p:txBody>
+      </p:sp>
+      <p:sp>
+        <p:nvSpPr>
+          <p:cNvPr id="77" name="Rectangle 76"/>
+          <p:cNvSpPr/>
+          <p:nvPr/>
+        </p:nvSpPr>
+        <p:spPr>
+          <a:xfrm>
+            <a:off x="8823960" y="2139696"/>
+            <a:ext cx="1965960" cy="786384"/>
+          </a:xfrm>
+          <a:prstGeom prst="rect">
+            <a:avLst/>
+          </a:prstGeom>
+          <a:solidFill>
+            <a:srgbClr val="FFFFFF"/>
+          </a:solidFill>
+          <a:ln w="9525">
+            <a:solidFill>
+              <a:srgbClr val="BFBFBF"/>
+            </a:solidFill>
+          </a:ln>
+          <a:effectLst/>
+        </p:spPr>
+        <p:style>
+          <a:lnRef idx="1">
+            <a:schemeClr val="accent1"/>
+          </a:lnRef>
+          <a:fillRef idx="3">
+            <a:schemeClr val="accent1"/>
+          </a:fillRef>
+          <a:effectRef idx="2">
+            <a:schemeClr val="accent1"/>
+          </a:effectRef>
+          <a:fontRef idx="minor">
+            <a:schemeClr val="lt1"/>
+          </a:fontRef>
+        </p:style>
+        <p:txBody>
+          <a:bodyPr rtlCol="0" anchor="ctr" wrap="square" lIns="45720" rIns="45720" tIns="27432" bIns="27432"/>
+          <a:lstStyle/>
+          <a:p>
+            <a:pPr algn="l"/>
+            <a:r>
+              <a:rPr sz="800" b="0">
+                <a:solidFill>
+                  <a:srgbClr val="1A1A1A"/>
+                </a:solidFill>
+                <a:latin typeface="맑은 고딕"/>
+                <a:ea typeface="맑은 고딕"/>
+              </a:rPr>
+              <a:t>Baseline끼리 0.973~1.028배(측정), 약</a:t>
+            </a:r>
+          </a:p>
+          <a:p>
+            <a:pPr algn="l"/>
+            <a:r>
+              <a:rPr sz="800" b="0">
+                <a:solidFill>
+                  <a:srgbClr val="1A1A1A"/>
+                </a:solidFill>
+                <a:latin typeface="맑은 고딕"/>
+                <a:ea typeface="맑은 고딕"/>
+              </a:rPr>
+              <a:t>간 느슨하게 0.95. ★★★은 QA1과 같</a:t>
+            </a:r>
+          </a:p>
+          <a:p>
+            <a:pPr algn="l"/>
+            <a:r>
+              <a:rPr sz="800" b="0">
+                <a:solidFill>
+                  <a:srgbClr val="1A1A1A"/>
+                </a:solidFill>
+                <a:latin typeface="맑은 고딕"/>
+                <a:ea typeface="맑은 고딕"/>
+              </a:rPr>
+              <a:t>은 80%</a:t>
+            </a:r>
+          </a:p>
+        </p:txBody>
+      </p:sp>
+      <p:sp>
+        <p:nvSpPr>
+          <p:cNvPr id="78" name="Rectangle 77"/>
+          <p:cNvSpPr/>
+          <p:nvPr/>
+        </p:nvSpPr>
+        <p:spPr>
+          <a:xfrm>
+            <a:off x="10789920" y="2139696"/>
+            <a:ext cx="1097280" cy="786384"/>
+          </a:xfrm>
+          <a:prstGeom prst="rect">
+            <a:avLst/>
+          </a:prstGeom>
+          <a:solidFill>
+            <a:srgbClr val="FFFFFF"/>
+          </a:solidFill>
+          <a:ln w="9525">
+            <a:solidFill>
+              <a:srgbClr val="BFBFBF"/>
+            </a:solidFill>
+          </a:ln>
+          <a:effectLst/>
+        </p:spPr>
+        <p:style>
+          <a:lnRef idx="1">
+            <a:schemeClr val="accent1"/>
+          </a:lnRef>
+          <a:fillRef idx="3">
+            <a:schemeClr val="accent1"/>
+          </a:fillRef>
+          <a:effectRef idx="2">
+            <a:schemeClr val="accent1"/>
+          </a:effectRef>
+          <a:fontRef idx="minor">
+            <a:schemeClr val="lt1"/>
+          </a:fontRef>
+        </p:style>
+        <p:txBody>
+          <a:bodyPr rtlCol="0" anchor="ctr" wrap="square" lIns="45720" rIns="45720" tIns="27432" bIns="27432"/>
+          <a:lstStyle/>
+          <a:p>
+            <a:pPr algn="ctr"/>
+            <a:r>
+              <a:rPr sz="800" b="0">
+                <a:solidFill>
+                  <a:srgbClr val="1A1A1A"/>
+                </a:solidFill>
+                <a:latin typeface="맑은 고딕"/>
+                <a:ea typeface="맑은 고딕"/>
+              </a:rPr>
+              <a:t>C1 ★★ 23%</a:t>
+            </a:r>
+          </a:p>
+          <a:p>
+            <a:pPr algn="ctr"/>
+            <a:r>
+              <a:rPr sz="800" b="0">
+                <a:solidFill>
+                  <a:srgbClr val="1A1A1A"/>
+                </a:solidFill>
+                <a:latin typeface="맑은 고딕"/>
+                <a:ea typeface="맑은 고딕"/>
+              </a:rPr>
+              <a:t>C2 ★★ 42%</a:t>
+            </a:r>
+          </a:p>
+        </p:txBody>
+      </p:sp>
+      <p:sp>
+        <p:nvSpPr>
+          <p:cNvPr id="79" name="Rectangle 78"/>
+          <p:cNvSpPr/>
+          <p:nvPr/>
+        </p:nvSpPr>
+        <p:spPr>
+          <a:xfrm>
+            <a:off x="320040" y="2953512"/>
+            <a:ext cx="777240" cy="786384"/>
           </a:xfrm>
           <a:prstGeom prst="rect">
             <a:avLst/>
@@ -16544,30 +17505,43 @@
           <a:bodyPr rtlCol="0" anchor="ctr" wrap="square" lIns="45720" rIns="45720" tIns="27432" bIns="27432"/>
           <a:lstStyle/>
           <a:p>
-            <a:pPr algn="l"/>
-            <a:r>
-              <a:rPr sz="950" b="1">
-                <a:solidFill>
-                  <a:srgbClr val="1A1A1A"/>
-                </a:solidFill>
-                <a:latin typeface="맑은 고딕"/>
-                <a:ea typeface="맑은 고딕"/>
-              </a:rPr>
-              <a:t>QA2 latency</a:t>
-            </a:r>
-          </a:p>
-        </p:txBody>
-      </p:sp>
-      <p:sp>
-        <p:nvSpPr>
-          <p:cNvPr id="67" name="Rectangle 66"/>
-          <p:cNvSpPr/>
-          <p:nvPr/>
-        </p:nvSpPr>
-        <p:spPr>
-          <a:xfrm>
-            <a:off x="1554480" y="1975104"/>
-            <a:ext cx="4206240" cy="566928"/>
+            <a:pPr algn="ctr"/>
+            <a:r>
+              <a:rPr sz="800" b="1">
+                <a:solidFill>
+                  <a:srgbClr val="1A1A1A"/>
+                </a:solidFill>
+                <a:latin typeface="맑은 고딕"/>
+                <a:ea typeface="맑은 고딕"/>
+              </a:rPr>
+              <a:t>QA3</a:t>
+            </a:r>
+          </a:p>
+          <a:p>
+            <a:pPr algn="ctr"/>
+            <a:r>
+              <a:rPr sz="800" b="1">
+                <a:solidFill>
+                  <a:srgbClr val="1A1A1A"/>
+                </a:solidFill>
+                <a:latin typeface="맑은 고딕"/>
+                <a:ea typeface="맑은 고딕"/>
+              </a:rPr>
+              <a:t>HBM 사용</a:t>
+            </a:r>
+          </a:p>
+        </p:txBody>
+      </p:sp>
+      <p:sp>
+        <p:nvSpPr>
+          <p:cNvPr id="80" name="Rectangle 79"/>
+          <p:cNvSpPr/>
+          <p:nvPr/>
+        </p:nvSpPr>
+        <p:spPr>
+          <a:xfrm>
+            <a:off x="1097280" y="2953512"/>
+            <a:ext cx="2514600" cy="786384"/>
           </a:xfrm>
           <a:prstGeom prst="rect">
             <a:avLst/>
@@ -16602,28 +17576,54 @@
           <a:p>
             <a:pPr algn="l"/>
             <a:r>
-              <a:rPr sz="950" b="0">
-                <a:solidFill>
-                  <a:srgbClr val="1A1A1A"/>
-                </a:solidFill>
-                <a:latin typeface="맑은 고딕"/>
-                <a:ea typeface="맑은 고딕"/>
-              </a:rPr>
-              <a:t>잡음 범위 0.973 ~ 1.028 (sd 0.016, 20개 비교)</a:t>
-            </a:r>
-          </a:p>
-        </p:txBody>
-      </p:sp>
-      <p:sp>
-        <p:nvSpPr>
-          <p:cNvPr id="68" name="Rectangle 67"/>
-          <p:cNvSpPr/>
-          <p:nvPr/>
-        </p:nvSpPr>
-        <p:spPr>
-          <a:xfrm>
-            <a:off x="5760720" y="1975104"/>
-            <a:ext cx="1005840" cy="566928"/>
+              <a:rPr sz="800" b="0">
+                <a:solidFill>
+                  <a:srgbClr val="1A1A1A"/>
+                </a:solidFill>
+                <a:latin typeface="맑은 고딕"/>
+                <a:ea typeface="맑은 고딕"/>
+              </a:rPr>
+              <a:t>HBM 절감 배수(Baseline GiB÷후보 GiB)</a:t>
+            </a:r>
+          </a:p>
+          <a:p>
+            <a:pPr algn="l"/>
+            <a:r>
+              <a:rPr sz="800" b="0">
+                <a:solidFill>
+                  <a:srgbClr val="1A1A1A"/>
+                </a:solidFill>
+                <a:latin typeface="맑은 고딕"/>
+                <a:ea typeface="맑은 고딕"/>
+              </a:rPr>
+              <a:t>Oracle-lean: 틱마다 접근된 객체만 HBM에 두는 정</a:t>
+            </a:r>
+          </a:p>
+          <a:p>
+            <a:pPr algn="l"/>
+            <a:r>
+              <a:rPr sz="800" b="0">
+                <a:solidFill>
+                  <a:srgbClr val="1A1A1A"/>
+                </a:solidFill>
+                <a:latin typeface="맑은 고딕"/>
+                <a:ea typeface="맑은 고딕"/>
+              </a:rPr>
+              <a:t>책</a:t>
+            </a:r>
+          </a:p>
+        </p:txBody>
+      </p:sp>
+      <p:sp>
+        <p:nvSpPr>
+          <p:cNvPr id="81" name="Rectangle 80"/>
+          <p:cNvSpPr/>
+          <p:nvPr/>
+        </p:nvSpPr>
+        <p:spPr>
+          <a:xfrm>
+            <a:off x="3611880" y="2953512"/>
+            <a:ext cx="1691640" cy="786384"/>
           </a:xfrm>
           <a:prstGeom prst="rect">
             <a:avLst/>
@@ -16656,30 +17656,388 @@
           <a:bodyPr rtlCol="0" anchor="ctr" wrap="square" lIns="45720" rIns="45720" tIns="27432" bIns="27432"/>
           <a:lstStyle/>
           <a:p>
+            <a:pPr algn="l"/>
+            <a:r>
+              <a:rPr sz="800" b="0">
+                <a:solidFill>
+                  <a:srgbClr val="1A1A1A"/>
+                </a:solidFill>
+                <a:latin typeface="맑은 고딕"/>
+                <a:ea typeface="맑은 고딕"/>
+              </a:rPr>
+              <a:t>0.95배 미만 (HBM을 5%+ 더 씀)</a:t>
+            </a:r>
+          </a:p>
+        </p:txBody>
+      </p:sp>
+      <p:sp>
+        <p:nvSpPr>
+          <p:cNvPr id="82" name="Rectangle 81"/>
+          <p:cNvSpPr/>
+          <p:nvPr/>
+        </p:nvSpPr>
+        <p:spPr>
+          <a:xfrm>
+            <a:off x="5303520" y="2953512"/>
+            <a:ext cx="1920240" cy="786384"/>
+          </a:xfrm>
+          <a:prstGeom prst="rect">
+            <a:avLst/>
+          </a:prstGeom>
+          <a:solidFill>
+            <a:srgbClr val="FFFFFF"/>
+          </a:solidFill>
+          <a:ln w="9525">
+            <a:solidFill>
+              <a:srgbClr val="BFBFBF"/>
+            </a:solidFill>
+          </a:ln>
+          <a:effectLst/>
+        </p:spPr>
+        <p:style>
+          <a:lnRef idx="1">
+            <a:schemeClr val="accent1"/>
+          </a:lnRef>
+          <a:fillRef idx="3">
+            <a:schemeClr val="accent1"/>
+          </a:fillRef>
+          <a:effectRef idx="2">
+            <a:schemeClr val="accent1"/>
+          </a:effectRef>
+          <a:fontRef idx="minor">
+            <a:schemeClr val="lt1"/>
+          </a:fontRef>
+        </p:style>
+        <p:txBody>
+          <a:bodyPr rtlCol="0" anchor="ctr" wrap="square" lIns="45720" rIns="45720" tIns="27432" bIns="27432"/>
+          <a:lstStyle/>
+          <a:p>
+            <a:pPr algn="l"/>
+            <a:r>
+              <a:rPr sz="800" b="0">
+                <a:solidFill>
+                  <a:srgbClr val="1A1A1A"/>
+                </a:solidFill>
+                <a:latin typeface="맑은 고딕"/>
+                <a:ea typeface="맑은 고딕"/>
+              </a:rPr>
+              <a:t>0.95배 이상이고 Oracle 절감의 80% </a:t>
+            </a:r>
+          </a:p>
+          <a:p>
+            <a:pPr algn="l"/>
+            <a:r>
+              <a:rPr sz="800" b="0">
+                <a:solidFill>
+                  <a:srgbClr val="1A1A1A"/>
+                </a:solidFill>
+                <a:latin typeface="맑은 고딕"/>
+                <a:ea typeface="맑은 고딕"/>
+              </a:rPr>
+              <a:t>미만</a:t>
+            </a:r>
+          </a:p>
+        </p:txBody>
+      </p:sp>
+      <p:sp>
+        <p:nvSpPr>
+          <p:cNvPr id="83" name="Rectangle 82"/>
+          <p:cNvSpPr/>
+          <p:nvPr/>
+        </p:nvSpPr>
+        <p:spPr>
+          <a:xfrm>
+            <a:off x="7223760" y="2953512"/>
+            <a:ext cx="1600200" cy="786384"/>
+          </a:xfrm>
+          <a:prstGeom prst="rect">
+            <a:avLst/>
+          </a:prstGeom>
+          <a:solidFill>
+            <a:srgbClr val="FFFFFF"/>
+          </a:solidFill>
+          <a:ln w="9525">
+            <a:solidFill>
+              <a:srgbClr val="BFBFBF"/>
+            </a:solidFill>
+          </a:ln>
+          <a:effectLst/>
+        </p:spPr>
+        <p:style>
+          <a:lnRef idx="1">
+            <a:schemeClr val="accent1"/>
+          </a:lnRef>
+          <a:fillRef idx="3">
+            <a:schemeClr val="accent1"/>
+          </a:fillRef>
+          <a:effectRef idx="2">
+            <a:schemeClr val="accent1"/>
+          </a:effectRef>
+          <a:fontRef idx="minor">
+            <a:schemeClr val="lt1"/>
+          </a:fontRef>
+        </p:style>
+        <p:txBody>
+          <a:bodyPr rtlCol="0" anchor="ctr" wrap="square" lIns="45720" rIns="45720" tIns="27432" bIns="27432"/>
+          <a:lstStyle/>
+          <a:p>
+            <a:pPr algn="l"/>
+            <a:r>
+              <a:rPr sz="800" b="0">
+                <a:solidFill>
+                  <a:srgbClr val="1A1A1A"/>
+                </a:solidFill>
+                <a:latin typeface="맑은 고딕"/>
+                <a:ea typeface="맑은 고딕"/>
+              </a:rPr>
+              <a:t>Oracle 절감의 80% 이상</a:t>
+            </a:r>
+          </a:p>
+        </p:txBody>
+      </p:sp>
+      <p:sp>
+        <p:nvSpPr>
+          <p:cNvPr id="84" name="Rectangle 83"/>
+          <p:cNvSpPr/>
+          <p:nvPr/>
+        </p:nvSpPr>
+        <p:spPr>
+          <a:xfrm>
+            <a:off x="8823960" y="2953512"/>
+            <a:ext cx="1965960" cy="786384"/>
+          </a:xfrm>
+          <a:prstGeom prst="rect">
+            <a:avLst/>
+          </a:prstGeom>
+          <a:solidFill>
+            <a:srgbClr val="FFFFFF"/>
+          </a:solidFill>
+          <a:ln w="9525">
+            <a:solidFill>
+              <a:srgbClr val="BFBFBF"/>
+            </a:solidFill>
+          </a:ln>
+          <a:effectLst/>
+        </p:spPr>
+        <p:style>
+          <a:lnRef idx="1">
+            <a:schemeClr val="accent1"/>
+          </a:lnRef>
+          <a:fillRef idx="3">
+            <a:schemeClr val="accent1"/>
+          </a:fillRef>
+          <a:effectRef idx="2">
+            <a:schemeClr val="accent1"/>
+          </a:effectRef>
+          <a:fontRef idx="minor">
+            <a:schemeClr val="lt1"/>
+          </a:fontRef>
+        </p:style>
+        <p:txBody>
+          <a:bodyPr rtlCol="0" anchor="ctr" wrap="square" lIns="45720" rIns="45720" tIns="27432" bIns="27432"/>
+          <a:lstStyle/>
+          <a:p>
+            <a:pPr algn="l"/>
+            <a:r>
+              <a:rPr sz="800" b="0">
+                <a:solidFill>
+                  <a:srgbClr val="1A1A1A"/>
+                </a:solidFill>
+                <a:latin typeface="맑은 고딕"/>
+                <a:ea typeface="맑은 고딕"/>
+              </a:rPr>
+              <a:t>Baseline끼리 0.984~1.016배(측정), 느</a:t>
+            </a:r>
+          </a:p>
+          <a:p>
+            <a:pPr algn="l"/>
+            <a:r>
+              <a:rPr sz="800" b="0">
+                <a:solidFill>
+                  <a:srgbClr val="1A1A1A"/>
+                </a:solidFill>
+                <a:latin typeface="맑은 고딕"/>
+                <a:ea typeface="맑은 고딕"/>
+              </a:rPr>
+              <a:t>슨하게 0.95. ★★★은 QA1과 같은 80</a:t>
+            </a:r>
+          </a:p>
+          <a:p>
+            <a:pPr algn="l"/>
+            <a:r>
+              <a:rPr sz="800" b="0">
+                <a:solidFill>
+                  <a:srgbClr val="1A1A1A"/>
+                </a:solidFill>
+                <a:latin typeface="맑은 고딕"/>
+                <a:ea typeface="맑은 고딕"/>
+              </a:rPr>
+              <a:t>%</a:t>
+            </a:r>
+          </a:p>
+        </p:txBody>
+      </p:sp>
+      <p:sp>
+        <p:nvSpPr>
+          <p:cNvPr id="85" name="Rectangle 84"/>
+          <p:cNvSpPr/>
+          <p:nvPr/>
+        </p:nvSpPr>
+        <p:spPr>
+          <a:xfrm>
+            <a:off x="10789920" y="2953512"/>
+            <a:ext cx="1097280" cy="786384"/>
+          </a:xfrm>
+          <a:prstGeom prst="rect">
+            <a:avLst/>
+          </a:prstGeom>
+          <a:solidFill>
+            <a:srgbClr val="FFFFFF"/>
+          </a:solidFill>
+          <a:ln w="9525">
+            <a:solidFill>
+              <a:srgbClr val="BFBFBF"/>
+            </a:solidFill>
+          </a:ln>
+          <a:effectLst/>
+        </p:spPr>
+        <p:style>
+          <a:lnRef idx="1">
+            <a:schemeClr val="accent1"/>
+          </a:lnRef>
+          <a:fillRef idx="3">
+            <a:schemeClr val="accent1"/>
+          </a:fillRef>
+          <a:effectRef idx="2">
+            <a:schemeClr val="accent1"/>
+          </a:effectRef>
+          <a:fontRef idx="minor">
+            <a:schemeClr val="lt1"/>
+          </a:fontRef>
+        </p:style>
+        <p:txBody>
+          <a:bodyPr rtlCol="0" anchor="ctr" wrap="square" lIns="45720" rIns="45720" tIns="27432" bIns="27432"/>
+          <a:lstStyle/>
+          <a:p>
             <a:pPr algn="ctr"/>
             <a:r>
-              <a:rPr sz="950" b="1">
-                <a:solidFill>
-                  <a:srgbClr val="1A1A1A"/>
-                </a:solidFill>
-                <a:latin typeface="맑은 고딕"/>
-                <a:ea typeface="맑은 고딕"/>
-              </a:rPr>
-              <a:t>0.95</a:t>
-            </a:r>
-          </a:p>
-        </p:txBody>
-      </p:sp>
-      <p:sp>
-        <p:nvSpPr>
-          <p:cNvPr id="69" name="Rectangle 68"/>
-          <p:cNvSpPr/>
-          <p:nvPr/>
-        </p:nvSpPr>
-        <p:spPr>
-          <a:xfrm>
-            <a:off x="6766560" y="1975104"/>
-            <a:ext cx="5029200" cy="566928"/>
+              <a:rPr sz="800" b="0">
+                <a:solidFill>
+                  <a:srgbClr val="1A1A1A"/>
+                </a:solidFill>
+                <a:latin typeface="맑은 고딕"/>
+                <a:ea typeface="맑은 고딕"/>
+              </a:rPr>
+              <a:t>C1 ★★ 3%</a:t>
+            </a:r>
+          </a:p>
+          <a:p>
+            <a:pPr algn="ctr"/>
+            <a:r>
+              <a:rPr sz="800" b="0">
+                <a:solidFill>
+                  <a:srgbClr val="1A1A1A"/>
+                </a:solidFill>
+                <a:latin typeface="맑은 고딕"/>
+                <a:ea typeface="맑은 고딕"/>
+              </a:rPr>
+              <a:t>C2 ★ -15%</a:t>
+            </a:r>
+          </a:p>
+        </p:txBody>
+      </p:sp>
+      <p:sp>
+        <p:nvSpPr>
+          <p:cNvPr id="86" name="Rectangle 85"/>
+          <p:cNvSpPr/>
+          <p:nvPr/>
+        </p:nvSpPr>
+        <p:spPr>
+          <a:xfrm>
+            <a:off x="320040" y="3767328"/>
+            <a:ext cx="777240" cy="786384"/>
+          </a:xfrm>
+          <a:prstGeom prst="rect">
+            <a:avLst/>
+          </a:prstGeom>
+          <a:solidFill>
+            <a:srgbClr val="DCE9F5"/>
+          </a:solidFill>
+          <a:ln w="9525">
+            <a:solidFill>
+              <a:srgbClr val="4D7EA8"/>
+            </a:solidFill>
+          </a:ln>
+          <a:effectLst/>
+        </p:spPr>
+        <p:style>
+          <a:lnRef idx="1">
+            <a:schemeClr val="accent1"/>
+          </a:lnRef>
+          <a:fillRef idx="3">
+            <a:schemeClr val="accent1"/>
+          </a:fillRef>
+          <a:effectRef idx="2">
+            <a:schemeClr val="accent1"/>
+          </a:effectRef>
+          <a:fontRef idx="minor">
+            <a:schemeClr val="lt1"/>
+          </a:fontRef>
+        </p:style>
+        <p:txBody>
+          <a:bodyPr rtlCol="0" anchor="ctr" wrap="square" lIns="45720" rIns="45720" tIns="27432" bIns="27432"/>
+          <a:lstStyle/>
+          <a:p>
+            <a:pPr algn="ctr"/>
+            <a:r>
+              <a:rPr sz="800" b="1">
+                <a:solidFill>
+                  <a:srgbClr val="1A1A1A"/>
+                </a:solidFill>
+                <a:latin typeface="맑은 고딕"/>
+                <a:ea typeface="맑은 고딕"/>
+              </a:rPr>
+              <a:t>QA4</a:t>
+            </a:r>
+          </a:p>
+          <a:p>
+            <a:pPr algn="ctr"/>
+            <a:r>
+              <a:rPr sz="800" b="1">
+                <a:solidFill>
+                  <a:srgbClr val="1A1A1A"/>
+                </a:solidFill>
+                <a:latin typeface="맑은 고딕"/>
+                <a:ea typeface="맑은 고딕"/>
+              </a:rPr>
+              <a:t>변경 비용 (달</a:t>
+            </a:r>
+          </a:p>
+          <a:p>
+            <a:pPr algn="ctr"/>
+            <a:r>
+              <a:rPr sz="800" b="1">
+                <a:solidFill>
+                  <a:srgbClr val="1A1A1A"/>
+                </a:solidFill>
+                <a:latin typeface="맑은 고딕"/>
+                <a:ea typeface="맑은 고딕"/>
+              </a:rPr>
+              <a:t>성률 아님)</a:t>
+            </a:r>
+          </a:p>
+        </p:txBody>
+      </p:sp>
+      <p:sp>
+        <p:nvSpPr>
+          <p:cNvPr id="87" name="Rectangle 86"/>
+          <p:cNvSpPr/>
+          <p:nvPr/>
+        </p:nvSpPr>
+        <p:spPr>
+          <a:xfrm>
+            <a:off x="1097280" y="3767328"/>
+            <a:ext cx="2514600" cy="786384"/>
           </a:xfrm>
           <a:prstGeom prst="rect">
             <a:avLst/>
@@ -16714,38 +18072,51 @@
           <a:p>
             <a:pPr algn="l"/>
             <a:r>
-              <a:rPr sz="900" b="0">
-                <a:solidFill>
-                  <a:srgbClr val="1A1A1A"/>
-                </a:solidFill>
-                <a:latin typeface="맑은 고딕"/>
-                <a:ea typeface="맑은 고딕"/>
-              </a:rPr>
-              <a:t>x1.25 = latency 20% 감소 (TTFT P99 1,084 -&gt; 867 ms, TPOT P99 17.1 -&gt; 13.7 ms)</a:t>
-            </a:r>
-          </a:p>
-        </p:txBody>
-      </p:sp>
-      <p:sp>
-        <p:nvSpPr>
-          <p:cNvPr id="70" name="Rectangle 69"/>
-          <p:cNvSpPr/>
-          <p:nvPr/>
-        </p:nvSpPr>
-        <p:spPr>
-          <a:xfrm>
-            <a:off x="365760" y="2578608"/>
-            <a:ext cx="1188720" cy="566928"/>
-          </a:xfrm>
-          <a:prstGeom prst="rect">
-            <a:avLst/>
-          </a:prstGeom>
-          <a:solidFill>
-            <a:srgbClr val="DCE9F5"/>
+              <a:rPr sz="800" b="0">
+                <a:solidFill>
+                  <a:srgbClr val="1A1A1A"/>
+                </a:solidFill>
+                <a:latin typeface="맑은 고딕"/>
+                <a:ea typeface="맑은 고딕"/>
+              </a:rPr>
+              <a:t>변경 module 수 · 개발 공수(man-month) · 에이전트</a:t>
+            </a:r>
+          </a:p>
+          <a:p>
+            <a:pPr algn="l"/>
+            <a:r>
+              <a:rPr sz="800" b="0">
+                <a:solidFill>
+                  <a:srgbClr val="1A1A1A"/>
+                </a:solidFill>
+                <a:latin typeface="맑은 고딕"/>
+                <a:ea typeface="맑은 고딕"/>
+              </a:rPr>
+              <a:t>비용($) 3개의 중앙값 별</a:t>
+            </a:r>
+          </a:p>
+        </p:txBody>
+      </p:sp>
+      <p:sp>
+        <p:nvSpPr>
+          <p:cNvPr id="88" name="Rectangle 87"/>
+          <p:cNvSpPr/>
+          <p:nvPr/>
+        </p:nvSpPr>
+        <p:spPr>
+          <a:xfrm>
+            <a:off x="3611880" y="3767328"/>
+            <a:ext cx="1691640" cy="786384"/>
+          </a:xfrm>
+          <a:prstGeom prst="rect">
+            <a:avLst/>
+          </a:prstGeom>
+          <a:solidFill>
+            <a:srgbClr val="FFFFFF"/>
           </a:solidFill>
           <a:ln w="9525">
             <a:solidFill>
-              <a:srgbClr val="4D7EA8"/>
+              <a:srgbClr val="BFBFBF"/>
             </a:solidFill>
           </a:ln>
           <a:effectLst/>
@@ -16770,28 +18141,41 @@
           <a:p>
             <a:pPr algn="l"/>
             <a:r>
-              <a:rPr sz="950" b="1">
-                <a:solidFill>
-                  <a:srgbClr val="1A1A1A"/>
-                </a:solidFill>
-                <a:latin typeface="맑은 고딕"/>
-                <a:ea typeface="맑은 고딕"/>
-              </a:rPr>
-              <a:t>QA3 HBM 절감</a:t>
-            </a:r>
-          </a:p>
-        </p:txBody>
-      </p:sp>
-      <p:sp>
-        <p:nvSpPr>
-          <p:cNvPr id="71" name="Rectangle 70"/>
-          <p:cNvSpPr/>
-          <p:nvPr/>
-        </p:nvSpPr>
-        <p:spPr>
-          <a:xfrm>
-            <a:off x="1554480" y="2578608"/>
-            <a:ext cx="4206240" cy="566928"/>
+              <a:rPr sz="800" b="0">
+                <a:solidFill>
+                  <a:srgbClr val="1A1A1A"/>
+                </a:solidFill>
+                <a:latin typeface="맑은 고딕"/>
+                <a:ea typeface="맑은 고딕"/>
+              </a:rPr>
+              <a:t>module 6개 이상, 공수 1.0 초과, </a:t>
+            </a:r>
+          </a:p>
+          <a:p>
+            <a:pPr algn="l"/>
+            <a:r>
+              <a:rPr sz="800" b="0">
+                <a:solidFill>
+                  <a:srgbClr val="1A1A1A"/>
+                </a:solidFill>
+                <a:latin typeface="맑은 고딕"/>
+                <a:ea typeface="맑은 고딕"/>
+              </a:rPr>
+              <a:t>$10 초과</a:t>
+            </a:r>
+          </a:p>
+        </p:txBody>
+      </p:sp>
+      <p:sp>
+        <p:nvSpPr>
+          <p:cNvPr id="89" name="Rectangle 88"/>
+          <p:cNvSpPr/>
+          <p:nvPr/>
+        </p:nvSpPr>
+        <p:spPr>
+          <a:xfrm>
+            <a:off x="5303520" y="3767328"/>
+            <a:ext cx="1920240" cy="786384"/>
           </a:xfrm>
           <a:prstGeom prst="rect">
             <a:avLst/>
@@ -16826,28 +18210,41 @@
           <a:p>
             <a:pPr algn="l"/>
             <a:r>
-              <a:rPr sz="950" b="0">
-                <a:solidFill>
-                  <a:srgbClr val="1A1A1A"/>
-                </a:solidFill>
-                <a:latin typeface="맑은 고딕"/>
-                <a:ea typeface="맑은 고딕"/>
-              </a:rPr>
-              <a:t>잡음 범위 0.984 ~ 1.016 (sd 0.009, 20개 비교)</a:t>
-            </a:r>
-          </a:p>
-        </p:txBody>
-      </p:sp>
-      <p:sp>
-        <p:nvSpPr>
-          <p:cNvPr id="72" name="Rectangle 71"/>
-          <p:cNvSpPr/>
-          <p:nvPr/>
-        </p:nvSpPr>
-        <p:spPr>
-          <a:xfrm>
-            <a:off x="5760720" y="2578608"/>
-            <a:ext cx="1005840" cy="566928"/>
+              <a:rPr sz="800" b="0">
+                <a:solidFill>
+                  <a:srgbClr val="1A1A1A"/>
+                </a:solidFill>
+                <a:latin typeface="맑은 고딕"/>
+                <a:ea typeface="맑은 고딕"/>
+              </a:rPr>
+              <a:t>module 3~5개, 공수 1.0 이하, $10 이</a:t>
+            </a:r>
+          </a:p>
+          <a:p>
+            <a:pPr algn="l"/>
+            <a:r>
+              <a:rPr sz="800" b="0">
+                <a:solidFill>
+                  <a:srgbClr val="1A1A1A"/>
+                </a:solidFill>
+                <a:latin typeface="맑은 고딕"/>
+                <a:ea typeface="맑은 고딕"/>
+              </a:rPr>
+              <a:t>하</a:t>
+            </a:r>
+          </a:p>
+        </p:txBody>
+      </p:sp>
+      <p:sp>
+        <p:nvSpPr>
+          <p:cNvPr id="90" name="Rectangle 89"/>
+          <p:cNvSpPr/>
+          <p:nvPr/>
+        </p:nvSpPr>
+        <p:spPr>
+          <a:xfrm>
+            <a:off x="7223760" y="3767328"/>
+            <a:ext cx="1600200" cy="786384"/>
           </a:xfrm>
           <a:prstGeom prst="rect">
             <a:avLst/>
@@ -16880,39 +18277,324 @@
           <a:bodyPr rtlCol="0" anchor="ctr" wrap="square" lIns="45720" rIns="45720" tIns="27432" bIns="27432"/>
           <a:lstStyle/>
           <a:p>
+            <a:pPr algn="l"/>
+            <a:r>
+              <a:rPr sz="800" b="0">
+                <a:solidFill>
+                  <a:srgbClr val="1A1A1A"/>
+                </a:solidFill>
+                <a:latin typeface="맑은 고딕"/>
+                <a:ea typeface="맑은 고딕"/>
+              </a:rPr>
+              <a:t>module 2개 이하, 공수 0.5 이</a:t>
+            </a:r>
+          </a:p>
+          <a:p>
+            <a:pPr algn="l"/>
+            <a:r>
+              <a:rPr sz="800" b="0">
+                <a:solidFill>
+                  <a:srgbClr val="1A1A1A"/>
+                </a:solidFill>
+                <a:latin typeface="맑은 고딕"/>
+                <a:ea typeface="맑은 고딕"/>
+              </a:rPr>
+              <a:t>하, $3 이하</a:t>
+            </a:r>
+          </a:p>
+        </p:txBody>
+      </p:sp>
+      <p:sp>
+        <p:nvSpPr>
+          <p:cNvPr id="91" name="Rectangle 90"/>
+          <p:cNvSpPr/>
+          <p:nvPr/>
+        </p:nvSpPr>
+        <p:spPr>
+          <a:xfrm>
+            <a:off x="8823960" y="3767328"/>
+            <a:ext cx="1965960" cy="786384"/>
+          </a:xfrm>
+          <a:prstGeom prst="rect">
+            <a:avLst/>
+          </a:prstGeom>
+          <a:solidFill>
+            <a:srgbClr val="FFFFFF"/>
+          </a:solidFill>
+          <a:ln w="9525">
+            <a:solidFill>
+              <a:srgbClr val="BFBFBF"/>
+            </a:solidFill>
+          </a:ln>
+          <a:effectLst/>
+        </p:spPr>
+        <p:style>
+          <a:lnRef idx="1">
+            <a:schemeClr val="accent1"/>
+          </a:lnRef>
+          <a:fillRef idx="3">
+            <a:schemeClr val="accent1"/>
+          </a:fillRef>
+          <a:effectRef idx="2">
+            <a:schemeClr val="accent1"/>
+          </a:effectRef>
+          <a:fontRef idx="minor">
+            <a:schemeClr val="lt1"/>
+          </a:fontRef>
+        </p:style>
+        <p:txBody>
+          <a:bodyPr rtlCol="0" anchor="ctr" wrap="square" lIns="45720" rIns="45720" tIns="27432" bIns="27432"/>
+          <a:lstStyle/>
+          <a:p>
+            <a:pPr algn="l"/>
+            <a:r>
+              <a:rPr sz="800" b="0">
+                <a:solidFill>
+                  <a:srgbClr val="1A1A1A"/>
+                </a:solidFill>
+                <a:latin typeface="맑은 고딕"/>
+                <a:ea typeface="맑은 고딕"/>
+              </a:rPr>
+              <a:t>module 수 경계는 공통 룰, 공수·$는 사</a:t>
+            </a:r>
+          </a:p>
+          <a:p>
+            <a:pPr algn="l"/>
+            <a:r>
+              <a:rPr sz="800" b="0">
+                <a:solidFill>
+                  <a:srgbClr val="1A1A1A"/>
+                </a:solidFill>
+                <a:latin typeface="맑은 고딕"/>
+                <a:ea typeface="맑은 고딕"/>
+              </a:rPr>
+              <a:t>전 등록한 가정값(ASSUMED)</a:t>
+            </a:r>
+          </a:p>
+        </p:txBody>
+      </p:sp>
+      <p:sp>
+        <p:nvSpPr>
+          <p:cNvPr id="92" name="Rectangle 91"/>
+          <p:cNvSpPr/>
+          <p:nvPr/>
+        </p:nvSpPr>
+        <p:spPr>
+          <a:xfrm>
+            <a:off x="10789920" y="3767328"/>
+            <a:ext cx="1097280" cy="786384"/>
+          </a:xfrm>
+          <a:prstGeom prst="rect">
+            <a:avLst/>
+          </a:prstGeom>
+          <a:solidFill>
+            <a:srgbClr val="FFFFFF"/>
+          </a:solidFill>
+          <a:ln w="9525">
+            <a:solidFill>
+              <a:srgbClr val="BFBFBF"/>
+            </a:solidFill>
+          </a:ln>
+          <a:effectLst/>
+        </p:spPr>
+        <p:style>
+          <a:lnRef idx="1">
+            <a:schemeClr val="accent1"/>
+          </a:lnRef>
+          <a:fillRef idx="3">
+            <a:schemeClr val="accent1"/>
+          </a:fillRef>
+          <a:effectRef idx="2">
+            <a:schemeClr val="accent1"/>
+          </a:effectRef>
+          <a:fontRef idx="minor">
+            <a:schemeClr val="lt1"/>
+          </a:fontRef>
+        </p:style>
+        <p:txBody>
+          <a:bodyPr rtlCol="0" anchor="ctr" wrap="square" lIns="45720" rIns="45720" tIns="27432" bIns="27432"/>
+          <a:lstStyle/>
+          <a:p>
             <a:pPr algn="ctr"/>
             <a:r>
-              <a:rPr sz="950" b="1">
-                <a:solidFill>
-                  <a:srgbClr val="1A1A1A"/>
-                </a:solidFill>
-                <a:latin typeface="맑은 고딕"/>
-                <a:ea typeface="맑은 고딕"/>
-              </a:rPr>
-              <a:t>0.95</a:t>
-            </a:r>
-          </a:p>
-        </p:txBody>
-      </p:sp>
-      <p:sp>
-        <p:nvSpPr>
-          <p:cNvPr id="73" name="Rectangle 72"/>
-          <p:cNvSpPr/>
-          <p:nvPr/>
-        </p:nvSpPr>
-        <p:spPr>
-          <a:xfrm>
-            <a:off x="6766560" y="2578608"/>
-            <a:ext cx="5029200" cy="566928"/>
-          </a:xfrm>
-          <a:prstGeom prst="rect">
-            <a:avLst/>
-          </a:prstGeom>
-          <a:solidFill>
-            <a:srgbClr val="FFFFFF"/>
+              <a:rPr sz="800" b="0">
+                <a:solidFill>
+                  <a:srgbClr val="1A1A1A"/>
+                </a:solidFill>
+                <a:latin typeface="맑은 고딕"/>
+                <a:ea typeface="맑은 고딕"/>
+              </a:rPr>
+              <a:t>C1 ★★★</a:t>
+            </a:r>
+          </a:p>
+          <a:p>
+            <a:pPr algn="ctr"/>
+            <a:r>
+              <a:rPr sz="800" b="0">
+                <a:solidFill>
+                  <a:srgbClr val="1A1A1A"/>
+                </a:solidFill>
+                <a:latin typeface="맑은 고딕"/>
+                <a:ea typeface="맑은 고딕"/>
+              </a:rPr>
+              <a:t>C2 ★★</a:t>
+            </a:r>
+          </a:p>
+        </p:txBody>
+      </p:sp>
+      <p:sp>
+        <p:nvSpPr>
+          <p:cNvPr id="93" name="Rectangle 92"/>
+          <p:cNvSpPr/>
+          <p:nvPr/>
+        </p:nvSpPr>
+        <p:spPr>
+          <a:xfrm>
+            <a:off x="320040" y="4626864"/>
+            <a:ext cx="5669280" cy="1874519"/>
+          </a:xfrm>
+          <a:prstGeom prst="rect">
+            <a:avLst/>
+          </a:prstGeom>
+          <a:solidFill>
+            <a:srgbClr val="E3F1E3"/>
           </a:solidFill>
           <a:ln w="9525">
             <a:solidFill>
+              <a:srgbClr val="5B9B5B"/>
+            </a:solidFill>
+          </a:ln>
+          <a:effectLst/>
+        </p:spPr>
+        <p:style>
+          <a:lnRef idx="1">
+            <a:schemeClr val="accent1"/>
+          </a:lnRef>
+          <a:fillRef idx="3">
+            <a:schemeClr val="accent1"/>
+          </a:fillRef>
+          <a:effectRef idx="2">
+            <a:schemeClr val="accent1"/>
+          </a:effectRef>
+          <a:fontRef idx="minor">
+            <a:schemeClr val="lt1"/>
+          </a:fontRef>
+        </p:style>
+        <p:txBody>
+          <a:bodyPr rtlCol="0" anchor="t" wrap="square" lIns="45720" rIns="45720" tIns="27432" bIns="27432"/>
+          <a:lstStyle/>
+          <a:p>
+            <a:pPr algn="l"/>
+            <a:r>
+              <a:rPr sz="850" b="1">
+                <a:solidFill>
+                  <a:srgbClr val="1A1A1A"/>
+                </a:solidFill>
+                <a:latin typeface="맑은 고딕"/>
+                <a:ea typeface="맑은 고딕"/>
+              </a:rPr>
+              <a:t>정의와 근거</a:t>
+            </a:r>
+          </a:p>
+          <a:p>
+            <a:pPr algn="l"/>
+            <a:r>
+              <a:rPr sz="850" b="0">
+                <a:solidFill>
+                  <a:srgbClr val="1A1A1A"/>
+                </a:solidFill>
+                <a:latin typeface="맑은 고딕"/>
+                <a:ea typeface="맑은 고딕"/>
+              </a:rPr>
+              <a:t>- Oracle 달성률 = 후보가 낸 이득 / Oracle이 낼 수 있는 이득 (로그 비율의 합으로 집계, 개선 여지가 잡음 이하인 쌍 </a:t>
+            </a:r>
+          </a:p>
+          <a:p>
+            <a:pPr algn="l"/>
+            <a:r>
+              <a:rPr sz="850" b="0">
+                <a:solidFill>
+                  <a:srgbClr val="1A1A1A"/>
+                </a:solidFill>
+                <a:latin typeface="맑은 고딕"/>
+                <a:ea typeface="맑은 고딕"/>
+              </a:rPr>
+              <a:t>제외). Oracle은 모두 증명된 최적이 아닌 근사 상한.</a:t>
+            </a:r>
+          </a:p>
+          <a:p>
+            <a:pPr algn="l"/>
+            <a:r>
+              <a:rPr sz="850" b="0">
+                <a:solidFill>
+                  <a:srgbClr val="1A1A1A"/>
+                </a:solidFill>
+                <a:latin typeface="맑은 고딕"/>
+                <a:ea typeface="맑은 고딕"/>
+              </a:rPr>
+              <a:t>- ★/★★ 하한(측정): Baseline을 seed 묶음 5개로 돌려 서로 비교한 20회의 집계 범위.</a:t>
+            </a:r>
+          </a:p>
+          <a:p>
+            <a:pPr algn="l"/>
+            <a:r>
+              <a:rPr sz="850" b="0">
+                <a:solidFill>
+                  <a:srgbClr val="1A1A1A"/>
+                </a:solidFill>
+                <a:latin typeface="맑은 고딕"/>
+                <a:ea typeface="맑은 고딕"/>
+              </a:rPr>
+              <a:t>- ★★★ 기준 80%(문헌): 이득 달성률 57, 75, 87, 95%의 중앙값 81%를 반올림. 문헌 점수가 4개뿐이고 CPU 캐시/ti</a:t>
+            </a:r>
+          </a:p>
+          <a:p>
+            <a:pPr algn="l"/>
+            <a:r>
+              <a:rPr sz="850" b="0">
+                <a:solidFill>
+                  <a:srgbClr val="1A1A1A"/>
+                </a:solidFill>
+                <a:latin typeface="맑은 고딕"/>
+                <a:ea typeface="맑은 고딕"/>
+              </a:rPr>
+              <a:t>ered memory 연구다.</a:t>
+            </a:r>
+          </a:p>
+          <a:p>
+            <a:pPr algn="l"/>
+            <a:r>
+              <a:rPr sz="850" b="0">
+                <a:solidFill>
+                  <a:srgbClr val="1A1A1A"/>
+                </a:solidFill>
+                <a:latin typeface="맑은 고딕"/>
+                <a:ea typeface="맑은 고딕"/>
+              </a:rPr>
+              <a:t>- 이 기준은 결과를 본 뒤 정했고(집계 방식, QA2·QA3 Oracle 포함) 선택(C1 9점 대 C2 8점)은 이전 기준과 같다.</a:t>
+            </a:r>
+          </a:p>
+        </p:txBody>
+      </p:sp>
+      <p:sp>
+        <p:nvSpPr>
+          <p:cNvPr id="94" name="Rectangle 93"/>
+          <p:cNvSpPr/>
+          <p:nvPr/>
+        </p:nvSpPr>
+        <p:spPr>
+          <a:xfrm>
+            <a:off x="6172200" y="4626864"/>
+            <a:ext cx="5715000" cy="1874519"/>
+          </a:xfrm>
+          <a:prstGeom prst="rect">
+            <a:avLst/>
+          </a:prstGeom>
+          <a:solidFill>
+            <a:srgbClr val="F2F2F2"/>
+          </a:solidFill>
+          <a:ln w="9525">
+            <a:solidFill>
               <a:srgbClr val="BFBFBF"/>
             </a:solidFill>
           </a:ln>
@@ -16933,287 +18615,110 @@
           </a:fontRef>
         </p:style>
         <p:txBody>
-          <a:bodyPr rtlCol="0" anchor="ctr" wrap="square" lIns="45720" rIns="45720" tIns="27432" bIns="27432"/>
-          <a:lstStyle/>
-          <a:p>
-            <a:pPr algn="l"/>
-            <a:r>
-              <a:rPr sz="900" b="0">
-                <a:solidFill>
-                  <a:srgbClr val="1A1A1A"/>
-                </a:solidFill>
-                <a:latin typeface="맑은 고딕"/>
-                <a:ea typeface="맑은 고딕"/>
-              </a:rPr>
-              <a:t>x1.25 = HBM 20% 감소 (146.6 GiB 중 약 29 GiB, 8K KV object 약 1.6개)</a:t>
-            </a:r>
-          </a:p>
-        </p:txBody>
-      </p:sp>
-      <p:sp>
-        <p:nvSpPr>
-          <p:cNvPr id="74" name="Rectangle 73"/>
-          <p:cNvSpPr/>
-          <p:nvPr/>
-        </p:nvSpPr>
-        <p:spPr>
-          <a:xfrm>
-            <a:off x="365760" y="3273552"/>
-            <a:ext cx="5669280" cy="2468880"/>
-          </a:xfrm>
-          <a:prstGeom prst="rect">
-            <a:avLst/>
-          </a:prstGeom>
-          <a:solidFill>
-            <a:srgbClr val="E3F1E3"/>
-          </a:solidFill>
-          <a:ln w="9525">
-            <a:solidFill>
-              <a:srgbClr val="5B9B5B"/>
-            </a:solidFill>
-          </a:ln>
-          <a:effectLst/>
-        </p:spPr>
-        <p:style>
-          <a:lnRef idx="1">
-            <a:schemeClr val="accent1"/>
-          </a:lnRef>
-          <a:fillRef idx="3">
-            <a:schemeClr val="accent1"/>
-          </a:fillRef>
-          <a:effectRef idx="2">
-            <a:schemeClr val="accent1"/>
-          </a:effectRef>
-          <a:fontRef idx="minor">
-            <a:schemeClr val="lt1"/>
-          </a:fontRef>
-        </p:style>
-        <p:txBody>
           <a:bodyPr rtlCol="0" anchor="t" wrap="square" lIns="45720" rIns="45720" tIns="27432" bIns="27432"/>
           <a:lstStyle/>
           <a:p>
             <a:pPr algn="l"/>
             <a:r>
-              <a:rPr sz="950" b="1">
-                <a:solidFill>
-                  <a:srgbClr val="1A1A1A"/>
-                </a:solidFill>
-                <a:latin typeface="맑은 고딕"/>
-                <a:ea typeface="맑은 고딕"/>
-              </a:rPr>
-              <a:t>무엇이 근거 있고 무엇이 선택인가</a:t>
-            </a:r>
-          </a:p>
-          <a:p>
-            <a:pPr algn="l"/>
-            <a:r>
-              <a:rPr sz="950" b="0">
-                <a:solidFill>
-                  <a:srgbClr val="1A1A1A"/>
-                </a:solidFill>
-                <a:latin typeface="맑은 고딕"/>
-                <a:ea typeface="맑은 고딕"/>
-              </a:rPr>
-              <a:t>- 하한: QA1 0.97은 Baseline끼리 비교해도 나오는 잡음의 아래 끝과 같다(측정). QA2/QA3의 0.95는</a:t>
-            </a:r>
-          </a:p>
-          <a:p>
-            <a:pPr algn="l"/>
-            <a:r>
-              <a:rPr sz="950" b="0">
-                <a:solidFill>
-                  <a:srgbClr val="1A1A1A"/>
-                </a:solidFill>
-                <a:latin typeface="맑은 고딕"/>
-                <a:ea typeface="맑은 고딕"/>
-              </a:rPr>
-              <a:t>잡음(0.97/0.98)보다 느슨하지만 조여도 현재 별은 바뀌지 않는다.</a:t>
-            </a:r>
-          </a:p>
-          <a:p>
-            <a:pPr algn="l"/>
-            <a:r>
-              <a:rPr sz="950" b="0">
-                <a:solidFill>
-                  <a:srgbClr val="1A1A1A"/>
-                </a:solidFill>
-                <a:latin typeface="맑은 고딕"/>
-                <a:ea typeface="맑은 고딕"/>
-              </a:rPr>
-              <a:t>- 상한: 잡음(약 3%)으로는 정해지지 않는다. '도입 가치가 있는 크기'라는 정책 선택이며 위 환산으</a:t>
-            </a:r>
-          </a:p>
-          <a:p>
-            <a:pPr algn="l"/>
-            <a:r>
-              <a:rPr sz="950" b="0">
-                <a:solidFill>
-                  <a:srgbClr val="1A1A1A"/>
-                </a:solidFill>
-                <a:latin typeface="맑은 고딕"/>
-                <a:ea typeface="맑은 고딕"/>
-              </a:rPr>
-              <a:t>로 의미만 붙였다.</a:t>
-            </a:r>
-          </a:p>
-          <a:p>
-            <a:pPr algn="l"/>
-            <a:r>
-              <a:rPr sz="950" b="0">
-                <a:solidFill>
-                  <a:srgbClr val="1A1A1A"/>
-                </a:solidFill>
-                <a:latin typeface="맑은 고딕"/>
-                <a:ea typeface="맑은 고딕"/>
-              </a:rPr>
-              <a:t>- QA1 상한 1.30은 결과를 본 뒤 정한 값(defined_after_first_look)이고 1.25와 환산 차이가 작다(1.6 </a:t>
-            </a:r>
-          </a:p>
-          <a:p>
-            <a:pPr algn="l"/>
-            <a:r>
-              <a:rPr sz="950" b="0">
-                <a:solidFill>
-                  <a:srgbClr val="1A1A1A"/>
-                </a:solidFill>
-                <a:latin typeface="맑은 고딕"/>
-                <a:ea typeface="맑은 고딕"/>
-              </a:rPr>
-              <a:t>GPU 대 1.85 GPU).</a:t>
-            </a:r>
-          </a:p>
-        </p:txBody>
-      </p:sp>
-      <p:sp>
-        <p:nvSpPr>
-          <p:cNvPr id="75" name="Rectangle 74"/>
-          <p:cNvSpPr/>
-          <p:nvPr/>
-        </p:nvSpPr>
-        <p:spPr>
-          <a:xfrm>
-            <a:off x="6217920" y="3273552"/>
-            <a:ext cx="5577840" cy="2468880"/>
-          </a:xfrm>
-          <a:prstGeom prst="rect">
-            <a:avLst/>
-          </a:prstGeom>
-          <a:solidFill>
-            <a:srgbClr val="F2F2F2"/>
-          </a:solidFill>
-          <a:ln w="9525">
-            <a:solidFill>
-              <a:srgbClr val="BFBFBF"/>
-            </a:solidFill>
-          </a:ln>
-          <a:effectLst/>
-        </p:spPr>
-        <p:style>
-          <a:lnRef idx="1">
-            <a:schemeClr val="accent1"/>
-          </a:lnRef>
-          <a:fillRef idx="3">
-            <a:schemeClr val="accent1"/>
-          </a:fillRef>
-          <a:effectRef idx="2">
-            <a:schemeClr val="accent1"/>
-          </a:effectRef>
-          <a:fontRef idx="minor">
-            <a:schemeClr val="lt1"/>
-          </a:fontRef>
-        </p:style>
-        <p:txBody>
-          <a:bodyPr rtlCol="0" anchor="t" wrap="square" lIns="45720" rIns="45720" tIns="27432" bIns="27432"/>
-          <a:lstStyle/>
-          <a:p>
-            <a:pPr algn="l"/>
-            <a:r>
-              <a:rPr sz="950" b="1">
+              <a:rPr sz="850" b="1">
                 <a:solidFill>
                   <a:srgbClr val="404040"/>
                 </a:solidFill>
                 <a:latin typeface="맑은 고딕"/>
                 <a:ea typeface="맑은 고딕"/>
               </a:rPr>
-              <a:t>선택이 상한에 얼마나 민감한가 (상한을 QA1/2/3에 같게 적용)</a:t>
-            </a:r>
-          </a:p>
-          <a:p>
-            <a:pPr algn="l"/>
-            <a:r>
-              <a:rPr sz="950" b="0">
+              <a:t>문헌 자료 (원문에서 확인한 수치; 출처: qa-capture-literature.md)</a:t>
+            </a:r>
+          </a:p>
+          <a:p>
+            <a:pPr algn="l"/>
+            <a:r>
+              <a:rPr sz="850" b="0">
                 <a:solidFill>
                   <a:srgbClr val="404040"/>
                 </a:solidFill>
                 <a:latin typeface="맑은 고딕"/>
                 <a:ea typeface="맑은 고딕"/>
               </a:rPr>
-              <a:t>- 상한 1.10~1.25: C1 11점 대 C2 9점 -&gt; C1 선택</a:t>
-            </a:r>
-          </a:p>
-          <a:p>
-            <a:pPr algn="l"/>
-            <a:r>
-              <a:rPr sz="950" b="0">
+              <a:t>- Mockingjay, HPCA'22, Table I (IPC 개선 vs LRU, Belady MIN 6.0%): SHiP 3.4%=57%, Hawkeye 4.5%=75%, Mockingja</a:t>
+            </a:r>
+          </a:p>
+          <a:p>
+            <a:pPr algn="l"/>
+            <a:r>
+              <a:rPr sz="850" b="0">
                 <a:solidFill>
                   <a:srgbClr val="404040"/>
                 </a:solidFill>
                 <a:latin typeface="맑은 고딕"/>
                 <a:ea typeface="맑은 고딕"/>
               </a:rPr>
-              <a:t>- 상한 1.30~1.40: 둘 다 9점 동점, QA1 우선순위로 C2 선택</a:t>
-            </a:r>
-          </a:p>
-          <a:p>
-            <a:pPr algn="l"/>
-            <a:r>
-              <a:rPr sz="950" b="0">
+              <a:t>y 5.7%=95%.</a:t>
+            </a:r>
+          </a:p>
+          <a:p>
+            <a:pPr algn="l"/>
+            <a:r>
+              <a:rPr sz="850" b="0">
                 <a:solidFill>
                   <a:srgbClr val="404040"/>
                 </a:solidFill>
                 <a:latin typeface="맑은 고딕"/>
                 <a:ea typeface="맑은 고딕"/>
               </a:rPr>
-              <a:t>- 상한 1.45 이상: C1 9점 대 C2 8점 이하 -&gt; C1 선택</a:t>
-            </a:r>
-          </a:p>
-          <a:p>
-            <a:pPr algn="l"/>
-            <a:r>
-              <a:rPr sz="950" b="0">
+              <a:t>- ARMS, arXiv 2508.04417: 기본 HeMem 대비 1.26배, 튜닝 최적의 97% 이상이므로 달성률 87% 이상(환산).</a:t>
+            </a:r>
+          </a:p>
+          <a:p>
+            <a:pPr algn="l"/>
+            <a:r>
+              <a:rPr sz="850" b="0">
                 <a:solidFill>
                   <a:srgbClr val="404040"/>
                 </a:solidFill>
                 <a:latin typeface="맑은 고딕"/>
                 <a:ea typeface="맑은 고딕"/>
               </a:rPr>
-              <a:t>- 현재 공식 경계는 C1의 QA1(x1.298)과 0.2% 차이라 선택은 경계에 민감하다. 상한을 하드웨어 </a:t>
-            </a:r>
-          </a:p>
-          <a:p>
-            <a:pPr algn="l"/>
-            <a:r>
-              <a:rPr sz="950" b="0">
+              <a:t>- 참고(지표가 달라 80% 계산에서 제외): Colloid, SOSP'24: HeMem/TPP/MEMTIS가 best-case 처리량의 98.5/95.4/8</a:t>
+            </a:r>
+          </a:p>
+          <a:p>
+            <a:pPr algn="l"/>
+            <a:r>
+              <a:rPr sz="850" b="0">
                 <a:solidFill>
                   <a:srgbClr val="404040"/>
                 </a:solidFill>
                 <a:latin typeface="맑은 고딕"/>
                 <a:ea typeface="맑은 고딕"/>
               </a:rPr>
-              <a:t>환산(예: 1 GPU = x1.14, 2 GPU = x1.33)으로 고정할지는 소유자 결정 사항이다. 근거 문서: qa-crit</a:t>
-            </a:r>
-          </a:p>
-          <a:p>
-            <a:pPr algn="l"/>
-            <a:r>
-              <a:rPr sz="950" b="0">
+              <a:t>9.9%. LRB, NSDI'20: 기존 최고와 Belady 격차의 약 1/4 해소.</a:t>
+            </a:r>
+          </a:p>
+          <a:p>
+            <a:pPr algn="l"/>
+            <a:r>
+              <a:rPr sz="850" b="0">
                 <a:solidFill>
                   <a:srgbClr val="404040"/>
                 </a:solidFill>
                 <a:latin typeface="맑은 고딕"/>
                 <a:ea typeface="맑은 고딕"/>
               </a:rPr>
-              <a:t>eria-dp1.md §J.</a:t>
+              <a:t>- 반증: arXiv 2609.16215: 대역폭이 경합하면 oracle prefetch도 이득이 없었음(우리 링크 간섭 결과와 같은 방향).</a:t>
+            </a:r>
+          </a:p>
+          <a:p>
+            <a:pPr algn="l"/>
+            <a:r>
+              <a:rPr sz="850" b="0">
+                <a:solidFill>
+                  <a:srgbClr val="404040"/>
+                </a:solidFill>
+                <a:latin typeface="맑은 고딕"/>
+                <a:ea typeface="맑은 고딕"/>
+              </a:rPr>
+              <a:t>- 한계: LLM 서빙 직접 문헌 없음, QA2/QA3의 Oracle이 더 이상적이라 80%가 더 엄격, 개선 여지 쌍이 QA1 10개뿐.</a:t>
             </a:r>
           </a:p>
         </p:txBody>
@@ -17227,1577 +18732,6 @@
 </file>
 
 <file path=ppt/slides/slide25.xml><?xml version="1.0" encoding="utf-8"?>
-<p:sld xmlns:a="http://schemas.openxmlformats.org/drawingml/2006/main" xmlns:p="http://schemas.openxmlformats.org/presentationml/2006/main" xmlns:r="http://schemas.openxmlformats.org/officeDocument/2006/relationships">
-  <p:cSld>
-    <p:spTree>
-      <p:nvGrpSpPr>
-        <p:cNvPr id="1" name=""/>
-        <p:cNvGrpSpPr/>
-        <p:nvPr/>
-      </p:nvGrpSpPr>
-      <p:grpSpPr/>
-      <p:sp>
-        <p:nvSpPr>
-          <p:cNvPr id="3" name="제목 2"/>
-          <p:cNvSpPr>
-            <a:spLocks noGrp="1"/>
-          </p:cNvSpPr>
-          <p:nvPr>
-            <p:ph type="title"/>
-          </p:nvPr>
-        </p:nvSpPr>
-        <p:spPr>
-          <a:xfrm>
-            <a:off x="234949" y="137379"/>
-            <a:ext cx="7631530" cy="365125"/>
-          </a:xfrm>
-        </p:spPr>
-        <p:txBody>
-          <a:bodyPr/>
-          <a:lstStyle/>
-          <a:p>
-            <a:r>
-              <a:rPr lang="en-US" altLang="ko-KR" dirty="0"/>
-              <a:t>DP1. 이기종 메모리 기반 Data Migration 구조 - Appendix</a:t>
-            </a:r>
-            <a:r>
-              <a:rPr lang="ko-KR" altLang="en-US" dirty="0"/>
-              <a:t/>
-            </a:r>
-            <a:r>
-              <a:rPr lang="en-US" altLang="ko-KR" dirty="0"/>
-              <a:t/>
-            </a:r>
-            <a:r>
-              <a:rPr lang="ko-KR" altLang="en-US" dirty="0"/>
-              <a:t/>
-            </a:r>
-            <a:r>
-              <a:rPr lang="en-US" altLang="ko-KR" dirty="0"/>
-              <a:t/>
-            </a:r>
-            <a:r>
-              <a:rPr lang="ko-KR" altLang="en-US" dirty="0"/>
-              <a:t/>
-            </a:r>
-          </a:p>
-        </p:txBody>
-      </p:sp>
-      <p:sp>
-        <p:nvSpPr>
-          <p:cNvPr id="5" name="직사각형 4"/>
-          <p:cNvSpPr/>
-          <p:nvPr/>
-        </p:nvSpPr>
-        <p:spPr>
-          <a:xfrm>
-            <a:off x="234949" y="596176"/>
-            <a:ext cx="11747501" cy="396603"/>
-          </a:xfrm>
-          <a:prstGeom prst="rect">
-            <a:avLst/>
-          </a:prstGeom>
-          <a:solidFill>
-            <a:schemeClr val="bg1">
-              <a:lumMod val="50000"/>
-            </a:schemeClr>
-          </a:solidFill>
-          <a:ln>
-            <a:noFill/>
-          </a:ln>
-        </p:spPr>
-        <p:style>
-          <a:lnRef idx="2">
-            <a:schemeClr val="accent1">
-              <a:shade val="50000"/>
-            </a:schemeClr>
-          </a:lnRef>
-          <a:fillRef idx="1">
-            <a:schemeClr val="accent1"/>
-          </a:fillRef>
-          <a:effectRef idx="0">
-            <a:schemeClr val="accent1"/>
-          </a:effectRef>
-          <a:fontRef idx="minor">
-            <a:schemeClr val="lt1"/>
-          </a:fontRef>
-        </p:style>
-        <p:txBody>
-          <a:bodyPr rtlCol="0" anchor="ctr"/>
-          <a:lstStyle/>
-          <a:p>
-            <a:pPr algn="ctr"/>
-            <a:endParaRPr lang="ko-KR" altLang="en-US"/>
-          </a:p>
-        </p:txBody>
-      </p:sp>
-      <p:sp>
-        <p:nvSpPr>
-          <p:cNvPr id="8" name="TextBox 7"/>
-          <p:cNvSpPr txBox="1"/>
-          <p:nvPr/>
-        </p:nvSpPr>
-        <p:spPr>
-          <a:xfrm>
-            <a:off x="469760" y="627926"/>
-            <a:ext cx="11430000" cy="307777"/>
-          </a:xfrm>
-          <a:prstGeom prst="rect">
-            <a:avLst/>
-          </a:prstGeom>
-          <a:noFill/>
-        </p:spPr>
-        <p:txBody>
-          <a:bodyPr wrap="square" rtlCol="0">
-            <a:spAutoFit/>
-          </a:bodyPr>
-          <a:lstStyle/>
-          <a:p>
-            <a:pPr lvl="0">
-              <a:defRPr/>
-            </a:pPr>
-            <a:r>
-              <a:rPr lang="ko-KR" altLang="en-US" sz="1400" b="1" dirty="0">
-                <a:solidFill>
-                  <a:schemeClr val="bg1"/>
-                </a:solidFill>
-              </a:rPr>
-              <a:t>QA1 별 기준의 문헌 근거 - Oracle 대비 이득 달성률</a:t>
-            </a:r>
-            <a:r>
-              <a:rPr lang="en-US" altLang="ko-KR" sz="1400" b="1" dirty="0">
-                <a:solidFill>
-                  <a:schemeClr val="bg1"/>
-                </a:solidFill>
-              </a:rPr>
-              <a:t/>
-            </a:r>
-            <a:r>
-              <a:rPr lang="ko-KR" altLang="en-US" sz="1400" b="1" dirty="0">
-                <a:solidFill>
-                  <a:schemeClr val="bg1"/>
-                </a:solidFill>
-              </a:rPr>
-              <a:t/>
-            </a:r>
-            <a:r>
-              <a:rPr lang="en-US" altLang="ko-KR" sz="1400" b="1" dirty="0">
-                <a:solidFill>
-                  <a:schemeClr val="bg1"/>
-                </a:solidFill>
-              </a:rPr>
-              <a:t/>
-            </a:r>
-            <a:r>
-              <a:rPr lang="ko-KR" altLang="en-US" sz="1400" b="1" dirty="0">
-                <a:solidFill>
-                  <a:schemeClr val="bg1"/>
-                </a:solidFill>
-              </a:rPr>
-              <a:t/>
-            </a:r>
-          </a:p>
-        </p:txBody>
-      </p:sp>
-      <p:sp>
-        <p:nvSpPr>
-          <p:cNvPr id="39" name="직사각형 38"/>
-          <p:cNvSpPr/>
-          <p:nvPr/>
-        </p:nvSpPr>
-        <p:spPr>
-          <a:xfrm>
-            <a:off x="403086" y="678726"/>
-            <a:ext cx="66675" cy="216270"/>
-          </a:xfrm>
-          <a:prstGeom prst="rect">
-            <a:avLst/>
-          </a:prstGeom>
-          <a:solidFill>
-            <a:schemeClr val="bg1"/>
-          </a:solidFill>
-          <a:ln w="19050">
-            <a:noFill/>
-          </a:ln>
-        </p:spPr>
-        <p:style>
-          <a:lnRef idx="2">
-            <a:schemeClr val="accent1">
-              <a:shade val="50000"/>
-            </a:schemeClr>
-          </a:lnRef>
-          <a:fillRef idx="1">
-            <a:schemeClr val="accent1"/>
-          </a:fillRef>
-          <a:effectRef idx="0">
-            <a:schemeClr val="accent1"/>
-          </a:effectRef>
-          <a:fontRef idx="minor">
-            <a:schemeClr val="lt1"/>
-          </a:fontRef>
-        </p:style>
-        <p:txBody>
-          <a:bodyPr rtlCol="0" anchor="ctr"/>
-          <a:lstStyle/>
-          <a:p>
-            <a:pPr algn="ctr"/>
-            <a:endParaRPr lang="ko-KR" altLang="en-US" sz="1600"/>
-          </a:p>
-        </p:txBody>
-      </p:sp>
-      <p:sp>
-        <p:nvSpPr>
-          <p:cNvPr id="57" name="슬라이드 번호 개체 틀 1"/>
-          <p:cNvSpPr>
-            <a:spLocks noGrp="1"/>
-          </p:cNvSpPr>
-          <p:nvPr>
-            <p:ph type="sldNum" sz="quarter" idx="4"/>
-          </p:nvPr>
-        </p:nvSpPr>
-        <p:spPr>
-          <a:xfrm>
-            <a:off x="5620080" y="6597650"/>
-            <a:ext cx="456466" cy="209550"/>
-          </a:xfrm>
-        </p:spPr>
-        <p:txBody>
-          <a:bodyPr/>
-          <a:lstStyle/>
-          <a:p>
-            <a:fld id="{7F889C64-266A-4D07-AD8F-5B592E61CCE1}" type="slidenum">
-              <a:rPr lang="ko-KR" altLang="en-US" smtClean="0"/>
-              <a:pPr/>
-              <a:t>9</a:t>
-            </a:fld>
-            <a:endParaRPr lang="ko-KR" altLang="en-US" dirty="0"/>
-          </a:p>
-        </p:txBody>
-      </p:sp>
-      <p:sp>
-        <p:nvSpPr>
-          <p:cNvPr id="58" name="Rectangle 57"/>
-          <p:cNvSpPr/>
-          <p:nvPr/>
-        </p:nvSpPr>
-        <p:spPr>
-          <a:xfrm>
-            <a:off x="365760" y="1051560"/>
-            <a:ext cx="1463040" cy="292608"/>
-          </a:xfrm>
-          <a:prstGeom prst="rect">
-            <a:avLst/>
-          </a:prstGeom>
-          <a:solidFill>
-            <a:srgbClr val="1F4E79"/>
-          </a:solidFill>
-          <a:ln w="9525">
-            <a:solidFill>
-              <a:srgbClr val="1F4E79"/>
-            </a:solidFill>
-          </a:ln>
-          <a:effectLst/>
-        </p:spPr>
-        <p:style>
-          <a:lnRef idx="1">
-            <a:schemeClr val="accent1"/>
-          </a:lnRef>
-          <a:fillRef idx="3">
-            <a:schemeClr val="accent1"/>
-          </a:fillRef>
-          <a:effectRef idx="2">
-            <a:schemeClr val="accent1"/>
-          </a:effectRef>
-          <a:fontRef idx="minor">
-            <a:schemeClr val="lt1"/>
-          </a:fontRef>
-        </p:style>
-        <p:txBody>
-          <a:bodyPr rtlCol="0" anchor="ctr" wrap="square" lIns="45720" rIns="45720" tIns="27432" bIns="27432"/>
-          <a:lstStyle/>
-          <a:p>
-            <a:pPr algn="ctr"/>
-            <a:r>
-              <a:rPr sz="1000" b="1">
-                <a:solidFill>
-                  <a:srgbClr val="FFFFFF"/>
-                </a:solidFill>
-                <a:latin typeface="맑은 고딕"/>
-                <a:ea typeface="맑은 고딕"/>
-              </a:rPr>
-              <a:t>후보</a:t>
-            </a:r>
-          </a:p>
-        </p:txBody>
-      </p:sp>
-      <p:sp>
-        <p:nvSpPr>
-          <p:cNvPr id="59" name="Rectangle 58"/>
-          <p:cNvSpPr/>
-          <p:nvPr/>
-        </p:nvSpPr>
-        <p:spPr>
-          <a:xfrm>
-            <a:off x="1828800" y="1051560"/>
-            <a:ext cx="2011680" cy="292608"/>
-          </a:xfrm>
-          <a:prstGeom prst="rect">
-            <a:avLst/>
-          </a:prstGeom>
-          <a:solidFill>
-            <a:srgbClr val="1F4E79"/>
-          </a:solidFill>
-          <a:ln w="9525">
-            <a:solidFill>
-              <a:srgbClr val="1F4E79"/>
-            </a:solidFill>
-          </a:ln>
-          <a:effectLst/>
-        </p:spPr>
-        <p:style>
-          <a:lnRef idx="1">
-            <a:schemeClr val="accent1"/>
-          </a:lnRef>
-          <a:fillRef idx="3">
-            <a:schemeClr val="accent1"/>
-          </a:fillRef>
-          <a:effectRef idx="2">
-            <a:schemeClr val="accent1"/>
-          </a:effectRef>
-          <a:fontRef idx="minor">
-            <a:schemeClr val="lt1"/>
-          </a:fontRef>
-        </p:style>
-        <p:txBody>
-          <a:bodyPr rtlCol="0" anchor="ctr" wrap="square" lIns="45720" rIns="45720" tIns="27432" bIns="27432"/>
-          <a:lstStyle/>
-          <a:p>
-            <a:pPr algn="ctr"/>
-            <a:r>
-              <a:rPr sz="1000" b="1">
-                <a:solidFill>
-                  <a:srgbClr val="FFFFFF"/>
-                </a:solidFill>
-                <a:latin typeface="맑은 고딕"/>
-                <a:ea typeface="맑은 고딕"/>
-              </a:rPr>
-              <a:t>pooled 달성률</a:t>
-            </a:r>
-          </a:p>
-        </p:txBody>
-      </p:sp>
-      <p:sp>
-        <p:nvSpPr>
-          <p:cNvPr id="60" name="Rectangle 59"/>
-          <p:cNvSpPr/>
-          <p:nvPr/>
-        </p:nvSpPr>
-        <p:spPr>
-          <a:xfrm>
-            <a:off x="3840480" y="1051560"/>
-            <a:ext cx="1828800" cy="292608"/>
-          </a:xfrm>
-          <a:prstGeom prst="rect">
-            <a:avLst/>
-          </a:prstGeom>
-          <a:solidFill>
-            <a:srgbClr val="1F4E79"/>
-          </a:solidFill>
-          <a:ln w="9525">
-            <a:solidFill>
-              <a:srgbClr val="1F4E79"/>
-            </a:solidFill>
-          </a:ln>
-          <a:effectLst/>
-        </p:spPr>
-        <p:style>
-          <a:lnRef idx="1">
-            <a:schemeClr val="accent1"/>
-          </a:lnRef>
-          <a:fillRef idx="3">
-            <a:schemeClr val="accent1"/>
-          </a:fillRef>
-          <a:effectRef idx="2">
-            <a:schemeClr val="accent1"/>
-          </a:effectRef>
-          <a:fontRef idx="minor">
-            <a:schemeClr val="lt1"/>
-          </a:fontRef>
-        </p:style>
-        <p:txBody>
-          <a:bodyPr rtlCol="0" anchor="ctr" wrap="square" lIns="45720" rIns="45720" tIns="27432" bIns="27432"/>
-          <a:lstStyle/>
-          <a:p>
-            <a:pPr algn="ctr"/>
-            <a:r>
-              <a:rPr sz="1000" b="1">
-                <a:solidFill>
-                  <a:srgbClr val="FFFFFF"/>
-                </a:solidFill>
-                <a:latin typeface="맑은 고딕"/>
-                <a:ea typeface="맑은 고딕"/>
-              </a:rPr>
-              <a:t>쌍별 평균</a:t>
-            </a:r>
-          </a:p>
-        </p:txBody>
-      </p:sp>
-      <p:sp>
-        <p:nvSpPr>
-          <p:cNvPr id="61" name="Rectangle 60"/>
-          <p:cNvSpPr/>
-          <p:nvPr/>
-        </p:nvSpPr>
-        <p:spPr>
-          <a:xfrm>
-            <a:off x="5669280" y="1051560"/>
-            <a:ext cx="1828800" cy="292608"/>
-          </a:xfrm>
-          <a:prstGeom prst="rect">
-            <a:avLst/>
-          </a:prstGeom>
-          <a:solidFill>
-            <a:srgbClr val="1F4E79"/>
-          </a:solidFill>
-          <a:ln w="9525">
-            <a:solidFill>
-              <a:srgbClr val="1F4E79"/>
-            </a:solidFill>
-          </a:ln>
-          <a:effectLst/>
-        </p:spPr>
-        <p:style>
-          <a:lnRef idx="1">
-            <a:schemeClr val="accent1"/>
-          </a:lnRef>
-          <a:fillRef idx="3">
-            <a:schemeClr val="accent1"/>
-          </a:fillRef>
-          <a:effectRef idx="2">
-            <a:schemeClr val="accent1"/>
-          </a:effectRef>
-          <a:fontRef idx="minor">
-            <a:schemeClr val="lt1"/>
-          </a:fontRef>
-        </p:style>
-        <p:txBody>
-          <a:bodyPr rtlCol="0" anchor="ctr" wrap="square" lIns="45720" rIns="45720" tIns="27432" bIns="27432"/>
-          <a:lstStyle/>
-          <a:p>
-            <a:pPr algn="ctr"/>
-            <a:r>
-              <a:rPr sz="1000" b="1">
-                <a:solidFill>
-                  <a:srgbClr val="FFFFFF"/>
-                </a:solidFill>
-                <a:latin typeface="맑은 고딕"/>
-                <a:ea typeface="맑은 고딕"/>
-              </a:rPr>
-              <a:t>Oracle 초과 쌍</a:t>
-            </a:r>
-          </a:p>
-        </p:txBody>
-      </p:sp>
-      <p:sp>
-        <p:nvSpPr>
-          <p:cNvPr id="62" name="Rectangle 61"/>
-          <p:cNvSpPr/>
-          <p:nvPr/>
-        </p:nvSpPr>
-        <p:spPr>
-          <a:xfrm>
-            <a:off x="7498079" y="1051560"/>
-            <a:ext cx="2011680" cy="292608"/>
-          </a:xfrm>
-          <a:prstGeom prst="rect">
-            <a:avLst/>
-          </a:prstGeom>
-          <a:solidFill>
-            <a:srgbClr val="1F4E79"/>
-          </a:solidFill>
-          <a:ln w="9525">
-            <a:solidFill>
-              <a:srgbClr val="1F4E79"/>
-            </a:solidFill>
-          </a:ln>
-          <a:effectLst/>
-        </p:spPr>
-        <p:style>
-          <a:lnRef idx="1">
-            <a:schemeClr val="accent1"/>
-          </a:lnRef>
-          <a:fillRef idx="3">
-            <a:schemeClr val="accent1"/>
-          </a:fillRef>
-          <a:effectRef idx="2">
-            <a:schemeClr val="accent1"/>
-          </a:effectRef>
-          <a:fontRef idx="minor">
-            <a:schemeClr val="lt1"/>
-          </a:fontRef>
-        </p:style>
-        <p:txBody>
-          <a:bodyPr rtlCol="0" anchor="ctr" wrap="square" lIns="45720" rIns="45720" tIns="27432" bIns="27432"/>
-          <a:lstStyle/>
-          <a:p>
-            <a:pPr algn="ctr"/>
-            <a:r>
-              <a:rPr sz="1000" b="1">
-                <a:solidFill>
-                  <a:srgbClr val="FFFFFF"/>
-                </a:solidFill>
-                <a:latin typeface="맑은 고딕"/>
-                <a:ea typeface="맑은 고딕"/>
-              </a:rPr>
-              <a:t>QA1 별 (x = 80%)</a:t>
-            </a:r>
-          </a:p>
-        </p:txBody>
-      </p:sp>
-      <p:sp>
-        <p:nvSpPr>
-          <p:cNvPr id="63" name="Rectangle 62"/>
-          <p:cNvSpPr/>
-          <p:nvPr/>
-        </p:nvSpPr>
-        <p:spPr>
-          <a:xfrm>
-            <a:off x="9509760" y="1051560"/>
-            <a:ext cx="2286000" cy="292608"/>
-          </a:xfrm>
-          <a:prstGeom prst="rect">
-            <a:avLst/>
-          </a:prstGeom>
-          <a:solidFill>
-            <a:srgbClr val="1F4E79"/>
-          </a:solidFill>
-          <a:ln w="9525">
-            <a:solidFill>
-              <a:srgbClr val="1F4E79"/>
-            </a:solidFill>
-          </a:ln>
-          <a:effectLst/>
-        </p:spPr>
-        <p:style>
-          <a:lnRef idx="1">
-            <a:schemeClr val="accent1"/>
-          </a:lnRef>
-          <a:fillRef idx="3">
-            <a:schemeClr val="accent1"/>
-          </a:fillRef>
-          <a:effectRef idx="2">
-            <a:schemeClr val="accent1"/>
-          </a:effectRef>
-          <a:fontRef idx="minor">
-            <a:schemeClr val="lt1"/>
-          </a:fontRef>
-        </p:style>
-        <p:txBody>
-          <a:bodyPr rtlCol="0" anchor="ctr" wrap="square" lIns="45720" rIns="45720" tIns="27432" bIns="27432"/>
-          <a:lstStyle/>
-          <a:p>
-            <a:pPr algn="ctr"/>
-            <a:r>
-              <a:rPr sz="1000" b="1">
-                <a:solidFill>
-                  <a:srgbClr val="FFFFFF"/>
-                </a:solidFill>
-                <a:latin typeface="맑은 고딕"/>
-                <a:ea typeface="맑은 고딕"/>
-              </a:rPr>
-              <a:t>현재 공식 별</a:t>
-            </a:r>
-          </a:p>
-        </p:txBody>
-      </p:sp>
-      <p:sp>
-        <p:nvSpPr>
-          <p:cNvPr id="64" name="Rectangle 63"/>
-          <p:cNvSpPr/>
-          <p:nvPr/>
-        </p:nvSpPr>
-        <p:spPr>
-          <a:xfrm>
-            <a:off x="365760" y="1371600"/>
-            <a:ext cx="1463040" cy="365760"/>
-          </a:xfrm>
-          <a:prstGeom prst="rect">
-            <a:avLst/>
-          </a:prstGeom>
-          <a:solidFill>
-            <a:srgbClr val="FFFFFF"/>
-          </a:solidFill>
-          <a:ln w="9525">
-            <a:solidFill>
-              <a:srgbClr val="BFBFBF"/>
-            </a:solidFill>
-          </a:ln>
-          <a:effectLst/>
-        </p:spPr>
-        <p:style>
-          <a:lnRef idx="1">
-            <a:schemeClr val="accent1"/>
-          </a:lnRef>
-          <a:fillRef idx="3">
-            <a:schemeClr val="accent1"/>
-          </a:fillRef>
-          <a:effectRef idx="2">
-            <a:schemeClr val="accent1"/>
-          </a:effectRef>
-          <a:fontRef idx="minor">
-            <a:schemeClr val="lt1"/>
-          </a:fontRef>
-        </p:style>
-        <p:txBody>
-          <a:bodyPr rtlCol="0" anchor="ctr" wrap="square" lIns="45720" rIns="45720" tIns="27432" bIns="27432"/>
-          <a:lstStyle/>
-          <a:p>
-            <a:pPr algn="ctr"/>
-            <a:r>
-              <a:rPr sz="950" b="1">
-                <a:solidFill>
-                  <a:srgbClr val="1A1A1A"/>
-                </a:solidFill>
-                <a:latin typeface="맑은 고딕"/>
-                <a:ea typeface="맑은 고딕"/>
-              </a:rPr>
-              <a:t>C1</a:t>
-            </a:r>
-          </a:p>
-        </p:txBody>
-      </p:sp>
-      <p:sp>
-        <p:nvSpPr>
-          <p:cNvPr id="65" name="Rectangle 64"/>
-          <p:cNvSpPr/>
-          <p:nvPr/>
-        </p:nvSpPr>
-        <p:spPr>
-          <a:xfrm>
-            <a:off x="1828800" y="1371600"/>
-            <a:ext cx="2011680" cy="365760"/>
-          </a:xfrm>
-          <a:prstGeom prst="rect">
-            <a:avLst/>
-          </a:prstGeom>
-          <a:solidFill>
-            <a:srgbClr val="FFFFFF"/>
-          </a:solidFill>
-          <a:ln w="9525">
-            <a:solidFill>
-              <a:srgbClr val="BFBFBF"/>
-            </a:solidFill>
-          </a:ln>
-          <a:effectLst/>
-        </p:spPr>
-        <p:style>
-          <a:lnRef idx="1">
-            <a:schemeClr val="accent1"/>
-          </a:lnRef>
-          <a:fillRef idx="3">
-            <a:schemeClr val="accent1"/>
-          </a:fillRef>
-          <a:effectRef idx="2">
-            <a:schemeClr val="accent1"/>
-          </a:effectRef>
-          <a:fontRef idx="minor">
-            <a:schemeClr val="lt1"/>
-          </a:fontRef>
-        </p:style>
-        <p:txBody>
-          <a:bodyPr rtlCol="0" anchor="ctr" wrap="square" lIns="45720" rIns="45720" tIns="27432" bIns="27432"/>
-          <a:lstStyle/>
-          <a:p>
-            <a:pPr algn="ctr"/>
-            <a:r>
-              <a:rPr sz="950" b="0">
-                <a:solidFill>
-                  <a:srgbClr val="1A1A1A"/>
-                </a:solidFill>
-                <a:latin typeface="맑은 고딕"/>
-                <a:ea typeface="맑은 고딕"/>
-              </a:rPr>
-              <a:t>0.62</a:t>
-            </a:r>
-          </a:p>
-        </p:txBody>
-      </p:sp>
-      <p:sp>
-        <p:nvSpPr>
-          <p:cNvPr id="66" name="Rectangle 65"/>
-          <p:cNvSpPr/>
-          <p:nvPr/>
-        </p:nvSpPr>
-        <p:spPr>
-          <a:xfrm>
-            <a:off x="3840480" y="1371600"/>
-            <a:ext cx="1828800" cy="365760"/>
-          </a:xfrm>
-          <a:prstGeom prst="rect">
-            <a:avLst/>
-          </a:prstGeom>
-          <a:solidFill>
-            <a:srgbClr val="FFFFFF"/>
-          </a:solidFill>
-          <a:ln w="9525">
-            <a:solidFill>
-              <a:srgbClr val="BFBFBF"/>
-            </a:solidFill>
-          </a:ln>
-          <a:effectLst/>
-        </p:spPr>
-        <p:style>
-          <a:lnRef idx="1">
-            <a:schemeClr val="accent1"/>
-          </a:lnRef>
-          <a:fillRef idx="3">
-            <a:schemeClr val="accent1"/>
-          </a:fillRef>
-          <a:effectRef idx="2">
-            <a:schemeClr val="accent1"/>
-          </a:effectRef>
-          <a:fontRef idx="minor">
-            <a:schemeClr val="lt1"/>
-          </a:fontRef>
-        </p:style>
-        <p:txBody>
-          <a:bodyPr rtlCol="0" anchor="ctr" wrap="square" lIns="45720" rIns="45720" tIns="27432" bIns="27432"/>
-          <a:lstStyle/>
-          <a:p>
-            <a:pPr algn="ctr"/>
-            <a:r>
-              <a:rPr sz="950" b="0">
-                <a:solidFill>
-                  <a:srgbClr val="1A1A1A"/>
-                </a:solidFill>
-                <a:latin typeface="맑은 고딕"/>
-                <a:ea typeface="맑은 고딕"/>
-              </a:rPr>
-              <a:t>0.59</a:t>
-            </a:r>
-          </a:p>
-        </p:txBody>
-      </p:sp>
-      <p:sp>
-        <p:nvSpPr>
-          <p:cNvPr id="67" name="Rectangle 66"/>
-          <p:cNvSpPr/>
-          <p:nvPr/>
-        </p:nvSpPr>
-        <p:spPr>
-          <a:xfrm>
-            <a:off x="5669280" y="1371600"/>
-            <a:ext cx="1828800" cy="365760"/>
-          </a:xfrm>
-          <a:prstGeom prst="rect">
-            <a:avLst/>
-          </a:prstGeom>
-          <a:solidFill>
-            <a:srgbClr val="FFFFFF"/>
-          </a:solidFill>
-          <a:ln w="9525">
-            <a:solidFill>
-              <a:srgbClr val="BFBFBF"/>
-            </a:solidFill>
-          </a:ln>
-          <a:effectLst/>
-        </p:spPr>
-        <p:style>
-          <a:lnRef idx="1">
-            <a:schemeClr val="accent1"/>
-          </a:lnRef>
-          <a:fillRef idx="3">
-            <a:schemeClr val="accent1"/>
-          </a:fillRef>
-          <a:effectRef idx="2">
-            <a:schemeClr val="accent1"/>
-          </a:effectRef>
-          <a:fontRef idx="minor">
-            <a:schemeClr val="lt1"/>
-          </a:fontRef>
-        </p:style>
-        <p:txBody>
-          <a:bodyPr rtlCol="0" anchor="ctr" wrap="square" lIns="45720" rIns="45720" tIns="27432" bIns="27432"/>
-          <a:lstStyle/>
-          <a:p>
-            <a:pPr algn="ctr"/>
-            <a:r>
-              <a:rPr sz="950" b="0">
-                <a:solidFill>
-                  <a:srgbClr val="1A1A1A"/>
-                </a:solidFill>
-                <a:latin typeface="맑은 고딕"/>
-                <a:ea typeface="맑은 고딕"/>
-              </a:rPr>
-              <a:t>0</a:t>
-            </a:r>
-          </a:p>
-        </p:txBody>
-      </p:sp>
-      <p:sp>
-        <p:nvSpPr>
-          <p:cNvPr id="68" name="Rectangle 67"/>
-          <p:cNvSpPr/>
-          <p:nvPr/>
-        </p:nvSpPr>
-        <p:spPr>
-          <a:xfrm>
-            <a:off x="7498079" y="1371600"/>
-            <a:ext cx="2011680" cy="365760"/>
-          </a:xfrm>
-          <a:prstGeom prst="rect">
-            <a:avLst/>
-          </a:prstGeom>
-          <a:solidFill>
-            <a:srgbClr val="FFFFFF"/>
-          </a:solidFill>
-          <a:ln w="9525">
-            <a:solidFill>
-              <a:srgbClr val="BFBFBF"/>
-            </a:solidFill>
-          </a:ln>
-          <a:effectLst/>
-        </p:spPr>
-        <p:style>
-          <a:lnRef idx="1">
-            <a:schemeClr val="accent1"/>
-          </a:lnRef>
-          <a:fillRef idx="3">
-            <a:schemeClr val="accent1"/>
-          </a:fillRef>
-          <a:effectRef idx="2">
-            <a:schemeClr val="accent1"/>
-          </a:effectRef>
-          <a:fontRef idx="minor">
-            <a:schemeClr val="lt1"/>
-          </a:fontRef>
-        </p:style>
-        <p:txBody>
-          <a:bodyPr rtlCol="0" anchor="ctr" wrap="square" lIns="45720" rIns="45720" tIns="27432" bIns="27432"/>
-          <a:lstStyle/>
-          <a:p>
-            <a:pPr algn="ctr"/>
-            <a:r>
-              <a:rPr sz="950" b="1">
-                <a:solidFill>
-                  <a:srgbClr val="1A1A1A"/>
-                </a:solidFill>
-                <a:latin typeface="맑은 고딕"/>
-                <a:ea typeface="맑은 고딕"/>
-              </a:rPr>
-              <a:t>★★</a:t>
-            </a:r>
-          </a:p>
-        </p:txBody>
-      </p:sp>
-      <p:sp>
-        <p:nvSpPr>
-          <p:cNvPr id="69" name="Rectangle 68"/>
-          <p:cNvSpPr/>
-          <p:nvPr/>
-        </p:nvSpPr>
-        <p:spPr>
-          <a:xfrm>
-            <a:off x="9509760" y="1371600"/>
-            <a:ext cx="2286000" cy="365760"/>
-          </a:xfrm>
-          <a:prstGeom prst="rect">
-            <a:avLst/>
-          </a:prstGeom>
-          <a:solidFill>
-            <a:srgbClr val="FFFFFF"/>
-          </a:solidFill>
-          <a:ln w="9525">
-            <a:solidFill>
-              <a:srgbClr val="BFBFBF"/>
-            </a:solidFill>
-          </a:ln>
-          <a:effectLst/>
-        </p:spPr>
-        <p:style>
-          <a:lnRef idx="1">
-            <a:schemeClr val="accent1"/>
-          </a:lnRef>
-          <a:fillRef idx="3">
-            <a:schemeClr val="accent1"/>
-          </a:fillRef>
-          <a:effectRef idx="2">
-            <a:schemeClr val="accent1"/>
-          </a:effectRef>
-          <a:fontRef idx="minor">
-            <a:schemeClr val="lt1"/>
-          </a:fontRef>
-        </p:style>
-        <p:txBody>
-          <a:bodyPr rtlCol="0" anchor="ctr" wrap="square" lIns="45720" rIns="45720" tIns="27432" bIns="27432"/>
-          <a:lstStyle/>
-          <a:p>
-            <a:pPr algn="ctr"/>
-            <a:r>
-              <a:rPr sz="950" b="0">
-                <a:solidFill>
-                  <a:srgbClr val="1A1A1A"/>
-                </a:solidFill>
-                <a:latin typeface="맑은 고딕"/>
-                <a:ea typeface="맑은 고딕"/>
-              </a:rPr>
-              <a:t>★★ (x1.298)</a:t>
-            </a:r>
-          </a:p>
-        </p:txBody>
-      </p:sp>
-      <p:sp>
-        <p:nvSpPr>
-          <p:cNvPr id="70" name="Rectangle 69"/>
-          <p:cNvSpPr/>
-          <p:nvPr/>
-        </p:nvSpPr>
-        <p:spPr>
-          <a:xfrm>
-            <a:off x="365760" y="1755648"/>
-            <a:ext cx="1463040" cy="365760"/>
-          </a:xfrm>
-          <a:prstGeom prst="rect">
-            <a:avLst/>
-          </a:prstGeom>
-          <a:solidFill>
-            <a:srgbClr val="FFFFFF"/>
-          </a:solidFill>
-          <a:ln w="9525">
-            <a:solidFill>
-              <a:srgbClr val="BFBFBF"/>
-            </a:solidFill>
-          </a:ln>
-          <a:effectLst/>
-        </p:spPr>
-        <p:style>
-          <a:lnRef idx="1">
-            <a:schemeClr val="accent1"/>
-          </a:lnRef>
-          <a:fillRef idx="3">
-            <a:schemeClr val="accent1"/>
-          </a:fillRef>
-          <a:effectRef idx="2">
-            <a:schemeClr val="accent1"/>
-          </a:effectRef>
-          <a:fontRef idx="minor">
-            <a:schemeClr val="lt1"/>
-          </a:fontRef>
-        </p:style>
-        <p:txBody>
-          <a:bodyPr rtlCol="0" anchor="ctr" wrap="square" lIns="45720" rIns="45720" tIns="27432" bIns="27432"/>
-          <a:lstStyle/>
-          <a:p>
-            <a:pPr algn="ctr"/>
-            <a:r>
-              <a:rPr sz="950" b="1">
-                <a:solidFill>
-                  <a:srgbClr val="1A1A1A"/>
-                </a:solidFill>
-                <a:latin typeface="맑은 고딕"/>
-                <a:ea typeface="맑은 고딕"/>
-              </a:rPr>
-              <a:t>C2</a:t>
-            </a:r>
-          </a:p>
-        </p:txBody>
-      </p:sp>
-      <p:sp>
-        <p:nvSpPr>
-          <p:cNvPr id="71" name="Rectangle 70"/>
-          <p:cNvSpPr/>
-          <p:nvPr/>
-        </p:nvSpPr>
-        <p:spPr>
-          <a:xfrm>
-            <a:off x="1828800" y="1755648"/>
-            <a:ext cx="2011680" cy="365760"/>
-          </a:xfrm>
-          <a:prstGeom prst="rect">
-            <a:avLst/>
-          </a:prstGeom>
-          <a:solidFill>
-            <a:srgbClr val="FFFFFF"/>
-          </a:solidFill>
-          <a:ln w="9525">
-            <a:solidFill>
-              <a:srgbClr val="BFBFBF"/>
-            </a:solidFill>
-          </a:ln>
-          <a:effectLst/>
-        </p:spPr>
-        <p:style>
-          <a:lnRef idx="1">
-            <a:schemeClr val="accent1"/>
-          </a:lnRef>
-          <a:fillRef idx="3">
-            <a:schemeClr val="accent1"/>
-          </a:fillRef>
-          <a:effectRef idx="2">
-            <a:schemeClr val="accent1"/>
-          </a:effectRef>
-          <a:fontRef idx="minor">
-            <a:schemeClr val="lt1"/>
-          </a:fontRef>
-        </p:style>
-        <p:txBody>
-          <a:bodyPr rtlCol="0" anchor="ctr" wrap="square" lIns="45720" rIns="45720" tIns="27432" bIns="27432"/>
-          <a:lstStyle/>
-          <a:p>
-            <a:pPr algn="ctr"/>
-            <a:r>
-              <a:rPr sz="950" b="0">
-                <a:solidFill>
-                  <a:srgbClr val="1A1A1A"/>
-                </a:solidFill>
-                <a:latin typeface="맑은 고딕"/>
-                <a:ea typeface="맑은 고딕"/>
-              </a:rPr>
-              <a:t>0.83</a:t>
-            </a:r>
-          </a:p>
-        </p:txBody>
-      </p:sp>
-      <p:sp>
-        <p:nvSpPr>
-          <p:cNvPr id="72" name="Rectangle 71"/>
-          <p:cNvSpPr/>
-          <p:nvPr/>
-        </p:nvSpPr>
-        <p:spPr>
-          <a:xfrm>
-            <a:off x="3840480" y="1755648"/>
-            <a:ext cx="1828800" cy="365760"/>
-          </a:xfrm>
-          <a:prstGeom prst="rect">
-            <a:avLst/>
-          </a:prstGeom>
-          <a:solidFill>
-            <a:srgbClr val="FFFFFF"/>
-          </a:solidFill>
-          <a:ln w="9525">
-            <a:solidFill>
-              <a:srgbClr val="BFBFBF"/>
-            </a:solidFill>
-          </a:ln>
-          <a:effectLst/>
-        </p:spPr>
-        <p:style>
-          <a:lnRef idx="1">
-            <a:schemeClr val="accent1"/>
-          </a:lnRef>
-          <a:fillRef idx="3">
-            <a:schemeClr val="accent1"/>
-          </a:fillRef>
-          <a:effectRef idx="2">
-            <a:schemeClr val="accent1"/>
-          </a:effectRef>
-          <a:fontRef idx="minor">
-            <a:schemeClr val="lt1"/>
-          </a:fontRef>
-        </p:style>
-        <p:txBody>
-          <a:bodyPr rtlCol="0" anchor="ctr" wrap="square" lIns="45720" rIns="45720" tIns="27432" bIns="27432"/>
-          <a:lstStyle/>
-          <a:p>
-            <a:pPr algn="ctr"/>
-            <a:r>
-              <a:rPr sz="950" b="0">
-                <a:solidFill>
-                  <a:srgbClr val="1A1A1A"/>
-                </a:solidFill>
-                <a:latin typeface="맑은 고딕"/>
-                <a:ea typeface="맑은 고딕"/>
-              </a:rPr>
-              <a:t>0.75</a:t>
-            </a:r>
-          </a:p>
-        </p:txBody>
-      </p:sp>
-      <p:sp>
-        <p:nvSpPr>
-          <p:cNvPr id="73" name="Rectangle 72"/>
-          <p:cNvSpPr/>
-          <p:nvPr/>
-        </p:nvSpPr>
-        <p:spPr>
-          <a:xfrm>
-            <a:off x="5669280" y="1755648"/>
-            <a:ext cx="1828800" cy="365760"/>
-          </a:xfrm>
-          <a:prstGeom prst="rect">
-            <a:avLst/>
-          </a:prstGeom>
-          <a:solidFill>
-            <a:srgbClr val="FFFFFF"/>
-          </a:solidFill>
-          <a:ln w="9525">
-            <a:solidFill>
-              <a:srgbClr val="BFBFBF"/>
-            </a:solidFill>
-          </a:ln>
-          <a:effectLst/>
-        </p:spPr>
-        <p:style>
-          <a:lnRef idx="1">
-            <a:schemeClr val="accent1"/>
-          </a:lnRef>
-          <a:fillRef idx="3">
-            <a:schemeClr val="accent1"/>
-          </a:fillRef>
-          <a:effectRef idx="2">
-            <a:schemeClr val="accent1"/>
-          </a:effectRef>
-          <a:fontRef idx="minor">
-            <a:schemeClr val="lt1"/>
-          </a:fontRef>
-        </p:style>
-        <p:txBody>
-          <a:bodyPr rtlCol="0" anchor="ctr" wrap="square" lIns="45720" rIns="45720" tIns="27432" bIns="27432"/>
-          <a:lstStyle/>
-          <a:p>
-            <a:pPr algn="ctr"/>
-            <a:r>
-              <a:rPr sz="950" b="0">
-                <a:solidFill>
-                  <a:srgbClr val="1A1A1A"/>
-                </a:solidFill>
-                <a:latin typeface="맑은 고딕"/>
-                <a:ea typeface="맑은 고딕"/>
-              </a:rPr>
-              <a:t>1</a:t>
-            </a:r>
-          </a:p>
-        </p:txBody>
-      </p:sp>
-      <p:sp>
-        <p:nvSpPr>
-          <p:cNvPr id="74" name="Rectangle 73"/>
-          <p:cNvSpPr/>
-          <p:nvPr/>
-        </p:nvSpPr>
-        <p:spPr>
-          <a:xfrm>
-            <a:off x="7498079" y="1755648"/>
-            <a:ext cx="2011680" cy="365760"/>
-          </a:xfrm>
-          <a:prstGeom prst="rect">
-            <a:avLst/>
-          </a:prstGeom>
-          <a:solidFill>
-            <a:srgbClr val="FFFFFF"/>
-          </a:solidFill>
-          <a:ln w="9525">
-            <a:solidFill>
-              <a:srgbClr val="BFBFBF"/>
-            </a:solidFill>
-          </a:ln>
-          <a:effectLst/>
-        </p:spPr>
-        <p:style>
-          <a:lnRef idx="1">
-            <a:schemeClr val="accent1"/>
-          </a:lnRef>
-          <a:fillRef idx="3">
-            <a:schemeClr val="accent1"/>
-          </a:fillRef>
-          <a:effectRef idx="2">
-            <a:schemeClr val="accent1"/>
-          </a:effectRef>
-          <a:fontRef idx="minor">
-            <a:schemeClr val="lt1"/>
-          </a:fontRef>
-        </p:style>
-        <p:txBody>
-          <a:bodyPr rtlCol="0" anchor="ctr" wrap="square" lIns="45720" rIns="45720" tIns="27432" bIns="27432"/>
-          <a:lstStyle/>
-          <a:p>
-            <a:pPr algn="ctr"/>
-            <a:r>
-              <a:rPr sz="950" b="1">
-                <a:solidFill>
-                  <a:srgbClr val="1A1A1A"/>
-                </a:solidFill>
-                <a:latin typeface="맑은 고딕"/>
-                <a:ea typeface="맑은 고딕"/>
-              </a:rPr>
-              <a:t>★★★</a:t>
-            </a:r>
-          </a:p>
-        </p:txBody>
-      </p:sp>
-      <p:sp>
-        <p:nvSpPr>
-          <p:cNvPr id="75" name="Rectangle 74"/>
-          <p:cNvSpPr/>
-          <p:nvPr/>
-        </p:nvSpPr>
-        <p:spPr>
-          <a:xfrm>
-            <a:off x="9509760" y="1755648"/>
-            <a:ext cx="2286000" cy="365760"/>
-          </a:xfrm>
-          <a:prstGeom prst="rect">
-            <a:avLst/>
-          </a:prstGeom>
-          <a:solidFill>
-            <a:srgbClr val="FFFFFF"/>
-          </a:solidFill>
-          <a:ln w="9525">
-            <a:solidFill>
-              <a:srgbClr val="BFBFBF"/>
-            </a:solidFill>
-          </a:ln>
-          <a:effectLst/>
-        </p:spPr>
-        <p:style>
-          <a:lnRef idx="1">
-            <a:schemeClr val="accent1"/>
-          </a:lnRef>
-          <a:fillRef idx="3">
-            <a:schemeClr val="accent1"/>
-          </a:fillRef>
-          <a:effectRef idx="2">
-            <a:schemeClr val="accent1"/>
-          </a:effectRef>
-          <a:fontRef idx="minor">
-            <a:schemeClr val="lt1"/>
-          </a:fontRef>
-        </p:style>
-        <p:txBody>
-          <a:bodyPr rtlCol="0" anchor="ctr" wrap="square" lIns="45720" rIns="45720" tIns="27432" bIns="27432"/>
-          <a:lstStyle/>
-          <a:p>
-            <a:pPr algn="ctr"/>
-            <a:r>
-              <a:rPr sz="950" b="0">
-                <a:solidFill>
-                  <a:srgbClr val="1A1A1A"/>
-                </a:solidFill>
-                <a:latin typeface="맑은 고딕"/>
-                <a:ea typeface="맑은 고딕"/>
-              </a:rPr>
-              <a:t>★★★ (x1.422)</a:t>
-            </a:r>
-          </a:p>
-        </p:txBody>
-      </p:sp>
-      <p:sp>
-        <p:nvSpPr>
-          <p:cNvPr id="76" name="Rectangle 75"/>
-          <p:cNvSpPr/>
-          <p:nvPr/>
-        </p:nvSpPr>
-        <p:spPr>
-          <a:xfrm>
-            <a:off x="365760" y="2286000"/>
-            <a:ext cx="5669280" cy="3840480"/>
-          </a:xfrm>
-          <a:prstGeom prst="rect">
-            <a:avLst/>
-          </a:prstGeom>
-          <a:solidFill>
-            <a:srgbClr val="E3F1E3"/>
-          </a:solidFill>
-          <a:ln w="9525">
-            <a:solidFill>
-              <a:srgbClr val="5B9B5B"/>
-            </a:solidFill>
-          </a:ln>
-          <a:effectLst/>
-        </p:spPr>
-        <p:style>
-          <a:lnRef idx="1">
-            <a:schemeClr val="accent1"/>
-          </a:lnRef>
-          <a:fillRef idx="3">
-            <a:schemeClr val="accent1"/>
-          </a:fillRef>
-          <a:effectRef idx="2">
-            <a:schemeClr val="accent1"/>
-          </a:effectRef>
-          <a:fontRef idx="minor">
-            <a:schemeClr val="lt1"/>
-          </a:fontRef>
-        </p:style>
-        <p:txBody>
-          <a:bodyPr rtlCol="0" anchor="t" wrap="square" lIns="45720" rIns="45720" tIns="27432" bIns="27432"/>
-          <a:lstStyle/>
-          <a:p>
-            <a:pPr algn="l"/>
-            <a:r>
-              <a:rPr sz="950" b="1">
-                <a:solidFill>
-                  <a:srgbClr val="1A1A1A"/>
-                </a:solidFill>
-                <a:latin typeface="맑은 고딕"/>
-                <a:ea typeface="맑은 고딕"/>
-              </a:rPr>
-              <a:t>정의와 x의 근거</a:t>
-            </a:r>
-          </a:p>
-          <a:p>
-            <a:pPr algn="l"/>
-            <a:r>
-              <a:rPr sz="950" b="0">
-                <a:solidFill>
-                  <a:srgbClr val="1A1A1A"/>
-                </a:solidFill>
-                <a:latin typeface="맑은 고딕"/>
-                <a:ea typeface="맑은 고딕"/>
-              </a:rPr>
-              <a:t>- 달성률 = (후보 - Baseline) / (Oracle - Baseline), 시나리오 쌍마다. Oracle = 미래 접근률 완전 정보 </a:t>
-            </a:r>
-          </a:p>
-          <a:p>
-            <a:pPr algn="l"/>
-            <a:r>
-              <a:rPr sz="950" b="0">
-                <a:solidFill>
-                  <a:srgbClr val="1A1A1A"/>
-                </a:solidFill>
-                <a:latin typeface="맑은 고딕"/>
-                <a:ea typeface="맑은 고딕"/>
-              </a:rPr>
-              <a:t>+ 무비용 즉시 이동을 준 정책(Oracle-ideal, 증명된 최적은 아님). 개선 여지 3.3% 이하인 쌍은 제외(</a:t>
-            </a:r>
-          </a:p>
-          <a:p>
-            <a:pPr algn="l"/>
-            <a:r>
-              <a:rPr sz="950" b="0">
-                <a:solidFill>
-                  <a:srgbClr val="1A1A1A"/>
-                </a:solidFill>
-                <a:latin typeface="맑은 고딕"/>
-                <a:ea typeface="맑은 고딕"/>
-              </a:rPr>
-              <a:t>비교 가능 21쌍 중 10쌍 사용).</a:t>
-            </a:r>
-          </a:p>
-          <a:p>
-            <a:pPr algn="l"/>
-            <a:r>
-              <a:rPr sz="950" b="0">
-                <a:solidFill>
-                  <a:srgbClr val="1A1A1A"/>
-                </a:solidFill>
-                <a:latin typeface="맑은 고딕"/>
-                <a:ea typeface="맑은 고딕"/>
-              </a:rPr>
-              <a:t>- x = 80%: 문헌의 이득 달성률 {57, 75, 87, 95}%의 중앙값 81%를 반올림. Mockingjay(HPCA'22) Ta</a:t>
-            </a:r>
-          </a:p>
-          <a:p>
-            <a:pPr algn="l"/>
-            <a:r>
-              <a:rPr sz="950" b="0">
-                <a:solidFill>
-                  <a:srgbClr val="1A1A1A"/>
-                </a:solidFill>
-                <a:latin typeface="맑은 고딕"/>
-                <a:ea typeface="맑은 고딕"/>
-              </a:rPr>
-              <a:t>ble I: SHiP 57%, Hawkeye 75%, Mockingjay 95%(Belady MIN 대비 IPC 개선), ARMS(arXiv 2508.0441</a:t>
-            </a:r>
-          </a:p>
-          <a:p>
-            <a:pPr algn="l"/>
-            <a:r>
-              <a:rPr sz="950" b="0">
-                <a:solidFill>
-                  <a:srgbClr val="1A1A1A"/>
-                </a:solidFill>
-                <a:latin typeface="맑은 고딕"/>
-                <a:ea typeface="맑은 고딕"/>
-              </a:rPr>
-              <a:t>7): 튜닝 최적의 97% 이상 -&gt; 87% 이상(환산).</a:t>
-            </a:r>
-          </a:p>
-          <a:p>
-            <a:pPr algn="l"/>
-            <a:r>
-              <a:rPr sz="950" b="0">
-                <a:solidFill>
-                  <a:srgbClr val="1A1A1A"/>
-                </a:solidFill>
-                <a:latin typeface="맑은 고딕"/>
-                <a:ea typeface="맑은 고딕"/>
-              </a:rPr>
-              <a:t>- ★/★★ 경계는 기존 잡음 기준(Baseline 대비 0.97) 유지.</a:t>
-            </a:r>
-          </a:p>
-        </p:txBody>
-      </p:sp>
-      <p:sp>
-        <p:nvSpPr>
-          <p:cNvPr id="77" name="Rectangle 76"/>
-          <p:cNvSpPr/>
-          <p:nvPr/>
-        </p:nvSpPr>
-        <p:spPr>
-          <a:xfrm>
-            <a:off x="6217920" y="2286000"/>
-            <a:ext cx="5577840" cy="3840480"/>
-          </a:xfrm>
-          <a:prstGeom prst="rect">
-            <a:avLst/>
-          </a:prstGeom>
-          <a:solidFill>
-            <a:srgbClr val="F2F2F2"/>
-          </a:solidFill>
-          <a:ln w="9525">
-            <a:solidFill>
-              <a:srgbClr val="BFBFBF"/>
-            </a:solidFill>
-          </a:ln>
-          <a:effectLst/>
-        </p:spPr>
-        <p:style>
-          <a:lnRef idx="1">
-            <a:schemeClr val="accent1"/>
-          </a:lnRef>
-          <a:fillRef idx="3">
-            <a:schemeClr val="accent1"/>
-          </a:fillRef>
-          <a:effectRef idx="2">
-            <a:schemeClr val="accent1"/>
-          </a:effectRef>
-          <a:fontRef idx="minor">
-            <a:schemeClr val="lt1"/>
-          </a:fontRef>
-        </p:style>
-        <p:txBody>
-          <a:bodyPr rtlCol="0" anchor="t" wrap="square" lIns="45720" rIns="45720" tIns="27432" bIns="27432"/>
-          <a:lstStyle/>
-          <a:p>
-            <a:pPr algn="l"/>
-            <a:r>
-              <a:rPr sz="950" b="1">
-                <a:solidFill>
-                  <a:srgbClr val="404040"/>
-                </a:solidFill>
-                <a:latin typeface="맑은 고딕"/>
-                <a:ea typeface="맑은 고딕"/>
-              </a:rPr>
-              <a:t>솔직한 한계</a:t>
-            </a:r>
-          </a:p>
-          <a:p>
-            <a:pPr algn="l"/>
-            <a:r>
-              <a:rPr sz="950" b="0">
-                <a:solidFill>
-                  <a:srgbClr val="404040"/>
-                </a:solidFill>
-                <a:latin typeface="맑은 고딕"/>
-                <a:ea typeface="맑은 고딕"/>
-              </a:rPr>
-              <a:t>- 문헌은 CPU 캐시 교체와 tiered memory 연구다. LLM 서빙에 직접 해당하는 이득 달성률 문헌은 </a:t>
-            </a:r>
-          </a:p>
-          <a:p>
-            <a:pPr algn="l"/>
-            <a:r>
-              <a:rPr sz="950" b="0">
-                <a:solidFill>
-                  <a:srgbClr val="404040"/>
-                </a:solidFill>
-                <a:latin typeface="맑은 고딕"/>
-                <a:ea typeface="맑은 고딕"/>
-              </a:rPr>
-              <a:t>찾지 못했다. LLM KV 연구(arXiv 2609.16215)는 대역폭이 경합하면 oracle prefetch도 이득이 없었</a:t>
-            </a:r>
-          </a:p>
-          <a:p>
-            <a:pPr algn="l"/>
-            <a:r>
-              <a:rPr sz="950" b="0">
-                <a:solidFill>
-                  <a:srgbClr val="404040"/>
-                </a:solidFill>
-                <a:latin typeface="맑은 고딕"/>
-                <a:ea typeface="맑은 고딕"/>
-              </a:rPr>
-              <a:t>다고 보고했고, 이는 우리 링크 간섭 결과와 같은 방향이다.</a:t>
-            </a:r>
-          </a:p>
-          <a:p>
-            <a:pPr algn="l"/>
-            <a:r>
-              <a:rPr sz="950" b="0">
-                <a:solidFill>
-                  <a:srgbClr val="404040"/>
-                </a:solidFill>
-                <a:latin typeface="맑은 고딕"/>
-                <a:ea typeface="맑은 고딕"/>
-              </a:rPr>
-              <a:t>- 쌍 10개뿐이라 부트스트랩 95% 구간이 C1 0.33~0.87, C2 0.70~0.93으로 겹친다. C2가 더 가깝</a:t>
-            </a:r>
-          </a:p>
-          <a:p>
-            <a:pPr algn="l"/>
-            <a:r>
-              <a:rPr sz="950" b="0">
-                <a:solidFill>
-                  <a:srgbClr val="404040"/>
-                </a:solidFill>
-                <a:latin typeface="맑은 고딕"/>
-                <a:ea typeface="맑은 고딕"/>
-              </a:rPr>
-              <a:t>다고 단정할 수 없다.</a:t>
-            </a:r>
-          </a:p>
-          <a:p>
-            <a:pPr algn="l"/>
-            <a:r>
-              <a:rPr sz="950" b="0">
-                <a:solidFill>
-                  <a:srgbClr val="404040"/>
-                </a:solidFill>
-                <a:latin typeface="맑은 고딕"/>
-                <a:ea typeface="맑은 고딕"/>
-              </a:rPr>
-              <a:t>- 쌍별 평균을 쓰면 C2는 0.75로 ★★이다(pooled는 문헌의 관례). 두 방식 모두 선택은 C1.</a:t>
-            </a:r>
-          </a:p>
-          <a:p>
-            <a:pPr algn="l"/>
-            <a:r>
-              <a:rPr sz="950" b="0">
-                <a:solidFill>
-                  <a:srgbClr val="404040"/>
-                </a:solidFill>
-                <a:latin typeface="맑은 고딕"/>
-                <a:ea typeface="맑은 고딕"/>
-              </a:rPr>
-              <a:t>- QA2(Oracle을 넘는 쌍 6개)와 QA3(Oracle 미정의)에는 적용하지 않았다. 출처 5개와 제외 사유: q</a:t>
-            </a:r>
-          </a:p>
-          <a:p>
-            <a:pPr algn="l"/>
-            <a:r>
-              <a:rPr sz="950" b="0">
-                <a:solidFill>
-                  <a:srgbClr val="404040"/>
-                </a:solidFill>
-                <a:latin typeface="맑은 고딕"/>
-                <a:ea typeface="맑은 고딕"/>
-              </a:rPr>
-              <a:t>a-capture-literature.md.</a:t>
-            </a:r>
-          </a:p>
-        </p:txBody>
-      </p:sp>
-    </p:spTree>
-  </p:cSld>
-  <p:clrMapOvr>
-    <a:masterClrMapping/>
-  </p:clrMapOvr>
-</p:sld>
-</file>
-
-<file path=ppt/slides/slide26.xml><?xml version="1.0" encoding="utf-8"?>
 <p:sld xmlns:a="http://schemas.openxmlformats.org/drawingml/2006/main" xmlns:p="http://schemas.openxmlformats.org/presentationml/2006/main" xmlns:r="http://schemas.openxmlformats.org/officeDocument/2006/relationships">
   <p:cSld>
     <p:spTree>

</xml_diff>

<commit_message>
DP1: revert official stars to v5 (owner decision), keep Oracle capture as reference; merged star-criteria slide with v5 criteria and basis
Co-Authored-By: Claude Sonnet 5.5 <noreply@anthropic.com>
Claude-Session: https://claude.ai/code/session_018inK4pZJGzYwjdk7QAyZgn
</commit_message>
<xml_diff>
--- a/doc-mk/DP1/DP1-appendix-qa-result.pptx
+++ b/doc-mk/DP1/DP1-appendix-qa-result.pptx
@@ -5838,7 +5838,7 @@
                 <a:latin typeface="맑은 고딕"/>
                 <a:ea typeface="맑은 고딕"/>
               </a:rPr>
-              <a:t>★★  x1.28 (TTFT x1.58 · TPOT x1.04)</a:t>
+              <a:t>★★★  x1.28 (TTFT x1.58 · TPOT x1.04)</a:t>
             </a:r>
           </a:p>
         </p:txBody>
@@ -5894,7 +5894,7 @@
                 <a:latin typeface="맑은 고딕"/>
                 <a:ea typeface="맑은 고딕"/>
               </a:rPr>
-              <a:t>★★  x1.56 (TTFT x2.18 · TPOT x1.12)</a:t>
+              <a:t>★★★  x1.56 (TTFT x2.18 · TPOT x1.12)</a:t>
             </a:r>
           </a:p>
         </p:txBody>
@@ -6549,7 +6549,7 @@
                 <a:latin typeface="맑은 고딕"/>
                 <a:ea typeface="맑은 고딕"/>
               </a:rPr>
-              <a:t>9</a:t>
+              <a:t>10</a:t>
             </a:r>
           </a:p>
         </p:txBody>
@@ -6605,7 +6605,7 @@
                 <a:latin typeface="맑은 고딕"/>
                 <a:ea typeface="맑은 고딕"/>
               </a:rPr>
-              <a:t>8</a:t>
+              <a:t>9</a:t>
             </a:r>
           </a:p>
         </p:txBody>
@@ -6730,7 +6730,7 @@
                 <a:latin typeface="맑은 고딕"/>
                 <a:ea typeface="맑은 고딕"/>
               </a:rPr>
-              <a:t>선택: C1  —  별 합계가 높은 C1 후보 (9 대 8). 합계 차이 1점이라 별 경계에 민감하다.</a:t>
+              <a:t>선택: C1  —  별 합계가 높은 C1 후보 (10 대 9). 합계 차이 1점이라 별 경계에 민감하다.</a:t>
             </a:r>
           </a:p>
           <a:p>
@@ -6743,7 +6743,7 @@
                 <a:latin typeface="맑은 고딕"/>
                 <a:ea typeface="맑은 고딕"/>
               </a:rPr>
-              <a:t>한계: [B] simulation. 별 기준(Oracle 달성률 80%, 집계 방식, QA2·QA3 Oracle)과 QA3 정의(선택을 C2에서 C1로 바꿈), QA4 평균 집계는 결과를 본 뒤 정함. QA4 공수·비용은 ASSUMED.</a:t>
+              <a:t>한계: [B] simulation, 별 경계(QA1 1.30)와 QA3 정의(선택을 C2에서 C1로 바꿈), QA4 평균 집계는 결과를 본 뒤 정함. QA4 공수·비용은 ASSUMED.</a:t>
             </a:r>
           </a:p>
         </p:txBody>
@@ -11582,7 +11582,7 @@
                 <a:latin typeface="맑은 고딕"/>
                 <a:ea typeface="맑은 고딕"/>
               </a:rPr>
-              <a:t>- 별 합계는 C1 9, C2 8로 근소해 선택(C1)은 별 경계와 QA 정의에 민감하다.</a:t>
+              <a:t>- 별 합계는 C1 10, C2 9로 근소해 선택(C1)은 별 경계와 QA 정의에 민감하다.</a:t>
             </a:r>
           </a:p>
         </p:txBody>
@@ -13251,7 +13251,7 @@
                 <a:latin typeface="맑은 고딕"/>
                 <a:ea typeface="맑은 고딕"/>
               </a:rPr>
-              <a:t>★★  x1.28</a:t>
+              <a:t>★★★  x1.28</a:t>
             </a:r>
           </a:p>
         </p:txBody>
@@ -13307,7 +13307,7 @@
                 <a:latin typeface="맑은 고딕"/>
                 <a:ea typeface="맑은 고딕"/>
               </a:rPr>
-              <a:t>★★  x1.56</a:t>
+              <a:t>★★★  x1.56</a:t>
             </a:r>
           </a:p>
         </p:txBody>
@@ -14035,7 +14035,7 @@
                 <a:latin typeface="맑은 고딕"/>
                 <a:ea typeface="맑은 고딕"/>
               </a:rPr>
-              <a:t>9 → C1 (합계)</a:t>
+              <a:t>9 → C2 (동점, 우선순위 QA1)</a:t>
             </a:r>
           </a:p>
         </p:txBody>
@@ -14091,7 +14091,7 @@
                 <a:latin typeface="맑은 고딕"/>
                 <a:ea typeface="맑은 고딕"/>
               </a:rPr>
-              <a:t>9 → C1 (합계)</a:t>
+              <a:t>10 → C1 (합계)</a:t>
             </a:r>
           </a:p>
         </p:txBody>
@@ -14147,7 +14147,7 @@
                 <a:latin typeface="맑은 고딕"/>
                 <a:ea typeface="맑은 고딕"/>
               </a:rPr>
-              <a:t>8</a:t>
+              <a:t>9</a:t>
             </a:r>
           </a:p>
         </p:txBody>
@@ -14203,7 +14203,7 @@
                 <a:latin typeface="맑은 고딕"/>
                 <a:ea typeface="맑은 고딕"/>
               </a:rPr>
-              <a:t>보완 설계: affinity 추가의 효과</a:t>
+              <a:t>보완 설계 스토리: affinity 추가</a:t>
             </a:r>
           </a:p>
           <a:p>
@@ -14216,7 +14216,7 @@
                 <a:latin typeface="맑은 고딕"/>
                 <a:ea typeface="맑은 고딕"/>
               </a:rPr>
-              <a:t>- affinity가 없는 C1은 자원 압박에만 반응한다. 처리량 x1.05(Oracle 달성률 13%), TTFT P99 x1.27(</a:t>
+              <a:t>- affinity가 없는 C1은 자원 압박에만 반응한다. 처리량 x1.05, TTFT P99 x1.27(악화)로 C2(x1.42)에 </a:t>
             </a:r>
           </a:p>
           <a:p>
@@ -14229,7 +14229,7 @@
                 <a:latin typeface="맑은 고딕"/>
                 <a:ea typeface="맑은 고딕"/>
               </a:rPr>
-              <a:t>악화), 승/무/패 2/29/0로 C2(x1.42, 달성률 83%)에 크게 못 미친다.</a:t>
+              <a:t>크게 못 미치고, 별 합계가 동점이라 우선순위로 C2가 선택된다.</a:t>
             </a:r>
           </a:p>
           <a:p>
@@ -14255,7 +14255,7 @@
                 <a:latin typeface="맑은 고딕"/>
                 <a:ea typeface="맑은 고딕"/>
               </a:rPr>
-              <a:t>' 객체를 승격, 필요하면 교환) 처리량 x1.30(달성률 62%), 승/무/패 6/25/0가 된다.</a:t>
+              <a:t>' 객체를 승격, 필요하면 교환) 처리량 x1.30, QA2 ★★★이 되어 합계 10 대 9로 C1이 선택된다.</a:t>
             </a:r>
           </a:p>
           <a:p>
@@ -14376,7 +14376,7 @@
                 <a:latin typeface="맑은 고딕"/>
                 <a:ea typeface="맑은 고딕"/>
               </a:rPr>
-              <a:t>- **별(v6)로는 affinity 제거가 선택을 바꾸지 못한다**: 두 변형 모두 QA1~3이 ★★로 같고 합계 </a:t>
+              <a:t>- 선택이 C1로 바뀐 것은 QA3(HBM x0.97 대 C2 x1.21)·QA4 우위와 QA2 별 경계(x1.28 vs 1.25)에</a:t>
             </a:r>
           </a:p>
           <a:p>
@@ -14389,20 +14389,7 @@
                 <a:latin typeface="맑은 고딕"/>
                 <a:ea typeface="맑은 고딕"/>
               </a:rPr>
-              <a:t>C1 9(제거)/9(포함) 대 C2 8라 둘 다 C1 선택. 3단계 별이 값의 차이를 가린다. 이전 기준(v5)에서</a:t>
-            </a:r>
-          </a:p>
-          <a:p>
-            <a:pPr algn="l"/>
-            <a:r>
-              <a:rPr sz="950" b="0">
-                <a:solidFill>
-                  <a:srgbClr val="404040"/>
-                </a:solidFill>
-                <a:latin typeface="맑은 고딕"/>
-                <a:ea typeface="맑은 고딕"/>
-              </a:rPr>
-              <a:t>는 QA2 ★★★ 경계 때문에 제거 시 동점(C2 선택)이었으나 경계 선택의 효과였다.</a:t>
+              <a:t>서 온다. 합계 차이 1점이라 경계에 민감하다.</a:t>
             </a:r>
           </a:p>
           <a:p>
@@ -15954,7 +15941,7 @@
                   <a:schemeClr val="bg1"/>
                 </a:solidFill>
               </a:rPr>
-              <a:t>별점 기준과 근거 (v6: Oracle 이득 달성률)</a:t>
+              <a:t>별점 기준과 근거 (QA별 ★ 1·2·3개)</a:t>
             </a:r>
             <a:r>
               <a:rPr lang="en-US" altLang="ko-KR" sz="1400" b="1" dirty="0">
@@ -16131,7 +16118,7 @@
         <p:spPr>
           <a:xfrm>
             <a:off x="1097280" y="1024128"/>
-            <a:ext cx="2514600" cy="274320"/>
+            <a:ext cx="2240280" cy="274320"/>
           </a:xfrm>
           <a:prstGeom prst="rect">
             <a:avLst/>
@@ -16173,7 +16160,7 @@
                 <a:latin typeface="맑은 고딕"/>
                 <a:ea typeface="맑은 고딕"/>
               </a:rPr>
-              <a:t>평가 지표 / Oracle(이론적 상한)</a:t>
+              <a:t>평가 지표</a:t>
             </a:r>
           </a:p>
         </p:txBody>
@@ -16186,8 +16173,8 @@
         </p:nvSpPr>
         <p:spPr>
           <a:xfrm>
-            <a:off x="3611880" y="1024128"/>
-            <a:ext cx="1691640" cy="274320"/>
+            <a:off x="3337560" y="1024128"/>
+            <a:ext cx="1417320" cy="274320"/>
           </a:xfrm>
           <a:prstGeom prst="rect">
             <a:avLst/>
@@ -16242,8 +16229,8 @@
         </p:nvSpPr>
         <p:spPr>
           <a:xfrm>
-            <a:off x="5303520" y="1024128"/>
-            <a:ext cx="1920240" cy="274320"/>
+            <a:off x="4754880" y="1024128"/>
+            <a:ext cx="1554480" cy="274320"/>
           </a:xfrm>
           <a:prstGeom prst="rect">
             <a:avLst/>
@@ -16298,8 +16285,8 @@
         </p:nvSpPr>
         <p:spPr>
           <a:xfrm>
-            <a:off x="7223760" y="1024128"/>
-            <a:ext cx="1600200" cy="274320"/>
+            <a:off x="6309360" y="1024128"/>
+            <a:ext cx="1554480" cy="274320"/>
           </a:xfrm>
           <a:prstGeom prst="rect">
             <a:avLst/>
@@ -16354,8 +16341,8 @@
         </p:nvSpPr>
         <p:spPr>
           <a:xfrm>
-            <a:off x="8823960" y="1024128"/>
-            <a:ext cx="1965960" cy="274320"/>
+            <a:off x="7863840" y="1024128"/>
+            <a:ext cx="2926080" cy="274320"/>
           </a:xfrm>
           <a:prstGeom prst="rect">
             <a:avLst/>
@@ -16467,7 +16454,7 @@
         <p:spPr>
           <a:xfrm>
             <a:off x="320040" y="1325880"/>
-            <a:ext cx="777240" cy="786384"/>
+            <a:ext cx="777240" cy="822960"/>
           </a:xfrm>
           <a:prstGeom prst="rect">
             <a:avLst/>
@@ -16536,7 +16523,7 @@
         <p:spPr>
           <a:xfrm>
             <a:off x="1097280" y="1325880"/>
-            <a:ext cx="2514600" cy="786384"/>
+            <a:ext cx="2240280" cy="822960"/>
           </a:xfrm>
           <a:prstGeom prst="rect">
             <a:avLst/>
@@ -16578,7 +16565,7 @@
                 <a:latin typeface="맑은 고딕"/>
                 <a:ea typeface="맑은 고딕"/>
               </a:rPr>
-              <a:t>Max SLO goodput의 Baseline 대비 배수</a:t>
+              <a:t>Max SLO goodput의 Baseline 대비 배수 (시</a:t>
             </a:r>
           </a:p>
           <a:p>
@@ -16591,9 +16578,52 @@
                 <a:latin typeface="맑은 고딕"/>
                 <a:ea typeface="맑은 고딕"/>
               </a:rPr>
-              <a:t>Oracle-ideal: 미래 접근률을 알고 이동 비용이 0인 </a:t>
-            </a:r>
-          </a:p>
+              <a:t>나리오 쌍별 비율의 geomean)</a:t>
+            </a:r>
+          </a:p>
+        </p:txBody>
+      </p:sp>
+      <p:sp>
+        <p:nvSpPr>
+          <p:cNvPr id="67" name="Rectangle 66"/>
+          <p:cNvSpPr/>
+          <p:nvPr/>
+        </p:nvSpPr>
+        <p:spPr>
+          <a:xfrm>
+            <a:off x="3337560" y="1325880"/>
+            <a:ext cx="1417320" cy="822960"/>
+          </a:xfrm>
+          <a:prstGeom prst="rect">
+            <a:avLst/>
+          </a:prstGeom>
+          <a:solidFill>
+            <a:srgbClr val="FFFFFF"/>
+          </a:solidFill>
+          <a:ln w="9525">
+            <a:solidFill>
+              <a:srgbClr val="BFBFBF"/>
+            </a:solidFill>
+          </a:ln>
+          <a:effectLst/>
+        </p:spPr>
+        <p:style>
+          <a:lnRef idx="1">
+            <a:schemeClr val="accent1"/>
+          </a:lnRef>
+          <a:fillRef idx="3">
+            <a:schemeClr val="accent1"/>
+          </a:fillRef>
+          <a:effectRef idx="2">
+            <a:schemeClr val="accent1"/>
+          </a:effectRef>
+          <a:fontRef idx="minor">
+            <a:schemeClr val="lt1"/>
+          </a:fontRef>
+        </p:style>
+        <p:txBody>
+          <a:bodyPr rtlCol="0" anchor="ctr" wrap="square" lIns="45720" rIns="45720" tIns="27432" bIns="27432"/>
+          <a:lstStyle/>
           <a:p>
             <a:pPr algn="l"/>
             <a:r>
@@ -16604,21 +16634,34 @@
                 <a:latin typeface="맑은 고딕"/>
                 <a:ea typeface="맑은 고딕"/>
               </a:rPr>
-              <a:t>정책</a:t>
-            </a:r>
-          </a:p>
-        </p:txBody>
-      </p:sp>
-      <p:sp>
-        <p:nvSpPr>
-          <p:cNvPr id="67" name="Rectangle 66"/>
-          <p:cNvSpPr/>
-          <p:nvPr/>
-        </p:nvSpPr>
-        <p:spPr>
-          <a:xfrm>
-            <a:off x="3611880" y="1325880"/>
-            <a:ext cx="1691640" cy="786384"/>
+              <a:t>0.97배 미만 (Baseline보다 </a:t>
+            </a:r>
+          </a:p>
+          <a:p>
+            <a:pPr algn="l"/>
+            <a:r>
+              <a:rPr sz="800" b="0">
+                <a:solidFill>
+                  <a:srgbClr val="1A1A1A"/>
+                </a:solidFill>
+                <a:latin typeface="맑은 고딕"/>
+                <a:ea typeface="맑은 고딕"/>
+              </a:rPr>
+              <a:t>느림)</a:t>
+            </a:r>
+          </a:p>
+        </p:txBody>
+      </p:sp>
+      <p:sp>
+        <p:nvSpPr>
+          <p:cNvPr id="68" name="Rectangle 67"/>
+          <p:cNvSpPr/>
+          <p:nvPr/>
+        </p:nvSpPr>
+        <p:spPr>
+          <a:xfrm>
+            <a:off x="4754880" y="1325880"/>
+            <a:ext cx="1554480" cy="822960"/>
           </a:xfrm>
           <a:prstGeom prst="rect">
             <a:avLst/>
@@ -16660,9 +16703,52 @@
                 <a:latin typeface="맑은 고딕"/>
                 <a:ea typeface="맑은 고딕"/>
               </a:rPr>
-              <a:t>Baseline의 0.97배 미만 (Baselin</a:t>
-            </a:r>
-          </a:p>
+              <a:t>0.97 이상 1.30 미만</a:t>
+            </a:r>
+          </a:p>
+        </p:txBody>
+      </p:sp>
+      <p:sp>
+        <p:nvSpPr>
+          <p:cNvPr id="69" name="Rectangle 68"/>
+          <p:cNvSpPr/>
+          <p:nvPr/>
+        </p:nvSpPr>
+        <p:spPr>
+          <a:xfrm>
+            <a:off x="6309360" y="1325880"/>
+            <a:ext cx="1554480" cy="822960"/>
+          </a:xfrm>
+          <a:prstGeom prst="rect">
+            <a:avLst/>
+          </a:prstGeom>
+          <a:solidFill>
+            <a:srgbClr val="FFFFFF"/>
+          </a:solidFill>
+          <a:ln w="9525">
+            <a:solidFill>
+              <a:srgbClr val="BFBFBF"/>
+            </a:solidFill>
+          </a:ln>
+          <a:effectLst/>
+        </p:spPr>
+        <p:style>
+          <a:lnRef idx="1">
+            <a:schemeClr val="accent1"/>
+          </a:lnRef>
+          <a:fillRef idx="3">
+            <a:schemeClr val="accent1"/>
+          </a:fillRef>
+          <a:effectRef idx="2">
+            <a:schemeClr val="accent1"/>
+          </a:effectRef>
+          <a:fontRef idx="minor">
+            <a:schemeClr val="lt1"/>
+          </a:fontRef>
+        </p:style>
+        <p:txBody>
+          <a:bodyPr rtlCol="0" anchor="ctr" wrap="square" lIns="45720" rIns="45720" tIns="27432" bIns="27432"/>
+          <a:lstStyle/>
           <a:p>
             <a:pPr algn="l"/>
             <a:r>
@@ -16673,21 +16759,21 @@
                 <a:latin typeface="맑은 고딕"/>
                 <a:ea typeface="맑은 고딕"/>
               </a:rPr>
-              <a:t>e보다 느림)</a:t>
-            </a:r>
-          </a:p>
-        </p:txBody>
-      </p:sp>
-      <p:sp>
-        <p:nvSpPr>
-          <p:cNvPr id="68" name="Rectangle 67"/>
-          <p:cNvSpPr/>
-          <p:nvPr/>
-        </p:nvSpPr>
-        <p:spPr>
-          <a:xfrm>
-            <a:off x="5303520" y="1325880"/>
-            <a:ext cx="1920240" cy="786384"/>
+              <a:t>1.30배 이상</a:t>
+            </a:r>
+          </a:p>
+        </p:txBody>
+      </p:sp>
+      <p:sp>
+        <p:nvSpPr>
+          <p:cNvPr id="70" name="Rectangle 69"/>
+          <p:cNvSpPr/>
+          <p:nvPr/>
+        </p:nvSpPr>
+        <p:spPr>
+          <a:xfrm>
+            <a:off x="7863840" y="1325880"/>
+            <a:ext cx="2926080" cy="822960"/>
           </a:xfrm>
           <a:prstGeom prst="rect">
             <a:avLst/>
@@ -16729,7 +16815,7 @@
                 <a:latin typeface="맑은 고딕"/>
                 <a:ea typeface="맑은 고딕"/>
               </a:rPr>
-              <a:t>0.97배 이상이고 Oracle 이득의 80% </a:t>
+              <a:t>★/★★ 경계: Baseline끼리 비교해도 0.968~1.033배 흔들</a:t>
             </a:r>
           </a:p>
           <a:p>
@@ -16742,21 +16828,47 @@
                 <a:latin typeface="맑은 고딕"/>
                 <a:ea typeface="맑은 고딕"/>
               </a:rPr>
-              <a:t>미만</a:t>
-            </a:r>
-          </a:p>
-        </p:txBody>
-      </p:sp>
-      <p:sp>
-        <p:nvSpPr>
-          <p:cNvPr id="69" name="Rectangle 68"/>
-          <p:cNvSpPr/>
-          <p:nvPr/>
-        </p:nvSpPr>
-        <p:spPr>
-          <a:xfrm>
-            <a:off x="7223760" y="1325880"/>
-            <a:ext cx="1600200" cy="786384"/>
+              <a:t>려 0.97은 그 하한(측정). ★★★ 경계: 1.30배 = 같은 수요</a:t>
+            </a:r>
+          </a:p>
+          <a:p>
+            <a:pPr algn="l"/>
+            <a:r>
+              <a:rPr sz="800" b="0">
+                <a:solidFill>
+                  <a:srgbClr val="1A1A1A"/>
+                </a:solidFill>
+                <a:latin typeface="맑은 고딕"/>
+                <a:ea typeface="맑은 고딕"/>
+              </a:rPr>
+              <a:t>를 하드웨어 77%로 처리 = 8-GPU 노드에서 약 1.85 GPU </a:t>
+            </a:r>
+          </a:p>
+          <a:p>
+            <a:pPr algn="l"/>
+            <a:r>
+              <a:rPr sz="800" b="0">
+                <a:solidFill>
+                  <a:srgbClr val="1A1A1A"/>
+                </a:solidFill>
+                <a:latin typeface="맑은 고딕"/>
+                <a:ea typeface="맑은 고딕"/>
+              </a:rPr>
+              <a:t>절감(환산, 정책 선택)</a:t>
+            </a:r>
+          </a:p>
+        </p:txBody>
+      </p:sp>
+      <p:sp>
+        <p:nvSpPr>
+          <p:cNvPr id="71" name="Rectangle 70"/>
+          <p:cNvSpPr/>
+          <p:nvPr/>
+        </p:nvSpPr>
+        <p:spPr>
+          <a:xfrm>
+            <a:off x="10789920" y="1325880"/>
+            <a:ext cx="1097280" cy="822960"/>
           </a:xfrm>
           <a:prstGeom prst="rect">
             <a:avLst/>
@@ -16789,7 +16901,7 @@
           <a:bodyPr rtlCol="0" anchor="ctr" wrap="square" lIns="45720" rIns="45720" tIns="27432" bIns="27432"/>
           <a:lstStyle/>
           <a:p>
-            <a:pPr algn="l"/>
+            <a:pPr algn="ctr"/>
             <a:r>
               <a:rPr sz="800" b="0">
                 <a:solidFill>
@@ -16798,21 +16910,103 @@
                 <a:latin typeface="맑은 고딕"/>
                 <a:ea typeface="맑은 고딕"/>
               </a:rPr>
-              <a:t>Oracle 이득의 80% 이상</a:t>
-            </a:r>
-          </a:p>
-        </p:txBody>
-      </p:sp>
-      <p:sp>
-        <p:nvSpPr>
-          <p:cNvPr id="70" name="Rectangle 69"/>
-          <p:cNvSpPr/>
-          <p:nvPr/>
-        </p:nvSpPr>
-        <p:spPr>
-          <a:xfrm>
-            <a:off x="8823960" y="1325880"/>
-            <a:ext cx="1965960" cy="786384"/>
+              <a:t>C1 ★★ x1.30</a:t>
+            </a:r>
+          </a:p>
+          <a:p>
+            <a:pPr algn="ctr"/>
+            <a:r>
+              <a:rPr sz="800" b="0">
+                <a:solidFill>
+                  <a:srgbClr val="1A1A1A"/>
+                </a:solidFill>
+                <a:latin typeface="맑은 고딕"/>
+                <a:ea typeface="맑은 고딕"/>
+              </a:rPr>
+              <a:t>C2 ★★★ x1.42</a:t>
+            </a:r>
+          </a:p>
+        </p:txBody>
+      </p:sp>
+      <p:sp>
+        <p:nvSpPr>
+          <p:cNvPr id="72" name="Rectangle 71"/>
+          <p:cNvSpPr/>
+          <p:nvPr/>
+        </p:nvSpPr>
+        <p:spPr>
+          <a:xfrm>
+            <a:off x="320040" y="2176272"/>
+            <a:ext cx="777240" cy="822960"/>
+          </a:xfrm>
+          <a:prstGeom prst="rect">
+            <a:avLst/>
+          </a:prstGeom>
+          <a:solidFill>
+            <a:srgbClr val="DCE9F5"/>
+          </a:solidFill>
+          <a:ln w="9525">
+            <a:solidFill>
+              <a:srgbClr val="4D7EA8"/>
+            </a:solidFill>
+          </a:ln>
+          <a:effectLst/>
+        </p:spPr>
+        <p:style>
+          <a:lnRef idx="1">
+            <a:schemeClr val="accent1"/>
+          </a:lnRef>
+          <a:fillRef idx="3">
+            <a:schemeClr val="accent1"/>
+          </a:fillRef>
+          <a:effectRef idx="2">
+            <a:schemeClr val="accent1"/>
+          </a:effectRef>
+          <a:fontRef idx="minor">
+            <a:schemeClr val="lt1"/>
+          </a:fontRef>
+        </p:style>
+        <p:txBody>
+          <a:bodyPr rtlCol="0" anchor="ctr" wrap="square" lIns="45720" rIns="45720" tIns="27432" bIns="27432"/>
+          <a:lstStyle/>
+          <a:p>
+            <a:pPr algn="ctr"/>
+            <a:r>
+              <a:rPr sz="800" b="1">
+                <a:solidFill>
+                  <a:srgbClr val="1A1A1A"/>
+                </a:solidFill>
+                <a:latin typeface="맑은 고딕"/>
+                <a:ea typeface="맑은 고딕"/>
+              </a:rPr>
+              <a:t>QA2</a:t>
+            </a:r>
+          </a:p>
+          <a:p>
+            <a:pPr algn="ctr"/>
+            <a:r>
+              <a:rPr sz="800" b="1">
+                <a:solidFill>
+                  <a:srgbClr val="1A1A1A"/>
+                </a:solidFill>
+                <a:latin typeface="맑은 고딕"/>
+                <a:ea typeface="맑은 고딕"/>
+              </a:rPr>
+              <a:t>지연</a:t>
+            </a:r>
+          </a:p>
+        </p:txBody>
+      </p:sp>
+      <p:sp>
+        <p:nvSpPr>
+          <p:cNvPr id="73" name="Rectangle 72"/>
+          <p:cNvSpPr/>
+          <p:nvPr/>
+        </p:nvSpPr>
+        <p:spPr>
+          <a:xfrm>
+            <a:off x="1097280" y="2176272"/>
+            <a:ext cx="2240280" cy="822960"/>
           </a:xfrm>
           <a:prstGeom prst="rect">
             <a:avLst/>
@@ -16854,7 +17048,7 @@
                 <a:latin typeface="맑은 고딕"/>
                 <a:ea typeface="맑은 고딕"/>
               </a:rPr>
-              <a:t>★/★★: Baseline끼리 비교해도 0.968</a:t>
+              <a:t>TTFT·TPOT x P50/P95/P99 6개 지표 개선 배</a:t>
             </a:r>
           </a:p>
           <a:p>
@@ -16867,9 +17061,52 @@
                 <a:latin typeface="맑은 고딕"/>
                 <a:ea typeface="맑은 고딕"/>
               </a:rPr>
-              <a:t>~1.033배 흔들림(측정). ★★★: 문헌 </a:t>
-            </a:r>
-          </a:p>
+              <a:t>수(Baseline÷후보)의 geomean</a:t>
+            </a:r>
+          </a:p>
+        </p:txBody>
+      </p:sp>
+      <p:sp>
+        <p:nvSpPr>
+          <p:cNvPr id="74" name="Rectangle 73"/>
+          <p:cNvSpPr/>
+          <p:nvPr/>
+        </p:nvSpPr>
+        <p:spPr>
+          <a:xfrm>
+            <a:off x="3337560" y="2176272"/>
+            <a:ext cx="1417320" cy="822960"/>
+          </a:xfrm>
+          <a:prstGeom prst="rect">
+            <a:avLst/>
+          </a:prstGeom>
+          <a:solidFill>
+            <a:srgbClr val="FFFFFF"/>
+          </a:solidFill>
+          <a:ln w="9525">
+            <a:solidFill>
+              <a:srgbClr val="BFBFBF"/>
+            </a:solidFill>
+          </a:ln>
+          <a:effectLst/>
+        </p:spPr>
+        <p:style>
+          <a:lnRef idx="1">
+            <a:schemeClr val="accent1"/>
+          </a:lnRef>
+          <a:fillRef idx="3">
+            <a:schemeClr val="accent1"/>
+          </a:fillRef>
+          <a:effectRef idx="2">
+            <a:schemeClr val="accent1"/>
+          </a:effectRef>
+          <a:fontRef idx="minor">
+            <a:schemeClr val="lt1"/>
+          </a:fontRef>
+        </p:style>
+        <p:txBody>
+          <a:bodyPr rtlCol="0" anchor="ctr" wrap="square" lIns="45720" rIns="45720" tIns="27432" bIns="27432"/>
+          <a:lstStyle/>
           <a:p>
             <a:pPr algn="l"/>
             <a:r>
@@ -16880,21 +17117,34 @@
                 <a:latin typeface="맑은 고딕"/>
                 <a:ea typeface="맑은 고딕"/>
               </a:rPr>
-              <a:t>달성률 중앙값 81%</a:t>
-            </a:r>
-          </a:p>
-        </p:txBody>
-      </p:sp>
-      <p:sp>
-        <p:nvSpPr>
-          <p:cNvPr id="71" name="Rectangle 70"/>
-          <p:cNvSpPr/>
-          <p:nvPr/>
-        </p:nvSpPr>
-        <p:spPr>
-          <a:xfrm>
-            <a:off x="10789920" y="1325880"/>
-            <a:ext cx="1097280" cy="786384"/>
+              <a:t>0.95배 미만 (지연이 5%+ </a:t>
+            </a:r>
+          </a:p>
+          <a:p>
+            <a:pPr algn="l"/>
+            <a:r>
+              <a:rPr sz="800" b="0">
+                <a:solidFill>
+                  <a:srgbClr val="1A1A1A"/>
+                </a:solidFill>
+                <a:latin typeface="맑은 고딕"/>
+                <a:ea typeface="맑은 고딕"/>
+              </a:rPr>
+              <a:t>나빠짐)</a:t>
+            </a:r>
+          </a:p>
+        </p:txBody>
+      </p:sp>
+      <p:sp>
+        <p:nvSpPr>
+          <p:cNvPr id="75" name="Rectangle 74"/>
+          <p:cNvSpPr/>
+          <p:nvPr/>
+        </p:nvSpPr>
+        <p:spPr>
+          <a:xfrm>
+            <a:off x="4754880" y="2176272"/>
+            <a:ext cx="1554480" cy="822960"/>
           </a:xfrm>
           <a:prstGeom prst="rect">
             <a:avLst/>
@@ -16927,6 +17177,200 @@
           <a:bodyPr rtlCol="0" anchor="ctr" wrap="square" lIns="45720" rIns="45720" tIns="27432" bIns="27432"/>
           <a:lstStyle/>
           <a:p>
+            <a:pPr algn="l"/>
+            <a:r>
+              <a:rPr sz="800" b="0">
+                <a:solidFill>
+                  <a:srgbClr val="1A1A1A"/>
+                </a:solidFill>
+                <a:latin typeface="맑은 고딕"/>
+                <a:ea typeface="맑은 고딕"/>
+              </a:rPr>
+              <a:t>0.95 이상 1.25 미만</a:t>
+            </a:r>
+          </a:p>
+        </p:txBody>
+      </p:sp>
+      <p:sp>
+        <p:nvSpPr>
+          <p:cNvPr id="76" name="Rectangle 75"/>
+          <p:cNvSpPr/>
+          <p:nvPr/>
+        </p:nvSpPr>
+        <p:spPr>
+          <a:xfrm>
+            <a:off x="6309360" y="2176272"/>
+            <a:ext cx="1554480" cy="822960"/>
+          </a:xfrm>
+          <a:prstGeom prst="rect">
+            <a:avLst/>
+          </a:prstGeom>
+          <a:solidFill>
+            <a:srgbClr val="FFFFFF"/>
+          </a:solidFill>
+          <a:ln w="9525">
+            <a:solidFill>
+              <a:srgbClr val="BFBFBF"/>
+            </a:solidFill>
+          </a:ln>
+          <a:effectLst/>
+        </p:spPr>
+        <p:style>
+          <a:lnRef idx="1">
+            <a:schemeClr val="accent1"/>
+          </a:lnRef>
+          <a:fillRef idx="3">
+            <a:schemeClr val="accent1"/>
+          </a:fillRef>
+          <a:effectRef idx="2">
+            <a:schemeClr val="accent1"/>
+          </a:effectRef>
+          <a:fontRef idx="minor">
+            <a:schemeClr val="lt1"/>
+          </a:fontRef>
+        </p:style>
+        <p:txBody>
+          <a:bodyPr rtlCol="0" anchor="ctr" wrap="square" lIns="45720" rIns="45720" tIns="27432" bIns="27432"/>
+          <a:lstStyle/>
+          <a:p>
+            <a:pPr algn="l"/>
+            <a:r>
+              <a:rPr sz="800" b="0">
+                <a:solidFill>
+                  <a:srgbClr val="1A1A1A"/>
+                </a:solidFill>
+                <a:latin typeface="맑은 고딕"/>
+                <a:ea typeface="맑은 고딕"/>
+              </a:rPr>
+              <a:t>1.25배 이상</a:t>
+            </a:r>
+          </a:p>
+        </p:txBody>
+      </p:sp>
+      <p:sp>
+        <p:nvSpPr>
+          <p:cNvPr id="77" name="Rectangle 76"/>
+          <p:cNvSpPr/>
+          <p:nvPr/>
+        </p:nvSpPr>
+        <p:spPr>
+          <a:xfrm>
+            <a:off x="7863840" y="2176272"/>
+            <a:ext cx="2926080" cy="822960"/>
+          </a:xfrm>
+          <a:prstGeom prst="rect">
+            <a:avLst/>
+          </a:prstGeom>
+          <a:solidFill>
+            <a:srgbClr val="FFFFFF"/>
+          </a:solidFill>
+          <a:ln w="9525">
+            <a:solidFill>
+              <a:srgbClr val="BFBFBF"/>
+            </a:solidFill>
+          </a:ln>
+          <a:effectLst/>
+        </p:spPr>
+        <p:style>
+          <a:lnRef idx="1">
+            <a:schemeClr val="accent1"/>
+          </a:lnRef>
+          <a:fillRef idx="3">
+            <a:schemeClr val="accent1"/>
+          </a:fillRef>
+          <a:effectRef idx="2">
+            <a:schemeClr val="accent1"/>
+          </a:effectRef>
+          <a:fontRef idx="minor">
+            <a:schemeClr val="lt1"/>
+          </a:fontRef>
+        </p:style>
+        <p:txBody>
+          <a:bodyPr rtlCol="0" anchor="ctr" wrap="square" lIns="45720" rIns="45720" tIns="27432" bIns="27432"/>
+          <a:lstStyle/>
+          <a:p>
+            <a:pPr algn="l"/>
+            <a:r>
+              <a:rPr sz="800" b="0">
+                <a:solidFill>
+                  <a:srgbClr val="1A1A1A"/>
+                </a:solidFill>
+                <a:latin typeface="맑은 고딕"/>
+                <a:ea typeface="맑은 고딕"/>
+              </a:rPr>
+              <a:t>★/★★ 경계: Baseline끼리 0.973~1.028배(측정), 약간 느</a:t>
+            </a:r>
+          </a:p>
+          <a:p>
+            <a:pPr algn="l"/>
+            <a:r>
+              <a:rPr sz="800" b="0">
+                <a:solidFill>
+                  <a:srgbClr val="1A1A1A"/>
+                </a:solidFill>
+                <a:latin typeface="맑은 고딕"/>
+                <a:ea typeface="맑은 고딕"/>
+              </a:rPr>
+              <a:t>슨하게 0.95. ★★★ 경계: 1.25배 = 지연 20% 감소(TTFT P</a:t>
+            </a:r>
+          </a:p>
+          <a:p>
+            <a:pPr algn="l"/>
+            <a:r>
+              <a:rPr sz="800" b="0">
+                <a:solidFill>
+                  <a:srgbClr val="1A1A1A"/>
+                </a:solidFill>
+                <a:latin typeface="맑은 고딕"/>
+                <a:ea typeface="맑은 고딕"/>
+              </a:rPr>
+              <a:t>99 1,084 ms가 867 ms로, 환산)</a:t>
+            </a:r>
+          </a:p>
+        </p:txBody>
+      </p:sp>
+      <p:sp>
+        <p:nvSpPr>
+          <p:cNvPr id="78" name="Rectangle 77"/>
+          <p:cNvSpPr/>
+          <p:nvPr/>
+        </p:nvSpPr>
+        <p:spPr>
+          <a:xfrm>
+            <a:off x="10789920" y="2176272"/>
+            <a:ext cx="1097280" cy="822960"/>
+          </a:xfrm>
+          <a:prstGeom prst="rect">
+            <a:avLst/>
+          </a:prstGeom>
+          <a:solidFill>
+            <a:srgbClr val="FFFFFF"/>
+          </a:solidFill>
+          <a:ln w="9525">
+            <a:solidFill>
+              <a:srgbClr val="BFBFBF"/>
+            </a:solidFill>
+          </a:ln>
+          <a:effectLst/>
+        </p:spPr>
+        <p:style>
+          <a:lnRef idx="1">
+            <a:schemeClr val="accent1"/>
+          </a:lnRef>
+          <a:fillRef idx="3">
+            <a:schemeClr val="accent1"/>
+          </a:fillRef>
+          <a:effectRef idx="2">
+            <a:schemeClr val="accent1"/>
+          </a:effectRef>
+          <a:fontRef idx="minor">
+            <a:schemeClr val="lt1"/>
+          </a:fontRef>
+        </p:style>
+        <p:txBody>
+          <a:bodyPr rtlCol="0" anchor="ctr" wrap="square" lIns="45720" rIns="45720" tIns="27432" bIns="27432"/>
+          <a:lstStyle/>
+          <a:p>
             <a:pPr algn="ctr"/>
             <a:r>
               <a:rPr sz="800" b="0">
@@ -16936,7 +17380,7 @@
                 <a:latin typeface="맑은 고딕"/>
                 <a:ea typeface="맑은 고딕"/>
               </a:rPr>
-              <a:t>C1 ★★ 62%</a:t>
+              <a:t>C1 ★★★ x1.28</a:t>
             </a:r>
           </a:p>
           <a:p>
@@ -16949,21 +17393,21 @@
                 <a:latin typeface="맑은 고딕"/>
                 <a:ea typeface="맑은 고딕"/>
               </a:rPr>
-              <a:t>C2 ★★★ 83%</a:t>
-            </a:r>
-          </a:p>
-        </p:txBody>
-      </p:sp>
-      <p:sp>
-        <p:nvSpPr>
-          <p:cNvPr id="72" name="Rectangle 71"/>
-          <p:cNvSpPr/>
-          <p:nvPr/>
-        </p:nvSpPr>
-        <p:spPr>
-          <a:xfrm>
-            <a:off x="320040" y="2139696"/>
-            <a:ext cx="777240" cy="786384"/>
+              <a:t>C2 ★★★ x1.56</a:t>
+            </a:r>
+          </a:p>
+        </p:txBody>
+      </p:sp>
+      <p:sp>
+        <p:nvSpPr>
+          <p:cNvPr id="79" name="Rectangle 78"/>
+          <p:cNvSpPr/>
+          <p:nvPr/>
+        </p:nvSpPr>
+        <p:spPr>
+          <a:xfrm>
+            <a:off x="320040" y="3026664"/>
+            <a:ext cx="777240" cy="822960"/>
           </a:xfrm>
           <a:prstGeom prst="rect">
             <a:avLst/>
@@ -17005,7 +17449,7 @@
                 <a:latin typeface="맑은 고딕"/>
                 <a:ea typeface="맑은 고딕"/>
               </a:rPr>
-              <a:t>QA2</a:t>
+              <a:t>QA3</a:t>
             </a:r>
           </a:p>
           <a:p>
@@ -17018,21 +17462,21 @@
                 <a:latin typeface="맑은 고딕"/>
                 <a:ea typeface="맑은 고딕"/>
               </a:rPr>
-              <a:t>지연</a:t>
-            </a:r>
-          </a:p>
-        </p:txBody>
-      </p:sp>
-      <p:sp>
-        <p:nvSpPr>
-          <p:cNvPr id="73" name="Rectangle 72"/>
-          <p:cNvSpPr/>
-          <p:nvPr/>
-        </p:nvSpPr>
-        <p:spPr>
-          <a:xfrm>
-            <a:off x="1097280" y="2139696"/>
-            <a:ext cx="2514600" cy="786384"/>
+              <a:t>HBM 사용</a:t>
+            </a:r>
+          </a:p>
+        </p:txBody>
+      </p:sp>
+      <p:sp>
+        <p:nvSpPr>
+          <p:cNvPr id="80" name="Rectangle 79"/>
+          <p:cNvSpPr/>
+          <p:nvPr/>
+        </p:nvSpPr>
+        <p:spPr>
+          <a:xfrm>
+            <a:off x="1097280" y="3026664"/>
+            <a:ext cx="2240280" cy="822960"/>
           </a:xfrm>
           <a:prstGeom prst="rect">
             <a:avLst/>
@@ -17074,7 +17518,7 @@
                 <a:latin typeface="맑은 고딕"/>
                 <a:ea typeface="맑은 고딕"/>
               </a:rPr>
-              <a:t>TTFT·TPOT x P50/95/99 6개 지표 개선 배수(Basel</a:t>
+              <a:t>HBM 절감 배수 (Baseline GiB ÷ 후보 GiB, 시</a:t>
             </a:r>
           </a:p>
           <a:p>
@@ -17087,9 +17531,52 @@
                 <a:latin typeface="맑은 고딕"/>
                 <a:ea typeface="맑은 고딕"/>
               </a:rPr>
-              <a:t>ine÷후보) 평균</a:t>
-            </a:r>
-          </a:p>
+              <a:t>간 평균 점유)</a:t>
+            </a:r>
+          </a:p>
+        </p:txBody>
+      </p:sp>
+      <p:sp>
+        <p:nvSpPr>
+          <p:cNvPr id="81" name="Rectangle 80"/>
+          <p:cNvSpPr/>
+          <p:nvPr/>
+        </p:nvSpPr>
+        <p:spPr>
+          <a:xfrm>
+            <a:off x="3337560" y="3026664"/>
+            <a:ext cx="1417320" cy="822960"/>
+          </a:xfrm>
+          <a:prstGeom prst="rect">
+            <a:avLst/>
+          </a:prstGeom>
+          <a:solidFill>
+            <a:srgbClr val="FFFFFF"/>
+          </a:solidFill>
+          <a:ln w="9525">
+            <a:solidFill>
+              <a:srgbClr val="BFBFBF"/>
+            </a:solidFill>
+          </a:ln>
+          <a:effectLst/>
+        </p:spPr>
+        <p:style>
+          <a:lnRef idx="1">
+            <a:schemeClr val="accent1"/>
+          </a:lnRef>
+          <a:fillRef idx="3">
+            <a:schemeClr val="accent1"/>
+          </a:fillRef>
+          <a:effectRef idx="2">
+            <a:schemeClr val="accent1"/>
+          </a:effectRef>
+          <a:fontRef idx="minor">
+            <a:schemeClr val="lt1"/>
+          </a:fontRef>
+        </p:style>
+        <p:txBody>
+          <a:bodyPr rtlCol="0" anchor="ctr" wrap="square" lIns="45720" rIns="45720" tIns="27432" bIns="27432"/>
+          <a:lstStyle/>
           <a:p>
             <a:pPr algn="l"/>
             <a:r>
@@ -17100,7 +17587,7 @@
                 <a:latin typeface="맑은 고딕"/>
                 <a:ea typeface="맑은 고딕"/>
               </a:rPr>
-              <a:t>Oracle-lean: 접근된 객체를 이동 비용 없이 HBM에</a:t>
+              <a:t>0.95배 미만 (HBM을 5%+ </a:t>
             </a:r>
           </a:p>
           <a:p>
@@ -17113,21 +17600,21 @@
                 <a:latin typeface="맑은 고딕"/>
                 <a:ea typeface="맑은 고딕"/>
               </a:rPr>
-              <a:t>두는 정책</a:t>
-            </a:r>
-          </a:p>
-        </p:txBody>
-      </p:sp>
-      <p:sp>
-        <p:nvSpPr>
-          <p:cNvPr id="74" name="Rectangle 73"/>
-          <p:cNvSpPr/>
-          <p:nvPr/>
-        </p:nvSpPr>
-        <p:spPr>
-          <a:xfrm>
-            <a:off x="3611880" y="2139696"/>
-            <a:ext cx="1691640" cy="786384"/>
+              <a:t>더 씀)</a:t>
+            </a:r>
+          </a:p>
+        </p:txBody>
+      </p:sp>
+      <p:sp>
+        <p:nvSpPr>
+          <p:cNvPr id="82" name="Rectangle 81"/>
+          <p:cNvSpPr/>
+          <p:nvPr/>
+        </p:nvSpPr>
+        <p:spPr>
+          <a:xfrm>
+            <a:off x="4754880" y="3026664"/>
+            <a:ext cx="1554480" cy="822960"/>
           </a:xfrm>
           <a:prstGeom prst="rect">
             <a:avLst/>
@@ -17169,9 +17656,52 @@
                 <a:latin typeface="맑은 고딕"/>
                 <a:ea typeface="맑은 고딕"/>
               </a:rPr>
-              <a:t>0.95배 미만 (지연이 5%+ 나빠짐</a:t>
-            </a:r>
-          </a:p>
+              <a:t>0.95 이상 1.25 미만</a:t>
+            </a:r>
+          </a:p>
+        </p:txBody>
+      </p:sp>
+      <p:sp>
+        <p:nvSpPr>
+          <p:cNvPr id="83" name="Rectangle 82"/>
+          <p:cNvSpPr/>
+          <p:nvPr/>
+        </p:nvSpPr>
+        <p:spPr>
+          <a:xfrm>
+            <a:off x="6309360" y="3026664"/>
+            <a:ext cx="1554480" cy="822960"/>
+          </a:xfrm>
+          <a:prstGeom prst="rect">
+            <a:avLst/>
+          </a:prstGeom>
+          <a:solidFill>
+            <a:srgbClr val="FFFFFF"/>
+          </a:solidFill>
+          <a:ln w="9525">
+            <a:solidFill>
+              <a:srgbClr val="BFBFBF"/>
+            </a:solidFill>
+          </a:ln>
+          <a:effectLst/>
+        </p:spPr>
+        <p:style>
+          <a:lnRef idx="1">
+            <a:schemeClr val="accent1"/>
+          </a:lnRef>
+          <a:fillRef idx="3">
+            <a:schemeClr val="accent1"/>
+          </a:fillRef>
+          <a:effectRef idx="2">
+            <a:schemeClr val="accent1"/>
+          </a:effectRef>
+          <a:fontRef idx="minor">
+            <a:schemeClr val="lt1"/>
+          </a:fontRef>
+        </p:style>
+        <p:txBody>
+          <a:bodyPr rtlCol="0" anchor="ctr" wrap="square" lIns="45720" rIns="45720" tIns="27432" bIns="27432"/>
+          <a:lstStyle/>
           <a:p>
             <a:pPr algn="l"/>
             <a:r>
@@ -17182,21 +17712,21 @@
                 <a:latin typeface="맑은 고딕"/>
                 <a:ea typeface="맑은 고딕"/>
               </a:rPr>
-              <a:t>)</a:t>
-            </a:r>
-          </a:p>
-        </p:txBody>
-      </p:sp>
-      <p:sp>
-        <p:nvSpPr>
-          <p:cNvPr id="75" name="Rectangle 74"/>
-          <p:cNvSpPr/>
-          <p:nvPr/>
-        </p:nvSpPr>
-        <p:spPr>
-          <a:xfrm>
-            <a:off x="5303520" y="2139696"/>
-            <a:ext cx="1920240" cy="786384"/>
+              <a:t>1.25배 이상</a:t>
+            </a:r>
+          </a:p>
+        </p:txBody>
+      </p:sp>
+      <p:sp>
+        <p:nvSpPr>
+          <p:cNvPr id="84" name="Rectangle 83"/>
+          <p:cNvSpPr/>
+          <p:nvPr/>
+        </p:nvSpPr>
+        <p:spPr>
+          <a:xfrm>
+            <a:off x="7863840" y="3026664"/>
+            <a:ext cx="2926080" cy="822960"/>
           </a:xfrm>
           <a:prstGeom prst="rect">
             <a:avLst/>
@@ -17238,7 +17768,7 @@
                 <a:latin typeface="맑은 고딕"/>
                 <a:ea typeface="맑은 고딕"/>
               </a:rPr>
-              <a:t>0.95배 이상이고 Oracle 이득의 80% </a:t>
+              <a:t>★/★★ 경계: Baseline끼리 0.984~1.016배(측정), 느슨하</a:t>
             </a:r>
           </a:p>
           <a:p>
@@ -17251,21 +17781,34 @@
                 <a:latin typeface="맑은 고딕"/>
                 <a:ea typeface="맑은 고딕"/>
               </a:rPr>
-              <a:t>미만</a:t>
-            </a:r>
-          </a:p>
-        </p:txBody>
-      </p:sp>
-      <p:sp>
-        <p:nvSpPr>
-          <p:cNvPr id="76" name="Rectangle 75"/>
-          <p:cNvSpPr/>
-          <p:nvPr/>
-        </p:nvSpPr>
-        <p:spPr>
-          <a:xfrm>
-            <a:off x="7223760" y="2139696"/>
-            <a:ext cx="1600200" cy="786384"/>
+              <a:t>게 0.95. ★★★ 경계: 1.25배 = HBM 20% 감소(평균 146.6</a:t>
+            </a:r>
+          </a:p>
+          <a:p>
+            <a:pPr algn="l"/>
+            <a:r>
+              <a:rPr sz="800" b="0">
+                <a:solidFill>
+                  <a:srgbClr val="1A1A1A"/>
+                </a:solidFill>
+                <a:latin typeface="맑은 고딕"/>
+                <a:ea typeface="맑은 고딕"/>
+              </a:rPr>
+              <a:t>GiB 중 약 29 GiB, 8K KV object 약 1.6개분, 환산)</a:t>
+            </a:r>
+          </a:p>
+        </p:txBody>
+      </p:sp>
+      <p:sp>
+        <p:nvSpPr>
+          <p:cNvPr id="85" name="Rectangle 84"/>
+          <p:cNvSpPr/>
+          <p:nvPr/>
+        </p:nvSpPr>
+        <p:spPr>
+          <a:xfrm>
+            <a:off x="10789920" y="3026664"/>
+            <a:ext cx="1097280" cy="822960"/>
           </a:xfrm>
           <a:prstGeom prst="rect">
             <a:avLst/>
@@ -17298,7 +17841,7 @@
           <a:bodyPr rtlCol="0" anchor="ctr" wrap="square" lIns="45720" rIns="45720" tIns="27432" bIns="27432"/>
           <a:lstStyle/>
           <a:p>
-            <a:pPr algn="l"/>
+            <a:pPr algn="ctr"/>
             <a:r>
               <a:rPr sz="800" b="0">
                 <a:solidFill>
@@ -17307,21 +17850,103 @@
                 <a:latin typeface="맑은 고딕"/>
                 <a:ea typeface="맑은 고딕"/>
               </a:rPr>
-              <a:t>Oracle 이득의 80% 이상</a:t>
-            </a:r>
-          </a:p>
-        </p:txBody>
-      </p:sp>
-      <p:sp>
-        <p:nvSpPr>
-          <p:cNvPr id="77" name="Rectangle 76"/>
-          <p:cNvSpPr/>
-          <p:nvPr/>
-        </p:nvSpPr>
-        <p:spPr>
-          <a:xfrm>
-            <a:off x="8823960" y="2139696"/>
-            <a:ext cx="1965960" cy="786384"/>
+              <a:t>C1 ★★ x1.03</a:t>
+            </a:r>
+          </a:p>
+          <a:p>
+            <a:pPr algn="ctr"/>
+            <a:r>
+              <a:rPr sz="800" b="0">
+                <a:solidFill>
+                  <a:srgbClr val="1A1A1A"/>
+                </a:solidFill>
+                <a:latin typeface="맑은 고딕"/>
+                <a:ea typeface="맑은 고딕"/>
+              </a:rPr>
+              <a:t>C2 ★ x0.82</a:t>
+            </a:r>
+          </a:p>
+        </p:txBody>
+      </p:sp>
+      <p:sp>
+        <p:nvSpPr>
+          <p:cNvPr id="86" name="Rectangle 85"/>
+          <p:cNvSpPr/>
+          <p:nvPr/>
+        </p:nvSpPr>
+        <p:spPr>
+          <a:xfrm>
+            <a:off x="320040" y="3877056"/>
+            <a:ext cx="777240" cy="822960"/>
+          </a:xfrm>
+          <a:prstGeom prst="rect">
+            <a:avLst/>
+          </a:prstGeom>
+          <a:solidFill>
+            <a:srgbClr val="DCE9F5"/>
+          </a:solidFill>
+          <a:ln w="9525">
+            <a:solidFill>
+              <a:srgbClr val="4D7EA8"/>
+            </a:solidFill>
+          </a:ln>
+          <a:effectLst/>
+        </p:spPr>
+        <p:style>
+          <a:lnRef idx="1">
+            <a:schemeClr val="accent1"/>
+          </a:lnRef>
+          <a:fillRef idx="3">
+            <a:schemeClr val="accent1"/>
+          </a:fillRef>
+          <a:effectRef idx="2">
+            <a:schemeClr val="accent1"/>
+          </a:effectRef>
+          <a:fontRef idx="minor">
+            <a:schemeClr val="lt1"/>
+          </a:fontRef>
+        </p:style>
+        <p:txBody>
+          <a:bodyPr rtlCol="0" anchor="ctr" wrap="square" lIns="45720" rIns="45720" tIns="27432" bIns="27432"/>
+          <a:lstStyle/>
+          <a:p>
+            <a:pPr algn="ctr"/>
+            <a:r>
+              <a:rPr sz="800" b="1">
+                <a:solidFill>
+                  <a:srgbClr val="1A1A1A"/>
+                </a:solidFill>
+                <a:latin typeface="맑은 고딕"/>
+                <a:ea typeface="맑은 고딕"/>
+              </a:rPr>
+              <a:t>QA4</a:t>
+            </a:r>
+          </a:p>
+          <a:p>
+            <a:pPr algn="ctr"/>
+            <a:r>
+              <a:rPr sz="800" b="1">
+                <a:solidFill>
+                  <a:srgbClr val="1A1A1A"/>
+                </a:solidFill>
+                <a:latin typeface="맑은 고딕"/>
+                <a:ea typeface="맑은 고딕"/>
+              </a:rPr>
+              <a:t>변경 비용</a:t>
+            </a:r>
+          </a:p>
+        </p:txBody>
+      </p:sp>
+      <p:sp>
+        <p:nvSpPr>
+          <p:cNvPr id="87" name="Rectangle 86"/>
+          <p:cNvSpPr/>
+          <p:nvPr/>
+        </p:nvSpPr>
+        <p:spPr>
+          <a:xfrm>
+            <a:off x="1097280" y="3877056"/>
+            <a:ext cx="2240280" cy="822960"/>
           </a:xfrm>
           <a:prstGeom prst="rect">
             <a:avLst/>
@@ -17363,7 +17988,7 @@
                 <a:latin typeface="맑은 고딕"/>
                 <a:ea typeface="맑은 고딕"/>
               </a:rPr>
-              <a:t>Baseline끼리 0.973~1.028배(측정), 약</a:t>
+              <a:t>변경 module 수 · 개발 공수(man-month) · 에</a:t>
             </a:r>
           </a:p>
           <a:p>
@@ -17376,9 +18001,52 @@
                 <a:latin typeface="맑은 고딕"/>
                 <a:ea typeface="맑은 고딕"/>
               </a:rPr>
-              <a:t>간 느슨하게 0.95. ★★★은 QA1과 같</a:t>
-            </a:r>
-          </a:p>
+              <a:t>이전트 비용($) 3개 sub-star의 중앙값</a:t>
+            </a:r>
+          </a:p>
+        </p:txBody>
+      </p:sp>
+      <p:sp>
+        <p:nvSpPr>
+          <p:cNvPr id="88" name="Rectangle 87"/>
+          <p:cNvSpPr/>
+          <p:nvPr/>
+        </p:nvSpPr>
+        <p:spPr>
+          <a:xfrm>
+            <a:off x="3337560" y="3877056"/>
+            <a:ext cx="1417320" cy="822960"/>
+          </a:xfrm>
+          <a:prstGeom prst="rect">
+            <a:avLst/>
+          </a:prstGeom>
+          <a:solidFill>
+            <a:srgbClr val="FFFFFF"/>
+          </a:solidFill>
+          <a:ln w="9525">
+            <a:solidFill>
+              <a:srgbClr val="BFBFBF"/>
+            </a:solidFill>
+          </a:ln>
+          <a:effectLst/>
+        </p:spPr>
+        <p:style>
+          <a:lnRef idx="1">
+            <a:schemeClr val="accent1"/>
+          </a:lnRef>
+          <a:fillRef idx="3">
+            <a:schemeClr val="accent1"/>
+          </a:fillRef>
+          <a:effectRef idx="2">
+            <a:schemeClr val="accent1"/>
+          </a:effectRef>
+          <a:fontRef idx="minor">
+            <a:schemeClr val="lt1"/>
+          </a:fontRef>
+        </p:style>
+        <p:txBody>
+          <a:bodyPr rtlCol="0" anchor="ctr" wrap="square" lIns="45720" rIns="45720" tIns="27432" bIns="27432"/>
+          <a:lstStyle/>
           <a:p>
             <a:pPr algn="l"/>
             <a:r>
@@ -17389,21 +18057,34 @@
                 <a:latin typeface="맑은 고딕"/>
                 <a:ea typeface="맑은 고딕"/>
               </a:rPr>
-              <a:t>은 80%</a:t>
-            </a:r>
-          </a:p>
-        </p:txBody>
-      </p:sp>
-      <p:sp>
-        <p:nvSpPr>
-          <p:cNvPr id="78" name="Rectangle 77"/>
-          <p:cNvSpPr/>
-          <p:nvPr/>
-        </p:nvSpPr>
-        <p:spPr>
-          <a:xfrm>
-            <a:off x="10789920" y="2139696"/>
-            <a:ext cx="1097280" cy="786384"/>
+              <a:t>module 6개 이상 · 공수 1.0</a:t>
+            </a:r>
+          </a:p>
+          <a:p>
+            <a:pPr algn="l"/>
+            <a:r>
+              <a:rPr sz="800" b="0">
+                <a:solidFill>
+                  <a:srgbClr val="1A1A1A"/>
+                </a:solidFill>
+                <a:latin typeface="맑은 고딕"/>
+                <a:ea typeface="맑은 고딕"/>
+              </a:rPr>
+              <a:t>초과 · $10 초과</a:t>
+            </a:r>
+          </a:p>
+        </p:txBody>
+      </p:sp>
+      <p:sp>
+        <p:nvSpPr>
+          <p:cNvPr id="89" name="Rectangle 88"/>
+          <p:cNvSpPr/>
+          <p:nvPr/>
+        </p:nvSpPr>
+        <p:spPr>
+          <a:xfrm>
+            <a:off x="4754880" y="3877056"/>
+            <a:ext cx="1554480" cy="822960"/>
           </a:xfrm>
           <a:prstGeom prst="rect">
             <a:avLst/>
@@ -17436,6 +18117,213 @@
           <a:bodyPr rtlCol="0" anchor="ctr" wrap="square" lIns="45720" rIns="45720" tIns="27432" bIns="27432"/>
           <a:lstStyle/>
           <a:p>
+            <a:pPr algn="l"/>
+            <a:r>
+              <a:rPr sz="800" b="0">
+                <a:solidFill>
+                  <a:srgbClr val="1A1A1A"/>
+                </a:solidFill>
+                <a:latin typeface="맑은 고딕"/>
+                <a:ea typeface="맑은 고딕"/>
+              </a:rPr>
+              <a:t>module 3~5개 · 공수 1.0 이하</a:t>
+            </a:r>
+          </a:p>
+          <a:p>
+            <a:pPr algn="l"/>
+            <a:r>
+              <a:rPr sz="800" b="0">
+                <a:solidFill>
+                  <a:srgbClr val="1A1A1A"/>
+                </a:solidFill>
+                <a:latin typeface="맑은 고딕"/>
+                <a:ea typeface="맑은 고딕"/>
+              </a:rPr>
+              <a:t>· $10 이하</a:t>
+            </a:r>
+          </a:p>
+        </p:txBody>
+      </p:sp>
+      <p:sp>
+        <p:nvSpPr>
+          <p:cNvPr id="90" name="Rectangle 89"/>
+          <p:cNvSpPr/>
+          <p:nvPr/>
+        </p:nvSpPr>
+        <p:spPr>
+          <a:xfrm>
+            <a:off x="6309360" y="3877056"/>
+            <a:ext cx="1554480" cy="822960"/>
+          </a:xfrm>
+          <a:prstGeom prst="rect">
+            <a:avLst/>
+          </a:prstGeom>
+          <a:solidFill>
+            <a:srgbClr val="FFFFFF"/>
+          </a:solidFill>
+          <a:ln w="9525">
+            <a:solidFill>
+              <a:srgbClr val="BFBFBF"/>
+            </a:solidFill>
+          </a:ln>
+          <a:effectLst/>
+        </p:spPr>
+        <p:style>
+          <a:lnRef idx="1">
+            <a:schemeClr val="accent1"/>
+          </a:lnRef>
+          <a:fillRef idx="3">
+            <a:schemeClr val="accent1"/>
+          </a:fillRef>
+          <a:effectRef idx="2">
+            <a:schemeClr val="accent1"/>
+          </a:effectRef>
+          <a:fontRef idx="minor">
+            <a:schemeClr val="lt1"/>
+          </a:fontRef>
+        </p:style>
+        <p:txBody>
+          <a:bodyPr rtlCol="0" anchor="ctr" wrap="square" lIns="45720" rIns="45720" tIns="27432" bIns="27432"/>
+          <a:lstStyle/>
+          <a:p>
+            <a:pPr algn="l"/>
+            <a:r>
+              <a:rPr sz="800" b="0">
+                <a:solidFill>
+                  <a:srgbClr val="1A1A1A"/>
+                </a:solidFill>
+                <a:latin typeface="맑은 고딕"/>
+                <a:ea typeface="맑은 고딕"/>
+              </a:rPr>
+              <a:t>module 2개 이하 · 공수 0.5 이</a:t>
+            </a:r>
+          </a:p>
+          <a:p>
+            <a:pPr algn="l"/>
+            <a:r>
+              <a:rPr sz="800" b="0">
+                <a:solidFill>
+                  <a:srgbClr val="1A1A1A"/>
+                </a:solidFill>
+                <a:latin typeface="맑은 고딕"/>
+                <a:ea typeface="맑은 고딕"/>
+              </a:rPr>
+              <a:t>하 · $3 이하</a:t>
+            </a:r>
+          </a:p>
+        </p:txBody>
+      </p:sp>
+      <p:sp>
+        <p:nvSpPr>
+          <p:cNvPr id="91" name="Rectangle 90"/>
+          <p:cNvSpPr/>
+          <p:nvPr/>
+        </p:nvSpPr>
+        <p:spPr>
+          <a:xfrm>
+            <a:off x="7863840" y="3877056"/>
+            <a:ext cx="2926080" cy="822960"/>
+          </a:xfrm>
+          <a:prstGeom prst="rect">
+            <a:avLst/>
+          </a:prstGeom>
+          <a:solidFill>
+            <a:srgbClr val="FFFFFF"/>
+          </a:solidFill>
+          <a:ln w="9525">
+            <a:solidFill>
+              <a:srgbClr val="BFBFBF"/>
+            </a:solidFill>
+          </a:ln>
+          <a:effectLst/>
+        </p:spPr>
+        <p:style>
+          <a:lnRef idx="1">
+            <a:schemeClr val="accent1"/>
+          </a:lnRef>
+          <a:fillRef idx="3">
+            <a:schemeClr val="accent1"/>
+          </a:fillRef>
+          <a:effectRef idx="2">
+            <a:schemeClr val="accent1"/>
+          </a:effectRef>
+          <a:fontRef idx="minor">
+            <a:schemeClr val="lt1"/>
+          </a:fontRef>
+        </p:style>
+        <p:txBody>
+          <a:bodyPr rtlCol="0" anchor="ctr" wrap="square" lIns="45720" rIns="45720" tIns="27432" bIns="27432"/>
+          <a:lstStyle/>
+          <a:p>
+            <a:pPr algn="l"/>
+            <a:r>
+              <a:rPr sz="800" b="0">
+                <a:solidFill>
+                  <a:srgbClr val="1A1A1A"/>
+                </a:solidFill>
+                <a:latin typeface="맑은 고딕"/>
+                <a:ea typeface="맑은 고딕"/>
+              </a:rPr>
+              <a:t>module 수 경계는 공통 룰 문서. 공수와 $ 경계는 사전 등록</a:t>
+            </a:r>
+          </a:p>
+          <a:p>
+            <a:pPr algn="l"/>
+            <a:r>
+              <a:rPr sz="800" b="0">
+                <a:solidFill>
+                  <a:srgbClr val="1A1A1A"/>
+                </a:solidFill>
+                <a:latin typeface="맑은 고딕"/>
+                <a:ea typeface="맑은 고딕"/>
+              </a:rPr>
+              <a:t>한 가정값(ASSUMED)</a:t>
+            </a:r>
+          </a:p>
+        </p:txBody>
+      </p:sp>
+      <p:sp>
+        <p:nvSpPr>
+          <p:cNvPr id="92" name="Rectangle 91"/>
+          <p:cNvSpPr/>
+          <p:nvPr/>
+        </p:nvSpPr>
+        <p:spPr>
+          <a:xfrm>
+            <a:off x="10789920" y="3877056"/>
+            <a:ext cx="1097280" cy="822960"/>
+          </a:xfrm>
+          <a:prstGeom prst="rect">
+            <a:avLst/>
+          </a:prstGeom>
+          <a:solidFill>
+            <a:srgbClr val="FFFFFF"/>
+          </a:solidFill>
+          <a:ln w="9525">
+            <a:solidFill>
+              <a:srgbClr val="BFBFBF"/>
+            </a:solidFill>
+          </a:ln>
+          <a:effectLst/>
+        </p:spPr>
+        <p:style>
+          <a:lnRef idx="1">
+            <a:schemeClr val="accent1"/>
+          </a:lnRef>
+          <a:fillRef idx="3">
+            <a:schemeClr val="accent1"/>
+          </a:fillRef>
+          <a:effectRef idx="2">
+            <a:schemeClr val="accent1"/>
+          </a:effectRef>
+          <a:fontRef idx="minor">
+            <a:schemeClr val="lt1"/>
+          </a:fontRef>
+        </p:style>
+        <p:txBody>
+          <a:bodyPr rtlCol="0" anchor="ctr" wrap="square" lIns="45720" rIns="45720" tIns="27432" bIns="27432"/>
+          <a:lstStyle/>
+          <a:p>
             <a:pPr algn="ctr"/>
             <a:r>
               <a:rPr sz="800" b="0">
@@ -17445,7 +18333,7 @@
                 <a:latin typeface="맑은 고딕"/>
                 <a:ea typeface="맑은 고딕"/>
               </a:rPr>
-              <a:t>C1 ★★ 23%</a:t>
+              <a:t>C1 ★★★</a:t>
             </a:r>
           </a:p>
           <a:p>
@@ -17458,31 +18346,31 @@
                 <a:latin typeface="맑은 고딕"/>
                 <a:ea typeface="맑은 고딕"/>
               </a:rPr>
-              <a:t>C2 ★★ 42%</a:t>
-            </a:r>
-          </a:p>
-        </p:txBody>
-      </p:sp>
-      <p:sp>
-        <p:nvSpPr>
-          <p:cNvPr id="79" name="Rectangle 78"/>
-          <p:cNvSpPr/>
-          <p:nvPr/>
-        </p:nvSpPr>
-        <p:spPr>
-          <a:xfrm>
-            <a:off x="320040" y="2953512"/>
-            <a:ext cx="777240" cy="786384"/>
-          </a:xfrm>
-          <a:prstGeom prst="rect">
-            <a:avLst/>
-          </a:prstGeom>
-          <a:solidFill>
-            <a:srgbClr val="DCE9F5"/>
+              <a:t>C2 ★★</a:t>
+            </a:r>
+          </a:p>
+        </p:txBody>
+      </p:sp>
+      <p:sp>
+        <p:nvSpPr>
+          <p:cNvPr id="93" name="Rectangle 92"/>
+          <p:cNvSpPr/>
+          <p:nvPr/>
+        </p:nvSpPr>
+        <p:spPr>
+          <a:xfrm>
+            <a:off x="320040" y="4773168"/>
+            <a:ext cx="5669280" cy="1828800"/>
+          </a:xfrm>
+          <a:prstGeom prst="rect">
+            <a:avLst/>
+          </a:prstGeom>
+          <a:solidFill>
+            <a:srgbClr val="E3F1E3"/>
           </a:solidFill>
           <a:ln w="9525">
             <a:solidFill>
-              <a:srgbClr val="4D7EA8"/>
+              <a:srgbClr val="5B9B5B"/>
             </a:solidFill>
           </a:ln>
           <a:effectLst/>
@@ -17502,52 +18390,117 @@
           </a:fontRef>
         </p:style>
         <p:txBody>
-          <a:bodyPr rtlCol="0" anchor="ctr" wrap="square" lIns="45720" rIns="45720" tIns="27432" bIns="27432"/>
-          <a:lstStyle/>
-          <a:p>
-            <a:pPr algn="ctr"/>
-            <a:r>
-              <a:rPr sz="800" b="1">
-                <a:solidFill>
-                  <a:srgbClr val="1A1A1A"/>
-                </a:solidFill>
-                <a:latin typeface="맑은 고딕"/>
-                <a:ea typeface="맑은 고딕"/>
-              </a:rPr>
-              <a:t>QA3</a:t>
-            </a:r>
-          </a:p>
-          <a:p>
-            <a:pPr algn="ctr"/>
-            <a:r>
-              <a:rPr sz="800" b="1">
-                <a:solidFill>
-                  <a:srgbClr val="1A1A1A"/>
-                </a:solidFill>
-                <a:latin typeface="맑은 고딕"/>
-                <a:ea typeface="맑은 고딕"/>
-              </a:rPr>
-              <a:t>HBM 사용</a:t>
-            </a:r>
-          </a:p>
-        </p:txBody>
-      </p:sp>
-      <p:sp>
-        <p:nvSpPr>
-          <p:cNvPr id="80" name="Rectangle 79"/>
-          <p:cNvSpPr/>
-          <p:nvPr/>
-        </p:nvSpPr>
-        <p:spPr>
-          <a:xfrm>
-            <a:off x="1097280" y="2953512"/>
-            <a:ext cx="2514600" cy="786384"/>
-          </a:xfrm>
-          <a:prstGeom prst="rect">
-            <a:avLst/>
-          </a:prstGeom>
-          <a:solidFill>
-            <a:srgbClr val="FFFFFF"/>
+          <a:bodyPr rtlCol="0" anchor="t" wrap="square" lIns="45720" rIns="45720" tIns="27432" bIns="27432"/>
+          <a:lstStyle/>
+          <a:p>
+            <a:pPr algn="l"/>
+            <a:r>
+              <a:rPr sz="850" b="1">
+                <a:solidFill>
+                  <a:srgbClr val="1A1A1A"/>
+                </a:solidFill>
+                <a:latin typeface="맑은 고딕"/>
+                <a:ea typeface="맑은 고딕"/>
+              </a:rPr>
+              <a:t>부가 설명: 근거의 강도</a:t>
+            </a:r>
+          </a:p>
+          <a:p>
+            <a:pPr algn="l"/>
+            <a:r>
+              <a:rPr sz="850" b="0">
+                <a:solidFill>
+                  <a:srgbClr val="1A1A1A"/>
+                </a:solidFill>
+                <a:latin typeface="맑은 고딕"/>
+                <a:ea typeface="맑은 고딕"/>
+              </a:rPr>
+              <a:t>- ★/★★ 하한은 측정: Baseline을 seed 묶음 5개로 돌려 서로 비교한 20회의 집계 범위(효과가 없을 때의 잡음).</a:t>
+            </a:r>
+          </a:p>
+          <a:p>
+            <a:pPr algn="l"/>
+            <a:r>
+              <a:rPr sz="850" b="0">
+                <a:solidFill>
+                  <a:srgbClr val="1A1A1A"/>
+                </a:solidFill>
+                <a:latin typeface="맑은 고딕"/>
+                <a:ea typeface="맑은 고딕"/>
+              </a:rPr>
+              <a:t>- ★★★ 상한은 측정할 수 없다. 환산(GPU 수, ms, GiB)으로 의미만 붙인 정책 선택이고, 특히 QA1의 1.30은 결과를 </a:t>
+            </a:r>
+          </a:p>
+          <a:p>
+            <a:pPr algn="l"/>
+            <a:r>
+              <a:rPr sz="850" b="0">
+                <a:solidFill>
+                  <a:srgbClr val="1A1A1A"/>
+                </a:solidFill>
+                <a:latin typeface="맑은 고딕"/>
+                <a:ea typeface="맑은 고딕"/>
+              </a:rPr>
+              <a:t>본 뒤 정했다.</a:t>
+            </a:r>
+          </a:p>
+          <a:p>
+            <a:pPr algn="l"/>
+            <a:r>
+              <a:rPr sz="850" b="0">
+                <a:solidFill>
+                  <a:srgbClr val="1A1A1A"/>
+                </a:solidFill>
+                <a:latin typeface="맑은 고딕"/>
+                <a:ea typeface="맑은 고딕"/>
+              </a:rPr>
+              <a:t>- 상한을 QA1/2/3에 같게 적용하면 선택이 바뀐다: 상한 1.25 이하 또는 1.45 이상이면 C1, 1.30~1.40이면 동점이</a:t>
+            </a:r>
+          </a:p>
+          <a:p>
+            <a:pPr algn="l"/>
+            <a:r>
+              <a:rPr sz="850" b="0">
+                <a:solidFill>
+                  <a:srgbClr val="1A1A1A"/>
+                </a:solidFill>
+                <a:latin typeface="맑은 고딕"/>
+                <a:ea typeface="맑은 고딕"/>
+              </a:rPr>
+              <a:t>라 QA1 우선순위로 C2. 현재 경계는 C1의 QA1(x1.298)과 0.2% 차이다.</a:t>
+            </a:r>
+          </a:p>
+          <a:p>
+            <a:pPr algn="l"/>
+            <a:r>
+              <a:rPr sz="850" b="0">
+                <a:solidFill>
+                  <a:srgbClr val="1A1A1A"/>
+                </a:solidFill>
+                <a:latin typeface="맑은 고딕"/>
+                <a:ea typeface="맑은 고딕"/>
+              </a:rPr>
+              <a:t>- 위 기준은 5개 시스템 구성이 아닌 H100+B200 통합 21쌍 기준이며 Evidence는 [B+C].</a:t>
+            </a:r>
+          </a:p>
+        </p:txBody>
+      </p:sp>
+      <p:sp>
+        <p:nvSpPr>
+          <p:cNvPr id="94" name="Rectangle 93"/>
+          <p:cNvSpPr/>
+          <p:nvPr/>
+        </p:nvSpPr>
+        <p:spPr>
+          <a:xfrm>
+            <a:off x="6172200" y="4773168"/>
+            <a:ext cx="5715000" cy="1828800"/>
+          </a:xfrm>
+          <a:prstGeom prst="rect">
+            <a:avLst/>
+          </a:prstGeom>
+          <a:solidFill>
+            <a:srgbClr val="F2F2F2"/>
           </a:solidFill>
           <a:ln w="9525">
             <a:solidFill>
@@ -17571,916 +18524,6 @@
           </a:fontRef>
         </p:style>
         <p:txBody>
-          <a:bodyPr rtlCol="0" anchor="ctr" wrap="square" lIns="45720" rIns="45720" tIns="27432" bIns="27432"/>
-          <a:lstStyle/>
-          <a:p>
-            <a:pPr algn="l"/>
-            <a:r>
-              <a:rPr sz="800" b="0">
-                <a:solidFill>
-                  <a:srgbClr val="1A1A1A"/>
-                </a:solidFill>
-                <a:latin typeface="맑은 고딕"/>
-                <a:ea typeface="맑은 고딕"/>
-              </a:rPr>
-              <a:t>HBM 절감 배수(Baseline GiB÷후보 GiB)</a:t>
-            </a:r>
-          </a:p>
-          <a:p>
-            <a:pPr algn="l"/>
-            <a:r>
-              <a:rPr sz="800" b="0">
-                <a:solidFill>
-                  <a:srgbClr val="1A1A1A"/>
-                </a:solidFill>
-                <a:latin typeface="맑은 고딕"/>
-                <a:ea typeface="맑은 고딕"/>
-              </a:rPr>
-              <a:t>Oracle-lean: 틱마다 접근된 객체만 HBM에 두는 정</a:t>
-            </a:r>
-          </a:p>
-          <a:p>
-            <a:pPr algn="l"/>
-            <a:r>
-              <a:rPr sz="800" b="0">
-                <a:solidFill>
-                  <a:srgbClr val="1A1A1A"/>
-                </a:solidFill>
-                <a:latin typeface="맑은 고딕"/>
-                <a:ea typeface="맑은 고딕"/>
-              </a:rPr>
-              <a:t>책</a:t>
-            </a:r>
-          </a:p>
-        </p:txBody>
-      </p:sp>
-      <p:sp>
-        <p:nvSpPr>
-          <p:cNvPr id="81" name="Rectangle 80"/>
-          <p:cNvSpPr/>
-          <p:nvPr/>
-        </p:nvSpPr>
-        <p:spPr>
-          <a:xfrm>
-            <a:off x="3611880" y="2953512"/>
-            <a:ext cx="1691640" cy="786384"/>
-          </a:xfrm>
-          <a:prstGeom prst="rect">
-            <a:avLst/>
-          </a:prstGeom>
-          <a:solidFill>
-            <a:srgbClr val="FFFFFF"/>
-          </a:solidFill>
-          <a:ln w="9525">
-            <a:solidFill>
-              <a:srgbClr val="BFBFBF"/>
-            </a:solidFill>
-          </a:ln>
-          <a:effectLst/>
-        </p:spPr>
-        <p:style>
-          <a:lnRef idx="1">
-            <a:schemeClr val="accent1"/>
-          </a:lnRef>
-          <a:fillRef idx="3">
-            <a:schemeClr val="accent1"/>
-          </a:fillRef>
-          <a:effectRef idx="2">
-            <a:schemeClr val="accent1"/>
-          </a:effectRef>
-          <a:fontRef idx="minor">
-            <a:schemeClr val="lt1"/>
-          </a:fontRef>
-        </p:style>
-        <p:txBody>
-          <a:bodyPr rtlCol="0" anchor="ctr" wrap="square" lIns="45720" rIns="45720" tIns="27432" bIns="27432"/>
-          <a:lstStyle/>
-          <a:p>
-            <a:pPr algn="l"/>
-            <a:r>
-              <a:rPr sz="800" b="0">
-                <a:solidFill>
-                  <a:srgbClr val="1A1A1A"/>
-                </a:solidFill>
-                <a:latin typeface="맑은 고딕"/>
-                <a:ea typeface="맑은 고딕"/>
-              </a:rPr>
-              <a:t>0.95배 미만 (HBM을 5%+ 더 씀)</a:t>
-            </a:r>
-          </a:p>
-        </p:txBody>
-      </p:sp>
-      <p:sp>
-        <p:nvSpPr>
-          <p:cNvPr id="82" name="Rectangle 81"/>
-          <p:cNvSpPr/>
-          <p:nvPr/>
-        </p:nvSpPr>
-        <p:spPr>
-          <a:xfrm>
-            <a:off x="5303520" y="2953512"/>
-            <a:ext cx="1920240" cy="786384"/>
-          </a:xfrm>
-          <a:prstGeom prst="rect">
-            <a:avLst/>
-          </a:prstGeom>
-          <a:solidFill>
-            <a:srgbClr val="FFFFFF"/>
-          </a:solidFill>
-          <a:ln w="9525">
-            <a:solidFill>
-              <a:srgbClr val="BFBFBF"/>
-            </a:solidFill>
-          </a:ln>
-          <a:effectLst/>
-        </p:spPr>
-        <p:style>
-          <a:lnRef idx="1">
-            <a:schemeClr val="accent1"/>
-          </a:lnRef>
-          <a:fillRef idx="3">
-            <a:schemeClr val="accent1"/>
-          </a:fillRef>
-          <a:effectRef idx="2">
-            <a:schemeClr val="accent1"/>
-          </a:effectRef>
-          <a:fontRef idx="minor">
-            <a:schemeClr val="lt1"/>
-          </a:fontRef>
-        </p:style>
-        <p:txBody>
-          <a:bodyPr rtlCol="0" anchor="ctr" wrap="square" lIns="45720" rIns="45720" tIns="27432" bIns="27432"/>
-          <a:lstStyle/>
-          <a:p>
-            <a:pPr algn="l"/>
-            <a:r>
-              <a:rPr sz="800" b="0">
-                <a:solidFill>
-                  <a:srgbClr val="1A1A1A"/>
-                </a:solidFill>
-                <a:latin typeface="맑은 고딕"/>
-                <a:ea typeface="맑은 고딕"/>
-              </a:rPr>
-              <a:t>0.95배 이상이고 Oracle 절감의 80% </a:t>
-            </a:r>
-          </a:p>
-          <a:p>
-            <a:pPr algn="l"/>
-            <a:r>
-              <a:rPr sz="800" b="0">
-                <a:solidFill>
-                  <a:srgbClr val="1A1A1A"/>
-                </a:solidFill>
-                <a:latin typeface="맑은 고딕"/>
-                <a:ea typeface="맑은 고딕"/>
-              </a:rPr>
-              <a:t>미만</a:t>
-            </a:r>
-          </a:p>
-        </p:txBody>
-      </p:sp>
-      <p:sp>
-        <p:nvSpPr>
-          <p:cNvPr id="83" name="Rectangle 82"/>
-          <p:cNvSpPr/>
-          <p:nvPr/>
-        </p:nvSpPr>
-        <p:spPr>
-          <a:xfrm>
-            <a:off x="7223760" y="2953512"/>
-            <a:ext cx="1600200" cy="786384"/>
-          </a:xfrm>
-          <a:prstGeom prst="rect">
-            <a:avLst/>
-          </a:prstGeom>
-          <a:solidFill>
-            <a:srgbClr val="FFFFFF"/>
-          </a:solidFill>
-          <a:ln w="9525">
-            <a:solidFill>
-              <a:srgbClr val="BFBFBF"/>
-            </a:solidFill>
-          </a:ln>
-          <a:effectLst/>
-        </p:spPr>
-        <p:style>
-          <a:lnRef idx="1">
-            <a:schemeClr val="accent1"/>
-          </a:lnRef>
-          <a:fillRef idx="3">
-            <a:schemeClr val="accent1"/>
-          </a:fillRef>
-          <a:effectRef idx="2">
-            <a:schemeClr val="accent1"/>
-          </a:effectRef>
-          <a:fontRef idx="minor">
-            <a:schemeClr val="lt1"/>
-          </a:fontRef>
-        </p:style>
-        <p:txBody>
-          <a:bodyPr rtlCol="0" anchor="ctr" wrap="square" lIns="45720" rIns="45720" tIns="27432" bIns="27432"/>
-          <a:lstStyle/>
-          <a:p>
-            <a:pPr algn="l"/>
-            <a:r>
-              <a:rPr sz="800" b="0">
-                <a:solidFill>
-                  <a:srgbClr val="1A1A1A"/>
-                </a:solidFill>
-                <a:latin typeface="맑은 고딕"/>
-                <a:ea typeface="맑은 고딕"/>
-              </a:rPr>
-              <a:t>Oracle 절감의 80% 이상</a:t>
-            </a:r>
-          </a:p>
-        </p:txBody>
-      </p:sp>
-      <p:sp>
-        <p:nvSpPr>
-          <p:cNvPr id="84" name="Rectangle 83"/>
-          <p:cNvSpPr/>
-          <p:nvPr/>
-        </p:nvSpPr>
-        <p:spPr>
-          <a:xfrm>
-            <a:off x="8823960" y="2953512"/>
-            <a:ext cx="1965960" cy="786384"/>
-          </a:xfrm>
-          <a:prstGeom prst="rect">
-            <a:avLst/>
-          </a:prstGeom>
-          <a:solidFill>
-            <a:srgbClr val="FFFFFF"/>
-          </a:solidFill>
-          <a:ln w="9525">
-            <a:solidFill>
-              <a:srgbClr val="BFBFBF"/>
-            </a:solidFill>
-          </a:ln>
-          <a:effectLst/>
-        </p:spPr>
-        <p:style>
-          <a:lnRef idx="1">
-            <a:schemeClr val="accent1"/>
-          </a:lnRef>
-          <a:fillRef idx="3">
-            <a:schemeClr val="accent1"/>
-          </a:fillRef>
-          <a:effectRef idx="2">
-            <a:schemeClr val="accent1"/>
-          </a:effectRef>
-          <a:fontRef idx="minor">
-            <a:schemeClr val="lt1"/>
-          </a:fontRef>
-        </p:style>
-        <p:txBody>
-          <a:bodyPr rtlCol="0" anchor="ctr" wrap="square" lIns="45720" rIns="45720" tIns="27432" bIns="27432"/>
-          <a:lstStyle/>
-          <a:p>
-            <a:pPr algn="l"/>
-            <a:r>
-              <a:rPr sz="800" b="0">
-                <a:solidFill>
-                  <a:srgbClr val="1A1A1A"/>
-                </a:solidFill>
-                <a:latin typeface="맑은 고딕"/>
-                <a:ea typeface="맑은 고딕"/>
-              </a:rPr>
-              <a:t>Baseline끼리 0.984~1.016배(측정), 느</a:t>
-            </a:r>
-          </a:p>
-          <a:p>
-            <a:pPr algn="l"/>
-            <a:r>
-              <a:rPr sz="800" b="0">
-                <a:solidFill>
-                  <a:srgbClr val="1A1A1A"/>
-                </a:solidFill>
-                <a:latin typeface="맑은 고딕"/>
-                <a:ea typeface="맑은 고딕"/>
-              </a:rPr>
-              <a:t>슨하게 0.95. ★★★은 QA1과 같은 80</a:t>
-            </a:r>
-          </a:p>
-          <a:p>
-            <a:pPr algn="l"/>
-            <a:r>
-              <a:rPr sz="800" b="0">
-                <a:solidFill>
-                  <a:srgbClr val="1A1A1A"/>
-                </a:solidFill>
-                <a:latin typeface="맑은 고딕"/>
-                <a:ea typeface="맑은 고딕"/>
-              </a:rPr>
-              <a:t>%</a:t>
-            </a:r>
-          </a:p>
-        </p:txBody>
-      </p:sp>
-      <p:sp>
-        <p:nvSpPr>
-          <p:cNvPr id="85" name="Rectangle 84"/>
-          <p:cNvSpPr/>
-          <p:nvPr/>
-        </p:nvSpPr>
-        <p:spPr>
-          <a:xfrm>
-            <a:off x="10789920" y="2953512"/>
-            <a:ext cx="1097280" cy="786384"/>
-          </a:xfrm>
-          <a:prstGeom prst="rect">
-            <a:avLst/>
-          </a:prstGeom>
-          <a:solidFill>
-            <a:srgbClr val="FFFFFF"/>
-          </a:solidFill>
-          <a:ln w="9525">
-            <a:solidFill>
-              <a:srgbClr val="BFBFBF"/>
-            </a:solidFill>
-          </a:ln>
-          <a:effectLst/>
-        </p:spPr>
-        <p:style>
-          <a:lnRef idx="1">
-            <a:schemeClr val="accent1"/>
-          </a:lnRef>
-          <a:fillRef idx="3">
-            <a:schemeClr val="accent1"/>
-          </a:fillRef>
-          <a:effectRef idx="2">
-            <a:schemeClr val="accent1"/>
-          </a:effectRef>
-          <a:fontRef idx="minor">
-            <a:schemeClr val="lt1"/>
-          </a:fontRef>
-        </p:style>
-        <p:txBody>
-          <a:bodyPr rtlCol="0" anchor="ctr" wrap="square" lIns="45720" rIns="45720" tIns="27432" bIns="27432"/>
-          <a:lstStyle/>
-          <a:p>
-            <a:pPr algn="ctr"/>
-            <a:r>
-              <a:rPr sz="800" b="0">
-                <a:solidFill>
-                  <a:srgbClr val="1A1A1A"/>
-                </a:solidFill>
-                <a:latin typeface="맑은 고딕"/>
-                <a:ea typeface="맑은 고딕"/>
-              </a:rPr>
-              <a:t>C1 ★★ 3%</a:t>
-            </a:r>
-          </a:p>
-          <a:p>
-            <a:pPr algn="ctr"/>
-            <a:r>
-              <a:rPr sz="800" b="0">
-                <a:solidFill>
-                  <a:srgbClr val="1A1A1A"/>
-                </a:solidFill>
-                <a:latin typeface="맑은 고딕"/>
-                <a:ea typeface="맑은 고딕"/>
-              </a:rPr>
-              <a:t>C2 ★ -15%</a:t>
-            </a:r>
-          </a:p>
-        </p:txBody>
-      </p:sp>
-      <p:sp>
-        <p:nvSpPr>
-          <p:cNvPr id="86" name="Rectangle 85"/>
-          <p:cNvSpPr/>
-          <p:nvPr/>
-        </p:nvSpPr>
-        <p:spPr>
-          <a:xfrm>
-            <a:off x="320040" y="3767328"/>
-            <a:ext cx="777240" cy="786384"/>
-          </a:xfrm>
-          <a:prstGeom prst="rect">
-            <a:avLst/>
-          </a:prstGeom>
-          <a:solidFill>
-            <a:srgbClr val="DCE9F5"/>
-          </a:solidFill>
-          <a:ln w="9525">
-            <a:solidFill>
-              <a:srgbClr val="4D7EA8"/>
-            </a:solidFill>
-          </a:ln>
-          <a:effectLst/>
-        </p:spPr>
-        <p:style>
-          <a:lnRef idx="1">
-            <a:schemeClr val="accent1"/>
-          </a:lnRef>
-          <a:fillRef idx="3">
-            <a:schemeClr val="accent1"/>
-          </a:fillRef>
-          <a:effectRef idx="2">
-            <a:schemeClr val="accent1"/>
-          </a:effectRef>
-          <a:fontRef idx="minor">
-            <a:schemeClr val="lt1"/>
-          </a:fontRef>
-        </p:style>
-        <p:txBody>
-          <a:bodyPr rtlCol="0" anchor="ctr" wrap="square" lIns="45720" rIns="45720" tIns="27432" bIns="27432"/>
-          <a:lstStyle/>
-          <a:p>
-            <a:pPr algn="ctr"/>
-            <a:r>
-              <a:rPr sz="800" b="1">
-                <a:solidFill>
-                  <a:srgbClr val="1A1A1A"/>
-                </a:solidFill>
-                <a:latin typeface="맑은 고딕"/>
-                <a:ea typeface="맑은 고딕"/>
-              </a:rPr>
-              <a:t>QA4</a:t>
-            </a:r>
-          </a:p>
-          <a:p>
-            <a:pPr algn="ctr"/>
-            <a:r>
-              <a:rPr sz="800" b="1">
-                <a:solidFill>
-                  <a:srgbClr val="1A1A1A"/>
-                </a:solidFill>
-                <a:latin typeface="맑은 고딕"/>
-                <a:ea typeface="맑은 고딕"/>
-              </a:rPr>
-              <a:t>변경 비용 (달</a:t>
-            </a:r>
-          </a:p>
-          <a:p>
-            <a:pPr algn="ctr"/>
-            <a:r>
-              <a:rPr sz="800" b="1">
-                <a:solidFill>
-                  <a:srgbClr val="1A1A1A"/>
-                </a:solidFill>
-                <a:latin typeface="맑은 고딕"/>
-                <a:ea typeface="맑은 고딕"/>
-              </a:rPr>
-              <a:t>성률 아님)</a:t>
-            </a:r>
-          </a:p>
-        </p:txBody>
-      </p:sp>
-      <p:sp>
-        <p:nvSpPr>
-          <p:cNvPr id="87" name="Rectangle 86"/>
-          <p:cNvSpPr/>
-          <p:nvPr/>
-        </p:nvSpPr>
-        <p:spPr>
-          <a:xfrm>
-            <a:off x="1097280" y="3767328"/>
-            <a:ext cx="2514600" cy="786384"/>
-          </a:xfrm>
-          <a:prstGeom prst="rect">
-            <a:avLst/>
-          </a:prstGeom>
-          <a:solidFill>
-            <a:srgbClr val="FFFFFF"/>
-          </a:solidFill>
-          <a:ln w="9525">
-            <a:solidFill>
-              <a:srgbClr val="BFBFBF"/>
-            </a:solidFill>
-          </a:ln>
-          <a:effectLst/>
-        </p:spPr>
-        <p:style>
-          <a:lnRef idx="1">
-            <a:schemeClr val="accent1"/>
-          </a:lnRef>
-          <a:fillRef idx="3">
-            <a:schemeClr val="accent1"/>
-          </a:fillRef>
-          <a:effectRef idx="2">
-            <a:schemeClr val="accent1"/>
-          </a:effectRef>
-          <a:fontRef idx="minor">
-            <a:schemeClr val="lt1"/>
-          </a:fontRef>
-        </p:style>
-        <p:txBody>
-          <a:bodyPr rtlCol="0" anchor="ctr" wrap="square" lIns="45720" rIns="45720" tIns="27432" bIns="27432"/>
-          <a:lstStyle/>
-          <a:p>
-            <a:pPr algn="l"/>
-            <a:r>
-              <a:rPr sz="800" b="0">
-                <a:solidFill>
-                  <a:srgbClr val="1A1A1A"/>
-                </a:solidFill>
-                <a:latin typeface="맑은 고딕"/>
-                <a:ea typeface="맑은 고딕"/>
-              </a:rPr>
-              <a:t>변경 module 수 · 개발 공수(man-month) · 에이전트</a:t>
-            </a:r>
-          </a:p>
-          <a:p>
-            <a:pPr algn="l"/>
-            <a:r>
-              <a:rPr sz="800" b="0">
-                <a:solidFill>
-                  <a:srgbClr val="1A1A1A"/>
-                </a:solidFill>
-                <a:latin typeface="맑은 고딕"/>
-                <a:ea typeface="맑은 고딕"/>
-              </a:rPr>
-              <a:t>비용($) 3개의 중앙값 별</a:t>
-            </a:r>
-          </a:p>
-        </p:txBody>
-      </p:sp>
-      <p:sp>
-        <p:nvSpPr>
-          <p:cNvPr id="88" name="Rectangle 87"/>
-          <p:cNvSpPr/>
-          <p:nvPr/>
-        </p:nvSpPr>
-        <p:spPr>
-          <a:xfrm>
-            <a:off x="3611880" y="3767328"/>
-            <a:ext cx="1691640" cy="786384"/>
-          </a:xfrm>
-          <a:prstGeom prst="rect">
-            <a:avLst/>
-          </a:prstGeom>
-          <a:solidFill>
-            <a:srgbClr val="FFFFFF"/>
-          </a:solidFill>
-          <a:ln w="9525">
-            <a:solidFill>
-              <a:srgbClr val="BFBFBF"/>
-            </a:solidFill>
-          </a:ln>
-          <a:effectLst/>
-        </p:spPr>
-        <p:style>
-          <a:lnRef idx="1">
-            <a:schemeClr val="accent1"/>
-          </a:lnRef>
-          <a:fillRef idx="3">
-            <a:schemeClr val="accent1"/>
-          </a:fillRef>
-          <a:effectRef idx="2">
-            <a:schemeClr val="accent1"/>
-          </a:effectRef>
-          <a:fontRef idx="minor">
-            <a:schemeClr val="lt1"/>
-          </a:fontRef>
-        </p:style>
-        <p:txBody>
-          <a:bodyPr rtlCol="0" anchor="ctr" wrap="square" lIns="45720" rIns="45720" tIns="27432" bIns="27432"/>
-          <a:lstStyle/>
-          <a:p>
-            <a:pPr algn="l"/>
-            <a:r>
-              <a:rPr sz="800" b="0">
-                <a:solidFill>
-                  <a:srgbClr val="1A1A1A"/>
-                </a:solidFill>
-                <a:latin typeface="맑은 고딕"/>
-                <a:ea typeface="맑은 고딕"/>
-              </a:rPr>
-              <a:t>module 6개 이상, 공수 1.0 초과, </a:t>
-            </a:r>
-          </a:p>
-          <a:p>
-            <a:pPr algn="l"/>
-            <a:r>
-              <a:rPr sz="800" b="0">
-                <a:solidFill>
-                  <a:srgbClr val="1A1A1A"/>
-                </a:solidFill>
-                <a:latin typeface="맑은 고딕"/>
-                <a:ea typeface="맑은 고딕"/>
-              </a:rPr>
-              <a:t>$10 초과</a:t>
-            </a:r>
-          </a:p>
-        </p:txBody>
-      </p:sp>
-      <p:sp>
-        <p:nvSpPr>
-          <p:cNvPr id="89" name="Rectangle 88"/>
-          <p:cNvSpPr/>
-          <p:nvPr/>
-        </p:nvSpPr>
-        <p:spPr>
-          <a:xfrm>
-            <a:off x="5303520" y="3767328"/>
-            <a:ext cx="1920240" cy="786384"/>
-          </a:xfrm>
-          <a:prstGeom prst="rect">
-            <a:avLst/>
-          </a:prstGeom>
-          <a:solidFill>
-            <a:srgbClr val="FFFFFF"/>
-          </a:solidFill>
-          <a:ln w="9525">
-            <a:solidFill>
-              <a:srgbClr val="BFBFBF"/>
-            </a:solidFill>
-          </a:ln>
-          <a:effectLst/>
-        </p:spPr>
-        <p:style>
-          <a:lnRef idx="1">
-            <a:schemeClr val="accent1"/>
-          </a:lnRef>
-          <a:fillRef idx="3">
-            <a:schemeClr val="accent1"/>
-          </a:fillRef>
-          <a:effectRef idx="2">
-            <a:schemeClr val="accent1"/>
-          </a:effectRef>
-          <a:fontRef idx="minor">
-            <a:schemeClr val="lt1"/>
-          </a:fontRef>
-        </p:style>
-        <p:txBody>
-          <a:bodyPr rtlCol="0" anchor="ctr" wrap="square" lIns="45720" rIns="45720" tIns="27432" bIns="27432"/>
-          <a:lstStyle/>
-          <a:p>
-            <a:pPr algn="l"/>
-            <a:r>
-              <a:rPr sz="800" b="0">
-                <a:solidFill>
-                  <a:srgbClr val="1A1A1A"/>
-                </a:solidFill>
-                <a:latin typeface="맑은 고딕"/>
-                <a:ea typeface="맑은 고딕"/>
-              </a:rPr>
-              <a:t>module 3~5개, 공수 1.0 이하, $10 이</a:t>
-            </a:r>
-          </a:p>
-          <a:p>
-            <a:pPr algn="l"/>
-            <a:r>
-              <a:rPr sz="800" b="0">
-                <a:solidFill>
-                  <a:srgbClr val="1A1A1A"/>
-                </a:solidFill>
-                <a:latin typeface="맑은 고딕"/>
-                <a:ea typeface="맑은 고딕"/>
-              </a:rPr>
-              <a:t>하</a:t>
-            </a:r>
-          </a:p>
-        </p:txBody>
-      </p:sp>
-      <p:sp>
-        <p:nvSpPr>
-          <p:cNvPr id="90" name="Rectangle 89"/>
-          <p:cNvSpPr/>
-          <p:nvPr/>
-        </p:nvSpPr>
-        <p:spPr>
-          <a:xfrm>
-            <a:off x="7223760" y="3767328"/>
-            <a:ext cx="1600200" cy="786384"/>
-          </a:xfrm>
-          <a:prstGeom prst="rect">
-            <a:avLst/>
-          </a:prstGeom>
-          <a:solidFill>
-            <a:srgbClr val="FFFFFF"/>
-          </a:solidFill>
-          <a:ln w="9525">
-            <a:solidFill>
-              <a:srgbClr val="BFBFBF"/>
-            </a:solidFill>
-          </a:ln>
-          <a:effectLst/>
-        </p:spPr>
-        <p:style>
-          <a:lnRef idx="1">
-            <a:schemeClr val="accent1"/>
-          </a:lnRef>
-          <a:fillRef idx="3">
-            <a:schemeClr val="accent1"/>
-          </a:fillRef>
-          <a:effectRef idx="2">
-            <a:schemeClr val="accent1"/>
-          </a:effectRef>
-          <a:fontRef idx="minor">
-            <a:schemeClr val="lt1"/>
-          </a:fontRef>
-        </p:style>
-        <p:txBody>
-          <a:bodyPr rtlCol="0" anchor="ctr" wrap="square" lIns="45720" rIns="45720" tIns="27432" bIns="27432"/>
-          <a:lstStyle/>
-          <a:p>
-            <a:pPr algn="l"/>
-            <a:r>
-              <a:rPr sz="800" b="0">
-                <a:solidFill>
-                  <a:srgbClr val="1A1A1A"/>
-                </a:solidFill>
-                <a:latin typeface="맑은 고딕"/>
-                <a:ea typeface="맑은 고딕"/>
-              </a:rPr>
-              <a:t>module 2개 이하, 공수 0.5 이</a:t>
-            </a:r>
-          </a:p>
-          <a:p>
-            <a:pPr algn="l"/>
-            <a:r>
-              <a:rPr sz="800" b="0">
-                <a:solidFill>
-                  <a:srgbClr val="1A1A1A"/>
-                </a:solidFill>
-                <a:latin typeface="맑은 고딕"/>
-                <a:ea typeface="맑은 고딕"/>
-              </a:rPr>
-              <a:t>하, $3 이하</a:t>
-            </a:r>
-          </a:p>
-        </p:txBody>
-      </p:sp>
-      <p:sp>
-        <p:nvSpPr>
-          <p:cNvPr id="91" name="Rectangle 90"/>
-          <p:cNvSpPr/>
-          <p:nvPr/>
-        </p:nvSpPr>
-        <p:spPr>
-          <a:xfrm>
-            <a:off x="8823960" y="3767328"/>
-            <a:ext cx="1965960" cy="786384"/>
-          </a:xfrm>
-          <a:prstGeom prst="rect">
-            <a:avLst/>
-          </a:prstGeom>
-          <a:solidFill>
-            <a:srgbClr val="FFFFFF"/>
-          </a:solidFill>
-          <a:ln w="9525">
-            <a:solidFill>
-              <a:srgbClr val="BFBFBF"/>
-            </a:solidFill>
-          </a:ln>
-          <a:effectLst/>
-        </p:spPr>
-        <p:style>
-          <a:lnRef idx="1">
-            <a:schemeClr val="accent1"/>
-          </a:lnRef>
-          <a:fillRef idx="3">
-            <a:schemeClr val="accent1"/>
-          </a:fillRef>
-          <a:effectRef idx="2">
-            <a:schemeClr val="accent1"/>
-          </a:effectRef>
-          <a:fontRef idx="minor">
-            <a:schemeClr val="lt1"/>
-          </a:fontRef>
-        </p:style>
-        <p:txBody>
-          <a:bodyPr rtlCol="0" anchor="ctr" wrap="square" lIns="45720" rIns="45720" tIns="27432" bIns="27432"/>
-          <a:lstStyle/>
-          <a:p>
-            <a:pPr algn="l"/>
-            <a:r>
-              <a:rPr sz="800" b="0">
-                <a:solidFill>
-                  <a:srgbClr val="1A1A1A"/>
-                </a:solidFill>
-                <a:latin typeface="맑은 고딕"/>
-                <a:ea typeface="맑은 고딕"/>
-              </a:rPr>
-              <a:t>module 수 경계는 공통 룰, 공수·$는 사</a:t>
-            </a:r>
-          </a:p>
-          <a:p>
-            <a:pPr algn="l"/>
-            <a:r>
-              <a:rPr sz="800" b="0">
-                <a:solidFill>
-                  <a:srgbClr val="1A1A1A"/>
-                </a:solidFill>
-                <a:latin typeface="맑은 고딕"/>
-                <a:ea typeface="맑은 고딕"/>
-              </a:rPr>
-              <a:t>전 등록한 가정값(ASSUMED)</a:t>
-            </a:r>
-          </a:p>
-        </p:txBody>
-      </p:sp>
-      <p:sp>
-        <p:nvSpPr>
-          <p:cNvPr id="92" name="Rectangle 91"/>
-          <p:cNvSpPr/>
-          <p:nvPr/>
-        </p:nvSpPr>
-        <p:spPr>
-          <a:xfrm>
-            <a:off x="10789920" y="3767328"/>
-            <a:ext cx="1097280" cy="786384"/>
-          </a:xfrm>
-          <a:prstGeom prst="rect">
-            <a:avLst/>
-          </a:prstGeom>
-          <a:solidFill>
-            <a:srgbClr val="FFFFFF"/>
-          </a:solidFill>
-          <a:ln w="9525">
-            <a:solidFill>
-              <a:srgbClr val="BFBFBF"/>
-            </a:solidFill>
-          </a:ln>
-          <a:effectLst/>
-        </p:spPr>
-        <p:style>
-          <a:lnRef idx="1">
-            <a:schemeClr val="accent1"/>
-          </a:lnRef>
-          <a:fillRef idx="3">
-            <a:schemeClr val="accent1"/>
-          </a:fillRef>
-          <a:effectRef idx="2">
-            <a:schemeClr val="accent1"/>
-          </a:effectRef>
-          <a:fontRef idx="minor">
-            <a:schemeClr val="lt1"/>
-          </a:fontRef>
-        </p:style>
-        <p:txBody>
-          <a:bodyPr rtlCol="0" anchor="ctr" wrap="square" lIns="45720" rIns="45720" tIns="27432" bIns="27432"/>
-          <a:lstStyle/>
-          <a:p>
-            <a:pPr algn="ctr"/>
-            <a:r>
-              <a:rPr sz="800" b="0">
-                <a:solidFill>
-                  <a:srgbClr val="1A1A1A"/>
-                </a:solidFill>
-                <a:latin typeface="맑은 고딕"/>
-                <a:ea typeface="맑은 고딕"/>
-              </a:rPr>
-              <a:t>C1 ★★★</a:t>
-            </a:r>
-          </a:p>
-          <a:p>
-            <a:pPr algn="ctr"/>
-            <a:r>
-              <a:rPr sz="800" b="0">
-                <a:solidFill>
-                  <a:srgbClr val="1A1A1A"/>
-                </a:solidFill>
-                <a:latin typeface="맑은 고딕"/>
-                <a:ea typeface="맑은 고딕"/>
-              </a:rPr>
-              <a:t>C2 ★★</a:t>
-            </a:r>
-          </a:p>
-        </p:txBody>
-      </p:sp>
-      <p:sp>
-        <p:nvSpPr>
-          <p:cNvPr id="93" name="Rectangle 92"/>
-          <p:cNvSpPr/>
-          <p:nvPr/>
-        </p:nvSpPr>
-        <p:spPr>
-          <a:xfrm>
-            <a:off x="320040" y="4626864"/>
-            <a:ext cx="5669280" cy="1874519"/>
-          </a:xfrm>
-          <a:prstGeom prst="rect">
-            <a:avLst/>
-          </a:prstGeom>
-          <a:solidFill>
-            <a:srgbClr val="E3F1E3"/>
-          </a:solidFill>
-          <a:ln w="9525">
-            <a:solidFill>
-              <a:srgbClr val="5B9B5B"/>
-            </a:solidFill>
-          </a:ln>
-          <a:effectLst/>
-        </p:spPr>
-        <p:style>
-          <a:lnRef idx="1">
-            <a:schemeClr val="accent1"/>
-          </a:lnRef>
-          <a:fillRef idx="3">
-            <a:schemeClr val="accent1"/>
-          </a:fillRef>
-          <a:effectRef idx="2">
-            <a:schemeClr val="accent1"/>
-          </a:effectRef>
-          <a:fontRef idx="minor">
-            <a:schemeClr val="lt1"/>
-          </a:fontRef>
-        </p:style>
-        <p:txBody>
           <a:bodyPr rtlCol="0" anchor="t" wrap="square" lIns="45720" rIns="45720" tIns="27432" bIns="27432"/>
           <a:lstStyle/>
           <a:p>
@@ -18488,12 +18531,12 @@
             <a:r>
               <a:rPr sz="850" b="1">
                 <a:solidFill>
-                  <a:srgbClr val="1A1A1A"/>
-                </a:solidFill>
-                <a:latin typeface="맑은 고딕"/>
-                <a:ea typeface="맑은 고딕"/>
-              </a:rPr>
-              <a:t>정의와 근거</a:t>
+                  <a:srgbClr val="404040"/>
+                </a:solidFill>
+                <a:latin typeface="맑은 고딕"/>
+                <a:ea typeface="맑은 고딕"/>
+              </a:rPr>
+              <a:t>부가 설명: 문헌 자료와 Oracle 달성률 (참고, 공식 별 아님)</a:t>
             </a:r>
           </a:p>
           <a:p>
@@ -18501,12 +18544,12 @@
             <a:r>
               <a:rPr sz="850" b="0">
                 <a:solidFill>
-                  <a:srgbClr val="1A1A1A"/>
-                </a:solidFill>
-                <a:latin typeface="맑은 고딕"/>
-                <a:ea typeface="맑은 고딕"/>
-              </a:rPr>
-              <a:t>- Oracle 달성률 = 후보가 낸 이득 / Oracle이 낼 수 있는 이득 (로그 비율의 합으로 집계, 개선 여지가 잡음 이하인 쌍 </a:t>
+                  <a:srgbClr val="404040"/>
+                </a:solidFill>
+                <a:latin typeface="맑은 고딕"/>
+                <a:ea typeface="맑은 고딕"/>
+              </a:rPr>
+              <a:t>- Oracle(미래 접근률을 알고 이동 비용이 0인 상한) 이득 중 얻은 비율: QA1 C1 62% / C2 83%, QA2 C1 23% / C2 42</a:t>
             </a:r>
           </a:p>
           <a:p>
@@ -18514,12 +18557,12 @@
             <a:r>
               <a:rPr sz="850" b="0">
                 <a:solidFill>
-                  <a:srgbClr val="1A1A1A"/>
-                </a:solidFill>
-                <a:latin typeface="맑은 고딕"/>
-                <a:ea typeface="맑은 고딕"/>
-              </a:rPr>
-              <a:t>제외). Oracle은 모두 증명된 최적이 아닌 근사 상한.</a:t>
+                  <a:srgbClr val="404040"/>
+                </a:solidFill>
+                <a:latin typeface="맑은 고딕"/>
+                <a:ea typeface="맑은 고딕"/>
+              </a:rPr>
+              <a:t>%, QA3 C1 3% / C2 -15%.</a:t>
             </a:r>
           </a:p>
           <a:p>
@@ -18527,12 +18570,12 @@
             <a:r>
               <a:rPr sz="850" b="0">
                 <a:solidFill>
-                  <a:srgbClr val="1A1A1A"/>
-                </a:solidFill>
-                <a:latin typeface="맑은 고딕"/>
-                <a:ea typeface="맑은 고딕"/>
-              </a:rPr>
-              <a:t>- ★/★★ 하한(측정): Baseline을 seed 묶음 5개로 돌려 서로 비교한 20회의 집계 범위.</a:t>
+                  <a:srgbClr val="404040"/>
+                </a:solidFill>
+                <a:latin typeface="맑은 고딕"/>
+                <a:ea typeface="맑은 고딕"/>
+              </a:rPr>
+              <a:t>- 문헌 달성률(원문 확인): Mockingjay HPCA'22 Table I (Belady MIN 대비 IPC 개선) SHiP 57%, Hawkeye 75%, Mockingj</a:t>
             </a:r>
           </a:p>
           <a:p>
@@ -18540,12 +18583,12 @@
             <a:r>
               <a:rPr sz="850" b="0">
                 <a:solidFill>
-                  <a:srgbClr val="1A1A1A"/>
-                </a:solidFill>
-                <a:latin typeface="맑은 고딕"/>
-                <a:ea typeface="맑은 고딕"/>
-              </a:rPr>
-              <a:t>- ★★★ 기준 80%(문헌): 이득 달성률 57, 75, 87, 95%의 중앙값 81%를 반올림. 문헌 점수가 4개뿐이고 CPU 캐시/ti</a:t>
+                  <a:srgbClr val="404040"/>
+                </a:solidFill>
+                <a:latin typeface="맑은 고딕"/>
+                <a:ea typeface="맑은 고딕"/>
+              </a:rPr>
+              <a:t>ay 95%; ARMS arXiv 2508.04417 튜닝 최적의 97% 이상 = 87% 이상(환산). 중앙값 81%.</a:t>
             </a:r>
           </a:p>
           <a:p>
@@ -18553,12 +18596,12 @@
             <a:r>
               <a:rPr sz="850" b="0">
                 <a:solidFill>
-                  <a:srgbClr val="1A1A1A"/>
-                </a:solidFill>
-                <a:latin typeface="맑은 고딕"/>
-                <a:ea typeface="맑은 고딕"/>
-              </a:rPr>
-              <a:t>ered memory 연구다.</a:t>
+                  <a:srgbClr val="404040"/>
+                </a:solidFill>
+                <a:latin typeface="맑은 고딕"/>
+                <a:ea typeface="맑은 고딕"/>
+              </a:rPr>
+              <a:t>- 참고: Colloid SOSP'24는 HeMem/TPP/MEMTIS가 best-case 처리량의 98.5/95.4/89.9%, LRB NSDI'20은 기존 최고</a:t>
             </a:r>
           </a:p>
           <a:p>
@@ -18566,68 +18609,12 @@
             <a:r>
               <a:rPr sz="850" b="0">
                 <a:solidFill>
-                  <a:srgbClr val="1A1A1A"/>
-                </a:solidFill>
-                <a:latin typeface="맑은 고딕"/>
-                <a:ea typeface="맑은 고딕"/>
-              </a:rPr>
-              <a:t>- 이 기준은 결과를 본 뒤 정했고(집계 방식, QA2·QA3 Oracle 포함) 선택(C1 9점 대 C2 8점)은 이전 기준과 같다.</a:t>
-            </a:r>
-          </a:p>
-        </p:txBody>
-      </p:sp>
-      <p:sp>
-        <p:nvSpPr>
-          <p:cNvPr id="94" name="Rectangle 93"/>
-          <p:cNvSpPr/>
-          <p:nvPr/>
-        </p:nvSpPr>
-        <p:spPr>
-          <a:xfrm>
-            <a:off x="6172200" y="4626864"/>
-            <a:ext cx="5715000" cy="1874519"/>
-          </a:xfrm>
-          <a:prstGeom prst="rect">
-            <a:avLst/>
-          </a:prstGeom>
-          <a:solidFill>
-            <a:srgbClr val="F2F2F2"/>
-          </a:solidFill>
-          <a:ln w="9525">
-            <a:solidFill>
-              <a:srgbClr val="BFBFBF"/>
-            </a:solidFill>
-          </a:ln>
-          <a:effectLst/>
-        </p:spPr>
-        <p:style>
-          <a:lnRef idx="1">
-            <a:schemeClr val="accent1"/>
-          </a:lnRef>
-          <a:fillRef idx="3">
-            <a:schemeClr val="accent1"/>
-          </a:fillRef>
-          <a:effectRef idx="2">
-            <a:schemeClr val="accent1"/>
-          </a:effectRef>
-          <a:fontRef idx="minor">
-            <a:schemeClr val="lt1"/>
-          </a:fontRef>
-        </p:style>
-        <p:txBody>
-          <a:bodyPr rtlCol="0" anchor="t" wrap="square" lIns="45720" rIns="45720" tIns="27432" bIns="27432"/>
-          <a:lstStyle/>
-          <a:p>
-            <a:pPr algn="l"/>
-            <a:r>
-              <a:rPr sz="850" b="1">
-                <a:solidFill>
                   <a:srgbClr val="404040"/>
                 </a:solidFill>
                 <a:latin typeface="맑은 고딕"/>
                 <a:ea typeface="맑은 고딕"/>
               </a:rPr>
-              <a:t>문헌 자료 (원문에서 확인한 수치; 출처: qa-capture-literature.md)</a:t>
+              <a:t>와 Belady 격차의 약 1/4 해소. 반증: arXiv 2609.16215는 대역폭 경합 시 oracle prefetch도 이득이 없었다고 보고.</a:t>
             </a:r>
           </a:p>
           <a:p>
@@ -18640,7 +18627,7 @@
                 <a:latin typeface="맑은 고딕"/>
                 <a:ea typeface="맑은 고딕"/>
               </a:rPr>
-              <a:t>- Mockingjay, HPCA'22, Table I (IPC 개선 vs LRU, Belady MIN 6.0%): SHiP 3.4%=57%, Hawkeye 4.5%=75%, Mockingja</a:t>
+              <a:t>- 한계: LLM 서빙 직접 문헌 없음(CPU 캐시/tiered memory), Oracle은 근사 상한. 출처 5개와 제외 사유: qa-capture-lite</a:t>
             </a:r>
           </a:p>
           <a:p>
@@ -18653,72 +18640,7 @@
                 <a:latin typeface="맑은 고딕"/>
                 <a:ea typeface="맑은 고딕"/>
               </a:rPr>
-              <a:t>y 5.7%=95%.</a:t>
-            </a:r>
-          </a:p>
-          <a:p>
-            <a:pPr algn="l"/>
-            <a:r>
-              <a:rPr sz="850" b="0">
-                <a:solidFill>
-                  <a:srgbClr val="404040"/>
-                </a:solidFill>
-                <a:latin typeface="맑은 고딕"/>
-                <a:ea typeface="맑은 고딕"/>
-              </a:rPr>
-              <a:t>- ARMS, arXiv 2508.04417: 기본 HeMem 대비 1.26배, 튜닝 최적의 97% 이상이므로 달성률 87% 이상(환산).</a:t>
-            </a:r>
-          </a:p>
-          <a:p>
-            <a:pPr algn="l"/>
-            <a:r>
-              <a:rPr sz="850" b="0">
-                <a:solidFill>
-                  <a:srgbClr val="404040"/>
-                </a:solidFill>
-                <a:latin typeface="맑은 고딕"/>
-                <a:ea typeface="맑은 고딕"/>
-              </a:rPr>
-              <a:t>- 참고(지표가 달라 80% 계산에서 제외): Colloid, SOSP'24: HeMem/TPP/MEMTIS가 best-case 처리량의 98.5/95.4/8</a:t>
-            </a:r>
-          </a:p>
-          <a:p>
-            <a:pPr algn="l"/>
-            <a:r>
-              <a:rPr sz="850" b="0">
-                <a:solidFill>
-                  <a:srgbClr val="404040"/>
-                </a:solidFill>
-                <a:latin typeface="맑은 고딕"/>
-                <a:ea typeface="맑은 고딕"/>
-              </a:rPr>
-              <a:t>9.9%. LRB, NSDI'20: 기존 최고와 Belady 격차의 약 1/4 해소.</a:t>
-            </a:r>
-          </a:p>
-          <a:p>
-            <a:pPr algn="l"/>
-            <a:r>
-              <a:rPr sz="850" b="0">
-                <a:solidFill>
-                  <a:srgbClr val="404040"/>
-                </a:solidFill>
-                <a:latin typeface="맑은 고딕"/>
-                <a:ea typeface="맑은 고딕"/>
-              </a:rPr>
-              <a:t>- 반증: arXiv 2609.16215: 대역폭이 경합하면 oracle prefetch도 이득이 없었음(우리 링크 간섭 결과와 같은 방향).</a:t>
-            </a:r>
-          </a:p>
-          <a:p>
-            <a:pPr algn="l"/>
-            <a:r>
-              <a:rPr sz="850" b="0">
-                <a:solidFill>
-                  <a:srgbClr val="404040"/>
-                </a:solidFill>
-                <a:latin typeface="맑은 고딕"/>
-                <a:ea typeface="맑은 고딕"/>
-              </a:rPr>
-              <a:t>- 한계: LLM 서빙 직접 문헌 없음, QA2/QA3의 Oracle이 더 이상적이라 80%가 더 엄격, 개선 여지 쌍이 QA1 10개뿐.</a:t>
+              <a:t>rature.md.</a:t>
             </a:r>
           </a:p>
         </p:txBody>

</xml_diff>